<commit_message>
Incorrect Info deck: process slide as a flowchart with Sales call review pop-up
Co-Authored-By: Claude Opus 5.5 <noreply@anthropic.com>
Claude-Session: https://claude.ai/code/session_01FEzv8wwqWDgTsXP8Yz6XYn
</commit_message>
<xml_diff>
--- a/incorrect-info-lmc-lockout/incorrect-info-lmc-lockout.pptx
+++ b/incorrect-info-lmc-lockout/incorrect-info-lmc-lockout.pptx
@@ -2818,7 +2818,7 @@
           <a:p>
             <a:r>
               <a:rPr lang="en-US" dirty="0"/>
-              <a:t>1) Confirm it's genuinely a guaranteed promise, not an estimate or a gap in what was proactively mentioned. Look for the specific language used, not just whether the customer was surprised. Verify against the sales call recording or notes. 2) Refund any overpayment that resulted, where applicable: e.g. promised a $49/month MF but charged $59, refund the difference. Not every case has an overpayment; service-capability and guarantee-pairing cases often don't. 3) Acknowledge the error directly. Don't frame it as a misunderstanding on the customer's side. 4) Correct the charges or expectations going forward, and clearly explain what changed. 5) Assess retainability as for any other case. If retainable, attempt retention with one light offer, not a push: up to $20 credit or a 1-hr courtesy voucher. While you wait for their reply, set a TR before the next MF. If they decline, or aren't retainable, waive the ETF and process the cancellation. Macro: Misinformation: address incorrect claims about charges.</a:t>
+              <a:t>1) Verify: confirm it's genuinely a guaranteed promise, not an estimate or a gap in what was proactively mentioned. Look for the specific language used, not just whether the customer was surprised. To verify, run a Sales call review: submit a Sales call review request (link icon on the pop-up opens the request sheet), add an internal note with your escalation link, and don't resolve yet: change the queue to Waiting on CSQ. If misinformation is not verified, handle it as a normal case. If it is verified, continue: 2) Refund any overpayment that resulted, where applicable: e.g. promised a $49/month MF but charged $59, refund the difference. Not every case has an overpayment; service-capability and guarantee-pairing cases often don't. 3) Acknowledge the error directly. Don't frame it as a misunderstanding on the customer's side. 4) Correct the charges or expectations going forward, and clearly explain what changed. 5) Assess retainability as for any other case. If retainable, attempt retention with one light offer, not a push: up to $20 credit or a 1-hr courtesy voucher. While you wait for their reply, set a TR before the next MF. 6) If the customer declines the offer, or isn't retainable, waive the ETF and cancel the FC. Macro: Misinformation: address incorrect claims about charges. TRAINER: click once (Sales call review) to open the escalation steps; click again to close them. In slideshow mode, the link icon on the pop-up opens the Sales call review request sheet.</a:t>
             </a:r>
             <a:endParaRPr lang="en-US" dirty="0"/>
           </a:p>
@@ -25719,7 +25719,7 @@
                 <a:ea typeface="SF Pro Text" pitchFamily="34" charset="-122"/>
                 <a:cs typeface="SF Pro Text" pitchFamily="34" charset="-120"/>
               </a:rPr>
-              <a:t>Five steps, in order.</a:t>
+              <a:t>Verify first. Only verified misinformation moves on to steps 2–6.</a:t>
             </a:r>
             <a:endParaRPr lang="en-US" sz="1200" dirty="0"/>
           </a:p>
@@ -25733,18 +25733,524 @@
         </p:nvSpPr>
         <p:spPr>
           <a:xfrm>
-            <a:off x="411480" y="1280160"/>
-            <a:ext cx="1554480" cy="1965960"/>
+            <a:off x="411480" y="1298448"/>
+            <a:ext cx="1737360" cy="566928"/>
           </a:xfrm>
           <a:prstGeom prst="roundRect">
             <a:avLst>
-              <a:gd name="adj" fmla="val 4706"/>
+              <a:gd name="adj" fmla="val 12903"/>
+            </a:avLst>
+          </a:prstGeom>
+          <a:solidFill>
+            <a:srgbClr val="0B7A6F"/>
+          </a:solidFill>
+          <a:ln w="12700">
+            <a:solidFill>
+              <a:srgbClr val="0B7A6F"/>
+            </a:solidFill>
+            <a:prstDash val="solid"/>
+          </a:ln>
+        </p:spPr>
+      </p:sp>
+      <p:sp>
+        <p:nvSpPr>
+          <p:cNvPr id="7" name="Text 4"/>
+          <p:cNvSpPr txBox="1"/>
+          <p:nvPr/>
+        </p:nvSpPr>
+        <p:spPr>
+          <a:xfrm>
+            <a:off x="457200" y="1298448"/>
+            <a:ext cx="1645920" cy="566928"/>
+          </a:xfrm>
+          <a:prstGeom prst="rect">
+            <a:avLst/>
+          </a:prstGeom>
+          <a:noFill/>
+          <a:ln/>
+        </p:spPr>
+        <p:txBody>
+          <a:bodyPr wrap="square" lIns="0" tIns="0" rIns="0" bIns="0" rtlCol="0" anchor="ctr"/>
+          <a:lstStyle/>
+          <a:p>
+            <a:pPr algn="ctr" indent="0" marL="0">
+              <a:buNone/>
+            </a:pPr>
+            <a:r>
+              <a:rPr lang="en-US" sz="1050" b="1" dirty="0">
+                <a:solidFill>
+                  <a:srgbClr val="FFFFFF"/>
+                </a:solidFill>
+                <a:latin typeface="SF Pro Display" pitchFamily="34" charset="0"/>
+                <a:ea typeface="SF Pro Display" pitchFamily="34" charset="-122"/>
+                <a:cs typeface="SF Pro Display" pitchFamily="34" charset="-120"/>
+              </a:rPr>
+              <a:t>1  Verify</a:t>
+            </a:r>
+            <a:endParaRPr lang="en-US" sz="1050" dirty="0"/>
+          </a:p>
+          <a:p>
+            <a:pPr algn="ctr" indent="0" marL="0">
+              <a:buNone/>
+            </a:pPr>
+            <a:r>
+              <a:rPr lang="en-US" sz="800" dirty="0">
+                <a:solidFill>
+                  <a:srgbClr val="FFFFFF"/>
+                </a:solidFill>
+                <a:latin typeface="SF Pro Text" pitchFamily="34" charset="0"/>
+                <a:ea typeface="SF Pro Text" pitchFamily="34" charset="-122"/>
+                <a:cs typeface="SF Pro Text" pitchFamily="34" charset="-120"/>
+              </a:rPr>
+              <a:t>Is it a real promise?</a:t>
+            </a:r>
+            <a:endParaRPr lang="en-US" sz="1050" dirty="0"/>
+          </a:p>
+        </p:txBody>
+      </p:sp>
+      <p:sp>
+        <p:nvSpPr>
+          <p:cNvPr id="8" name="Shape 5"/>
+          <p:cNvSpPr/>
+          <p:nvPr/>
+        </p:nvSpPr>
+        <p:spPr>
+          <a:xfrm>
+            <a:off x="2148840" y="1581912"/>
+            <a:ext cx="228600" cy="0"/>
+          </a:xfrm>
+          <a:prstGeom prst="line">
+            <a:avLst/>
+          </a:prstGeom>
+          <a:noFill/>
+          <a:ln w="12700">
+            <a:solidFill>
+              <a:srgbClr val="6E6E73"/>
+            </a:solidFill>
+            <a:prstDash val="solid"/>
+            <a:tailEnd type="triangle"/>
+          </a:ln>
+        </p:spPr>
+      </p:sp>
+      <p:sp>
+        <p:nvSpPr>
+          <p:cNvPr id="9" name="Shape 6"/>
+          <p:cNvSpPr/>
+          <p:nvPr/>
+        </p:nvSpPr>
+        <p:spPr>
+          <a:xfrm>
+            <a:off x="2377440" y="1298448"/>
+            <a:ext cx="1874520" cy="566928"/>
+          </a:xfrm>
+          <a:prstGeom prst="roundRect">
+            <a:avLst>
+              <a:gd name="adj" fmla="val 12903"/>
+            </a:avLst>
+          </a:prstGeom>
+          <a:solidFill>
+            <a:srgbClr val="FFF3D6"/>
+          </a:solidFill>
+          <a:ln w="12700">
+            <a:solidFill>
+              <a:srgbClr val="9A6410"/>
+            </a:solidFill>
+            <a:prstDash val="solid"/>
+          </a:ln>
+        </p:spPr>
+      </p:sp>
+      <p:sp>
+        <p:nvSpPr>
+          <p:cNvPr id="10" name="Text 7"/>
+          <p:cNvSpPr txBox="1"/>
+          <p:nvPr/>
+        </p:nvSpPr>
+        <p:spPr>
+          <a:xfrm>
+            <a:off x="2377440" y="1298448"/>
+            <a:ext cx="1874520" cy="566928"/>
+          </a:xfrm>
+          <a:prstGeom prst="rect">
+            <a:avLst/>
+          </a:prstGeom>
+          <a:noFill/>
+          <a:ln/>
+        </p:spPr>
+        <p:txBody>
+          <a:bodyPr wrap="square" lIns="0" tIns="0" rIns="0" bIns="0" rtlCol="0" anchor="ctr"/>
+          <a:lstStyle/>
+          <a:p>
+            <a:pPr algn="ctr" indent="0" marL="0">
+              <a:buNone/>
+            </a:pPr>
+            <a:r>
+              <a:rPr lang="en-US" sz="1000" b="1" dirty="0">
+                <a:solidFill>
+                  <a:srgbClr val="9A6410"/>
+                </a:solidFill>
+                <a:latin typeface="SF Pro Display" pitchFamily="34" charset="0"/>
+                <a:ea typeface="SF Pro Display" pitchFamily="34" charset="-122"/>
+                <a:cs typeface="SF Pro Display" pitchFamily="34" charset="-120"/>
+              </a:rPr>
+              <a:t>Misinformation</a:t>
+            </a:r>
+            <a:endParaRPr lang="en-US" sz="1000" dirty="0"/>
+          </a:p>
+          <a:p>
+            <a:pPr algn="ctr" indent="0" marL="0">
+              <a:buNone/>
+            </a:pPr>
+            <a:r>
+              <a:rPr lang="en-US" sz="1000" b="1" dirty="0">
+                <a:solidFill>
+                  <a:srgbClr val="9A6410"/>
+                </a:solidFill>
+                <a:latin typeface="SF Pro Display" pitchFamily="34" charset="0"/>
+                <a:ea typeface="SF Pro Display" pitchFamily="34" charset="-122"/>
+                <a:cs typeface="SF Pro Display" pitchFamily="34" charset="-120"/>
+              </a:rPr>
+              <a:t>verified?</a:t>
+            </a:r>
+            <a:endParaRPr lang="en-US" sz="1000" dirty="0"/>
+          </a:p>
+        </p:txBody>
+      </p:sp>
+      <p:sp>
+        <p:nvSpPr>
+          <p:cNvPr id="11" name="Shape 8"/>
+          <p:cNvSpPr/>
+          <p:nvPr/>
+        </p:nvSpPr>
+        <p:spPr>
+          <a:xfrm>
+            <a:off x="4251960" y="1581912"/>
+            <a:ext cx="274320" cy="0"/>
+          </a:xfrm>
+          <a:prstGeom prst="line">
+            <a:avLst/>
+          </a:prstGeom>
+          <a:noFill/>
+          <a:ln w="12700">
+            <a:solidFill>
+              <a:srgbClr val="6E6E73"/>
+            </a:solidFill>
+            <a:prstDash val="solid"/>
+            <a:tailEnd type="triangle"/>
+          </a:ln>
+        </p:spPr>
+      </p:sp>
+      <p:sp>
+        <p:nvSpPr>
+          <p:cNvPr id="12" name="Text 9"/>
+          <p:cNvSpPr txBox="1"/>
+          <p:nvPr/>
+        </p:nvSpPr>
+        <p:spPr>
+          <a:xfrm>
+            <a:off x="4160520" y="1380744"/>
+            <a:ext cx="457200" cy="182880"/>
+          </a:xfrm>
+          <a:prstGeom prst="rect">
+            <a:avLst/>
+          </a:prstGeom>
+          <a:noFill/>
+          <a:ln/>
+        </p:spPr>
+        <p:txBody>
+          <a:bodyPr wrap="square" lIns="0" tIns="0" rIns="0" bIns="0" rtlCol="0" anchor="t"/>
+          <a:lstStyle/>
+          <a:p>
+            <a:pPr algn="ctr" indent="0" marL="0">
+              <a:buNone/>
+            </a:pPr>
+            <a:r>
+              <a:rPr lang="en-US" sz="800" b="1" dirty="0">
+                <a:solidFill>
+                  <a:srgbClr val="6E6E73"/>
+                </a:solidFill>
+                <a:latin typeface="SF Pro Text" pitchFamily="34" charset="0"/>
+                <a:ea typeface="SF Pro Text" pitchFamily="34" charset="-122"/>
+                <a:cs typeface="SF Pro Text" pitchFamily="34" charset="-120"/>
+              </a:rPr>
+              <a:t>Yes</a:t>
+            </a:r>
+            <a:endParaRPr lang="en-US" sz="800" dirty="0"/>
+          </a:p>
+        </p:txBody>
+      </p:sp>
+      <p:sp>
+        <p:nvSpPr>
+          <p:cNvPr id="13" name="Shape 10"/>
+          <p:cNvSpPr/>
+          <p:nvPr/>
+        </p:nvSpPr>
+        <p:spPr>
+          <a:xfrm>
+            <a:off x="4526280" y="1298448"/>
+            <a:ext cx="1828800" cy="566928"/>
+          </a:xfrm>
+          <a:prstGeom prst="roundRect">
+            <a:avLst>
+              <a:gd name="adj" fmla="val 12903"/>
+            </a:avLst>
+          </a:prstGeom>
+          <a:solidFill>
+            <a:srgbClr val="0B7A6F"/>
+          </a:solidFill>
+          <a:ln w="12700">
+            <a:solidFill>
+              <a:srgbClr val="0B7A6F"/>
+            </a:solidFill>
+            <a:prstDash val="solid"/>
+          </a:ln>
+        </p:spPr>
+      </p:sp>
+      <p:sp>
+        <p:nvSpPr>
+          <p:cNvPr id="14" name="Text 11"/>
+          <p:cNvSpPr txBox="1"/>
+          <p:nvPr/>
+        </p:nvSpPr>
+        <p:spPr>
+          <a:xfrm>
+            <a:off x="4572000" y="1298448"/>
+            <a:ext cx="1737360" cy="566928"/>
+          </a:xfrm>
+          <a:prstGeom prst="rect">
+            <a:avLst/>
+          </a:prstGeom>
+          <a:noFill/>
+          <a:ln/>
+        </p:spPr>
+        <p:txBody>
+          <a:bodyPr wrap="square" lIns="0" tIns="0" rIns="0" bIns="0" rtlCol="0" anchor="ctr"/>
+          <a:lstStyle/>
+          <a:p>
+            <a:pPr algn="ctr" indent="0" marL="0">
+              <a:buNone/>
+            </a:pPr>
+            <a:r>
+              <a:rPr lang="en-US" sz="1050" b="1" dirty="0">
+                <a:solidFill>
+                  <a:srgbClr val="FFFFFF"/>
+                </a:solidFill>
+                <a:latin typeface="SF Pro Display" pitchFamily="34" charset="0"/>
+                <a:ea typeface="SF Pro Display" pitchFamily="34" charset="-122"/>
+                <a:cs typeface="SF Pro Display" pitchFamily="34" charset="-120"/>
+              </a:rPr>
+              <a:t>2  Refund the gap</a:t>
+            </a:r>
+            <a:endParaRPr lang="en-US" sz="1050" dirty="0"/>
+          </a:p>
+          <a:p>
+            <a:pPr algn="ctr" indent="0" marL="0">
+              <a:buNone/>
+            </a:pPr>
+            <a:r>
+              <a:rPr lang="en-US" sz="800" dirty="0">
+                <a:solidFill>
+                  <a:srgbClr val="FFFFFF"/>
+                </a:solidFill>
+                <a:latin typeface="SF Pro Text" pitchFamily="34" charset="0"/>
+                <a:ea typeface="SF Pro Text" pitchFamily="34" charset="-122"/>
+                <a:cs typeface="SF Pro Text" pitchFamily="34" charset="-120"/>
+              </a:rPr>
+              <a:t>Charged more than promised?</a:t>
+            </a:r>
+            <a:endParaRPr lang="en-US" sz="1050" dirty="0"/>
+          </a:p>
+        </p:txBody>
+      </p:sp>
+      <p:sp>
+        <p:nvSpPr>
+          <p:cNvPr id="15" name="Shape 12"/>
+          <p:cNvSpPr/>
+          <p:nvPr/>
+        </p:nvSpPr>
+        <p:spPr>
+          <a:xfrm>
+            <a:off x="6355080" y="1581912"/>
+            <a:ext cx="274320" cy="0"/>
+          </a:xfrm>
+          <a:prstGeom prst="line">
+            <a:avLst/>
+          </a:prstGeom>
+          <a:noFill/>
+          <a:ln w="12700">
+            <a:solidFill>
+              <a:srgbClr val="6E6E73"/>
+            </a:solidFill>
+            <a:prstDash val="solid"/>
+            <a:tailEnd type="triangle"/>
+          </a:ln>
+        </p:spPr>
+      </p:sp>
+      <p:sp>
+        <p:nvSpPr>
+          <p:cNvPr id="16" name="Shape 13"/>
+          <p:cNvSpPr/>
+          <p:nvPr/>
+        </p:nvSpPr>
+        <p:spPr>
+          <a:xfrm>
+            <a:off x="6629400" y="1298448"/>
+            <a:ext cx="2103120" cy="566928"/>
+          </a:xfrm>
+          <a:prstGeom prst="roundRect">
+            <a:avLst>
+              <a:gd name="adj" fmla="val 12903"/>
+            </a:avLst>
+          </a:prstGeom>
+          <a:solidFill>
+            <a:srgbClr val="0B7A6F"/>
+          </a:solidFill>
+          <a:ln w="12700">
+            <a:solidFill>
+              <a:srgbClr val="0B7A6F"/>
+            </a:solidFill>
+            <a:prstDash val="solid"/>
+          </a:ln>
+        </p:spPr>
+      </p:sp>
+      <p:sp>
+        <p:nvSpPr>
+          <p:cNvPr id="17" name="Text 14"/>
+          <p:cNvSpPr txBox="1"/>
+          <p:nvPr/>
+        </p:nvSpPr>
+        <p:spPr>
+          <a:xfrm>
+            <a:off x="6675120" y="1298448"/>
+            <a:ext cx="2011680" cy="566928"/>
+          </a:xfrm>
+          <a:prstGeom prst="rect">
+            <a:avLst/>
+          </a:prstGeom>
+          <a:noFill/>
+          <a:ln/>
+        </p:spPr>
+        <p:txBody>
+          <a:bodyPr wrap="square" lIns="0" tIns="0" rIns="0" bIns="0" rtlCol="0" anchor="ctr"/>
+          <a:lstStyle/>
+          <a:p>
+            <a:pPr algn="ctr" indent="0" marL="0">
+              <a:buNone/>
+            </a:pPr>
+            <a:r>
+              <a:rPr lang="en-US" sz="1050" b="1" dirty="0">
+                <a:solidFill>
+                  <a:srgbClr val="FFFFFF"/>
+                </a:solidFill>
+                <a:latin typeface="SF Pro Display" pitchFamily="34" charset="0"/>
+                <a:ea typeface="SF Pro Display" pitchFamily="34" charset="-122"/>
+                <a:cs typeface="SF Pro Display" pitchFamily="34" charset="-120"/>
+              </a:rPr>
+              <a:t>3  Own the error</a:t>
+            </a:r>
+            <a:endParaRPr lang="en-US" sz="1050" dirty="0"/>
+          </a:p>
+          <a:p>
+            <a:pPr algn="ctr" indent="0" marL="0">
+              <a:buNone/>
+            </a:pPr>
+            <a:r>
+              <a:rPr lang="en-US" sz="800" dirty="0">
+                <a:solidFill>
+                  <a:srgbClr val="FFFFFF"/>
+                </a:solidFill>
+                <a:latin typeface="SF Pro Text" pitchFamily="34" charset="0"/>
+                <a:ea typeface="SF Pro Text" pitchFamily="34" charset="-122"/>
+                <a:cs typeface="SF Pro Text" pitchFamily="34" charset="-120"/>
+              </a:rPr>
+              <a:t>Ours, not "a misunderstanding"</a:t>
+            </a:r>
+            <a:endParaRPr lang="en-US" sz="1050" dirty="0"/>
+          </a:p>
+        </p:txBody>
+      </p:sp>
+      <p:sp>
+        <p:nvSpPr>
+          <p:cNvPr id="18" name="Shape 15"/>
+          <p:cNvSpPr/>
+          <p:nvPr/>
+        </p:nvSpPr>
+        <p:spPr>
+          <a:xfrm>
+            <a:off x="3314700" y="1865376"/>
+            <a:ext cx="0" cy="237744"/>
+          </a:xfrm>
+          <a:prstGeom prst="line">
+            <a:avLst/>
+          </a:prstGeom>
+          <a:noFill/>
+          <a:ln w="12700">
+            <a:solidFill>
+              <a:srgbClr val="6E6E73"/>
+            </a:solidFill>
+            <a:prstDash val="solid"/>
+            <a:tailEnd type="triangle"/>
+          </a:ln>
+        </p:spPr>
+      </p:sp>
+      <p:sp>
+        <p:nvSpPr>
+          <p:cNvPr id="19" name="Text 16"/>
+          <p:cNvSpPr txBox="1"/>
+          <p:nvPr/>
+        </p:nvSpPr>
+        <p:spPr>
+          <a:xfrm>
+            <a:off x="3337560" y="1883664"/>
+            <a:ext cx="274320" cy="182880"/>
+          </a:xfrm>
+          <a:prstGeom prst="rect">
+            <a:avLst/>
+          </a:prstGeom>
+          <a:noFill/>
+          <a:ln/>
+        </p:spPr>
+        <p:txBody>
+          <a:bodyPr wrap="square" lIns="0" tIns="0" rIns="0" bIns="0" rtlCol="0" anchor="t"/>
+          <a:lstStyle/>
+          <a:p>
+            <a:pPr algn="ctr" indent="0" marL="0">
+              <a:buNone/>
+            </a:pPr>
+            <a:r>
+              <a:rPr lang="en-US" sz="800" b="1" dirty="0">
+                <a:solidFill>
+                  <a:srgbClr val="6E6E73"/>
+                </a:solidFill>
+                <a:latin typeface="SF Pro Text" pitchFamily="34" charset="0"/>
+                <a:ea typeface="SF Pro Text" pitchFamily="34" charset="-122"/>
+                <a:cs typeface="SF Pro Text" pitchFamily="34" charset="-120"/>
+              </a:rPr>
+              <a:t>No</a:t>
+            </a:r>
+            <a:endParaRPr lang="en-US" sz="800" dirty="0"/>
+          </a:p>
+        </p:txBody>
+      </p:sp>
+      <p:sp>
+        <p:nvSpPr>
+          <p:cNvPr id="20" name="Shape 17"/>
+          <p:cNvSpPr/>
+          <p:nvPr/>
+        </p:nvSpPr>
+        <p:spPr>
+          <a:xfrm>
+            <a:off x="2377440" y="2103120"/>
+            <a:ext cx="1874520" cy="365760"/>
+          </a:xfrm>
+          <a:prstGeom prst="roundRect">
+            <a:avLst>
+              <a:gd name="adj" fmla="val 20000"/>
             </a:avLst>
           </a:prstGeom>
           <a:solidFill>
             <a:srgbClr val="FFFFFF"/>
           </a:solidFill>
-          <a:ln w="9525">
+          <a:ln w="12700">
             <a:solidFill>
               <a:srgbClr val="DCE1E7"/>
             </a:solidFill>
@@ -25754,24 +26260,205 @@
       </p:sp>
       <p:sp>
         <p:nvSpPr>
-          <p:cNvPr id="7" name="Shape 4"/>
+          <p:cNvPr id="21" name="Text 18"/>
+          <p:cNvSpPr txBox="1"/>
+          <p:nvPr/>
+        </p:nvSpPr>
+        <p:spPr>
+          <a:xfrm>
+            <a:off x="2377440" y="2103120"/>
+            <a:ext cx="1874520" cy="365760"/>
+          </a:xfrm>
+          <a:prstGeom prst="rect">
+            <a:avLst/>
+          </a:prstGeom>
+          <a:noFill/>
+          <a:ln/>
+        </p:spPr>
+        <p:txBody>
+          <a:bodyPr wrap="square" lIns="0" tIns="0" rIns="0" bIns="0" rtlCol="0" anchor="ctr"/>
+          <a:lstStyle/>
+          <a:p>
+            <a:pPr algn="ctr" indent="0" marL="0">
+              <a:buNone/>
+            </a:pPr>
+            <a:r>
+              <a:rPr lang="en-US" sz="1000" b="1" dirty="0">
+                <a:solidFill>
+                  <a:srgbClr val="1D1D1F"/>
+                </a:solidFill>
+                <a:latin typeface="SF Pro Display" pitchFamily="34" charset="0"/>
+                <a:ea typeface="SF Pro Display" pitchFamily="34" charset="-122"/>
+                <a:cs typeface="SF Pro Display" pitchFamily="34" charset="-120"/>
+              </a:rPr>
+              <a:t>Handle as a normal case</a:t>
+            </a:r>
+            <a:endParaRPr lang="en-US" sz="1000" dirty="0"/>
+          </a:p>
+        </p:txBody>
+      </p:sp>
+      <p:sp>
+        <p:nvSpPr>
+          <p:cNvPr id="22" name="Text 19"/>
           <p:cNvSpPr/>
           <p:nvPr/>
         </p:nvSpPr>
         <p:spPr>
           <a:xfrm>
-            <a:off x="576072" y="1463040"/>
-            <a:ext cx="274320" cy="274320"/>
-          </a:xfrm>
-          <a:prstGeom prst="ellipse">
-            <a:avLst/>
+            <a:off x="411480" y="2011680"/>
+            <a:ext cx="1737360" cy="365760"/>
+          </a:xfrm>
+          <a:prstGeom prst="roundRect">
+            <a:avLst>
+              <a:gd name="adj" fmla="val 20000"/>
+            </a:avLst>
           </a:prstGeom>
           <a:solidFill>
-            <a:srgbClr val="E3F4F1"/>
+            <a:srgbClr val="FFFFFF"/>
+          </a:solidFill>
+          <a:ln w="19050">
+            <a:solidFill>
+              <a:srgbClr val="0B7A6F"/>
+            </a:solidFill>
+          </a:ln>
+        </p:spPr>
+        <p:txBody>
+          <a:bodyPr wrap="square" rtlCol="0" anchor="ctr"/>
+          <a:lstStyle/>
+          <a:p>
+            <a:pPr algn="ctr" indent="0" marL="0">
+              <a:buNone/>
+            </a:pPr>
+            <a:r>
+              <a:rPr lang="en-US" sz="1000" b="1" dirty="0">
+                <a:solidFill>
+                  <a:srgbClr val="0B7A6F"/>
+                </a:solidFill>
+                <a:latin typeface="SF Pro Display" pitchFamily="34" charset="0"/>
+                <a:ea typeface="SF Pro Display" pitchFamily="34" charset="-122"/>
+                <a:cs typeface="SF Pro Display" pitchFamily="34" charset="-120"/>
+              </a:rPr>
+              <a:t>Sales call review  ›</a:t>
+            </a:r>
+            <a:endParaRPr lang="en-US" sz="1000" dirty="0"/>
+          </a:p>
+        </p:txBody>
+      </p:sp>
+      <p:sp>
+        <p:nvSpPr>
+          <p:cNvPr id="23" name="Shape 20"/>
+          <p:cNvSpPr/>
+          <p:nvPr/>
+        </p:nvSpPr>
+        <p:spPr>
+          <a:xfrm>
+            <a:off x="1280160" y="1865376"/>
+            <a:ext cx="0" cy="146304"/>
+          </a:xfrm>
+          <a:prstGeom prst="line">
+            <a:avLst/>
+          </a:prstGeom>
+          <a:noFill/>
+          <a:ln w="12700">
+            <a:solidFill>
+              <a:srgbClr val="6E6E73"/>
+            </a:solidFill>
+            <a:prstDash val="solid"/>
+          </a:ln>
+        </p:spPr>
+      </p:sp>
+      <p:sp>
+        <p:nvSpPr>
+          <p:cNvPr id="24" name="Shape 21"/>
+          <p:cNvSpPr/>
+          <p:nvPr/>
+        </p:nvSpPr>
+        <p:spPr>
+          <a:xfrm>
+            <a:off x="7680960" y="1865376"/>
+            <a:ext cx="0" cy="768096"/>
+          </a:xfrm>
+          <a:prstGeom prst="line">
+            <a:avLst/>
+          </a:prstGeom>
+          <a:noFill/>
+          <a:ln w="12700">
+            <a:solidFill>
+              <a:srgbClr val="6E6E73"/>
+            </a:solidFill>
+            <a:prstDash val="solid"/>
+          </a:ln>
+        </p:spPr>
+      </p:sp>
+      <p:sp>
+        <p:nvSpPr>
+          <p:cNvPr id="25" name="Shape 22"/>
+          <p:cNvSpPr/>
+          <p:nvPr/>
+        </p:nvSpPr>
+        <p:spPr>
+          <a:xfrm>
+            <a:off x="1325880" y="2633472"/>
+            <a:ext cx="6355080" cy="0"/>
+          </a:xfrm>
+          <a:prstGeom prst="line">
+            <a:avLst/>
+          </a:prstGeom>
+          <a:noFill/>
+          <a:ln w="12700">
+            <a:solidFill>
+              <a:srgbClr val="6E6E73"/>
+            </a:solidFill>
+            <a:prstDash val="solid"/>
+          </a:ln>
+        </p:spPr>
+      </p:sp>
+      <p:sp>
+        <p:nvSpPr>
+          <p:cNvPr id="26" name="Shape 23"/>
+          <p:cNvSpPr/>
+          <p:nvPr/>
+        </p:nvSpPr>
+        <p:spPr>
+          <a:xfrm>
+            <a:off x="1325880" y="2633472"/>
+            <a:ext cx="0" cy="155448"/>
+          </a:xfrm>
+          <a:prstGeom prst="line">
+            <a:avLst/>
+          </a:prstGeom>
+          <a:noFill/>
+          <a:ln w="12700">
+            <a:solidFill>
+              <a:srgbClr val="6E6E73"/>
+            </a:solidFill>
+            <a:prstDash val="solid"/>
+            <a:tailEnd type="triangle"/>
+          </a:ln>
+        </p:spPr>
+      </p:sp>
+      <p:sp>
+        <p:nvSpPr>
+          <p:cNvPr id="27" name="Shape 24"/>
+          <p:cNvSpPr/>
+          <p:nvPr/>
+        </p:nvSpPr>
+        <p:spPr>
+          <a:xfrm>
+            <a:off x="411480" y="2788920"/>
+            <a:ext cx="1828800" cy="566928"/>
+          </a:xfrm>
+          <a:prstGeom prst="roundRect">
+            <a:avLst>
+              <a:gd name="adj" fmla="val 12903"/>
+            </a:avLst>
+          </a:prstGeom>
+          <a:solidFill>
+            <a:srgbClr val="0B7A6F"/>
           </a:solidFill>
           <a:ln w="12700">
             <a:solidFill>
-              <a:srgbClr val="E3F4F1"/>
+              <a:srgbClr val="0B7A6F"/>
             </a:solidFill>
             <a:prstDash val="solid"/>
           </a:ln>
@@ -25779,14 +26466,14 @@
       </p:sp>
       <p:sp>
         <p:nvSpPr>
-          <p:cNvPr id="8" name="Text 5"/>
+          <p:cNvPr id="28" name="Text 25"/>
           <p:cNvSpPr txBox="1"/>
           <p:nvPr/>
         </p:nvSpPr>
         <p:spPr>
           <a:xfrm>
-            <a:off x="576072" y="1463040"/>
-            <a:ext cx="274320" cy="274320"/>
+            <a:off x="457200" y="2788920"/>
+            <a:ext cx="1737360" cy="566928"/>
           </a:xfrm>
           <a:prstGeom prst="rect">
             <a:avLst/>
@@ -25802,30 +26489,98 @@
               <a:buNone/>
             </a:pPr>
             <a:r>
-              <a:rPr lang="en-US" sz="900" b="1" dirty="0">
-                <a:solidFill>
-                  <a:srgbClr val="0B7A6F"/>
+              <a:rPr lang="en-US" sz="1050" b="1" dirty="0">
+                <a:solidFill>
+                  <a:srgbClr val="FFFFFF"/>
                 </a:solidFill>
                 <a:latin typeface="SF Pro Display" pitchFamily="34" charset="0"/>
                 <a:ea typeface="SF Pro Display" pitchFamily="34" charset="-122"/>
                 <a:cs typeface="SF Pro Display" pitchFamily="34" charset="-120"/>
               </a:rPr>
-              <a:t>1</a:t>
-            </a:r>
-            <a:endParaRPr lang="en-US" sz="900" dirty="0"/>
-          </a:p>
-        </p:txBody>
-      </p:sp>
-      <p:sp>
-        <p:nvSpPr>
-          <p:cNvPr id="9" name="Text 6"/>
+              <a:t>4  Correct it</a:t>
+            </a:r>
+            <a:endParaRPr lang="en-US" sz="1050" dirty="0"/>
+          </a:p>
+          <a:p>
+            <a:pPr algn="ctr" indent="0" marL="0">
+              <a:buNone/>
+            </a:pPr>
+            <a:r>
+              <a:rPr lang="en-US" sz="800" dirty="0">
+                <a:solidFill>
+                  <a:srgbClr val="FFFFFF"/>
+                </a:solidFill>
+                <a:latin typeface="SF Pro Text" pitchFamily="34" charset="0"/>
+                <a:ea typeface="SF Pro Text" pitchFamily="34" charset="-122"/>
+                <a:cs typeface="SF Pro Text" pitchFamily="34" charset="-120"/>
+              </a:rPr>
+              <a:t>Fix charges, explain what changed</a:t>
+            </a:r>
+            <a:endParaRPr lang="en-US" sz="1050" dirty="0"/>
+          </a:p>
+        </p:txBody>
+      </p:sp>
+      <p:sp>
+        <p:nvSpPr>
+          <p:cNvPr id="29" name="Shape 26"/>
+          <p:cNvSpPr/>
+          <p:nvPr/>
+        </p:nvSpPr>
+        <p:spPr>
+          <a:xfrm>
+            <a:off x="2240280" y="3072384"/>
+            <a:ext cx="320040" cy="0"/>
+          </a:xfrm>
+          <a:prstGeom prst="line">
+            <a:avLst/>
+          </a:prstGeom>
+          <a:noFill/>
+          <a:ln w="12700">
+            <a:solidFill>
+              <a:srgbClr val="6E6E73"/>
+            </a:solidFill>
+            <a:prstDash val="solid"/>
+            <a:tailEnd type="triangle"/>
+          </a:ln>
+        </p:spPr>
+      </p:sp>
+      <p:sp>
+        <p:nvSpPr>
+          <p:cNvPr id="30" name="Shape 27"/>
+          <p:cNvSpPr/>
+          <p:nvPr/>
+        </p:nvSpPr>
+        <p:spPr>
+          <a:xfrm>
+            <a:off x="2560320" y="2788920"/>
+            <a:ext cx="2286000" cy="566928"/>
+          </a:xfrm>
+          <a:prstGeom prst="roundRect">
+            <a:avLst>
+              <a:gd name="adj" fmla="val 12903"/>
+            </a:avLst>
+          </a:prstGeom>
+          <a:solidFill>
+            <a:srgbClr val="0B7A6F"/>
+          </a:solidFill>
+          <a:ln w="12700">
+            <a:solidFill>
+              <a:srgbClr val="0B7A6F"/>
+            </a:solidFill>
+            <a:prstDash val="solid"/>
+          </a:ln>
+        </p:spPr>
+      </p:sp>
+      <p:sp>
+        <p:nvSpPr>
+          <p:cNvPr id="31" name="Text 28"/>
           <p:cNvSpPr txBox="1"/>
           <p:nvPr/>
         </p:nvSpPr>
         <p:spPr>
           <a:xfrm>
-            <a:off x="576072" y="1883664"/>
-            <a:ext cx="1225296" cy="274320"/>
+            <a:off x="2606040" y="2788920"/>
+            <a:ext cx="2194560" cy="566928"/>
           </a:xfrm>
           <a:prstGeom prst="rect">
             <a:avLst/>
@@ -25834,88 +26589,146 @@
           <a:ln/>
         </p:spPr>
         <p:txBody>
-          <a:bodyPr wrap="square" lIns="0" tIns="0" rIns="0" bIns="0" rtlCol="0" anchor="t"/>
-          <a:lstStyle/>
-          <a:p>
-            <a:pPr indent="0" marL="0">
-              <a:buNone/>
-            </a:pPr>
-            <a:r>
-              <a:rPr lang="en-US" sz="1200" b="1" dirty="0">
-                <a:solidFill>
-                  <a:srgbClr val="1D1D1F"/>
+          <a:bodyPr wrap="square" lIns="0" tIns="0" rIns="0" bIns="0" rtlCol="0" anchor="ctr"/>
+          <a:lstStyle/>
+          <a:p>
+            <a:pPr algn="ctr" indent="0" marL="0">
+              <a:buNone/>
+            </a:pPr>
+            <a:r>
+              <a:rPr lang="en-US" sz="1050" b="1" dirty="0">
+                <a:solidFill>
+                  <a:srgbClr val="FFFFFF"/>
                 </a:solidFill>
                 <a:latin typeface="SF Pro Display" pitchFamily="34" charset="0"/>
                 <a:ea typeface="SF Pro Display" pitchFamily="34" charset="-122"/>
                 <a:cs typeface="SF Pro Display" pitchFamily="34" charset="-120"/>
               </a:rPr>
-              <a:t>Verify it</a:t>
-            </a:r>
-            <a:endParaRPr lang="en-US" sz="1200" dirty="0"/>
-          </a:p>
-        </p:txBody>
-      </p:sp>
-      <p:sp>
-        <p:nvSpPr>
-          <p:cNvPr id="10" name="Text 7"/>
-          <p:cNvSpPr txBox="1"/>
-          <p:nvPr/>
-        </p:nvSpPr>
-        <p:spPr>
-          <a:xfrm>
-            <a:off x="576072" y="2176272"/>
-            <a:ext cx="1225296" cy="978408"/>
-          </a:xfrm>
-          <a:prstGeom prst="rect">
-            <a:avLst/>
-          </a:prstGeom>
-          <a:noFill/>
-          <a:ln/>
-        </p:spPr>
-        <p:txBody>
-          <a:bodyPr wrap="square" lIns="0" tIns="0" rIns="0" bIns="0" rtlCol="0" anchor="t"/>
-          <a:lstStyle/>
-          <a:p>
-            <a:pPr indent="0" marL="0">
-              <a:buNone/>
-            </a:pPr>
-            <a:r>
-              <a:rPr lang="en-US" sz="950" dirty="0">
-                <a:solidFill>
-                  <a:srgbClr val="6E6E73"/>
+              <a:t>5  One light offer</a:t>
+            </a:r>
+            <a:endParaRPr lang="en-US" sz="1050" dirty="0"/>
+          </a:p>
+          <a:p>
+            <a:pPr algn="ctr" indent="0" marL="0">
+              <a:buNone/>
+            </a:pPr>
+            <a:r>
+              <a:rPr lang="en-US" sz="800" dirty="0">
+                <a:solidFill>
+                  <a:srgbClr val="FFFFFF"/>
                 </a:solidFill>
                 <a:latin typeface="SF Pro Text" pitchFamily="34" charset="0"/>
                 <a:ea typeface="SF Pro Text" pitchFamily="34" charset="-122"/>
                 <a:cs typeface="SF Pro Text" pitchFamily="34" charset="-120"/>
               </a:rPr>
-              <a:t>Exact words, checked against the recording or notes.</a:t>
-            </a:r>
-            <a:endParaRPr lang="en-US" sz="950" dirty="0"/>
-          </a:p>
-        </p:txBody>
-      </p:sp>
-      <p:sp>
-        <p:nvSpPr>
-          <p:cNvPr id="11" name="Shape 8"/>
+              <a:t>Up to $20 credit or a 1-hr voucher</a:t>
+            </a:r>
+            <a:endParaRPr lang="en-US" sz="1050" dirty="0"/>
+          </a:p>
+        </p:txBody>
+      </p:sp>
+      <p:sp>
+        <p:nvSpPr>
+          <p:cNvPr id="32" name="Shape 29"/>
           <p:cNvSpPr/>
           <p:nvPr/>
         </p:nvSpPr>
         <p:spPr>
           <a:xfrm>
-            <a:off x="2103120" y="1280160"/>
-            <a:ext cx="1554480" cy="1965960"/>
+            <a:off x="4846320" y="3072384"/>
+            <a:ext cx="1234440" cy="0"/>
+          </a:xfrm>
+          <a:prstGeom prst="line">
+            <a:avLst/>
+          </a:prstGeom>
+          <a:noFill/>
+          <a:ln w="12700">
+            <a:solidFill>
+              <a:srgbClr val="6E6E73"/>
+            </a:solidFill>
+            <a:prstDash val="solid"/>
+            <a:tailEnd type="triangle"/>
+          </a:ln>
+        </p:spPr>
+      </p:sp>
+      <p:sp>
+        <p:nvSpPr>
+          <p:cNvPr id="33" name="Text 30"/>
+          <p:cNvSpPr txBox="1"/>
+          <p:nvPr/>
+        </p:nvSpPr>
+        <p:spPr>
+          <a:xfrm>
+            <a:off x="4846320" y="2688336"/>
+            <a:ext cx="1234440" cy="347472"/>
+          </a:xfrm>
+          <a:prstGeom prst="rect">
+            <a:avLst/>
+          </a:prstGeom>
+          <a:noFill/>
+          <a:ln/>
+        </p:spPr>
+        <p:txBody>
+          <a:bodyPr wrap="square" lIns="0" tIns="0" rIns="0" bIns="0" rtlCol="0" anchor="b"/>
+          <a:lstStyle/>
+          <a:p>
+            <a:pPr algn="ctr" indent="0" marL="0">
+              <a:buNone/>
+            </a:pPr>
+            <a:r>
+              <a:rPr lang="en-US" sz="800" b="1" dirty="0">
+                <a:solidFill>
+                  <a:srgbClr val="6E6E73"/>
+                </a:solidFill>
+                <a:latin typeface="SF Pro Text" pitchFamily="34" charset="0"/>
+                <a:ea typeface="SF Pro Text" pitchFamily="34" charset="-122"/>
+                <a:cs typeface="SF Pro Text" pitchFamily="34" charset="-120"/>
+              </a:rPr>
+              <a:t>Declined or</a:t>
+            </a:r>
+            <a:endParaRPr lang="en-US" sz="800" dirty="0"/>
+          </a:p>
+          <a:p>
+            <a:pPr algn="ctr" indent="0" marL="0">
+              <a:buNone/>
+            </a:pPr>
+            <a:r>
+              <a:rPr lang="en-US" sz="800" b="1" dirty="0">
+                <a:solidFill>
+                  <a:srgbClr val="6E6E73"/>
+                </a:solidFill>
+                <a:latin typeface="SF Pro Text" pitchFamily="34" charset="0"/>
+                <a:ea typeface="SF Pro Text" pitchFamily="34" charset="-122"/>
+                <a:cs typeface="SF Pro Text" pitchFamily="34" charset="-120"/>
+              </a:rPr>
+              <a:t>not retainable</a:t>
+            </a:r>
+            <a:endParaRPr lang="en-US" sz="800" dirty="0"/>
+          </a:p>
+        </p:txBody>
+      </p:sp>
+      <p:sp>
+        <p:nvSpPr>
+          <p:cNvPr id="34" name="Shape 31"/>
+          <p:cNvSpPr/>
+          <p:nvPr/>
+        </p:nvSpPr>
+        <p:spPr>
+          <a:xfrm>
+            <a:off x="6080760" y="2788920"/>
+            <a:ext cx="2651760" cy="566928"/>
           </a:xfrm>
           <a:prstGeom prst="roundRect">
             <a:avLst>
-              <a:gd name="adj" fmla="val 4706"/>
+              <a:gd name="adj" fmla="val 12903"/>
             </a:avLst>
           </a:prstGeom>
           <a:solidFill>
-            <a:srgbClr val="FFFFFF"/>
+            <a:srgbClr val="1D1D1F"/>
           </a:solidFill>
-          <a:ln w="9525">
+          <a:ln w="12700">
             <a:solidFill>
-              <a:srgbClr val="DCE1E7"/>
+              <a:srgbClr val="1D1D1F"/>
             </a:solidFill>
             <a:prstDash val="solid"/>
           </a:ln>
@@ -25923,39 +26736,14 @@
       </p:sp>
       <p:sp>
         <p:nvSpPr>
-          <p:cNvPr id="12" name="Shape 9"/>
-          <p:cNvSpPr/>
-          <p:nvPr/>
-        </p:nvSpPr>
-        <p:spPr>
-          <a:xfrm>
-            <a:off x="2267712" y="1463040"/>
-            <a:ext cx="274320" cy="274320"/>
-          </a:xfrm>
-          <a:prstGeom prst="ellipse">
-            <a:avLst/>
-          </a:prstGeom>
-          <a:solidFill>
-            <a:srgbClr val="E3F4F1"/>
-          </a:solidFill>
-          <a:ln w="12700">
-            <a:solidFill>
-              <a:srgbClr val="E3F4F1"/>
-            </a:solidFill>
-            <a:prstDash val="solid"/>
-          </a:ln>
-        </p:spPr>
-      </p:sp>
-      <p:sp>
-        <p:nvSpPr>
-          <p:cNvPr id="13" name="Text 10"/>
+          <p:cNvPr id="35" name="Text 32"/>
           <p:cNvSpPr txBox="1"/>
           <p:nvPr/>
         </p:nvSpPr>
         <p:spPr>
           <a:xfrm>
-            <a:off x="2267712" y="1463040"/>
-            <a:ext cx="274320" cy="274320"/>
+            <a:off x="6126480" y="2788920"/>
+            <a:ext cx="2560320" cy="566928"/>
           </a:xfrm>
           <a:prstGeom prst="rect">
             <a:avLst/>
@@ -25971,614 +26759,46 @@
               <a:buNone/>
             </a:pPr>
             <a:r>
-              <a:rPr lang="en-US" sz="900" b="1" dirty="0">
-                <a:solidFill>
-                  <a:srgbClr val="0B7A6F"/>
+              <a:rPr lang="en-US" sz="1050" b="1" dirty="0">
+                <a:solidFill>
+                  <a:srgbClr val="FFFFFF"/>
                 </a:solidFill>
                 <a:latin typeface="SF Pro Display" pitchFamily="34" charset="0"/>
                 <a:ea typeface="SF Pro Display" pitchFamily="34" charset="-122"/>
                 <a:cs typeface="SF Pro Display" pitchFamily="34" charset="-120"/>
               </a:rPr>
-              <a:t>2</a:t>
-            </a:r>
-            <a:endParaRPr lang="en-US" sz="900" dirty="0"/>
-          </a:p>
-        </p:txBody>
-      </p:sp>
-      <p:sp>
-        <p:nvSpPr>
-          <p:cNvPr id="14" name="Text 11"/>
-          <p:cNvSpPr txBox="1"/>
-          <p:nvPr/>
-        </p:nvSpPr>
-        <p:spPr>
-          <a:xfrm>
-            <a:off x="2267712" y="1883664"/>
-            <a:ext cx="1225296" cy="274320"/>
-          </a:xfrm>
-          <a:prstGeom prst="rect">
-            <a:avLst/>
-          </a:prstGeom>
-          <a:noFill/>
-          <a:ln/>
-        </p:spPr>
-        <p:txBody>
-          <a:bodyPr wrap="square" lIns="0" tIns="0" rIns="0" bIns="0" rtlCol="0" anchor="t"/>
-          <a:lstStyle/>
-          <a:p>
-            <a:pPr indent="0" marL="0">
-              <a:buNone/>
-            </a:pPr>
-            <a:r>
-              <a:rPr lang="en-US" sz="1200" b="1" dirty="0">
-                <a:solidFill>
-                  <a:srgbClr val="1D1D1F"/>
-                </a:solidFill>
-                <a:latin typeface="SF Pro Display" pitchFamily="34" charset="0"/>
-                <a:ea typeface="SF Pro Display" pitchFamily="34" charset="-122"/>
-                <a:cs typeface="SF Pro Display" pitchFamily="34" charset="-120"/>
-              </a:rPr>
-              <a:t>Refund the gap</a:t>
-            </a:r>
-            <a:endParaRPr lang="en-US" sz="1200" dirty="0"/>
-          </a:p>
-        </p:txBody>
-      </p:sp>
-      <p:sp>
-        <p:nvSpPr>
-          <p:cNvPr id="15" name="Text 12"/>
-          <p:cNvSpPr txBox="1"/>
-          <p:nvPr/>
-        </p:nvSpPr>
-        <p:spPr>
-          <a:xfrm>
-            <a:off x="2267712" y="2176272"/>
-            <a:ext cx="1225296" cy="978408"/>
-          </a:xfrm>
-          <a:prstGeom prst="rect">
-            <a:avLst/>
-          </a:prstGeom>
-          <a:noFill/>
-          <a:ln/>
-        </p:spPr>
-        <p:txBody>
-          <a:bodyPr wrap="square" lIns="0" tIns="0" rIns="0" bIns="0" rtlCol="0" anchor="t"/>
-          <a:lstStyle/>
-          <a:p>
-            <a:pPr indent="0" marL="0">
-              <a:buNone/>
-            </a:pPr>
-            <a:r>
-              <a:rPr lang="en-US" sz="950" dirty="0">
-                <a:solidFill>
-                  <a:srgbClr val="6E6E73"/>
+              <a:t>6  Waive the ETF, cancel FC</a:t>
+            </a:r>
+            <a:endParaRPr lang="en-US" sz="1050" dirty="0"/>
+          </a:p>
+          <a:p>
+            <a:pPr algn="ctr" indent="0" marL="0">
+              <a:buNone/>
+            </a:pPr>
+            <a:r>
+              <a:rPr lang="en-US" sz="800" dirty="0">
+                <a:solidFill>
+                  <a:srgbClr val="FFFFFF"/>
                 </a:solidFill>
                 <a:latin typeface="SF Pro Text" pitchFamily="34" charset="0"/>
                 <a:ea typeface="SF Pro Text" pitchFamily="34" charset="-122"/>
                 <a:cs typeface="SF Pro Text" pitchFamily="34" charset="-120"/>
               </a:rPr>
-              <a:t>Promised $49 MF, charged $59? Refund the $10.</a:t>
-            </a:r>
-            <a:endParaRPr lang="en-US" sz="950" dirty="0"/>
-          </a:p>
-        </p:txBody>
-      </p:sp>
-      <p:sp>
-        <p:nvSpPr>
-          <p:cNvPr id="16" name="Shape 13"/>
+              <a:t>No ETF: the error was ours</a:t>
+            </a:r>
+            <a:endParaRPr lang="en-US" sz="1050" dirty="0"/>
+          </a:p>
+        </p:txBody>
+      </p:sp>
+      <p:sp>
+        <p:nvSpPr>
+          <p:cNvPr id="36" name="Shape 33"/>
           <p:cNvSpPr/>
           <p:nvPr/>
         </p:nvSpPr>
         <p:spPr>
           <a:xfrm>
-            <a:off x="3794760" y="1280160"/>
-            <a:ext cx="1554480" cy="1965960"/>
-          </a:xfrm>
-          <a:prstGeom prst="roundRect">
-            <a:avLst>
-              <a:gd name="adj" fmla="val 4706"/>
-            </a:avLst>
-          </a:prstGeom>
-          <a:solidFill>
-            <a:srgbClr val="FFFFFF"/>
-          </a:solidFill>
-          <a:ln w="9525">
-            <a:solidFill>
-              <a:srgbClr val="DCE1E7"/>
-            </a:solidFill>
-            <a:prstDash val="solid"/>
-          </a:ln>
-        </p:spPr>
-      </p:sp>
-      <p:sp>
-        <p:nvSpPr>
-          <p:cNvPr id="17" name="Shape 14"/>
-          <p:cNvSpPr/>
-          <p:nvPr/>
-        </p:nvSpPr>
-        <p:spPr>
-          <a:xfrm>
-            <a:off x="3959352" y="1463040"/>
-            <a:ext cx="274320" cy="274320"/>
-          </a:xfrm>
-          <a:prstGeom prst="ellipse">
-            <a:avLst/>
-          </a:prstGeom>
-          <a:solidFill>
-            <a:srgbClr val="E3F4F1"/>
-          </a:solidFill>
-          <a:ln w="12700">
-            <a:solidFill>
-              <a:srgbClr val="E3F4F1"/>
-            </a:solidFill>
-            <a:prstDash val="solid"/>
-          </a:ln>
-        </p:spPr>
-      </p:sp>
-      <p:sp>
-        <p:nvSpPr>
-          <p:cNvPr id="18" name="Text 15"/>
-          <p:cNvSpPr txBox="1"/>
-          <p:nvPr/>
-        </p:nvSpPr>
-        <p:spPr>
-          <a:xfrm>
-            <a:off x="3959352" y="1463040"/>
-            <a:ext cx="274320" cy="274320"/>
-          </a:xfrm>
-          <a:prstGeom prst="rect">
-            <a:avLst/>
-          </a:prstGeom>
-          <a:noFill/>
-          <a:ln/>
-        </p:spPr>
-        <p:txBody>
-          <a:bodyPr wrap="square" lIns="0" tIns="0" rIns="0" bIns="0" rtlCol="0" anchor="ctr"/>
-          <a:lstStyle/>
-          <a:p>
-            <a:pPr algn="ctr" indent="0" marL="0">
-              <a:buNone/>
-            </a:pPr>
-            <a:r>
-              <a:rPr lang="en-US" sz="900" b="1" dirty="0">
-                <a:solidFill>
-                  <a:srgbClr val="0B7A6F"/>
-                </a:solidFill>
-                <a:latin typeface="SF Pro Display" pitchFamily="34" charset="0"/>
-                <a:ea typeface="SF Pro Display" pitchFamily="34" charset="-122"/>
-                <a:cs typeface="SF Pro Display" pitchFamily="34" charset="-120"/>
-              </a:rPr>
-              <a:t>3</a:t>
-            </a:r>
-            <a:endParaRPr lang="en-US" sz="900" dirty="0"/>
-          </a:p>
-        </p:txBody>
-      </p:sp>
-      <p:sp>
-        <p:nvSpPr>
-          <p:cNvPr id="19" name="Text 16"/>
-          <p:cNvSpPr txBox="1"/>
-          <p:nvPr/>
-        </p:nvSpPr>
-        <p:spPr>
-          <a:xfrm>
-            <a:off x="3959352" y="1883664"/>
-            <a:ext cx="1225296" cy="274320"/>
-          </a:xfrm>
-          <a:prstGeom prst="rect">
-            <a:avLst/>
-          </a:prstGeom>
-          <a:noFill/>
-          <a:ln/>
-        </p:spPr>
-        <p:txBody>
-          <a:bodyPr wrap="square" lIns="0" tIns="0" rIns="0" bIns="0" rtlCol="0" anchor="t"/>
-          <a:lstStyle/>
-          <a:p>
-            <a:pPr indent="0" marL="0">
-              <a:buNone/>
-            </a:pPr>
-            <a:r>
-              <a:rPr lang="en-US" sz="1200" b="1" dirty="0">
-                <a:solidFill>
-                  <a:srgbClr val="1D1D1F"/>
-                </a:solidFill>
-                <a:latin typeface="SF Pro Display" pitchFamily="34" charset="0"/>
-                <a:ea typeface="SF Pro Display" pitchFamily="34" charset="-122"/>
-                <a:cs typeface="SF Pro Display" pitchFamily="34" charset="-120"/>
-              </a:rPr>
-              <a:t>Own the error</a:t>
-            </a:r>
-            <a:endParaRPr lang="en-US" sz="1200" dirty="0"/>
-          </a:p>
-        </p:txBody>
-      </p:sp>
-      <p:sp>
-        <p:nvSpPr>
-          <p:cNvPr id="20" name="Text 17"/>
-          <p:cNvSpPr txBox="1"/>
-          <p:nvPr/>
-        </p:nvSpPr>
-        <p:spPr>
-          <a:xfrm>
-            <a:off x="3959352" y="2176272"/>
-            <a:ext cx="1225296" cy="978408"/>
-          </a:xfrm>
-          <a:prstGeom prst="rect">
-            <a:avLst/>
-          </a:prstGeom>
-          <a:noFill/>
-          <a:ln/>
-        </p:spPr>
-        <p:txBody>
-          <a:bodyPr wrap="square" lIns="0" tIns="0" rIns="0" bIns="0" rtlCol="0" anchor="t"/>
-          <a:lstStyle/>
-          <a:p>
-            <a:pPr indent="0" marL="0">
-              <a:buNone/>
-            </a:pPr>
-            <a:r>
-              <a:rPr lang="en-US" sz="950" dirty="0">
-                <a:solidFill>
-                  <a:srgbClr val="6E6E73"/>
-                </a:solidFill>
-                <a:latin typeface="SF Pro Text" pitchFamily="34" charset="0"/>
-                <a:ea typeface="SF Pro Text" pitchFamily="34" charset="-122"/>
-                <a:cs typeface="SF Pro Text" pitchFamily="34" charset="-120"/>
-              </a:rPr>
-              <a:t>Say it was ours. Not "a misunderstanding".</a:t>
-            </a:r>
-            <a:endParaRPr lang="en-US" sz="950" dirty="0"/>
-          </a:p>
-        </p:txBody>
-      </p:sp>
-      <p:sp>
-        <p:nvSpPr>
-          <p:cNvPr id="21" name="Shape 18"/>
-          <p:cNvSpPr/>
-          <p:nvPr/>
-        </p:nvSpPr>
-        <p:spPr>
-          <a:xfrm>
-            <a:off x="5486400" y="1280160"/>
-            <a:ext cx="1554480" cy="1965960"/>
-          </a:xfrm>
-          <a:prstGeom prst="roundRect">
-            <a:avLst>
-              <a:gd name="adj" fmla="val 4706"/>
-            </a:avLst>
-          </a:prstGeom>
-          <a:solidFill>
-            <a:srgbClr val="FFFFFF"/>
-          </a:solidFill>
-          <a:ln w="9525">
-            <a:solidFill>
-              <a:srgbClr val="DCE1E7"/>
-            </a:solidFill>
-            <a:prstDash val="solid"/>
-          </a:ln>
-        </p:spPr>
-      </p:sp>
-      <p:sp>
-        <p:nvSpPr>
-          <p:cNvPr id="22" name="Shape 19"/>
-          <p:cNvSpPr/>
-          <p:nvPr/>
-        </p:nvSpPr>
-        <p:spPr>
-          <a:xfrm>
-            <a:off x="5650992" y="1463040"/>
-            <a:ext cx="274320" cy="274320"/>
-          </a:xfrm>
-          <a:prstGeom prst="ellipse">
-            <a:avLst/>
-          </a:prstGeom>
-          <a:solidFill>
-            <a:srgbClr val="E3F4F1"/>
-          </a:solidFill>
-          <a:ln w="12700">
-            <a:solidFill>
-              <a:srgbClr val="E3F4F1"/>
-            </a:solidFill>
-            <a:prstDash val="solid"/>
-          </a:ln>
-        </p:spPr>
-      </p:sp>
-      <p:sp>
-        <p:nvSpPr>
-          <p:cNvPr id="23" name="Text 20"/>
-          <p:cNvSpPr txBox="1"/>
-          <p:nvPr/>
-        </p:nvSpPr>
-        <p:spPr>
-          <a:xfrm>
-            <a:off x="5650992" y="1463040"/>
-            <a:ext cx="274320" cy="274320"/>
-          </a:xfrm>
-          <a:prstGeom prst="rect">
-            <a:avLst/>
-          </a:prstGeom>
-          <a:noFill/>
-          <a:ln/>
-        </p:spPr>
-        <p:txBody>
-          <a:bodyPr wrap="square" lIns="0" tIns="0" rIns="0" bIns="0" rtlCol="0" anchor="ctr"/>
-          <a:lstStyle/>
-          <a:p>
-            <a:pPr algn="ctr" indent="0" marL="0">
-              <a:buNone/>
-            </a:pPr>
-            <a:r>
-              <a:rPr lang="en-US" sz="900" b="1" dirty="0">
-                <a:solidFill>
-                  <a:srgbClr val="0B7A6F"/>
-                </a:solidFill>
-                <a:latin typeface="SF Pro Display" pitchFamily="34" charset="0"/>
-                <a:ea typeface="SF Pro Display" pitchFamily="34" charset="-122"/>
-                <a:cs typeface="SF Pro Display" pitchFamily="34" charset="-120"/>
-              </a:rPr>
-              <a:t>4</a:t>
-            </a:r>
-            <a:endParaRPr lang="en-US" sz="900" dirty="0"/>
-          </a:p>
-        </p:txBody>
-      </p:sp>
-      <p:sp>
-        <p:nvSpPr>
-          <p:cNvPr id="24" name="Text 21"/>
-          <p:cNvSpPr txBox="1"/>
-          <p:nvPr/>
-        </p:nvSpPr>
-        <p:spPr>
-          <a:xfrm>
-            <a:off x="5650992" y="1883664"/>
-            <a:ext cx="1225296" cy="274320"/>
-          </a:xfrm>
-          <a:prstGeom prst="rect">
-            <a:avLst/>
-          </a:prstGeom>
-          <a:noFill/>
-          <a:ln/>
-        </p:spPr>
-        <p:txBody>
-          <a:bodyPr wrap="square" lIns="0" tIns="0" rIns="0" bIns="0" rtlCol="0" anchor="t"/>
-          <a:lstStyle/>
-          <a:p>
-            <a:pPr indent="0" marL="0">
-              <a:buNone/>
-            </a:pPr>
-            <a:r>
-              <a:rPr lang="en-US" sz="1200" b="1" dirty="0">
-                <a:solidFill>
-                  <a:srgbClr val="1D1D1F"/>
-                </a:solidFill>
-                <a:latin typeface="SF Pro Display" pitchFamily="34" charset="0"/>
-                <a:ea typeface="SF Pro Display" pitchFamily="34" charset="-122"/>
-                <a:cs typeface="SF Pro Display" pitchFamily="34" charset="-120"/>
-              </a:rPr>
-              <a:t>Correct it</a:t>
-            </a:r>
-            <a:endParaRPr lang="en-US" sz="1200" dirty="0"/>
-          </a:p>
-        </p:txBody>
-      </p:sp>
-      <p:sp>
-        <p:nvSpPr>
-          <p:cNvPr id="25" name="Text 22"/>
-          <p:cNvSpPr txBox="1"/>
-          <p:nvPr/>
-        </p:nvSpPr>
-        <p:spPr>
-          <a:xfrm>
-            <a:off x="5650992" y="2176272"/>
-            <a:ext cx="1225296" cy="978408"/>
-          </a:xfrm>
-          <a:prstGeom prst="rect">
-            <a:avLst/>
-          </a:prstGeom>
-          <a:noFill/>
-          <a:ln/>
-        </p:spPr>
-        <p:txBody>
-          <a:bodyPr wrap="square" lIns="0" tIns="0" rIns="0" bIns="0" rtlCol="0" anchor="t"/>
-          <a:lstStyle/>
-          <a:p>
-            <a:pPr indent="0" marL="0">
-              <a:buNone/>
-            </a:pPr>
-            <a:r>
-              <a:rPr lang="en-US" sz="950" dirty="0">
-                <a:solidFill>
-                  <a:srgbClr val="6E6E73"/>
-                </a:solidFill>
-                <a:latin typeface="SF Pro Text" pitchFamily="34" charset="0"/>
-                <a:ea typeface="SF Pro Text" pitchFamily="34" charset="-122"/>
-                <a:cs typeface="SF Pro Text" pitchFamily="34" charset="-120"/>
-              </a:rPr>
-              <a:t>Fix charges or expectations. Explain what changed.</a:t>
-            </a:r>
-            <a:endParaRPr lang="en-US" sz="950" dirty="0"/>
-          </a:p>
-        </p:txBody>
-      </p:sp>
-      <p:sp>
-        <p:nvSpPr>
-          <p:cNvPr id="26" name="Shape 23"/>
-          <p:cNvSpPr/>
-          <p:nvPr/>
-        </p:nvSpPr>
-        <p:spPr>
-          <a:xfrm>
-            <a:off x="7178040" y="1280160"/>
-            <a:ext cx="1554480" cy="1965960"/>
-          </a:xfrm>
-          <a:prstGeom prst="roundRect">
-            <a:avLst>
-              <a:gd name="adj" fmla="val 4706"/>
-            </a:avLst>
-          </a:prstGeom>
-          <a:solidFill>
-            <a:srgbClr val="FFFFFF"/>
-          </a:solidFill>
-          <a:ln w="9525">
-            <a:solidFill>
-              <a:srgbClr val="DCE1E7"/>
-            </a:solidFill>
-            <a:prstDash val="solid"/>
-          </a:ln>
-        </p:spPr>
-      </p:sp>
-      <p:sp>
-        <p:nvSpPr>
-          <p:cNvPr id="27" name="Shape 24"/>
-          <p:cNvSpPr/>
-          <p:nvPr/>
-        </p:nvSpPr>
-        <p:spPr>
-          <a:xfrm>
-            <a:off x="7342632" y="1463040"/>
-            <a:ext cx="274320" cy="274320"/>
-          </a:xfrm>
-          <a:prstGeom prst="ellipse">
-            <a:avLst/>
-          </a:prstGeom>
-          <a:solidFill>
-            <a:srgbClr val="E3F4F1"/>
-          </a:solidFill>
-          <a:ln w="12700">
-            <a:solidFill>
-              <a:srgbClr val="E3F4F1"/>
-            </a:solidFill>
-            <a:prstDash val="solid"/>
-          </a:ln>
-        </p:spPr>
-      </p:sp>
-      <p:sp>
-        <p:nvSpPr>
-          <p:cNvPr id="28" name="Text 25"/>
-          <p:cNvSpPr txBox="1"/>
-          <p:nvPr/>
-        </p:nvSpPr>
-        <p:spPr>
-          <a:xfrm>
-            <a:off x="7342632" y="1463040"/>
-            <a:ext cx="274320" cy="274320"/>
-          </a:xfrm>
-          <a:prstGeom prst="rect">
-            <a:avLst/>
-          </a:prstGeom>
-          <a:noFill/>
-          <a:ln/>
-        </p:spPr>
-        <p:txBody>
-          <a:bodyPr wrap="square" lIns="0" tIns="0" rIns="0" bIns="0" rtlCol="0" anchor="ctr"/>
-          <a:lstStyle/>
-          <a:p>
-            <a:pPr algn="ctr" indent="0" marL="0">
-              <a:buNone/>
-            </a:pPr>
-            <a:r>
-              <a:rPr lang="en-US" sz="900" b="1" dirty="0">
-                <a:solidFill>
-                  <a:srgbClr val="0B7A6F"/>
-                </a:solidFill>
-                <a:latin typeface="SF Pro Display" pitchFamily="34" charset="0"/>
-                <a:ea typeface="SF Pro Display" pitchFamily="34" charset="-122"/>
-                <a:cs typeface="SF Pro Display" pitchFamily="34" charset="-120"/>
-              </a:rPr>
-              <a:t>5</a:t>
-            </a:r>
-            <a:endParaRPr lang="en-US" sz="900" dirty="0"/>
-          </a:p>
-        </p:txBody>
-      </p:sp>
-      <p:sp>
-        <p:nvSpPr>
-          <p:cNvPr id="29" name="Text 26"/>
-          <p:cNvSpPr txBox="1"/>
-          <p:nvPr/>
-        </p:nvSpPr>
-        <p:spPr>
-          <a:xfrm>
-            <a:off x="7342632" y="1883664"/>
-            <a:ext cx="1225296" cy="274320"/>
-          </a:xfrm>
-          <a:prstGeom prst="rect">
-            <a:avLst/>
-          </a:prstGeom>
-          <a:noFill/>
-          <a:ln/>
-        </p:spPr>
-        <p:txBody>
-          <a:bodyPr wrap="square" lIns="0" tIns="0" rIns="0" bIns="0" rtlCol="0" anchor="t"/>
-          <a:lstStyle/>
-          <a:p>
-            <a:pPr indent="0" marL="0">
-              <a:buNone/>
-            </a:pPr>
-            <a:r>
-              <a:rPr lang="en-US" sz="1200" b="1" dirty="0">
-                <a:solidFill>
-                  <a:srgbClr val="1D1D1F"/>
-                </a:solidFill>
-                <a:latin typeface="SF Pro Display" pitchFamily="34" charset="0"/>
-                <a:ea typeface="SF Pro Display" pitchFamily="34" charset="-122"/>
-                <a:cs typeface="SF Pro Display" pitchFamily="34" charset="-120"/>
-              </a:rPr>
-              <a:t>One light offer</a:t>
-            </a:r>
-            <a:endParaRPr lang="en-US" sz="1200" dirty="0"/>
-          </a:p>
-        </p:txBody>
-      </p:sp>
-      <p:sp>
-        <p:nvSpPr>
-          <p:cNvPr id="30" name="Text 27"/>
-          <p:cNvSpPr txBox="1"/>
-          <p:nvPr/>
-        </p:nvSpPr>
-        <p:spPr>
-          <a:xfrm>
-            <a:off x="7342632" y="2176272"/>
-            <a:ext cx="1225296" cy="978408"/>
-          </a:xfrm>
-          <a:prstGeom prst="rect">
-            <a:avLst/>
-          </a:prstGeom>
-          <a:noFill/>
-          <a:ln/>
-        </p:spPr>
-        <p:txBody>
-          <a:bodyPr wrap="square" lIns="0" tIns="0" rIns="0" bIns="0" rtlCol="0" anchor="t"/>
-          <a:lstStyle/>
-          <a:p>
-            <a:pPr indent="0" marL="0">
-              <a:buNone/>
-            </a:pPr>
-            <a:r>
-              <a:rPr lang="en-US" sz="950" dirty="0">
-                <a:solidFill>
-                  <a:srgbClr val="6E6E73"/>
-                </a:solidFill>
-                <a:latin typeface="SF Pro Text" pitchFamily="34" charset="0"/>
-                <a:ea typeface="SF Pro Text" pitchFamily="34" charset="-122"/>
-                <a:cs typeface="SF Pro Text" pitchFamily="34" charset="-120"/>
-              </a:rPr>
-              <a:t>Up to $20 credit or a 1-hr voucher. Declined? Waive ETF, cancel.</a:t>
-            </a:r>
-            <a:endParaRPr lang="en-US" sz="950" dirty="0"/>
-          </a:p>
-        </p:txBody>
-      </p:sp>
-      <p:sp>
-        <p:nvSpPr>
-          <p:cNvPr id="31" name="Shape 28"/>
-          <p:cNvSpPr/>
-          <p:nvPr/>
-        </p:nvSpPr>
-        <p:spPr>
-          <a:xfrm>
-            <a:off x="411480" y="3429000"/>
+            <a:off x="411480" y="3566160"/>
             <a:ext cx="8321040" cy="384048"/>
           </a:xfrm>
           <a:prstGeom prst="roundRect">
@@ -26599,7 +26819,7 @@
       </p:sp>
       <p:pic>
         <p:nvPicPr>
-          <p:cNvPr id="32" name="Image 0" descr="preencoded.png">    </p:cNvPr>
+          <p:cNvPr id="37" name="Image 0" descr="preencoded.png">    </p:cNvPr>
           <p:cNvPicPr>
             <a:picLocks noChangeAspect="1"/>
           </p:cNvPicPr>
@@ -26613,7 +26833,7 @@
         </p:blipFill>
         <p:spPr>
           <a:xfrm>
-            <a:off x="566928" y="3538728"/>
+            <a:off x="566928" y="3675888"/>
             <a:ext cx="164592" cy="164592"/>
           </a:xfrm>
           <a:prstGeom prst="rect">
@@ -26623,13 +26843,13 @@
       </p:pic>
       <p:sp>
         <p:nvSpPr>
-          <p:cNvPr id="33" name="Text 29"/>
+          <p:cNvPr id="38" name="Text 34"/>
           <p:cNvSpPr txBox="1"/>
           <p:nvPr/>
         </p:nvSpPr>
         <p:spPr>
           <a:xfrm>
-            <a:off x="822960" y="3529584"/>
+            <a:off x="822960" y="3666744"/>
             <a:ext cx="7772400" cy="201168"/>
           </a:xfrm>
           <a:prstGeom prst="rect">
@@ -26676,13 +26896,13 @@
       </p:sp>
       <p:sp>
         <p:nvSpPr>
-          <p:cNvPr id="34" name="Shape 30"/>
+          <p:cNvPr id="39" name="Shape 35"/>
           <p:cNvSpPr/>
           <p:nvPr/>
         </p:nvSpPr>
         <p:spPr>
           <a:xfrm>
-            <a:off x="411480" y="3977640"/>
+            <a:off x="411480" y="4114800"/>
             <a:ext cx="5669280" cy="292608"/>
           </a:xfrm>
           <a:prstGeom prst="roundRect">
@@ -26703,7 +26923,7 @@
       </p:sp>
       <p:pic>
         <p:nvPicPr>
-          <p:cNvPr id="35" name="Image 1" descr="preencoded.png">    </p:cNvPr>
+          <p:cNvPr id="40" name="Image 1" descr="preencoded.png">    </p:cNvPr>
           <p:cNvPicPr>
             <a:picLocks noChangeAspect="1"/>
           </p:cNvPicPr>
@@ -26717,7 +26937,7 @@
         </p:blipFill>
         <p:spPr>
           <a:xfrm>
-            <a:off x="521208" y="4050792"/>
+            <a:off x="521208" y="4187952"/>
             <a:ext cx="146304" cy="146304"/>
           </a:xfrm>
           <a:prstGeom prst="rect">
@@ -26727,13 +26947,13 @@
       </p:pic>
       <p:sp>
         <p:nvSpPr>
-          <p:cNvPr id="36" name="Text 31"/>
+          <p:cNvPr id="41" name="Text 36"/>
           <p:cNvSpPr txBox="1"/>
           <p:nvPr/>
         </p:nvSpPr>
         <p:spPr>
           <a:xfrm>
-            <a:off x="731520" y="3977640"/>
+            <a:off x="731520" y="4114800"/>
             <a:ext cx="5303520" cy="292608"/>
           </a:xfrm>
           <a:prstGeom prst="rect">
@@ -26775,6 +26995,425 @@
               <a:t>Misinformation: address incorrect claims about charges</a:t>
             </a:r>
             <a:endParaRPr lang="en-US" sz="950" dirty="0"/>
+          </a:p>
+        </p:txBody>
+      </p:sp>
+      <p:sp>
+        <p:nvSpPr>
+          <p:cNvPr id="42" name="pop1_2Panel"/>
+          <p:cNvSpPr/>
+          <p:nvPr/>
+        </p:nvSpPr>
+        <p:spPr>
+          <a:xfrm>
+            <a:off x="411480" y="2468880"/>
+            <a:ext cx="5120640" cy="1572768"/>
+          </a:xfrm>
+          <a:prstGeom prst="roundRect">
+            <a:avLst>
+              <a:gd name="adj" fmla="val 3488"/>
+            </a:avLst>
+          </a:prstGeom>
+          <a:solidFill>
+            <a:srgbClr val="FFFFFF"/>
+          </a:solidFill>
+          <a:ln w="19050">
+            <a:solidFill>
+              <a:srgbClr val="0B7A6F"/>
+            </a:solidFill>
+            <a:prstDash val="solid"/>
+          </a:ln>
+          <a:effectLst>
+            <a:outerShdw sx="100000" sy="100000" kx="0" ky="0" algn="bl" rotWithShape="0" blurRad="76200" dist="25400" dir="5400000">
+              <a:srgbClr val="000000">
+                <a:alpha val="18000"/>
+              </a:srgbClr>
+            </a:outerShdw>
+          </a:effectLst>
+        </p:spPr>
+      </p:sp>
+      <p:sp>
+        <p:nvSpPr>
+          <p:cNvPr id="43" name="pop1_2Title"/>
+          <p:cNvSpPr txBox="1"/>
+          <p:nvPr/>
+        </p:nvSpPr>
+        <p:spPr>
+          <a:xfrm>
+            <a:off x="548640" y="2523744"/>
+            <a:ext cx="2743200" cy="274320"/>
+          </a:xfrm>
+          <a:prstGeom prst="rect">
+            <a:avLst/>
+          </a:prstGeom>
+          <a:noFill/>
+          <a:ln/>
+        </p:spPr>
+        <p:txBody>
+          <a:bodyPr wrap="square" lIns="0" tIns="0" rIns="0" bIns="0" rtlCol="0" anchor="ctr"/>
+          <a:lstStyle/>
+          <a:p>
+            <a:pPr indent="0" marL="0">
+              <a:buNone/>
+            </a:pPr>
+            <a:r>
+              <a:rPr lang="en-US" sz="1100" b="1" dirty="0">
+                <a:solidFill>
+                  <a:srgbClr val="0B7A6F"/>
+                </a:solidFill>
+                <a:latin typeface="SF Pro Display" pitchFamily="34" charset="0"/>
+                <a:ea typeface="SF Pro Display" pitchFamily="34" charset="-122"/>
+                <a:cs typeface="SF Pro Display" pitchFamily="34" charset="-120"/>
+              </a:rPr>
+              <a:t>Sales call review</a:t>
+            </a:r>
+            <a:endParaRPr lang="en-US" sz="1100" dirty="0"/>
+          </a:p>
+        </p:txBody>
+      </p:sp>
+      <p:sp>
+        <p:nvSpPr>
+          <p:cNvPr id="44" name="pop1_2Num1"/>
+          <p:cNvSpPr/>
+          <p:nvPr/>
+        </p:nvSpPr>
+        <p:spPr>
+          <a:xfrm>
+            <a:off x="576072" y="2880360"/>
+            <a:ext cx="219456" cy="219456"/>
+          </a:xfrm>
+          <a:prstGeom prst="ellipse">
+            <a:avLst/>
+          </a:prstGeom>
+          <a:solidFill>
+            <a:srgbClr val="E3F4F1"/>
+          </a:solidFill>
+          <a:ln>
+            <a:solidFill>
+              <a:srgbClr val="E3F4F1"/>
+            </a:solidFill>
+          </a:ln>
+        </p:spPr>
+        <p:txBody>
+          <a:bodyPr wrap="square" lIns="0" tIns="0" rIns="0" bIns="0" rtlCol="0" anchor="ctr"/>
+          <a:lstStyle/>
+          <a:p>
+            <a:pPr algn="ctr" indent="0" marL="0">
+              <a:buNone/>
+            </a:pPr>
+            <a:r>
+              <a:rPr lang="en-US" sz="850" b="1" dirty="0">
+                <a:solidFill>
+                  <a:srgbClr val="0B7A6F"/>
+                </a:solidFill>
+                <a:latin typeface="SF Pro Display" pitchFamily="34" charset="0"/>
+                <a:ea typeface="SF Pro Display" pitchFamily="34" charset="-122"/>
+                <a:cs typeface="SF Pro Display" pitchFamily="34" charset="-120"/>
+              </a:rPr>
+              <a:t>1</a:t>
+            </a:r>
+            <a:endParaRPr lang="en-US" sz="850" dirty="0"/>
+          </a:p>
+        </p:txBody>
+      </p:sp>
+      <p:sp>
+        <p:nvSpPr>
+          <p:cNvPr id="45" name="pop1_2Row1"/>
+          <p:cNvSpPr txBox="1"/>
+          <p:nvPr/>
+        </p:nvSpPr>
+        <p:spPr>
+          <a:xfrm>
+            <a:off x="886968" y="2852928"/>
+            <a:ext cx="2103120" cy="274320"/>
+          </a:xfrm>
+          <a:prstGeom prst="rect">
+            <a:avLst/>
+          </a:prstGeom>
+          <a:noFill/>
+          <a:ln/>
+        </p:spPr>
+        <p:txBody>
+          <a:bodyPr wrap="square" lIns="0" tIns="0" rIns="0" bIns="0" rtlCol="0" anchor="ctr"/>
+          <a:lstStyle/>
+          <a:p>
+            <a:pPr indent="0" marL="0">
+              <a:buNone/>
+            </a:pPr>
+            <a:r>
+              <a:rPr lang="en-US" sz="1000" dirty="0">
+                <a:solidFill>
+                  <a:srgbClr val="1D1D1F"/>
+                </a:solidFill>
+                <a:latin typeface="SF Pro Text" pitchFamily="34" charset="0"/>
+                <a:ea typeface="SF Pro Text" pitchFamily="34" charset="-122"/>
+                <a:cs typeface="SF Pro Text" pitchFamily="34" charset="-120"/>
+              </a:rPr>
+              <a:t>Sales call review request</a:t>
+            </a:r>
+            <a:endParaRPr lang="en-US" sz="1000" dirty="0"/>
+          </a:p>
+        </p:txBody>
+      </p:sp>
+      <p:sp>
+        <p:nvSpPr>
+          <p:cNvPr id="46" name="pop1_2Num2"/>
+          <p:cNvSpPr/>
+          <p:nvPr/>
+        </p:nvSpPr>
+        <p:spPr>
+          <a:xfrm>
+            <a:off x="576072" y="3182112"/>
+            <a:ext cx="219456" cy="219456"/>
+          </a:xfrm>
+          <a:prstGeom prst="ellipse">
+            <a:avLst/>
+          </a:prstGeom>
+          <a:solidFill>
+            <a:srgbClr val="E3F4F1"/>
+          </a:solidFill>
+          <a:ln>
+            <a:solidFill>
+              <a:srgbClr val="E3F4F1"/>
+            </a:solidFill>
+          </a:ln>
+        </p:spPr>
+        <p:txBody>
+          <a:bodyPr wrap="square" lIns="0" tIns="0" rIns="0" bIns="0" rtlCol="0" anchor="ctr"/>
+          <a:lstStyle/>
+          <a:p>
+            <a:pPr algn="ctr" indent="0" marL="0">
+              <a:buNone/>
+            </a:pPr>
+            <a:r>
+              <a:rPr lang="en-US" sz="850" b="1" dirty="0">
+                <a:solidFill>
+                  <a:srgbClr val="0B7A6F"/>
+                </a:solidFill>
+                <a:latin typeface="SF Pro Display" pitchFamily="34" charset="0"/>
+                <a:ea typeface="SF Pro Display" pitchFamily="34" charset="-122"/>
+                <a:cs typeface="SF Pro Display" pitchFamily="34" charset="-120"/>
+              </a:rPr>
+              <a:t>2</a:t>
+            </a:r>
+            <a:endParaRPr lang="en-US" sz="850" dirty="0"/>
+          </a:p>
+        </p:txBody>
+      </p:sp>
+      <p:sp>
+        <p:nvSpPr>
+          <p:cNvPr id="47" name="pop1_2Row2"/>
+          <p:cNvSpPr txBox="1"/>
+          <p:nvPr/>
+        </p:nvSpPr>
+        <p:spPr>
+          <a:xfrm>
+            <a:off x="886968" y="3154680"/>
+            <a:ext cx="4480560" cy="274320"/>
+          </a:xfrm>
+          <a:prstGeom prst="rect">
+            <a:avLst/>
+          </a:prstGeom>
+          <a:noFill/>
+          <a:ln/>
+        </p:spPr>
+        <p:txBody>
+          <a:bodyPr wrap="square" lIns="0" tIns="0" rIns="0" bIns="0" rtlCol="0" anchor="ctr"/>
+          <a:lstStyle/>
+          <a:p>
+            <a:pPr indent="0" marL="0">
+              <a:buNone/>
+            </a:pPr>
+            <a:r>
+              <a:rPr lang="en-US" sz="1000" dirty="0">
+                <a:solidFill>
+                  <a:srgbClr val="1D1D1F"/>
+                </a:solidFill>
+                <a:latin typeface="SF Pro Text" pitchFamily="34" charset="0"/>
+                <a:ea typeface="SF Pro Text" pitchFamily="34" charset="-122"/>
+                <a:cs typeface="SF Pro Text" pitchFamily="34" charset="-120"/>
+              </a:rPr>
+              <a:t>Add an internal note with your escalation link</a:t>
+            </a:r>
+            <a:endParaRPr lang="en-US" sz="1000" dirty="0"/>
+          </a:p>
+        </p:txBody>
+      </p:sp>
+      <p:sp>
+        <p:nvSpPr>
+          <p:cNvPr id="48" name="pop1_2Num3"/>
+          <p:cNvSpPr/>
+          <p:nvPr/>
+        </p:nvSpPr>
+        <p:spPr>
+          <a:xfrm>
+            <a:off x="576072" y="3483864"/>
+            <a:ext cx="219456" cy="219456"/>
+          </a:xfrm>
+          <a:prstGeom prst="ellipse">
+            <a:avLst/>
+          </a:prstGeom>
+          <a:solidFill>
+            <a:srgbClr val="E3F4F1"/>
+          </a:solidFill>
+          <a:ln>
+            <a:solidFill>
+              <a:srgbClr val="E3F4F1"/>
+            </a:solidFill>
+          </a:ln>
+        </p:spPr>
+        <p:txBody>
+          <a:bodyPr wrap="square" lIns="0" tIns="0" rIns="0" bIns="0" rtlCol="0" anchor="ctr"/>
+          <a:lstStyle/>
+          <a:p>
+            <a:pPr algn="ctr" indent="0" marL="0">
+              <a:buNone/>
+            </a:pPr>
+            <a:r>
+              <a:rPr lang="en-US" sz="850" b="1" dirty="0">
+                <a:solidFill>
+                  <a:srgbClr val="0B7A6F"/>
+                </a:solidFill>
+                <a:latin typeface="SF Pro Display" pitchFamily="34" charset="0"/>
+                <a:ea typeface="SF Pro Display" pitchFamily="34" charset="-122"/>
+                <a:cs typeface="SF Pro Display" pitchFamily="34" charset="-120"/>
+              </a:rPr>
+              <a:t>3</a:t>
+            </a:r>
+            <a:endParaRPr lang="en-US" sz="850" dirty="0"/>
+          </a:p>
+        </p:txBody>
+      </p:sp>
+      <p:sp>
+        <p:nvSpPr>
+          <p:cNvPr id="49" name="pop1_2Row3"/>
+          <p:cNvSpPr txBox="1"/>
+          <p:nvPr/>
+        </p:nvSpPr>
+        <p:spPr>
+          <a:xfrm>
+            <a:off x="886968" y="3456432"/>
+            <a:ext cx="4480560" cy="274320"/>
+          </a:xfrm>
+          <a:prstGeom prst="rect">
+            <a:avLst/>
+          </a:prstGeom>
+          <a:noFill/>
+          <a:ln/>
+        </p:spPr>
+        <p:txBody>
+          <a:bodyPr wrap="square" lIns="0" tIns="0" rIns="0" bIns="0" rtlCol="0" anchor="ctr"/>
+          <a:lstStyle/>
+          <a:p>
+            <a:pPr indent="0" marL="0">
+              <a:buNone/>
+            </a:pPr>
+            <a:r>
+              <a:rPr lang="en-US" sz="1000" b="1" dirty="0">
+                <a:solidFill>
+                  <a:srgbClr val="1D1D1F"/>
+                </a:solidFill>
+                <a:latin typeface="SF Pro Text" pitchFamily="34" charset="0"/>
+                <a:ea typeface="SF Pro Text" pitchFamily="34" charset="-122"/>
+                <a:cs typeface="SF Pro Text" pitchFamily="34" charset="-120"/>
+              </a:rPr>
+              <a:t>Don't resolve yet. Change the queue to Waiting on CSQ</a:t>
+            </a:r>
+            <a:endParaRPr lang="en-US" sz="1000" dirty="0"/>
+          </a:p>
+        </p:txBody>
+      </p:sp>
+      <p:sp>
+        <p:nvSpPr>
+          <p:cNvPr id="50" name="pop1_2LinkBg">
+            <a:hlinkClick r:id="rId5" tooltip="Open the Sales call review request sheet"/>
+          </p:cNvPr>
+          <p:cNvSpPr/>
+          <p:nvPr/>
+        </p:nvSpPr>
+        <p:spPr>
+          <a:xfrm>
+            <a:off x="2651760" y="2862072"/>
+            <a:ext cx="310896" cy="256032"/>
+          </a:xfrm>
+          <a:prstGeom prst="roundRect">
+            <a:avLst>
+              <a:gd name="adj" fmla="val 21429"/>
+            </a:avLst>
+          </a:prstGeom>
+          <a:solidFill>
+            <a:srgbClr val="9A6410"/>
+          </a:solidFill>
+          <a:ln w="12700">
+            <a:solidFill>
+              <a:srgbClr val="9A6410"/>
+            </a:solidFill>
+            <a:prstDash val="solid"/>
+          </a:ln>
+        </p:spPr>
+      </p:sp>
+      <p:pic>
+        <p:nvPicPr>
+          <p:cNvPr id="51" name="pop1_2LinkIcon" descr="preencoded.png">
+            <a:hlinkClick r:id="rId5" tooltip="Open the Sales call review request sheet"/>
+          </p:cNvPr>
+          <p:cNvPicPr>
+            <a:picLocks noChangeAspect="1"/>
+          </p:cNvPicPr>
+          <p:nvPr/>
+        </p:nvPicPr>
+        <p:blipFill>
+          <a:blip r:embed="rId4"/>
+          <a:stretch>
+            <a:fillRect/>
+          </a:stretch>
+        </p:blipFill>
+        <p:spPr>
+          <a:xfrm>
+            <a:off x="2734056" y="2898648"/>
+            <a:ext cx="155448" cy="155448"/>
+          </a:xfrm>
+          <a:prstGeom prst="rect">
+            <a:avLst/>
+          </a:prstGeom>
+        </p:spPr>
+      </p:pic>
+      <p:sp>
+        <p:nvSpPr>
+          <p:cNvPr id="52" name="pop1_2Foot"/>
+          <p:cNvSpPr txBox="1"/>
+          <p:nvPr/>
+        </p:nvSpPr>
+        <p:spPr>
+          <a:xfrm>
+            <a:off x="576072" y="3749040"/>
+            <a:ext cx="4791456" cy="237744"/>
+          </a:xfrm>
+          <a:prstGeom prst="rect">
+            <a:avLst/>
+          </a:prstGeom>
+          <a:noFill/>
+          <a:ln/>
+        </p:spPr>
+        <p:txBody>
+          <a:bodyPr wrap="square" lIns="0" tIns="0" rIns="0" bIns="0" rtlCol="0" anchor="ctr"/>
+          <a:lstStyle/>
+          <a:p>
+            <a:pPr indent="0" marL="0">
+              <a:buNone/>
+            </a:pPr>
+            <a:r>
+              <a:rPr lang="en-US" sz="850" i="1" dirty="0">
+                <a:solidFill>
+                  <a:srgbClr val="6E6E73"/>
+                </a:solidFill>
+                <a:latin typeface="SF Pro Text" pitchFamily="34" charset="0"/>
+                <a:ea typeface="SF Pro Text" pitchFamily="34" charset="-122"/>
+                <a:cs typeface="SF Pro Text" pitchFamily="34" charset="-120"/>
+              </a:rPr>
+              <a:t>Verified? Continue to step 2.</a:t>
+            </a:r>
+            <a:endParaRPr lang="en-US" sz="850" dirty="0"/>
           </a:p>
         </p:txBody>
       </p:sp>
@@ -26831,6 +27470,776 @@
   <p:clrMapOvr>
     <a:masterClrMapping/>
   </p:clrMapOvr>
+  <p:timing>
+    <p:tnLst>
+      <p:par>
+        <p:cTn id="1" dur="indefinite" restart="never" nodeType="tmRoot">
+          <p:childTnLst>
+            <p:seq concurrent="1" nextAc="seek">
+              <p:cTn id="2" dur="indefinite" nodeType="mainSeq">
+                <p:childTnLst>
+                  <p:par>
+                    <p:cTn id="36" fill="hold">
+                      <p:stCondLst>
+                        <p:cond delay="indefinite"/>
+                      </p:stCondLst>
+                      <p:childTnLst>
+                        <p:par>
+                          <p:cTn id="37" fill="hold">
+                            <p:stCondLst>
+                              <p:cond delay="0"/>
+                            </p:stCondLst>
+                            <p:childTnLst>
+                              <p:par>
+                                <p:cTn id="5" presetID="10" presetClass="entr" presetSubtype="0" fill="hold" grpId="0" nodeType="clickEffect">
+                                  <p:stCondLst>
+                                    <p:cond delay="0"/>
+                                  </p:stCondLst>
+                                  <p:childTnLst>
+                                    <p:set>
+                                      <p:cBhvr>
+                                        <p:cTn id="6" dur="1" fill="hold">
+                                          <p:stCondLst>
+                                            <p:cond delay="0"/>
+                                          </p:stCondLst>
+                                        </p:cTn>
+                                        <p:tgtEl>
+                                          <p:spTgt spid="42"/>
+                                        </p:tgtEl>
+                                        <p:attrNameLst>
+                                          <p:attrName>style.visibility</p:attrName>
+                                        </p:attrNameLst>
+                                      </p:cBhvr>
+                                      <p:to>
+                                        <p:strVal val="visible"/>
+                                      </p:to>
+                                    </p:set>
+                                    <p:animEffect transition="in" filter="fade">
+                                      <p:cBhvr>
+                                        <p:cTn id="7" dur="600"/>
+                                        <p:tgtEl>
+                                          <p:spTgt spid="42"/>
+                                        </p:tgtEl>
+                                      </p:cBhvr>
+                                    </p:animEffect>
+                                  </p:childTnLst>
+                                </p:cTn>
+                              </p:par>
+                              <p:par>
+                                <p:cTn id="8" presetID="10" presetClass="entr" presetSubtype="0" fill="hold" grpId="0" nodeType="withEffect">
+                                  <p:stCondLst>
+                                    <p:cond delay="0"/>
+                                  </p:stCondLst>
+                                  <p:childTnLst>
+                                    <p:set>
+                                      <p:cBhvr>
+                                        <p:cTn id="9" dur="1" fill="hold">
+                                          <p:stCondLst>
+                                            <p:cond delay="0"/>
+                                          </p:stCondLst>
+                                        </p:cTn>
+                                        <p:tgtEl>
+                                          <p:spTgt spid="43"/>
+                                        </p:tgtEl>
+                                        <p:attrNameLst>
+                                          <p:attrName>style.visibility</p:attrName>
+                                        </p:attrNameLst>
+                                      </p:cBhvr>
+                                      <p:to>
+                                        <p:strVal val="visible"/>
+                                      </p:to>
+                                    </p:set>
+                                    <p:animEffect transition="in" filter="fade">
+                                      <p:cBhvr>
+                                        <p:cTn id="10" dur="600"/>
+                                        <p:tgtEl>
+                                          <p:spTgt spid="43"/>
+                                        </p:tgtEl>
+                                      </p:cBhvr>
+                                    </p:animEffect>
+                                  </p:childTnLst>
+                                </p:cTn>
+                              </p:par>
+                              <p:par>
+                                <p:cTn id="11" presetID="10" presetClass="entr" presetSubtype="0" fill="hold" grpId="0" nodeType="withEffect">
+                                  <p:stCondLst>
+                                    <p:cond delay="0"/>
+                                  </p:stCondLst>
+                                  <p:childTnLst>
+                                    <p:set>
+                                      <p:cBhvr>
+                                        <p:cTn id="12" dur="1" fill="hold">
+                                          <p:stCondLst>
+                                            <p:cond delay="0"/>
+                                          </p:stCondLst>
+                                        </p:cTn>
+                                        <p:tgtEl>
+                                          <p:spTgt spid="44"/>
+                                        </p:tgtEl>
+                                        <p:attrNameLst>
+                                          <p:attrName>style.visibility</p:attrName>
+                                        </p:attrNameLst>
+                                      </p:cBhvr>
+                                      <p:to>
+                                        <p:strVal val="visible"/>
+                                      </p:to>
+                                    </p:set>
+                                    <p:animEffect transition="in" filter="fade">
+                                      <p:cBhvr>
+                                        <p:cTn id="13" dur="600"/>
+                                        <p:tgtEl>
+                                          <p:spTgt spid="44"/>
+                                        </p:tgtEl>
+                                      </p:cBhvr>
+                                    </p:animEffect>
+                                  </p:childTnLst>
+                                </p:cTn>
+                              </p:par>
+                              <p:par>
+                                <p:cTn id="14" presetID="10" presetClass="entr" presetSubtype="0" fill="hold" grpId="0" nodeType="withEffect">
+                                  <p:stCondLst>
+                                    <p:cond delay="0"/>
+                                  </p:stCondLst>
+                                  <p:childTnLst>
+                                    <p:set>
+                                      <p:cBhvr>
+                                        <p:cTn id="15" dur="1" fill="hold">
+                                          <p:stCondLst>
+                                            <p:cond delay="0"/>
+                                          </p:stCondLst>
+                                        </p:cTn>
+                                        <p:tgtEl>
+                                          <p:spTgt spid="45"/>
+                                        </p:tgtEl>
+                                        <p:attrNameLst>
+                                          <p:attrName>style.visibility</p:attrName>
+                                        </p:attrNameLst>
+                                      </p:cBhvr>
+                                      <p:to>
+                                        <p:strVal val="visible"/>
+                                      </p:to>
+                                    </p:set>
+                                    <p:animEffect transition="in" filter="fade">
+                                      <p:cBhvr>
+                                        <p:cTn id="16" dur="600"/>
+                                        <p:tgtEl>
+                                          <p:spTgt spid="45"/>
+                                        </p:tgtEl>
+                                      </p:cBhvr>
+                                    </p:animEffect>
+                                  </p:childTnLst>
+                                </p:cTn>
+                              </p:par>
+                              <p:par>
+                                <p:cTn id="17" presetID="10" presetClass="entr" presetSubtype="0" fill="hold" grpId="0" nodeType="withEffect">
+                                  <p:stCondLst>
+                                    <p:cond delay="0"/>
+                                  </p:stCondLst>
+                                  <p:childTnLst>
+                                    <p:set>
+                                      <p:cBhvr>
+                                        <p:cTn id="18" dur="1" fill="hold">
+                                          <p:stCondLst>
+                                            <p:cond delay="0"/>
+                                          </p:stCondLst>
+                                        </p:cTn>
+                                        <p:tgtEl>
+                                          <p:spTgt spid="46"/>
+                                        </p:tgtEl>
+                                        <p:attrNameLst>
+                                          <p:attrName>style.visibility</p:attrName>
+                                        </p:attrNameLst>
+                                      </p:cBhvr>
+                                      <p:to>
+                                        <p:strVal val="visible"/>
+                                      </p:to>
+                                    </p:set>
+                                    <p:animEffect transition="in" filter="fade">
+                                      <p:cBhvr>
+                                        <p:cTn id="19" dur="600"/>
+                                        <p:tgtEl>
+                                          <p:spTgt spid="46"/>
+                                        </p:tgtEl>
+                                      </p:cBhvr>
+                                    </p:animEffect>
+                                  </p:childTnLst>
+                                </p:cTn>
+                              </p:par>
+                              <p:par>
+                                <p:cTn id="20" presetID="10" presetClass="entr" presetSubtype="0" fill="hold" grpId="0" nodeType="withEffect">
+                                  <p:stCondLst>
+                                    <p:cond delay="0"/>
+                                  </p:stCondLst>
+                                  <p:childTnLst>
+                                    <p:set>
+                                      <p:cBhvr>
+                                        <p:cTn id="21" dur="1" fill="hold">
+                                          <p:stCondLst>
+                                            <p:cond delay="0"/>
+                                          </p:stCondLst>
+                                        </p:cTn>
+                                        <p:tgtEl>
+                                          <p:spTgt spid="47"/>
+                                        </p:tgtEl>
+                                        <p:attrNameLst>
+                                          <p:attrName>style.visibility</p:attrName>
+                                        </p:attrNameLst>
+                                      </p:cBhvr>
+                                      <p:to>
+                                        <p:strVal val="visible"/>
+                                      </p:to>
+                                    </p:set>
+                                    <p:animEffect transition="in" filter="fade">
+                                      <p:cBhvr>
+                                        <p:cTn id="22" dur="600"/>
+                                        <p:tgtEl>
+                                          <p:spTgt spid="47"/>
+                                        </p:tgtEl>
+                                      </p:cBhvr>
+                                    </p:animEffect>
+                                  </p:childTnLst>
+                                </p:cTn>
+                              </p:par>
+                              <p:par>
+                                <p:cTn id="23" presetID="10" presetClass="entr" presetSubtype="0" fill="hold" grpId="0" nodeType="withEffect">
+                                  <p:stCondLst>
+                                    <p:cond delay="0"/>
+                                  </p:stCondLst>
+                                  <p:childTnLst>
+                                    <p:set>
+                                      <p:cBhvr>
+                                        <p:cTn id="24" dur="1" fill="hold">
+                                          <p:stCondLst>
+                                            <p:cond delay="0"/>
+                                          </p:stCondLst>
+                                        </p:cTn>
+                                        <p:tgtEl>
+                                          <p:spTgt spid="48"/>
+                                        </p:tgtEl>
+                                        <p:attrNameLst>
+                                          <p:attrName>style.visibility</p:attrName>
+                                        </p:attrNameLst>
+                                      </p:cBhvr>
+                                      <p:to>
+                                        <p:strVal val="visible"/>
+                                      </p:to>
+                                    </p:set>
+                                    <p:animEffect transition="in" filter="fade">
+                                      <p:cBhvr>
+                                        <p:cTn id="25" dur="600"/>
+                                        <p:tgtEl>
+                                          <p:spTgt spid="48"/>
+                                        </p:tgtEl>
+                                      </p:cBhvr>
+                                    </p:animEffect>
+                                  </p:childTnLst>
+                                </p:cTn>
+                              </p:par>
+                              <p:par>
+                                <p:cTn id="26" presetID="10" presetClass="entr" presetSubtype="0" fill="hold" grpId="0" nodeType="withEffect">
+                                  <p:stCondLst>
+                                    <p:cond delay="0"/>
+                                  </p:stCondLst>
+                                  <p:childTnLst>
+                                    <p:set>
+                                      <p:cBhvr>
+                                        <p:cTn id="27" dur="1" fill="hold">
+                                          <p:stCondLst>
+                                            <p:cond delay="0"/>
+                                          </p:stCondLst>
+                                        </p:cTn>
+                                        <p:tgtEl>
+                                          <p:spTgt spid="49"/>
+                                        </p:tgtEl>
+                                        <p:attrNameLst>
+                                          <p:attrName>style.visibility</p:attrName>
+                                        </p:attrNameLst>
+                                      </p:cBhvr>
+                                      <p:to>
+                                        <p:strVal val="visible"/>
+                                      </p:to>
+                                    </p:set>
+                                    <p:animEffect transition="in" filter="fade">
+                                      <p:cBhvr>
+                                        <p:cTn id="28" dur="600"/>
+                                        <p:tgtEl>
+                                          <p:spTgt spid="49"/>
+                                        </p:tgtEl>
+                                      </p:cBhvr>
+                                    </p:animEffect>
+                                  </p:childTnLst>
+                                </p:cTn>
+                              </p:par>
+                              <p:par>
+                                <p:cTn id="29" presetID="10" presetClass="entr" presetSubtype="0" fill="hold" grpId="0" nodeType="withEffect">
+                                  <p:stCondLst>
+                                    <p:cond delay="0"/>
+                                  </p:stCondLst>
+                                  <p:childTnLst>
+                                    <p:set>
+                                      <p:cBhvr>
+                                        <p:cTn id="30" dur="1" fill="hold">
+                                          <p:stCondLst>
+                                            <p:cond delay="0"/>
+                                          </p:stCondLst>
+                                        </p:cTn>
+                                        <p:tgtEl>
+                                          <p:spTgt spid="50"/>
+                                        </p:tgtEl>
+                                        <p:attrNameLst>
+                                          <p:attrName>style.visibility</p:attrName>
+                                        </p:attrNameLst>
+                                      </p:cBhvr>
+                                      <p:to>
+                                        <p:strVal val="visible"/>
+                                      </p:to>
+                                    </p:set>
+                                    <p:animEffect transition="in" filter="fade">
+                                      <p:cBhvr>
+                                        <p:cTn id="31" dur="600"/>
+                                        <p:tgtEl>
+                                          <p:spTgt spid="50"/>
+                                        </p:tgtEl>
+                                      </p:cBhvr>
+                                    </p:animEffect>
+                                  </p:childTnLst>
+                                </p:cTn>
+                              </p:par>
+                              <p:par>
+                                <p:cTn id="32" presetID="10" presetClass="entr" presetSubtype="0" fill="hold" grpId="0" nodeType="withEffect">
+                                  <p:stCondLst>
+                                    <p:cond delay="0"/>
+                                  </p:stCondLst>
+                                  <p:childTnLst>
+                                    <p:set>
+                                      <p:cBhvr>
+                                        <p:cTn id="33" dur="1" fill="hold">
+                                          <p:stCondLst>
+                                            <p:cond delay="0"/>
+                                          </p:stCondLst>
+                                        </p:cTn>
+                                        <p:tgtEl>
+                                          <p:spTgt spid="51"/>
+                                        </p:tgtEl>
+                                        <p:attrNameLst>
+                                          <p:attrName>style.visibility</p:attrName>
+                                        </p:attrNameLst>
+                                      </p:cBhvr>
+                                      <p:to>
+                                        <p:strVal val="visible"/>
+                                      </p:to>
+                                    </p:set>
+                                    <p:animEffect transition="in" filter="fade">
+                                      <p:cBhvr>
+                                        <p:cTn id="34" dur="600"/>
+                                        <p:tgtEl>
+                                          <p:spTgt spid="51"/>
+                                        </p:tgtEl>
+                                      </p:cBhvr>
+                                    </p:animEffect>
+                                  </p:childTnLst>
+                                </p:cTn>
+                              </p:par>
+                              <p:par>
+                                <p:cTn id="35" presetID="10" presetClass="entr" presetSubtype="0" fill="hold" grpId="0" nodeType="withEffect">
+                                  <p:stCondLst>
+                                    <p:cond delay="0"/>
+                                  </p:stCondLst>
+                                  <p:childTnLst>
+                                    <p:set>
+                                      <p:cBhvr>
+                                        <p:cTn id="36" dur="1" fill="hold">
+                                          <p:stCondLst>
+                                            <p:cond delay="0"/>
+                                          </p:stCondLst>
+                                        </p:cTn>
+                                        <p:tgtEl>
+                                          <p:spTgt spid="52"/>
+                                        </p:tgtEl>
+                                        <p:attrNameLst>
+                                          <p:attrName>style.visibility</p:attrName>
+                                        </p:attrNameLst>
+                                      </p:cBhvr>
+                                      <p:to>
+                                        <p:strVal val="visible"/>
+                                      </p:to>
+                                    </p:set>
+                                    <p:animEffect transition="in" filter="fade">
+                                      <p:cBhvr>
+                                        <p:cTn id="37" dur="600"/>
+                                        <p:tgtEl>
+                                          <p:spTgt spid="52"/>
+                                        </p:tgtEl>
+                                      </p:cBhvr>
+                                    </p:animEffect>
+                                  </p:childTnLst>
+                                </p:cTn>
+                              </p:par>
+                            </p:childTnLst>
+                          </p:cTn>
+                        </p:par>
+                      </p:childTnLst>
+                    </p:cTn>
+                  </p:par>
+                  <p:par>
+                    <p:cTn id="71" fill="hold">
+                      <p:stCondLst>
+                        <p:cond delay="indefinite"/>
+                      </p:stCondLst>
+                      <p:childTnLst>
+                        <p:par>
+                          <p:cTn id="72" fill="hold">
+                            <p:stCondLst>
+                              <p:cond delay="0"/>
+                            </p:stCondLst>
+                            <p:childTnLst>
+                              <p:par>
+                                <p:cTn id="40" presetID="1" presetClass="exit" presetSubtype="0" fill="hold" grpId="1" nodeType="clickEffect">
+                                  <p:stCondLst>
+                                    <p:cond delay="0"/>
+                                  </p:stCondLst>
+                                  <p:childTnLst>
+                                    <p:set>
+                                      <p:cBhvr>
+                                        <p:cTn id="41" dur="1" fill="hold">
+                                          <p:stCondLst>
+                                            <p:cond delay="0"/>
+                                          </p:stCondLst>
+                                        </p:cTn>
+                                        <p:tgtEl>
+                                          <p:spTgt spid="42"/>
+                                        </p:tgtEl>
+                                        <p:attrNameLst>
+                                          <p:attrName>style.visibility</p:attrName>
+                                        </p:attrNameLst>
+                                      </p:cBhvr>
+                                      <p:to>
+                                        <p:strVal val="hidden"/>
+                                      </p:to>
+                                    </p:set>
+                                  </p:childTnLst>
+                                </p:cTn>
+                              </p:par>
+                              <p:par>
+                                <p:cTn id="43" presetID="1" presetClass="exit" presetSubtype="0" fill="hold" grpId="1" nodeType="withEffect">
+                                  <p:stCondLst>
+                                    <p:cond delay="0"/>
+                                  </p:stCondLst>
+                                  <p:childTnLst>
+                                    <p:set>
+                                      <p:cBhvr>
+                                        <p:cTn id="44" dur="1" fill="hold">
+                                          <p:stCondLst>
+                                            <p:cond delay="0"/>
+                                          </p:stCondLst>
+                                        </p:cTn>
+                                        <p:tgtEl>
+                                          <p:spTgt spid="43"/>
+                                        </p:tgtEl>
+                                        <p:attrNameLst>
+                                          <p:attrName>style.visibility</p:attrName>
+                                        </p:attrNameLst>
+                                      </p:cBhvr>
+                                      <p:to>
+                                        <p:strVal val="hidden"/>
+                                      </p:to>
+                                    </p:set>
+                                  </p:childTnLst>
+                                </p:cTn>
+                              </p:par>
+                              <p:par>
+                                <p:cTn id="46" presetID="1" presetClass="exit" presetSubtype="0" fill="hold" grpId="1" nodeType="withEffect">
+                                  <p:stCondLst>
+                                    <p:cond delay="0"/>
+                                  </p:stCondLst>
+                                  <p:childTnLst>
+                                    <p:set>
+                                      <p:cBhvr>
+                                        <p:cTn id="47" dur="1" fill="hold">
+                                          <p:stCondLst>
+                                            <p:cond delay="0"/>
+                                          </p:stCondLst>
+                                        </p:cTn>
+                                        <p:tgtEl>
+                                          <p:spTgt spid="44"/>
+                                        </p:tgtEl>
+                                        <p:attrNameLst>
+                                          <p:attrName>style.visibility</p:attrName>
+                                        </p:attrNameLst>
+                                      </p:cBhvr>
+                                      <p:to>
+                                        <p:strVal val="hidden"/>
+                                      </p:to>
+                                    </p:set>
+                                  </p:childTnLst>
+                                </p:cTn>
+                              </p:par>
+                              <p:par>
+                                <p:cTn id="49" presetID="1" presetClass="exit" presetSubtype="0" fill="hold" grpId="1" nodeType="withEffect">
+                                  <p:stCondLst>
+                                    <p:cond delay="0"/>
+                                  </p:stCondLst>
+                                  <p:childTnLst>
+                                    <p:set>
+                                      <p:cBhvr>
+                                        <p:cTn id="50" dur="1" fill="hold">
+                                          <p:stCondLst>
+                                            <p:cond delay="0"/>
+                                          </p:stCondLst>
+                                        </p:cTn>
+                                        <p:tgtEl>
+                                          <p:spTgt spid="45"/>
+                                        </p:tgtEl>
+                                        <p:attrNameLst>
+                                          <p:attrName>style.visibility</p:attrName>
+                                        </p:attrNameLst>
+                                      </p:cBhvr>
+                                      <p:to>
+                                        <p:strVal val="hidden"/>
+                                      </p:to>
+                                    </p:set>
+                                  </p:childTnLst>
+                                </p:cTn>
+                              </p:par>
+                              <p:par>
+                                <p:cTn id="52" presetID="1" presetClass="exit" presetSubtype="0" fill="hold" grpId="1" nodeType="withEffect">
+                                  <p:stCondLst>
+                                    <p:cond delay="0"/>
+                                  </p:stCondLst>
+                                  <p:childTnLst>
+                                    <p:set>
+                                      <p:cBhvr>
+                                        <p:cTn id="53" dur="1" fill="hold">
+                                          <p:stCondLst>
+                                            <p:cond delay="0"/>
+                                          </p:stCondLst>
+                                        </p:cTn>
+                                        <p:tgtEl>
+                                          <p:spTgt spid="46"/>
+                                        </p:tgtEl>
+                                        <p:attrNameLst>
+                                          <p:attrName>style.visibility</p:attrName>
+                                        </p:attrNameLst>
+                                      </p:cBhvr>
+                                      <p:to>
+                                        <p:strVal val="hidden"/>
+                                      </p:to>
+                                    </p:set>
+                                  </p:childTnLst>
+                                </p:cTn>
+                              </p:par>
+                              <p:par>
+                                <p:cTn id="55" presetID="1" presetClass="exit" presetSubtype="0" fill="hold" grpId="1" nodeType="withEffect">
+                                  <p:stCondLst>
+                                    <p:cond delay="0"/>
+                                  </p:stCondLst>
+                                  <p:childTnLst>
+                                    <p:set>
+                                      <p:cBhvr>
+                                        <p:cTn id="56" dur="1" fill="hold">
+                                          <p:stCondLst>
+                                            <p:cond delay="0"/>
+                                          </p:stCondLst>
+                                        </p:cTn>
+                                        <p:tgtEl>
+                                          <p:spTgt spid="47"/>
+                                        </p:tgtEl>
+                                        <p:attrNameLst>
+                                          <p:attrName>style.visibility</p:attrName>
+                                        </p:attrNameLst>
+                                      </p:cBhvr>
+                                      <p:to>
+                                        <p:strVal val="hidden"/>
+                                      </p:to>
+                                    </p:set>
+                                  </p:childTnLst>
+                                </p:cTn>
+                              </p:par>
+                              <p:par>
+                                <p:cTn id="58" presetID="1" presetClass="exit" presetSubtype="0" fill="hold" grpId="1" nodeType="withEffect">
+                                  <p:stCondLst>
+                                    <p:cond delay="0"/>
+                                  </p:stCondLst>
+                                  <p:childTnLst>
+                                    <p:set>
+                                      <p:cBhvr>
+                                        <p:cTn id="59" dur="1" fill="hold">
+                                          <p:stCondLst>
+                                            <p:cond delay="0"/>
+                                          </p:stCondLst>
+                                        </p:cTn>
+                                        <p:tgtEl>
+                                          <p:spTgt spid="48"/>
+                                        </p:tgtEl>
+                                        <p:attrNameLst>
+                                          <p:attrName>style.visibility</p:attrName>
+                                        </p:attrNameLst>
+                                      </p:cBhvr>
+                                      <p:to>
+                                        <p:strVal val="hidden"/>
+                                      </p:to>
+                                    </p:set>
+                                  </p:childTnLst>
+                                </p:cTn>
+                              </p:par>
+                              <p:par>
+                                <p:cTn id="61" presetID="1" presetClass="exit" presetSubtype="0" fill="hold" grpId="1" nodeType="withEffect">
+                                  <p:stCondLst>
+                                    <p:cond delay="0"/>
+                                  </p:stCondLst>
+                                  <p:childTnLst>
+                                    <p:set>
+                                      <p:cBhvr>
+                                        <p:cTn id="62" dur="1" fill="hold">
+                                          <p:stCondLst>
+                                            <p:cond delay="0"/>
+                                          </p:stCondLst>
+                                        </p:cTn>
+                                        <p:tgtEl>
+                                          <p:spTgt spid="49"/>
+                                        </p:tgtEl>
+                                        <p:attrNameLst>
+                                          <p:attrName>style.visibility</p:attrName>
+                                        </p:attrNameLst>
+                                      </p:cBhvr>
+                                      <p:to>
+                                        <p:strVal val="hidden"/>
+                                      </p:to>
+                                    </p:set>
+                                  </p:childTnLst>
+                                </p:cTn>
+                              </p:par>
+                              <p:par>
+                                <p:cTn id="64" presetID="1" presetClass="exit" presetSubtype="0" fill="hold" grpId="1" nodeType="withEffect">
+                                  <p:stCondLst>
+                                    <p:cond delay="0"/>
+                                  </p:stCondLst>
+                                  <p:childTnLst>
+                                    <p:set>
+                                      <p:cBhvr>
+                                        <p:cTn id="65" dur="1" fill="hold">
+                                          <p:stCondLst>
+                                            <p:cond delay="0"/>
+                                          </p:stCondLst>
+                                        </p:cTn>
+                                        <p:tgtEl>
+                                          <p:spTgt spid="50"/>
+                                        </p:tgtEl>
+                                        <p:attrNameLst>
+                                          <p:attrName>style.visibility</p:attrName>
+                                        </p:attrNameLst>
+                                      </p:cBhvr>
+                                      <p:to>
+                                        <p:strVal val="hidden"/>
+                                      </p:to>
+                                    </p:set>
+                                  </p:childTnLst>
+                                </p:cTn>
+                              </p:par>
+                              <p:par>
+                                <p:cTn id="67" presetID="1" presetClass="exit" presetSubtype="0" fill="hold" grpId="1" nodeType="withEffect">
+                                  <p:stCondLst>
+                                    <p:cond delay="0"/>
+                                  </p:stCondLst>
+                                  <p:childTnLst>
+                                    <p:set>
+                                      <p:cBhvr>
+                                        <p:cTn id="68" dur="1" fill="hold">
+                                          <p:stCondLst>
+                                            <p:cond delay="0"/>
+                                          </p:stCondLst>
+                                        </p:cTn>
+                                        <p:tgtEl>
+                                          <p:spTgt spid="51"/>
+                                        </p:tgtEl>
+                                        <p:attrNameLst>
+                                          <p:attrName>style.visibility</p:attrName>
+                                        </p:attrNameLst>
+                                      </p:cBhvr>
+                                      <p:to>
+                                        <p:strVal val="hidden"/>
+                                      </p:to>
+                                    </p:set>
+                                  </p:childTnLst>
+                                </p:cTn>
+                              </p:par>
+                              <p:par>
+                                <p:cTn id="70" presetID="1" presetClass="exit" presetSubtype="0" fill="hold" grpId="1" nodeType="withEffect">
+                                  <p:stCondLst>
+                                    <p:cond delay="0"/>
+                                  </p:stCondLst>
+                                  <p:childTnLst>
+                                    <p:set>
+                                      <p:cBhvr>
+                                        <p:cTn id="71" dur="1" fill="hold">
+                                          <p:stCondLst>
+                                            <p:cond delay="0"/>
+                                          </p:stCondLst>
+                                        </p:cTn>
+                                        <p:tgtEl>
+                                          <p:spTgt spid="52"/>
+                                        </p:tgtEl>
+                                        <p:attrNameLst>
+                                          <p:attrName>style.visibility</p:attrName>
+                                        </p:attrNameLst>
+                                      </p:cBhvr>
+                                      <p:to>
+                                        <p:strVal val="hidden"/>
+                                      </p:to>
+                                    </p:set>
+                                  </p:childTnLst>
+                                </p:cTn>
+                              </p:par>
+                            </p:childTnLst>
+                          </p:cTn>
+                        </p:par>
+                      </p:childTnLst>
+                    </p:cTn>
+                  </p:par>
+                </p:childTnLst>
+              </p:cTn>
+              <p:prevCondLst>
+                <p:cond evt="onPrev" delay="0">
+                  <p:tgtEl>
+                    <p:sldTgt/>
+                  </p:tgtEl>
+                </p:cond>
+              </p:prevCondLst>
+              <p:nextCondLst>
+                <p:cond evt="onNext" delay="0">
+                  <p:tgtEl>
+                    <p:sldTgt/>
+                  </p:tgtEl>
+                </p:cond>
+              </p:nextCondLst>
+            </p:seq>
+          </p:childTnLst>
+        </p:cTn>
+      </p:par>
+    </p:tnLst>
+    <p:bldLst>
+      <p:bldP spid="42" grpId="0" animBg="1"/>
+      <p:bldP spid="43" grpId="0" animBg="1"/>
+      <p:bldP spid="44" grpId="0" animBg="1"/>
+      <p:bldP spid="45" grpId="0" animBg="1"/>
+      <p:bldP spid="46" grpId="0" animBg="1"/>
+      <p:bldP spid="47" grpId="0" animBg="1"/>
+      <p:bldP spid="48" grpId="0" animBg="1"/>
+      <p:bldP spid="49" grpId="0" animBg="1"/>
+      <p:bldP spid="50" grpId="0" animBg="1"/>
+      <p:bldP spid="52" grpId="0" animBg="1"/>
+      <p:bldP spid="42" grpId="1" animBg="1"/>
+      <p:bldP spid="43" grpId="1" animBg="1"/>
+      <p:bldP spid="44" grpId="1" animBg="1"/>
+      <p:bldP spid="45" grpId="1" animBg="1"/>
+      <p:bldP spid="46" grpId="1" animBg="1"/>
+      <p:bldP spid="47" grpId="1" animBg="1"/>
+      <p:bldP spid="48" grpId="1" animBg="1"/>
+      <p:bldP spid="49" grpId="1" animBg="1"/>
+      <p:bldP spid="50" grpId="1" animBg="1"/>
+      <p:bldP spid="52" grpId="1" animBg="1"/>
+    </p:bldLst>
+  </p:timing>
 </p:sld>
 </file>
 

</xml_diff>

<commit_message>
Incorrect Info deck: move macro flag to Quoted a rate slide; keep trainer's edits
Co-Authored-By: Claude Opus 5.5 <noreply@anthropic.com>
Claude-Session: https://claude.ai/code/session_01FEzv8wwqWDgTsXP8Yz6XYn
</commit_message>
<xml_diff>
--- a/incorrect-info-lmc-lockout/incorrect-info-lmc-lockout.pptx
+++ b/incorrect-info-lmc-lockout/incorrect-info-lmc-lockout.pptx
@@ -2730,7 +2730,7 @@
           <a:p>
             <a:r>
               <a:rPr lang="en-US" dirty="0"/>
-              <a:t>If the rep quoted a specific rate and left out the processing fee, tax or Premium, the customer had no way to know the real price. That's misrepresentation. Honor the total they were told: admin refund so the job comes to what they expected. If someone disclosed a charge before it happened and the customer agreed to it (e.g. the CP explained the extra-hours rate), refund only the part that was never disclosed. Worked example: FCR told the customer "$20/hr" and didn't mention the processing fee, tax or Premium. Admin refund so the job totals $20/hr × hours worked. Set the max CP rate to $20 and the Cleaner Experience Level to Standard, and explain the fees going forward.</a:t>
+              <a:t>1) Verify: confirm it's genuinely a guaranteed promise, not an estimate or a gap in what was proactively mentioned. Look for the specific language used, not just whether the customer was surprised. To verify, run a Sales call review: submit a Sales call review request (link icon on the pop-up opens the request sheet), add an internal note with your escalation link, and don't resolve yet: change the status to Waiting on CSQ. If misinformation is not verified, clarify the information and address any confusion. If it is verified, continue: 2) Refund any overpayment that resulted, where applicable: e.g. promised a $49/month MF but charged $59, refund the difference. Not every case has an overpayment; service-capability and guarantee-pairing cases often don't. 3) Acknowledge the error directly. Don't frame it as a misunderstanding on the customer's side. 4) Correct the charges or expectations going forward, and clearly explain what changed. 5) Assess retainability as for any other case. If retainable, attempt retention with one light offer, not a push: up to $20 credit or a 1-hr courtesy voucher. While you wait for their reply, set a TR before the next MF. 6) If the customer declines the offer, or isn't retainable, waive the ETF and cancel the FC. TRAINER: click once (Sales call review) to open the escalation steps; click again to close them. In slideshow mode, the link icon on the pop-up opens the Sales call review request sheet.</a:t>
             </a:r>
             <a:endParaRPr lang="en-US" dirty="0"/>
           </a:p>
@@ -2818,7 +2818,7 @@
           <a:p>
             <a:r>
               <a:rPr lang="en-US" dirty="0"/>
-              <a:t>1) Verify: confirm it's genuinely a guaranteed promise, not an estimate or a gap in what was proactively mentioned. Look for the specific language used, not just whether the customer was surprised. To verify, run a Sales call review: submit a Sales call review request (link icon on the pop-up opens the request sheet), add an internal note with your escalation link, and don't resolve yet: change the queue to Waiting on CSQ. If misinformation is not verified, handle it as a normal case. If it is verified, continue: 2) Refund any overpayment that resulted, where applicable: e.g. promised a $49/month MF but charged $59, refund the difference. Not every case has an overpayment; service-capability and guarantee-pairing cases often don't. 3) Acknowledge the error directly. Don't frame it as a misunderstanding on the customer's side. 4) Correct the charges or expectations going forward, and clearly explain what changed. 5) Assess retainability as for any other case. If retainable, attempt retention with one light offer, not a push: up to $20 credit or a 1-hr courtesy voucher. While you wait for their reply, set a TR before the next MF. 6) If the customer declines the offer, or isn't retainable, waive the ETF and cancel the FC. Macro: Misinformation: address incorrect claims about charges. TRAINER: click once (Sales call review) to open the escalation steps; click again to close them. In slideshow mode, the link icon on the pop-up opens the Sales call review request sheet.</a:t>
+              <a:t>If the rep quoted a specific rate and left out the processing fee, tax or Premium, the customer had no way to know the real price. That's misrepresentation. Honor the total they were told: admin refund so the job comes to what they expected. If someone disclosed a charge before it happened and the customer agreed to it (e.g. the CP explained the extra-hours rate), refund only the part that was never disclosed. Worked example: FCR told the customer "$20/hr" and didn't mention the processing fee, tax or Premium. Admin refund so the job totals $20/hr × hours worked. Set the max CP rate to $20 and the Cleaner Experience Level to Standard, and explain the fees going forward. Recommended macro: Misinformation: address incorrect claims about charges.</a:t>
             </a:r>
             <a:endParaRPr lang="en-US" dirty="0"/>
           </a:p>
@@ -24894,7 +24894,7 @@
                 <a:ea typeface="SF Pro Display" pitchFamily="34" charset="-122"/>
                 <a:cs typeface="SF Pro Display" pitchFamily="34" charset="-120"/>
               </a:rPr>
-              <a:t>Quoted a rate, left out the fees</a:t>
+              <a:t>The process</a:t>
             </a:r>
             <a:endParaRPr lang="en-US" sz="2400" dirty="0"/>
           </a:p>
@@ -24933,7 +24933,7 @@
                 <a:ea typeface="SF Pro Text" pitchFamily="34" charset="-122"/>
                 <a:cs typeface="SF Pro Text" pitchFamily="34" charset="-120"/>
               </a:rPr>
-              <a:t>Never just "a gap in what was mentioned".</a:t>
+              <a:t>Verify first. Only verified misinformation moves on to steps 2–6.</a:t>
             </a:r>
             <a:endParaRPr lang="en-US" sz="1200" dirty="0"/>
           </a:p>
@@ -24947,12 +24947,994 @@
         </p:nvSpPr>
         <p:spPr>
           <a:xfrm>
-            <a:off x="411480" y="1417320"/>
-            <a:ext cx="1920240" cy="548640"/>
+            <a:off x="411480" y="1298448"/>
+            <a:ext cx="1737360" cy="566928"/>
           </a:xfrm>
           <a:prstGeom prst="roundRect">
             <a:avLst>
-              <a:gd name="adj" fmla="val 13333"/>
+              <a:gd name="adj" fmla="val 12903"/>
+            </a:avLst>
+          </a:prstGeom>
+          <a:solidFill>
+            <a:srgbClr val="0B7A6F"/>
+          </a:solidFill>
+          <a:ln w="12700">
+            <a:solidFill>
+              <a:srgbClr val="0B7A6F"/>
+            </a:solidFill>
+            <a:prstDash val="solid"/>
+          </a:ln>
+        </p:spPr>
+      </p:sp>
+      <p:sp>
+        <p:nvSpPr>
+          <p:cNvPr id="7" name="Text 4"/>
+          <p:cNvSpPr txBox="1"/>
+          <p:nvPr/>
+        </p:nvSpPr>
+        <p:spPr>
+          <a:xfrm>
+            <a:off x="457200" y="1298448"/>
+            <a:ext cx="1645920" cy="566928"/>
+          </a:xfrm>
+          <a:prstGeom prst="rect">
+            <a:avLst/>
+          </a:prstGeom>
+          <a:noFill/>
+          <a:ln/>
+        </p:spPr>
+        <p:txBody>
+          <a:bodyPr wrap="square" lIns="0" tIns="0" rIns="0" bIns="0" rtlCol="0" anchor="ctr"/>
+          <a:lstStyle/>
+          <a:p>
+            <a:pPr algn="ctr" indent="0" marL="0">
+              <a:buNone/>
+            </a:pPr>
+            <a:r>
+              <a:rPr lang="en-US" sz="1050" b="1" dirty="0">
+                <a:solidFill>
+                  <a:srgbClr val="FFFFFF"/>
+                </a:solidFill>
+                <a:latin typeface="SF Pro Display" pitchFamily="34" charset="0"/>
+                <a:ea typeface="SF Pro Display" pitchFamily="34" charset="-122"/>
+                <a:cs typeface="SF Pro Display" pitchFamily="34" charset="-120"/>
+              </a:rPr>
+              <a:t>1  Verify</a:t>
+            </a:r>
+            <a:endParaRPr lang="en-US" sz="1050" dirty="0"/>
+          </a:p>
+          <a:p>
+            <a:pPr algn="ctr" indent="0" marL="0">
+              <a:buNone/>
+            </a:pPr>
+            <a:r>
+              <a:rPr lang="en-US" sz="800" dirty="0">
+                <a:solidFill>
+                  <a:srgbClr val="FFFFFF"/>
+                </a:solidFill>
+                <a:latin typeface="SF Pro Text" pitchFamily="34" charset="0"/>
+                <a:ea typeface="SF Pro Text" pitchFamily="34" charset="-122"/>
+                <a:cs typeface="SF Pro Text" pitchFamily="34" charset="-120"/>
+              </a:rPr>
+              <a:t>Is it a real promise?</a:t>
+            </a:r>
+            <a:endParaRPr lang="en-US" sz="1050" dirty="0"/>
+          </a:p>
+        </p:txBody>
+      </p:sp>
+      <p:sp>
+        <p:nvSpPr>
+          <p:cNvPr id="8" name="Shape 5"/>
+          <p:cNvSpPr/>
+          <p:nvPr/>
+        </p:nvSpPr>
+        <p:spPr>
+          <a:xfrm>
+            <a:off x="2148840" y="1581912"/>
+            <a:ext cx="228600" cy="0"/>
+          </a:xfrm>
+          <a:prstGeom prst="line">
+            <a:avLst/>
+          </a:prstGeom>
+          <a:noFill/>
+          <a:ln w="12700">
+            <a:solidFill>
+              <a:srgbClr val="6E6E73"/>
+            </a:solidFill>
+            <a:prstDash val="solid"/>
+            <a:tailEnd type="triangle"/>
+          </a:ln>
+        </p:spPr>
+      </p:sp>
+      <p:sp>
+        <p:nvSpPr>
+          <p:cNvPr id="9" name="Shape 6"/>
+          <p:cNvSpPr/>
+          <p:nvPr/>
+        </p:nvSpPr>
+        <p:spPr>
+          <a:xfrm>
+            <a:off x="2377440" y="1298448"/>
+            <a:ext cx="1874520" cy="566928"/>
+          </a:xfrm>
+          <a:prstGeom prst="roundRect">
+            <a:avLst>
+              <a:gd name="adj" fmla="val 12903"/>
+            </a:avLst>
+          </a:prstGeom>
+          <a:solidFill>
+            <a:srgbClr val="FFF3D6"/>
+          </a:solidFill>
+          <a:ln w="12700">
+            <a:solidFill>
+              <a:srgbClr val="9A6410"/>
+            </a:solidFill>
+            <a:prstDash val="solid"/>
+          </a:ln>
+        </p:spPr>
+      </p:sp>
+      <p:sp>
+        <p:nvSpPr>
+          <p:cNvPr id="10" name="Text 7"/>
+          <p:cNvSpPr txBox="1"/>
+          <p:nvPr/>
+        </p:nvSpPr>
+        <p:spPr>
+          <a:xfrm>
+            <a:off x="2377440" y="1298448"/>
+            <a:ext cx="1874520" cy="566928"/>
+          </a:xfrm>
+          <a:prstGeom prst="rect">
+            <a:avLst/>
+          </a:prstGeom>
+          <a:noFill/>
+          <a:ln/>
+        </p:spPr>
+        <p:txBody>
+          <a:bodyPr wrap="square" lIns="0" tIns="0" rIns="0" bIns="0" rtlCol="0" anchor="ctr"/>
+          <a:lstStyle/>
+          <a:p>
+            <a:pPr algn="ctr" indent="0" marL="0">
+              <a:buNone/>
+            </a:pPr>
+            <a:r>
+              <a:rPr lang="en-US" sz="1000" b="1" dirty="0">
+                <a:solidFill>
+                  <a:srgbClr val="9A6410"/>
+                </a:solidFill>
+                <a:latin typeface="SF Pro Display" pitchFamily="34" charset="0"/>
+                <a:ea typeface="SF Pro Display" pitchFamily="34" charset="-122"/>
+                <a:cs typeface="SF Pro Display" pitchFamily="34" charset="-120"/>
+              </a:rPr>
+              <a:t>Misinformation</a:t>
+            </a:r>
+            <a:endParaRPr lang="en-US" sz="1000" dirty="0"/>
+          </a:p>
+          <a:p>
+            <a:pPr algn="ctr" indent="0" marL="0">
+              <a:buNone/>
+            </a:pPr>
+            <a:r>
+              <a:rPr lang="en-US" sz="1000" b="1" dirty="0">
+                <a:solidFill>
+                  <a:srgbClr val="9A6410"/>
+                </a:solidFill>
+                <a:latin typeface="SF Pro Display" pitchFamily="34" charset="0"/>
+                <a:ea typeface="SF Pro Display" pitchFamily="34" charset="-122"/>
+                <a:cs typeface="SF Pro Display" pitchFamily="34" charset="-120"/>
+              </a:rPr>
+              <a:t>verified?</a:t>
+            </a:r>
+            <a:endParaRPr lang="en-US" sz="1000" dirty="0"/>
+          </a:p>
+        </p:txBody>
+      </p:sp>
+      <p:sp>
+        <p:nvSpPr>
+          <p:cNvPr id="11" name="Shape 8"/>
+          <p:cNvSpPr/>
+          <p:nvPr/>
+        </p:nvSpPr>
+        <p:spPr>
+          <a:xfrm>
+            <a:off x="4251960" y="1581912"/>
+            <a:ext cx="274320" cy="0"/>
+          </a:xfrm>
+          <a:prstGeom prst="line">
+            <a:avLst/>
+          </a:prstGeom>
+          <a:noFill/>
+          <a:ln w="12700">
+            <a:solidFill>
+              <a:srgbClr val="6E6E73"/>
+            </a:solidFill>
+            <a:prstDash val="solid"/>
+            <a:tailEnd type="triangle"/>
+          </a:ln>
+        </p:spPr>
+      </p:sp>
+      <p:sp>
+        <p:nvSpPr>
+          <p:cNvPr id="12" name="Text 9"/>
+          <p:cNvSpPr txBox="1"/>
+          <p:nvPr/>
+        </p:nvSpPr>
+        <p:spPr>
+          <a:xfrm>
+            <a:off x="4160520" y="1380744"/>
+            <a:ext cx="457200" cy="182880"/>
+          </a:xfrm>
+          <a:prstGeom prst="rect">
+            <a:avLst/>
+          </a:prstGeom>
+          <a:noFill/>
+          <a:ln/>
+        </p:spPr>
+        <p:txBody>
+          <a:bodyPr wrap="square" lIns="0" tIns="0" rIns="0" bIns="0" rtlCol="0" anchor="t"/>
+          <a:lstStyle/>
+          <a:p>
+            <a:pPr algn="ctr" indent="0" marL="0">
+              <a:buNone/>
+            </a:pPr>
+            <a:r>
+              <a:rPr lang="en-US" sz="800" b="1" dirty="0">
+                <a:solidFill>
+                  <a:srgbClr val="6E6E73"/>
+                </a:solidFill>
+                <a:latin typeface="SF Pro Text" pitchFamily="34" charset="0"/>
+                <a:ea typeface="SF Pro Text" pitchFamily="34" charset="-122"/>
+                <a:cs typeface="SF Pro Text" pitchFamily="34" charset="-120"/>
+              </a:rPr>
+              <a:t>Yes</a:t>
+            </a:r>
+            <a:endParaRPr lang="en-US" sz="800" dirty="0"/>
+          </a:p>
+        </p:txBody>
+      </p:sp>
+      <p:sp>
+        <p:nvSpPr>
+          <p:cNvPr id="13" name="Shape 10"/>
+          <p:cNvSpPr/>
+          <p:nvPr/>
+        </p:nvSpPr>
+        <p:spPr>
+          <a:xfrm>
+            <a:off x="4526280" y="1298448"/>
+            <a:ext cx="1828800" cy="566928"/>
+          </a:xfrm>
+          <a:prstGeom prst="roundRect">
+            <a:avLst>
+              <a:gd name="adj" fmla="val 12903"/>
+            </a:avLst>
+          </a:prstGeom>
+          <a:solidFill>
+            <a:srgbClr val="0B7A6F"/>
+          </a:solidFill>
+          <a:ln w="12700">
+            <a:solidFill>
+              <a:srgbClr val="0B7A6F"/>
+            </a:solidFill>
+            <a:prstDash val="solid"/>
+          </a:ln>
+        </p:spPr>
+      </p:sp>
+      <p:sp>
+        <p:nvSpPr>
+          <p:cNvPr id="14" name="Text 11"/>
+          <p:cNvSpPr txBox="1"/>
+          <p:nvPr/>
+        </p:nvSpPr>
+        <p:spPr>
+          <a:xfrm>
+            <a:off x="4572000" y="1298448"/>
+            <a:ext cx="1737360" cy="566928"/>
+          </a:xfrm>
+          <a:prstGeom prst="rect">
+            <a:avLst/>
+          </a:prstGeom>
+          <a:noFill/>
+          <a:ln/>
+        </p:spPr>
+        <p:txBody>
+          <a:bodyPr wrap="square" lIns="0" tIns="0" rIns="0" bIns="0" rtlCol="0" anchor="ctr"/>
+          <a:lstStyle/>
+          <a:p>
+            <a:pPr algn="ctr" indent="0" marL="0">
+              <a:buNone/>
+            </a:pPr>
+            <a:r>
+              <a:rPr lang="en-US" sz="1050" b="1" dirty="0">
+                <a:solidFill>
+                  <a:srgbClr val="FFFFFF"/>
+                </a:solidFill>
+                <a:latin typeface="SF Pro Display" pitchFamily="34" charset="0"/>
+                <a:ea typeface="SF Pro Display" pitchFamily="34" charset="-122"/>
+                <a:cs typeface="SF Pro Display" pitchFamily="34" charset="-120"/>
+              </a:rPr>
+              <a:t>2  Refund the gap</a:t>
+            </a:r>
+            <a:endParaRPr lang="en-US" sz="1050" dirty="0"/>
+          </a:p>
+          <a:p>
+            <a:pPr algn="ctr" indent="0" marL="0">
+              <a:buNone/>
+            </a:pPr>
+            <a:r>
+              <a:rPr lang="en-US" sz="800" dirty="0">
+                <a:solidFill>
+                  <a:srgbClr val="FFFFFF"/>
+                </a:solidFill>
+                <a:latin typeface="SF Pro Text" pitchFamily="34" charset="0"/>
+                <a:ea typeface="SF Pro Text" pitchFamily="34" charset="-122"/>
+                <a:cs typeface="SF Pro Text" pitchFamily="34" charset="-120"/>
+              </a:rPr>
+              <a:t>Charged more than promised?</a:t>
+            </a:r>
+            <a:endParaRPr lang="en-US" sz="1050" dirty="0"/>
+          </a:p>
+        </p:txBody>
+      </p:sp>
+      <p:sp>
+        <p:nvSpPr>
+          <p:cNvPr id="15" name="Shape 12"/>
+          <p:cNvSpPr/>
+          <p:nvPr/>
+        </p:nvSpPr>
+        <p:spPr>
+          <a:xfrm>
+            <a:off x="6355080" y="1581912"/>
+            <a:ext cx="274320" cy="0"/>
+          </a:xfrm>
+          <a:prstGeom prst="line">
+            <a:avLst/>
+          </a:prstGeom>
+          <a:noFill/>
+          <a:ln w="12700">
+            <a:solidFill>
+              <a:srgbClr val="6E6E73"/>
+            </a:solidFill>
+            <a:prstDash val="solid"/>
+            <a:tailEnd type="triangle"/>
+          </a:ln>
+        </p:spPr>
+      </p:sp>
+      <p:sp>
+        <p:nvSpPr>
+          <p:cNvPr id="16" name="Shape 13"/>
+          <p:cNvSpPr/>
+          <p:nvPr/>
+        </p:nvSpPr>
+        <p:spPr>
+          <a:xfrm>
+            <a:off x="6629400" y="1298448"/>
+            <a:ext cx="2103120" cy="566928"/>
+          </a:xfrm>
+          <a:prstGeom prst="roundRect">
+            <a:avLst>
+              <a:gd name="adj" fmla="val 12903"/>
+            </a:avLst>
+          </a:prstGeom>
+          <a:solidFill>
+            <a:srgbClr val="0B7A6F"/>
+          </a:solidFill>
+          <a:ln w="12700">
+            <a:solidFill>
+              <a:srgbClr val="0B7A6F"/>
+            </a:solidFill>
+            <a:prstDash val="solid"/>
+          </a:ln>
+        </p:spPr>
+      </p:sp>
+      <p:sp>
+        <p:nvSpPr>
+          <p:cNvPr id="17" name="Text 14"/>
+          <p:cNvSpPr txBox="1"/>
+          <p:nvPr/>
+        </p:nvSpPr>
+        <p:spPr>
+          <a:xfrm>
+            <a:off x="6675120" y="1298448"/>
+            <a:ext cx="2011680" cy="566928"/>
+          </a:xfrm>
+          <a:prstGeom prst="rect">
+            <a:avLst/>
+          </a:prstGeom>
+          <a:noFill/>
+          <a:ln/>
+        </p:spPr>
+        <p:txBody>
+          <a:bodyPr wrap="square" lIns="0" tIns="0" rIns="0" bIns="0" rtlCol="0" anchor="ctr"/>
+          <a:lstStyle/>
+          <a:p>
+            <a:pPr algn="ctr" indent="0" marL="0">
+              <a:buNone/>
+            </a:pPr>
+            <a:r>
+              <a:rPr lang="en-US" sz="1050" b="1" dirty="0">
+                <a:solidFill>
+                  <a:srgbClr val="FFFFFF"/>
+                </a:solidFill>
+                <a:latin typeface="SF Pro Display" pitchFamily="34" charset="0"/>
+                <a:ea typeface="SF Pro Display" pitchFamily="34" charset="-122"/>
+                <a:cs typeface="SF Pro Display" pitchFamily="34" charset="-120"/>
+              </a:rPr>
+              <a:t>3  Own the error</a:t>
+            </a:r>
+            <a:endParaRPr lang="en-US" sz="1050" dirty="0"/>
+          </a:p>
+          <a:p>
+            <a:pPr algn="ctr" indent="0" marL="0">
+              <a:buNone/>
+            </a:pPr>
+            <a:r>
+              <a:rPr lang="en-US" sz="800" dirty="0">
+                <a:solidFill>
+                  <a:srgbClr val="FFFFFF"/>
+                </a:solidFill>
+                <a:latin typeface="SF Pro Text" pitchFamily="34" charset="0"/>
+                <a:ea typeface="SF Pro Text" pitchFamily="34" charset="-122"/>
+                <a:cs typeface="SF Pro Text" pitchFamily="34" charset="-120"/>
+              </a:rPr>
+              <a:t>Ours, not "a misunderstanding"</a:t>
+            </a:r>
+            <a:endParaRPr lang="en-US" sz="1050" dirty="0"/>
+          </a:p>
+        </p:txBody>
+      </p:sp>
+      <p:sp>
+        <p:nvSpPr>
+          <p:cNvPr id="18" name="Shape 15"/>
+          <p:cNvSpPr/>
+          <p:nvPr/>
+        </p:nvSpPr>
+        <p:spPr>
+          <a:xfrm>
+            <a:off x="3314700" y="1865376"/>
+            <a:ext cx="0" cy="237744"/>
+          </a:xfrm>
+          <a:prstGeom prst="line">
+            <a:avLst/>
+          </a:prstGeom>
+          <a:noFill/>
+          <a:ln w="12700">
+            <a:solidFill>
+              <a:srgbClr val="6E6E73"/>
+            </a:solidFill>
+            <a:prstDash val="solid"/>
+            <a:tailEnd type="triangle"/>
+          </a:ln>
+        </p:spPr>
+      </p:sp>
+      <p:sp>
+        <p:nvSpPr>
+          <p:cNvPr id="19" name="Text 16"/>
+          <p:cNvSpPr txBox="1"/>
+          <p:nvPr/>
+        </p:nvSpPr>
+        <p:spPr>
+          <a:xfrm>
+            <a:off x="3337560" y="1883664"/>
+            <a:ext cx="274320" cy="182880"/>
+          </a:xfrm>
+          <a:prstGeom prst="rect">
+            <a:avLst/>
+          </a:prstGeom>
+          <a:noFill/>
+          <a:ln/>
+        </p:spPr>
+        <p:txBody>
+          <a:bodyPr wrap="square" lIns="0" tIns="0" rIns="0" bIns="0" rtlCol="0" anchor="t"/>
+          <a:lstStyle/>
+          <a:p>
+            <a:pPr algn="ctr" indent="0" marL="0">
+              <a:buNone/>
+            </a:pPr>
+            <a:r>
+              <a:rPr lang="en-US" sz="800" b="1" dirty="0">
+                <a:solidFill>
+                  <a:srgbClr val="6E6E73"/>
+                </a:solidFill>
+                <a:latin typeface="SF Pro Text" pitchFamily="34" charset="0"/>
+                <a:ea typeface="SF Pro Text" pitchFamily="34" charset="-122"/>
+                <a:cs typeface="SF Pro Text" pitchFamily="34" charset="-120"/>
+              </a:rPr>
+              <a:t>No</a:t>
+            </a:r>
+            <a:endParaRPr lang="en-US" sz="800" dirty="0"/>
+          </a:p>
+        </p:txBody>
+      </p:sp>
+      <p:sp>
+        <p:nvSpPr>
+          <p:cNvPr id="20" name="Shape 17"/>
+          <p:cNvSpPr/>
+          <p:nvPr/>
+        </p:nvSpPr>
+        <p:spPr>
+          <a:xfrm>
+            <a:off x="2377440" y="2103120"/>
+            <a:ext cx="1874520" cy="457200"/>
+          </a:xfrm>
+          <a:prstGeom prst="roundRect">
+            <a:avLst>
+              <a:gd name="adj" fmla="val 16000"/>
+            </a:avLst>
+          </a:prstGeom>
+          <a:solidFill>
+            <a:srgbClr val="FFFFFF"/>
+          </a:solidFill>
+          <a:ln w="12700">
+            <a:solidFill>
+              <a:srgbClr val="DCE1E7"/>
+            </a:solidFill>
+            <a:prstDash val="solid"/>
+          </a:ln>
+        </p:spPr>
+      </p:sp>
+      <p:sp>
+        <p:nvSpPr>
+          <p:cNvPr id="21" name="Text 18"/>
+          <p:cNvSpPr txBox="1"/>
+          <p:nvPr/>
+        </p:nvSpPr>
+        <p:spPr>
+          <a:xfrm>
+            <a:off x="2377440" y="2103120"/>
+            <a:ext cx="1874520" cy="457200"/>
+          </a:xfrm>
+          <a:prstGeom prst="rect">
+            <a:avLst/>
+          </a:prstGeom>
+          <a:noFill/>
+          <a:ln/>
+        </p:spPr>
+        <p:txBody>
+          <a:bodyPr wrap="square" lIns="0" tIns="0" rIns="0" bIns="0" rtlCol="0" anchor="ctr"/>
+          <a:lstStyle/>
+          <a:p>
+            <a:pPr algn="ctr" indent="0" marL="0">
+              <a:buNone/>
+            </a:pPr>
+            <a:r>
+              <a:rPr lang="en-US" sz="1000" b="1" dirty="0">
+                <a:solidFill>
+                  <a:srgbClr val="1D1D1F"/>
+                </a:solidFill>
+                <a:latin typeface="SF Pro Display" pitchFamily="34" charset="0"/>
+                <a:ea typeface="SF Pro Display" pitchFamily="34" charset="-122"/>
+                <a:cs typeface="SF Pro Display" pitchFamily="34" charset="-120"/>
+              </a:rPr>
+              <a:t>Clarify the information and address any confusion</a:t>
+            </a:r>
+            <a:endParaRPr lang="en-US" sz="1000" dirty="0"/>
+          </a:p>
+        </p:txBody>
+      </p:sp>
+      <p:sp>
+        <p:nvSpPr>
+          <p:cNvPr id="22" name="Text 19"/>
+          <p:cNvSpPr/>
+          <p:nvPr/>
+        </p:nvSpPr>
+        <p:spPr>
+          <a:xfrm>
+            <a:off x="411480" y="2011680"/>
+            <a:ext cx="1737360" cy="365760"/>
+          </a:xfrm>
+          <a:prstGeom prst="roundRect">
+            <a:avLst>
+              <a:gd name="adj" fmla="val 20000"/>
+            </a:avLst>
+          </a:prstGeom>
+          <a:solidFill>
+            <a:srgbClr val="FFFFFF"/>
+          </a:solidFill>
+          <a:ln w="19050">
+            <a:solidFill>
+              <a:srgbClr val="0B7A6F"/>
+            </a:solidFill>
+          </a:ln>
+        </p:spPr>
+        <p:txBody>
+          <a:bodyPr wrap="square" rtlCol="0" anchor="ctr"/>
+          <a:lstStyle/>
+          <a:p>
+            <a:pPr algn="ctr" indent="0" marL="0">
+              <a:buNone/>
+            </a:pPr>
+            <a:r>
+              <a:rPr lang="en-US" sz="1000" b="1" dirty="0">
+                <a:solidFill>
+                  <a:srgbClr val="0B7A6F"/>
+                </a:solidFill>
+                <a:latin typeface="SF Pro Display" pitchFamily="34" charset="0"/>
+                <a:ea typeface="SF Pro Display" pitchFamily="34" charset="-122"/>
+                <a:cs typeface="SF Pro Display" pitchFamily="34" charset="-120"/>
+              </a:rPr>
+              <a:t>Sales call review  ›</a:t>
+            </a:r>
+            <a:endParaRPr lang="en-US" sz="1000" dirty="0"/>
+          </a:p>
+        </p:txBody>
+      </p:sp>
+      <p:sp>
+        <p:nvSpPr>
+          <p:cNvPr id="23" name="Shape 20"/>
+          <p:cNvSpPr/>
+          <p:nvPr/>
+        </p:nvSpPr>
+        <p:spPr>
+          <a:xfrm>
+            <a:off x="1280160" y="1865376"/>
+            <a:ext cx="0" cy="146304"/>
+          </a:xfrm>
+          <a:prstGeom prst="line">
+            <a:avLst/>
+          </a:prstGeom>
+          <a:noFill/>
+          <a:ln w="12700">
+            <a:solidFill>
+              <a:srgbClr val="6E6E73"/>
+            </a:solidFill>
+            <a:prstDash val="solid"/>
+          </a:ln>
+        </p:spPr>
+      </p:sp>
+      <p:sp>
+        <p:nvSpPr>
+          <p:cNvPr id="24" name="Shape 21"/>
+          <p:cNvSpPr/>
+          <p:nvPr/>
+        </p:nvSpPr>
+        <p:spPr>
+          <a:xfrm>
+            <a:off x="7680960" y="1865376"/>
+            <a:ext cx="0" cy="768096"/>
+          </a:xfrm>
+          <a:prstGeom prst="line">
+            <a:avLst/>
+          </a:prstGeom>
+          <a:noFill/>
+          <a:ln w="12700">
+            <a:solidFill>
+              <a:srgbClr val="6E6E73"/>
+            </a:solidFill>
+            <a:prstDash val="solid"/>
+          </a:ln>
+        </p:spPr>
+      </p:sp>
+      <p:sp>
+        <p:nvSpPr>
+          <p:cNvPr id="25" name="Shape 22"/>
+          <p:cNvSpPr/>
+          <p:nvPr/>
+        </p:nvSpPr>
+        <p:spPr>
+          <a:xfrm>
+            <a:off x="1325880" y="2633472"/>
+            <a:ext cx="6355080" cy="0"/>
+          </a:xfrm>
+          <a:prstGeom prst="line">
+            <a:avLst/>
+          </a:prstGeom>
+          <a:noFill/>
+          <a:ln w="12700">
+            <a:solidFill>
+              <a:srgbClr val="6E6E73"/>
+            </a:solidFill>
+            <a:prstDash val="solid"/>
+          </a:ln>
+        </p:spPr>
+      </p:sp>
+      <p:sp>
+        <p:nvSpPr>
+          <p:cNvPr id="26" name="Shape 23"/>
+          <p:cNvSpPr/>
+          <p:nvPr/>
+        </p:nvSpPr>
+        <p:spPr>
+          <a:xfrm>
+            <a:off x="1325880" y="2633472"/>
+            <a:ext cx="0" cy="155448"/>
+          </a:xfrm>
+          <a:prstGeom prst="line">
+            <a:avLst/>
+          </a:prstGeom>
+          <a:noFill/>
+          <a:ln w="12700">
+            <a:solidFill>
+              <a:srgbClr val="6E6E73"/>
+            </a:solidFill>
+            <a:prstDash val="solid"/>
+            <a:tailEnd type="triangle"/>
+          </a:ln>
+        </p:spPr>
+      </p:sp>
+      <p:sp>
+        <p:nvSpPr>
+          <p:cNvPr id="27" name="Shape 24"/>
+          <p:cNvSpPr/>
+          <p:nvPr/>
+        </p:nvSpPr>
+        <p:spPr>
+          <a:xfrm>
+            <a:off x="411480" y="2788920"/>
+            <a:ext cx="1828800" cy="566928"/>
+          </a:xfrm>
+          <a:prstGeom prst="roundRect">
+            <a:avLst>
+              <a:gd name="adj" fmla="val 12903"/>
+            </a:avLst>
+          </a:prstGeom>
+          <a:solidFill>
+            <a:srgbClr val="0B7A6F"/>
+          </a:solidFill>
+          <a:ln w="12700">
+            <a:solidFill>
+              <a:srgbClr val="0B7A6F"/>
+            </a:solidFill>
+            <a:prstDash val="solid"/>
+          </a:ln>
+        </p:spPr>
+      </p:sp>
+      <p:sp>
+        <p:nvSpPr>
+          <p:cNvPr id="28" name="Text 25"/>
+          <p:cNvSpPr txBox="1"/>
+          <p:nvPr/>
+        </p:nvSpPr>
+        <p:spPr>
+          <a:xfrm>
+            <a:off x="457200" y="2788920"/>
+            <a:ext cx="1737360" cy="566928"/>
+          </a:xfrm>
+          <a:prstGeom prst="rect">
+            <a:avLst/>
+          </a:prstGeom>
+          <a:noFill/>
+          <a:ln/>
+        </p:spPr>
+        <p:txBody>
+          <a:bodyPr wrap="square" lIns="0" tIns="0" rIns="0" bIns="0" rtlCol="0" anchor="ctr"/>
+          <a:lstStyle/>
+          <a:p>
+            <a:pPr algn="ctr" indent="0" marL="0">
+              <a:buNone/>
+            </a:pPr>
+            <a:r>
+              <a:rPr lang="en-US" sz="1050" b="1" dirty="0">
+                <a:solidFill>
+                  <a:srgbClr val="FFFFFF"/>
+                </a:solidFill>
+                <a:latin typeface="SF Pro Display" pitchFamily="34" charset="0"/>
+                <a:ea typeface="SF Pro Display" pitchFamily="34" charset="-122"/>
+                <a:cs typeface="SF Pro Display" pitchFamily="34" charset="-120"/>
+              </a:rPr>
+              <a:t>4  Correct it</a:t>
+            </a:r>
+            <a:endParaRPr lang="en-US" sz="1050" dirty="0"/>
+          </a:p>
+          <a:p>
+            <a:pPr algn="ctr" indent="0" marL="0">
+              <a:buNone/>
+            </a:pPr>
+            <a:r>
+              <a:rPr lang="en-US" sz="800" dirty="0">
+                <a:solidFill>
+                  <a:srgbClr val="FFFFFF"/>
+                </a:solidFill>
+                <a:latin typeface="SF Pro Text" pitchFamily="34" charset="0"/>
+                <a:ea typeface="SF Pro Text" pitchFamily="34" charset="-122"/>
+                <a:cs typeface="SF Pro Text" pitchFamily="34" charset="-120"/>
+              </a:rPr>
+              <a:t>Fix charges, explain what changed</a:t>
+            </a:r>
+            <a:endParaRPr lang="en-US" sz="1050" dirty="0"/>
+          </a:p>
+        </p:txBody>
+      </p:sp>
+      <p:sp>
+        <p:nvSpPr>
+          <p:cNvPr id="29" name="Shape 26"/>
+          <p:cNvSpPr/>
+          <p:nvPr/>
+        </p:nvSpPr>
+        <p:spPr>
+          <a:xfrm>
+            <a:off x="2240280" y="3072384"/>
+            <a:ext cx="320040" cy="0"/>
+          </a:xfrm>
+          <a:prstGeom prst="line">
+            <a:avLst/>
+          </a:prstGeom>
+          <a:noFill/>
+          <a:ln w="12700">
+            <a:solidFill>
+              <a:srgbClr val="6E6E73"/>
+            </a:solidFill>
+            <a:prstDash val="solid"/>
+            <a:tailEnd type="triangle"/>
+          </a:ln>
+        </p:spPr>
+      </p:sp>
+      <p:sp>
+        <p:nvSpPr>
+          <p:cNvPr id="30" name="Shape 27"/>
+          <p:cNvSpPr/>
+          <p:nvPr/>
+        </p:nvSpPr>
+        <p:spPr>
+          <a:xfrm>
+            <a:off x="2560320" y="2788920"/>
+            <a:ext cx="2286000" cy="566928"/>
+          </a:xfrm>
+          <a:prstGeom prst="roundRect">
+            <a:avLst>
+              <a:gd name="adj" fmla="val 12903"/>
+            </a:avLst>
+          </a:prstGeom>
+          <a:solidFill>
+            <a:srgbClr val="0B7A6F"/>
+          </a:solidFill>
+          <a:ln w="12700">
+            <a:solidFill>
+              <a:srgbClr val="0B7A6F"/>
+            </a:solidFill>
+            <a:prstDash val="solid"/>
+          </a:ln>
+        </p:spPr>
+      </p:sp>
+      <p:sp>
+        <p:nvSpPr>
+          <p:cNvPr id="31" name="Text 28"/>
+          <p:cNvSpPr txBox="1"/>
+          <p:nvPr/>
+        </p:nvSpPr>
+        <p:spPr>
+          <a:xfrm>
+            <a:off x="2606040" y="2788920"/>
+            <a:ext cx="2194560" cy="566928"/>
+          </a:xfrm>
+          <a:prstGeom prst="rect">
+            <a:avLst/>
+          </a:prstGeom>
+          <a:noFill/>
+          <a:ln/>
+        </p:spPr>
+        <p:txBody>
+          <a:bodyPr wrap="square" lIns="0" tIns="0" rIns="0" bIns="0" rtlCol="0" anchor="ctr"/>
+          <a:lstStyle/>
+          <a:p>
+            <a:pPr algn="ctr" indent="0" marL="0">
+              <a:buNone/>
+            </a:pPr>
+            <a:r>
+              <a:rPr lang="en-US" sz="1050" b="1" dirty="0">
+                <a:solidFill>
+                  <a:srgbClr val="FFFFFF"/>
+                </a:solidFill>
+                <a:latin typeface="SF Pro Display" pitchFamily="34" charset="0"/>
+                <a:ea typeface="SF Pro Display" pitchFamily="34" charset="-122"/>
+                <a:cs typeface="SF Pro Display" pitchFamily="34" charset="-120"/>
+              </a:rPr>
+              <a:t>5  One light offer</a:t>
+            </a:r>
+            <a:endParaRPr lang="en-US" sz="1050" dirty="0"/>
+          </a:p>
+          <a:p>
+            <a:pPr algn="ctr" indent="0" marL="0">
+              <a:buNone/>
+            </a:pPr>
+            <a:r>
+              <a:rPr lang="en-US" sz="800" dirty="0">
+                <a:solidFill>
+                  <a:srgbClr val="FFFFFF"/>
+                </a:solidFill>
+                <a:latin typeface="SF Pro Text" pitchFamily="34" charset="0"/>
+                <a:ea typeface="SF Pro Text" pitchFamily="34" charset="-122"/>
+                <a:cs typeface="SF Pro Text" pitchFamily="34" charset="-120"/>
+              </a:rPr>
+              <a:t>Up to $20 credit or a 1-hr voucher</a:t>
+            </a:r>
+            <a:endParaRPr lang="en-US" sz="1050" dirty="0"/>
+          </a:p>
+        </p:txBody>
+      </p:sp>
+      <p:sp>
+        <p:nvSpPr>
+          <p:cNvPr id="32" name="Shape 29"/>
+          <p:cNvSpPr/>
+          <p:nvPr/>
+        </p:nvSpPr>
+        <p:spPr>
+          <a:xfrm>
+            <a:off x="4846320" y="3072384"/>
+            <a:ext cx="1234440" cy="0"/>
+          </a:xfrm>
+          <a:prstGeom prst="line">
+            <a:avLst/>
+          </a:prstGeom>
+          <a:noFill/>
+          <a:ln w="12700">
+            <a:solidFill>
+              <a:srgbClr val="6E6E73"/>
+            </a:solidFill>
+            <a:prstDash val="solid"/>
+            <a:tailEnd type="triangle"/>
+          </a:ln>
+        </p:spPr>
+      </p:sp>
+      <p:sp>
+        <p:nvSpPr>
+          <p:cNvPr id="33" name="Text 30"/>
+          <p:cNvSpPr txBox="1"/>
+          <p:nvPr/>
+        </p:nvSpPr>
+        <p:spPr>
+          <a:xfrm>
+            <a:off x="4846320" y="2688336"/>
+            <a:ext cx="1234440" cy="347472"/>
+          </a:xfrm>
+          <a:prstGeom prst="rect">
+            <a:avLst/>
+          </a:prstGeom>
+          <a:noFill/>
+          <a:ln/>
+        </p:spPr>
+        <p:txBody>
+          <a:bodyPr wrap="square" lIns="0" tIns="0" rIns="0" bIns="0" rtlCol="0" anchor="b"/>
+          <a:lstStyle/>
+          <a:p>
+            <a:pPr algn="ctr" indent="0" marL="0">
+              <a:buNone/>
+            </a:pPr>
+            <a:r>
+              <a:rPr lang="en-US" sz="800" b="1" dirty="0">
+                <a:solidFill>
+                  <a:srgbClr val="6E6E73"/>
+                </a:solidFill>
+                <a:latin typeface="SF Pro Text" pitchFamily="34" charset="0"/>
+                <a:ea typeface="SF Pro Text" pitchFamily="34" charset="-122"/>
+                <a:cs typeface="SF Pro Text" pitchFamily="34" charset="-120"/>
+              </a:rPr>
+              <a:t>Declined or</a:t>
+            </a:r>
+            <a:endParaRPr lang="en-US" sz="800" dirty="0"/>
+          </a:p>
+          <a:p>
+            <a:pPr algn="ctr" indent="0" marL="0">
+              <a:buNone/>
+            </a:pPr>
+            <a:r>
+              <a:rPr lang="en-US" sz="800" b="1" dirty="0">
+                <a:solidFill>
+                  <a:srgbClr val="6E6E73"/>
+                </a:solidFill>
+                <a:latin typeface="SF Pro Text" pitchFamily="34" charset="0"/>
+                <a:ea typeface="SF Pro Text" pitchFamily="34" charset="-122"/>
+                <a:cs typeface="SF Pro Text" pitchFamily="34" charset="-120"/>
+              </a:rPr>
+              <a:t>not retainable</a:t>
+            </a:r>
+            <a:endParaRPr lang="en-US" sz="800" dirty="0"/>
+          </a:p>
+        </p:txBody>
+      </p:sp>
+      <p:sp>
+        <p:nvSpPr>
+          <p:cNvPr id="34" name="Shape 31"/>
+          <p:cNvSpPr/>
+          <p:nvPr/>
+        </p:nvSpPr>
+        <p:spPr>
+          <a:xfrm>
+            <a:off x="6080760" y="2788920"/>
+            <a:ext cx="2651760" cy="566928"/>
+          </a:xfrm>
+          <a:prstGeom prst="roundRect">
+            <a:avLst>
+              <a:gd name="adj" fmla="val 12903"/>
             </a:avLst>
           </a:prstGeom>
           <a:solidFill>
@@ -24968,14 +25950,14 @@
       </p:sp>
       <p:sp>
         <p:nvSpPr>
-          <p:cNvPr id="7" name="Text 4"/>
+          <p:cNvPr id="35" name="Text 32"/>
           <p:cNvSpPr txBox="1"/>
           <p:nvPr/>
         </p:nvSpPr>
         <p:spPr>
           <a:xfrm>
-            <a:off x="411480" y="1417320"/>
-            <a:ext cx="1920240" cy="548640"/>
+            <a:off x="6126480" y="2788920"/>
+            <a:ext cx="2560320" cy="566928"/>
           </a:xfrm>
           <a:prstGeom prst="rect">
             <a:avLst/>
@@ -24991,7 +25973,7 @@
               <a:buNone/>
             </a:pPr>
             <a:r>
-              <a:rPr lang="en-US" sz="1000" b="1" dirty="0">
+              <a:rPr lang="en-US" sz="1050" b="1" dirty="0">
                 <a:solidFill>
                   <a:srgbClr val="FFFFFF"/>
                 </a:solidFill>
@@ -24999,447 +25981,38 @@
                 <a:ea typeface="SF Pro Display" pitchFamily="34" charset="-122"/>
                 <a:cs typeface="SF Pro Display" pitchFamily="34" charset="-120"/>
               </a:rPr>
-              <a:t>Told "$20/hr"</a:t>
-            </a:r>
-            <a:endParaRPr lang="en-US" sz="1000" dirty="0"/>
-          </a:p>
-        </p:txBody>
-      </p:sp>
-      <p:sp>
-        <p:nvSpPr>
-          <p:cNvPr id="8" name="Shape 5"/>
-          <p:cNvSpPr/>
-          <p:nvPr/>
-        </p:nvSpPr>
-        <p:spPr>
-          <a:xfrm>
-            <a:off x="2331720" y="1691640"/>
-            <a:ext cx="210312" cy="0"/>
-          </a:xfrm>
-          <a:prstGeom prst="line">
-            <a:avLst/>
-          </a:prstGeom>
-          <a:noFill/>
-          <a:ln w="12700">
-            <a:solidFill>
-              <a:srgbClr val="6E6E73"/>
-            </a:solidFill>
-            <a:prstDash val="solid"/>
-            <a:tailEnd type="triangle"/>
-          </a:ln>
-        </p:spPr>
-      </p:sp>
-      <p:sp>
-        <p:nvSpPr>
-          <p:cNvPr id="9" name="Text 6"/>
-          <p:cNvSpPr txBox="1"/>
-          <p:nvPr/>
-        </p:nvSpPr>
-        <p:spPr>
-          <a:xfrm>
-            <a:off x="411480" y="2057400"/>
-            <a:ext cx="1920240" cy="640080"/>
-          </a:xfrm>
-          <a:prstGeom prst="rect">
-            <a:avLst/>
-          </a:prstGeom>
-          <a:noFill/>
-          <a:ln/>
-        </p:spPr>
-        <p:txBody>
-          <a:bodyPr wrap="square" lIns="0" tIns="0" rIns="0" bIns="0" rtlCol="0" anchor="t"/>
-          <a:lstStyle/>
+              <a:t>6  Waive the ETF, cancel FC</a:t>
+            </a:r>
+            <a:endParaRPr lang="en-US" sz="1050" dirty="0"/>
+          </a:p>
           <a:p>
             <a:pPr algn="ctr" indent="0" marL="0">
               <a:buNone/>
             </a:pPr>
             <a:r>
-              <a:rPr lang="en-US" sz="950" dirty="0">
-                <a:solidFill>
-                  <a:srgbClr val="6E6E73"/>
+              <a:rPr lang="en-US" sz="800" dirty="0">
+                <a:solidFill>
+                  <a:srgbClr val="FFFFFF"/>
                 </a:solidFill>
                 <a:latin typeface="SF Pro Text" pitchFamily="34" charset="0"/>
                 <a:ea typeface="SF Pro Text" pitchFamily="34" charset="-122"/>
                 <a:cs typeface="SF Pro Text" pitchFamily="34" charset="-120"/>
               </a:rPr>
-              <a:t>No mention of processing fee, tax or Premium.</a:t>
-            </a:r>
-            <a:endParaRPr lang="en-US" sz="950" dirty="0"/>
-          </a:p>
-        </p:txBody>
-      </p:sp>
-      <p:sp>
-        <p:nvSpPr>
-          <p:cNvPr id="10" name="Shape 7"/>
+              <a:t>No ETF: the error was ours</a:t>
+            </a:r>
+            <a:endParaRPr lang="en-US" sz="1050" dirty="0"/>
+          </a:p>
+        </p:txBody>
+      </p:sp>
+      <p:sp>
+        <p:nvSpPr>
+          <p:cNvPr id="36" name="Shape 33"/>
           <p:cNvSpPr/>
           <p:nvPr/>
         </p:nvSpPr>
         <p:spPr>
           <a:xfrm>
-            <a:off x="2542032" y="1417320"/>
-            <a:ext cx="1920240" cy="548640"/>
-          </a:xfrm>
-          <a:prstGeom prst="roundRect">
-            <a:avLst>
-              <a:gd name="adj" fmla="val 13333"/>
-            </a:avLst>
-          </a:prstGeom>
-          <a:solidFill>
-            <a:srgbClr val="0B7A6F"/>
-          </a:solidFill>
-          <a:ln w="12700">
-            <a:solidFill>
-              <a:srgbClr val="0B7A6F"/>
-            </a:solidFill>
-            <a:prstDash val="solid"/>
-          </a:ln>
-        </p:spPr>
-      </p:sp>
-      <p:sp>
-        <p:nvSpPr>
-          <p:cNvPr id="11" name="Text 8"/>
-          <p:cNvSpPr txBox="1"/>
-          <p:nvPr/>
-        </p:nvSpPr>
-        <p:spPr>
-          <a:xfrm>
-            <a:off x="2542032" y="1417320"/>
-            <a:ext cx="1920240" cy="548640"/>
-          </a:xfrm>
-          <a:prstGeom prst="rect">
-            <a:avLst/>
-          </a:prstGeom>
-          <a:noFill/>
-          <a:ln/>
-        </p:spPr>
-        <p:txBody>
-          <a:bodyPr wrap="square" lIns="0" tIns="0" rIns="0" bIns="0" rtlCol="0" anchor="ctr"/>
-          <a:lstStyle/>
-          <a:p>
-            <a:pPr algn="ctr" indent="0" marL="0">
-              <a:buNone/>
-            </a:pPr>
-            <a:r>
-              <a:rPr lang="en-US" sz="1000" b="1" dirty="0">
-                <a:solidFill>
-                  <a:srgbClr val="FFFFFF"/>
-                </a:solidFill>
-                <a:latin typeface="SF Pro Display" pitchFamily="34" charset="0"/>
-                <a:ea typeface="SF Pro Display" pitchFamily="34" charset="-122"/>
-                <a:cs typeface="SF Pro Display" pitchFamily="34" charset="-120"/>
-              </a:rPr>
-              <a:t>Admin refund</a:t>
-            </a:r>
-            <a:endParaRPr lang="en-US" sz="1000" dirty="0"/>
-          </a:p>
-        </p:txBody>
-      </p:sp>
-      <p:sp>
-        <p:nvSpPr>
-          <p:cNvPr id="12" name="Shape 9"/>
-          <p:cNvSpPr/>
-          <p:nvPr/>
-        </p:nvSpPr>
-        <p:spPr>
-          <a:xfrm>
-            <a:off x="4462272" y="1691640"/>
-            <a:ext cx="210312" cy="0"/>
-          </a:xfrm>
-          <a:prstGeom prst="line">
-            <a:avLst/>
-          </a:prstGeom>
-          <a:noFill/>
-          <a:ln w="12700">
-            <a:solidFill>
-              <a:srgbClr val="6E6E73"/>
-            </a:solidFill>
-            <a:prstDash val="solid"/>
-            <a:tailEnd type="triangle"/>
-          </a:ln>
-        </p:spPr>
-      </p:sp>
-      <p:sp>
-        <p:nvSpPr>
-          <p:cNvPr id="13" name="Text 10"/>
-          <p:cNvSpPr txBox="1"/>
-          <p:nvPr/>
-        </p:nvSpPr>
-        <p:spPr>
-          <a:xfrm>
-            <a:off x="2542032" y="2057400"/>
-            <a:ext cx="1920240" cy="640080"/>
-          </a:xfrm>
-          <a:prstGeom prst="rect">
-            <a:avLst/>
-          </a:prstGeom>
-          <a:noFill/>
-          <a:ln/>
-        </p:spPr>
-        <p:txBody>
-          <a:bodyPr wrap="square" lIns="0" tIns="0" rIns="0" bIns="0" rtlCol="0" anchor="t"/>
-          <a:lstStyle/>
-          <a:p>
-            <a:pPr algn="ctr" indent="0" marL="0">
-              <a:buNone/>
-            </a:pPr>
-            <a:r>
-              <a:rPr lang="en-US" sz="950" dirty="0">
-                <a:solidFill>
-                  <a:srgbClr val="6E6E73"/>
-                </a:solidFill>
-                <a:latin typeface="SF Pro Text" pitchFamily="34" charset="0"/>
-                <a:ea typeface="SF Pro Text" pitchFamily="34" charset="-122"/>
-                <a:cs typeface="SF Pro Text" pitchFamily="34" charset="-120"/>
-              </a:rPr>
-              <a:t>So the job totals $20/hr × hours worked.</a:t>
-            </a:r>
-            <a:endParaRPr lang="en-US" sz="950" dirty="0"/>
-          </a:p>
-        </p:txBody>
-      </p:sp>
-      <p:sp>
-        <p:nvSpPr>
-          <p:cNvPr id="14" name="Shape 11"/>
-          <p:cNvSpPr/>
-          <p:nvPr/>
-        </p:nvSpPr>
-        <p:spPr>
-          <a:xfrm>
-            <a:off x="4672584" y="1417320"/>
-            <a:ext cx="1920240" cy="548640"/>
-          </a:xfrm>
-          <a:prstGeom prst="roundRect">
-            <a:avLst>
-              <a:gd name="adj" fmla="val 13333"/>
-            </a:avLst>
-          </a:prstGeom>
-          <a:solidFill>
-            <a:srgbClr val="0B7A6F"/>
-          </a:solidFill>
-          <a:ln w="12700">
-            <a:solidFill>
-              <a:srgbClr val="0B7A6F"/>
-            </a:solidFill>
-            <a:prstDash val="solid"/>
-          </a:ln>
-        </p:spPr>
-      </p:sp>
-      <p:sp>
-        <p:nvSpPr>
-          <p:cNvPr id="15" name="Text 12"/>
-          <p:cNvSpPr txBox="1"/>
-          <p:nvPr/>
-        </p:nvSpPr>
-        <p:spPr>
-          <a:xfrm>
-            <a:off x="4672584" y="1417320"/>
-            <a:ext cx="1920240" cy="548640"/>
-          </a:xfrm>
-          <a:prstGeom prst="rect">
-            <a:avLst/>
-          </a:prstGeom>
-          <a:noFill/>
-          <a:ln/>
-        </p:spPr>
-        <p:txBody>
-          <a:bodyPr wrap="square" lIns="0" tIns="0" rIns="0" bIns="0" rtlCol="0" anchor="ctr"/>
-          <a:lstStyle/>
-          <a:p>
-            <a:pPr algn="ctr" indent="0" marL="0">
-              <a:buNone/>
-            </a:pPr>
-            <a:r>
-              <a:rPr lang="en-US" sz="1000" b="1" dirty="0">
-                <a:solidFill>
-                  <a:srgbClr val="FFFFFF"/>
-                </a:solidFill>
-                <a:latin typeface="SF Pro Display" pitchFamily="34" charset="0"/>
-                <a:ea typeface="SF Pro Display" pitchFamily="34" charset="-122"/>
-                <a:cs typeface="SF Pro Display" pitchFamily="34" charset="-120"/>
-              </a:rPr>
-              <a:t>Set the account</a:t>
-            </a:r>
-            <a:endParaRPr lang="en-US" sz="1000" dirty="0"/>
-          </a:p>
-        </p:txBody>
-      </p:sp>
-      <p:sp>
-        <p:nvSpPr>
-          <p:cNvPr id="16" name="Shape 13"/>
-          <p:cNvSpPr/>
-          <p:nvPr/>
-        </p:nvSpPr>
-        <p:spPr>
-          <a:xfrm>
-            <a:off x="6592824" y="1691640"/>
-            <a:ext cx="210312" cy="0"/>
-          </a:xfrm>
-          <a:prstGeom prst="line">
-            <a:avLst/>
-          </a:prstGeom>
-          <a:noFill/>
-          <a:ln w="12700">
-            <a:solidFill>
-              <a:srgbClr val="6E6E73"/>
-            </a:solidFill>
-            <a:prstDash val="solid"/>
-            <a:tailEnd type="triangle"/>
-          </a:ln>
-        </p:spPr>
-      </p:sp>
-      <p:sp>
-        <p:nvSpPr>
-          <p:cNvPr id="17" name="Text 14"/>
-          <p:cNvSpPr txBox="1"/>
-          <p:nvPr/>
-        </p:nvSpPr>
-        <p:spPr>
-          <a:xfrm>
-            <a:off x="4672584" y="2057400"/>
-            <a:ext cx="1920240" cy="640080"/>
-          </a:xfrm>
-          <a:prstGeom prst="rect">
-            <a:avLst/>
-          </a:prstGeom>
-          <a:noFill/>
-          <a:ln/>
-        </p:spPr>
-        <p:txBody>
-          <a:bodyPr wrap="square" lIns="0" tIns="0" rIns="0" bIns="0" rtlCol="0" anchor="t"/>
-          <a:lstStyle/>
-          <a:p>
-            <a:pPr algn="ctr" indent="0" marL="0">
-              <a:buNone/>
-            </a:pPr>
-            <a:r>
-              <a:rPr lang="en-US" sz="950" dirty="0">
-                <a:solidFill>
-                  <a:srgbClr val="6E6E73"/>
-                </a:solidFill>
-                <a:latin typeface="SF Pro Text" pitchFamily="34" charset="0"/>
-                <a:ea typeface="SF Pro Text" pitchFamily="34" charset="-122"/>
-                <a:cs typeface="SF Pro Text" pitchFamily="34" charset="-120"/>
-              </a:rPr>
-              <a:t>Max CP rate $20. Cleaner Experience Level: Standard.</a:t>
-            </a:r>
-            <a:endParaRPr lang="en-US" sz="950" dirty="0"/>
-          </a:p>
-        </p:txBody>
-      </p:sp>
-      <p:sp>
-        <p:nvSpPr>
-          <p:cNvPr id="18" name="Shape 15"/>
-          <p:cNvSpPr/>
-          <p:nvPr/>
-        </p:nvSpPr>
-        <p:spPr>
-          <a:xfrm>
-            <a:off x="6803136" y="1417320"/>
-            <a:ext cx="1920240" cy="548640"/>
-          </a:xfrm>
-          <a:prstGeom prst="roundRect">
-            <a:avLst>
-              <a:gd name="adj" fmla="val 13333"/>
-            </a:avLst>
-          </a:prstGeom>
-          <a:solidFill>
-            <a:srgbClr val="FFFFFF"/>
-          </a:solidFill>
-          <a:ln w="12700">
-            <a:solidFill>
-              <a:srgbClr val="DCE1E7"/>
-            </a:solidFill>
-            <a:prstDash val="solid"/>
-          </a:ln>
-        </p:spPr>
-      </p:sp>
-      <p:sp>
-        <p:nvSpPr>
-          <p:cNvPr id="19" name="Text 16"/>
-          <p:cNvSpPr txBox="1"/>
-          <p:nvPr/>
-        </p:nvSpPr>
-        <p:spPr>
-          <a:xfrm>
-            <a:off x="6803136" y="1417320"/>
-            <a:ext cx="1920240" cy="548640"/>
-          </a:xfrm>
-          <a:prstGeom prst="rect">
-            <a:avLst/>
-          </a:prstGeom>
-          <a:noFill/>
-          <a:ln/>
-        </p:spPr>
-        <p:txBody>
-          <a:bodyPr wrap="square" lIns="0" tIns="0" rIns="0" bIns="0" rtlCol="0" anchor="ctr"/>
-          <a:lstStyle/>
-          <a:p>
-            <a:pPr algn="ctr" indent="0" marL="0">
-              <a:buNone/>
-            </a:pPr>
-            <a:r>
-              <a:rPr lang="en-US" sz="1000" b="1" dirty="0">
-                <a:solidFill>
-                  <a:srgbClr val="1D1D1F"/>
-                </a:solidFill>
-                <a:latin typeface="SF Pro Display" pitchFamily="34" charset="0"/>
-                <a:ea typeface="SF Pro Display" pitchFamily="34" charset="-122"/>
-                <a:cs typeface="SF Pro Display" pitchFamily="34" charset="-120"/>
-              </a:rPr>
-              <a:t>Explain the fees</a:t>
-            </a:r>
-            <a:endParaRPr lang="en-US" sz="1000" dirty="0"/>
-          </a:p>
-        </p:txBody>
-      </p:sp>
-      <p:sp>
-        <p:nvSpPr>
-          <p:cNvPr id="20" name="Text 17"/>
-          <p:cNvSpPr txBox="1"/>
-          <p:nvPr/>
-        </p:nvSpPr>
-        <p:spPr>
-          <a:xfrm>
-            <a:off x="6803136" y="2057400"/>
-            <a:ext cx="1920240" cy="640080"/>
-          </a:xfrm>
-          <a:prstGeom prst="rect">
-            <a:avLst/>
-          </a:prstGeom>
-          <a:noFill/>
-          <a:ln/>
-        </p:spPr>
-        <p:txBody>
-          <a:bodyPr wrap="square" lIns="0" tIns="0" rIns="0" bIns="0" rtlCol="0" anchor="t"/>
-          <a:lstStyle/>
-          <a:p>
-            <a:pPr algn="ctr" indent="0" marL="0">
-              <a:buNone/>
-            </a:pPr>
-            <a:r>
-              <a:rPr lang="en-US" sz="950" dirty="0">
-                <a:solidFill>
-                  <a:srgbClr val="6E6E73"/>
-                </a:solidFill>
-                <a:latin typeface="SF Pro Text" pitchFamily="34" charset="0"/>
-                <a:ea typeface="SF Pro Text" pitchFamily="34" charset="-122"/>
-                <a:cs typeface="SF Pro Text" pitchFamily="34" charset="-120"/>
-              </a:rPr>
-              <a:t>So the next invoice isn't a surprise.</a:t>
-            </a:r>
-            <a:endParaRPr lang="en-US" sz="950" dirty="0"/>
-          </a:p>
-        </p:txBody>
-      </p:sp>
-      <p:sp>
-        <p:nvSpPr>
-          <p:cNvPr id="21" name="Shape 18"/>
-          <p:cNvSpPr/>
-          <p:nvPr/>
-        </p:nvSpPr>
-        <p:spPr>
-          <a:xfrm>
-            <a:off x="411480" y="3063240"/>
+            <a:off x="411480" y="3566160"/>
             <a:ext cx="8321040" cy="384048"/>
           </a:xfrm>
           <a:prstGeom prst="roundRect">
@@ -25460,7 +26033,7 @@
       </p:sp>
       <p:pic>
         <p:nvPicPr>
-          <p:cNvPr id="22" name="Image 0" descr="preencoded.png">    </p:cNvPr>
+          <p:cNvPr id="37" name="Image 0" descr="preencoded.png">    </p:cNvPr>
           <p:cNvPicPr>
             <a:picLocks noChangeAspect="1"/>
           </p:cNvPicPr>
@@ -25474,7 +26047,7 @@
         </p:blipFill>
         <p:spPr>
           <a:xfrm>
-            <a:off x="566928" y="3172968"/>
+            <a:off x="566928" y="3675888"/>
             <a:ext cx="164592" cy="164592"/>
           </a:xfrm>
           <a:prstGeom prst="rect">
@@ -25484,13 +26057,13 @@
       </p:pic>
       <p:sp>
         <p:nvSpPr>
-          <p:cNvPr id="23" name="Text 19"/>
+          <p:cNvPr id="38" name="Text 34"/>
           <p:cNvSpPr txBox="1"/>
           <p:nvPr/>
         </p:nvSpPr>
         <p:spPr>
           <a:xfrm>
-            <a:off x="822960" y="3163824"/>
+            <a:off x="822960" y="3666744"/>
             <a:ext cx="7772400" cy="201168"/>
           </a:xfrm>
           <a:prstGeom prst="rect">
@@ -25515,7 +26088,7 @@
                 <a:ea typeface="SF Pro Text" pitchFamily="34" charset="-122"/>
                 <a:cs typeface="SF Pro Text" pitchFamily="34" charset="-120"/>
               </a:rPr>
-              <a:t>Disclosed and agreed?  </a:t>
+              <a:t>Waiting on a reply?  </a:t>
             </a:r>
             <a:pPr indent="0" marL="0">
               <a:buNone/>
@@ -25529,7 +26102,7 @@
                 <a:ea typeface="SF Pro Text" pitchFamily="34" charset="-122"/>
                 <a:cs typeface="SF Pro Text" pitchFamily="34" charset="-120"/>
               </a:rPr>
-              <a:t>refund only the part that was never disclosed.</a:t>
+              <a:t>set a TR before the next MF.</a:t>
             </a:r>
             <a:endParaRPr lang="en-US" sz="1000" dirty="0"/>
           </a:p>
@@ -25537,1470 +26110,7 @@
       </p:sp>
       <p:sp>
         <p:nvSpPr>
-          <p:cNvPr id="25" name="Slide Number Placeholder 0"/>
-          <p:cNvSpPr>
-            <a:spLocks noGrp="1"/>
-          </p:cNvSpPr>
-          <p:nvPr>
-            <p:ph type="sldNum" sz="quarter" idx="4294967295"/>
-          </p:nvPr>
-        </p:nvSpPr>
-        <p:spPr>
-          <a:xfrm>
-            <a:off x="8229600" y="4800600"/>
-            <a:ext cx="457200" cy="182880"/>
-          </a:xfrm>
-          <a:prstGeom prst="rect">
-            <a:avLst/>
-          </a:prstGeom>
-          <a:extLst>
-            <a:ext uri="{C572A759-6A51-4108-AA02-DFA0A04FC94B}">
-              <ma14:wrappingTextBoxFlag xmlns:ma14="http://schemas.microsoft.com/office/mac/drawingml/2011/main" val="0"/>
-            </a:ext>
-          </a:extLst>
-        </p:spPr>
-        <p:txBody>
-          <a:bodyPr/>
-          <a:lstStyle>
-            <a:lvl1pPr>
-              <a:defRPr sz="700">
-                <a:solidFill>
-                  <a:srgbClr val="6E6E73"/>
-                </a:solidFill>
-                <a:latin typeface="SF Pro Text"/>
-                <a:ea typeface="SF Pro Text"/>
-                <a:cs typeface="SF Pro Text"/>
-              </a:defRPr>
-            </a:lvl1pPr>
-          </a:lstStyle>
-          <a:p>
-            <a:pPr algn="r"/>
-            <a:fld id="{F7021451-1387-4CA6-816F-3879F97B5CBC}" type="slidenum">
-              <a:rPr b="0" lang="en-US"/>
-              <a:t>6</a:t>
-            </a:fld>
-            <a:endParaRPr lang="en-US"/>
-          </a:p>
-        </p:txBody>
-      </p:sp>
-    </p:spTree>
-  </p:cSld>
-  <p:clrMapOvr>
-    <a:masterClrMapping/>
-  </p:clrMapOvr>
-</p:sld>
-</file>
-
-<file path=ppt/slides/slide7.xml><?xml version="1.0" encoding="utf-8"?>
-<p:sld xmlns:a="http://schemas.openxmlformats.org/drawingml/2006/main" xmlns:r="http://schemas.openxmlformats.org/officeDocument/2006/relationships" xmlns:p="http://schemas.openxmlformats.org/presentationml/2006/main">
-  <p:cSld name="Slide 7">
-    <p:spTree>
-      <p:nvGrpSpPr>
-        <p:cNvPr id="1" name=""/>
-        <p:cNvGrpSpPr/>
-        <p:nvPr/>
-      </p:nvGrpSpPr>
-      <p:grpSpPr>
-        <a:xfrm>
-          <a:off x="0" y="0"/>
-          <a:ext cx="0" cy="0"/>
-          <a:chOff x="0" y="0"/>
-          <a:chExt cx="0" cy="0"/>
-        </a:xfrm>
-      </p:grpSpPr>
-      <p:sp>
-        <p:nvSpPr>
-          <p:cNvPr id="2" name="Text 0"/>
-          <p:cNvSpPr txBox="1"/>
-          <p:nvPr/>
-        </p:nvSpPr>
-        <p:spPr>
-          <a:xfrm>
-            <a:off x="438912" y="274320"/>
-            <a:ext cx="8229600" cy="182880"/>
-          </a:xfrm>
-          <a:prstGeom prst="rect">
-            <a:avLst/>
-          </a:prstGeom>
-          <a:noFill/>
-          <a:ln/>
-        </p:spPr>
-        <p:txBody>
-          <a:bodyPr wrap="square" lIns="0" tIns="0" rIns="0" bIns="0" rtlCol="0" anchor="t"/>
-          <a:lstStyle/>
-          <a:p>
-            <a:pPr indent="0" marL="0">
-              <a:buNone/>
-            </a:pPr>
-            <a:r>
-              <a:rPr lang="en-US" sz="800" b="1" spc="50" kern="0" dirty="0">
-                <a:solidFill>
-                  <a:srgbClr val="0B7A6F"/>
-                </a:solidFill>
-                <a:latin typeface="SF Pro Display" pitchFamily="34" charset="0"/>
-                <a:ea typeface="SF Pro Display" pitchFamily="34" charset="-122"/>
-                <a:cs typeface="SF Pro Display" pitchFamily="34" charset="-120"/>
-              </a:rPr>
-              <a:t>INCORRECT INFORMATION</a:t>
-            </a:r>
-            <a:endParaRPr lang="en-US" sz="800" dirty="0"/>
-          </a:p>
-        </p:txBody>
-      </p:sp>
-      <p:sp>
-        <p:nvSpPr>
-          <p:cNvPr id="3" name="Text 1"/>
-          <p:cNvSpPr txBox="1"/>
-          <p:nvPr/>
-        </p:nvSpPr>
-        <p:spPr>
-          <a:xfrm>
-            <a:off x="438912" y="457200"/>
-            <a:ext cx="8229600" cy="457200"/>
-          </a:xfrm>
-          <a:prstGeom prst="rect">
-            <a:avLst/>
-          </a:prstGeom>
-          <a:noFill/>
-          <a:ln/>
-        </p:spPr>
-        <p:txBody>
-          <a:bodyPr wrap="square" lIns="0" tIns="0" rIns="0" bIns="0" rtlCol="0" anchor="t"/>
-          <a:lstStyle/>
-          <a:p>
-            <a:pPr indent="0" marL="0">
-              <a:buNone/>
-            </a:pPr>
-            <a:r>
-              <a:rPr lang="en-US" sz="2400" b="1" dirty="0">
-                <a:solidFill>
-                  <a:srgbClr val="1D1D1F"/>
-                </a:solidFill>
-                <a:latin typeface="SF Pro Display" pitchFamily="34" charset="0"/>
-                <a:ea typeface="SF Pro Display" pitchFamily="34" charset="-122"/>
-                <a:cs typeface="SF Pro Display" pitchFamily="34" charset="-120"/>
-              </a:rPr>
-              <a:t>The process</a:t>
-            </a:r>
-            <a:endParaRPr lang="en-US" sz="2400" dirty="0"/>
-          </a:p>
-        </p:txBody>
-      </p:sp>
-      <p:sp>
-        <p:nvSpPr>
-          <p:cNvPr id="4" name="Text 2"/>
-          <p:cNvSpPr txBox="1"/>
-          <p:nvPr/>
-        </p:nvSpPr>
-        <p:spPr>
-          <a:xfrm>
-            <a:off x="438912" y="960120"/>
-            <a:ext cx="8229600" cy="274320"/>
-          </a:xfrm>
-          <a:prstGeom prst="rect">
-            <a:avLst/>
-          </a:prstGeom>
-          <a:noFill/>
-          <a:ln/>
-        </p:spPr>
-        <p:txBody>
-          <a:bodyPr wrap="square" lIns="0" tIns="0" rIns="0" bIns="0" rtlCol="0" anchor="t"/>
-          <a:lstStyle/>
-          <a:p>
-            <a:pPr indent="0" marL="0">
-              <a:buNone/>
-            </a:pPr>
-            <a:r>
-              <a:rPr lang="en-US" sz="1200" dirty="0">
-                <a:solidFill>
-                  <a:srgbClr val="6E6E73"/>
-                </a:solidFill>
-                <a:latin typeface="SF Pro Text" pitchFamily="34" charset="0"/>
-                <a:ea typeface="SF Pro Text" pitchFamily="34" charset="-122"/>
-                <a:cs typeface="SF Pro Text" pitchFamily="34" charset="-120"/>
-              </a:rPr>
-              <a:t>Verify first. Only verified misinformation moves on to steps 2–6.</a:t>
-            </a:r>
-            <a:endParaRPr lang="en-US" sz="1200" dirty="0"/>
-          </a:p>
-        </p:txBody>
-      </p:sp>
-      <p:sp>
-        <p:nvSpPr>
-          <p:cNvPr id="6" name="Shape 3"/>
-          <p:cNvSpPr/>
-          <p:nvPr/>
-        </p:nvSpPr>
-        <p:spPr>
-          <a:xfrm>
-            <a:off x="411480" y="1298448"/>
-            <a:ext cx="1737360" cy="566928"/>
-          </a:xfrm>
-          <a:prstGeom prst="roundRect">
-            <a:avLst>
-              <a:gd name="adj" fmla="val 12903"/>
-            </a:avLst>
-          </a:prstGeom>
-          <a:solidFill>
-            <a:srgbClr val="0B7A6F"/>
-          </a:solidFill>
-          <a:ln w="12700">
-            <a:solidFill>
-              <a:srgbClr val="0B7A6F"/>
-            </a:solidFill>
-            <a:prstDash val="solid"/>
-          </a:ln>
-        </p:spPr>
-      </p:sp>
-      <p:sp>
-        <p:nvSpPr>
-          <p:cNvPr id="7" name="Text 4"/>
-          <p:cNvSpPr txBox="1"/>
-          <p:nvPr/>
-        </p:nvSpPr>
-        <p:spPr>
-          <a:xfrm>
-            <a:off x="457200" y="1298448"/>
-            <a:ext cx="1645920" cy="566928"/>
-          </a:xfrm>
-          <a:prstGeom prst="rect">
-            <a:avLst/>
-          </a:prstGeom>
-          <a:noFill/>
-          <a:ln/>
-        </p:spPr>
-        <p:txBody>
-          <a:bodyPr wrap="square" lIns="0" tIns="0" rIns="0" bIns="0" rtlCol="0" anchor="ctr"/>
-          <a:lstStyle/>
-          <a:p>
-            <a:pPr algn="ctr" indent="0" marL="0">
-              <a:buNone/>
-            </a:pPr>
-            <a:r>
-              <a:rPr lang="en-US" sz="1050" b="1" dirty="0">
-                <a:solidFill>
-                  <a:srgbClr val="FFFFFF"/>
-                </a:solidFill>
-                <a:latin typeface="SF Pro Display" pitchFamily="34" charset="0"/>
-                <a:ea typeface="SF Pro Display" pitchFamily="34" charset="-122"/>
-                <a:cs typeface="SF Pro Display" pitchFamily="34" charset="-120"/>
-              </a:rPr>
-              <a:t>1  Verify</a:t>
-            </a:r>
-            <a:endParaRPr lang="en-US" sz="1050" dirty="0"/>
-          </a:p>
-          <a:p>
-            <a:pPr algn="ctr" indent="0" marL="0">
-              <a:buNone/>
-            </a:pPr>
-            <a:r>
-              <a:rPr lang="en-US" sz="800" dirty="0">
-                <a:solidFill>
-                  <a:srgbClr val="FFFFFF"/>
-                </a:solidFill>
-                <a:latin typeface="SF Pro Text" pitchFamily="34" charset="0"/>
-                <a:ea typeface="SF Pro Text" pitchFamily="34" charset="-122"/>
-                <a:cs typeface="SF Pro Text" pitchFamily="34" charset="-120"/>
-              </a:rPr>
-              <a:t>Is it a real promise?</a:t>
-            </a:r>
-            <a:endParaRPr lang="en-US" sz="1050" dirty="0"/>
-          </a:p>
-        </p:txBody>
-      </p:sp>
-      <p:sp>
-        <p:nvSpPr>
-          <p:cNvPr id="8" name="Shape 5"/>
-          <p:cNvSpPr/>
-          <p:nvPr/>
-        </p:nvSpPr>
-        <p:spPr>
-          <a:xfrm>
-            <a:off x="2148840" y="1581912"/>
-            <a:ext cx="228600" cy="0"/>
-          </a:xfrm>
-          <a:prstGeom prst="line">
-            <a:avLst/>
-          </a:prstGeom>
-          <a:noFill/>
-          <a:ln w="12700">
-            <a:solidFill>
-              <a:srgbClr val="6E6E73"/>
-            </a:solidFill>
-            <a:prstDash val="solid"/>
-            <a:tailEnd type="triangle"/>
-          </a:ln>
-        </p:spPr>
-      </p:sp>
-      <p:sp>
-        <p:nvSpPr>
-          <p:cNvPr id="9" name="Shape 6"/>
-          <p:cNvSpPr/>
-          <p:nvPr/>
-        </p:nvSpPr>
-        <p:spPr>
-          <a:xfrm>
-            <a:off x="2377440" y="1298448"/>
-            <a:ext cx="1874520" cy="566928"/>
-          </a:xfrm>
-          <a:prstGeom prst="roundRect">
-            <a:avLst>
-              <a:gd name="adj" fmla="val 12903"/>
-            </a:avLst>
-          </a:prstGeom>
-          <a:solidFill>
-            <a:srgbClr val="FFF3D6"/>
-          </a:solidFill>
-          <a:ln w="12700">
-            <a:solidFill>
-              <a:srgbClr val="9A6410"/>
-            </a:solidFill>
-            <a:prstDash val="solid"/>
-          </a:ln>
-        </p:spPr>
-      </p:sp>
-      <p:sp>
-        <p:nvSpPr>
-          <p:cNvPr id="10" name="Text 7"/>
-          <p:cNvSpPr txBox="1"/>
-          <p:nvPr/>
-        </p:nvSpPr>
-        <p:spPr>
-          <a:xfrm>
-            <a:off x="2377440" y="1298448"/>
-            <a:ext cx="1874520" cy="566928"/>
-          </a:xfrm>
-          <a:prstGeom prst="rect">
-            <a:avLst/>
-          </a:prstGeom>
-          <a:noFill/>
-          <a:ln/>
-        </p:spPr>
-        <p:txBody>
-          <a:bodyPr wrap="square" lIns="0" tIns="0" rIns="0" bIns="0" rtlCol="0" anchor="ctr"/>
-          <a:lstStyle/>
-          <a:p>
-            <a:pPr algn="ctr" indent="0" marL="0">
-              <a:buNone/>
-            </a:pPr>
-            <a:r>
-              <a:rPr lang="en-US" sz="1000" b="1" dirty="0">
-                <a:solidFill>
-                  <a:srgbClr val="9A6410"/>
-                </a:solidFill>
-                <a:latin typeface="SF Pro Display" pitchFamily="34" charset="0"/>
-                <a:ea typeface="SF Pro Display" pitchFamily="34" charset="-122"/>
-                <a:cs typeface="SF Pro Display" pitchFamily="34" charset="-120"/>
-              </a:rPr>
-              <a:t>Misinformation</a:t>
-            </a:r>
-            <a:endParaRPr lang="en-US" sz="1000" dirty="0"/>
-          </a:p>
-          <a:p>
-            <a:pPr algn="ctr" indent="0" marL="0">
-              <a:buNone/>
-            </a:pPr>
-            <a:r>
-              <a:rPr lang="en-US" sz="1000" b="1" dirty="0">
-                <a:solidFill>
-                  <a:srgbClr val="9A6410"/>
-                </a:solidFill>
-                <a:latin typeface="SF Pro Display" pitchFamily="34" charset="0"/>
-                <a:ea typeface="SF Pro Display" pitchFamily="34" charset="-122"/>
-                <a:cs typeface="SF Pro Display" pitchFamily="34" charset="-120"/>
-              </a:rPr>
-              <a:t>verified?</a:t>
-            </a:r>
-            <a:endParaRPr lang="en-US" sz="1000" dirty="0"/>
-          </a:p>
-        </p:txBody>
-      </p:sp>
-      <p:sp>
-        <p:nvSpPr>
-          <p:cNvPr id="11" name="Shape 8"/>
-          <p:cNvSpPr/>
-          <p:nvPr/>
-        </p:nvSpPr>
-        <p:spPr>
-          <a:xfrm>
-            <a:off x="4251960" y="1581912"/>
-            <a:ext cx="274320" cy="0"/>
-          </a:xfrm>
-          <a:prstGeom prst="line">
-            <a:avLst/>
-          </a:prstGeom>
-          <a:noFill/>
-          <a:ln w="12700">
-            <a:solidFill>
-              <a:srgbClr val="6E6E73"/>
-            </a:solidFill>
-            <a:prstDash val="solid"/>
-            <a:tailEnd type="triangle"/>
-          </a:ln>
-        </p:spPr>
-      </p:sp>
-      <p:sp>
-        <p:nvSpPr>
-          <p:cNvPr id="12" name="Text 9"/>
-          <p:cNvSpPr txBox="1"/>
-          <p:nvPr/>
-        </p:nvSpPr>
-        <p:spPr>
-          <a:xfrm>
-            <a:off x="4160520" y="1380744"/>
-            <a:ext cx="457200" cy="182880"/>
-          </a:xfrm>
-          <a:prstGeom prst="rect">
-            <a:avLst/>
-          </a:prstGeom>
-          <a:noFill/>
-          <a:ln/>
-        </p:spPr>
-        <p:txBody>
-          <a:bodyPr wrap="square" lIns="0" tIns="0" rIns="0" bIns="0" rtlCol="0" anchor="t"/>
-          <a:lstStyle/>
-          <a:p>
-            <a:pPr algn="ctr" indent="0" marL="0">
-              <a:buNone/>
-            </a:pPr>
-            <a:r>
-              <a:rPr lang="en-US" sz="800" b="1" dirty="0">
-                <a:solidFill>
-                  <a:srgbClr val="6E6E73"/>
-                </a:solidFill>
-                <a:latin typeface="SF Pro Text" pitchFamily="34" charset="0"/>
-                <a:ea typeface="SF Pro Text" pitchFamily="34" charset="-122"/>
-                <a:cs typeface="SF Pro Text" pitchFamily="34" charset="-120"/>
-              </a:rPr>
-              <a:t>Yes</a:t>
-            </a:r>
-            <a:endParaRPr lang="en-US" sz="800" dirty="0"/>
-          </a:p>
-        </p:txBody>
-      </p:sp>
-      <p:sp>
-        <p:nvSpPr>
-          <p:cNvPr id="13" name="Shape 10"/>
-          <p:cNvSpPr/>
-          <p:nvPr/>
-        </p:nvSpPr>
-        <p:spPr>
-          <a:xfrm>
-            <a:off x="4526280" y="1298448"/>
-            <a:ext cx="1828800" cy="566928"/>
-          </a:xfrm>
-          <a:prstGeom prst="roundRect">
-            <a:avLst>
-              <a:gd name="adj" fmla="val 12903"/>
-            </a:avLst>
-          </a:prstGeom>
-          <a:solidFill>
-            <a:srgbClr val="0B7A6F"/>
-          </a:solidFill>
-          <a:ln w="12700">
-            <a:solidFill>
-              <a:srgbClr val="0B7A6F"/>
-            </a:solidFill>
-            <a:prstDash val="solid"/>
-          </a:ln>
-        </p:spPr>
-      </p:sp>
-      <p:sp>
-        <p:nvSpPr>
-          <p:cNvPr id="14" name="Text 11"/>
-          <p:cNvSpPr txBox="1"/>
-          <p:nvPr/>
-        </p:nvSpPr>
-        <p:spPr>
-          <a:xfrm>
-            <a:off x="4572000" y="1298448"/>
-            <a:ext cx="1737360" cy="566928"/>
-          </a:xfrm>
-          <a:prstGeom prst="rect">
-            <a:avLst/>
-          </a:prstGeom>
-          <a:noFill/>
-          <a:ln/>
-        </p:spPr>
-        <p:txBody>
-          <a:bodyPr wrap="square" lIns="0" tIns="0" rIns="0" bIns="0" rtlCol="0" anchor="ctr"/>
-          <a:lstStyle/>
-          <a:p>
-            <a:pPr algn="ctr" indent="0" marL="0">
-              <a:buNone/>
-            </a:pPr>
-            <a:r>
-              <a:rPr lang="en-US" sz="1050" b="1" dirty="0">
-                <a:solidFill>
-                  <a:srgbClr val="FFFFFF"/>
-                </a:solidFill>
-                <a:latin typeface="SF Pro Display" pitchFamily="34" charset="0"/>
-                <a:ea typeface="SF Pro Display" pitchFamily="34" charset="-122"/>
-                <a:cs typeface="SF Pro Display" pitchFamily="34" charset="-120"/>
-              </a:rPr>
-              <a:t>2  Refund the gap</a:t>
-            </a:r>
-            <a:endParaRPr lang="en-US" sz="1050" dirty="0"/>
-          </a:p>
-          <a:p>
-            <a:pPr algn="ctr" indent="0" marL="0">
-              <a:buNone/>
-            </a:pPr>
-            <a:r>
-              <a:rPr lang="en-US" sz="800" dirty="0">
-                <a:solidFill>
-                  <a:srgbClr val="FFFFFF"/>
-                </a:solidFill>
-                <a:latin typeface="SF Pro Text" pitchFamily="34" charset="0"/>
-                <a:ea typeface="SF Pro Text" pitchFamily="34" charset="-122"/>
-                <a:cs typeface="SF Pro Text" pitchFamily="34" charset="-120"/>
-              </a:rPr>
-              <a:t>Charged more than promised?</a:t>
-            </a:r>
-            <a:endParaRPr lang="en-US" sz="1050" dirty="0"/>
-          </a:p>
-        </p:txBody>
-      </p:sp>
-      <p:sp>
-        <p:nvSpPr>
-          <p:cNvPr id="15" name="Shape 12"/>
-          <p:cNvSpPr/>
-          <p:nvPr/>
-        </p:nvSpPr>
-        <p:spPr>
-          <a:xfrm>
-            <a:off x="6355080" y="1581912"/>
-            <a:ext cx="274320" cy="0"/>
-          </a:xfrm>
-          <a:prstGeom prst="line">
-            <a:avLst/>
-          </a:prstGeom>
-          <a:noFill/>
-          <a:ln w="12700">
-            <a:solidFill>
-              <a:srgbClr val="6E6E73"/>
-            </a:solidFill>
-            <a:prstDash val="solid"/>
-            <a:tailEnd type="triangle"/>
-          </a:ln>
-        </p:spPr>
-      </p:sp>
-      <p:sp>
-        <p:nvSpPr>
-          <p:cNvPr id="16" name="Shape 13"/>
-          <p:cNvSpPr/>
-          <p:nvPr/>
-        </p:nvSpPr>
-        <p:spPr>
-          <a:xfrm>
-            <a:off x="6629400" y="1298448"/>
-            <a:ext cx="2103120" cy="566928"/>
-          </a:xfrm>
-          <a:prstGeom prst="roundRect">
-            <a:avLst>
-              <a:gd name="adj" fmla="val 12903"/>
-            </a:avLst>
-          </a:prstGeom>
-          <a:solidFill>
-            <a:srgbClr val="0B7A6F"/>
-          </a:solidFill>
-          <a:ln w="12700">
-            <a:solidFill>
-              <a:srgbClr val="0B7A6F"/>
-            </a:solidFill>
-            <a:prstDash val="solid"/>
-          </a:ln>
-        </p:spPr>
-      </p:sp>
-      <p:sp>
-        <p:nvSpPr>
-          <p:cNvPr id="17" name="Text 14"/>
-          <p:cNvSpPr txBox="1"/>
-          <p:nvPr/>
-        </p:nvSpPr>
-        <p:spPr>
-          <a:xfrm>
-            <a:off x="6675120" y="1298448"/>
-            <a:ext cx="2011680" cy="566928"/>
-          </a:xfrm>
-          <a:prstGeom prst="rect">
-            <a:avLst/>
-          </a:prstGeom>
-          <a:noFill/>
-          <a:ln/>
-        </p:spPr>
-        <p:txBody>
-          <a:bodyPr wrap="square" lIns="0" tIns="0" rIns="0" bIns="0" rtlCol="0" anchor="ctr"/>
-          <a:lstStyle/>
-          <a:p>
-            <a:pPr algn="ctr" indent="0" marL="0">
-              <a:buNone/>
-            </a:pPr>
-            <a:r>
-              <a:rPr lang="en-US" sz="1050" b="1" dirty="0">
-                <a:solidFill>
-                  <a:srgbClr val="FFFFFF"/>
-                </a:solidFill>
-                <a:latin typeface="SF Pro Display" pitchFamily="34" charset="0"/>
-                <a:ea typeface="SF Pro Display" pitchFamily="34" charset="-122"/>
-                <a:cs typeface="SF Pro Display" pitchFamily="34" charset="-120"/>
-              </a:rPr>
-              <a:t>3  Own the error</a:t>
-            </a:r>
-            <a:endParaRPr lang="en-US" sz="1050" dirty="0"/>
-          </a:p>
-          <a:p>
-            <a:pPr algn="ctr" indent="0" marL="0">
-              <a:buNone/>
-            </a:pPr>
-            <a:r>
-              <a:rPr lang="en-US" sz="800" dirty="0">
-                <a:solidFill>
-                  <a:srgbClr val="FFFFFF"/>
-                </a:solidFill>
-                <a:latin typeface="SF Pro Text" pitchFamily="34" charset="0"/>
-                <a:ea typeface="SF Pro Text" pitchFamily="34" charset="-122"/>
-                <a:cs typeface="SF Pro Text" pitchFamily="34" charset="-120"/>
-              </a:rPr>
-              <a:t>Ours, not "a misunderstanding"</a:t>
-            </a:r>
-            <a:endParaRPr lang="en-US" sz="1050" dirty="0"/>
-          </a:p>
-        </p:txBody>
-      </p:sp>
-      <p:sp>
-        <p:nvSpPr>
-          <p:cNvPr id="18" name="Shape 15"/>
-          <p:cNvSpPr/>
-          <p:nvPr/>
-        </p:nvSpPr>
-        <p:spPr>
-          <a:xfrm>
-            <a:off x="3314700" y="1865376"/>
-            <a:ext cx="0" cy="237744"/>
-          </a:xfrm>
-          <a:prstGeom prst="line">
-            <a:avLst/>
-          </a:prstGeom>
-          <a:noFill/>
-          <a:ln w="12700">
-            <a:solidFill>
-              <a:srgbClr val="6E6E73"/>
-            </a:solidFill>
-            <a:prstDash val="solid"/>
-            <a:tailEnd type="triangle"/>
-          </a:ln>
-        </p:spPr>
-      </p:sp>
-      <p:sp>
-        <p:nvSpPr>
-          <p:cNvPr id="19" name="Text 16"/>
-          <p:cNvSpPr txBox="1"/>
-          <p:nvPr/>
-        </p:nvSpPr>
-        <p:spPr>
-          <a:xfrm>
-            <a:off x="3337560" y="1883664"/>
-            <a:ext cx="274320" cy="182880"/>
-          </a:xfrm>
-          <a:prstGeom prst="rect">
-            <a:avLst/>
-          </a:prstGeom>
-          <a:noFill/>
-          <a:ln/>
-        </p:spPr>
-        <p:txBody>
-          <a:bodyPr wrap="square" lIns="0" tIns="0" rIns="0" bIns="0" rtlCol="0" anchor="t"/>
-          <a:lstStyle/>
-          <a:p>
-            <a:pPr algn="ctr" indent="0" marL="0">
-              <a:buNone/>
-            </a:pPr>
-            <a:r>
-              <a:rPr lang="en-US" sz="800" b="1" dirty="0">
-                <a:solidFill>
-                  <a:srgbClr val="6E6E73"/>
-                </a:solidFill>
-                <a:latin typeface="SF Pro Text" pitchFamily="34" charset="0"/>
-                <a:ea typeface="SF Pro Text" pitchFamily="34" charset="-122"/>
-                <a:cs typeface="SF Pro Text" pitchFamily="34" charset="-120"/>
-              </a:rPr>
-              <a:t>No</a:t>
-            </a:r>
-            <a:endParaRPr lang="en-US" sz="800" dirty="0"/>
-          </a:p>
-        </p:txBody>
-      </p:sp>
-      <p:sp>
-        <p:nvSpPr>
-          <p:cNvPr id="20" name="Shape 17"/>
-          <p:cNvSpPr/>
-          <p:nvPr/>
-        </p:nvSpPr>
-        <p:spPr>
-          <a:xfrm>
-            <a:off x="2377440" y="2103120"/>
-            <a:ext cx="1874520" cy="365760"/>
-          </a:xfrm>
-          <a:prstGeom prst="roundRect">
-            <a:avLst>
-              <a:gd name="adj" fmla="val 20000"/>
-            </a:avLst>
-          </a:prstGeom>
-          <a:solidFill>
-            <a:srgbClr val="FFFFFF"/>
-          </a:solidFill>
-          <a:ln w="12700">
-            <a:solidFill>
-              <a:srgbClr val="DCE1E7"/>
-            </a:solidFill>
-            <a:prstDash val="solid"/>
-          </a:ln>
-        </p:spPr>
-      </p:sp>
-      <p:sp>
-        <p:nvSpPr>
-          <p:cNvPr id="21" name="Text 18"/>
-          <p:cNvSpPr txBox="1"/>
-          <p:nvPr/>
-        </p:nvSpPr>
-        <p:spPr>
-          <a:xfrm>
-            <a:off x="2377440" y="2103120"/>
-            <a:ext cx="1874520" cy="365760"/>
-          </a:xfrm>
-          <a:prstGeom prst="rect">
-            <a:avLst/>
-          </a:prstGeom>
-          <a:noFill/>
-          <a:ln/>
-        </p:spPr>
-        <p:txBody>
-          <a:bodyPr wrap="square" lIns="0" tIns="0" rIns="0" bIns="0" rtlCol="0" anchor="ctr"/>
-          <a:lstStyle/>
-          <a:p>
-            <a:pPr algn="ctr" indent="0" marL="0">
-              <a:buNone/>
-            </a:pPr>
-            <a:r>
-              <a:rPr lang="en-US" sz="1000" b="1" dirty="0">
-                <a:solidFill>
-                  <a:srgbClr val="1D1D1F"/>
-                </a:solidFill>
-                <a:latin typeface="SF Pro Display" pitchFamily="34" charset="0"/>
-                <a:ea typeface="SF Pro Display" pitchFamily="34" charset="-122"/>
-                <a:cs typeface="SF Pro Display" pitchFamily="34" charset="-120"/>
-              </a:rPr>
-              <a:t>Handle as a normal case</a:t>
-            </a:r>
-            <a:endParaRPr lang="en-US" sz="1000" dirty="0"/>
-          </a:p>
-        </p:txBody>
-      </p:sp>
-      <p:sp>
-        <p:nvSpPr>
-          <p:cNvPr id="22" name="Text 19"/>
-          <p:cNvSpPr/>
-          <p:nvPr/>
-        </p:nvSpPr>
-        <p:spPr>
-          <a:xfrm>
-            <a:off x="411480" y="2011680"/>
-            <a:ext cx="1737360" cy="365760"/>
-          </a:xfrm>
-          <a:prstGeom prst="roundRect">
-            <a:avLst>
-              <a:gd name="adj" fmla="val 20000"/>
-            </a:avLst>
-          </a:prstGeom>
-          <a:solidFill>
-            <a:srgbClr val="FFFFFF"/>
-          </a:solidFill>
-          <a:ln w="19050">
-            <a:solidFill>
-              <a:srgbClr val="0B7A6F"/>
-            </a:solidFill>
-          </a:ln>
-        </p:spPr>
-        <p:txBody>
-          <a:bodyPr wrap="square" rtlCol="0" anchor="ctr"/>
-          <a:lstStyle/>
-          <a:p>
-            <a:pPr algn="ctr" indent="0" marL="0">
-              <a:buNone/>
-            </a:pPr>
-            <a:r>
-              <a:rPr lang="en-US" sz="1000" b="1" dirty="0">
-                <a:solidFill>
-                  <a:srgbClr val="0B7A6F"/>
-                </a:solidFill>
-                <a:latin typeface="SF Pro Display" pitchFamily="34" charset="0"/>
-                <a:ea typeface="SF Pro Display" pitchFamily="34" charset="-122"/>
-                <a:cs typeface="SF Pro Display" pitchFamily="34" charset="-120"/>
-              </a:rPr>
-              <a:t>Sales call review  ›</a:t>
-            </a:r>
-            <a:endParaRPr lang="en-US" sz="1000" dirty="0"/>
-          </a:p>
-        </p:txBody>
-      </p:sp>
-      <p:sp>
-        <p:nvSpPr>
-          <p:cNvPr id="23" name="Shape 20"/>
-          <p:cNvSpPr/>
-          <p:nvPr/>
-        </p:nvSpPr>
-        <p:spPr>
-          <a:xfrm>
-            <a:off x="1280160" y="1865376"/>
-            <a:ext cx="0" cy="146304"/>
-          </a:xfrm>
-          <a:prstGeom prst="line">
-            <a:avLst/>
-          </a:prstGeom>
-          <a:noFill/>
-          <a:ln w="12700">
-            <a:solidFill>
-              <a:srgbClr val="6E6E73"/>
-            </a:solidFill>
-            <a:prstDash val="solid"/>
-          </a:ln>
-        </p:spPr>
-      </p:sp>
-      <p:sp>
-        <p:nvSpPr>
-          <p:cNvPr id="24" name="Shape 21"/>
-          <p:cNvSpPr/>
-          <p:nvPr/>
-        </p:nvSpPr>
-        <p:spPr>
-          <a:xfrm>
-            <a:off x="7680960" y="1865376"/>
-            <a:ext cx="0" cy="768096"/>
-          </a:xfrm>
-          <a:prstGeom prst="line">
-            <a:avLst/>
-          </a:prstGeom>
-          <a:noFill/>
-          <a:ln w="12700">
-            <a:solidFill>
-              <a:srgbClr val="6E6E73"/>
-            </a:solidFill>
-            <a:prstDash val="solid"/>
-          </a:ln>
-        </p:spPr>
-      </p:sp>
-      <p:sp>
-        <p:nvSpPr>
-          <p:cNvPr id="25" name="Shape 22"/>
-          <p:cNvSpPr/>
-          <p:nvPr/>
-        </p:nvSpPr>
-        <p:spPr>
-          <a:xfrm>
-            <a:off x="1325880" y="2633472"/>
-            <a:ext cx="6355080" cy="0"/>
-          </a:xfrm>
-          <a:prstGeom prst="line">
-            <a:avLst/>
-          </a:prstGeom>
-          <a:noFill/>
-          <a:ln w="12700">
-            <a:solidFill>
-              <a:srgbClr val="6E6E73"/>
-            </a:solidFill>
-            <a:prstDash val="solid"/>
-          </a:ln>
-        </p:spPr>
-      </p:sp>
-      <p:sp>
-        <p:nvSpPr>
-          <p:cNvPr id="26" name="Shape 23"/>
-          <p:cNvSpPr/>
-          <p:nvPr/>
-        </p:nvSpPr>
-        <p:spPr>
-          <a:xfrm>
-            <a:off x="1325880" y="2633472"/>
-            <a:ext cx="0" cy="155448"/>
-          </a:xfrm>
-          <a:prstGeom prst="line">
-            <a:avLst/>
-          </a:prstGeom>
-          <a:noFill/>
-          <a:ln w="12700">
-            <a:solidFill>
-              <a:srgbClr val="6E6E73"/>
-            </a:solidFill>
-            <a:prstDash val="solid"/>
-            <a:tailEnd type="triangle"/>
-          </a:ln>
-        </p:spPr>
-      </p:sp>
-      <p:sp>
-        <p:nvSpPr>
-          <p:cNvPr id="27" name="Shape 24"/>
-          <p:cNvSpPr/>
-          <p:nvPr/>
-        </p:nvSpPr>
-        <p:spPr>
-          <a:xfrm>
-            <a:off x="411480" y="2788920"/>
-            <a:ext cx="1828800" cy="566928"/>
-          </a:xfrm>
-          <a:prstGeom prst="roundRect">
-            <a:avLst>
-              <a:gd name="adj" fmla="val 12903"/>
-            </a:avLst>
-          </a:prstGeom>
-          <a:solidFill>
-            <a:srgbClr val="0B7A6F"/>
-          </a:solidFill>
-          <a:ln w="12700">
-            <a:solidFill>
-              <a:srgbClr val="0B7A6F"/>
-            </a:solidFill>
-            <a:prstDash val="solid"/>
-          </a:ln>
-        </p:spPr>
-      </p:sp>
-      <p:sp>
-        <p:nvSpPr>
-          <p:cNvPr id="28" name="Text 25"/>
-          <p:cNvSpPr txBox="1"/>
-          <p:nvPr/>
-        </p:nvSpPr>
-        <p:spPr>
-          <a:xfrm>
-            <a:off x="457200" y="2788920"/>
-            <a:ext cx="1737360" cy="566928"/>
-          </a:xfrm>
-          <a:prstGeom prst="rect">
-            <a:avLst/>
-          </a:prstGeom>
-          <a:noFill/>
-          <a:ln/>
-        </p:spPr>
-        <p:txBody>
-          <a:bodyPr wrap="square" lIns="0" tIns="0" rIns="0" bIns="0" rtlCol="0" anchor="ctr"/>
-          <a:lstStyle/>
-          <a:p>
-            <a:pPr algn="ctr" indent="0" marL="0">
-              <a:buNone/>
-            </a:pPr>
-            <a:r>
-              <a:rPr lang="en-US" sz="1050" b="1" dirty="0">
-                <a:solidFill>
-                  <a:srgbClr val="FFFFFF"/>
-                </a:solidFill>
-                <a:latin typeface="SF Pro Display" pitchFamily="34" charset="0"/>
-                <a:ea typeface="SF Pro Display" pitchFamily="34" charset="-122"/>
-                <a:cs typeface="SF Pro Display" pitchFamily="34" charset="-120"/>
-              </a:rPr>
-              <a:t>4  Correct it</a:t>
-            </a:r>
-            <a:endParaRPr lang="en-US" sz="1050" dirty="0"/>
-          </a:p>
-          <a:p>
-            <a:pPr algn="ctr" indent="0" marL="0">
-              <a:buNone/>
-            </a:pPr>
-            <a:r>
-              <a:rPr lang="en-US" sz="800" dirty="0">
-                <a:solidFill>
-                  <a:srgbClr val="FFFFFF"/>
-                </a:solidFill>
-                <a:latin typeface="SF Pro Text" pitchFamily="34" charset="0"/>
-                <a:ea typeface="SF Pro Text" pitchFamily="34" charset="-122"/>
-                <a:cs typeface="SF Pro Text" pitchFamily="34" charset="-120"/>
-              </a:rPr>
-              <a:t>Fix charges, explain what changed</a:t>
-            </a:r>
-            <a:endParaRPr lang="en-US" sz="1050" dirty="0"/>
-          </a:p>
-        </p:txBody>
-      </p:sp>
-      <p:sp>
-        <p:nvSpPr>
-          <p:cNvPr id="29" name="Shape 26"/>
-          <p:cNvSpPr/>
-          <p:nvPr/>
-        </p:nvSpPr>
-        <p:spPr>
-          <a:xfrm>
-            <a:off x="2240280" y="3072384"/>
-            <a:ext cx="320040" cy="0"/>
-          </a:xfrm>
-          <a:prstGeom prst="line">
-            <a:avLst/>
-          </a:prstGeom>
-          <a:noFill/>
-          <a:ln w="12700">
-            <a:solidFill>
-              <a:srgbClr val="6E6E73"/>
-            </a:solidFill>
-            <a:prstDash val="solid"/>
-            <a:tailEnd type="triangle"/>
-          </a:ln>
-        </p:spPr>
-      </p:sp>
-      <p:sp>
-        <p:nvSpPr>
-          <p:cNvPr id="30" name="Shape 27"/>
-          <p:cNvSpPr/>
-          <p:nvPr/>
-        </p:nvSpPr>
-        <p:spPr>
-          <a:xfrm>
-            <a:off x="2560320" y="2788920"/>
-            <a:ext cx="2286000" cy="566928"/>
-          </a:xfrm>
-          <a:prstGeom prst="roundRect">
-            <a:avLst>
-              <a:gd name="adj" fmla="val 12903"/>
-            </a:avLst>
-          </a:prstGeom>
-          <a:solidFill>
-            <a:srgbClr val="0B7A6F"/>
-          </a:solidFill>
-          <a:ln w="12700">
-            <a:solidFill>
-              <a:srgbClr val="0B7A6F"/>
-            </a:solidFill>
-            <a:prstDash val="solid"/>
-          </a:ln>
-        </p:spPr>
-      </p:sp>
-      <p:sp>
-        <p:nvSpPr>
-          <p:cNvPr id="31" name="Text 28"/>
-          <p:cNvSpPr txBox="1"/>
-          <p:nvPr/>
-        </p:nvSpPr>
-        <p:spPr>
-          <a:xfrm>
-            <a:off x="2606040" y="2788920"/>
-            <a:ext cx="2194560" cy="566928"/>
-          </a:xfrm>
-          <a:prstGeom prst="rect">
-            <a:avLst/>
-          </a:prstGeom>
-          <a:noFill/>
-          <a:ln/>
-        </p:spPr>
-        <p:txBody>
-          <a:bodyPr wrap="square" lIns="0" tIns="0" rIns="0" bIns="0" rtlCol="0" anchor="ctr"/>
-          <a:lstStyle/>
-          <a:p>
-            <a:pPr algn="ctr" indent="0" marL="0">
-              <a:buNone/>
-            </a:pPr>
-            <a:r>
-              <a:rPr lang="en-US" sz="1050" b="1" dirty="0">
-                <a:solidFill>
-                  <a:srgbClr val="FFFFFF"/>
-                </a:solidFill>
-                <a:latin typeface="SF Pro Display" pitchFamily="34" charset="0"/>
-                <a:ea typeface="SF Pro Display" pitchFamily="34" charset="-122"/>
-                <a:cs typeface="SF Pro Display" pitchFamily="34" charset="-120"/>
-              </a:rPr>
-              <a:t>5  One light offer</a:t>
-            </a:r>
-            <a:endParaRPr lang="en-US" sz="1050" dirty="0"/>
-          </a:p>
-          <a:p>
-            <a:pPr algn="ctr" indent="0" marL="0">
-              <a:buNone/>
-            </a:pPr>
-            <a:r>
-              <a:rPr lang="en-US" sz="800" dirty="0">
-                <a:solidFill>
-                  <a:srgbClr val="FFFFFF"/>
-                </a:solidFill>
-                <a:latin typeface="SF Pro Text" pitchFamily="34" charset="0"/>
-                <a:ea typeface="SF Pro Text" pitchFamily="34" charset="-122"/>
-                <a:cs typeface="SF Pro Text" pitchFamily="34" charset="-120"/>
-              </a:rPr>
-              <a:t>Up to $20 credit or a 1-hr voucher</a:t>
-            </a:r>
-            <a:endParaRPr lang="en-US" sz="1050" dirty="0"/>
-          </a:p>
-        </p:txBody>
-      </p:sp>
-      <p:sp>
-        <p:nvSpPr>
-          <p:cNvPr id="32" name="Shape 29"/>
-          <p:cNvSpPr/>
-          <p:nvPr/>
-        </p:nvSpPr>
-        <p:spPr>
-          <a:xfrm>
-            <a:off x="4846320" y="3072384"/>
-            <a:ext cx="1234440" cy="0"/>
-          </a:xfrm>
-          <a:prstGeom prst="line">
-            <a:avLst/>
-          </a:prstGeom>
-          <a:noFill/>
-          <a:ln w="12700">
-            <a:solidFill>
-              <a:srgbClr val="6E6E73"/>
-            </a:solidFill>
-            <a:prstDash val="solid"/>
-            <a:tailEnd type="triangle"/>
-          </a:ln>
-        </p:spPr>
-      </p:sp>
-      <p:sp>
-        <p:nvSpPr>
-          <p:cNvPr id="33" name="Text 30"/>
-          <p:cNvSpPr txBox="1"/>
-          <p:nvPr/>
-        </p:nvSpPr>
-        <p:spPr>
-          <a:xfrm>
-            <a:off x="4846320" y="2688336"/>
-            <a:ext cx="1234440" cy="347472"/>
-          </a:xfrm>
-          <a:prstGeom prst="rect">
-            <a:avLst/>
-          </a:prstGeom>
-          <a:noFill/>
-          <a:ln/>
-        </p:spPr>
-        <p:txBody>
-          <a:bodyPr wrap="square" lIns="0" tIns="0" rIns="0" bIns="0" rtlCol="0" anchor="b"/>
-          <a:lstStyle/>
-          <a:p>
-            <a:pPr algn="ctr" indent="0" marL="0">
-              <a:buNone/>
-            </a:pPr>
-            <a:r>
-              <a:rPr lang="en-US" sz="800" b="1" dirty="0">
-                <a:solidFill>
-                  <a:srgbClr val="6E6E73"/>
-                </a:solidFill>
-                <a:latin typeface="SF Pro Text" pitchFamily="34" charset="0"/>
-                <a:ea typeface="SF Pro Text" pitchFamily="34" charset="-122"/>
-                <a:cs typeface="SF Pro Text" pitchFamily="34" charset="-120"/>
-              </a:rPr>
-              <a:t>Declined or</a:t>
-            </a:r>
-            <a:endParaRPr lang="en-US" sz="800" dirty="0"/>
-          </a:p>
-          <a:p>
-            <a:pPr algn="ctr" indent="0" marL="0">
-              <a:buNone/>
-            </a:pPr>
-            <a:r>
-              <a:rPr lang="en-US" sz="800" b="1" dirty="0">
-                <a:solidFill>
-                  <a:srgbClr val="6E6E73"/>
-                </a:solidFill>
-                <a:latin typeface="SF Pro Text" pitchFamily="34" charset="0"/>
-                <a:ea typeface="SF Pro Text" pitchFamily="34" charset="-122"/>
-                <a:cs typeface="SF Pro Text" pitchFamily="34" charset="-120"/>
-              </a:rPr>
-              <a:t>not retainable</a:t>
-            </a:r>
-            <a:endParaRPr lang="en-US" sz="800" dirty="0"/>
-          </a:p>
-        </p:txBody>
-      </p:sp>
-      <p:sp>
-        <p:nvSpPr>
-          <p:cNvPr id="34" name="Shape 31"/>
-          <p:cNvSpPr/>
-          <p:nvPr/>
-        </p:nvSpPr>
-        <p:spPr>
-          <a:xfrm>
-            <a:off x="6080760" y="2788920"/>
-            <a:ext cx="2651760" cy="566928"/>
-          </a:xfrm>
-          <a:prstGeom prst="roundRect">
-            <a:avLst>
-              <a:gd name="adj" fmla="val 12903"/>
-            </a:avLst>
-          </a:prstGeom>
-          <a:solidFill>
-            <a:srgbClr val="1D1D1F"/>
-          </a:solidFill>
-          <a:ln w="12700">
-            <a:solidFill>
-              <a:srgbClr val="1D1D1F"/>
-            </a:solidFill>
-            <a:prstDash val="solid"/>
-          </a:ln>
-        </p:spPr>
-      </p:sp>
-      <p:sp>
-        <p:nvSpPr>
-          <p:cNvPr id="35" name="Text 32"/>
-          <p:cNvSpPr txBox="1"/>
-          <p:nvPr/>
-        </p:nvSpPr>
-        <p:spPr>
-          <a:xfrm>
-            <a:off x="6126480" y="2788920"/>
-            <a:ext cx="2560320" cy="566928"/>
-          </a:xfrm>
-          <a:prstGeom prst="rect">
-            <a:avLst/>
-          </a:prstGeom>
-          <a:noFill/>
-          <a:ln/>
-        </p:spPr>
-        <p:txBody>
-          <a:bodyPr wrap="square" lIns="0" tIns="0" rIns="0" bIns="0" rtlCol="0" anchor="ctr"/>
-          <a:lstStyle/>
-          <a:p>
-            <a:pPr algn="ctr" indent="0" marL="0">
-              <a:buNone/>
-            </a:pPr>
-            <a:r>
-              <a:rPr lang="en-US" sz="1050" b="1" dirty="0">
-                <a:solidFill>
-                  <a:srgbClr val="FFFFFF"/>
-                </a:solidFill>
-                <a:latin typeface="SF Pro Display" pitchFamily="34" charset="0"/>
-                <a:ea typeface="SF Pro Display" pitchFamily="34" charset="-122"/>
-                <a:cs typeface="SF Pro Display" pitchFamily="34" charset="-120"/>
-              </a:rPr>
-              <a:t>6  Waive the ETF, cancel FC</a:t>
-            </a:r>
-            <a:endParaRPr lang="en-US" sz="1050" dirty="0"/>
-          </a:p>
-          <a:p>
-            <a:pPr algn="ctr" indent="0" marL="0">
-              <a:buNone/>
-            </a:pPr>
-            <a:r>
-              <a:rPr lang="en-US" sz="800" dirty="0">
-                <a:solidFill>
-                  <a:srgbClr val="FFFFFF"/>
-                </a:solidFill>
-                <a:latin typeface="SF Pro Text" pitchFamily="34" charset="0"/>
-                <a:ea typeface="SF Pro Text" pitchFamily="34" charset="-122"/>
-                <a:cs typeface="SF Pro Text" pitchFamily="34" charset="-120"/>
-              </a:rPr>
-              <a:t>No ETF: the error was ours</a:t>
-            </a:r>
-            <a:endParaRPr lang="en-US" sz="1050" dirty="0"/>
-          </a:p>
-        </p:txBody>
-      </p:sp>
-      <p:sp>
-        <p:nvSpPr>
-          <p:cNvPr id="36" name="Shape 33"/>
-          <p:cNvSpPr/>
-          <p:nvPr/>
-        </p:nvSpPr>
-        <p:spPr>
-          <a:xfrm>
-            <a:off x="411480" y="3566160"/>
-            <a:ext cx="8321040" cy="384048"/>
-          </a:xfrm>
-          <a:prstGeom prst="roundRect">
-            <a:avLst>
-              <a:gd name="adj" fmla="val 19048"/>
-            </a:avLst>
-          </a:prstGeom>
-          <a:solidFill>
-            <a:srgbClr val="FFF3D6"/>
-          </a:solidFill>
-          <a:ln w="9525">
-            <a:solidFill>
-              <a:srgbClr val="FFF3D6"/>
-            </a:solidFill>
-            <a:prstDash val="solid"/>
-          </a:ln>
-        </p:spPr>
-      </p:sp>
-      <p:pic>
-        <p:nvPicPr>
-          <p:cNvPr id="37" name="Image 0" descr="preencoded.png">    </p:cNvPr>
-          <p:cNvPicPr>
-            <a:picLocks noChangeAspect="1"/>
-          </p:cNvPicPr>
-          <p:nvPr/>
-        </p:nvPicPr>
-        <p:blipFill>
-          <a:blip r:embed="rId1"/>
-          <a:stretch>
-            <a:fillRect/>
-          </a:stretch>
-        </p:blipFill>
-        <p:spPr>
-          <a:xfrm>
-            <a:off x="566928" y="3675888"/>
-            <a:ext cx="164592" cy="164592"/>
-          </a:xfrm>
-          <a:prstGeom prst="rect">
-            <a:avLst/>
-          </a:prstGeom>
-        </p:spPr>
-      </p:pic>
-      <p:sp>
-        <p:nvSpPr>
-          <p:cNvPr id="38" name="Text 34"/>
-          <p:cNvSpPr txBox="1"/>
-          <p:nvPr/>
-        </p:nvSpPr>
-        <p:spPr>
-          <a:xfrm>
-            <a:off x="822960" y="3666744"/>
-            <a:ext cx="7772400" cy="201168"/>
-          </a:xfrm>
-          <a:prstGeom prst="rect">
-            <a:avLst/>
-          </a:prstGeom>
-          <a:noFill/>
-          <a:ln/>
-        </p:spPr>
-        <p:txBody>
-          <a:bodyPr wrap="square" lIns="0" tIns="0" rIns="0" bIns="0" rtlCol="0" anchor="t"/>
-          <a:lstStyle/>
-          <a:p>
-            <a:pPr indent="0" marL="0">
-              <a:buNone/>
-            </a:pPr>
-            <a:r>
-              <a:rPr lang="en-US" sz="1000" b="1" dirty="0">
-                <a:solidFill>
-                  <a:srgbClr val="9A6410"/>
-                </a:solidFill>
-                <a:latin typeface="SF Pro Text" pitchFamily="34" charset="0"/>
-                <a:ea typeface="SF Pro Text" pitchFamily="34" charset="-122"/>
-                <a:cs typeface="SF Pro Text" pitchFamily="34" charset="-120"/>
-              </a:rPr>
-              <a:t>Waiting on a reply?  </a:t>
-            </a:r>
-            <a:pPr indent="0" marL="0">
-              <a:buNone/>
-            </a:pPr>
-            <a:r>
-              <a:rPr lang="en-US" sz="1000" dirty="0">
-                <a:solidFill>
-                  <a:srgbClr val="1D1D1F"/>
-                </a:solidFill>
-                <a:latin typeface="SF Pro Text" pitchFamily="34" charset="0"/>
-                <a:ea typeface="SF Pro Text" pitchFamily="34" charset="-122"/>
-                <a:cs typeface="SF Pro Text" pitchFamily="34" charset="-120"/>
-              </a:rPr>
-              <a:t>set a TR before the next MF.</a:t>
-            </a:r>
-            <a:endParaRPr lang="en-US" sz="1000" dirty="0"/>
-          </a:p>
-        </p:txBody>
-      </p:sp>
-      <p:sp>
-        <p:nvSpPr>
-          <p:cNvPr id="39" name="Shape 35"/>
-          <p:cNvSpPr/>
-          <p:nvPr/>
-        </p:nvSpPr>
-        <p:spPr>
-          <a:xfrm>
-            <a:off x="411480" y="4114800"/>
-            <a:ext cx="5669280" cy="292608"/>
-          </a:xfrm>
-          <a:prstGeom prst="roundRect">
-            <a:avLst>
-              <a:gd name="adj" fmla="val 25000"/>
-            </a:avLst>
-          </a:prstGeom>
-          <a:solidFill>
-            <a:srgbClr val="FFF3D6"/>
-          </a:solidFill>
-          <a:ln w="9525">
-            <a:solidFill>
-              <a:srgbClr val="9A6410"/>
-            </a:solidFill>
-            <a:prstDash val="solid"/>
-          </a:ln>
-        </p:spPr>
-      </p:sp>
-      <p:pic>
-        <p:nvPicPr>
-          <p:cNvPr id="40" name="Image 1" descr="preencoded.png">    </p:cNvPr>
-          <p:cNvPicPr>
-            <a:picLocks noChangeAspect="1"/>
-          </p:cNvPicPr>
-          <p:nvPr/>
-        </p:nvPicPr>
-        <p:blipFill>
-          <a:blip r:embed="rId2"/>
-          <a:stretch>
-            <a:fillRect/>
-          </a:stretch>
-        </p:blipFill>
-        <p:spPr>
-          <a:xfrm>
-            <a:off x="521208" y="4187952"/>
-            <a:ext cx="146304" cy="146304"/>
-          </a:xfrm>
-          <a:prstGeom prst="rect">
-            <a:avLst/>
-          </a:prstGeom>
-        </p:spPr>
-      </p:pic>
-      <p:sp>
-        <p:nvSpPr>
-          <p:cNvPr id="41" name="Text 36"/>
-          <p:cNvSpPr txBox="1"/>
-          <p:nvPr/>
-        </p:nvSpPr>
-        <p:spPr>
-          <a:xfrm>
-            <a:off x="731520" y="4114800"/>
-            <a:ext cx="5303520" cy="292608"/>
-          </a:xfrm>
-          <a:prstGeom prst="rect">
-            <a:avLst/>
-          </a:prstGeom>
-          <a:noFill/>
-          <a:ln/>
-        </p:spPr>
-        <p:txBody>
-          <a:bodyPr wrap="square" lIns="0" tIns="0" rIns="0" bIns="0" rtlCol="0" anchor="ctr"/>
-          <a:lstStyle/>
-          <a:p>
-            <a:pPr indent="0" marL="0">
-              <a:buNone/>
-            </a:pPr>
-            <a:r>
-              <a:rPr lang="en-US" sz="950" b="1" dirty="0">
-                <a:solidFill>
-                  <a:srgbClr val="9A6410"/>
-                </a:solidFill>
-                <a:latin typeface="SF Pro Display" pitchFamily="34" charset="0"/>
-                <a:ea typeface="SF Pro Display" pitchFamily="34" charset="-122"/>
-                <a:cs typeface="SF Pro Display" pitchFamily="34" charset="-120"/>
-              </a:rPr>
-              <a:t>Recommended Macro:  </a:t>
-            </a:r>
-            <a:pPr indent="0" marL="0">
-              <a:buNone/>
-            </a:pPr>
-            <a:r>
-              <a:rPr lang="en-US" sz="950" b="1" dirty="0">
-                <a:solidFill>
-                  <a:srgbClr val="1D1D1F"/>
-                </a:solidFill>
-                <a:latin typeface="SF Pro Display" pitchFamily="34" charset="0"/>
-                <a:ea typeface="SF Pro Display" pitchFamily="34" charset="-122"/>
-                <a:cs typeface="SF Pro Display" pitchFamily="34" charset="-120"/>
-              </a:rPr>
-              <a:t>Misinformation: address incorrect claims about charges</a:t>
-            </a:r>
-            <a:endParaRPr lang="en-US" sz="950" dirty="0"/>
-          </a:p>
-        </p:txBody>
-      </p:sp>
-      <p:sp>
-        <p:nvSpPr>
-          <p:cNvPr id="42" name="pop1_2Panel"/>
+          <p:cNvPr id="39" name="pop1_2Panel"/>
           <p:cNvSpPr/>
           <p:nvPr/>
         </p:nvSpPr>
@@ -27034,7 +26144,7 @@
       </p:sp>
       <p:sp>
         <p:nvSpPr>
-          <p:cNvPr id="43" name="pop1_2Title"/>
+          <p:cNvPr id="40" name="pop1_2Title"/>
           <p:cNvSpPr txBox="1"/>
           <p:nvPr/>
         </p:nvSpPr>
@@ -27073,7 +26183,7 @@
       </p:sp>
       <p:sp>
         <p:nvSpPr>
-          <p:cNvPr id="44" name="pop1_2Num1"/>
+          <p:cNvPr id="41" name="pop1_2Num1"/>
           <p:cNvSpPr/>
           <p:nvPr/>
         </p:nvSpPr>
@@ -27118,7 +26228,7 @@
       </p:sp>
       <p:sp>
         <p:nvSpPr>
-          <p:cNvPr id="45" name="pop1_2Row1"/>
+          <p:cNvPr id="42" name="pop1_2Row1"/>
           <p:cNvSpPr txBox="1"/>
           <p:nvPr/>
         </p:nvSpPr>
@@ -27157,7 +26267,7 @@
       </p:sp>
       <p:sp>
         <p:nvSpPr>
-          <p:cNvPr id="46" name="pop1_2Num2"/>
+          <p:cNvPr id="43" name="pop1_2Num2"/>
           <p:cNvSpPr/>
           <p:nvPr/>
         </p:nvSpPr>
@@ -27202,7 +26312,7 @@
       </p:sp>
       <p:sp>
         <p:nvSpPr>
-          <p:cNvPr id="47" name="pop1_2Row2"/>
+          <p:cNvPr id="44" name="pop1_2Row2"/>
           <p:cNvSpPr txBox="1"/>
           <p:nvPr/>
         </p:nvSpPr>
@@ -27241,7 +26351,7 @@
       </p:sp>
       <p:sp>
         <p:nvSpPr>
-          <p:cNvPr id="48" name="pop1_2Num3"/>
+          <p:cNvPr id="45" name="pop1_2Num3"/>
           <p:cNvSpPr/>
           <p:nvPr/>
         </p:nvSpPr>
@@ -27286,7 +26396,7 @@
       </p:sp>
       <p:sp>
         <p:nvSpPr>
-          <p:cNvPr id="49" name="pop1_2Row3"/>
+          <p:cNvPr id="46" name="pop1_2Row3"/>
           <p:cNvSpPr txBox="1"/>
           <p:nvPr/>
         </p:nvSpPr>
@@ -27317,7 +26427,7 @@
                 <a:ea typeface="SF Pro Text" pitchFamily="34" charset="-122"/>
                 <a:cs typeface="SF Pro Text" pitchFamily="34" charset="-120"/>
               </a:rPr>
-              <a:t>Don't resolve yet. Change the queue to Waiting on CSQ</a:t>
+              <a:t>Don't resolve yet. Change the status to Waiting on CSQ</a:t>
             </a:r>
             <a:endParaRPr lang="en-US" sz="1000" dirty="0"/>
           </a:p>
@@ -27325,8 +26435,8 @@
       </p:sp>
       <p:sp>
         <p:nvSpPr>
-          <p:cNvPr id="50" name="pop1_2LinkBg">
-            <a:hlinkClick r:id="rId5" tooltip="Open the Sales call review request sheet"/>
+          <p:cNvPr id="47" name="pop1_2LinkBg">
+            <a:hlinkClick r:id="rId4" tooltip="Open the Sales call review request sheet"/>
           </p:cNvPr>
           <p:cNvSpPr/>
           <p:nvPr/>
@@ -27354,8 +26464,8 @@
       </p:sp>
       <p:pic>
         <p:nvPicPr>
-          <p:cNvPr id="51" name="pop1_2LinkIcon" descr="preencoded.png">
-            <a:hlinkClick r:id="rId5" tooltip="Open the Sales call review request sheet"/>
+          <p:cNvPr id="48" name="pop1_2LinkIcon" descr="preencoded.png">
+            <a:hlinkClick r:id="rId4" tooltip="Open the Sales call review request sheet"/>
           </p:cNvPr>
           <p:cNvPicPr>
             <a:picLocks noChangeAspect="1"/>
@@ -27363,7 +26473,7 @@
           <p:nvPr/>
         </p:nvPicPr>
         <p:blipFill>
-          <a:blip r:embed="rId4"/>
+          <a:blip r:embed="rId3"/>
           <a:stretch>
             <a:fillRect/>
           </a:stretch>
@@ -27380,7 +26490,7 @@
       </p:pic>
       <p:sp>
         <p:nvSpPr>
-          <p:cNvPr id="52" name="pop1_2Foot"/>
+          <p:cNvPr id="49" name="pop1_2Foot"/>
           <p:cNvSpPr txBox="1"/>
           <p:nvPr/>
         </p:nvSpPr>
@@ -27459,7 +26569,7 @@
             <a:pPr algn="r"/>
             <a:fld id="{F7021451-1387-4CA6-816F-3879F97B5CBC}" type="slidenum">
               <a:rPr b="0" lang="en-US"/>
-              <a:t>7</a:t>
+              <a:t>6</a:t>
             </a:fld>
             <a:endParaRPr lang="en-US"/>
           </a:p>
@@ -27504,7 +26614,7 @@
                                           </p:stCondLst>
                                         </p:cTn>
                                         <p:tgtEl>
-                                          <p:spTgt spid="42"/>
+                                          <p:spTgt spid="39"/>
                                         </p:tgtEl>
                                         <p:attrNameLst>
                                           <p:attrName>style.visibility</p:attrName>
@@ -27518,7 +26628,7 @@
                                       <p:cBhvr>
                                         <p:cTn id="7" dur="600"/>
                                         <p:tgtEl>
-                                          <p:spTgt spid="42"/>
+                                          <p:spTgt spid="39"/>
                                         </p:tgtEl>
                                       </p:cBhvr>
                                     </p:animEffect>
@@ -27539,7 +26649,7 @@
                                           </p:stCondLst>
                                         </p:cTn>
                                         <p:tgtEl>
-                                          <p:spTgt spid="43"/>
+                                          <p:spTgt spid="40"/>
                                         </p:tgtEl>
                                         <p:attrNameLst>
                                           <p:attrName>style.visibility</p:attrName>
@@ -27553,7 +26663,7 @@
                                       <p:cBhvr>
                                         <p:cTn id="10" dur="600"/>
                                         <p:tgtEl>
-                                          <p:spTgt spid="43"/>
+                                          <p:spTgt spid="40"/>
                                         </p:tgtEl>
                                       </p:cBhvr>
                                     </p:animEffect>
@@ -27574,7 +26684,7 @@
                                           </p:stCondLst>
                                         </p:cTn>
                                         <p:tgtEl>
-                                          <p:spTgt spid="44"/>
+                                          <p:spTgt spid="41"/>
                                         </p:tgtEl>
                                         <p:attrNameLst>
                                           <p:attrName>style.visibility</p:attrName>
@@ -27588,7 +26698,7 @@
                                       <p:cBhvr>
                                         <p:cTn id="13" dur="600"/>
                                         <p:tgtEl>
-                                          <p:spTgt spid="44"/>
+                                          <p:spTgt spid="41"/>
                                         </p:tgtEl>
                                       </p:cBhvr>
                                     </p:animEffect>
@@ -27609,7 +26719,7 @@
                                           </p:stCondLst>
                                         </p:cTn>
                                         <p:tgtEl>
-                                          <p:spTgt spid="45"/>
+                                          <p:spTgt spid="42"/>
                                         </p:tgtEl>
                                         <p:attrNameLst>
                                           <p:attrName>style.visibility</p:attrName>
@@ -27623,7 +26733,7 @@
                                       <p:cBhvr>
                                         <p:cTn id="16" dur="600"/>
                                         <p:tgtEl>
-                                          <p:spTgt spid="45"/>
+                                          <p:spTgt spid="42"/>
                                         </p:tgtEl>
                                       </p:cBhvr>
                                     </p:animEffect>
@@ -27644,7 +26754,7 @@
                                           </p:stCondLst>
                                         </p:cTn>
                                         <p:tgtEl>
-                                          <p:spTgt spid="46"/>
+                                          <p:spTgt spid="43"/>
                                         </p:tgtEl>
                                         <p:attrNameLst>
                                           <p:attrName>style.visibility</p:attrName>
@@ -27658,7 +26768,7 @@
                                       <p:cBhvr>
                                         <p:cTn id="19" dur="600"/>
                                         <p:tgtEl>
-                                          <p:spTgt spid="46"/>
+                                          <p:spTgt spid="43"/>
                                         </p:tgtEl>
                                       </p:cBhvr>
                                     </p:animEffect>
@@ -27679,7 +26789,7 @@
                                           </p:stCondLst>
                                         </p:cTn>
                                         <p:tgtEl>
-                                          <p:spTgt spid="47"/>
+                                          <p:spTgt spid="44"/>
                                         </p:tgtEl>
                                         <p:attrNameLst>
                                           <p:attrName>style.visibility</p:attrName>
@@ -27693,7 +26803,7 @@
                                       <p:cBhvr>
                                         <p:cTn id="22" dur="600"/>
                                         <p:tgtEl>
-                                          <p:spTgt spid="47"/>
+                                          <p:spTgt spid="44"/>
                                         </p:tgtEl>
                                       </p:cBhvr>
                                     </p:animEffect>
@@ -27714,7 +26824,7 @@
                                           </p:stCondLst>
                                         </p:cTn>
                                         <p:tgtEl>
-                                          <p:spTgt spid="48"/>
+                                          <p:spTgt spid="45"/>
                                         </p:tgtEl>
                                         <p:attrNameLst>
                                           <p:attrName>style.visibility</p:attrName>
@@ -27728,7 +26838,7 @@
                                       <p:cBhvr>
                                         <p:cTn id="25" dur="600"/>
                                         <p:tgtEl>
-                                          <p:spTgt spid="48"/>
+                                          <p:spTgt spid="45"/>
                                         </p:tgtEl>
                                       </p:cBhvr>
                                     </p:animEffect>
@@ -27749,7 +26859,7 @@
                                           </p:stCondLst>
                                         </p:cTn>
                                         <p:tgtEl>
-                                          <p:spTgt spid="49"/>
+                                          <p:spTgt spid="46"/>
                                         </p:tgtEl>
                                         <p:attrNameLst>
                                           <p:attrName>style.visibility</p:attrName>
@@ -27763,7 +26873,7 @@
                                       <p:cBhvr>
                                         <p:cTn id="28" dur="600"/>
                                         <p:tgtEl>
-                                          <p:spTgt spid="49"/>
+                                          <p:spTgt spid="46"/>
                                         </p:tgtEl>
                                       </p:cBhvr>
                                     </p:animEffect>
@@ -27784,7 +26894,7 @@
                                           </p:stCondLst>
                                         </p:cTn>
                                         <p:tgtEl>
-                                          <p:spTgt spid="50"/>
+                                          <p:spTgt spid="47"/>
                                         </p:tgtEl>
                                         <p:attrNameLst>
                                           <p:attrName>style.visibility</p:attrName>
@@ -27798,7 +26908,7 @@
                                       <p:cBhvr>
                                         <p:cTn id="31" dur="600"/>
                                         <p:tgtEl>
-                                          <p:spTgt spid="50"/>
+                                          <p:spTgt spid="47"/>
                                         </p:tgtEl>
                                       </p:cBhvr>
                                     </p:animEffect>
@@ -27819,7 +26929,7 @@
                                           </p:stCondLst>
                                         </p:cTn>
                                         <p:tgtEl>
-                                          <p:spTgt spid="51"/>
+                                          <p:spTgt spid="48"/>
                                         </p:tgtEl>
                                         <p:attrNameLst>
                                           <p:attrName>style.visibility</p:attrName>
@@ -27833,7 +26943,7 @@
                                       <p:cBhvr>
                                         <p:cTn id="34" dur="600"/>
                                         <p:tgtEl>
-                                          <p:spTgt spid="51"/>
+                                          <p:spTgt spid="48"/>
                                         </p:tgtEl>
                                       </p:cBhvr>
                                     </p:animEffect>
@@ -27854,7 +26964,7 @@
                                           </p:stCondLst>
                                         </p:cTn>
                                         <p:tgtEl>
-                                          <p:spTgt spid="52"/>
+                                          <p:spTgt spid="49"/>
                                         </p:tgtEl>
                                         <p:attrNameLst>
                                           <p:attrName>style.visibility</p:attrName>
@@ -27868,7 +26978,7 @@
                                       <p:cBhvr>
                                         <p:cTn id="37" dur="600"/>
                                         <p:tgtEl>
-                                          <p:spTgt spid="52"/>
+                                          <p:spTgt spid="49"/>
                                         </p:tgtEl>
                                       </p:cBhvr>
                                     </p:animEffect>
@@ -27907,7 +27017,7 @@
                                           </p:stCondLst>
                                         </p:cTn>
                                         <p:tgtEl>
-                                          <p:spTgt spid="42"/>
+                                          <p:spTgt spid="39"/>
                                         </p:tgtEl>
                                         <p:attrNameLst>
                                           <p:attrName>style.visibility</p:attrName>
@@ -27934,7 +27044,7 @@
                                           </p:stCondLst>
                                         </p:cTn>
                                         <p:tgtEl>
-                                          <p:spTgt spid="43"/>
+                                          <p:spTgt spid="40"/>
                                         </p:tgtEl>
                                         <p:attrNameLst>
                                           <p:attrName>style.visibility</p:attrName>
@@ -27961,7 +27071,7 @@
                                           </p:stCondLst>
                                         </p:cTn>
                                         <p:tgtEl>
-                                          <p:spTgt spid="44"/>
+                                          <p:spTgt spid="41"/>
                                         </p:tgtEl>
                                         <p:attrNameLst>
                                           <p:attrName>style.visibility</p:attrName>
@@ -27988,7 +27098,7 @@
                                           </p:stCondLst>
                                         </p:cTn>
                                         <p:tgtEl>
-                                          <p:spTgt spid="45"/>
+                                          <p:spTgt spid="42"/>
                                         </p:tgtEl>
                                         <p:attrNameLst>
                                           <p:attrName>style.visibility</p:attrName>
@@ -28015,7 +27125,7 @@
                                           </p:stCondLst>
                                         </p:cTn>
                                         <p:tgtEl>
-                                          <p:spTgt spid="46"/>
+                                          <p:spTgt spid="43"/>
                                         </p:tgtEl>
                                         <p:attrNameLst>
                                           <p:attrName>style.visibility</p:attrName>
@@ -28042,7 +27152,7 @@
                                           </p:stCondLst>
                                         </p:cTn>
                                         <p:tgtEl>
-                                          <p:spTgt spid="47"/>
+                                          <p:spTgt spid="44"/>
                                         </p:tgtEl>
                                         <p:attrNameLst>
                                           <p:attrName>style.visibility</p:attrName>
@@ -28069,7 +27179,7 @@
                                           </p:stCondLst>
                                         </p:cTn>
                                         <p:tgtEl>
-                                          <p:spTgt spid="48"/>
+                                          <p:spTgt spid="45"/>
                                         </p:tgtEl>
                                         <p:attrNameLst>
                                           <p:attrName>style.visibility</p:attrName>
@@ -28096,7 +27206,7 @@
                                           </p:stCondLst>
                                         </p:cTn>
                                         <p:tgtEl>
-                                          <p:spTgt spid="49"/>
+                                          <p:spTgt spid="46"/>
                                         </p:tgtEl>
                                         <p:attrNameLst>
                                           <p:attrName>style.visibility</p:attrName>
@@ -28123,7 +27233,7 @@
                                           </p:stCondLst>
                                         </p:cTn>
                                         <p:tgtEl>
-                                          <p:spTgt spid="50"/>
+                                          <p:spTgt spid="47"/>
                                         </p:tgtEl>
                                         <p:attrNameLst>
                                           <p:attrName>style.visibility</p:attrName>
@@ -28150,7 +27260,7 @@
                                           </p:stCondLst>
                                         </p:cTn>
                                         <p:tgtEl>
-                                          <p:spTgt spid="51"/>
+                                          <p:spTgt spid="48"/>
                                         </p:tgtEl>
                                         <p:attrNameLst>
                                           <p:attrName>style.visibility</p:attrName>
@@ -28177,7 +27287,7 @@
                                           </p:stCondLst>
                                         </p:cTn>
                                         <p:tgtEl>
-                                          <p:spTgt spid="52"/>
+                                          <p:spTgt spid="49"/>
                                         </p:tgtEl>
                                         <p:attrNameLst>
                                           <p:attrName>style.visibility</p:attrName>
@@ -28218,28 +27328,918 @@
       </p:par>
     </p:tnLst>
     <p:bldLst>
+      <p:bldP spid="39" grpId="0" animBg="1"/>
+      <p:bldP spid="40" grpId="0" animBg="1"/>
+      <p:bldP spid="41" grpId="0" animBg="1"/>
       <p:bldP spid="42" grpId="0" animBg="1"/>
       <p:bldP spid="43" grpId="0" animBg="1"/>
       <p:bldP spid="44" grpId="0" animBg="1"/>
       <p:bldP spid="45" grpId="0" animBg="1"/>
       <p:bldP spid="46" grpId="0" animBg="1"/>
       <p:bldP spid="47" grpId="0" animBg="1"/>
-      <p:bldP spid="48" grpId="0" animBg="1"/>
       <p:bldP spid="49" grpId="0" animBg="1"/>
-      <p:bldP spid="50" grpId="0" animBg="1"/>
-      <p:bldP spid="52" grpId="0" animBg="1"/>
+      <p:bldP spid="39" grpId="1" animBg="1"/>
+      <p:bldP spid="40" grpId="1" animBg="1"/>
+      <p:bldP spid="41" grpId="1" animBg="1"/>
       <p:bldP spid="42" grpId="1" animBg="1"/>
       <p:bldP spid="43" grpId="1" animBg="1"/>
       <p:bldP spid="44" grpId="1" animBg="1"/>
       <p:bldP spid="45" grpId="1" animBg="1"/>
       <p:bldP spid="46" grpId="1" animBg="1"/>
       <p:bldP spid="47" grpId="1" animBg="1"/>
-      <p:bldP spid="48" grpId="1" animBg="1"/>
       <p:bldP spid="49" grpId="1" animBg="1"/>
-      <p:bldP spid="50" grpId="1" animBg="1"/>
-      <p:bldP spid="52" grpId="1" animBg="1"/>
     </p:bldLst>
   </p:timing>
+</p:sld>
+</file>
+
+<file path=ppt/slides/slide7.xml><?xml version="1.0" encoding="utf-8"?>
+<p:sld xmlns:a="http://schemas.openxmlformats.org/drawingml/2006/main" xmlns:r="http://schemas.openxmlformats.org/officeDocument/2006/relationships" xmlns:p="http://schemas.openxmlformats.org/presentationml/2006/main">
+  <p:cSld name="Slide 7">
+    <p:spTree>
+      <p:nvGrpSpPr>
+        <p:cNvPr id="1" name=""/>
+        <p:cNvGrpSpPr/>
+        <p:nvPr/>
+      </p:nvGrpSpPr>
+      <p:grpSpPr>
+        <a:xfrm>
+          <a:off x="0" y="0"/>
+          <a:ext cx="0" cy="0"/>
+          <a:chOff x="0" y="0"/>
+          <a:chExt cx="0" cy="0"/>
+        </a:xfrm>
+      </p:grpSpPr>
+      <p:sp>
+        <p:nvSpPr>
+          <p:cNvPr id="2" name="Text 0"/>
+          <p:cNvSpPr txBox="1"/>
+          <p:nvPr/>
+        </p:nvSpPr>
+        <p:spPr>
+          <a:xfrm>
+            <a:off x="438912" y="274320"/>
+            <a:ext cx="8229600" cy="182880"/>
+          </a:xfrm>
+          <a:prstGeom prst="rect">
+            <a:avLst/>
+          </a:prstGeom>
+          <a:noFill/>
+          <a:ln/>
+        </p:spPr>
+        <p:txBody>
+          <a:bodyPr wrap="square" lIns="0" tIns="0" rIns="0" bIns="0" rtlCol="0" anchor="t"/>
+          <a:lstStyle/>
+          <a:p>
+            <a:pPr indent="0" marL="0">
+              <a:buNone/>
+            </a:pPr>
+            <a:r>
+              <a:rPr lang="en-US" sz="800" b="1" spc="50" kern="0" dirty="0">
+                <a:solidFill>
+                  <a:srgbClr val="0B7A6F"/>
+                </a:solidFill>
+                <a:latin typeface="SF Pro Display" pitchFamily="34" charset="0"/>
+                <a:ea typeface="SF Pro Display" pitchFamily="34" charset="-122"/>
+                <a:cs typeface="SF Pro Display" pitchFamily="34" charset="-120"/>
+              </a:rPr>
+              <a:t>INCORRECT INFORMATION</a:t>
+            </a:r>
+            <a:endParaRPr lang="en-US" sz="800" dirty="0"/>
+          </a:p>
+        </p:txBody>
+      </p:sp>
+      <p:sp>
+        <p:nvSpPr>
+          <p:cNvPr id="3" name="Text 1"/>
+          <p:cNvSpPr txBox="1"/>
+          <p:nvPr/>
+        </p:nvSpPr>
+        <p:spPr>
+          <a:xfrm>
+            <a:off x="438912" y="457200"/>
+            <a:ext cx="8229600" cy="457200"/>
+          </a:xfrm>
+          <a:prstGeom prst="rect">
+            <a:avLst/>
+          </a:prstGeom>
+          <a:noFill/>
+          <a:ln/>
+        </p:spPr>
+        <p:txBody>
+          <a:bodyPr wrap="square" lIns="0" tIns="0" rIns="0" bIns="0" rtlCol="0" anchor="t"/>
+          <a:lstStyle/>
+          <a:p>
+            <a:pPr indent="0" marL="0">
+              <a:buNone/>
+            </a:pPr>
+            <a:r>
+              <a:rPr lang="en-US" sz="2400" b="1" dirty="0">
+                <a:solidFill>
+                  <a:srgbClr val="1D1D1F"/>
+                </a:solidFill>
+                <a:latin typeface="SF Pro Display" pitchFamily="34" charset="0"/>
+                <a:ea typeface="SF Pro Display" pitchFamily="34" charset="-122"/>
+                <a:cs typeface="SF Pro Display" pitchFamily="34" charset="-120"/>
+              </a:rPr>
+              <a:t>Quoted a rate, left out the fees</a:t>
+            </a:r>
+            <a:endParaRPr lang="en-US" sz="2400" dirty="0"/>
+          </a:p>
+        </p:txBody>
+      </p:sp>
+      <p:sp>
+        <p:nvSpPr>
+          <p:cNvPr id="4" name="Text 2"/>
+          <p:cNvSpPr txBox="1"/>
+          <p:nvPr/>
+        </p:nvSpPr>
+        <p:spPr>
+          <a:xfrm>
+            <a:off x="438912" y="960120"/>
+            <a:ext cx="8229600" cy="274320"/>
+          </a:xfrm>
+          <a:prstGeom prst="rect">
+            <a:avLst/>
+          </a:prstGeom>
+          <a:noFill/>
+          <a:ln/>
+        </p:spPr>
+        <p:txBody>
+          <a:bodyPr wrap="square" lIns="0" tIns="0" rIns="0" bIns="0" rtlCol="0" anchor="t"/>
+          <a:lstStyle/>
+          <a:p>
+            <a:pPr indent="0" marL="0">
+              <a:buNone/>
+            </a:pPr>
+            <a:r>
+              <a:rPr lang="en-US" sz="1200" dirty="0">
+                <a:solidFill>
+                  <a:srgbClr val="6E6E73"/>
+                </a:solidFill>
+                <a:latin typeface="SF Pro Text" pitchFamily="34" charset="0"/>
+                <a:ea typeface="SF Pro Text" pitchFamily="34" charset="-122"/>
+                <a:cs typeface="SF Pro Text" pitchFamily="34" charset="-120"/>
+              </a:rPr>
+              <a:t>Never just "a gap in what was mentioned".</a:t>
+            </a:r>
+            <a:endParaRPr lang="en-US" sz="1200" dirty="0"/>
+          </a:p>
+        </p:txBody>
+      </p:sp>
+      <p:sp>
+        <p:nvSpPr>
+          <p:cNvPr id="6" name="Shape 3"/>
+          <p:cNvSpPr/>
+          <p:nvPr/>
+        </p:nvSpPr>
+        <p:spPr>
+          <a:xfrm>
+            <a:off x="411480" y="1417320"/>
+            <a:ext cx="1920240" cy="548640"/>
+          </a:xfrm>
+          <a:prstGeom prst="roundRect">
+            <a:avLst>
+              <a:gd name="adj" fmla="val 13333"/>
+            </a:avLst>
+          </a:prstGeom>
+          <a:solidFill>
+            <a:srgbClr val="1D1D1F"/>
+          </a:solidFill>
+          <a:ln w="12700">
+            <a:solidFill>
+              <a:srgbClr val="1D1D1F"/>
+            </a:solidFill>
+            <a:prstDash val="solid"/>
+          </a:ln>
+        </p:spPr>
+      </p:sp>
+      <p:sp>
+        <p:nvSpPr>
+          <p:cNvPr id="7" name="Text 4"/>
+          <p:cNvSpPr txBox="1"/>
+          <p:nvPr/>
+        </p:nvSpPr>
+        <p:spPr>
+          <a:xfrm>
+            <a:off x="411480" y="1417320"/>
+            <a:ext cx="1920240" cy="548640"/>
+          </a:xfrm>
+          <a:prstGeom prst="rect">
+            <a:avLst/>
+          </a:prstGeom>
+          <a:noFill/>
+          <a:ln/>
+        </p:spPr>
+        <p:txBody>
+          <a:bodyPr wrap="square" lIns="0" tIns="0" rIns="0" bIns="0" rtlCol="0" anchor="ctr"/>
+          <a:lstStyle/>
+          <a:p>
+            <a:pPr algn="ctr" indent="0" marL="0">
+              <a:buNone/>
+            </a:pPr>
+            <a:r>
+              <a:rPr lang="en-US" sz="1000" b="1" dirty="0">
+                <a:solidFill>
+                  <a:srgbClr val="FFFFFF"/>
+                </a:solidFill>
+                <a:latin typeface="SF Pro Display" pitchFamily="34" charset="0"/>
+                <a:ea typeface="SF Pro Display" pitchFamily="34" charset="-122"/>
+                <a:cs typeface="SF Pro Display" pitchFamily="34" charset="-120"/>
+              </a:rPr>
+              <a:t>Told "$20/hr"</a:t>
+            </a:r>
+            <a:endParaRPr lang="en-US" sz="1000" dirty="0"/>
+          </a:p>
+        </p:txBody>
+      </p:sp>
+      <p:sp>
+        <p:nvSpPr>
+          <p:cNvPr id="8" name="Shape 5"/>
+          <p:cNvSpPr/>
+          <p:nvPr/>
+        </p:nvSpPr>
+        <p:spPr>
+          <a:xfrm>
+            <a:off x="2331720" y="1691640"/>
+            <a:ext cx="210312" cy="0"/>
+          </a:xfrm>
+          <a:prstGeom prst="line">
+            <a:avLst/>
+          </a:prstGeom>
+          <a:noFill/>
+          <a:ln w="12700">
+            <a:solidFill>
+              <a:srgbClr val="6E6E73"/>
+            </a:solidFill>
+            <a:prstDash val="solid"/>
+            <a:tailEnd type="triangle"/>
+          </a:ln>
+        </p:spPr>
+      </p:sp>
+      <p:sp>
+        <p:nvSpPr>
+          <p:cNvPr id="9" name="Text 6"/>
+          <p:cNvSpPr txBox="1"/>
+          <p:nvPr/>
+        </p:nvSpPr>
+        <p:spPr>
+          <a:xfrm>
+            <a:off x="411480" y="2057400"/>
+            <a:ext cx="1920240" cy="640080"/>
+          </a:xfrm>
+          <a:prstGeom prst="rect">
+            <a:avLst/>
+          </a:prstGeom>
+          <a:noFill/>
+          <a:ln/>
+        </p:spPr>
+        <p:txBody>
+          <a:bodyPr wrap="square" lIns="0" tIns="0" rIns="0" bIns="0" rtlCol="0" anchor="t"/>
+          <a:lstStyle/>
+          <a:p>
+            <a:pPr algn="ctr" indent="0" marL="0">
+              <a:buNone/>
+            </a:pPr>
+            <a:r>
+              <a:rPr lang="en-US" sz="950" dirty="0">
+                <a:solidFill>
+                  <a:srgbClr val="6E6E73"/>
+                </a:solidFill>
+                <a:latin typeface="SF Pro Text" pitchFamily="34" charset="0"/>
+                <a:ea typeface="SF Pro Text" pitchFamily="34" charset="-122"/>
+                <a:cs typeface="SF Pro Text" pitchFamily="34" charset="-120"/>
+              </a:rPr>
+              <a:t>No mention of processing fee, tax or Premium.</a:t>
+            </a:r>
+            <a:endParaRPr lang="en-US" sz="950" dirty="0"/>
+          </a:p>
+        </p:txBody>
+      </p:sp>
+      <p:sp>
+        <p:nvSpPr>
+          <p:cNvPr id="10" name="Shape 7"/>
+          <p:cNvSpPr/>
+          <p:nvPr/>
+        </p:nvSpPr>
+        <p:spPr>
+          <a:xfrm>
+            <a:off x="2542032" y="1417320"/>
+            <a:ext cx="1920240" cy="548640"/>
+          </a:xfrm>
+          <a:prstGeom prst="roundRect">
+            <a:avLst>
+              <a:gd name="adj" fmla="val 13333"/>
+            </a:avLst>
+          </a:prstGeom>
+          <a:solidFill>
+            <a:srgbClr val="0B7A6F"/>
+          </a:solidFill>
+          <a:ln w="12700">
+            <a:solidFill>
+              <a:srgbClr val="0B7A6F"/>
+            </a:solidFill>
+            <a:prstDash val="solid"/>
+          </a:ln>
+        </p:spPr>
+      </p:sp>
+      <p:sp>
+        <p:nvSpPr>
+          <p:cNvPr id="11" name="Text 8"/>
+          <p:cNvSpPr txBox="1"/>
+          <p:nvPr/>
+        </p:nvSpPr>
+        <p:spPr>
+          <a:xfrm>
+            <a:off x="2542032" y="1417320"/>
+            <a:ext cx="1920240" cy="548640"/>
+          </a:xfrm>
+          <a:prstGeom prst="rect">
+            <a:avLst/>
+          </a:prstGeom>
+          <a:noFill/>
+          <a:ln/>
+        </p:spPr>
+        <p:txBody>
+          <a:bodyPr wrap="square" lIns="0" tIns="0" rIns="0" bIns="0" rtlCol="0" anchor="ctr"/>
+          <a:lstStyle/>
+          <a:p>
+            <a:pPr algn="ctr" indent="0" marL="0">
+              <a:buNone/>
+            </a:pPr>
+            <a:r>
+              <a:rPr lang="en-US" sz="1000" b="1" dirty="0">
+                <a:solidFill>
+                  <a:srgbClr val="FFFFFF"/>
+                </a:solidFill>
+                <a:latin typeface="SF Pro Display" pitchFamily="34" charset="0"/>
+                <a:ea typeface="SF Pro Display" pitchFamily="34" charset="-122"/>
+                <a:cs typeface="SF Pro Display" pitchFamily="34" charset="-120"/>
+              </a:rPr>
+              <a:t>Admin refund</a:t>
+            </a:r>
+            <a:endParaRPr lang="en-US" sz="1000" dirty="0"/>
+          </a:p>
+        </p:txBody>
+      </p:sp>
+      <p:sp>
+        <p:nvSpPr>
+          <p:cNvPr id="12" name="Shape 9"/>
+          <p:cNvSpPr/>
+          <p:nvPr/>
+        </p:nvSpPr>
+        <p:spPr>
+          <a:xfrm>
+            <a:off x="4462272" y="1691640"/>
+            <a:ext cx="210312" cy="0"/>
+          </a:xfrm>
+          <a:prstGeom prst="line">
+            <a:avLst/>
+          </a:prstGeom>
+          <a:noFill/>
+          <a:ln w="12700">
+            <a:solidFill>
+              <a:srgbClr val="6E6E73"/>
+            </a:solidFill>
+            <a:prstDash val="solid"/>
+            <a:tailEnd type="triangle"/>
+          </a:ln>
+        </p:spPr>
+      </p:sp>
+      <p:sp>
+        <p:nvSpPr>
+          <p:cNvPr id="13" name="Text 10"/>
+          <p:cNvSpPr txBox="1"/>
+          <p:nvPr/>
+        </p:nvSpPr>
+        <p:spPr>
+          <a:xfrm>
+            <a:off x="2542032" y="2057400"/>
+            <a:ext cx="1920240" cy="640080"/>
+          </a:xfrm>
+          <a:prstGeom prst="rect">
+            <a:avLst/>
+          </a:prstGeom>
+          <a:noFill/>
+          <a:ln/>
+        </p:spPr>
+        <p:txBody>
+          <a:bodyPr wrap="square" lIns="0" tIns="0" rIns="0" bIns="0" rtlCol="0" anchor="t"/>
+          <a:lstStyle/>
+          <a:p>
+            <a:pPr algn="ctr" indent="0" marL="0">
+              <a:buNone/>
+            </a:pPr>
+            <a:r>
+              <a:rPr lang="en-US" sz="950" dirty="0">
+                <a:solidFill>
+                  <a:srgbClr val="6E6E73"/>
+                </a:solidFill>
+                <a:latin typeface="SF Pro Text" pitchFamily="34" charset="0"/>
+                <a:ea typeface="SF Pro Text" pitchFamily="34" charset="-122"/>
+                <a:cs typeface="SF Pro Text" pitchFamily="34" charset="-120"/>
+              </a:rPr>
+              <a:t>So the job totals $20/hr × hours worked.</a:t>
+            </a:r>
+            <a:endParaRPr lang="en-US" sz="950" dirty="0"/>
+          </a:p>
+        </p:txBody>
+      </p:sp>
+      <p:sp>
+        <p:nvSpPr>
+          <p:cNvPr id="14" name="Shape 11"/>
+          <p:cNvSpPr/>
+          <p:nvPr/>
+        </p:nvSpPr>
+        <p:spPr>
+          <a:xfrm>
+            <a:off x="4672584" y="1417320"/>
+            <a:ext cx="1920240" cy="548640"/>
+          </a:xfrm>
+          <a:prstGeom prst="roundRect">
+            <a:avLst>
+              <a:gd name="adj" fmla="val 13333"/>
+            </a:avLst>
+          </a:prstGeom>
+          <a:solidFill>
+            <a:srgbClr val="0B7A6F"/>
+          </a:solidFill>
+          <a:ln w="12700">
+            <a:solidFill>
+              <a:srgbClr val="0B7A6F"/>
+            </a:solidFill>
+            <a:prstDash val="solid"/>
+          </a:ln>
+        </p:spPr>
+      </p:sp>
+      <p:sp>
+        <p:nvSpPr>
+          <p:cNvPr id="15" name="Text 12"/>
+          <p:cNvSpPr txBox="1"/>
+          <p:nvPr/>
+        </p:nvSpPr>
+        <p:spPr>
+          <a:xfrm>
+            <a:off x="4672584" y="1417320"/>
+            <a:ext cx="1920240" cy="548640"/>
+          </a:xfrm>
+          <a:prstGeom prst="rect">
+            <a:avLst/>
+          </a:prstGeom>
+          <a:noFill/>
+          <a:ln/>
+        </p:spPr>
+        <p:txBody>
+          <a:bodyPr wrap="square" lIns="0" tIns="0" rIns="0" bIns="0" rtlCol="0" anchor="ctr"/>
+          <a:lstStyle/>
+          <a:p>
+            <a:pPr algn="ctr" indent="0" marL="0">
+              <a:buNone/>
+            </a:pPr>
+            <a:r>
+              <a:rPr lang="en-US" sz="1000" b="1" dirty="0">
+                <a:solidFill>
+                  <a:srgbClr val="FFFFFF"/>
+                </a:solidFill>
+                <a:latin typeface="SF Pro Display" pitchFamily="34" charset="0"/>
+                <a:ea typeface="SF Pro Display" pitchFamily="34" charset="-122"/>
+                <a:cs typeface="SF Pro Display" pitchFamily="34" charset="-120"/>
+              </a:rPr>
+              <a:t>Set the account</a:t>
+            </a:r>
+            <a:endParaRPr lang="en-US" sz="1000" dirty="0"/>
+          </a:p>
+        </p:txBody>
+      </p:sp>
+      <p:sp>
+        <p:nvSpPr>
+          <p:cNvPr id="16" name="Shape 13"/>
+          <p:cNvSpPr/>
+          <p:nvPr/>
+        </p:nvSpPr>
+        <p:spPr>
+          <a:xfrm>
+            <a:off x="6592824" y="1691640"/>
+            <a:ext cx="210312" cy="0"/>
+          </a:xfrm>
+          <a:prstGeom prst="line">
+            <a:avLst/>
+          </a:prstGeom>
+          <a:noFill/>
+          <a:ln w="12700">
+            <a:solidFill>
+              <a:srgbClr val="6E6E73"/>
+            </a:solidFill>
+            <a:prstDash val="solid"/>
+            <a:tailEnd type="triangle"/>
+          </a:ln>
+        </p:spPr>
+      </p:sp>
+      <p:sp>
+        <p:nvSpPr>
+          <p:cNvPr id="17" name="Text 14"/>
+          <p:cNvSpPr txBox="1"/>
+          <p:nvPr/>
+        </p:nvSpPr>
+        <p:spPr>
+          <a:xfrm>
+            <a:off x="4672584" y="2057400"/>
+            <a:ext cx="1920240" cy="640080"/>
+          </a:xfrm>
+          <a:prstGeom prst="rect">
+            <a:avLst/>
+          </a:prstGeom>
+          <a:noFill/>
+          <a:ln/>
+        </p:spPr>
+        <p:txBody>
+          <a:bodyPr wrap="square" lIns="0" tIns="0" rIns="0" bIns="0" rtlCol="0" anchor="t"/>
+          <a:lstStyle/>
+          <a:p>
+            <a:pPr algn="ctr" indent="0" marL="0">
+              <a:buNone/>
+            </a:pPr>
+            <a:r>
+              <a:rPr lang="en-US" sz="950" dirty="0">
+                <a:solidFill>
+                  <a:srgbClr val="6E6E73"/>
+                </a:solidFill>
+                <a:latin typeface="SF Pro Text" pitchFamily="34" charset="0"/>
+                <a:ea typeface="SF Pro Text" pitchFamily="34" charset="-122"/>
+                <a:cs typeface="SF Pro Text" pitchFamily="34" charset="-120"/>
+              </a:rPr>
+              <a:t>Max CP rate $20. Cleaner Experience Level: Standard.</a:t>
+            </a:r>
+            <a:endParaRPr lang="en-US" sz="950" dirty="0"/>
+          </a:p>
+        </p:txBody>
+      </p:sp>
+      <p:sp>
+        <p:nvSpPr>
+          <p:cNvPr id="18" name="Shape 15"/>
+          <p:cNvSpPr/>
+          <p:nvPr/>
+        </p:nvSpPr>
+        <p:spPr>
+          <a:xfrm>
+            <a:off x="6803136" y="1417320"/>
+            <a:ext cx="1920240" cy="548640"/>
+          </a:xfrm>
+          <a:prstGeom prst="roundRect">
+            <a:avLst>
+              <a:gd name="adj" fmla="val 13333"/>
+            </a:avLst>
+          </a:prstGeom>
+          <a:solidFill>
+            <a:srgbClr val="FFFFFF"/>
+          </a:solidFill>
+          <a:ln w="12700">
+            <a:solidFill>
+              <a:srgbClr val="DCE1E7"/>
+            </a:solidFill>
+            <a:prstDash val="solid"/>
+          </a:ln>
+        </p:spPr>
+      </p:sp>
+      <p:sp>
+        <p:nvSpPr>
+          <p:cNvPr id="19" name="Text 16"/>
+          <p:cNvSpPr txBox="1"/>
+          <p:nvPr/>
+        </p:nvSpPr>
+        <p:spPr>
+          <a:xfrm>
+            <a:off x="6803136" y="1417320"/>
+            <a:ext cx="1920240" cy="548640"/>
+          </a:xfrm>
+          <a:prstGeom prst="rect">
+            <a:avLst/>
+          </a:prstGeom>
+          <a:noFill/>
+          <a:ln/>
+        </p:spPr>
+        <p:txBody>
+          <a:bodyPr wrap="square" lIns="0" tIns="0" rIns="0" bIns="0" rtlCol="0" anchor="ctr"/>
+          <a:lstStyle/>
+          <a:p>
+            <a:pPr algn="ctr" indent="0" marL="0">
+              <a:buNone/>
+            </a:pPr>
+            <a:r>
+              <a:rPr lang="en-US" sz="1000" b="1" dirty="0">
+                <a:solidFill>
+                  <a:srgbClr val="1D1D1F"/>
+                </a:solidFill>
+                <a:latin typeface="SF Pro Display" pitchFamily="34" charset="0"/>
+                <a:ea typeface="SF Pro Display" pitchFamily="34" charset="-122"/>
+                <a:cs typeface="SF Pro Display" pitchFamily="34" charset="-120"/>
+              </a:rPr>
+              <a:t>Explain the fees</a:t>
+            </a:r>
+            <a:endParaRPr lang="en-US" sz="1000" dirty="0"/>
+          </a:p>
+        </p:txBody>
+      </p:sp>
+      <p:sp>
+        <p:nvSpPr>
+          <p:cNvPr id="20" name="Text 17"/>
+          <p:cNvSpPr txBox="1"/>
+          <p:nvPr/>
+        </p:nvSpPr>
+        <p:spPr>
+          <a:xfrm>
+            <a:off x="6803136" y="2057400"/>
+            <a:ext cx="1920240" cy="640080"/>
+          </a:xfrm>
+          <a:prstGeom prst="rect">
+            <a:avLst/>
+          </a:prstGeom>
+          <a:noFill/>
+          <a:ln/>
+        </p:spPr>
+        <p:txBody>
+          <a:bodyPr wrap="square" lIns="0" tIns="0" rIns="0" bIns="0" rtlCol="0" anchor="t"/>
+          <a:lstStyle/>
+          <a:p>
+            <a:pPr algn="ctr" indent="0" marL="0">
+              <a:buNone/>
+            </a:pPr>
+            <a:r>
+              <a:rPr lang="en-US" sz="950" dirty="0">
+                <a:solidFill>
+                  <a:srgbClr val="6E6E73"/>
+                </a:solidFill>
+                <a:latin typeface="SF Pro Text" pitchFamily="34" charset="0"/>
+                <a:ea typeface="SF Pro Text" pitchFamily="34" charset="-122"/>
+                <a:cs typeface="SF Pro Text" pitchFamily="34" charset="-120"/>
+              </a:rPr>
+              <a:t>So the next invoice isn't a surprise.</a:t>
+            </a:r>
+            <a:endParaRPr lang="en-US" sz="950" dirty="0"/>
+          </a:p>
+        </p:txBody>
+      </p:sp>
+      <p:sp>
+        <p:nvSpPr>
+          <p:cNvPr id="21" name="Shape 18"/>
+          <p:cNvSpPr/>
+          <p:nvPr/>
+        </p:nvSpPr>
+        <p:spPr>
+          <a:xfrm>
+            <a:off x="411480" y="3063240"/>
+            <a:ext cx="8321040" cy="384048"/>
+          </a:xfrm>
+          <a:prstGeom prst="roundRect">
+            <a:avLst>
+              <a:gd name="adj" fmla="val 19048"/>
+            </a:avLst>
+          </a:prstGeom>
+          <a:solidFill>
+            <a:srgbClr val="FFF3D6"/>
+          </a:solidFill>
+          <a:ln w="9525">
+            <a:solidFill>
+              <a:srgbClr val="FFF3D6"/>
+            </a:solidFill>
+            <a:prstDash val="solid"/>
+          </a:ln>
+        </p:spPr>
+      </p:sp>
+      <p:pic>
+        <p:nvPicPr>
+          <p:cNvPr id="22" name="Image 0" descr="preencoded.png">    </p:cNvPr>
+          <p:cNvPicPr>
+            <a:picLocks noChangeAspect="1"/>
+          </p:cNvPicPr>
+          <p:nvPr/>
+        </p:nvPicPr>
+        <p:blipFill>
+          <a:blip r:embed="rId1"/>
+          <a:stretch>
+            <a:fillRect/>
+          </a:stretch>
+        </p:blipFill>
+        <p:spPr>
+          <a:xfrm>
+            <a:off x="566928" y="3172968"/>
+            <a:ext cx="164592" cy="164592"/>
+          </a:xfrm>
+          <a:prstGeom prst="rect">
+            <a:avLst/>
+          </a:prstGeom>
+        </p:spPr>
+      </p:pic>
+      <p:sp>
+        <p:nvSpPr>
+          <p:cNvPr id="23" name="Text 19"/>
+          <p:cNvSpPr txBox="1"/>
+          <p:nvPr/>
+        </p:nvSpPr>
+        <p:spPr>
+          <a:xfrm>
+            <a:off x="822960" y="3163824"/>
+            <a:ext cx="7772400" cy="201168"/>
+          </a:xfrm>
+          <a:prstGeom prst="rect">
+            <a:avLst/>
+          </a:prstGeom>
+          <a:noFill/>
+          <a:ln/>
+        </p:spPr>
+        <p:txBody>
+          <a:bodyPr wrap="square" lIns="0" tIns="0" rIns="0" bIns="0" rtlCol="0" anchor="t"/>
+          <a:lstStyle/>
+          <a:p>
+            <a:pPr indent="0" marL="0">
+              <a:buNone/>
+            </a:pPr>
+            <a:r>
+              <a:rPr lang="en-US" sz="1000" b="1" dirty="0">
+                <a:solidFill>
+                  <a:srgbClr val="9A6410"/>
+                </a:solidFill>
+                <a:latin typeface="SF Pro Text" pitchFamily="34" charset="0"/>
+                <a:ea typeface="SF Pro Text" pitchFamily="34" charset="-122"/>
+                <a:cs typeface="SF Pro Text" pitchFamily="34" charset="-120"/>
+              </a:rPr>
+              <a:t>Disclosed and agreed?  </a:t>
+            </a:r>
+            <a:pPr indent="0" marL="0">
+              <a:buNone/>
+            </a:pPr>
+            <a:r>
+              <a:rPr lang="en-US" sz="1000" dirty="0">
+                <a:solidFill>
+                  <a:srgbClr val="1D1D1F"/>
+                </a:solidFill>
+                <a:latin typeface="SF Pro Text" pitchFamily="34" charset="0"/>
+                <a:ea typeface="SF Pro Text" pitchFamily="34" charset="-122"/>
+                <a:cs typeface="SF Pro Text" pitchFamily="34" charset="-120"/>
+              </a:rPr>
+              <a:t>refund only the part that was never disclosed.</a:t>
+            </a:r>
+            <a:endParaRPr lang="en-US" sz="1000" dirty="0"/>
+          </a:p>
+        </p:txBody>
+      </p:sp>
+      <p:sp>
+        <p:nvSpPr>
+          <p:cNvPr id="24" name="Shape 20"/>
+          <p:cNvSpPr/>
+          <p:nvPr/>
+        </p:nvSpPr>
+        <p:spPr>
+          <a:xfrm>
+            <a:off x="411480" y="3611880"/>
+            <a:ext cx="5669280" cy="292608"/>
+          </a:xfrm>
+          <a:prstGeom prst="roundRect">
+            <a:avLst>
+              <a:gd name="adj" fmla="val 25000"/>
+            </a:avLst>
+          </a:prstGeom>
+          <a:solidFill>
+            <a:srgbClr val="FFF3D6"/>
+          </a:solidFill>
+          <a:ln w="9525">
+            <a:solidFill>
+              <a:srgbClr val="9A6410"/>
+            </a:solidFill>
+            <a:prstDash val="solid"/>
+          </a:ln>
+        </p:spPr>
+      </p:sp>
+      <p:pic>
+        <p:nvPicPr>
+          <p:cNvPr id="25" name="Image 1" descr="preencoded.png">    </p:cNvPr>
+          <p:cNvPicPr>
+            <a:picLocks noChangeAspect="1"/>
+          </p:cNvPicPr>
+          <p:nvPr/>
+        </p:nvPicPr>
+        <p:blipFill>
+          <a:blip r:embed="rId2"/>
+          <a:stretch>
+            <a:fillRect/>
+          </a:stretch>
+        </p:blipFill>
+        <p:spPr>
+          <a:xfrm>
+            <a:off x="521208" y="3685032"/>
+            <a:ext cx="146304" cy="146304"/>
+          </a:xfrm>
+          <a:prstGeom prst="rect">
+            <a:avLst/>
+          </a:prstGeom>
+        </p:spPr>
+      </p:pic>
+      <p:sp>
+        <p:nvSpPr>
+          <p:cNvPr id="26" name="Text 21"/>
+          <p:cNvSpPr txBox="1"/>
+          <p:nvPr/>
+        </p:nvSpPr>
+        <p:spPr>
+          <a:xfrm>
+            <a:off x="731520" y="3611880"/>
+            <a:ext cx="5303520" cy="292608"/>
+          </a:xfrm>
+          <a:prstGeom prst="rect">
+            <a:avLst/>
+          </a:prstGeom>
+          <a:noFill/>
+          <a:ln/>
+        </p:spPr>
+        <p:txBody>
+          <a:bodyPr wrap="square" lIns="0" tIns="0" rIns="0" bIns="0" rtlCol="0" anchor="ctr"/>
+          <a:lstStyle/>
+          <a:p>
+            <a:pPr indent="0" marL="0">
+              <a:buNone/>
+            </a:pPr>
+            <a:r>
+              <a:rPr lang="en-US" sz="950" b="1" dirty="0">
+                <a:solidFill>
+                  <a:srgbClr val="9A6410"/>
+                </a:solidFill>
+                <a:latin typeface="SF Pro Display" pitchFamily="34" charset="0"/>
+                <a:ea typeface="SF Pro Display" pitchFamily="34" charset="-122"/>
+                <a:cs typeface="SF Pro Display" pitchFamily="34" charset="-120"/>
+              </a:rPr>
+              <a:t>Recommended Macro:  </a:t>
+            </a:r>
+            <a:pPr indent="0" marL="0">
+              <a:buNone/>
+            </a:pPr>
+            <a:r>
+              <a:rPr lang="en-US" sz="950" b="1" dirty="0">
+                <a:solidFill>
+                  <a:srgbClr val="1D1D1F"/>
+                </a:solidFill>
+                <a:latin typeface="SF Pro Display" pitchFamily="34" charset="0"/>
+                <a:ea typeface="SF Pro Display" pitchFamily="34" charset="-122"/>
+                <a:cs typeface="SF Pro Display" pitchFamily="34" charset="-120"/>
+              </a:rPr>
+              <a:t>Misinformation: address incorrect claims about charges</a:t>
+            </a:r>
+            <a:endParaRPr lang="en-US" sz="950" dirty="0"/>
+          </a:p>
+        </p:txBody>
+      </p:sp>
+      <p:sp>
+        <p:nvSpPr>
+          <p:cNvPr id="25" name="Slide Number Placeholder 0"/>
+          <p:cNvSpPr>
+            <a:spLocks noGrp="1"/>
+          </p:cNvSpPr>
+          <p:nvPr>
+            <p:ph type="sldNum" sz="quarter" idx="4294967295"/>
+          </p:nvPr>
+        </p:nvSpPr>
+        <p:spPr>
+          <a:xfrm>
+            <a:off x="8229600" y="4800600"/>
+            <a:ext cx="457200" cy="182880"/>
+          </a:xfrm>
+          <a:prstGeom prst="rect">
+            <a:avLst/>
+          </a:prstGeom>
+          <a:extLst>
+            <a:ext uri="{C572A759-6A51-4108-AA02-DFA0A04FC94B}">
+              <ma14:wrappingTextBoxFlag xmlns:ma14="http://schemas.microsoft.com/office/mac/drawingml/2011/main" val="0"/>
+            </a:ext>
+          </a:extLst>
+        </p:spPr>
+        <p:txBody>
+          <a:bodyPr/>
+          <a:lstStyle>
+            <a:lvl1pPr>
+              <a:defRPr sz="700">
+                <a:solidFill>
+                  <a:srgbClr val="6E6E73"/>
+                </a:solidFill>
+                <a:latin typeface="SF Pro Text"/>
+                <a:ea typeface="SF Pro Text"/>
+                <a:cs typeface="SF Pro Text"/>
+              </a:defRPr>
+            </a:lvl1pPr>
+          </a:lstStyle>
+          <a:p>
+            <a:pPr algn="r"/>
+            <a:fld id="{F7021451-1387-4CA6-816F-3879F97B5CBC}" type="slidenum">
+              <a:rPr b="0" lang="en-US"/>
+              <a:t>7</a:t>
+            </a:fld>
+            <a:endParaRPr lang="en-US"/>
+          </a:p>
+        </p:txBody>
+      </p:sp>
+    </p:spTree>
+  </p:cSld>
+  <p:clrMapOvr>
+    <a:masterClrMapping/>
+  </p:clrMapOvr>
 </p:sld>
 </file>
 

</xml_diff>

<commit_message>
Incorrect Info deck: live-ticket investigation wrap-up; keep Quick check title
Co-Authored-By: Claude Opus 5.5 <noreply@anthropic.com>
Claude-Session: https://claude.ai/code/session_01FEzv8wwqWDgTsXP8Yz6XYn
</commit_message>
<xml_diff>
--- a/incorrect-info-lmc-lockout/incorrect-info-lmc-lockout.pptx
+++ b/incorrect-info-lmc-lockout/incorrect-info-lmc-lockout.pptx
@@ -618,7 +618,7 @@
           <a:p>
             <a:r>
               <a:rPr lang="en-US" dirty="0"/>
-              <a:t>TRAINER: recap the three takeaways, then open the floor for questions on Incorrect Information Provided.</a:t>
+              <a:t>TRAINER: share a live Incorrect Information ticket (type the ticket ID on the slide, or share your screen). Give trainees a few minutes to investigate on their own, then walk through it together using the four prompts: 1) What was said? Find the exact words the customer says they were told, and by whom (Sales, an agent, the website). 2) Promise or estimate? "At $23/hour" is a guarantee; "around" or "starting at" is an estimate. Was a fee simply never mentioned, or was a specific total promised? 3) Verify: would this need a Sales call review? Walk through the request, the internal note with the escalation link, and setting the status to Waiting on CSQ. 4) What's the fix? If verified: refund the gap, own the error, correct it, one light offer; declined or not retainable: waive the ETF and cancel the FC. Which macro? Then open the floor for questions on Incorrect Information Provided.</a:t>
             </a:r>
             <a:endParaRPr lang="en-US" dirty="0"/>
           </a:p>
@@ -4057,7 +4057,7 @@
                 <a:ea typeface="SF Pro Display" pitchFamily="34" charset="-122"/>
                 <a:cs typeface="SF Pro Display" pitchFamily="34" charset="-120"/>
               </a:rPr>
-              <a:t>Wrap-up</a:t>
+              <a:t>Investigate a live ticket</a:t>
             </a:r>
             <a:endParaRPr lang="en-US" sz="2400" dirty="0"/>
           </a:p>
@@ -4096,7 +4096,7 @@
                 <a:ea typeface="SF Pro Text" pitchFamily="34" charset="-122"/>
                 <a:cs typeface="SF Pro Text" pitchFamily="34" charset="-120"/>
               </a:rPr>
-              <a:t>Key takeaways before we move on.</a:t>
+              <a:t>Your trainer shares a real ticket. Work it through the process.</a:t>
             </a:r>
             <a:endParaRPr lang="en-US" sz="1200" dirty="0"/>
           </a:p>
@@ -4110,12 +4110,206 @@
         </p:nvSpPr>
         <p:spPr>
           <a:xfrm>
-            <a:off x="411480" y="1325880"/>
-            <a:ext cx="2682240" cy="1600200"/>
+            <a:off x="411480" y="1298448"/>
+            <a:ext cx="2743200" cy="1691640"/>
           </a:xfrm>
           <a:prstGeom prst="roundRect">
             <a:avLst>
-              <a:gd name="adj" fmla="val 4571"/>
+              <a:gd name="adj" fmla="val 4324"/>
+            </a:avLst>
+          </a:prstGeom>
+          <a:solidFill>
+            <a:srgbClr val="E3F4F1"/>
+          </a:solidFill>
+          <a:ln w="15875">
+            <a:solidFill>
+              <a:srgbClr val="0B7A6F"/>
+            </a:solidFill>
+            <a:prstDash val="dash"/>
+          </a:ln>
+        </p:spPr>
+      </p:sp>
+      <p:sp>
+        <p:nvSpPr>
+          <p:cNvPr id="7" name="Shape 4"/>
+          <p:cNvSpPr/>
+          <p:nvPr/>
+        </p:nvSpPr>
+        <p:spPr>
+          <a:xfrm>
+            <a:off x="594360" y="1481328"/>
+            <a:ext cx="384048" cy="384048"/>
+          </a:xfrm>
+          <a:prstGeom prst="ellipse">
+            <a:avLst/>
+          </a:prstGeom>
+          <a:solidFill>
+            <a:srgbClr val="FFFFFF"/>
+          </a:solidFill>
+          <a:ln w="12700">
+            <a:solidFill>
+              <a:srgbClr val="FFFFFF"/>
+            </a:solidFill>
+            <a:prstDash val="solid"/>
+          </a:ln>
+        </p:spPr>
+      </p:sp>
+      <p:pic>
+        <p:nvPicPr>
+          <p:cNvPr id="8" name="Image 0" descr="preencoded.png">    </p:cNvPr>
+          <p:cNvPicPr>
+            <a:picLocks noChangeAspect="1"/>
+          </p:cNvPicPr>
+          <p:nvPr/>
+        </p:nvPicPr>
+        <p:blipFill>
+          <a:blip r:embed="rId1"/>
+          <a:stretch>
+            <a:fillRect/>
+          </a:stretch>
+        </p:blipFill>
+        <p:spPr>
+          <a:xfrm>
+            <a:off x="686532" y="1573500"/>
+            <a:ext cx="199705" cy="199705"/>
+          </a:xfrm>
+          <a:prstGeom prst="rect">
+            <a:avLst/>
+          </a:prstGeom>
+        </p:spPr>
+      </p:pic>
+      <p:sp>
+        <p:nvSpPr>
+          <p:cNvPr id="9" name="Text 5"/>
+          <p:cNvSpPr txBox="1"/>
+          <p:nvPr/>
+        </p:nvSpPr>
+        <p:spPr>
+          <a:xfrm>
+            <a:off x="1097280" y="1481328"/>
+            <a:ext cx="1920240" cy="384048"/>
+          </a:xfrm>
+          <a:prstGeom prst="rect">
+            <a:avLst/>
+          </a:prstGeom>
+          <a:noFill/>
+          <a:ln/>
+        </p:spPr>
+        <p:txBody>
+          <a:bodyPr wrap="square" lIns="0" tIns="0" rIns="0" bIns="0" rtlCol="0" anchor="ctr"/>
+          <a:lstStyle/>
+          <a:p>
+            <a:pPr indent="0" marL="0">
+              <a:buNone/>
+            </a:pPr>
+            <a:r>
+              <a:rPr lang="en-US" sz="1300" b="1" dirty="0">
+                <a:solidFill>
+                  <a:srgbClr val="0B7A6F"/>
+                </a:solidFill>
+                <a:latin typeface="SF Pro Display" pitchFamily="34" charset="0"/>
+                <a:ea typeface="SF Pro Display" pitchFamily="34" charset="-122"/>
+                <a:cs typeface="SF Pro Display" pitchFamily="34" charset="-120"/>
+              </a:rPr>
+              <a:t>Today's ticket</a:t>
+            </a:r>
+            <a:endParaRPr lang="en-US" sz="1300" dirty="0"/>
+          </a:p>
+        </p:txBody>
+      </p:sp>
+      <p:sp>
+        <p:nvSpPr>
+          <p:cNvPr id="10" name="Text 6"/>
+          <p:cNvSpPr txBox="1"/>
+          <p:nvPr/>
+        </p:nvSpPr>
+        <p:spPr>
+          <a:xfrm>
+            <a:off x="594360" y="2075688"/>
+            <a:ext cx="2377440" cy="731520"/>
+          </a:xfrm>
+          <a:prstGeom prst="rect">
+            <a:avLst/>
+          </a:prstGeom>
+          <a:noFill/>
+          <a:ln/>
+        </p:spPr>
+        <p:txBody>
+          <a:bodyPr wrap="square" lIns="0" tIns="0" rIns="0" bIns="0" rtlCol="0" anchor="t"/>
+          <a:lstStyle/>
+          <a:p>
+            <a:pPr indent="0" marL="0">
+              <a:spcAft>
+                <a:spcPts val="600"/>
+              </a:spcAft>
+              <a:buNone/>
+            </a:pPr>
+            <a:r>
+              <a:rPr lang="en-US" sz="1100" b="1" dirty="0">
+                <a:solidFill>
+                  <a:srgbClr val="1D1D1F"/>
+                </a:solidFill>
+                <a:latin typeface="SF Pro Text" pitchFamily="34" charset="0"/>
+                <a:ea typeface="SF Pro Text" pitchFamily="34" charset="-122"/>
+                <a:cs typeface="SF Pro Text" pitchFamily="34" charset="-120"/>
+              </a:rPr>
+              <a:t>Ticket ID:  </a:t>
+            </a:r>
+            <a:pPr indent="0" marL="0">
+              <a:spcAft>
+                <a:spcPts val="600"/>
+              </a:spcAft>
+              <a:buNone/>
+            </a:pPr>
+            <a:r>
+              <a:rPr lang="en-US" sz="1100" dirty="0">
+                <a:solidFill>
+                  <a:srgbClr val="6E6E73"/>
+                </a:solidFill>
+                <a:latin typeface="SF Pro Text" pitchFamily="34" charset="0"/>
+                <a:ea typeface="SF Pro Text" pitchFamily="34" charset="-122"/>
+                <a:cs typeface="SF Pro Text" pitchFamily="34" charset="-120"/>
+              </a:rPr>
+              <a:t>__________</a:t>
+            </a:r>
+            <a:endParaRPr lang="en-US" sz="1100" dirty="0"/>
+          </a:p>
+          <a:p>
+            <a:pPr indent="0" marL="0">
+              <a:spcAft>
+                <a:spcPts val="600"/>
+              </a:spcAft>
+              <a:buNone/>
+            </a:pPr>
+            <a:r>
+              <a:rPr lang="en-US" sz="900" i="1" dirty="0">
+                <a:solidFill>
+                  <a:srgbClr val="6E6E73"/>
+                </a:solidFill>
+                <a:latin typeface="SF Pro Text" pitchFamily="34" charset="0"/>
+                <a:ea typeface="SF Pro Text" pitchFamily="34" charset="-122"/>
+                <a:cs typeface="SF Pro Text" pitchFamily="34" charset="-120"/>
+              </a:rPr>
+              <a:t>Provided by your trainer</a:t>
+            </a:r>
+            <a:endParaRPr lang="en-US" sz="1100" dirty="0"/>
+          </a:p>
+        </p:txBody>
+      </p:sp>
+      <p:sp>
+        <p:nvSpPr>
+          <p:cNvPr id="11" name="Shape 7"/>
+          <p:cNvSpPr/>
+          <p:nvPr/>
+        </p:nvSpPr>
+        <p:spPr>
+          <a:xfrm>
+            <a:off x="3291840" y="1298448"/>
+            <a:ext cx="2651760" cy="777240"/>
+          </a:xfrm>
+          <a:prstGeom prst="roundRect">
+            <a:avLst>
+              <a:gd name="adj" fmla="val 9412"/>
             </a:avLst>
           </a:prstGeom>
           <a:solidFill>
@@ -4131,13 +4325,13 @@
       </p:sp>
       <p:sp>
         <p:nvSpPr>
-          <p:cNvPr id="7" name="Shape 4"/>
+          <p:cNvPr id="12" name="Shape 8"/>
           <p:cNvSpPr/>
           <p:nvPr/>
         </p:nvSpPr>
         <p:spPr>
           <a:xfrm>
-            <a:off x="576072" y="1508760"/>
+            <a:off x="3429000" y="1435608"/>
             <a:ext cx="274320" cy="274320"/>
           </a:xfrm>
           <a:prstGeom prst="ellipse">
@@ -4156,13 +4350,13 @@
       </p:sp>
       <p:sp>
         <p:nvSpPr>
-          <p:cNvPr id="8" name="Text 5"/>
+          <p:cNvPr id="13" name="Text 9"/>
           <p:cNvSpPr txBox="1"/>
           <p:nvPr/>
         </p:nvSpPr>
         <p:spPr>
           <a:xfrm>
-            <a:off x="576072" y="1508760"/>
+            <a:off x="3429000" y="1435608"/>
             <a:ext cx="274320" cy="274320"/>
           </a:xfrm>
           <a:prstGeom prst="rect">
@@ -4195,14 +4389,14 @@
       </p:sp>
       <p:sp>
         <p:nvSpPr>
-          <p:cNvPr id="9" name="Text 6"/>
+          <p:cNvPr id="14" name="Text 10"/>
           <p:cNvSpPr txBox="1"/>
           <p:nvPr/>
         </p:nvSpPr>
         <p:spPr>
           <a:xfrm>
-            <a:off x="576072" y="1929384"/>
-            <a:ext cx="2353056" cy="274320"/>
+            <a:off x="3794760" y="1408176"/>
+            <a:ext cx="2011680" cy="292608"/>
           </a:xfrm>
           <a:prstGeom prst="rect">
             <a:avLst/>
@@ -4211,14 +4405,14 @@
           <a:ln/>
         </p:spPr>
         <p:txBody>
-          <a:bodyPr wrap="square" lIns="0" tIns="0" rIns="0" bIns="0" rtlCol="0" anchor="t"/>
+          <a:bodyPr wrap="square" lIns="0" tIns="0" rIns="0" bIns="0" rtlCol="0" anchor="ctr"/>
           <a:lstStyle/>
           <a:p>
             <a:pPr indent="0" marL="0">
               <a:buNone/>
             </a:pPr>
             <a:r>
-              <a:rPr lang="en-US" sz="1200" b="1" dirty="0">
+              <a:rPr lang="en-US" sz="1150" b="1" dirty="0">
                 <a:solidFill>
                   <a:srgbClr val="1D1D1F"/>
                 </a:solidFill>
@@ -4226,22 +4420,22 @@
                 <a:ea typeface="SF Pro Display" pitchFamily="34" charset="-122"/>
                 <a:cs typeface="SF Pro Display" pitchFamily="34" charset="-120"/>
               </a:rPr>
-              <a:t>Test the words</a:t>
-            </a:r>
-            <a:endParaRPr lang="en-US" sz="1200" dirty="0"/>
-          </a:p>
-        </p:txBody>
-      </p:sp>
-      <p:sp>
-        <p:nvSpPr>
-          <p:cNvPr id="10" name="Text 7"/>
+              <a:t>What was said?</a:t>
+            </a:r>
+            <a:endParaRPr lang="en-US" sz="1150" dirty="0"/>
+          </a:p>
+        </p:txBody>
+      </p:sp>
+      <p:sp>
+        <p:nvSpPr>
+          <p:cNvPr id="15" name="Text 11"/>
           <p:cNvSpPr txBox="1"/>
           <p:nvPr/>
         </p:nvSpPr>
         <p:spPr>
           <a:xfrm>
-            <a:off x="576072" y="2221992"/>
-            <a:ext cx="2353056" cy="612648"/>
+            <a:off x="3794760" y="1719072"/>
+            <a:ext cx="2011680" cy="301752"/>
           </a:xfrm>
           <a:prstGeom prst="rect">
             <a:avLst/>
@@ -4265,7 +4459,7 @@
                 <a:ea typeface="SF Pro Text" pitchFamily="34" charset="-122"/>
                 <a:cs typeface="SF Pro Text" pitchFamily="34" charset="-120"/>
               </a:rPr>
-              <a:t>"At" is a guarantee. "Around" is an estimate.</a:t>
+              <a:t>Find the exact words, and who said them.</a:t>
             </a:r>
             <a:endParaRPr lang="en-US" sz="950" dirty="0"/>
           </a:p>
@@ -4273,18 +4467,18 @@
       </p:sp>
       <p:sp>
         <p:nvSpPr>
-          <p:cNvPr id="11" name="Shape 8"/>
+          <p:cNvPr id="16" name="Shape 12"/>
           <p:cNvSpPr/>
           <p:nvPr/>
         </p:nvSpPr>
         <p:spPr>
           <a:xfrm>
-            <a:off x="3230880" y="1325880"/>
-            <a:ext cx="2682240" cy="1600200"/>
+            <a:off x="6080760" y="1298448"/>
+            <a:ext cx="2651760" cy="777240"/>
           </a:xfrm>
           <a:prstGeom prst="roundRect">
             <a:avLst>
-              <a:gd name="adj" fmla="val 4571"/>
+              <a:gd name="adj" fmla="val 9412"/>
             </a:avLst>
           </a:prstGeom>
           <a:solidFill>
@@ -4300,13 +4494,13 @@
       </p:sp>
       <p:sp>
         <p:nvSpPr>
-          <p:cNvPr id="12" name="Shape 9"/>
+          <p:cNvPr id="17" name="Shape 13"/>
           <p:cNvSpPr/>
           <p:nvPr/>
         </p:nvSpPr>
         <p:spPr>
           <a:xfrm>
-            <a:off x="3395472" y="1508760"/>
+            <a:off x="6217920" y="1435608"/>
             <a:ext cx="274320" cy="274320"/>
           </a:xfrm>
           <a:prstGeom prst="ellipse">
@@ -4325,13 +4519,13 @@
       </p:sp>
       <p:sp>
         <p:nvSpPr>
-          <p:cNvPr id="13" name="Text 10"/>
+          <p:cNvPr id="18" name="Text 14"/>
           <p:cNvSpPr txBox="1"/>
           <p:nvPr/>
         </p:nvSpPr>
         <p:spPr>
           <a:xfrm>
-            <a:off x="3395472" y="1508760"/>
+            <a:off x="6217920" y="1435608"/>
             <a:ext cx="274320" cy="274320"/>
           </a:xfrm>
           <a:prstGeom prst="rect">
@@ -4364,14 +4558,14 @@
       </p:sp>
       <p:sp>
         <p:nvSpPr>
-          <p:cNvPr id="14" name="Text 11"/>
+          <p:cNvPr id="19" name="Text 15"/>
           <p:cNvSpPr txBox="1"/>
           <p:nvPr/>
         </p:nvSpPr>
         <p:spPr>
           <a:xfrm>
-            <a:off x="3395472" y="1929384"/>
-            <a:ext cx="2353056" cy="274320"/>
+            <a:off x="6583680" y="1408176"/>
+            <a:ext cx="2011680" cy="292608"/>
           </a:xfrm>
           <a:prstGeom prst="rect">
             <a:avLst/>
@@ -4380,14 +4574,14 @@
           <a:ln/>
         </p:spPr>
         <p:txBody>
-          <a:bodyPr wrap="square" lIns="0" tIns="0" rIns="0" bIns="0" rtlCol="0" anchor="t"/>
+          <a:bodyPr wrap="square" lIns="0" tIns="0" rIns="0" bIns="0" rtlCol="0" anchor="ctr"/>
           <a:lstStyle/>
           <a:p>
             <a:pPr indent="0" marL="0">
               <a:buNone/>
             </a:pPr>
             <a:r>
-              <a:rPr lang="en-US" sz="1200" b="1" dirty="0">
+              <a:rPr lang="en-US" sz="1150" b="1" dirty="0">
                 <a:solidFill>
                   <a:srgbClr val="1D1D1F"/>
                 </a:solidFill>
@@ -4395,22 +4589,22 @@
                 <a:ea typeface="SF Pro Display" pitchFamily="34" charset="-122"/>
                 <a:cs typeface="SF Pro Display" pitchFamily="34" charset="-120"/>
               </a:rPr>
-              <a:t>Verify, then own it</a:t>
-            </a:r>
-            <a:endParaRPr lang="en-US" sz="1200" dirty="0"/>
-          </a:p>
-        </p:txBody>
-      </p:sp>
-      <p:sp>
-        <p:nvSpPr>
-          <p:cNvPr id="15" name="Text 12"/>
+              <a:t>Promise or estimate?</a:t>
+            </a:r>
+            <a:endParaRPr lang="en-US" sz="1150" dirty="0"/>
+          </a:p>
+        </p:txBody>
+      </p:sp>
+      <p:sp>
+        <p:nvSpPr>
+          <p:cNvPr id="20" name="Text 16"/>
           <p:cNvSpPr txBox="1"/>
           <p:nvPr/>
         </p:nvSpPr>
         <p:spPr>
           <a:xfrm>
-            <a:off x="3395472" y="2221992"/>
-            <a:ext cx="2353056" cy="612648"/>
+            <a:off x="6583680" y="1719072"/>
+            <a:ext cx="2011680" cy="301752"/>
           </a:xfrm>
           <a:prstGeom prst="rect">
             <a:avLst/>
@@ -4434,7 +4628,7 @@
                 <a:ea typeface="SF Pro Text" pitchFamily="34" charset="-122"/>
                 <a:cs typeface="SF Pro Text" pitchFamily="34" charset="-120"/>
               </a:rPr>
-              <a:t>Check the recording. Call it our error.</a:t>
+              <a:t>"At" is a guarantee. "Around" is an estimate.</a:t>
             </a:r>
             <a:endParaRPr lang="en-US" sz="950" dirty="0"/>
           </a:p>
@@ -4442,18 +4636,18 @@
       </p:sp>
       <p:sp>
         <p:nvSpPr>
-          <p:cNvPr id="16" name="Shape 13"/>
+          <p:cNvPr id="21" name="Shape 17"/>
           <p:cNvSpPr/>
           <p:nvPr/>
         </p:nvSpPr>
         <p:spPr>
           <a:xfrm>
-            <a:off x="6050280" y="1325880"/>
-            <a:ext cx="2682240" cy="1600200"/>
+            <a:off x="3291840" y="2212848"/>
+            <a:ext cx="2651760" cy="777240"/>
           </a:xfrm>
           <a:prstGeom prst="roundRect">
             <a:avLst>
-              <a:gd name="adj" fmla="val 4571"/>
+              <a:gd name="adj" fmla="val 9412"/>
             </a:avLst>
           </a:prstGeom>
           <a:solidFill>
@@ -4469,13 +4663,13 @@
       </p:sp>
       <p:sp>
         <p:nvSpPr>
-          <p:cNvPr id="17" name="Shape 14"/>
+          <p:cNvPr id="22" name="Shape 18"/>
           <p:cNvSpPr/>
           <p:nvPr/>
         </p:nvSpPr>
         <p:spPr>
           <a:xfrm>
-            <a:off x="6214872" y="1508760"/>
+            <a:off x="3429000" y="2350008"/>
             <a:ext cx="274320" cy="274320"/>
           </a:xfrm>
           <a:prstGeom prst="ellipse">
@@ -4494,13 +4688,13 @@
       </p:sp>
       <p:sp>
         <p:nvSpPr>
-          <p:cNvPr id="18" name="Text 15"/>
+          <p:cNvPr id="23" name="Text 19"/>
           <p:cNvSpPr txBox="1"/>
           <p:nvPr/>
         </p:nvSpPr>
         <p:spPr>
           <a:xfrm>
-            <a:off x="6214872" y="1508760"/>
+            <a:off x="3429000" y="2350008"/>
             <a:ext cx="274320" cy="274320"/>
           </a:xfrm>
           <a:prstGeom prst="rect">
@@ -4533,14 +4727,14 @@
       </p:sp>
       <p:sp>
         <p:nvSpPr>
-          <p:cNvPr id="19" name="Text 16"/>
+          <p:cNvPr id="24" name="Text 20"/>
           <p:cNvSpPr txBox="1"/>
           <p:nvPr/>
         </p:nvSpPr>
         <p:spPr>
           <a:xfrm>
-            <a:off x="6214872" y="1929384"/>
-            <a:ext cx="2353056" cy="274320"/>
+            <a:off x="3794760" y="2322576"/>
+            <a:ext cx="2011680" cy="292608"/>
           </a:xfrm>
           <a:prstGeom prst="rect">
             <a:avLst/>
@@ -4549,14 +4743,14 @@
           <a:ln/>
         </p:spPr>
         <p:txBody>
-          <a:bodyPr wrap="square" lIns="0" tIns="0" rIns="0" bIns="0" rtlCol="0" anchor="t"/>
+          <a:bodyPr wrap="square" lIns="0" tIns="0" rIns="0" bIns="0" rtlCol="0" anchor="ctr"/>
           <a:lstStyle/>
           <a:p>
             <a:pPr indent="0" marL="0">
               <a:buNone/>
             </a:pPr>
             <a:r>
-              <a:rPr lang="en-US" sz="1200" b="1" dirty="0">
+              <a:rPr lang="en-US" sz="1150" b="1" dirty="0">
                 <a:solidFill>
                   <a:srgbClr val="1D1D1F"/>
                 </a:solidFill>
@@ -4564,22 +4758,22 @@
                 <a:ea typeface="SF Pro Display" pitchFamily="34" charset="-122"/>
                 <a:cs typeface="SF Pro Display" pitchFamily="34" charset="-120"/>
               </a:rPr>
-              <a:t>Fix, then one offer</a:t>
-            </a:r>
-            <a:endParaRPr lang="en-US" sz="1200" dirty="0"/>
-          </a:p>
-        </p:txBody>
-      </p:sp>
-      <p:sp>
-        <p:nvSpPr>
-          <p:cNvPr id="20" name="Text 17"/>
+              <a:t>Verify it</a:t>
+            </a:r>
+            <a:endParaRPr lang="en-US" sz="1150" dirty="0"/>
+          </a:p>
+        </p:txBody>
+      </p:sp>
+      <p:sp>
+        <p:nvSpPr>
+          <p:cNvPr id="25" name="Text 21"/>
           <p:cNvSpPr txBox="1"/>
           <p:nvPr/>
         </p:nvSpPr>
         <p:spPr>
           <a:xfrm>
-            <a:off x="6214872" y="2221992"/>
-            <a:ext cx="2353056" cy="612648"/>
+            <a:off x="3794760" y="2633472"/>
+            <a:ext cx="2011680" cy="301752"/>
           </a:xfrm>
           <a:prstGeom prst="rect">
             <a:avLst/>
@@ -4603,7 +4797,7 @@
                 <a:ea typeface="SF Pro Text" pitchFamily="34" charset="-122"/>
                 <a:cs typeface="SF Pro Text" pitchFamily="34" charset="-120"/>
               </a:rPr>
-              <a:t>Refund overpayment. One light offer, else waive ETF.</a:t>
+              <a:t>Sales call review? Note, then Waiting on CSQ.</a:t>
             </a:r>
             <a:endParaRPr lang="en-US" sz="950" dirty="0"/>
           </a:p>
@@ -4611,7 +4805,176 @@
       </p:sp>
       <p:sp>
         <p:nvSpPr>
-          <p:cNvPr id="21" name="Shape 18"/>
+          <p:cNvPr id="26" name="Shape 22"/>
+          <p:cNvSpPr/>
+          <p:nvPr/>
+        </p:nvSpPr>
+        <p:spPr>
+          <a:xfrm>
+            <a:off x="6080760" y="2212848"/>
+            <a:ext cx="2651760" cy="777240"/>
+          </a:xfrm>
+          <a:prstGeom prst="roundRect">
+            <a:avLst>
+              <a:gd name="adj" fmla="val 9412"/>
+            </a:avLst>
+          </a:prstGeom>
+          <a:solidFill>
+            <a:srgbClr val="FFFFFF"/>
+          </a:solidFill>
+          <a:ln w="9525">
+            <a:solidFill>
+              <a:srgbClr val="DCE1E7"/>
+            </a:solidFill>
+            <a:prstDash val="solid"/>
+          </a:ln>
+        </p:spPr>
+      </p:sp>
+      <p:sp>
+        <p:nvSpPr>
+          <p:cNvPr id="27" name="Shape 23"/>
+          <p:cNvSpPr/>
+          <p:nvPr/>
+        </p:nvSpPr>
+        <p:spPr>
+          <a:xfrm>
+            <a:off x="6217920" y="2350008"/>
+            <a:ext cx="274320" cy="274320"/>
+          </a:xfrm>
+          <a:prstGeom prst="ellipse">
+            <a:avLst/>
+          </a:prstGeom>
+          <a:solidFill>
+            <a:srgbClr val="E3F4F1"/>
+          </a:solidFill>
+          <a:ln w="12700">
+            <a:solidFill>
+              <a:srgbClr val="E3F4F1"/>
+            </a:solidFill>
+            <a:prstDash val="solid"/>
+          </a:ln>
+        </p:spPr>
+      </p:sp>
+      <p:sp>
+        <p:nvSpPr>
+          <p:cNvPr id="28" name="Text 24"/>
+          <p:cNvSpPr txBox="1"/>
+          <p:nvPr/>
+        </p:nvSpPr>
+        <p:spPr>
+          <a:xfrm>
+            <a:off x="6217920" y="2350008"/>
+            <a:ext cx="274320" cy="274320"/>
+          </a:xfrm>
+          <a:prstGeom prst="rect">
+            <a:avLst/>
+          </a:prstGeom>
+          <a:noFill/>
+          <a:ln/>
+        </p:spPr>
+        <p:txBody>
+          <a:bodyPr wrap="square" lIns="0" tIns="0" rIns="0" bIns="0" rtlCol="0" anchor="ctr"/>
+          <a:lstStyle/>
+          <a:p>
+            <a:pPr algn="ctr" indent="0" marL="0">
+              <a:buNone/>
+            </a:pPr>
+            <a:r>
+              <a:rPr lang="en-US" sz="900" b="1" dirty="0">
+                <a:solidFill>
+                  <a:srgbClr val="0B7A6F"/>
+                </a:solidFill>
+                <a:latin typeface="SF Pro Display" pitchFamily="34" charset="0"/>
+                <a:ea typeface="SF Pro Display" pitchFamily="34" charset="-122"/>
+                <a:cs typeface="SF Pro Display" pitchFamily="34" charset="-120"/>
+              </a:rPr>
+              <a:t>4</a:t>
+            </a:r>
+            <a:endParaRPr lang="en-US" sz="900" dirty="0"/>
+          </a:p>
+        </p:txBody>
+      </p:sp>
+      <p:sp>
+        <p:nvSpPr>
+          <p:cNvPr id="29" name="Text 25"/>
+          <p:cNvSpPr txBox="1"/>
+          <p:nvPr/>
+        </p:nvSpPr>
+        <p:spPr>
+          <a:xfrm>
+            <a:off x="6583680" y="2322576"/>
+            <a:ext cx="2011680" cy="292608"/>
+          </a:xfrm>
+          <a:prstGeom prst="rect">
+            <a:avLst/>
+          </a:prstGeom>
+          <a:noFill/>
+          <a:ln/>
+        </p:spPr>
+        <p:txBody>
+          <a:bodyPr wrap="square" lIns="0" tIns="0" rIns="0" bIns="0" rtlCol="0" anchor="ctr"/>
+          <a:lstStyle/>
+          <a:p>
+            <a:pPr indent="0" marL="0">
+              <a:buNone/>
+            </a:pPr>
+            <a:r>
+              <a:rPr lang="en-US" sz="1150" b="1" dirty="0">
+                <a:solidFill>
+                  <a:srgbClr val="1D1D1F"/>
+                </a:solidFill>
+                <a:latin typeface="SF Pro Display" pitchFamily="34" charset="0"/>
+                <a:ea typeface="SF Pro Display" pitchFamily="34" charset="-122"/>
+                <a:cs typeface="SF Pro Display" pitchFamily="34" charset="-120"/>
+              </a:rPr>
+              <a:t>What's the fix?</a:t>
+            </a:r>
+            <a:endParaRPr lang="en-US" sz="1150" dirty="0"/>
+          </a:p>
+        </p:txBody>
+      </p:sp>
+      <p:sp>
+        <p:nvSpPr>
+          <p:cNvPr id="30" name="Text 26"/>
+          <p:cNvSpPr txBox="1"/>
+          <p:nvPr/>
+        </p:nvSpPr>
+        <p:spPr>
+          <a:xfrm>
+            <a:off x="6583680" y="2633472"/>
+            <a:ext cx="2011680" cy="301752"/>
+          </a:xfrm>
+          <a:prstGeom prst="rect">
+            <a:avLst/>
+          </a:prstGeom>
+          <a:noFill/>
+          <a:ln/>
+        </p:spPr>
+        <p:txBody>
+          <a:bodyPr wrap="square" lIns="0" tIns="0" rIns="0" bIns="0" rtlCol="0" anchor="t"/>
+          <a:lstStyle/>
+          <a:p>
+            <a:pPr indent="0" marL="0">
+              <a:buNone/>
+            </a:pPr>
+            <a:r>
+              <a:rPr lang="en-US" sz="950" dirty="0">
+                <a:solidFill>
+                  <a:srgbClr val="6E6E73"/>
+                </a:solidFill>
+                <a:latin typeface="SF Pro Text" pitchFamily="34" charset="0"/>
+                <a:ea typeface="SF Pro Text" pitchFamily="34" charset="-122"/>
+                <a:cs typeface="SF Pro Text" pitchFamily="34" charset="-120"/>
+              </a:rPr>
+              <a:t>Steps 2–6, and which macro?</a:t>
+            </a:r>
+            <a:endParaRPr lang="en-US" sz="950" dirty="0"/>
+          </a:p>
+        </p:txBody>
+      </p:sp>
+      <p:sp>
+        <p:nvSpPr>
+          <p:cNvPr id="31" name="Shape 27"/>
           <p:cNvSpPr/>
           <p:nvPr/>
         </p:nvSpPr>
@@ -4638,14 +5001,14 @@
       </p:sp>
       <p:pic>
         <p:nvPicPr>
-          <p:cNvPr id="22" name="Image 0" descr="preencoded.png">    </p:cNvPr>
+          <p:cNvPr id="32" name="Image 1" descr="preencoded.png">    </p:cNvPr>
           <p:cNvPicPr>
             <a:picLocks noChangeAspect="1"/>
           </p:cNvPicPr>
           <p:nvPr/>
         </p:nvPicPr>
         <p:blipFill>
-          <a:blip r:embed="rId1"/>
+          <a:blip r:embed="rId2"/>
           <a:stretch>
             <a:fillRect/>
           </a:stretch>
@@ -4662,7 +5025,7 @@
       </p:pic>
       <p:sp>
         <p:nvSpPr>
-          <p:cNvPr id="23" name="Text 19"/>
+          <p:cNvPr id="33" name="Text 28"/>
           <p:cNvSpPr txBox="1"/>
           <p:nvPr/>
         </p:nvSpPr>
@@ -29583,7 +29946,7 @@
                 <a:ea typeface="SF Pro Display" pitchFamily="34" charset="-122"/>
                 <a:cs typeface="SF Pro Display" pitchFamily="34" charset="-120"/>
               </a:rPr>
-              <a:t>Knowledge check</a:t>
+              <a:t>Quick check</a:t>
             </a:r>
             <a:endParaRPr lang="en-US" sz="2400" dirty="0"/>
           </a:p>

</xml_diff>

<commit_message>
Incorrect Info deck: practice slide in the Let's practice layout
Co-Authored-By: Claude Opus 5.5 <noreply@anthropic.com>
Claude-Session: https://claude.ai/code/session_01FEzv8wwqWDgTsXP8Yz6XYn
</commit_message>
<xml_diff>
--- a/incorrect-info-lmc-lockout/incorrect-info-lmc-lockout.pptx
+++ b/incorrect-info-lmc-lockout/incorrect-info-lmc-lockout.pptx
@@ -618,7 +618,7 @@
           <a:p>
             <a:r>
               <a:rPr lang="en-US" dirty="0"/>
-              <a:t>TRAINER: share a live Incorrect Information ticket (type the ticket ID on the slide, or share your screen). Give trainees a few minutes to investigate on their own, then walk through it together using the four prompts: 1) What was said? Find the exact words the customer says they were told, and by whom (Sales, an agent, the website). 2) Promise or estimate? "At $23/hour" is a guarantee; "around" or "starting at" is an estimate. Was a fee simply never mentioned, or was a specific total promised? 3) Verify: would this need a Sales call review? Walk through the request, the internal note with the escalation link, and setting the status to Waiting on CSQ. 4) What's the fix? If verified: refund the gap, own the error, correct it, one light offer; declined or not retainable: waive the ETF and cancel the FC. Which macro? Then open the floor for questions on Incorrect Information Provided.</a:t>
+              <a:t>TRAINER: share a live Incorrect Information ticket. Give trainees a few minutes to review it on their own, then work through it together. 1) Is there verified misinformation? What exactly was said, and by whom? "At $23/hour" is a guarantee; "around" or "starting at" is an estimate. Would this need a Sales call review (request, internal note with the escalation link, status Waiting on CSQ)? 2) What was the misinformation, and how do we correct it? Refund the gap, own the error, correct the charges or expectations, one light offer; declined or not retainable: waive the ETF and cancel the FC. Which macro? 3) 5-minute writing challenge: each trainee writes the comms they would send the customer. Read a few aloud and compare. Then open the floor for questions on Incorrect Information Provided.</a:t>
             </a:r>
             <a:endParaRPr lang="en-US" dirty="0"/>
           </a:p>
@@ -4018,7 +4018,7 @@
                 <a:ea typeface="SF Pro Display" pitchFamily="34" charset="-122"/>
                 <a:cs typeface="SF Pro Display" pitchFamily="34" charset="-120"/>
               </a:rPr>
-              <a:t>INCORRECT INFORMATION  ·  WRAP-UP</a:t>
+              <a:t>INCORRECT INFORMATION  ·  PRACTICE</a:t>
             </a:r>
             <a:endParaRPr lang="en-US" sz="800" dirty="0"/>
           </a:p>
@@ -4057,7 +4057,7 @@
                 <a:ea typeface="SF Pro Display" pitchFamily="34" charset="-122"/>
                 <a:cs typeface="SF Pro Display" pitchFamily="34" charset="-120"/>
               </a:rPr>
-              <a:t>Investigate a live ticket</a:t>
+              <a:t>Let's investigate together!</a:t>
             </a:r>
             <a:endParaRPr lang="en-US" sz="2400" dirty="0"/>
           </a:p>
@@ -4096,7 +4096,7 @@
                 <a:ea typeface="SF Pro Text" pitchFamily="34" charset="-122"/>
                 <a:cs typeface="SF Pro Text" pitchFamily="34" charset="-120"/>
               </a:rPr>
-              <a:t>Your trainer shares a real ticket. Work it through the process.</a:t>
+              <a:t>Review the live ticket and investigate.</a:t>
             </a:r>
             <a:endParaRPr lang="en-US" sz="1200" dirty="0"/>
           </a:p>
@@ -4111,205 +4111,11 @@
         <p:spPr>
           <a:xfrm>
             <a:off x="411480" y="1298448"/>
-            <a:ext cx="2743200" cy="1691640"/>
+            <a:ext cx="3383280" cy="2633472"/>
           </a:xfrm>
           <a:prstGeom prst="roundRect">
             <a:avLst>
-              <a:gd name="adj" fmla="val 4324"/>
-            </a:avLst>
-          </a:prstGeom>
-          <a:solidFill>
-            <a:srgbClr val="E3F4F1"/>
-          </a:solidFill>
-          <a:ln w="15875">
-            <a:solidFill>
-              <a:srgbClr val="0B7A6F"/>
-            </a:solidFill>
-            <a:prstDash val="dash"/>
-          </a:ln>
-        </p:spPr>
-      </p:sp>
-      <p:sp>
-        <p:nvSpPr>
-          <p:cNvPr id="7" name="Shape 4"/>
-          <p:cNvSpPr/>
-          <p:nvPr/>
-        </p:nvSpPr>
-        <p:spPr>
-          <a:xfrm>
-            <a:off x="594360" y="1481328"/>
-            <a:ext cx="384048" cy="384048"/>
-          </a:xfrm>
-          <a:prstGeom prst="ellipse">
-            <a:avLst/>
-          </a:prstGeom>
-          <a:solidFill>
-            <a:srgbClr val="FFFFFF"/>
-          </a:solidFill>
-          <a:ln w="12700">
-            <a:solidFill>
-              <a:srgbClr val="FFFFFF"/>
-            </a:solidFill>
-            <a:prstDash val="solid"/>
-          </a:ln>
-        </p:spPr>
-      </p:sp>
-      <p:pic>
-        <p:nvPicPr>
-          <p:cNvPr id="8" name="Image 0" descr="preencoded.png">    </p:cNvPr>
-          <p:cNvPicPr>
-            <a:picLocks noChangeAspect="1"/>
-          </p:cNvPicPr>
-          <p:nvPr/>
-        </p:nvPicPr>
-        <p:blipFill>
-          <a:blip r:embed="rId1"/>
-          <a:stretch>
-            <a:fillRect/>
-          </a:stretch>
-        </p:blipFill>
-        <p:spPr>
-          <a:xfrm>
-            <a:off x="686532" y="1573500"/>
-            <a:ext cx="199705" cy="199705"/>
-          </a:xfrm>
-          <a:prstGeom prst="rect">
-            <a:avLst/>
-          </a:prstGeom>
-        </p:spPr>
-      </p:pic>
-      <p:sp>
-        <p:nvSpPr>
-          <p:cNvPr id="9" name="Text 5"/>
-          <p:cNvSpPr txBox="1"/>
-          <p:nvPr/>
-        </p:nvSpPr>
-        <p:spPr>
-          <a:xfrm>
-            <a:off x="1097280" y="1481328"/>
-            <a:ext cx="1920240" cy="384048"/>
-          </a:xfrm>
-          <a:prstGeom prst="rect">
-            <a:avLst/>
-          </a:prstGeom>
-          <a:noFill/>
-          <a:ln/>
-        </p:spPr>
-        <p:txBody>
-          <a:bodyPr wrap="square" lIns="0" tIns="0" rIns="0" bIns="0" rtlCol="0" anchor="ctr"/>
-          <a:lstStyle/>
-          <a:p>
-            <a:pPr indent="0" marL="0">
-              <a:buNone/>
-            </a:pPr>
-            <a:r>
-              <a:rPr lang="en-US" sz="1300" b="1" dirty="0">
-                <a:solidFill>
-                  <a:srgbClr val="0B7A6F"/>
-                </a:solidFill>
-                <a:latin typeface="SF Pro Display" pitchFamily="34" charset="0"/>
-                <a:ea typeface="SF Pro Display" pitchFamily="34" charset="-122"/>
-                <a:cs typeface="SF Pro Display" pitchFamily="34" charset="-120"/>
-              </a:rPr>
-              <a:t>Today's ticket</a:t>
-            </a:r>
-            <a:endParaRPr lang="en-US" sz="1300" dirty="0"/>
-          </a:p>
-        </p:txBody>
-      </p:sp>
-      <p:sp>
-        <p:nvSpPr>
-          <p:cNvPr id="10" name="Text 6"/>
-          <p:cNvSpPr txBox="1"/>
-          <p:nvPr/>
-        </p:nvSpPr>
-        <p:spPr>
-          <a:xfrm>
-            <a:off x="594360" y="2075688"/>
-            <a:ext cx="2377440" cy="731520"/>
-          </a:xfrm>
-          <a:prstGeom prst="rect">
-            <a:avLst/>
-          </a:prstGeom>
-          <a:noFill/>
-          <a:ln/>
-        </p:spPr>
-        <p:txBody>
-          <a:bodyPr wrap="square" lIns="0" tIns="0" rIns="0" bIns="0" rtlCol="0" anchor="t"/>
-          <a:lstStyle/>
-          <a:p>
-            <a:pPr indent="0" marL="0">
-              <a:spcAft>
-                <a:spcPts val="600"/>
-              </a:spcAft>
-              <a:buNone/>
-            </a:pPr>
-            <a:r>
-              <a:rPr lang="en-US" sz="1100" b="1" dirty="0">
-                <a:solidFill>
-                  <a:srgbClr val="1D1D1F"/>
-                </a:solidFill>
-                <a:latin typeface="SF Pro Text" pitchFamily="34" charset="0"/>
-                <a:ea typeface="SF Pro Text" pitchFamily="34" charset="-122"/>
-                <a:cs typeface="SF Pro Text" pitchFamily="34" charset="-120"/>
-              </a:rPr>
-              <a:t>Ticket ID:  </a:t>
-            </a:r>
-            <a:pPr indent="0" marL="0">
-              <a:spcAft>
-                <a:spcPts val="600"/>
-              </a:spcAft>
-              <a:buNone/>
-            </a:pPr>
-            <a:r>
-              <a:rPr lang="en-US" sz="1100" dirty="0">
-                <a:solidFill>
-                  <a:srgbClr val="6E6E73"/>
-                </a:solidFill>
-                <a:latin typeface="SF Pro Text" pitchFamily="34" charset="0"/>
-                <a:ea typeface="SF Pro Text" pitchFamily="34" charset="-122"/>
-                <a:cs typeface="SF Pro Text" pitchFamily="34" charset="-120"/>
-              </a:rPr>
-              <a:t>__________</a:t>
-            </a:r>
-            <a:endParaRPr lang="en-US" sz="1100" dirty="0"/>
-          </a:p>
-          <a:p>
-            <a:pPr indent="0" marL="0">
-              <a:spcAft>
-                <a:spcPts val="600"/>
-              </a:spcAft>
-              <a:buNone/>
-            </a:pPr>
-            <a:r>
-              <a:rPr lang="en-US" sz="900" i="1" dirty="0">
-                <a:solidFill>
-                  <a:srgbClr val="6E6E73"/>
-                </a:solidFill>
-                <a:latin typeface="SF Pro Text" pitchFamily="34" charset="0"/>
-                <a:ea typeface="SF Pro Text" pitchFamily="34" charset="-122"/>
-                <a:cs typeface="SF Pro Text" pitchFamily="34" charset="-120"/>
-              </a:rPr>
-              <a:t>Provided by your trainer</a:t>
-            </a:r>
-            <a:endParaRPr lang="en-US" sz="1100" dirty="0"/>
-          </a:p>
-        </p:txBody>
-      </p:sp>
-      <p:sp>
-        <p:nvSpPr>
-          <p:cNvPr id="11" name="Shape 7"/>
-          <p:cNvSpPr/>
-          <p:nvPr/>
-        </p:nvSpPr>
-        <p:spPr>
-          <a:xfrm>
-            <a:off x="3291840" y="1298448"/>
-            <a:ext cx="2651760" cy="777240"/>
-          </a:xfrm>
-          <a:prstGeom prst="roundRect">
-            <a:avLst>
-              <a:gd name="adj" fmla="val 9412"/>
+              <a:gd name="adj" fmla="val 2778"/>
             </a:avLst>
           </a:prstGeom>
           <a:solidFill>
@@ -4325,14 +4131,14 @@
       </p:sp>
       <p:sp>
         <p:nvSpPr>
-          <p:cNvPr id="12" name="Shape 8"/>
+          <p:cNvPr id="7" name="Shape 4"/>
           <p:cNvSpPr/>
           <p:nvPr/>
         </p:nvSpPr>
         <p:spPr>
           <a:xfrm>
-            <a:off x="3429000" y="1435608"/>
-            <a:ext cx="274320" cy="274320"/>
+            <a:off x="594360" y="1481328"/>
+            <a:ext cx="384048" cy="384048"/>
           </a:xfrm>
           <a:prstGeom prst="ellipse">
             <a:avLst/>
@@ -4348,16 +4154,40 @@
           </a:ln>
         </p:spPr>
       </p:sp>
-      <p:sp>
-        <p:nvSpPr>
-          <p:cNvPr id="13" name="Text 9"/>
+      <p:pic>
+        <p:nvPicPr>
+          <p:cNvPr id="8" name="Image 0" descr="preencoded.png">    </p:cNvPr>
+          <p:cNvPicPr>
+            <a:picLocks noChangeAspect="1"/>
+          </p:cNvPicPr>
+          <p:nvPr/>
+        </p:nvPicPr>
+        <p:blipFill>
+          <a:blip r:embed="rId1"/>
+          <a:stretch>
+            <a:fillRect/>
+          </a:stretch>
+        </p:blipFill>
+        <p:spPr>
+          <a:xfrm>
+            <a:off x="686532" y="1573500"/>
+            <a:ext cx="199705" cy="199705"/>
+          </a:xfrm>
+          <a:prstGeom prst="rect">
+            <a:avLst/>
+          </a:prstGeom>
+        </p:spPr>
+      </p:pic>
+      <p:sp>
+        <p:nvSpPr>
+          <p:cNvPr id="9" name="Text 5"/>
           <p:cNvSpPr txBox="1"/>
           <p:nvPr/>
         </p:nvSpPr>
         <p:spPr>
           <a:xfrm>
-            <a:off x="3429000" y="1435608"/>
-            <a:ext cx="274320" cy="274320"/>
+            <a:off x="594360" y="2011680"/>
+            <a:ext cx="3017520" cy="292608"/>
           </a:xfrm>
           <a:prstGeom prst="rect">
             <a:avLst/>
@@ -4366,37 +4196,37 @@
           <a:ln/>
         </p:spPr>
         <p:txBody>
-          <a:bodyPr wrap="square" lIns="0" tIns="0" rIns="0" bIns="0" rtlCol="0" anchor="ctr"/>
-          <a:lstStyle/>
-          <a:p>
-            <a:pPr algn="ctr" indent="0" marL="0">
-              <a:buNone/>
-            </a:pPr>
-            <a:r>
-              <a:rPr lang="en-US" sz="900" b="1" dirty="0">
-                <a:solidFill>
-                  <a:srgbClr val="0B7A6F"/>
+          <a:bodyPr wrap="square" lIns="0" tIns="0" rIns="0" bIns="0" rtlCol="0" anchor="t"/>
+          <a:lstStyle/>
+          <a:p>
+            <a:pPr indent="0" marL="0">
+              <a:buNone/>
+            </a:pPr>
+            <a:r>
+              <a:rPr lang="en-US" sz="1300" b="1" dirty="0">
+                <a:solidFill>
+                  <a:srgbClr val="1D1D1F"/>
                 </a:solidFill>
                 <a:latin typeface="SF Pro Display" pitchFamily="34" charset="0"/>
                 <a:ea typeface="SF Pro Display" pitchFamily="34" charset="-122"/>
                 <a:cs typeface="SF Pro Display" pitchFamily="34" charset="-120"/>
               </a:rPr>
-              <a:t>1</a:t>
-            </a:r>
-            <a:endParaRPr lang="en-US" sz="900" dirty="0"/>
-          </a:p>
-        </p:txBody>
-      </p:sp>
-      <p:sp>
-        <p:nvSpPr>
-          <p:cNvPr id="14" name="Text 10"/>
+              <a:t>Live ticket</a:t>
+            </a:r>
+            <a:endParaRPr lang="en-US" sz="1300" dirty="0"/>
+          </a:p>
+        </p:txBody>
+      </p:sp>
+      <p:sp>
+        <p:nvSpPr>
+          <p:cNvPr id="10" name="Text 6"/>
           <p:cNvSpPr txBox="1"/>
           <p:nvPr/>
         </p:nvSpPr>
         <p:spPr>
           <a:xfrm>
-            <a:off x="3794760" y="1408176"/>
-            <a:ext cx="2011680" cy="292608"/>
+            <a:off x="594360" y="2350008"/>
+            <a:ext cx="3017520" cy="731520"/>
           </a:xfrm>
           <a:prstGeom prst="rect">
             <a:avLst/>
@@ -4405,53 +4235,14 @@
           <a:ln/>
         </p:spPr>
         <p:txBody>
-          <a:bodyPr wrap="square" lIns="0" tIns="0" rIns="0" bIns="0" rtlCol="0" anchor="ctr"/>
+          <a:bodyPr wrap="square" lIns="0" tIns="0" rIns="0" bIns="0" rtlCol="0" anchor="t"/>
           <a:lstStyle/>
           <a:p>
             <a:pPr indent="0" marL="0">
               <a:buNone/>
             </a:pPr>
             <a:r>
-              <a:rPr lang="en-US" sz="1150" b="1" dirty="0">
-                <a:solidFill>
-                  <a:srgbClr val="1D1D1F"/>
-                </a:solidFill>
-                <a:latin typeface="SF Pro Display" pitchFamily="34" charset="0"/>
-                <a:ea typeface="SF Pro Display" pitchFamily="34" charset="-122"/>
-                <a:cs typeface="SF Pro Display" pitchFamily="34" charset="-120"/>
-              </a:rPr>
-              <a:t>What was said?</a:t>
-            </a:r>
-            <a:endParaRPr lang="en-US" sz="1150" dirty="0"/>
-          </a:p>
-        </p:txBody>
-      </p:sp>
-      <p:sp>
-        <p:nvSpPr>
-          <p:cNvPr id="15" name="Text 11"/>
-          <p:cNvSpPr txBox="1"/>
-          <p:nvPr/>
-        </p:nvSpPr>
-        <p:spPr>
-          <a:xfrm>
-            <a:off x="3794760" y="1719072"/>
-            <a:ext cx="2011680" cy="301752"/>
-          </a:xfrm>
-          <a:prstGeom prst="rect">
-            <a:avLst/>
-          </a:prstGeom>
-          <a:noFill/>
-          <a:ln/>
-        </p:spPr>
-        <p:txBody>
-          <a:bodyPr wrap="square" lIns="0" tIns="0" rIns="0" bIns="0" rtlCol="0" anchor="t"/>
-          <a:lstStyle/>
-          <a:p>
-            <a:pPr indent="0" marL="0">
-              <a:buNone/>
-            </a:pPr>
-            <a:r>
-              <a:rPr lang="en-US" sz="950" dirty="0">
+              <a:rPr lang="en-US" sz="1050" dirty="0">
                 <a:solidFill>
                   <a:srgbClr val="6E6E73"/>
                 </a:solidFill>
@@ -4459,26 +4250,73 @@
                 <a:ea typeface="SF Pro Text" pitchFamily="34" charset="-122"/>
                 <a:cs typeface="SF Pro Text" pitchFamily="34" charset="-120"/>
               </a:rPr>
-              <a:t>Find the exact words, and who said them.</a:t>
-            </a:r>
-            <a:endParaRPr lang="en-US" sz="950" dirty="0"/>
-          </a:p>
-        </p:txBody>
-      </p:sp>
-      <p:sp>
-        <p:nvSpPr>
-          <p:cNvPr id="16" name="Shape 12"/>
+              <a:t>Your trainer will provide a live ticket. Review it and investigate before you decide anything.</a:t>
+            </a:r>
+            <a:endParaRPr lang="en-US" sz="1050" dirty="0"/>
+          </a:p>
+        </p:txBody>
+      </p:sp>
+      <p:sp>
+        <p:nvSpPr>
+          <p:cNvPr id="11" name="Text 7"/>
           <p:cNvSpPr/>
           <p:nvPr/>
         </p:nvSpPr>
         <p:spPr>
           <a:xfrm>
-            <a:off x="6080760" y="1298448"/>
-            <a:ext cx="2651760" cy="777240"/>
+            <a:off x="594360" y="3401568"/>
+            <a:ext cx="1371600" cy="329184"/>
           </a:xfrm>
           <a:prstGeom prst="roundRect">
             <a:avLst>
-              <a:gd name="adj" fmla="val 9412"/>
+              <a:gd name="adj" fmla="val 22222"/>
+            </a:avLst>
+          </a:prstGeom>
+          <a:solidFill>
+            <a:srgbClr val="FFF3D6"/>
+          </a:solidFill>
+          <a:ln>
+            <a:solidFill>
+              <a:srgbClr val="FFF3D6"/>
+            </a:solidFill>
+          </a:ln>
+        </p:spPr>
+        <p:txBody>
+          <a:bodyPr wrap="square" lIns="0" tIns="0" rIns="0" bIns="0" rtlCol="0" anchor="ctr"/>
+          <a:lstStyle/>
+          <a:p>
+            <a:pPr algn="ctr" indent="0" marL="0">
+              <a:buNone/>
+            </a:pPr>
+            <a:r>
+              <a:rPr lang="en-US" sz="950" b="1" dirty="0">
+                <a:solidFill>
+                  <a:srgbClr val="9A6410"/>
+                </a:solidFill>
+                <a:latin typeface="SF Pro Text" pitchFamily="34" charset="0"/>
+                <a:ea typeface="SF Pro Text" pitchFamily="34" charset="-122"/>
+                <a:cs typeface="SF Pro Text" pitchFamily="34" charset="-120"/>
+              </a:rPr>
+              <a:t>Trainer provides</a:t>
+            </a:r>
+            <a:endParaRPr lang="en-US" sz="950" dirty="0"/>
+          </a:p>
+        </p:txBody>
+      </p:sp>
+      <p:sp>
+        <p:nvSpPr>
+          <p:cNvPr id="12" name="Shape 8"/>
+          <p:cNvSpPr/>
+          <p:nvPr/>
+        </p:nvSpPr>
+        <p:spPr>
+          <a:xfrm>
+            <a:off x="3931920" y="1298448"/>
+            <a:ext cx="4800600" cy="786384"/>
+          </a:xfrm>
+          <a:prstGeom prst="roundRect">
+            <a:avLst>
+              <a:gd name="adj" fmla="val 9302"/>
             </a:avLst>
           </a:prstGeom>
           <a:solidFill>
@@ -4494,13 +4332,13 @@
       </p:sp>
       <p:sp>
         <p:nvSpPr>
-          <p:cNvPr id="17" name="Shape 13"/>
+          <p:cNvPr id="13" name="Shape 9"/>
           <p:cNvSpPr/>
           <p:nvPr/>
         </p:nvSpPr>
         <p:spPr>
           <a:xfrm>
-            <a:off x="6217920" y="1435608"/>
+            <a:off x="4114800" y="1554480"/>
             <a:ext cx="274320" cy="274320"/>
           </a:xfrm>
           <a:prstGeom prst="ellipse">
@@ -4519,13 +4357,13 @@
       </p:sp>
       <p:sp>
         <p:nvSpPr>
-          <p:cNvPr id="18" name="Text 14"/>
+          <p:cNvPr id="14" name="Text 10"/>
           <p:cNvSpPr txBox="1"/>
           <p:nvPr/>
         </p:nvSpPr>
         <p:spPr>
           <a:xfrm>
-            <a:off x="6217920" y="1435608"/>
+            <a:off x="4114800" y="1554480"/>
             <a:ext cx="274320" cy="274320"/>
           </a:xfrm>
           <a:prstGeom prst="rect">
@@ -4550,7 +4388,7 @@
                 <a:ea typeface="SF Pro Display" pitchFamily="34" charset="-122"/>
                 <a:cs typeface="SF Pro Display" pitchFamily="34" charset="-120"/>
               </a:rPr>
-              <a:t>2</a:t>
+              <a:t>1</a:t>
             </a:r>
             <a:endParaRPr lang="en-US" sz="900" dirty="0"/>
           </a:p>
@@ -4558,14 +4396,14 @@
       </p:sp>
       <p:sp>
         <p:nvSpPr>
-          <p:cNvPr id="19" name="Text 15"/>
+          <p:cNvPr id="15" name="Text 11"/>
           <p:cNvSpPr txBox="1"/>
           <p:nvPr/>
         </p:nvSpPr>
         <p:spPr>
           <a:xfrm>
-            <a:off x="6583680" y="1408176"/>
-            <a:ext cx="2011680" cy="292608"/>
+            <a:off x="4572000" y="1426464"/>
+            <a:ext cx="3977640" cy="292608"/>
           </a:xfrm>
           <a:prstGeom prst="rect">
             <a:avLst/>
@@ -4581,7 +4419,7 @@
               <a:buNone/>
             </a:pPr>
             <a:r>
-              <a:rPr lang="en-US" sz="1150" b="1" dirty="0">
+              <a:rPr lang="en-US" sz="1250" b="1" dirty="0">
                 <a:solidFill>
                   <a:srgbClr val="1D1D1F"/>
                 </a:solidFill>
@@ -4589,22 +4427,22 @@
                 <a:ea typeface="SF Pro Display" pitchFamily="34" charset="-122"/>
                 <a:cs typeface="SF Pro Display" pitchFamily="34" charset="-120"/>
               </a:rPr>
-              <a:t>Promise or estimate?</a:t>
-            </a:r>
-            <a:endParaRPr lang="en-US" sz="1150" dirty="0"/>
-          </a:p>
-        </p:txBody>
-      </p:sp>
-      <p:sp>
-        <p:nvSpPr>
-          <p:cNvPr id="20" name="Text 16"/>
+              <a:t>Is there verified misinformation?</a:t>
+            </a:r>
+            <a:endParaRPr lang="en-US" sz="1250" dirty="0"/>
+          </a:p>
+        </p:txBody>
+      </p:sp>
+      <p:sp>
+        <p:nvSpPr>
+          <p:cNvPr id="16" name="Text 12"/>
           <p:cNvSpPr txBox="1"/>
           <p:nvPr/>
         </p:nvSpPr>
         <p:spPr>
           <a:xfrm>
-            <a:off x="6583680" y="1719072"/>
-            <a:ext cx="2011680" cy="301752"/>
+            <a:off x="4572000" y="1737360"/>
+            <a:ext cx="3977640" cy="256032"/>
           </a:xfrm>
           <a:prstGeom prst="rect">
             <a:avLst/>
@@ -4613,14 +4451,14 @@
           <a:ln/>
         </p:spPr>
         <p:txBody>
-          <a:bodyPr wrap="square" lIns="0" tIns="0" rIns="0" bIns="0" rtlCol="0" anchor="t"/>
+          <a:bodyPr wrap="square" lIns="0" tIns="0" rIns="0" bIns="0" rtlCol="0" anchor="ctr"/>
           <a:lstStyle/>
           <a:p>
             <a:pPr indent="0" marL="0">
               <a:buNone/>
             </a:pPr>
             <a:r>
-              <a:rPr lang="en-US" sz="950" dirty="0">
+              <a:rPr lang="en-US" sz="1000" dirty="0">
                 <a:solidFill>
                   <a:srgbClr val="6E6E73"/>
                 </a:solidFill>
@@ -4628,26 +4466,26 @@
                 <a:ea typeface="SF Pro Text" pitchFamily="34" charset="-122"/>
                 <a:cs typeface="SF Pro Text" pitchFamily="34" charset="-120"/>
               </a:rPr>
-              <a:t>"At" is a guarantee. "Around" is an estimate.</a:t>
-            </a:r>
-            <a:endParaRPr lang="en-US" sz="950" dirty="0"/>
-          </a:p>
-        </p:txBody>
-      </p:sp>
-      <p:sp>
-        <p:nvSpPr>
-          <p:cNvPr id="21" name="Shape 17"/>
+              <a:t>What exactly was said: a promise or an estimate?</a:t>
+            </a:r>
+            <a:endParaRPr lang="en-US" sz="1000" dirty="0"/>
+          </a:p>
+        </p:txBody>
+      </p:sp>
+      <p:sp>
+        <p:nvSpPr>
+          <p:cNvPr id="17" name="Shape 13"/>
           <p:cNvSpPr/>
           <p:nvPr/>
         </p:nvSpPr>
         <p:spPr>
           <a:xfrm>
-            <a:off x="3291840" y="2212848"/>
-            <a:ext cx="2651760" cy="777240"/>
+            <a:off x="3931920" y="2221992"/>
+            <a:ext cx="4800600" cy="786384"/>
           </a:xfrm>
           <a:prstGeom prst="roundRect">
             <a:avLst>
-              <a:gd name="adj" fmla="val 9412"/>
+              <a:gd name="adj" fmla="val 9302"/>
             </a:avLst>
           </a:prstGeom>
           <a:solidFill>
@@ -4663,13 +4501,13 @@
       </p:sp>
       <p:sp>
         <p:nvSpPr>
-          <p:cNvPr id="22" name="Shape 18"/>
+          <p:cNvPr id="18" name="Shape 14"/>
           <p:cNvSpPr/>
           <p:nvPr/>
         </p:nvSpPr>
         <p:spPr>
           <a:xfrm>
-            <a:off x="3429000" y="2350008"/>
+            <a:off x="4114800" y="2478024"/>
             <a:ext cx="274320" cy="274320"/>
           </a:xfrm>
           <a:prstGeom prst="ellipse">
@@ -4688,13 +4526,13 @@
       </p:sp>
       <p:sp>
         <p:nvSpPr>
-          <p:cNvPr id="23" name="Text 19"/>
+          <p:cNvPr id="19" name="Text 15"/>
           <p:cNvSpPr txBox="1"/>
           <p:nvPr/>
         </p:nvSpPr>
         <p:spPr>
           <a:xfrm>
-            <a:off x="3429000" y="2350008"/>
+            <a:off x="4114800" y="2478024"/>
             <a:ext cx="274320" cy="274320"/>
           </a:xfrm>
           <a:prstGeom prst="rect">
@@ -4719,7 +4557,7 @@
                 <a:ea typeface="SF Pro Display" pitchFamily="34" charset="-122"/>
                 <a:cs typeface="SF Pro Display" pitchFamily="34" charset="-120"/>
               </a:rPr>
-              <a:t>3</a:t>
+              <a:t>2</a:t>
             </a:r>
             <a:endParaRPr lang="en-US" sz="900" dirty="0"/>
           </a:p>
@@ -4727,14 +4565,14 @@
       </p:sp>
       <p:sp>
         <p:nvSpPr>
-          <p:cNvPr id="24" name="Text 20"/>
+          <p:cNvPr id="20" name="Text 16"/>
           <p:cNvSpPr txBox="1"/>
           <p:nvPr/>
         </p:nvSpPr>
         <p:spPr>
           <a:xfrm>
-            <a:off x="3794760" y="2322576"/>
-            <a:ext cx="2011680" cy="292608"/>
+            <a:off x="4572000" y="2350008"/>
+            <a:ext cx="3977640" cy="292608"/>
           </a:xfrm>
           <a:prstGeom prst="rect">
             <a:avLst/>
@@ -4750,7 +4588,7 @@
               <a:buNone/>
             </a:pPr>
             <a:r>
-              <a:rPr lang="en-US" sz="1150" b="1" dirty="0">
+              <a:rPr lang="en-US" sz="1250" b="1" dirty="0">
                 <a:solidFill>
                   <a:srgbClr val="1D1D1F"/>
                 </a:solidFill>
@@ -4758,22 +4596,22 @@
                 <a:ea typeface="SF Pro Display" pitchFamily="34" charset="-122"/>
                 <a:cs typeface="SF Pro Display" pitchFamily="34" charset="-120"/>
               </a:rPr>
-              <a:t>Verify it</a:t>
-            </a:r>
-            <a:endParaRPr lang="en-US" sz="1150" dirty="0"/>
-          </a:p>
-        </p:txBody>
-      </p:sp>
-      <p:sp>
-        <p:nvSpPr>
-          <p:cNvPr id="25" name="Text 21"/>
+              <a:t>What are those, and how do we correct them?</a:t>
+            </a:r>
+            <a:endParaRPr lang="en-US" sz="1250" dirty="0"/>
+          </a:p>
+        </p:txBody>
+      </p:sp>
+      <p:sp>
+        <p:nvSpPr>
+          <p:cNvPr id="21" name="Text 17"/>
           <p:cNvSpPr txBox="1"/>
           <p:nvPr/>
         </p:nvSpPr>
         <p:spPr>
           <a:xfrm>
-            <a:off x="3794760" y="2633472"/>
-            <a:ext cx="2011680" cy="301752"/>
+            <a:off x="4572000" y="2660904"/>
+            <a:ext cx="3977640" cy="256032"/>
           </a:xfrm>
           <a:prstGeom prst="rect">
             <a:avLst/>
@@ -4782,14 +4620,14 @@
           <a:ln/>
         </p:spPr>
         <p:txBody>
-          <a:bodyPr wrap="square" lIns="0" tIns="0" rIns="0" bIns="0" rtlCol="0" anchor="t"/>
+          <a:bodyPr wrap="square" lIns="0" tIns="0" rIns="0" bIns="0" rtlCol="0" anchor="ctr"/>
           <a:lstStyle/>
           <a:p>
             <a:pPr indent="0" marL="0">
               <a:buNone/>
             </a:pPr>
             <a:r>
-              <a:rPr lang="en-US" sz="950" dirty="0">
+              <a:rPr lang="en-US" sz="1000" dirty="0">
                 <a:solidFill>
                   <a:srgbClr val="6E6E73"/>
                 </a:solidFill>
@@ -4797,26 +4635,26 @@
                 <a:ea typeface="SF Pro Text" pitchFamily="34" charset="-122"/>
                 <a:cs typeface="SF Pro Text" pitchFamily="34" charset="-120"/>
               </a:rPr>
-              <a:t>Sales call review? Note, then Waiting on CSQ.</a:t>
-            </a:r>
-            <a:endParaRPr lang="en-US" sz="950" dirty="0"/>
-          </a:p>
-        </p:txBody>
-      </p:sp>
-      <p:sp>
-        <p:nvSpPr>
-          <p:cNvPr id="26" name="Shape 22"/>
+              <a:t>Refund the gap, own it, correct it, one light offer.</a:t>
+            </a:r>
+            <a:endParaRPr lang="en-US" sz="1000" dirty="0"/>
+          </a:p>
+        </p:txBody>
+      </p:sp>
+      <p:sp>
+        <p:nvSpPr>
+          <p:cNvPr id="22" name="Shape 18"/>
           <p:cNvSpPr/>
           <p:nvPr/>
         </p:nvSpPr>
         <p:spPr>
           <a:xfrm>
-            <a:off x="6080760" y="2212848"/>
-            <a:ext cx="2651760" cy="777240"/>
+            <a:off x="3931920" y="3145536"/>
+            <a:ext cx="4800600" cy="786384"/>
           </a:xfrm>
           <a:prstGeom prst="roundRect">
             <a:avLst>
-              <a:gd name="adj" fmla="val 9412"/>
+              <a:gd name="adj" fmla="val 9302"/>
             </a:avLst>
           </a:prstGeom>
           <a:solidFill>
@@ -4832,13 +4670,13 @@
       </p:sp>
       <p:sp>
         <p:nvSpPr>
-          <p:cNvPr id="27" name="Shape 23"/>
+          <p:cNvPr id="23" name="Shape 19"/>
           <p:cNvSpPr/>
           <p:nvPr/>
         </p:nvSpPr>
         <p:spPr>
           <a:xfrm>
-            <a:off x="6217920" y="2350008"/>
+            <a:off x="4114800" y="3401568"/>
             <a:ext cx="274320" cy="274320"/>
           </a:xfrm>
           <a:prstGeom prst="ellipse">
@@ -4857,13 +4695,13 @@
       </p:sp>
       <p:sp>
         <p:nvSpPr>
-          <p:cNvPr id="28" name="Text 24"/>
+          <p:cNvPr id="24" name="Text 20"/>
           <p:cNvSpPr txBox="1"/>
           <p:nvPr/>
         </p:nvSpPr>
         <p:spPr>
           <a:xfrm>
-            <a:off x="6217920" y="2350008"/>
+            <a:off x="4114800" y="3401568"/>
             <a:ext cx="274320" cy="274320"/>
           </a:xfrm>
           <a:prstGeom prst="rect">
@@ -4888,7 +4726,7 @@
                 <a:ea typeface="SF Pro Display" pitchFamily="34" charset="-122"/>
                 <a:cs typeface="SF Pro Display" pitchFamily="34" charset="-120"/>
               </a:rPr>
-              <a:t>4</a:t>
+              <a:t>3</a:t>
             </a:r>
             <a:endParaRPr lang="en-US" sz="900" dirty="0"/>
           </a:p>
@@ -4896,14 +4734,14 @@
       </p:sp>
       <p:sp>
         <p:nvSpPr>
-          <p:cNvPr id="29" name="Text 25"/>
+          <p:cNvPr id="25" name="Text 21"/>
           <p:cNvSpPr txBox="1"/>
           <p:nvPr/>
         </p:nvSpPr>
         <p:spPr>
           <a:xfrm>
-            <a:off x="6583680" y="2322576"/>
-            <a:ext cx="2011680" cy="292608"/>
+            <a:off x="4572000" y="3273552"/>
+            <a:ext cx="3977640" cy="292608"/>
           </a:xfrm>
           <a:prstGeom prst="rect">
             <a:avLst/>
@@ -4919,7 +4757,7 @@
               <a:buNone/>
             </a:pPr>
             <a:r>
-              <a:rPr lang="en-US" sz="1150" b="1" dirty="0">
+              <a:rPr lang="en-US" sz="1250" b="1" dirty="0">
                 <a:solidFill>
                   <a:srgbClr val="1D1D1F"/>
                 </a:solidFill>
@@ -4927,22 +4765,22 @@
                 <a:ea typeface="SF Pro Display" pitchFamily="34" charset="-122"/>
                 <a:cs typeface="SF Pro Display" pitchFamily="34" charset="-120"/>
               </a:rPr>
-              <a:t>What's the fix?</a:t>
-            </a:r>
-            <a:endParaRPr lang="en-US" sz="1150" dirty="0"/>
-          </a:p>
-        </p:txBody>
-      </p:sp>
-      <p:sp>
-        <p:nvSpPr>
-          <p:cNvPr id="30" name="Text 26"/>
+              <a:t>5-min writing challenge</a:t>
+            </a:r>
+            <a:endParaRPr lang="en-US" sz="1250" dirty="0"/>
+          </a:p>
+        </p:txBody>
+      </p:sp>
+      <p:sp>
+        <p:nvSpPr>
+          <p:cNvPr id="26" name="Text 22"/>
           <p:cNvSpPr txBox="1"/>
           <p:nvPr/>
         </p:nvSpPr>
         <p:spPr>
           <a:xfrm>
-            <a:off x="6583680" y="2633472"/>
-            <a:ext cx="2011680" cy="301752"/>
+            <a:off x="4572000" y="3584448"/>
+            <a:ext cx="3977640" cy="256032"/>
           </a:xfrm>
           <a:prstGeom prst="rect">
             <a:avLst/>
@@ -4951,14 +4789,14 @@
           <a:ln/>
         </p:spPr>
         <p:txBody>
-          <a:bodyPr wrap="square" lIns="0" tIns="0" rIns="0" bIns="0" rtlCol="0" anchor="t"/>
+          <a:bodyPr wrap="square" lIns="0" tIns="0" rIns="0" bIns="0" rtlCol="0" anchor="ctr"/>
           <a:lstStyle/>
           <a:p>
             <a:pPr indent="0" marL="0">
               <a:buNone/>
             </a:pPr>
             <a:r>
-              <a:rPr lang="en-US" sz="950" dirty="0">
+              <a:rPr lang="en-US" sz="1000" dirty="0">
                 <a:solidFill>
                   <a:srgbClr val="6E6E73"/>
                 </a:solidFill>
@@ -4966,26 +4804,89 @@
                 <a:ea typeface="SF Pro Text" pitchFamily="34" charset="-122"/>
                 <a:cs typeface="SF Pro Text" pitchFamily="34" charset="-120"/>
               </a:rPr>
-              <a:t>Steps 2–6, and which macro?</a:t>
-            </a:r>
-            <a:endParaRPr lang="en-US" sz="950" dirty="0"/>
-          </a:p>
-        </p:txBody>
-      </p:sp>
-      <p:sp>
-        <p:nvSpPr>
-          <p:cNvPr id="31" name="Shape 27"/>
+              <a:t>Create your comms for the customer.</a:t>
+            </a:r>
+            <a:endParaRPr lang="en-US" sz="1000" dirty="0"/>
+          </a:p>
+        </p:txBody>
+      </p:sp>
+      <p:pic>
+        <p:nvPicPr>
+          <p:cNvPr id="27" name="Image 1" descr="preencoded.png">    </p:cNvPr>
+          <p:cNvPicPr>
+            <a:picLocks noChangeAspect="1"/>
+          </p:cNvPicPr>
+          <p:nvPr/>
+        </p:nvPicPr>
+        <p:blipFill>
+          <a:blip r:embed="rId2"/>
+          <a:stretch>
+            <a:fillRect/>
+          </a:stretch>
+        </p:blipFill>
+        <p:spPr>
+          <a:xfrm>
+            <a:off x="7772400" y="3328416"/>
+            <a:ext cx="164592" cy="164592"/>
+          </a:xfrm>
+          <a:prstGeom prst="rect">
+            <a:avLst/>
+          </a:prstGeom>
+        </p:spPr>
+      </p:pic>
+      <p:sp>
+        <p:nvSpPr>
+          <p:cNvPr id="28" name="Text 23"/>
+          <p:cNvSpPr txBox="1"/>
+          <p:nvPr/>
+        </p:nvSpPr>
+        <p:spPr>
+          <a:xfrm>
+            <a:off x="7982712" y="3273552"/>
+            <a:ext cx="548640" cy="274320"/>
+          </a:xfrm>
+          <a:prstGeom prst="rect">
+            <a:avLst/>
+          </a:prstGeom>
+          <a:noFill/>
+          <a:ln/>
+        </p:spPr>
+        <p:txBody>
+          <a:bodyPr wrap="square" lIns="0" tIns="0" rIns="0" bIns="0" rtlCol="0" anchor="ctr"/>
+          <a:lstStyle/>
+          <a:p>
+            <a:pPr indent="0" marL="0">
+              <a:buNone/>
+            </a:pPr>
+            <a:r>
+              <a:rPr lang="en-US" sz="1000" b="1" dirty="0">
+                <a:solidFill>
+                  <a:srgbClr val="9A6410"/>
+                </a:solidFill>
+                <a:latin typeface="SF Pro Text" pitchFamily="34" charset="0"/>
+                <a:ea typeface="SF Pro Text" pitchFamily="34" charset="-122"/>
+                <a:cs typeface="SF Pro Text" pitchFamily="34" charset="-120"/>
+              </a:rPr>
+              <a:t>5 min</a:t>
+            </a:r>
+            <a:endParaRPr lang="en-US" sz="1000" dirty="0"/>
+          </a:p>
+        </p:txBody>
+      </p:sp>
+      <p:sp>
+        <p:nvSpPr>
+          <p:cNvPr id="29" name="Shape 24"/>
           <p:cNvSpPr/>
           <p:nvPr/>
         </p:nvSpPr>
         <p:spPr>
           <a:xfrm>
-            <a:off x="411480" y="3108960"/>
-            <a:ext cx="8321040" cy="914400"/>
+            <a:off x="411480" y="4069080"/>
+            <a:ext cx="8321040" cy="502920"/>
           </a:xfrm>
           <a:prstGeom prst="roundRect">
             <a:avLst>
-              <a:gd name="adj" fmla="val 8000"/>
+              <a:gd name="adj" fmla="val 14545"/>
             </a:avLst>
           </a:prstGeom>
           <a:solidFill>
@@ -5001,22 +4902,22 @@
       </p:sp>
       <p:pic>
         <p:nvPicPr>
-          <p:cNvPr id="32" name="Image 1" descr="preencoded.png">    </p:cNvPr>
+          <p:cNvPr id="30" name="Image 2" descr="preencoded.png">    </p:cNvPr>
           <p:cNvPicPr>
             <a:picLocks noChangeAspect="1"/>
           </p:cNvPicPr>
           <p:nvPr/>
         </p:nvPicPr>
         <p:blipFill>
-          <a:blip r:embed="rId2"/>
+          <a:blip r:embed="rId3"/>
           <a:stretch>
             <a:fillRect/>
           </a:stretch>
         </p:blipFill>
         <p:spPr>
           <a:xfrm>
-            <a:off x="731520" y="3383280"/>
-            <a:ext cx="365760" cy="365760"/>
+            <a:off x="640080" y="4192524"/>
+            <a:ext cx="256032" cy="256032"/>
           </a:xfrm>
           <a:prstGeom prst="rect">
             <a:avLst/>
@@ -5025,14 +4926,14 @@
       </p:pic>
       <p:sp>
         <p:nvSpPr>
-          <p:cNvPr id="33" name="Text 28"/>
+          <p:cNvPr id="31" name="Text 25"/>
           <p:cNvSpPr txBox="1"/>
           <p:nvPr/>
         </p:nvSpPr>
         <p:spPr>
           <a:xfrm>
-            <a:off x="1325880" y="3108960"/>
-            <a:ext cx="7223760" cy="914400"/>
+            <a:off x="1051560" y="4069080"/>
+            <a:ext cx="7498080" cy="502920"/>
           </a:xfrm>
           <a:prstGeom prst="rect">
             <a:avLst/>
@@ -5048,7 +4949,7 @@
               <a:buNone/>
             </a:pPr>
             <a:r>
-              <a:rPr lang="en-US" sz="2000" b="1" dirty="0">
+              <a:rPr lang="en-US" sz="1400" b="1" dirty="0">
                 <a:solidFill>
                   <a:srgbClr val="FFFFFF"/>
                 </a:solidFill>
@@ -5056,11 +4957,8 @@
                 <a:ea typeface="SF Pro Display" pitchFamily="34" charset="-122"/>
                 <a:cs typeface="SF Pro Display" pitchFamily="34" charset="-120"/>
               </a:rPr>
-              <a:t>Questions?</a:t>
-            </a:r>
-            <a:endParaRPr lang="en-US" sz="2000" dirty="0"/>
-          </a:p>
-          <a:p>
+              <a:t>Questions?  </a:t>
+            </a:r>
             <a:pPr indent="0" marL="0">
               <a:buNone/>
             </a:pPr>
@@ -5075,7 +4973,7 @@
               </a:rPr>
               <a:t>Open the floor before we move to the next topic.</a:t>
             </a:r>
-            <a:endParaRPr lang="en-US" sz="2000" dirty="0"/>
+            <a:endParaRPr lang="en-US" sz="1400" dirty="0"/>
           </a:p>
         </p:txBody>
       </p:sp>

</xml_diff>

<commit_message>
Incorrect Info deck: clickable 5-minute timer on the practice slide
Co-Authored-By: Claude Opus 5.5 <noreply@anthropic.com>
Claude-Session: https://claude.ai/code/session_01FEzv8wwqWDgTsXP8Yz6XYn
</commit_message>
<xml_diff>
--- a/incorrect-info-lmc-lockout/incorrect-info-lmc-lockout.pptx
+++ b/incorrect-info-lmc-lockout/incorrect-info-lmc-lockout.pptx
@@ -618,7 +618,7 @@
           <a:p>
             <a:r>
               <a:rPr lang="en-US" dirty="0"/>
-              <a:t>TRAINER: share a live Incorrect Information ticket. Give trainees a few minutes to review it on their own, then work through it together. 1) Is there verified misinformation? What exactly was said, and by whom? "At $23/hour" is a guarantee; "around" or "starting at" is an estimate. Would this need a Sales call review (request, internal note with the escalation link, status Waiting on CSQ)? 2) What was the misinformation, and how do we correct it? Refund the gap, own the error, correct the charges or expectations, one light offer; declined or not retainable: waive the ETF and cancel the FC. Which macro? 3) 5-minute writing challenge: each trainee writes the comms they would send the customer. Read a few aloud and compare. Then open the floor for questions on Incorrect Information Provided.</a:t>
+              <a:t>TRAINER: share a live Incorrect Information ticket. Give trainees a few minutes to review it on their own, then work through it together. 1) Is there verified misinformation? What exactly was said, and by whom? "At $23/hour" is a guarantee; "around" or "starting at" is an estimate. Would this need a Sales call review (request, internal note with the escalation link, status Waiting on CSQ)? 2) What was the misinformation, and how do we correct it? Refund the gap, own the error, correct the charges or expectations, one light offer; declined or not retainable: waive the ETF and cancel the FC. Which macro? 3) 5-minute writing challenge: in slideshow mode, click the 5 min button to start a countdown in a new tab. Each trainee writes the comms they would send the customer. Read a few aloud and compare. Then open the floor for questions on Incorrect Information Provided.</a:t>
             </a:r>
             <a:endParaRPr lang="en-US" dirty="0"/>
           </a:p>
@@ -4810,23 +4810,54 @@
           </a:p>
         </p:txBody>
       </p:sp>
+      <p:sp>
+        <p:nvSpPr>
+          <p:cNvPr id="27" name="Shape 23">
+            <a:hlinkClick r:id="rId4" tooltip="Start a 5-minute timer"/>
+          </p:cNvPr>
+          <p:cNvSpPr/>
+          <p:nvPr/>
+        </p:nvSpPr>
+        <p:spPr>
+          <a:xfrm>
+            <a:off x="7543800" y="3255264"/>
+            <a:ext cx="1005840" cy="310896"/>
+          </a:xfrm>
+          <a:prstGeom prst="roundRect">
+            <a:avLst>
+              <a:gd name="adj" fmla="val 23529"/>
+            </a:avLst>
+          </a:prstGeom>
+          <a:solidFill>
+            <a:srgbClr val="FFF3D6"/>
+          </a:solidFill>
+          <a:ln w="12700">
+            <a:solidFill>
+              <a:srgbClr val="9A6410"/>
+            </a:solidFill>
+            <a:prstDash val="solid"/>
+          </a:ln>
+        </p:spPr>
+      </p:sp>
       <p:pic>
         <p:nvPicPr>
-          <p:cNvPr id="27" name="Image 1" descr="preencoded.png">    </p:cNvPr>
+          <p:cNvPr id="28" name="Image 1" descr="preencoded.png">
+            <a:hlinkClick r:id="rId4" tooltip="Start a 5-minute timer"/>
+          </p:cNvPr>
           <p:cNvPicPr>
             <a:picLocks noChangeAspect="1"/>
           </p:cNvPicPr>
           <p:nvPr/>
         </p:nvPicPr>
         <p:blipFill>
-          <a:blip r:embed="rId2"/>
+          <a:blip r:embed="rId3"/>
           <a:stretch>
             <a:fillRect/>
           </a:stretch>
         </p:blipFill>
         <p:spPr>
           <a:xfrm>
-            <a:off x="7772400" y="3328416"/>
+            <a:off x="7635240" y="3328416"/>
             <a:ext cx="164592" cy="164592"/>
           </a:xfrm>
           <a:prstGeom prst="rect">
@@ -4836,14 +4867,16 @@
       </p:pic>
       <p:sp>
         <p:nvSpPr>
-          <p:cNvPr id="28" name="Text 23"/>
-          <p:cNvSpPr txBox="1"/>
-          <p:nvPr/>
-        </p:nvSpPr>
-        <p:spPr>
-          <a:xfrm>
-            <a:off x="7982712" y="3273552"/>
-            <a:ext cx="548640" cy="274320"/>
+          <p:cNvPr id="29" name="Text 24">
+            <a:hlinkClick r:id="rId4" tooltip="Start a 5-minute timer"/>
+          </p:cNvPr>
+          <p:cNvSpPr/>
+          <p:nvPr/>
+        </p:nvSpPr>
+        <p:spPr>
+          <a:xfrm>
+            <a:off x="7845552" y="3255264"/>
+            <a:ext cx="640080" cy="310896"/>
           </a:xfrm>
           <a:prstGeom prst="rect">
             <a:avLst/>
@@ -4859,7 +4892,7 @@
               <a:buNone/>
             </a:pPr>
             <a:r>
-              <a:rPr lang="en-US" sz="1000" b="1" dirty="0">
+              <a:rPr lang="en-US" sz="1000" b="1" u="none" dirty="0">
                 <a:solidFill>
                   <a:srgbClr val="9A6410"/>
                 </a:solidFill>
@@ -4875,7 +4908,7 @@
       </p:sp>
       <p:sp>
         <p:nvSpPr>
-          <p:cNvPr id="29" name="Shape 24"/>
+          <p:cNvPr id="30" name="Shape 25"/>
           <p:cNvSpPr/>
           <p:nvPr/>
         </p:nvSpPr>
@@ -4902,14 +4935,14 @@
       </p:sp>
       <p:pic>
         <p:nvPicPr>
-          <p:cNvPr id="30" name="Image 2" descr="preencoded.png">    </p:cNvPr>
+          <p:cNvPr id="31" name="Image 2" descr="preencoded.png">    </p:cNvPr>
           <p:cNvPicPr>
             <a:picLocks noChangeAspect="1"/>
           </p:cNvPicPr>
           <p:nvPr/>
         </p:nvPicPr>
         <p:blipFill>
-          <a:blip r:embed="rId3"/>
+          <a:blip r:embed="rId5"/>
           <a:stretch>
             <a:fillRect/>
           </a:stretch>
@@ -4926,7 +4959,7 @@
       </p:pic>
       <p:sp>
         <p:nvSpPr>
-          <p:cNvPr id="31" name="Text 25"/>
+          <p:cNvPr id="32" name="Text 26"/>
           <p:cNvSpPr txBox="1"/>
           <p:nvPr/>
         </p:nvSpPr>

</xml_diff>

<commit_message>
Incorrect Info deck: drop the timer from the practice slide
Co-Authored-By: Claude Opus 5.5 <noreply@anthropic.com>
Claude-Session: https://claude.ai/code/session_01FEzv8wwqWDgTsXP8Yz6XYn
</commit_message>
<xml_diff>
--- a/incorrect-info-lmc-lockout/incorrect-info-lmc-lockout.pptx
+++ b/incorrect-info-lmc-lockout/incorrect-info-lmc-lockout.pptx
@@ -618,7 +618,7 @@
           <a:p>
             <a:r>
               <a:rPr lang="en-US" dirty="0"/>
-              <a:t>TRAINER: share a live Incorrect Information ticket. Give trainees a few minutes to review it on their own, then work through it together. 1) Is there verified misinformation? What exactly was said, and by whom? "At $23/hour" is a guarantee; "around" or "starting at" is an estimate. Would this need a Sales call review (request, internal note with the escalation link, status Waiting on CSQ)? 2) What was the misinformation, and how do we correct it? Refund the gap, own the error, correct the charges or expectations, one light offer; declined or not retainable: waive the ETF and cancel the FC. Which macro? 3) 5-minute writing challenge: in slideshow mode, click the 5 min button to start a countdown in a new tab. Each trainee writes the comms they would send the customer. Read a few aloud and compare. Then open the floor for questions on Incorrect Information Provided.</a:t>
+              <a:t>TRAINER: share a live Incorrect Information ticket. Give trainees a few minutes to review it on their own, then work through it together. 1) Is there verified misinformation? What exactly was said, and by whom? "At $23/hour" is a guarantee; "around" or "starting at" is an estimate. Would this need a Sales call review (request, internal note with the escalation link, status Waiting on CSQ)? 2) What was the misinformation, and how do we correct it? Refund the gap, own the error, correct the charges or expectations, one light offer; declined or not retainable: waive the ETF and cancel the FC. Which macro? 3) 5-minute writing challenge: each trainee writes the comms they would send the customer. Read a few aloud and compare. Then open the floor for questions on Incorrect Information Provided.</a:t>
             </a:r>
             <a:endParaRPr lang="en-US" dirty="0"/>
           </a:p>
@@ -4812,103 +4812,7 @@
       </p:sp>
       <p:sp>
         <p:nvSpPr>
-          <p:cNvPr id="27" name="Shape 23">
-            <a:hlinkClick r:id="rId4" tooltip="Start a 5-minute timer"/>
-          </p:cNvPr>
-          <p:cNvSpPr/>
-          <p:nvPr/>
-        </p:nvSpPr>
-        <p:spPr>
-          <a:xfrm>
-            <a:off x="7543800" y="3255264"/>
-            <a:ext cx="1005840" cy="310896"/>
-          </a:xfrm>
-          <a:prstGeom prst="roundRect">
-            <a:avLst>
-              <a:gd name="adj" fmla="val 23529"/>
-            </a:avLst>
-          </a:prstGeom>
-          <a:solidFill>
-            <a:srgbClr val="FFF3D6"/>
-          </a:solidFill>
-          <a:ln w="12700">
-            <a:solidFill>
-              <a:srgbClr val="9A6410"/>
-            </a:solidFill>
-            <a:prstDash val="solid"/>
-          </a:ln>
-        </p:spPr>
-      </p:sp>
-      <p:pic>
-        <p:nvPicPr>
-          <p:cNvPr id="28" name="Image 1" descr="preencoded.png">
-            <a:hlinkClick r:id="rId4" tooltip="Start a 5-minute timer"/>
-          </p:cNvPr>
-          <p:cNvPicPr>
-            <a:picLocks noChangeAspect="1"/>
-          </p:cNvPicPr>
-          <p:nvPr/>
-        </p:nvPicPr>
-        <p:blipFill>
-          <a:blip r:embed="rId3"/>
-          <a:stretch>
-            <a:fillRect/>
-          </a:stretch>
-        </p:blipFill>
-        <p:spPr>
-          <a:xfrm>
-            <a:off x="7635240" y="3328416"/>
-            <a:ext cx="164592" cy="164592"/>
-          </a:xfrm>
-          <a:prstGeom prst="rect">
-            <a:avLst/>
-          </a:prstGeom>
-        </p:spPr>
-      </p:pic>
-      <p:sp>
-        <p:nvSpPr>
-          <p:cNvPr id="29" name="Text 24">
-            <a:hlinkClick r:id="rId4" tooltip="Start a 5-minute timer"/>
-          </p:cNvPr>
-          <p:cNvSpPr/>
-          <p:nvPr/>
-        </p:nvSpPr>
-        <p:spPr>
-          <a:xfrm>
-            <a:off x="7845552" y="3255264"/>
-            <a:ext cx="640080" cy="310896"/>
-          </a:xfrm>
-          <a:prstGeom prst="rect">
-            <a:avLst/>
-          </a:prstGeom>
-          <a:noFill/>
-          <a:ln/>
-        </p:spPr>
-        <p:txBody>
-          <a:bodyPr wrap="square" lIns="0" tIns="0" rIns="0" bIns="0" rtlCol="0" anchor="ctr"/>
-          <a:lstStyle/>
-          <a:p>
-            <a:pPr indent="0" marL="0">
-              <a:buNone/>
-            </a:pPr>
-            <a:r>
-              <a:rPr lang="en-US" sz="1000" b="1" u="none" dirty="0">
-                <a:solidFill>
-                  <a:srgbClr val="9A6410"/>
-                </a:solidFill>
-                <a:latin typeface="SF Pro Text" pitchFamily="34" charset="0"/>
-                <a:ea typeface="SF Pro Text" pitchFamily="34" charset="-122"/>
-                <a:cs typeface="SF Pro Text" pitchFamily="34" charset="-120"/>
-              </a:rPr>
-              <a:t>5 min</a:t>
-            </a:r>
-            <a:endParaRPr lang="en-US" sz="1000" dirty="0"/>
-          </a:p>
-        </p:txBody>
-      </p:sp>
-      <p:sp>
-        <p:nvSpPr>
-          <p:cNvPr id="30" name="Shape 25"/>
+          <p:cNvPr id="27" name="Shape 23"/>
           <p:cNvSpPr/>
           <p:nvPr/>
         </p:nvSpPr>
@@ -4935,14 +4839,14 @@
       </p:sp>
       <p:pic>
         <p:nvPicPr>
-          <p:cNvPr id="31" name="Image 2" descr="preencoded.png">    </p:cNvPr>
+          <p:cNvPr id="28" name="Image 1" descr="preencoded.png">    </p:cNvPr>
           <p:cNvPicPr>
             <a:picLocks noChangeAspect="1"/>
           </p:cNvPicPr>
           <p:nvPr/>
         </p:nvPicPr>
         <p:blipFill>
-          <a:blip r:embed="rId5"/>
+          <a:blip r:embed="rId2"/>
           <a:stretch>
             <a:fillRect/>
           </a:stretch>
@@ -4959,7 +4863,7 @@
       </p:pic>
       <p:sp>
         <p:nvSpPr>
-          <p:cNvPr id="32" name="Text 26"/>
+          <p:cNvPr id="29" name="Text 24"/>
           <p:cNvSpPr txBox="1"/>
           <p:nvPr/>
         </p:nvSpPr>

</xml_diff>

<commit_message>
LMC deck: link refund and holdback steps to their how-to videos; keep trainer's label edit
Co-Authored-By: Claude Opus 5.5 <noreply@anthropic.com>
Claude-Session: https://claude.ai/code/session_01FEzv8wwqWDgTsXP8Yz6XYn
</commit_message>
<xml_diff>
--- a/incorrect-info-lmc-lockout/incorrect-info-lmc-lockout.pptx
+++ b/incorrect-info-lmc-lockout/incorrect-info-lmc-lockout.pptx
@@ -970,7 +970,7 @@
           <a:p>
             <a:r>
               <a:rPr lang="en-US" dirty="0"/>
-              <a:t>If the charge is invalid: 1) Refund the LMC charge via the Manual Charges section. 2) Create a Cleaner Payment Holdback for the $20 the CP received: CP CRM &gt; Do &gt; CleanerPaymentHoldback &gt; create (the amount is entered in cents, so $20 = 2000). Special case: the customer was charged LMC but the job was later completed anyway. Refund the LMC charge, create a $20 holdback with invalid_lmc as the holdback type, log the ticket, then recreate the job and invoice it normally so it still triggers the customer's FC correctly.</a:t>
+              <a:t>If the charge is invalid: 1) Refund the LMC charge via the Manual Charges section. 2) Create a Cleaner Payment Holdback for the $20 the CP received: CP CRM &gt; Do &gt; CleanerPaymentHoldback &gt; create (the amount is entered in cents, so $20 = 2000). Special case: the customer was charged LMC but the job was later completed anyway. Refund the LMC charge, create a $20 holdback with invalid_lmc as the holdback type, log the ticket, then recreate the job and invoice it normally so it still triggers the customer's FC correctly. TRAINER: in slideshow mode, click Refund the LMC charge or Hold back the CP's $20 to play that how-to video.</a:t>
             </a:r>
             <a:endParaRPr lang="en-US" dirty="0"/>
           </a:p>
@@ -7675,7 +7675,9 @@
       </p:sp>
       <p:sp>
         <p:nvSpPr>
-          <p:cNvPr id="7" name="Shape 4"/>
+          <p:cNvPr id="7" name="Text 4">
+            <a:hlinkClick r:id="rId1" tooltip="Play: how to refund the LMC fee"/>
+          </p:cNvPr>
           <p:cNvSpPr/>
           <p:nvPr/>
         </p:nvSpPr>
@@ -7696,36 +7698,17 @@
             <a:solidFill>
               <a:srgbClr val="0B7A6F"/>
             </a:solidFill>
-            <a:prstDash val="solid"/>
           </a:ln>
         </p:spPr>
-      </p:sp>
-      <p:sp>
-        <p:nvSpPr>
-          <p:cNvPr id="8" name="Text 5"/>
-          <p:cNvSpPr txBox="1"/>
-          <p:nvPr/>
-        </p:nvSpPr>
-        <p:spPr>
-          <a:xfrm>
-            <a:off x="411480" y="1645920"/>
-            <a:ext cx="3657600" cy="502920"/>
-          </a:xfrm>
-          <a:prstGeom prst="rect">
-            <a:avLst/>
-          </a:prstGeom>
-          <a:noFill/>
-          <a:ln/>
-        </p:spPr>
-        <p:txBody>
-          <a:bodyPr wrap="square" lIns="0" tIns="0" rIns="0" bIns="0" rtlCol="0" anchor="ctr"/>
+        <p:txBody>
+          <a:bodyPr wrap="square" rtlCol="0" anchor="ctr"/>
           <a:lstStyle/>
           <a:p>
             <a:pPr algn="ctr" indent="0" marL="0">
               <a:buNone/>
             </a:pPr>
             <a:r>
-              <a:rPr lang="en-US" sz="1000" b="1" dirty="0">
+              <a:rPr lang="en-US" sz="1000" b="1" u="none" dirty="0">
                 <a:solidFill>
                   <a:srgbClr val="FFFFFF"/>
                 </a:solidFill>
@@ -7733,7 +7716,7 @@
                 <a:ea typeface="SF Pro Display" pitchFamily="34" charset="-122"/>
                 <a:cs typeface="SF Pro Display" pitchFamily="34" charset="-120"/>
               </a:rPr>
-              <a:t>Refund the LMC charge</a:t>
+              <a:t>▶  Refund the LMC charge</a:t>
             </a:r>
             <a:endParaRPr lang="en-US" sz="1000" dirty="0"/>
           </a:p>
@@ -7741,7 +7724,7 @@
       </p:sp>
       <p:sp>
         <p:nvSpPr>
-          <p:cNvPr id="9" name="Text 6"/>
+          <p:cNvPr id="8" name="Text 5"/>
           <p:cNvSpPr txBox="1"/>
           <p:nvPr/>
         </p:nvSpPr>
@@ -7780,7 +7763,7 @@
       </p:sp>
       <p:sp>
         <p:nvSpPr>
-          <p:cNvPr id="10" name="Shape 7"/>
+          <p:cNvPr id="9" name="Shape 6"/>
           <p:cNvSpPr/>
           <p:nvPr/>
         </p:nvSpPr>
@@ -7804,7 +7787,9 @@
       </p:sp>
       <p:sp>
         <p:nvSpPr>
-          <p:cNvPr id="11" name="Shape 8"/>
+          <p:cNvPr id="10" name="Text 7">
+            <a:hlinkClick r:id="rId2" tooltip="Play: how to create an LMC fee holdback"/>
+          </p:cNvPr>
           <p:cNvSpPr/>
           <p:nvPr/>
         </p:nvSpPr>
@@ -7825,36 +7810,17 @@
             <a:solidFill>
               <a:srgbClr val="0B7A6F"/>
             </a:solidFill>
-            <a:prstDash val="solid"/>
           </a:ln>
         </p:spPr>
-      </p:sp>
-      <p:sp>
-        <p:nvSpPr>
-          <p:cNvPr id="12" name="Text 9"/>
-          <p:cNvSpPr txBox="1"/>
-          <p:nvPr/>
-        </p:nvSpPr>
-        <p:spPr>
-          <a:xfrm>
-            <a:off x="411480" y="2651760"/>
-            <a:ext cx="3657600" cy="502920"/>
-          </a:xfrm>
-          <a:prstGeom prst="rect">
-            <a:avLst/>
-          </a:prstGeom>
-          <a:noFill/>
-          <a:ln/>
-        </p:spPr>
-        <p:txBody>
-          <a:bodyPr wrap="square" lIns="0" tIns="0" rIns="0" bIns="0" rtlCol="0" anchor="ctr"/>
+        <p:txBody>
+          <a:bodyPr wrap="square" rtlCol="0" anchor="ctr"/>
           <a:lstStyle/>
           <a:p>
             <a:pPr algn="ctr" indent="0" marL="0">
               <a:buNone/>
             </a:pPr>
             <a:r>
-              <a:rPr lang="en-US" sz="1000" b="1" dirty="0">
+              <a:rPr lang="en-US" sz="1000" b="1" u="none" dirty="0">
                 <a:solidFill>
                   <a:srgbClr val="FFFFFF"/>
                 </a:solidFill>
@@ -7862,7 +7828,7 @@
                 <a:ea typeface="SF Pro Display" pitchFamily="34" charset="-122"/>
                 <a:cs typeface="SF Pro Display" pitchFamily="34" charset="-120"/>
               </a:rPr>
-              <a:t>Hold back the CP's $20</a:t>
+              <a:t>▶  Hold back the CP's $20</a:t>
             </a:r>
             <a:endParaRPr lang="en-US" sz="1000" dirty="0"/>
           </a:p>
@@ -7870,7 +7836,7 @@
       </p:sp>
       <p:sp>
         <p:nvSpPr>
-          <p:cNvPr id="13" name="Text 10"/>
+          <p:cNvPr id="11" name="Text 8"/>
           <p:cNvSpPr txBox="1"/>
           <p:nvPr/>
         </p:nvSpPr>
@@ -7926,7 +7892,7 @@
       </p:sp>
       <p:sp>
         <p:nvSpPr>
-          <p:cNvPr id="14" name="Text 11"/>
+          <p:cNvPr id="12" name="Text 9"/>
           <p:cNvSpPr txBox="1"/>
           <p:nvPr/>
         </p:nvSpPr>
@@ -7957,7 +7923,7 @@
                 <a:ea typeface="SF Pro Display" pitchFamily="34" charset="-122"/>
                 <a:cs typeface="SF Pro Display" pitchFamily="34" charset="-120"/>
               </a:rPr>
-              <a:t>SPECIAL CASE: JOB COMPLETED ANYWAY</a:t>
+              <a:t>SPECIAL CASE: LMC was charged but JOB COMPLETED later anyway</a:t>
             </a:r>
             <a:endParaRPr lang="en-US" sz="800" dirty="0"/>
           </a:p>
@@ -7965,7 +7931,7 @@
       </p:sp>
       <p:sp>
         <p:nvSpPr>
-          <p:cNvPr id="15" name="Shape 12"/>
+          <p:cNvPr id="13" name="Shape 10"/>
           <p:cNvSpPr/>
           <p:nvPr/>
         </p:nvSpPr>
@@ -7992,7 +7958,7 @@
       </p:sp>
       <p:sp>
         <p:nvSpPr>
-          <p:cNvPr id="16" name="Text 13"/>
+          <p:cNvPr id="14" name="Text 11"/>
           <p:cNvSpPr txBox="1"/>
           <p:nvPr/>
         </p:nvSpPr>

</xml_diff>

<commit_message>
LMC deck: live-ticket practice slide; carry over trainer's edits on slides 15-17
Co-Authored-By: Claude Opus 5.5 <noreply@anthropic.com>
Claude-Session: https://claude.ai/code/session_01FEzv8wwqWDgTsXP8Yz6XYn
</commit_message>
<xml_diff>
--- a/incorrect-info-lmc-lockout/incorrect-info-lmc-lockout.pptx
+++ b/incorrect-info-lmc-lockout/incorrect-info-lmc-lockout.pptx
@@ -1322,7 +1322,7 @@
           <a:p>
             <a:r>
               <a:rPr lang="en-US" dirty="0"/>
-              <a:t>TRAINER: recap the three takeaways, then open the floor for questions on Last-Minute Cancellation.</a:t>
+              <a:t>TRAINER: share a live Last-Minute Cancellation ticket. Give trainees a few minutes to review it on their own, then work through it together. 1) Is this a valid or invalid LMC fee, and why? Check the six automatic waivers first: job still Submitted (no CP matched), severe weather, CP rescheduled less than 24 hours before, Alternate Start Time claimed, ETA asked with no check-in, or all of these together. Then read what the customer and the CP said (e.g. the CP asked to reschedule or cancel, or no-showed). 2) What actions are you going to take? Invalid: refund the LMC charge and create a $20 Cleaner Payment Holdback (invalid_lmc, 2000 cents); special case if the job was completed anyway. Valid: only if the customer asks for a refund or contests it, go straight to their customer category offer. Which macro? 3) 5-minute writing challenge: each trainee writes the comms they would send the customer. Read a few aloud and compare. Then open the floor for questions on Last-Minute Cancellation.</a:t>
             </a:r>
             <a:endParaRPr lang="en-US" dirty="0"/>
           </a:p>
@@ -8845,7 +8845,49 @@
                           <a:ea typeface="SF Pro Text" pitchFamily="34" charset="-122"/>
                           <a:cs typeface="SF Pro Text" pitchFamily="34" charset="-120"/>
                         </a:rPr>
-                        <a:t>Credits up to 100% of the fee, not cash. Upset? Service Recovery. Cancelling? Apply it to the ETF.</a:t>
+                        <a:t>Offer credits up to 100% of the fee, not cash refund. reason code: lmc</a:t>
+                      </a:r>
+                      <a:endParaRPr lang="en-US" sz="1000" dirty="0">
+                        <a:latin typeface="SF Pro Text" charset="0"/>
+                        <a:ea typeface="SF Pro Text" charset="0"/>
+                        <a:cs typeface="SF Pro Text" charset="0"/>
+                      </a:endParaRPr>
+                    </a:p>
+                    <a:p>
+                      <a:pPr indent="0" marL="0">
+                        <a:buNone/>
+                      </a:pPr>
+                      <a:r>
+                        <a:rPr lang="en-US" sz="1000" dirty="0">
+                          <a:solidFill>
+                            <a:srgbClr val="6E6E73"/>
+                          </a:solidFill>
+                          <a:latin typeface="SF Pro Text" pitchFamily="34" charset="0"/>
+                          <a:ea typeface="SF Pro Text" pitchFamily="34" charset="-122"/>
+                          <a:cs typeface="SF Pro Text" pitchFamily="34" charset="-120"/>
+                        </a:rPr>
+                        <a:t>Upset? Send to Service Recovery. </a:t>
+                      </a:r>
+                      <a:endParaRPr lang="en-US" sz="1000" dirty="0">
+                        <a:latin typeface="SF Pro Text" charset="0"/>
+                        <a:ea typeface="SF Pro Text" charset="0"/>
+                        <a:cs typeface="SF Pro Text" charset="0"/>
+                      </a:endParaRPr>
+                    </a:p>
+                    <a:p>
+                      <a:pPr indent="0" marL="0">
+                        <a:buNone/>
+                      </a:pPr>
+                      <a:r>
+                        <a:rPr lang="en-US" sz="1000" dirty="0">
+                          <a:solidFill>
+                            <a:srgbClr val="6E6E73"/>
+                          </a:solidFill>
+                          <a:latin typeface="SF Pro Text" pitchFamily="34" charset="0"/>
+                          <a:ea typeface="SF Pro Text" pitchFamily="34" charset="-122"/>
+                          <a:cs typeface="SF Pro Text" pitchFamily="34" charset="-120"/>
+                        </a:rPr>
+                        <a:t>Cancelling? Offer to apply the LMC fee to the ETF.</a:t>
                       </a:r>
                       <a:endParaRPr lang="en-US" sz="1000" dirty="0">
                         <a:latin typeface="SF Pro Text" charset="0"/>
@@ -9205,7 +9247,7 @@
                 <a:ea typeface="SF Pro Text" pitchFamily="34" charset="-122"/>
                 <a:cs typeface="SF Pro Text" pitchFamily="34" charset="-120"/>
               </a:rPr>
-              <a:t>use this when they want the charge reversed, not when they just want it explained.</a:t>
+              <a:t>use this table only when the customer explicitly asks a refund or contests the charge, not when they just want it explained.</a:t>
             </a:r>
             <a:endParaRPr lang="en-US" sz="1000" dirty="0"/>
           </a:p>
@@ -9295,7 +9337,7 @@
                 <a:ea typeface="SF Pro Display" pitchFamily="34" charset="-122"/>
                 <a:cs typeface="SF Pro Display" pitchFamily="34" charset="-120"/>
               </a:rPr>
-              <a:t>Recommended Macros:  </a:t>
+              <a:t>Recommended Macro:  </a:t>
             </a:r>
             <a:pPr indent="0" marL="0">
               <a:buNone/>
@@ -9614,7 +9656,7 @@
                 <a:ea typeface="SF Pro Display" pitchFamily="34" charset="-122"/>
                 <a:cs typeface="SF Pro Display" pitchFamily="34" charset="-120"/>
               </a:rPr>
-              <a:t>Where to find it</a:t>
+              <a:t>Where to check</a:t>
             </a:r>
             <a:endParaRPr lang="en-US" sz="1300" dirty="0"/>
           </a:p>
@@ -9657,7 +9699,7 @@
                 <a:ea typeface="SF Pro Text" pitchFamily="34" charset="-122"/>
                 <a:cs typeface="SF Pro Text" pitchFamily="34" charset="-120"/>
               </a:rPr>
-              <a:t>CRM › Manual Charges</a:t>
+              <a:t>New CRM › Payment History </a:t>
             </a:r>
             <a:endParaRPr lang="en-US" sz="1000" dirty="0"/>
           </a:p>
@@ -9678,7 +9720,7 @@
                 <a:ea typeface="SF Pro Text" pitchFamily="34" charset="-122"/>
                 <a:cs typeface="SF Pro Text" pitchFamily="34" charset="-120"/>
               </a:rPr>
-              <a:t>C CRM › View › ManualCustomerPaymentTxn</a:t>
+              <a:t>Open Customer Stripe Charges</a:t>
             </a:r>
             <a:endParaRPr lang="en-US" sz="1000" dirty="0"/>
           </a:p>
@@ -9699,7 +9741,7 @@
                 <a:ea typeface="SF Pro Text" pitchFamily="34" charset="-122"/>
                 <a:cs typeface="SF Pro Text" pitchFamily="34" charset="-120"/>
               </a:rPr>
-              <a:t>Credits reason code: lmc</a:t>
+              <a:t>Failed charges: Tracked in Stripe only</a:t>
             </a:r>
             <a:endParaRPr lang="en-US" sz="1000" dirty="0"/>
           </a:p>
@@ -9857,7 +9899,7 @@
                 <a:ea typeface="SF Pro Text" pitchFamily="34" charset="-122"/>
                 <a:cs typeface="SF Pro Text" pitchFamily="34" charset="-120"/>
               </a:rPr>
-              <a:t>Let it go: the system stops retrying</a:t>
+              <a:t>Let it go: the system stops retrying after a couple of times</a:t>
             </a:r>
             <a:endParaRPr lang="en-US" sz="1000" dirty="0"/>
           </a:p>
@@ -10781,7 +10823,7 @@
                 <a:ea typeface="SF Pro Text" pitchFamily="34" charset="-122"/>
                 <a:cs typeface="SF Pro Text" pitchFamily="34" charset="-120"/>
               </a:rPr>
-              <a:t>Credits up to 100% of the fee, not cash.</a:t>
+              <a:t>Credits up to 100% of the fee, not cash refund.</a:t>
             </a:r>
             <a:endParaRPr lang="en-US" sz="900" dirty="0"/>
           </a:p>
@@ -11337,7 +11379,7 @@
                 <a:ea typeface="SF Pro Display" pitchFamily="34" charset="-122"/>
                 <a:cs typeface="SF Pro Display" pitchFamily="34" charset="-120"/>
               </a:rPr>
-              <a:t>LAST-MINUTE CANCELLATION  ·  WRAP-UP</a:t>
+              <a:t>LAST-MINUTE CANCELLATION  ·  PRACTICE</a:t>
             </a:r>
             <a:endParaRPr lang="en-US" sz="800" dirty="0"/>
           </a:p>
@@ -11376,7 +11418,7 @@
                 <a:ea typeface="SF Pro Display" pitchFamily="34" charset="-122"/>
                 <a:cs typeface="SF Pro Display" pitchFamily="34" charset="-120"/>
               </a:rPr>
-              <a:t>Wrap-up</a:t>
+              <a:t>Let's investigate together!</a:t>
             </a:r>
             <a:endParaRPr lang="en-US" sz="2400" dirty="0"/>
           </a:p>
@@ -11415,7 +11457,7 @@
                 <a:ea typeface="SF Pro Text" pitchFamily="34" charset="-122"/>
                 <a:cs typeface="SF Pro Text" pitchFamily="34" charset="-120"/>
               </a:rPr>
-              <a:t>Key takeaways before we move on.</a:t>
+              <a:t>Review the live ticket and investigate.</a:t>
             </a:r>
             <a:endParaRPr lang="en-US" sz="1200" dirty="0"/>
           </a:p>
@@ -11429,12 +11471,12 @@
         </p:nvSpPr>
         <p:spPr>
           <a:xfrm>
-            <a:off x="411480" y="1325880"/>
-            <a:ext cx="2682240" cy="1600200"/>
+            <a:off x="411480" y="1298448"/>
+            <a:ext cx="3383280" cy="2633472"/>
           </a:xfrm>
           <a:prstGeom prst="roundRect">
             <a:avLst>
-              <a:gd name="adj" fmla="val 4571"/>
+              <a:gd name="adj" fmla="val 2778"/>
             </a:avLst>
           </a:prstGeom>
           <a:solidFill>
@@ -11456,8 +11498,8 @@
         </p:nvSpPr>
         <p:spPr>
           <a:xfrm>
-            <a:off x="576072" y="1508760"/>
-            <a:ext cx="274320" cy="274320"/>
+            <a:off x="594360" y="1481328"/>
+            <a:ext cx="384048" cy="384048"/>
           </a:xfrm>
           <a:prstGeom prst="ellipse">
             <a:avLst/>
@@ -11473,16 +11515,40 @@
           </a:ln>
         </p:spPr>
       </p:sp>
-      <p:sp>
-        <p:nvSpPr>
-          <p:cNvPr id="8" name="Text 5"/>
+      <p:pic>
+        <p:nvPicPr>
+          <p:cNvPr id="8" name="Image 0" descr="preencoded.png">    </p:cNvPr>
+          <p:cNvPicPr>
+            <a:picLocks noChangeAspect="1"/>
+          </p:cNvPicPr>
+          <p:nvPr/>
+        </p:nvPicPr>
+        <p:blipFill>
+          <a:blip r:embed="rId1"/>
+          <a:stretch>
+            <a:fillRect/>
+          </a:stretch>
+        </p:blipFill>
+        <p:spPr>
+          <a:xfrm>
+            <a:off x="686532" y="1573500"/>
+            <a:ext cx="199705" cy="199705"/>
+          </a:xfrm>
+          <a:prstGeom prst="rect">
+            <a:avLst/>
+          </a:prstGeom>
+        </p:spPr>
+      </p:pic>
+      <p:sp>
+        <p:nvSpPr>
+          <p:cNvPr id="9" name="Text 5"/>
           <p:cNvSpPr txBox="1"/>
           <p:nvPr/>
         </p:nvSpPr>
         <p:spPr>
           <a:xfrm>
-            <a:off x="576072" y="1508760"/>
-            <a:ext cx="274320" cy="274320"/>
+            <a:off x="594360" y="2011680"/>
+            <a:ext cx="3017520" cy="292608"/>
           </a:xfrm>
           <a:prstGeom prst="rect">
             <a:avLst/>
@@ -11491,37 +11557,37 @@
           <a:ln/>
         </p:spPr>
         <p:txBody>
-          <a:bodyPr wrap="square" lIns="0" tIns="0" rIns="0" bIns="0" rtlCol="0" anchor="ctr"/>
-          <a:lstStyle/>
-          <a:p>
-            <a:pPr algn="ctr" indent="0" marL="0">
-              <a:buNone/>
-            </a:pPr>
-            <a:r>
-              <a:rPr lang="en-US" sz="900" b="1" dirty="0">
-                <a:solidFill>
-                  <a:srgbClr val="0B7A6F"/>
+          <a:bodyPr wrap="square" lIns="0" tIns="0" rIns="0" bIns="0" rtlCol="0" anchor="t"/>
+          <a:lstStyle/>
+          <a:p>
+            <a:pPr indent="0" marL="0">
+              <a:buNone/>
+            </a:pPr>
+            <a:r>
+              <a:rPr lang="en-US" sz="1300" b="1" dirty="0">
+                <a:solidFill>
+                  <a:srgbClr val="1D1D1F"/>
                 </a:solidFill>
                 <a:latin typeface="SF Pro Display" pitchFamily="34" charset="0"/>
                 <a:ea typeface="SF Pro Display" pitchFamily="34" charset="-122"/>
                 <a:cs typeface="SF Pro Display" pitchFamily="34" charset="-120"/>
               </a:rPr>
-              <a:t>1</a:t>
-            </a:r>
-            <a:endParaRPr lang="en-US" sz="900" dirty="0"/>
-          </a:p>
-        </p:txBody>
-      </p:sp>
-      <p:sp>
-        <p:nvSpPr>
-          <p:cNvPr id="9" name="Text 6"/>
+              <a:t>Live ticket</a:t>
+            </a:r>
+            <a:endParaRPr lang="en-US" sz="1300" dirty="0"/>
+          </a:p>
+        </p:txBody>
+      </p:sp>
+      <p:sp>
+        <p:nvSpPr>
+          <p:cNvPr id="10" name="Text 6"/>
           <p:cNvSpPr txBox="1"/>
           <p:nvPr/>
         </p:nvSpPr>
         <p:spPr>
           <a:xfrm>
-            <a:off x="576072" y="1929384"/>
-            <a:ext cx="2353056" cy="274320"/>
+            <a:off x="594360" y="2350008"/>
+            <a:ext cx="3017520" cy="731520"/>
           </a:xfrm>
           <a:prstGeom prst="rect">
             <a:avLst/>
@@ -11537,46 +11603,7 @@
               <a:buNone/>
             </a:pPr>
             <a:r>
-              <a:rPr lang="en-US" sz="1200" b="1" dirty="0">
-                <a:solidFill>
-                  <a:srgbClr val="1D1D1F"/>
-                </a:solidFill>
-                <a:latin typeface="SF Pro Display" pitchFamily="34" charset="0"/>
-                <a:ea typeface="SF Pro Display" pitchFamily="34" charset="-122"/>
-                <a:cs typeface="SF Pro Display" pitchFamily="34" charset="-120"/>
-              </a:rPr>
-              <a:t>Validate first</a:t>
-            </a:r>
-            <a:endParaRPr lang="en-US" sz="1200" dirty="0"/>
-          </a:p>
-        </p:txBody>
-      </p:sp>
-      <p:sp>
-        <p:nvSpPr>
-          <p:cNvPr id="10" name="Text 7"/>
-          <p:cNvSpPr txBox="1"/>
-          <p:nvPr/>
-        </p:nvSpPr>
-        <p:spPr>
-          <a:xfrm>
-            <a:off x="576072" y="2221992"/>
-            <a:ext cx="2353056" cy="612648"/>
-          </a:xfrm>
-          <a:prstGeom prst="rect">
-            <a:avLst/>
-          </a:prstGeom>
-          <a:noFill/>
-          <a:ln/>
-        </p:spPr>
-        <p:txBody>
-          <a:bodyPr wrap="square" lIns="0" tIns="0" rIns="0" bIns="0" rtlCol="0" anchor="t"/>
-          <a:lstStyle/>
-          <a:p>
-            <a:pPr indent="0" marL="0">
-              <a:buNone/>
-            </a:pPr>
-            <a:r>
-              <a:rPr lang="en-US" sz="950" dirty="0">
+              <a:rPr lang="en-US" sz="1050" dirty="0">
                 <a:solidFill>
                   <a:srgbClr val="6E6E73"/>
                 </a:solidFill>
@@ -11584,26 +11611,73 @@
                 <a:ea typeface="SF Pro Text" pitchFamily="34" charset="-122"/>
                 <a:cs typeface="SF Pro Text" pitchFamily="34" charset="-120"/>
               </a:rPr>
-              <a:t>Check the six automatic waivers before anything else.</a:t>
-            </a:r>
-            <a:endParaRPr lang="en-US" sz="950" dirty="0"/>
-          </a:p>
-        </p:txBody>
-      </p:sp>
-      <p:sp>
-        <p:nvSpPr>
-          <p:cNvPr id="11" name="Shape 8"/>
+              <a:t>Your trainer will provide a live ticket. Review it and investigate before you decide anything.</a:t>
+            </a:r>
+            <a:endParaRPr lang="en-US" sz="1050" dirty="0"/>
+          </a:p>
+        </p:txBody>
+      </p:sp>
+      <p:sp>
+        <p:nvSpPr>
+          <p:cNvPr id="11" name="Text 7"/>
           <p:cNvSpPr/>
           <p:nvPr/>
         </p:nvSpPr>
         <p:spPr>
           <a:xfrm>
-            <a:off x="3230880" y="1325880"/>
-            <a:ext cx="2682240" cy="1600200"/>
+            <a:off x="594360" y="3401568"/>
+            <a:ext cx="1371600" cy="329184"/>
           </a:xfrm>
           <a:prstGeom prst="roundRect">
             <a:avLst>
-              <a:gd name="adj" fmla="val 4571"/>
+              <a:gd name="adj" fmla="val 22222"/>
+            </a:avLst>
+          </a:prstGeom>
+          <a:solidFill>
+            <a:srgbClr val="FFF3D6"/>
+          </a:solidFill>
+          <a:ln>
+            <a:solidFill>
+              <a:srgbClr val="FFF3D6"/>
+            </a:solidFill>
+          </a:ln>
+        </p:spPr>
+        <p:txBody>
+          <a:bodyPr wrap="square" lIns="0" tIns="0" rIns="0" bIns="0" rtlCol="0" anchor="ctr"/>
+          <a:lstStyle/>
+          <a:p>
+            <a:pPr algn="ctr" indent="0" marL="0">
+              <a:buNone/>
+            </a:pPr>
+            <a:r>
+              <a:rPr lang="en-US" sz="950" b="1" dirty="0">
+                <a:solidFill>
+                  <a:srgbClr val="9A6410"/>
+                </a:solidFill>
+                <a:latin typeface="SF Pro Text" pitchFamily="34" charset="0"/>
+                <a:ea typeface="SF Pro Text" pitchFamily="34" charset="-122"/>
+                <a:cs typeface="SF Pro Text" pitchFamily="34" charset="-120"/>
+              </a:rPr>
+              <a:t>Trainer provides</a:t>
+            </a:r>
+            <a:endParaRPr lang="en-US" sz="950" dirty="0"/>
+          </a:p>
+        </p:txBody>
+      </p:sp>
+      <p:sp>
+        <p:nvSpPr>
+          <p:cNvPr id="12" name="Shape 8"/>
+          <p:cNvSpPr/>
+          <p:nvPr/>
+        </p:nvSpPr>
+        <p:spPr>
+          <a:xfrm>
+            <a:off x="3931920" y="1298448"/>
+            <a:ext cx="4800600" cy="786384"/>
+          </a:xfrm>
+          <a:prstGeom prst="roundRect">
+            <a:avLst>
+              <a:gd name="adj" fmla="val 9302"/>
             </a:avLst>
           </a:prstGeom>
           <a:solidFill>
@@ -11619,13 +11693,13 @@
       </p:sp>
       <p:sp>
         <p:nvSpPr>
-          <p:cNvPr id="12" name="Shape 9"/>
+          <p:cNvPr id="13" name="Shape 9"/>
           <p:cNvSpPr/>
           <p:nvPr/>
         </p:nvSpPr>
         <p:spPr>
           <a:xfrm>
-            <a:off x="3395472" y="1508760"/>
+            <a:off x="4114800" y="1554480"/>
             <a:ext cx="274320" cy="274320"/>
           </a:xfrm>
           <a:prstGeom prst="ellipse">
@@ -11644,13 +11718,13 @@
       </p:sp>
       <p:sp>
         <p:nvSpPr>
-          <p:cNvPr id="13" name="Text 10"/>
+          <p:cNvPr id="14" name="Text 10"/>
           <p:cNvSpPr txBox="1"/>
           <p:nvPr/>
         </p:nvSpPr>
         <p:spPr>
           <a:xfrm>
-            <a:off x="3395472" y="1508760"/>
+            <a:off x="4114800" y="1554480"/>
             <a:ext cx="274320" cy="274320"/>
           </a:xfrm>
           <a:prstGeom prst="rect">
@@ -11675,7 +11749,7 @@
                 <a:ea typeface="SF Pro Display" pitchFamily="34" charset="-122"/>
                 <a:cs typeface="SF Pro Display" pitchFamily="34" charset="-120"/>
               </a:rPr>
-              <a:t>2</a:t>
+              <a:t>1</a:t>
             </a:r>
             <a:endParaRPr lang="en-US" sz="900" dirty="0"/>
           </a:p>
@@ -11683,14 +11757,14 @@
       </p:sp>
       <p:sp>
         <p:nvSpPr>
-          <p:cNvPr id="14" name="Text 11"/>
+          <p:cNvPr id="15" name="Text 11"/>
           <p:cNvSpPr txBox="1"/>
           <p:nvPr/>
         </p:nvSpPr>
         <p:spPr>
           <a:xfrm>
-            <a:off x="3395472" y="1929384"/>
-            <a:ext cx="2353056" cy="274320"/>
+            <a:off x="4572000" y="1426464"/>
+            <a:ext cx="3977640" cy="292608"/>
           </a:xfrm>
           <a:prstGeom prst="rect">
             <a:avLst/>
@@ -11699,14 +11773,14 @@
           <a:ln/>
         </p:spPr>
         <p:txBody>
-          <a:bodyPr wrap="square" lIns="0" tIns="0" rIns="0" bIns="0" rtlCol="0" anchor="t"/>
+          <a:bodyPr wrap="square" lIns="0" tIns="0" rIns="0" bIns="0" rtlCol="0" anchor="ctr"/>
           <a:lstStyle/>
           <a:p>
             <a:pPr indent="0" marL="0">
               <a:buNone/>
             </a:pPr>
             <a:r>
-              <a:rPr lang="en-US" sz="1200" b="1" dirty="0">
+              <a:rPr lang="en-US" sz="1250" b="1" dirty="0">
                 <a:solidFill>
                   <a:srgbClr val="1D1D1F"/>
                 </a:solidFill>
@@ -11714,22 +11788,22 @@
                 <a:ea typeface="SF Pro Display" pitchFamily="34" charset="-122"/>
                 <a:cs typeface="SF Pro Display" pitchFamily="34" charset="-120"/>
               </a:rPr>
-              <a:t>Invalid? Both sides</a:t>
-            </a:r>
-            <a:endParaRPr lang="en-US" sz="1200" dirty="0"/>
-          </a:p>
-        </p:txBody>
-      </p:sp>
-      <p:sp>
-        <p:nvSpPr>
-          <p:cNvPr id="15" name="Text 12"/>
+              <a:t>Is this a valid or invalid LMC fee? Why?</a:t>
+            </a:r>
+            <a:endParaRPr lang="en-US" sz="1250" dirty="0"/>
+          </a:p>
+        </p:txBody>
+      </p:sp>
+      <p:sp>
+        <p:nvSpPr>
+          <p:cNvPr id="16" name="Text 12"/>
           <p:cNvSpPr txBox="1"/>
           <p:nvPr/>
         </p:nvSpPr>
         <p:spPr>
           <a:xfrm>
-            <a:off x="3395472" y="2221992"/>
-            <a:ext cx="2353056" cy="612648"/>
+            <a:off x="4572000" y="1737360"/>
+            <a:ext cx="3977640" cy="256032"/>
           </a:xfrm>
           <a:prstGeom prst="rect">
             <a:avLst/>
@@ -11738,14 +11812,14 @@
           <a:ln/>
         </p:spPr>
         <p:txBody>
-          <a:bodyPr wrap="square" lIns="0" tIns="0" rIns="0" bIns="0" rtlCol="0" anchor="t"/>
+          <a:bodyPr wrap="square" lIns="0" tIns="0" rIns="0" bIns="0" rtlCol="0" anchor="ctr"/>
           <a:lstStyle/>
           <a:p>
             <a:pPr indent="0" marL="0">
               <a:buNone/>
             </a:pPr>
             <a:r>
-              <a:rPr lang="en-US" sz="950" dirty="0">
+              <a:rPr lang="en-US" sz="1000" dirty="0">
                 <a:solidFill>
                   <a:srgbClr val="6E6E73"/>
                 </a:solidFill>
@@ -11753,26 +11827,26 @@
                 <a:ea typeface="SF Pro Text" pitchFamily="34" charset="-122"/>
                 <a:cs typeface="SF Pro Text" pitchFamily="34" charset="-120"/>
               </a:rPr>
-              <a:t>Refund the customer, hold back the CP's $20.</a:t>
-            </a:r>
-            <a:endParaRPr lang="en-US" sz="950" dirty="0"/>
-          </a:p>
-        </p:txBody>
-      </p:sp>
-      <p:sp>
-        <p:nvSpPr>
-          <p:cNvPr id="16" name="Shape 13"/>
+              <a:t>Check the six waivers first, then the messages.</a:t>
+            </a:r>
+            <a:endParaRPr lang="en-US" sz="1000" dirty="0"/>
+          </a:p>
+        </p:txBody>
+      </p:sp>
+      <p:sp>
+        <p:nvSpPr>
+          <p:cNvPr id="17" name="Shape 13"/>
           <p:cNvSpPr/>
           <p:nvPr/>
         </p:nvSpPr>
         <p:spPr>
           <a:xfrm>
-            <a:off x="6050280" y="1325880"/>
-            <a:ext cx="2682240" cy="1600200"/>
+            <a:off x="3931920" y="2221992"/>
+            <a:ext cx="4800600" cy="786384"/>
           </a:xfrm>
           <a:prstGeom prst="roundRect">
             <a:avLst>
-              <a:gd name="adj" fmla="val 4571"/>
+              <a:gd name="adj" fmla="val 9302"/>
             </a:avLst>
           </a:prstGeom>
           <a:solidFill>
@@ -11788,13 +11862,13 @@
       </p:sp>
       <p:sp>
         <p:nvSpPr>
-          <p:cNvPr id="17" name="Shape 14"/>
+          <p:cNvPr id="18" name="Shape 14"/>
           <p:cNvSpPr/>
           <p:nvPr/>
         </p:nvSpPr>
         <p:spPr>
           <a:xfrm>
-            <a:off x="6214872" y="1508760"/>
+            <a:off x="4114800" y="2478024"/>
             <a:ext cx="274320" cy="274320"/>
           </a:xfrm>
           <a:prstGeom prst="ellipse">
@@ -11813,13 +11887,13 @@
       </p:sp>
       <p:sp>
         <p:nvSpPr>
-          <p:cNvPr id="18" name="Text 15"/>
+          <p:cNvPr id="19" name="Text 15"/>
           <p:cNvSpPr txBox="1"/>
           <p:nvPr/>
         </p:nvSpPr>
         <p:spPr>
           <a:xfrm>
-            <a:off x="6214872" y="1508760"/>
+            <a:off x="4114800" y="2478024"/>
             <a:ext cx="274320" cy="274320"/>
           </a:xfrm>
           <a:prstGeom prst="rect">
@@ -11844,7 +11918,7 @@
                 <a:ea typeface="SF Pro Display" pitchFamily="34" charset="-122"/>
                 <a:cs typeface="SF Pro Display" pitchFamily="34" charset="-120"/>
               </a:rPr>
-              <a:t>3</a:t>
+              <a:t>2</a:t>
             </a:r>
             <a:endParaRPr lang="en-US" sz="900" dirty="0"/>
           </a:p>
@@ -11852,14 +11926,14 @@
       </p:sp>
       <p:sp>
         <p:nvSpPr>
-          <p:cNvPr id="19" name="Text 16"/>
+          <p:cNvPr id="20" name="Text 16"/>
           <p:cNvSpPr txBox="1"/>
           <p:nvPr/>
         </p:nvSpPr>
         <p:spPr>
           <a:xfrm>
-            <a:off x="6214872" y="1929384"/>
-            <a:ext cx="2353056" cy="274320"/>
+            <a:off x="4572000" y="2350008"/>
+            <a:ext cx="3977640" cy="292608"/>
           </a:xfrm>
           <a:prstGeom prst="rect">
             <a:avLst/>
@@ -11868,14 +11942,14 @@
           <a:ln/>
         </p:spPr>
         <p:txBody>
-          <a:bodyPr wrap="square" lIns="0" tIns="0" rIns="0" bIns="0" rtlCol="0" anchor="t"/>
+          <a:bodyPr wrap="square" lIns="0" tIns="0" rIns="0" bIns="0" rtlCol="0" anchor="ctr"/>
           <a:lstStyle/>
           <a:p>
             <a:pPr indent="0" marL="0">
               <a:buNone/>
             </a:pPr>
             <a:r>
-              <a:rPr lang="en-US" sz="1200" b="1" dirty="0">
+              <a:rPr lang="en-US" sz="1250" b="1" dirty="0">
                 <a:solidFill>
                   <a:srgbClr val="1D1D1F"/>
                 </a:solidFill>
@@ -11883,22 +11957,22 @@
                 <a:ea typeface="SF Pro Display" pitchFamily="34" charset="-122"/>
                 <a:cs typeface="SF Pro Display" pitchFamily="34" charset="-120"/>
               </a:rPr>
-              <a:t>Valid? Not a ladder</a:t>
-            </a:r>
-            <a:endParaRPr lang="en-US" sz="1200" dirty="0"/>
-          </a:p>
-        </p:txBody>
-      </p:sp>
-      <p:sp>
-        <p:nvSpPr>
-          <p:cNvPr id="20" name="Text 17"/>
+              <a:t>What actions are you going to take?</a:t>
+            </a:r>
+            <a:endParaRPr lang="en-US" sz="1250" dirty="0"/>
+          </a:p>
+        </p:txBody>
+      </p:sp>
+      <p:sp>
+        <p:nvSpPr>
+          <p:cNvPr id="21" name="Text 17"/>
           <p:cNvSpPr txBox="1"/>
           <p:nvPr/>
         </p:nvSpPr>
         <p:spPr>
           <a:xfrm>
-            <a:off x="6214872" y="2221992"/>
-            <a:ext cx="2353056" cy="612648"/>
+            <a:off x="4572000" y="2660904"/>
+            <a:ext cx="3977640" cy="256032"/>
           </a:xfrm>
           <a:prstGeom prst="rect">
             <a:avLst/>
@@ -11907,14 +11981,14 @@
           <a:ln/>
         </p:spPr>
         <p:txBody>
-          <a:bodyPr wrap="square" lIns="0" tIns="0" rIns="0" bIns="0" rtlCol="0" anchor="t"/>
+          <a:bodyPr wrap="square" lIns="0" tIns="0" rIns="0" bIns="0" rtlCol="0" anchor="ctr"/>
           <a:lstStyle/>
           <a:p>
             <a:pPr indent="0" marL="0">
               <a:buNone/>
             </a:pPr>
             <a:r>
-              <a:rPr lang="en-US" sz="950" dirty="0">
+              <a:rPr lang="en-US" sz="1000" dirty="0">
                 <a:solidFill>
                   <a:srgbClr val="6E6E73"/>
                 </a:solidFill>
@@ -11922,26 +11996,195 @@
                 <a:ea typeface="SF Pro Text" pitchFamily="34" charset="-122"/>
                 <a:cs typeface="SF Pro Text" pitchFamily="34" charset="-120"/>
               </a:rPr>
-              <a:t>Go straight to the category's offer.</a:t>
-            </a:r>
-            <a:endParaRPr lang="en-US" sz="950" dirty="0"/>
-          </a:p>
-        </p:txBody>
-      </p:sp>
-      <p:sp>
-        <p:nvSpPr>
-          <p:cNvPr id="21" name="Shape 18"/>
+              <a:t>Invalid: refund + $20 holdback. Valid: customer category.</a:t>
+            </a:r>
+            <a:endParaRPr lang="en-US" sz="1000" dirty="0"/>
+          </a:p>
+        </p:txBody>
+      </p:sp>
+      <p:sp>
+        <p:nvSpPr>
+          <p:cNvPr id="22" name="Shape 18"/>
           <p:cNvSpPr/>
           <p:nvPr/>
         </p:nvSpPr>
         <p:spPr>
           <a:xfrm>
-            <a:off x="411480" y="3108960"/>
-            <a:ext cx="8321040" cy="914400"/>
+            <a:off x="3931920" y="3145536"/>
+            <a:ext cx="4800600" cy="786384"/>
           </a:xfrm>
           <a:prstGeom prst="roundRect">
             <a:avLst>
-              <a:gd name="adj" fmla="val 8000"/>
+              <a:gd name="adj" fmla="val 9302"/>
+            </a:avLst>
+          </a:prstGeom>
+          <a:solidFill>
+            <a:srgbClr val="FFFFFF"/>
+          </a:solidFill>
+          <a:ln w="9525">
+            <a:solidFill>
+              <a:srgbClr val="DCE1E7"/>
+            </a:solidFill>
+            <a:prstDash val="solid"/>
+          </a:ln>
+        </p:spPr>
+      </p:sp>
+      <p:sp>
+        <p:nvSpPr>
+          <p:cNvPr id="23" name="Shape 19"/>
+          <p:cNvSpPr/>
+          <p:nvPr/>
+        </p:nvSpPr>
+        <p:spPr>
+          <a:xfrm>
+            <a:off x="4114800" y="3401568"/>
+            <a:ext cx="274320" cy="274320"/>
+          </a:xfrm>
+          <a:prstGeom prst="ellipse">
+            <a:avLst/>
+          </a:prstGeom>
+          <a:solidFill>
+            <a:srgbClr val="E3F4F1"/>
+          </a:solidFill>
+          <a:ln w="12700">
+            <a:solidFill>
+              <a:srgbClr val="E3F4F1"/>
+            </a:solidFill>
+            <a:prstDash val="solid"/>
+          </a:ln>
+        </p:spPr>
+      </p:sp>
+      <p:sp>
+        <p:nvSpPr>
+          <p:cNvPr id="24" name="Text 20"/>
+          <p:cNvSpPr txBox="1"/>
+          <p:nvPr/>
+        </p:nvSpPr>
+        <p:spPr>
+          <a:xfrm>
+            <a:off x="4114800" y="3401568"/>
+            <a:ext cx="274320" cy="274320"/>
+          </a:xfrm>
+          <a:prstGeom prst="rect">
+            <a:avLst/>
+          </a:prstGeom>
+          <a:noFill/>
+          <a:ln/>
+        </p:spPr>
+        <p:txBody>
+          <a:bodyPr wrap="square" lIns="0" tIns="0" rIns="0" bIns="0" rtlCol="0" anchor="ctr"/>
+          <a:lstStyle/>
+          <a:p>
+            <a:pPr algn="ctr" indent="0" marL="0">
+              <a:buNone/>
+            </a:pPr>
+            <a:r>
+              <a:rPr lang="en-US" sz="900" b="1" dirty="0">
+                <a:solidFill>
+                  <a:srgbClr val="0B7A6F"/>
+                </a:solidFill>
+                <a:latin typeface="SF Pro Display" pitchFamily="34" charset="0"/>
+                <a:ea typeface="SF Pro Display" pitchFamily="34" charset="-122"/>
+                <a:cs typeface="SF Pro Display" pitchFamily="34" charset="-120"/>
+              </a:rPr>
+              <a:t>3</a:t>
+            </a:r>
+            <a:endParaRPr lang="en-US" sz="900" dirty="0"/>
+          </a:p>
+        </p:txBody>
+      </p:sp>
+      <p:sp>
+        <p:nvSpPr>
+          <p:cNvPr id="25" name="Text 21"/>
+          <p:cNvSpPr txBox="1"/>
+          <p:nvPr/>
+        </p:nvSpPr>
+        <p:spPr>
+          <a:xfrm>
+            <a:off x="4572000" y="3273552"/>
+            <a:ext cx="3977640" cy="292608"/>
+          </a:xfrm>
+          <a:prstGeom prst="rect">
+            <a:avLst/>
+          </a:prstGeom>
+          <a:noFill/>
+          <a:ln/>
+        </p:spPr>
+        <p:txBody>
+          <a:bodyPr wrap="square" lIns="0" tIns="0" rIns="0" bIns="0" rtlCol="0" anchor="ctr"/>
+          <a:lstStyle/>
+          <a:p>
+            <a:pPr indent="0" marL="0">
+              <a:buNone/>
+            </a:pPr>
+            <a:r>
+              <a:rPr lang="en-US" sz="1250" b="1" dirty="0">
+                <a:solidFill>
+                  <a:srgbClr val="1D1D1F"/>
+                </a:solidFill>
+                <a:latin typeface="SF Pro Display" pitchFamily="34" charset="0"/>
+                <a:ea typeface="SF Pro Display" pitchFamily="34" charset="-122"/>
+                <a:cs typeface="SF Pro Display" pitchFamily="34" charset="-120"/>
+              </a:rPr>
+              <a:t>5-min writing challenge</a:t>
+            </a:r>
+            <a:endParaRPr lang="en-US" sz="1250" dirty="0"/>
+          </a:p>
+        </p:txBody>
+      </p:sp>
+      <p:sp>
+        <p:nvSpPr>
+          <p:cNvPr id="26" name="Text 22"/>
+          <p:cNvSpPr txBox="1"/>
+          <p:nvPr/>
+        </p:nvSpPr>
+        <p:spPr>
+          <a:xfrm>
+            <a:off x="4572000" y="3584448"/>
+            <a:ext cx="3977640" cy="256032"/>
+          </a:xfrm>
+          <a:prstGeom prst="rect">
+            <a:avLst/>
+          </a:prstGeom>
+          <a:noFill/>
+          <a:ln/>
+        </p:spPr>
+        <p:txBody>
+          <a:bodyPr wrap="square" lIns="0" tIns="0" rIns="0" bIns="0" rtlCol="0" anchor="ctr"/>
+          <a:lstStyle/>
+          <a:p>
+            <a:pPr indent="0" marL="0">
+              <a:buNone/>
+            </a:pPr>
+            <a:r>
+              <a:rPr lang="en-US" sz="1000" dirty="0">
+                <a:solidFill>
+                  <a:srgbClr val="6E6E73"/>
+                </a:solidFill>
+                <a:latin typeface="SF Pro Text" pitchFamily="34" charset="0"/>
+                <a:ea typeface="SF Pro Text" pitchFamily="34" charset="-122"/>
+                <a:cs typeface="SF Pro Text" pitchFamily="34" charset="-120"/>
+              </a:rPr>
+              <a:t>Create your comms for the customer.</a:t>
+            </a:r>
+            <a:endParaRPr lang="en-US" sz="1000" dirty="0"/>
+          </a:p>
+        </p:txBody>
+      </p:sp>
+      <p:sp>
+        <p:nvSpPr>
+          <p:cNvPr id="27" name="Shape 23"/>
+          <p:cNvSpPr/>
+          <p:nvPr/>
+        </p:nvSpPr>
+        <p:spPr>
+          <a:xfrm>
+            <a:off x="411480" y="4069080"/>
+            <a:ext cx="8321040" cy="502920"/>
+          </a:xfrm>
+          <a:prstGeom prst="roundRect">
+            <a:avLst>
+              <a:gd name="adj" fmla="val 14545"/>
             </a:avLst>
           </a:prstGeom>
           <a:solidFill>
@@ -11957,22 +12200,22 @@
       </p:sp>
       <p:pic>
         <p:nvPicPr>
-          <p:cNvPr id="22" name="Image 0" descr="preencoded.png">    </p:cNvPr>
+          <p:cNvPr id="28" name="Image 1" descr="preencoded.png">    </p:cNvPr>
           <p:cNvPicPr>
             <a:picLocks noChangeAspect="1"/>
           </p:cNvPicPr>
           <p:nvPr/>
         </p:nvPicPr>
         <p:blipFill>
-          <a:blip r:embed="rId1"/>
+          <a:blip r:embed="rId2"/>
           <a:stretch>
             <a:fillRect/>
           </a:stretch>
         </p:blipFill>
         <p:spPr>
           <a:xfrm>
-            <a:off x="731520" y="3383280"/>
-            <a:ext cx="365760" cy="365760"/>
+            <a:off x="640080" y="4192524"/>
+            <a:ext cx="256032" cy="256032"/>
           </a:xfrm>
           <a:prstGeom prst="rect">
             <a:avLst/>
@@ -11981,14 +12224,14 @@
       </p:pic>
       <p:sp>
         <p:nvSpPr>
-          <p:cNvPr id="23" name="Text 19"/>
+          <p:cNvPr id="29" name="Text 24"/>
           <p:cNvSpPr txBox="1"/>
           <p:nvPr/>
         </p:nvSpPr>
         <p:spPr>
           <a:xfrm>
-            <a:off x="1325880" y="3108960"/>
-            <a:ext cx="7223760" cy="914400"/>
+            <a:off x="1051560" y="4069080"/>
+            <a:ext cx="7498080" cy="502920"/>
           </a:xfrm>
           <a:prstGeom prst="rect">
             <a:avLst/>
@@ -12004,7 +12247,7 @@
               <a:buNone/>
             </a:pPr>
             <a:r>
-              <a:rPr lang="en-US" sz="2000" b="1" dirty="0">
+              <a:rPr lang="en-US" sz="1400" b="1" dirty="0">
                 <a:solidFill>
                   <a:srgbClr val="FFFFFF"/>
                 </a:solidFill>
@@ -12012,11 +12255,8 @@
                 <a:ea typeface="SF Pro Display" pitchFamily="34" charset="-122"/>
                 <a:cs typeface="SF Pro Display" pitchFamily="34" charset="-120"/>
               </a:rPr>
-              <a:t>Questions?</a:t>
-            </a:r>
-            <a:endParaRPr lang="en-US" sz="2000" dirty="0"/>
-          </a:p>
-          <a:p>
+              <a:t>Questions?  </a:t>
+            </a:r>
             <a:pPr indent="0" marL="0">
               <a:buNone/>
             </a:pPr>
@@ -12031,7 +12271,7 @@
               </a:rPr>
               <a:t>Open the floor before we move to the next topic.</a:t>
             </a:r>
-            <a:endParaRPr lang="en-US" sz="2000" dirty="0"/>
+            <a:endParaRPr lang="en-US" sz="1400" dirty="0"/>
           </a:p>
         </p:txBody>
       </p:sp>

</xml_diff>

<commit_message>
Lockout Step 1 slide: Always note replaces the Important panel; keep trainer's Invalid box edit
Co-Authored-By: Claude Opus 5.5 <noreply@anthropic.com>
Claude-Session: https://claude.ai/code/session_01FEzv8wwqWDgTsXP8Yz6XYn
</commit_message>
<xml_diff>
--- a/incorrect-info-lmc-lockout/incorrect-info-lmc-lockout.pptx
+++ b/incorrect-info-lmc-lockout/incorrect-info-lmc-lockout.pptx
@@ -1672,7 +1672,7 @@
           <a:p>
             <a:r>
               <a:rPr lang="en-US" dirty="0"/>
-              <a:t>Ask these four questions in order. Any "no" typically means the lockout is invalid. Always leave an internal note documenting your findings: it's your reference if either party disputes the outcome later. Invalid: refund through the CP Dashboard (it charges the cost back to the CP, who made the error), not an admin refund; also refund the Premium fee if any. All yes: valid, go to Step 3 (click the All yes box). WHAT TO CHECK: 1) Customer's messages to the CP. Mentioned cancelling or rescheduling more than 6 hours before start: invalid, the CP shouldn't have gone. Within 6 hours: if the CP acknowledged the appointment wouldn't happen, still invalid. 2) CPs may arrive 30 minutes before up to 30 minutes after the start time. Check call/text timestamps, CP-to-Care comms, check-in messages, GPS screenshots, CP App "approaching" notifications. More than 30 min late: invalid. Exception: the evidence shows the customer had already decided not to have the appointment (e.g. told Support but the job wasn't cancelled and the CP wasn't told; or told the CP after start time that they'd cancelled long before). The CP still has to show they were on site and tried to reach the customer. Coach lateness separately. 3) CP messages confirming arrival, CTJ logs, pre-evidence photos, or a selfie at the home. A photo of the house without the CP in frame: check it isn't reused or reverse-searchable. A photo is only required for CP Dashboard submissions, not the CP App. Faked (not just weak) evidence: stop and go to AG – Fraud › CP Document Fraud. 4) At least 2 contact attempts, at least 5 minutes apart, staying at least 15 minutes, and following any entry notes. Same rule for CP App and CP Dashboard. Confirm with timestamps: contact attempts, the lockout action in Job History, CP messages to the customer or CS. Waived if the CP says the customer refused entry or asked to cancel on arrival: then look for other proof the CP was on site on time. IMPORTANT: These requirements may be disregarded if the CP claims that the C did not let them in or wanted to cancel upon their arrival. If this is the case, check for other indicators proving that CP did arrive on time at the C's location. TRAINER: the details are hidden when the slide opens. Click 1 opens question 1's details, click 2 swaps to question 2, click 3 to question 3, click 4 to question 4, click 5 closes them. In slideshow mode, click the All yes box to jump to Step 3.</a:t>
+              <a:t>Ask these four questions in order. Any "no" typically means the lockout is invalid. Always leave an internal note documenting your findings: it's your reference if either party disputes the outcome later. Invalid: refund through the CP Dashboard (it charges the cost back to the CP, who made the error), not an admin refund; also refund the Premium fee if any. All yes: valid, go to Step 3 (click the All yes box). WHAT TO CHECK: 1) Customer's messages to the CP. Mentioned cancelling or rescheduling more than 6 hours before start: invalid, the CP shouldn't have gone. Within 6 hours: if the CP acknowledged the appointment wouldn't happen, still invalid. 2) CPs may arrive 30 minutes before up to 30 minutes after the start time. Check call/text timestamps, CP-to-Care comms, check-in messages, GPS screenshots, CP App "approaching" notifications. More than 30 min late: invalid. Exception: the evidence shows the customer had already decided not to have the appointment (e.g. told Support but the job wasn't cancelled and the CP wasn't told; or told the CP after start time that they'd cancelled long before). The CP still has to show they were on site and tried to reach the customer. Coach lateness separately. 3) CP messages confirming arrival, CTJ logs, pre-evidence photos, or a selfie at the home. A photo of the house without the CP in frame: check it isn't reused or reverse-searchable. A photo is only required for CP Dashboard submissions, not the CP App. Faked (not just weak) evidence: stop and go to AG – Fraud › CP Document Fraud. 4) At least 2 contact attempts, at least 5 minutes apart, staying at least 15 minutes, and following any entry notes. Same rule for CP App and CP Dashboard. Confirm with timestamps: contact attempts, the lockout action in Job History, CP messages to the customer or CS. Waived if the CP says the customer refused entry or asked to cancel on arrival: then look for other proof the CP was on site on time. IMPORTANT: These requirements may be disregarded if the CP claims that the C did not let them in or wanted to cancel upon their arrival. If this is the case, check for other indicators proving that CP did arrive on time at the C's location. TRAINER: the Always note shows on the right when the slide opens; the details are hidden. Click 1 opens question 1's details, click 2 swaps to question 2, click 3 to question 3, click 4 to question 4, click 5 closes them. In slideshow mode, click the All yes box to jump to Step 3.</a:t>
             </a:r>
             <a:endParaRPr lang="en-US" dirty="0"/>
           </a:p>
@@ -15642,12 +15642,12 @@
         </p:nvSpPr>
         <p:spPr>
           <a:xfrm>
-            <a:off x="4279392" y="2048256"/>
-            <a:ext cx="1463040" cy="457200"/>
+            <a:off x="4279392" y="1920240"/>
+            <a:ext cx="1463040" cy="676656"/>
           </a:xfrm>
           <a:prstGeom prst="roundRect">
             <a:avLst>
-              <a:gd name="adj" fmla="val 16000"/>
+              <a:gd name="adj" fmla="val 10811"/>
             </a:avLst>
           </a:prstGeom>
           <a:solidFill>
@@ -15669,8 +15669,8 @@
         </p:nvSpPr>
         <p:spPr>
           <a:xfrm>
-            <a:off x="4279392" y="2048256"/>
-            <a:ext cx="1463040" cy="457200"/>
+            <a:off x="4315968" y="1920240"/>
+            <a:ext cx="1389888" cy="713232"/>
           </a:xfrm>
           <a:prstGeom prst="rect">
             <a:avLst/>
@@ -15715,28 +15715,6 @@
             </a:r>
             <a:endParaRPr lang="en-US" sz="1000" dirty="0"/>
           </a:p>
-        </p:txBody>
-      </p:sp>
-      <p:sp>
-        <p:nvSpPr>
-          <p:cNvPr id="36" name="Text 33"/>
-          <p:cNvSpPr txBox="1"/>
-          <p:nvPr/>
-        </p:nvSpPr>
-        <p:spPr>
-          <a:xfrm>
-            <a:off x="4233672" y="2551176"/>
-            <a:ext cx="1783080" cy="228600"/>
-          </a:xfrm>
-          <a:prstGeom prst="rect">
-            <a:avLst/>
-          </a:prstGeom>
-          <a:noFill/>
-          <a:ln/>
-        </p:spPr>
-        <p:txBody>
-          <a:bodyPr wrap="square" lIns="0" tIns="0" rIns="0" bIns="0" rtlCol="0" anchor="t"/>
-          <a:lstStyle/>
           <a:p>
             <a:pPr algn="ctr" indent="0" marL="0">
               <a:buNone/>
@@ -15744,21 +15722,21 @@
             <a:r>
               <a:rPr lang="en-US" sz="800" b="1" dirty="0">
                 <a:solidFill>
-                  <a:srgbClr val="1D1D1F"/>
-                </a:solidFill>
-                <a:latin typeface="SF Pro Text" pitchFamily="34" charset="0"/>
-                <a:ea typeface="SF Pro Text" pitchFamily="34" charset="-122"/>
-                <a:cs typeface="SF Pro Text" pitchFamily="34" charset="-120"/>
-              </a:rPr>
-              <a:t>Also refund the Premium fee, if any.</a:t>
-            </a:r>
-            <a:endParaRPr lang="en-US" sz="800" dirty="0"/>
-          </a:p>
-        </p:txBody>
-      </p:sp>
-      <p:sp>
-        <p:nvSpPr>
-          <p:cNvPr id="37" name="Shape 34"/>
+                  <a:srgbClr val="FFFFFF"/>
+                </a:solidFill>
+                <a:latin typeface="SF Pro Display" pitchFamily="34" charset="0"/>
+                <a:ea typeface="SF Pro Display" pitchFamily="34" charset="-122"/>
+                <a:cs typeface="SF Pro Display" pitchFamily="34" charset="-120"/>
+              </a:rPr>
+              <a:t>Premium fee charged? → Refund  </a:t>
+            </a:r>
+            <a:endParaRPr lang="en-US" sz="1000" dirty="0"/>
+          </a:p>
+        </p:txBody>
+      </p:sp>
+      <p:sp>
+        <p:nvSpPr>
+          <p:cNvPr id="36" name="Shape 33"/>
           <p:cNvSpPr/>
           <p:nvPr/>
         </p:nvSpPr>
@@ -15782,7 +15760,7 @@
       </p:sp>
       <p:sp>
         <p:nvSpPr>
-          <p:cNvPr id="38" name="Text 35"/>
+          <p:cNvPr id="37" name="Text 34"/>
           <p:cNvSpPr txBox="1"/>
           <p:nvPr/>
         </p:nvSpPr>
@@ -15821,7 +15799,7 @@
       </p:sp>
       <p:sp>
         <p:nvSpPr>
-          <p:cNvPr id="39" name="Shape 36">
+          <p:cNvPr id="38" name="Shape 35">
             <a:hlinkClick r:id="rId1" tooltip="Go to Step 3: valid lockout, check the customer category" action="ppaction://hlinksldjump"/>
           </p:cNvPr>
           <p:cNvSpPr/>
@@ -15850,7 +15828,7 @@
       </p:sp>
       <p:sp>
         <p:nvSpPr>
-          <p:cNvPr id="40" name="Text 37">
+          <p:cNvPr id="39" name="Text 36">
             <a:hlinkClick r:id="rId2" tooltip="Go to Step 3: valid lockout, check the customer category" action="ppaction://hlinksldjump"/>
           </p:cNvPr>
           <p:cNvSpPr/>
@@ -15891,7 +15869,7 @@
       </p:sp>
       <p:sp>
         <p:nvSpPr>
-          <p:cNvPr id="41" name="Shape 38"/>
+          <p:cNvPr id="40" name="Shape 37"/>
           <p:cNvSpPr/>
           <p:nvPr/>
         </p:nvSpPr>
@@ -15902,15 +15880,15 @@
           </a:xfrm>
           <a:prstGeom prst="roundRect">
             <a:avLst>
-              <a:gd name="adj" fmla="val 3008"/>
+              <a:gd name="adj" fmla="val 2256"/>
             </a:avLst>
           </a:prstGeom>
           <a:solidFill>
-            <a:srgbClr val="FFF3D6"/>
+            <a:srgbClr val="FFFFFF"/>
           </a:solidFill>
-          <a:ln w="9525">
+          <a:ln w="19050">
             <a:solidFill>
-              <a:srgbClr val="9A6410"/>
+              <a:srgbClr val="0B7A6F"/>
             </a:solidFill>
             <a:prstDash val="solid"/>
           </a:ln>
@@ -15918,7 +15896,7 @@
       </p:sp>
       <p:pic>
         <p:nvPicPr>
-          <p:cNvPr id="42" name="Image 0" descr="preencoded.png">    </p:cNvPr>
+          <p:cNvPr id="41" name="Image 0" descr="preencoded.png">    </p:cNvPr>
           <p:cNvPicPr>
             <a:picLocks noChangeAspect="1"/>
           </p:cNvPicPr>
@@ -15932,7 +15910,7 @@
         </p:blipFill>
         <p:spPr>
           <a:xfrm>
-            <a:off x="6016752" y="1481328"/>
+            <a:off x="6035040" y="1499616"/>
             <a:ext cx="182880" cy="182880"/>
           </a:xfrm>
           <a:prstGeom prst="rect">
@@ -15942,14 +15920,14 @@
       </p:pic>
       <p:sp>
         <p:nvSpPr>
-          <p:cNvPr id="43" name="Text 39"/>
+          <p:cNvPr id="42" name="Text 38"/>
           <p:cNvSpPr txBox="1"/>
           <p:nvPr/>
         </p:nvSpPr>
         <p:spPr>
           <a:xfrm>
-            <a:off x="6263640" y="1435608"/>
-            <a:ext cx="2331720" cy="274320"/>
+            <a:off x="6291072" y="1435608"/>
+            <a:ext cx="2331720" cy="310896"/>
           </a:xfrm>
           <a:prstGeom prst="rect">
             <a:avLst/>
@@ -15965,30 +15943,30 @@
               <a:buNone/>
             </a:pPr>
             <a:r>
-              <a:rPr lang="en-US" sz="1150" b="1" dirty="0">
-                <a:solidFill>
-                  <a:srgbClr val="9A6410"/>
+              <a:rPr lang="en-US" sz="1200" b="1" dirty="0">
+                <a:solidFill>
+                  <a:srgbClr val="0B7A6F"/>
                 </a:solidFill>
                 <a:latin typeface="SF Pro Display" pitchFamily="34" charset="0"/>
                 <a:ea typeface="SF Pro Display" pitchFamily="34" charset="-122"/>
                 <a:cs typeface="SF Pro Display" pitchFamily="34" charset="-120"/>
               </a:rPr>
-              <a:t>Important</a:t>
-            </a:r>
-            <a:endParaRPr lang="en-US" sz="1150" dirty="0"/>
-          </a:p>
-        </p:txBody>
-      </p:sp>
-      <p:sp>
-        <p:nvSpPr>
-          <p:cNvPr id="44" name="Text 40"/>
+              <a:t>Always:</a:t>
+            </a:r>
+            <a:endParaRPr lang="en-US" sz="1200" dirty="0"/>
+          </a:p>
+        </p:txBody>
+      </p:sp>
+      <p:sp>
+        <p:nvSpPr>
+          <p:cNvPr id="43" name="Text 39"/>
           <p:cNvSpPr txBox="1"/>
           <p:nvPr/>
         </p:nvSpPr>
         <p:spPr>
           <a:xfrm>
-            <a:off x="6016752" y="1801368"/>
-            <a:ext cx="2551176" cy="1792224"/>
+            <a:off x="6035040" y="1828800"/>
+            <a:ext cx="2514600" cy="457200"/>
           </a:xfrm>
           <a:prstGeom prst="rect">
             <a:avLst/>
@@ -16001,13 +15979,79 @@
           <a:lstStyle/>
           <a:p>
             <a:pPr indent="0" marL="0">
+              <a:buNone/>
+            </a:pPr>
+            <a:r>
+              <a:rPr lang="en-US" sz="1100" b="1" dirty="0">
+                <a:solidFill>
+                  <a:srgbClr val="1D1D1F"/>
+                </a:solidFill>
+                <a:latin typeface="SF Pro Display" pitchFamily="34" charset="0"/>
+                <a:ea typeface="SF Pro Display" pitchFamily="34" charset="-122"/>
+                <a:cs typeface="SF Pro Display" pitchFamily="34" charset="-120"/>
+              </a:rPr>
+              <a:t>Leave an internal note with your findings.</a:t>
+            </a:r>
+            <a:endParaRPr lang="en-US" sz="1100" dirty="0"/>
+          </a:p>
+        </p:txBody>
+      </p:sp>
+      <p:sp>
+        <p:nvSpPr>
+          <p:cNvPr id="44" name="Shape 40"/>
+          <p:cNvSpPr/>
+          <p:nvPr/>
+        </p:nvSpPr>
+        <p:spPr>
+          <a:xfrm>
+            <a:off x="6035040" y="2395728"/>
+            <a:ext cx="2514600" cy="868680"/>
+          </a:xfrm>
+          <a:prstGeom prst="roundRect">
+            <a:avLst>
+              <a:gd name="adj" fmla="val 8421"/>
+            </a:avLst>
+          </a:prstGeom>
+          <a:solidFill>
+            <a:srgbClr val="E3F4F1"/>
+          </a:solidFill>
+          <a:ln w="9525">
+            <a:solidFill>
+              <a:srgbClr val="E3F4F1"/>
+            </a:solidFill>
+            <a:prstDash val="solid"/>
+          </a:ln>
+        </p:spPr>
+      </p:sp>
+      <p:sp>
+        <p:nvSpPr>
+          <p:cNvPr id="45" name="Text 41"/>
+          <p:cNvSpPr txBox="1"/>
+          <p:nvPr/>
+        </p:nvSpPr>
+        <p:spPr>
+          <a:xfrm>
+            <a:off x="6172200" y="2468880"/>
+            <a:ext cx="2240280" cy="731520"/>
+          </a:xfrm>
+          <a:prstGeom prst="rect">
+            <a:avLst/>
+          </a:prstGeom>
+          <a:noFill/>
+          <a:ln/>
+        </p:spPr>
+        <p:txBody>
+          <a:bodyPr wrap="square" lIns="0" tIns="0" rIns="0" bIns="0" rtlCol="0" anchor="ctr"/>
+          <a:lstStyle/>
+          <a:p>
+            <a:pPr indent="0" marL="0">
               <a:spcAft>
-                <a:spcPts val="400"/>
+                <a:spcPts val="300"/>
               </a:spcAft>
               <a:buNone/>
             </a:pPr>
             <a:r>
-              <a:rPr lang="en-US" sz="950" dirty="0">
+              <a:rPr lang="en-US" sz="950" b="1" dirty="0">
                 <a:solidFill>
                   <a:srgbClr val="1D1D1F"/>
                 </a:solidFill>
@@ -16015,15 +16059,55 @@
                 <a:ea typeface="SF Pro Text" pitchFamily="34" charset="-122"/>
                 <a:cs typeface="SF Pro Text" pitchFamily="34" charset="-120"/>
               </a:rPr>
-              <a:t>These requirements may be disregarded if the CP claims that the C did not let them in or wanted to cancel upon their arrival. If this is the case, check for other indicators proving that CP did arrive on time at the C’s location.</a:t>
+              <a:t>Job ID 45371</a:t>
             </a:r>
             <a:endParaRPr lang="en-US" sz="950" dirty="0"/>
           </a:p>
-        </p:txBody>
-      </p:sp>
-      <p:sp>
-        <p:nvSpPr>
-          <p:cNvPr id="45" name="pop1_2Panel"/>
+          <a:p>
+            <a:pPr indent="0" marL="0">
+              <a:spcAft>
+                <a:spcPts val="300"/>
+              </a:spcAft>
+              <a:buNone/>
+            </a:pPr>
+            <a:r>
+              <a:rPr lang="en-US" sz="950" b="1" dirty="0">
+                <a:solidFill>
+                  <a:srgbClr val="1D1D1F"/>
+                </a:solidFill>
+                <a:latin typeface="SF Pro Text" pitchFamily="34" charset="0"/>
+                <a:ea typeface="SF Pro Text" pitchFamily="34" charset="-122"/>
+                <a:cs typeface="SF Pro Text" pitchFamily="34" charset="-120"/>
+              </a:rPr>
+              <a:t>Invalid Lockout</a:t>
+            </a:r>
+            <a:endParaRPr lang="en-US" sz="950" dirty="0"/>
+          </a:p>
+          <a:p>
+            <a:pPr indent="0" marL="0">
+              <a:spcAft>
+                <a:spcPts val="300"/>
+              </a:spcAft>
+              <a:buNone/>
+            </a:pPr>
+            <a:r>
+              <a:rPr lang="en-US" sz="950" b="1" dirty="0">
+                <a:solidFill>
+                  <a:srgbClr val="1D1D1F"/>
+                </a:solidFill>
+                <a:latin typeface="SF Pro Text" pitchFamily="34" charset="0"/>
+                <a:ea typeface="SF Pro Text" pitchFamily="34" charset="-122"/>
+                <a:cs typeface="SF Pro Text" pitchFamily="34" charset="-120"/>
+              </a:rPr>
+              <a:t>Job start 10AM, CP arrived 11AM (more than 30 mins late)</a:t>
+            </a:r>
+            <a:endParaRPr lang="en-US" sz="950" dirty="0"/>
+          </a:p>
+        </p:txBody>
+      </p:sp>
+      <p:sp>
+        <p:nvSpPr>
+          <p:cNvPr id="46" name="pop1_2Panel"/>
           <p:cNvSpPr/>
           <p:nvPr/>
         </p:nvSpPr>
@@ -16057,7 +16141,7 @@
       </p:sp>
       <p:sp>
         <p:nvSpPr>
-          <p:cNvPr id="46" name="pop1_2Num"/>
+          <p:cNvPr id="47" name="pop1_2Num"/>
           <p:cNvSpPr/>
           <p:nvPr/>
         </p:nvSpPr>
@@ -16102,7 +16186,7 @@
       </p:sp>
       <p:sp>
         <p:nvSpPr>
-          <p:cNvPr id="47" name="pop1_2Title"/>
+          <p:cNvPr id="48" name="pop1_2Title"/>
           <p:cNvSpPr txBox="1"/>
           <p:nvPr/>
         </p:nvSpPr>
@@ -16141,7 +16225,7 @@
       </p:sp>
       <p:sp>
         <p:nvSpPr>
-          <p:cNvPr id="48" name="pop1_2Body"/>
+          <p:cNvPr id="49" name="pop1_2Body"/>
           <p:cNvSpPr txBox="1"/>
           <p:nvPr/>
         </p:nvSpPr>
@@ -16223,7 +16307,7 @@
       </p:sp>
       <p:sp>
         <p:nvSpPr>
-          <p:cNvPr id="49" name="pop2_3Panel"/>
+          <p:cNvPr id="50" name="pop2_3Panel"/>
           <p:cNvSpPr/>
           <p:nvPr/>
         </p:nvSpPr>
@@ -16257,7 +16341,7 @@
       </p:sp>
       <p:sp>
         <p:nvSpPr>
-          <p:cNvPr id="50" name="pop2_3Num"/>
+          <p:cNvPr id="51" name="pop2_3Num"/>
           <p:cNvSpPr/>
           <p:nvPr/>
         </p:nvSpPr>
@@ -16302,7 +16386,7 @@
       </p:sp>
       <p:sp>
         <p:nvSpPr>
-          <p:cNvPr id="51" name="pop2_3Title"/>
+          <p:cNvPr id="52" name="pop2_3Title"/>
           <p:cNvSpPr txBox="1"/>
           <p:nvPr/>
         </p:nvSpPr>
@@ -16341,7 +16425,7 @@
       </p:sp>
       <p:sp>
         <p:nvSpPr>
-          <p:cNvPr id="52" name="pop2_3Body"/>
+          <p:cNvPr id="53" name="pop2_3Body"/>
           <p:cNvSpPr txBox="1"/>
           <p:nvPr/>
         </p:nvSpPr>
@@ -16423,7 +16507,7 @@
       </p:sp>
       <p:sp>
         <p:nvSpPr>
-          <p:cNvPr id="53" name="pop3_4Panel"/>
+          <p:cNvPr id="54" name="pop3_4Panel"/>
           <p:cNvSpPr/>
           <p:nvPr/>
         </p:nvSpPr>
@@ -16457,7 +16541,7 @@
       </p:sp>
       <p:sp>
         <p:nvSpPr>
-          <p:cNvPr id="54" name="pop3_4Num"/>
+          <p:cNvPr id="55" name="pop3_4Num"/>
           <p:cNvSpPr/>
           <p:nvPr/>
         </p:nvSpPr>
@@ -16502,7 +16586,7 @@
       </p:sp>
       <p:sp>
         <p:nvSpPr>
-          <p:cNvPr id="55" name="pop3_4Title"/>
+          <p:cNvPr id="56" name="pop3_4Title"/>
           <p:cNvSpPr txBox="1"/>
           <p:nvPr/>
         </p:nvSpPr>
@@ -16541,7 +16625,7 @@
       </p:sp>
       <p:sp>
         <p:nvSpPr>
-          <p:cNvPr id="56" name="pop3_4Body"/>
+          <p:cNvPr id="57" name="pop3_4Body"/>
           <p:cNvSpPr txBox="1"/>
           <p:nvPr/>
         </p:nvSpPr>
@@ -16623,7 +16707,7 @@
       </p:sp>
       <p:sp>
         <p:nvSpPr>
-          <p:cNvPr id="57" name="pop4_5Panel"/>
+          <p:cNvPr id="58" name="pop4_5Panel"/>
           <p:cNvSpPr/>
           <p:nvPr/>
         </p:nvSpPr>
@@ -16657,7 +16741,7 @@
       </p:sp>
       <p:sp>
         <p:nvSpPr>
-          <p:cNvPr id="58" name="pop4_5Num"/>
+          <p:cNvPr id="59" name="pop4_5Num"/>
           <p:cNvSpPr/>
           <p:nvPr/>
         </p:nvSpPr>
@@ -16702,7 +16786,7 @@
       </p:sp>
       <p:sp>
         <p:nvSpPr>
-          <p:cNvPr id="59" name="pop4_5Title"/>
+          <p:cNvPr id="60" name="pop4_5Title"/>
           <p:cNvSpPr txBox="1"/>
           <p:nvPr/>
         </p:nvSpPr>
@@ -16741,7 +16825,7 @@
       </p:sp>
       <p:sp>
         <p:nvSpPr>
-          <p:cNvPr id="60" name="pop4_5Body"/>
+          <p:cNvPr id="61" name="pop4_5Body"/>
           <p:cNvSpPr txBox="1"/>
           <p:nvPr/>
         </p:nvSpPr>
@@ -16818,161 +16902,6 @@
               <a:t>Important: these requirements may be disregarded if the CP claims that the C did not let them in or wanted to cancel upon their arrival. If this is the case, check for other indicators proving that CP did arrive on time at the C’s location.</a:t>
             </a:r>
             <a:endParaRPr lang="en-US" sz="900" dirty="0"/>
-          </a:p>
-        </p:txBody>
-      </p:sp>
-      <p:sp>
-        <p:nvSpPr>
-          <p:cNvPr id="61" name="Shape 57"/>
-          <p:cNvSpPr/>
-          <p:nvPr/>
-        </p:nvSpPr>
-        <p:spPr>
-          <a:xfrm>
-            <a:off x="411480" y="3840480"/>
-            <a:ext cx="8321040" cy="713232"/>
-          </a:xfrm>
-          <a:prstGeom prst="roundRect">
-            <a:avLst>
-              <a:gd name="adj" fmla="val 10256"/>
-            </a:avLst>
-          </a:prstGeom>
-          <a:solidFill>
-            <a:srgbClr val="FFF3D6"/>
-          </a:solidFill>
-          <a:ln w="9525">
-            <a:solidFill>
-              <a:srgbClr val="FFF3D6"/>
-            </a:solidFill>
-            <a:prstDash val="solid"/>
-          </a:ln>
-        </p:spPr>
-      </p:sp>
-      <p:pic>
-        <p:nvPicPr>
-          <p:cNvPr id="62" name="Image 1" descr="preencoded.png">    </p:cNvPr>
-          <p:cNvPicPr>
-            <a:picLocks noChangeAspect="1"/>
-          </p:cNvPicPr>
-          <p:nvPr/>
-        </p:nvPicPr>
-        <p:blipFill>
-          <a:blip r:embed="rId4"/>
-          <a:stretch>
-            <a:fillRect/>
-          </a:stretch>
-        </p:blipFill>
-        <p:spPr>
-          <a:xfrm>
-            <a:off x="566928" y="3950208"/>
-            <a:ext cx="164592" cy="164592"/>
-          </a:xfrm>
-          <a:prstGeom prst="rect">
-            <a:avLst/>
-          </a:prstGeom>
-        </p:spPr>
-      </p:pic>
-      <p:sp>
-        <p:nvSpPr>
-          <p:cNvPr id="63" name="Text 58"/>
-          <p:cNvSpPr txBox="1"/>
-          <p:nvPr/>
-        </p:nvSpPr>
-        <p:spPr>
-          <a:xfrm>
-            <a:off x="822960" y="3922776"/>
-            <a:ext cx="7772400" cy="585216"/>
-          </a:xfrm>
-          <a:prstGeom prst="rect">
-            <a:avLst/>
-          </a:prstGeom>
-          <a:noFill/>
-          <a:ln/>
-        </p:spPr>
-        <p:txBody>
-          <a:bodyPr wrap="square" lIns="0" tIns="0" rIns="0" bIns="0" rtlCol="0" anchor="t"/>
-          <a:lstStyle/>
-          <a:p>
-            <a:pPr indent="0" marL="0">
-              <a:buNone/>
-            </a:pPr>
-            <a:r>
-              <a:rPr lang="en-US" sz="1000" b="1" dirty="0">
-                <a:solidFill>
-                  <a:srgbClr val="9A6410"/>
-                </a:solidFill>
-                <a:latin typeface="SF Pro Text" pitchFamily="34" charset="0"/>
-                <a:ea typeface="SF Pro Text" pitchFamily="34" charset="-122"/>
-                <a:cs typeface="SF Pro Text" pitchFamily="34" charset="-120"/>
-              </a:rPr>
-              <a:t>Always: </a:t>
-            </a:r>
-            <a:pPr indent="0" marL="0">
-              <a:buNone/>
-            </a:pPr>
-            <a:r>
-              <a:rPr lang="en-US" sz="1000" b="1" dirty="0">
-                <a:solidFill>
-                  <a:srgbClr val="1D1D1F"/>
-                </a:solidFill>
-                <a:latin typeface="SF Pro Text" pitchFamily="34" charset="0"/>
-                <a:ea typeface="SF Pro Text" pitchFamily="34" charset="-122"/>
-                <a:cs typeface="SF Pro Text" pitchFamily="34" charset="-120"/>
-              </a:rPr>
-              <a:t>Leave an internal note with your findings.</a:t>
-            </a:r>
-            <a:endParaRPr lang="en-US" sz="1000" dirty="0"/>
-          </a:p>
-          <a:p>
-            <a:pPr indent="0" marL="0">
-              <a:buNone/>
-            </a:pPr>
-            <a:r>
-              <a:rPr lang="en-US" sz="800" b="1" dirty="0">
-                <a:solidFill>
-                  <a:srgbClr val="1D1D1F"/>
-                </a:solidFill>
-                <a:latin typeface="SF Pro Text" pitchFamily="34" charset="0"/>
-                <a:ea typeface="SF Pro Text" pitchFamily="34" charset="-122"/>
-                <a:cs typeface="SF Pro Text" pitchFamily="34" charset="-120"/>
-              </a:rPr>
-              <a:t>Job ID 45371</a:t>
-            </a:r>
-            <a:endParaRPr lang="en-US" sz="1000" dirty="0"/>
-          </a:p>
-          <a:p>
-            <a:pPr indent="0" marL="0">
-              <a:buNone/>
-            </a:pPr>
-            <a:r>
-              <a:rPr lang="en-US" sz="800" b="1" dirty="0">
-                <a:solidFill>
-                  <a:srgbClr val="1D1D1F"/>
-                </a:solidFill>
-                <a:latin typeface="SF Pro Text" pitchFamily="34" charset="0"/>
-                <a:ea typeface="SF Pro Text" pitchFamily="34" charset="-122"/>
-                <a:cs typeface="SF Pro Text" pitchFamily="34" charset="-120"/>
-              </a:rPr>
-              <a:t>Invalid Lockout</a:t>
-            </a:r>
-            <a:endParaRPr lang="en-US" sz="1000" dirty="0"/>
-          </a:p>
-          <a:p>
-            <a:pPr indent="0" marL="0">
-              <a:buNone/>
-            </a:pPr>
-            <a:r>
-              <a:rPr lang="en-US" sz="800" b="1" dirty="0">
-                <a:solidFill>
-                  <a:srgbClr val="1D1D1F"/>
-                </a:solidFill>
-                <a:latin typeface="SF Pro Text" pitchFamily="34" charset="0"/>
-                <a:ea typeface="SF Pro Text" pitchFamily="34" charset="-122"/>
-                <a:cs typeface="SF Pro Text" pitchFamily="34" charset="-120"/>
-              </a:rPr>
-              <a:t>Job start 10AM, CP arrived 11AM (more than 30 mins late)</a:t>
-            </a:r>
-            <a:endParaRPr lang="en-US" sz="1000" dirty="0"/>
           </a:p>
         </p:txBody>
       </p:sp>
@@ -17063,7 +16992,7 @@
                                           </p:stCondLst>
                                         </p:cTn>
                                         <p:tgtEl>
-                                          <p:spTgt spid="45"/>
+                                          <p:spTgt spid="46"/>
                                         </p:tgtEl>
                                         <p:attrNameLst>
                                           <p:attrName>style.visibility</p:attrName>
@@ -17077,7 +17006,7 @@
                                       <p:cBhvr>
                                         <p:cTn id="7" dur="600"/>
                                         <p:tgtEl>
-                                          <p:spTgt spid="45"/>
+                                          <p:spTgt spid="46"/>
                                         </p:tgtEl>
                                       </p:cBhvr>
                                     </p:animEffect>
@@ -17098,7 +17027,7 @@
                                           </p:stCondLst>
                                         </p:cTn>
                                         <p:tgtEl>
-                                          <p:spTgt spid="46"/>
+                                          <p:spTgt spid="47"/>
                                         </p:tgtEl>
                                         <p:attrNameLst>
                                           <p:attrName>style.visibility</p:attrName>
@@ -17112,7 +17041,7 @@
                                       <p:cBhvr>
                                         <p:cTn id="10" dur="600"/>
                                         <p:tgtEl>
-                                          <p:spTgt spid="46"/>
+                                          <p:spTgt spid="47"/>
                                         </p:tgtEl>
                                       </p:cBhvr>
                                     </p:animEffect>
@@ -17133,7 +17062,7 @@
                                           </p:stCondLst>
                                         </p:cTn>
                                         <p:tgtEl>
-                                          <p:spTgt spid="47"/>
+                                          <p:spTgt spid="48"/>
                                         </p:tgtEl>
                                         <p:attrNameLst>
                                           <p:attrName>style.visibility</p:attrName>
@@ -17147,7 +17076,7 @@
                                       <p:cBhvr>
                                         <p:cTn id="13" dur="600"/>
                                         <p:tgtEl>
-                                          <p:spTgt spid="47"/>
+                                          <p:spTgt spid="48"/>
                                         </p:tgtEl>
                                       </p:cBhvr>
                                     </p:animEffect>
@@ -17168,7 +17097,7 @@
                                           </p:stCondLst>
                                         </p:cTn>
                                         <p:tgtEl>
-                                          <p:spTgt spid="48"/>
+                                          <p:spTgt spid="49"/>
                                         </p:tgtEl>
                                         <p:attrNameLst>
                                           <p:attrName>style.visibility</p:attrName>
@@ -17182,7 +17111,7 @@
                                       <p:cBhvr>
                                         <p:cTn id="16" dur="600"/>
                                         <p:tgtEl>
-                                          <p:spTgt spid="48"/>
+                                          <p:spTgt spid="49"/>
                                         </p:tgtEl>
                                       </p:cBhvr>
                                     </p:animEffect>
@@ -17221,7 +17150,7 @@
                                           </p:stCondLst>
                                         </p:cTn>
                                         <p:tgtEl>
-                                          <p:spTgt spid="45"/>
+                                          <p:spTgt spid="46"/>
                                         </p:tgtEl>
                                         <p:attrNameLst>
                                           <p:attrName>style.visibility</p:attrName>
@@ -17248,7 +17177,7 @@
                                           </p:stCondLst>
                                         </p:cTn>
                                         <p:tgtEl>
-                                          <p:spTgt spid="46"/>
+                                          <p:spTgt spid="47"/>
                                         </p:tgtEl>
                                         <p:attrNameLst>
                                           <p:attrName>style.visibility</p:attrName>
@@ -17275,7 +17204,7 @@
                                           </p:stCondLst>
                                         </p:cTn>
                                         <p:tgtEl>
-                                          <p:spTgt spid="47"/>
+                                          <p:spTgt spid="48"/>
                                         </p:tgtEl>
                                         <p:attrNameLst>
                                           <p:attrName>style.visibility</p:attrName>
@@ -17302,7 +17231,7 @@
                                           </p:stCondLst>
                                         </p:cTn>
                                         <p:tgtEl>
-                                          <p:spTgt spid="48"/>
+                                          <p:spTgt spid="49"/>
                                         </p:tgtEl>
                                         <p:attrNameLst>
                                           <p:attrName>style.visibility</p:attrName>
@@ -17329,7 +17258,7 @@
                                           </p:stCondLst>
                                         </p:cTn>
                                         <p:tgtEl>
-                                          <p:spTgt spid="49"/>
+                                          <p:spTgt spid="50"/>
                                         </p:tgtEl>
                                         <p:attrNameLst>
                                           <p:attrName>style.visibility</p:attrName>
@@ -17343,7 +17272,7 @@
                                       <p:cBhvr>
                                         <p:cTn id="33" dur="600"/>
                                         <p:tgtEl>
-                                          <p:spTgt spid="49"/>
+                                          <p:spTgt spid="50"/>
                                         </p:tgtEl>
                                       </p:cBhvr>
                                     </p:animEffect>
@@ -17364,7 +17293,7 @@
                                           </p:stCondLst>
                                         </p:cTn>
                                         <p:tgtEl>
-                                          <p:spTgt spid="50"/>
+                                          <p:spTgt spid="51"/>
                                         </p:tgtEl>
                                         <p:attrNameLst>
                                           <p:attrName>style.visibility</p:attrName>
@@ -17378,7 +17307,7 @@
                                       <p:cBhvr>
                                         <p:cTn id="36" dur="600"/>
                                         <p:tgtEl>
-                                          <p:spTgt spid="50"/>
+                                          <p:spTgt spid="51"/>
                                         </p:tgtEl>
                                       </p:cBhvr>
                                     </p:animEffect>
@@ -17399,7 +17328,7 @@
                                           </p:stCondLst>
                                         </p:cTn>
                                         <p:tgtEl>
-                                          <p:spTgt spid="51"/>
+                                          <p:spTgt spid="52"/>
                                         </p:tgtEl>
                                         <p:attrNameLst>
                                           <p:attrName>style.visibility</p:attrName>
@@ -17413,7 +17342,7 @@
                                       <p:cBhvr>
                                         <p:cTn id="39" dur="600"/>
                                         <p:tgtEl>
-                                          <p:spTgt spid="51"/>
+                                          <p:spTgt spid="52"/>
                                         </p:tgtEl>
                                       </p:cBhvr>
                                     </p:animEffect>
@@ -17434,7 +17363,7 @@
                                           </p:stCondLst>
                                         </p:cTn>
                                         <p:tgtEl>
-                                          <p:spTgt spid="52"/>
+                                          <p:spTgt spid="53"/>
                                         </p:tgtEl>
                                         <p:attrNameLst>
                                           <p:attrName>style.visibility</p:attrName>
@@ -17448,7 +17377,7 @@
                                       <p:cBhvr>
                                         <p:cTn id="42" dur="600"/>
                                         <p:tgtEl>
-                                          <p:spTgt spid="52"/>
+                                          <p:spTgt spid="53"/>
                                         </p:tgtEl>
                                       </p:cBhvr>
                                     </p:animEffect>
@@ -17487,7 +17416,7 @@
                                           </p:stCondLst>
                                         </p:cTn>
                                         <p:tgtEl>
-                                          <p:spTgt spid="49"/>
+                                          <p:spTgt spid="50"/>
                                         </p:tgtEl>
                                         <p:attrNameLst>
                                           <p:attrName>style.visibility</p:attrName>
@@ -17514,7 +17443,7 @@
                                           </p:stCondLst>
                                         </p:cTn>
                                         <p:tgtEl>
-                                          <p:spTgt spid="50"/>
+                                          <p:spTgt spid="51"/>
                                         </p:tgtEl>
                                         <p:attrNameLst>
                                           <p:attrName>style.visibility</p:attrName>
@@ -17541,7 +17470,7 @@
                                           </p:stCondLst>
                                         </p:cTn>
                                         <p:tgtEl>
-                                          <p:spTgt spid="51"/>
+                                          <p:spTgt spid="52"/>
                                         </p:tgtEl>
                                         <p:attrNameLst>
                                           <p:attrName>style.visibility</p:attrName>
@@ -17568,7 +17497,7 @@
                                           </p:stCondLst>
                                         </p:cTn>
                                         <p:tgtEl>
-                                          <p:spTgt spid="52"/>
+                                          <p:spTgt spid="53"/>
                                         </p:tgtEl>
                                         <p:attrNameLst>
                                           <p:attrName>style.visibility</p:attrName>
@@ -17595,7 +17524,7 @@
                                           </p:stCondLst>
                                         </p:cTn>
                                         <p:tgtEl>
-                                          <p:spTgt spid="53"/>
+                                          <p:spTgt spid="54"/>
                                         </p:tgtEl>
                                         <p:attrNameLst>
                                           <p:attrName>style.visibility</p:attrName>
@@ -17609,7 +17538,7 @@
                                       <p:cBhvr>
                                         <p:cTn id="59" dur="600"/>
                                         <p:tgtEl>
-                                          <p:spTgt spid="53"/>
+                                          <p:spTgt spid="54"/>
                                         </p:tgtEl>
                                       </p:cBhvr>
                                     </p:animEffect>
@@ -17630,7 +17559,7 @@
                                           </p:stCondLst>
                                         </p:cTn>
                                         <p:tgtEl>
-                                          <p:spTgt spid="54"/>
+                                          <p:spTgt spid="55"/>
                                         </p:tgtEl>
                                         <p:attrNameLst>
                                           <p:attrName>style.visibility</p:attrName>
@@ -17644,7 +17573,7 @@
                                       <p:cBhvr>
                                         <p:cTn id="62" dur="600"/>
                                         <p:tgtEl>
-                                          <p:spTgt spid="54"/>
+                                          <p:spTgt spid="55"/>
                                         </p:tgtEl>
                                       </p:cBhvr>
                                     </p:animEffect>
@@ -17665,7 +17594,7 @@
                                           </p:stCondLst>
                                         </p:cTn>
                                         <p:tgtEl>
-                                          <p:spTgt spid="55"/>
+                                          <p:spTgt spid="56"/>
                                         </p:tgtEl>
                                         <p:attrNameLst>
                                           <p:attrName>style.visibility</p:attrName>
@@ -17679,7 +17608,7 @@
                                       <p:cBhvr>
                                         <p:cTn id="65" dur="600"/>
                                         <p:tgtEl>
-                                          <p:spTgt spid="55"/>
+                                          <p:spTgt spid="56"/>
                                         </p:tgtEl>
                                       </p:cBhvr>
                                     </p:animEffect>
@@ -17700,7 +17629,7 @@
                                           </p:stCondLst>
                                         </p:cTn>
                                         <p:tgtEl>
-                                          <p:spTgt spid="56"/>
+                                          <p:spTgt spid="57"/>
                                         </p:tgtEl>
                                         <p:attrNameLst>
                                           <p:attrName>style.visibility</p:attrName>
@@ -17714,7 +17643,7 @@
                                       <p:cBhvr>
                                         <p:cTn id="68" dur="600"/>
                                         <p:tgtEl>
-                                          <p:spTgt spid="56"/>
+                                          <p:spTgt spid="57"/>
                                         </p:tgtEl>
                                       </p:cBhvr>
                                     </p:animEffect>
@@ -17753,7 +17682,7 @@
                                           </p:stCondLst>
                                         </p:cTn>
                                         <p:tgtEl>
-                                          <p:spTgt spid="53"/>
+                                          <p:spTgt spid="54"/>
                                         </p:tgtEl>
                                         <p:attrNameLst>
                                           <p:attrName>style.visibility</p:attrName>
@@ -17780,7 +17709,7 @@
                                           </p:stCondLst>
                                         </p:cTn>
                                         <p:tgtEl>
-                                          <p:spTgt spid="54"/>
+                                          <p:spTgt spid="55"/>
                                         </p:tgtEl>
                                         <p:attrNameLst>
                                           <p:attrName>style.visibility</p:attrName>
@@ -17807,7 +17736,7 @@
                                           </p:stCondLst>
                                         </p:cTn>
                                         <p:tgtEl>
-                                          <p:spTgt spid="55"/>
+                                          <p:spTgt spid="56"/>
                                         </p:tgtEl>
                                         <p:attrNameLst>
                                           <p:attrName>style.visibility</p:attrName>
@@ -17834,7 +17763,7 @@
                                           </p:stCondLst>
                                         </p:cTn>
                                         <p:tgtEl>
-                                          <p:spTgt spid="56"/>
+                                          <p:spTgt spid="57"/>
                                         </p:tgtEl>
                                         <p:attrNameLst>
                                           <p:attrName>style.visibility</p:attrName>
@@ -17861,7 +17790,7 @@
                                           </p:stCondLst>
                                         </p:cTn>
                                         <p:tgtEl>
-                                          <p:spTgt spid="57"/>
+                                          <p:spTgt spid="58"/>
                                         </p:tgtEl>
                                         <p:attrNameLst>
                                           <p:attrName>style.visibility</p:attrName>
@@ -17875,7 +17804,7 @@
                                       <p:cBhvr>
                                         <p:cTn id="85" dur="600"/>
                                         <p:tgtEl>
-                                          <p:spTgt spid="57"/>
+                                          <p:spTgt spid="58"/>
                                         </p:tgtEl>
                                       </p:cBhvr>
                                     </p:animEffect>
@@ -17896,7 +17825,7 @@
                                           </p:stCondLst>
                                         </p:cTn>
                                         <p:tgtEl>
-                                          <p:spTgt spid="58"/>
+                                          <p:spTgt spid="59"/>
                                         </p:tgtEl>
                                         <p:attrNameLst>
                                           <p:attrName>style.visibility</p:attrName>
@@ -17910,7 +17839,7 @@
                                       <p:cBhvr>
                                         <p:cTn id="88" dur="600"/>
                                         <p:tgtEl>
-                                          <p:spTgt spid="58"/>
+                                          <p:spTgt spid="59"/>
                                         </p:tgtEl>
                                       </p:cBhvr>
                                     </p:animEffect>
@@ -17931,7 +17860,7 @@
                                           </p:stCondLst>
                                         </p:cTn>
                                         <p:tgtEl>
-                                          <p:spTgt spid="59"/>
+                                          <p:spTgt spid="60"/>
                                         </p:tgtEl>
                                         <p:attrNameLst>
                                           <p:attrName>style.visibility</p:attrName>
@@ -17945,7 +17874,7 @@
                                       <p:cBhvr>
                                         <p:cTn id="91" dur="600"/>
                                         <p:tgtEl>
-                                          <p:spTgt spid="59"/>
+                                          <p:spTgt spid="60"/>
                                         </p:tgtEl>
                                       </p:cBhvr>
                                     </p:animEffect>
@@ -17966,7 +17895,7 @@
                                           </p:stCondLst>
                                         </p:cTn>
                                         <p:tgtEl>
-                                          <p:spTgt spid="60"/>
+                                          <p:spTgt spid="61"/>
                                         </p:tgtEl>
                                         <p:attrNameLst>
                                           <p:attrName>style.visibility</p:attrName>
@@ -17980,7 +17909,7 @@
                                       <p:cBhvr>
                                         <p:cTn id="94" dur="600"/>
                                         <p:tgtEl>
-                                          <p:spTgt spid="60"/>
+                                          <p:spTgt spid="61"/>
                                         </p:tgtEl>
                                       </p:cBhvr>
                                     </p:animEffect>
@@ -18019,7 +17948,7 @@
                                           </p:stCondLst>
                                         </p:cTn>
                                         <p:tgtEl>
-                                          <p:spTgt spid="57"/>
+                                          <p:spTgt spid="58"/>
                                         </p:tgtEl>
                                         <p:attrNameLst>
                                           <p:attrName>style.visibility</p:attrName>
@@ -18046,7 +17975,7 @@
                                           </p:stCondLst>
                                         </p:cTn>
                                         <p:tgtEl>
-                                          <p:spTgt spid="58"/>
+                                          <p:spTgt spid="59"/>
                                         </p:tgtEl>
                                         <p:attrNameLst>
                                           <p:attrName>style.visibility</p:attrName>
@@ -18073,7 +18002,7 @@
                                           </p:stCondLst>
                                         </p:cTn>
                                         <p:tgtEl>
-                                          <p:spTgt spid="59"/>
+                                          <p:spTgt spid="60"/>
                                         </p:tgtEl>
                                         <p:attrNameLst>
                                           <p:attrName>style.visibility</p:attrName>
@@ -18100,7 +18029,7 @@
                                           </p:stCondLst>
                                         </p:cTn>
                                         <p:tgtEl>
-                                          <p:spTgt spid="60"/>
+                                          <p:spTgt spid="61"/>
                                         </p:tgtEl>
                                         <p:attrNameLst>
                                           <p:attrName>style.visibility</p:attrName>
@@ -18141,38 +18070,38 @@
       </p:par>
     </p:tnLst>
     <p:bldLst>
-      <p:bldP spid="45" grpId="0" animBg="1"/>
       <p:bldP spid="46" grpId="0" animBg="1"/>
       <p:bldP spid="47" grpId="0" animBg="1"/>
       <p:bldP spid="48" grpId="0" animBg="1"/>
-      <p:bldP spid="45" grpId="1" animBg="1"/>
+      <p:bldP spid="49" grpId="0" animBg="1"/>
       <p:bldP spid="46" grpId="1" animBg="1"/>
       <p:bldP spid="47" grpId="1" animBg="1"/>
       <p:bldP spid="48" grpId="1" animBg="1"/>
-      <p:bldP spid="49" grpId="0" animBg="1"/>
+      <p:bldP spid="49" grpId="1" animBg="1"/>
       <p:bldP spid="50" grpId="0" animBg="1"/>
       <p:bldP spid="51" grpId="0" animBg="1"/>
       <p:bldP spid="52" grpId="0" animBg="1"/>
-      <p:bldP spid="49" grpId="1" animBg="1"/>
+      <p:bldP spid="53" grpId="0" animBg="1"/>
       <p:bldP spid="50" grpId="1" animBg="1"/>
       <p:bldP spid="51" grpId="1" animBg="1"/>
       <p:bldP spid="52" grpId="1" animBg="1"/>
-      <p:bldP spid="53" grpId="0" animBg="1"/>
+      <p:bldP spid="53" grpId="1" animBg="1"/>
       <p:bldP spid="54" grpId="0" animBg="1"/>
       <p:bldP spid="55" grpId="0" animBg="1"/>
       <p:bldP spid="56" grpId="0" animBg="1"/>
-      <p:bldP spid="53" grpId="1" animBg="1"/>
+      <p:bldP spid="57" grpId="0" animBg="1"/>
       <p:bldP spid="54" grpId="1" animBg="1"/>
       <p:bldP spid="55" grpId="1" animBg="1"/>
       <p:bldP spid="56" grpId="1" animBg="1"/>
-      <p:bldP spid="57" grpId="0" animBg="1"/>
+      <p:bldP spid="57" grpId="1" animBg="1"/>
       <p:bldP spid="58" grpId="0" animBg="1"/>
       <p:bldP spid="59" grpId="0" animBg="1"/>
       <p:bldP spid="60" grpId="0" animBg="1"/>
-      <p:bldP spid="57" grpId="1" animBg="1"/>
+      <p:bldP spid="61" grpId="0" animBg="1"/>
       <p:bldP spid="58" grpId="1" animBg="1"/>
       <p:bldP spid="59" grpId="1" animBg="1"/>
       <p:bldP spid="60" grpId="1" animBg="1"/>
+      <p:bldP spid="61" grpId="1" animBg="1"/>
     </p:bldLst>
   </p:timing>
 </p:sld>

</xml_diff>

<commit_message>
Lockout special scenarios: click-to-show descriptions; keep trainer's slide 21-22 edits
Co-Authored-By: Claude Opus 5.5 <noreply@anthropic.com>
Claude-Session: https://claude.ai/code/session_01FEzv8wwqWDgTsXP8Yz6XYn
</commit_message>
<xml_diff>
--- a/incorrect-info-lmc-lockout/incorrect-info-lmc-lockout.pptx
+++ b/incorrect-info-lmc-lockout/incorrect-info-lmc-lockout.pptx
@@ -1848,7 +1848,7 @@
           <a:p>
             <a:r>
               <a:rPr lang="en-US" dirty="0"/>
-              <a:t>Customer denied entry because of the CP or a Trust &amp; Safety concern (showed up unprofessional, brought an unauthorized guest, didn't have cleaning supplies): issue an admin refund for the lockout fee, still pay the CP $40 for their time and travel, document the incident clearly in internal notes, and coach the CP on why the customer denied entry. The customer's safety and trust come first, but the CP still showed up and is owed something. Customer cancelled through Support, but we didn't act on it (the job wasn't cancelled and the CP wasn't told): the miss is ours. Don't charge the customer: refund or cancel the job on the C-side. Pay the CP the standard lockout amount through MCP, as long as they show they were on site and tried to reach the customer. Their lateness doesn't matter here.</a:t>
+              <a:t>Customer denied entry because of the CP or a Trust &amp; Safety concern (showed up unprofessional, brought an unauthorized guest, didn't have cleaning supplies): issue an admin refund for the lockout fee, still pay the CP $40 for their time and travel, document the incident clearly in internal notes, and coach the CP on why the customer denied entry. The customer's safety and trust come first, but the CP still showed up and is owed something. Customer cancelled through Support, but we didn't act on it (the job wasn't cancelled and the CP wasn't told): the miss is ours. Don't charge the customer: refund or cancel the job on the C-side. Pay the CP the standard lockout amount through MCP, as long as they show they were on site and tried to reach the customer. Their lateness doesn't matter here. TRAINER: click once to show why the CP was denied entry (left), click again to show why the Support cancellation case is our fault (right).</a:t>
             </a:r>
             <a:endParaRPr lang="en-US" dirty="0"/>
           </a:p>
@@ -15642,12 +15642,12 @@
         </p:nvSpPr>
         <p:spPr>
           <a:xfrm>
-            <a:off x="4279392" y="1920240"/>
-            <a:ext cx="1463040" cy="676656"/>
+            <a:off x="4279392" y="1975104"/>
+            <a:ext cx="1463040" cy="457200"/>
           </a:xfrm>
           <a:prstGeom prst="roundRect">
             <a:avLst>
-              <a:gd name="adj" fmla="val 10811"/>
+              <a:gd name="adj" fmla="val 16000"/>
             </a:avLst>
           </a:prstGeom>
           <a:solidFill>
@@ -15669,8 +15669,8 @@
         </p:nvSpPr>
         <p:spPr>
           <a:xfrm>
-            <a:off x="4315968" y="1920240"/>
-            <a:ext cx="1389888" cy="713232"/>
+            <a:off x="4279392" y="1975104"/>
+            <a:ext cx="1463040" cy="457200"/>
           </a:xfrm>
           <a:prstGeom prst="rect">
             <a:avLst/>
@@ -15715,28 +15715,115 @@
             </a:r>
             <a:endParaRPr lang="en-US" sz="1000" dirty="0"/>
           </a:p>
-          <a:p>
-            <a:pPr algn="ctr" indent="0" marL="0">
-              <a:buNone/>
-            </a:pPr>
-            <a:r>
-              <a:rPr lang="en-US" sz="800" b="1" dirty="0">
-                <a:solidFill>
-                  <a:srgbClr val="FFFFFF"/>
+        </p:txBody>
+      </p:sp>
+      <p:sp>
+        <p:nvSpPr>
+          <p:cNvPr id="36" name="Shape 33"/>
+          <p:cNvSpPr/>
+          <p:nvPr/>
+        </p:nvSpPr>
+        <p:spPr>
+          <a:xfrm>
+            <a:off x="411480" y="4224528"/>
+            <a:ext cx="8321040" cy="292608"/>
+          </a:xfrm>
+          <a:prstGeom prst="roundRect">
+            <a:avLst>
+              <a:gd name="adj" fmla="val 25000"/>
+            </a:avLst>
+          </a:prstGeom>
+          <a:solidFill>
+            <a:srgbClr val="FFF3D6"/>
+          </a:solidFill>
+          <a:ln w="9525">
+            <a:solidFill>
+              <a:srgbClr val="9A6410"/>
+            </a:solidFill>
+            <a:prstDash val="solid"/>
+          </a:ln>
+        </p:spPr>
+      </p:sp>
+      <p:pic>
+        <p:nvPicPr>
+          <p:cNvPr id="37" name="Image 0" descr="preencoded.png">    </p:cNvPr>
+          <p:cNvPicPr>
+            <a:picLocks noChangeAspect="1"/>
+          </p:cNvPicPr>
+          <p:nvPr/>
+        </p:nvPicPr>
+        <p:blipFill>
+          <a:blip r:embed="rId1"/>
+          <a:stretch>
+            <a:fillRect/>
+          </a:stretch>
+        </p:blipFill>
+        <p:spPr>
+          <a:xfrm>
+            <a:off x="521208" y="4297680"/>
+            <a:ext cx="146304" cy="146304"/>
+          </a:xfrm>
+          <a:prstGeom prst="rect">
+            <a:avLst/>
+          </a:prstGeom>
+        </p:spPr>
+      </p:pic>
+      <p:sp>
+        <p:nvSpPr>
+          <p:cNvPr id="38" name="Text 34"/>
+          <p:cNvSpPr txBox="1"/>
+          <p:nvPr/>
+        </p:nvSpPr>
+        <p:spPr>
+          <a:xfrm>
+            <a:off x="731520" y="4224528"/>
+            <a:ext cx="7955280" cy="292608"/>
+          </a:xfrm>
+          <a:prstGeom prst="rect">
+            <a:avLst/>
+          </a:prstGeom>
+          <a:noFill/>
+          <a:ln/>
+        </p:spPr>
+        <p:txBody>
+          <a:bodyPr wrap="square" lIns="0" tIns="0" rIns="0" bIns="0" rtlCol="0" anchor="ctr"/>
+          <a:lstStyle/>
+          <a:p>
+            <a:pPr indent="0" marL="0">
+              <a:buNone/>
+            </a:pPr>
+            <a:r>
+              <a:rPr lang="en-US" sz="950" b="1" dirty="0">
+                <a:solidFill>
+                  <a:srgbClr val="9A6410"/>
                 </a:solidFill>
                 <a:latin typeface="SF Pro Display" pitchFamily="34" charset="0"/>
                 <a:ea typeface="SF Pro Display" pitchFamily="34" charset="-122"/>
                 <a:cs typeface="SF Pro Display" pitchFamily="34" charset="-120"/>
               </a:rPr>
-              <a:t>Premium fee charged? → Refund  </a:t>
-            </a:r>
-            <a:endParaRPr lang="en-US" sz="1000" dirty="0"/>
-          </a:p>
-        </p:txBody>
-      </p:sp>
-      <p:sp>
-        <p:nvSpPr>
-          <p:cNvPr id="36" name="Shape 33"/>
+              <a:t>Important:  </a:t>
+            </a:r>
+            <a:pPr indent="0" marL="0">
+              <a:buNone/>
+            </a:pPr>
+            <a:r>
+              <a:rPr lang="en-US" sz="950" b="1" dirty="0">
+                <a:solidFill>
+                  <a:srgbClr val="1D1D1F"/>
+                </a:solidFill>
+                <a:latin typeface="SF Pro Display" pitchFamily="34" charset="0"/>
+                <a:ea typeface="SF Pro Display" pitchFamily="34" charset="-122"/>
+                <a:cs typeface="SF Pro Display" pitchFamily="34" charset="-120"/>
+              </a:rPr>
+              <a:t>Premium fee charged? → Always refund</a:t>
+            </a:r>
+            <a:endParaRPr lang="en-US" sz="950" dirty="0"/>
+          </a:p>
+        </p:txBody>
+      </p:sp>
+      <p:sp>
+        <p:nvSpPr>
+          <p:cNvPr id="39" name="Shape 35"/>
           <p:cNvSpPr/>
           <p:nvPr/>
         </p:nvSpPr>
@@ -15760,7 +15847,7 @@
       </p:sp>
       <p:sp>
         <p:nvSpPr>
-          <p:cNvPr id="37" name="Text 34"/>
+          <p:cNvPr id="40" name="Text 36"/>
           <p:cNvSpPr txBox="1"/>
           <p:nvPr/>
         </p:nvSpPr>
@@ -15799,8 +15886,8 @@
       </p:sp>
       <p:sp>
         <p:nvSpPr>
-          <p:cNvPr id="38" name="Shape 35">
-            <a:hlinkClick r:id="rId1" tooltip="Go to Step 3: valid lockout, check the customer category" action="ppaction://hlinksldjump"/>
+          <p:cNvPr id="41" name="Shape 37">
+            <a:hlinkClick r:id="rId2" tooltip="Go to Step 3: valid lockout, check the customer category" action="ppaction://hlinksldjump"/>
           </p:cNvPr>
           <p:cNvSpPr/>
           <p:nvPr/>
@@ -15828,8 +15915,8 @@
       </p:sp>
       <p:sp>
         <p:nvSpPr>
-          <p:cNvPr id="39" name="Text 36">
-            <a:hlinkClick r:id="rId2" tooltip="Go to Step 3: valid lockout, check the customer category" action="ppaction://hlinksldjump"/>
+          <p:cNvPr id="42" name="Text 38">
+            <a:hlinkClick r:id="rId3" tooltip="Go to Step 3: valid lockout, check the customer category" action="ppaction://hlinksldjump"/>
           </p:cNvPr>
           <p:cNvSpPr/>
           <p:nvPr/>
@@ -15869,7 +15956,7 @@
       </p:sp>
       <p:sp>
         <p:nvSpPr>
-          <p:cNvPr id="40" name="Shape 37"/>
+          <p:cNvPr id="43" name="Shape 39"/>
           <p:cNvSpPr/>
           <p:nvPr/>
         </p:nvSpPr>
@@ -15896,14 +15983,14 @@
       </p:sp>
       <p:pic>
         <p:nvPicPr>
-          <p:cNvPr id="41" name="Image 0" descr="preencoded.png">    </p:cNvPr>
+          <p:cNvPr id="44" name="Image 1" descr="preencoded.png">    </p:cNvPr>
           <p:cNvPicPr>
             <a:picLocks noChangeAspect="1"/>
           </p:cNvPicPr>
           <p:nvPr/>
         </p:nvPicPr>
         <p:blipFill>
-          <a:blip r:embed="rId3"/>
+          <a:blip r:embed="rId4"/>
           <a:stretch>
             <a:fillRect/>
           </a:stretch>
@@ -15920,7 +16007,7 @@
       </p:pic>
       <p:sp>
         <p:nvSpPr>
-          <p:cNvPr id="42" name="Text 38"/>
+          <p:cNvPr id="45" name="Text 40"/>
           <p:cNvSpPr txBox="1"/>
           <p:nvPr/>
         </p:nvSpPr>
@@ -15959,7 +16046,7 @@
       </p:sp>
       <p:sp>
         <p:nvSpPr>
-          <p:cNvPr id="43" name="Text 39"/>
+          <p:cNvPr id="46" name="Text 41"/>
           <p:cNvSpPr txBox="1"/>
           <p:nvPr/>
         </p:nvSpPr>
@@ -15998,7 +16085,7 @@
       </p:sp>
       <p:sp>
         <p:nvSpPr>
-          <p:cNvPr id="44" name="Shape 40"/>
+          <p:cNvPr id="47" name="Shape 42"/>
           <p:cNvSpPr/>
           <p:nvPr/>
         </p:nvSpPr>
@@ -16025,7 +16112,7 @@
       </p:sp>
       <p:sp>
         <p:nvSpPr>
-          <p:cNvPr id="45" name="Text 41"/>
+          <p:cNvPr id="48" name="Text 43"/>
           <p:cNvSpPr txBox="1"/>
           <p:nvPr/>
         </p:nvSpPr>
@@ -16107,7 +16194,7 @@
       </p:sp>
       <p:sp>
         <p:nvSpPr>
-          <p:cNvPr id="46" name="pop1_2Panel"/>
+          <p:cNvPr id="49" name="pop1_2Panel"/>
           <p:cNvSpPr/>
           <p:nvPr/>
         </p:nvSpPr>
@@ -16141,7 +16228,7 @@
       </p:sp>
       <p:sp>
         <p:nvSpPr>
-          <p:cNvPr id="47" name="pop1_2Num"/>
+          <p:cNvPr id="50" name="pop1_2Num"/>
           <p:cNvSpPr/>
           <p:nvPr/>
         </p:nvSpPr>
@@ -16186,7 +16273,7 @@
       </p:sp>
       <p:sp>
         <p:nvSpPr>
-          <p:cNvPr id="48" name="pop1_2Title"/>
+          <p:cNvPr id="51" name="pop1_2Title"/>
           <p:cNvSpPr txBox="1"/>
           <p:nvPr/>
         </p:nvSpPr>
@@ -16225,7 +16312,7 @@
       </p:sp>
       <p:sp>
         <p:nvSpPr>
-          <p:cNvPr id="49" name="pop1_2Body"/>
+          <p:cNvPr id="52" name="pop1_2Body"/>
           <p:cNvSpPr txBox="1"/>
           <p:nvPr/>
         </p:nvSpPr>
@@ -16307,7 +16394,7 @@
       </p:sp>
       <p:sp>
         <p:nvSpPr>
-          <p:cNvPr id="50" name="pop2_3Panel"/>
+          <p:cNvPr id="53" name="pop2_3Panel"/>
           <p:cNvSpPr/>
           <p:nvPr/>
         </p:nvSpPr>
@@ -16341,7 +16428,7 @@
       </p:sp>
       <p:sp>
         <p:nvSpPr>
-          <p:cNvPr id="51" name="pop2_3Num"/>
+          <p:cNvPr id="54" name="pop2_3Num"/>
           <p:cNvSpPr/>
           <p:nvPr/>
         </p:nvSpPr>
@@ -16386,7 +16473,7 @@
       </p:sp>
       <p:sp>
         <p:nvSpPr>
-          <p:cNvPr id="52" name="pop2_3Title"/>
+          <p:cNvPr id="55" name="pop2_3Title"/>
           <p:cNvSpPr txBox="1"/>
           <p:nvPr/>
         </p:nvSpPr>
@@ -16425,7 +16512,7 @@
       </p:sp>
       <p:sp>
         <p:nvSpPr>
-          <p:cNvPr id="53" name="pop2_3Body"/>
+          <p:cNvPr id="56" name="pop2_3Body"/>
           <p:cNvSpPr txBox="1"/>
           <p:nvPr/>
         </p:nvSpPr>
@@ -16507,7 +16594,7 @@
       </p:sp>
       <p:sp>
         <p:nvSpPr>
-          <p:cNvPr id="54" name="pop3_4Panel"/>
+          <p:cNvPr id="57" name="pop3_4Panel"/>
           <p:cNvSpPr/>
           <p:nvPr/>
         </p:nvSpPr>
@@ -16541,7 +16628,7 @@
       </p:sp>
       <p:sp>
         <p:nvSpPr>
-          <p:cNvPr id="55" name="pop3_4Num"/>
+          <p:cNvPr id="58" name="pop3_4Num"/>
           <p:cNvSpPr/>
           <p:nvPr/>
         </p:nvSpPr>
@@ -16586,7 +16673,7 @@
       </p:sp>
       <p:sp>
         <p:nvSpPr>
-          <p:cNvPr id="56" name="pop3_4Title"/>
+          <p:cNvPr id="59" name="pop3_4Title"/>
           <p:cNvSpPr txBox="1"/>
           <p:nvPr/>
         </p:nvSpPr>
@@ -16625,7 +16712,7 @@
       </p:sp>
       <p:sp>
         <p:nvSpPr>
-          <p:cNvPr id="57" name="pop3_4Body"/>
+          <p:cNvPr id="60" name="pop3_4Body"/>
           <p:cNvSpPr txBox="1"/>
           <p:nvPr/>
         </p:nvSpPr>
@@ -16707,7 +16794,7 @@
       </p:sp>
       <p:sp>
         <p:nvSpPr>
-          <p:cNvPr id="58" name="pop4_5Panel"/>
+          <p:cNvPr id="61" name="pop4_5Panel"/>
           <p:cNvSpPr/>
           <p:nvPr/>
         </p:nvSpPr>
@@ -16741,7 +16828,7 @@
       </p:sp>
       <p:sp>
         <p:nvSpPr>
-          <p:cNvPr id="59" name="pop4_5Num"/>
+          <p:cNvPr id="62" name="pop4_5Num"/>
           <p:cNvSpPr/>
           <p:nvPr/>
         </p:nvSpPr>
@@ -16786,7 +16873,7 @@
       </p:sp>
       <p:sp>
         <p:nvSpPr>
-          <p:cNvPr id="60" name="pop4_5Title"/>
+          <p:cNvPr id="63" name="pop4_5Title"/>
           <p:cNvSpPr txBox="1"/>
           <p:nvPr/>
         </p:nvSpPr>
@@ -16825,7 +16912,7 @@
       </p:sp>
       <p:sp>
         <p:nvSpPr>
-          <p:cNvPr id="61" name="pop4_5Body"/>
+          <p:cNvPr id="64" name="pop4_5Body"/>
           <p:cNvSpPr txBox="1"/>
           <p:nvPr/>
         </p:nvSpPr>
@@ -16992,7 +17079,7 @@
                                           </p:stCondLst>
                                         </p:cTn>
                                         <p:tgtEl>
-                                          <p:spTgt spid="46"/>
+                                          <p:spTgt spid="49"/>
                                         </p:tgtEl>
                                         <p:attrNameLst>
                                           <p:attrName>style.visibility</p:attrName>
@@ -17006,7 +17093,7 @@
                                       <p:cBhvr>
                                         <p:cTn id="7" dur="600"/>
                                         <p:tgtEl>
-                                          <p:spTgt spid="46"/>
+                                          <p:spTgt spid="49"/>
                                         </p:tgtEl>
                                       </p:cBhvr>
                                     </p:animEffect>
@@ -17027,7 +17114,7 @@
                                           </p:stCondLst>
                                         </p:cTn>
                                         <p:tgtEl>
-                                          <p:spTgt spid="47"/>
+                                          <p:spTgt spid="50"/>
                                         </p:tgtEl>
                                         <p:attrNameLst>
                                           <p:attrName>style.visibility</p:attrName>
@@ -17041,7 +17128,7 @@
                                       <p:cBhvr>
                                         <p:cTn id="10" dur="600"/>
                                         <p:tgtEl>
-                                          <p:spTgt spid="47"/>
+                                          <p:spTgt spid="50"/>
                                         </p:tgtEl>
                                       </p:cBhvr>
                                     </p:animEffect>
@@ -17062,7 +17149,7 @@
                                           </p:stCondLst>
                                         </p:cTn>
                                         <p:tgtEl>
-                                          <p:spTgt spid="48"/>
+                                          <p:spTgt spid="51"/>
                                         </p:tgtEl>
                                         <p:attrNameLst>
                                           <p:attrName>style.visibility</p:attrName>
@@ -17076,7 +17163,7 @@
                                       <p:cBhvr>
                                         <p:cTn id="13" dur="600"/>
                                         <p:tgtEl>
-                                          <p:spTgt spid="48"/>
+                                          <p:spTgt spid="51"/>
                                         </p:tgtEl>
                                       </p:cBhvr>
                                     </p:animEffect>
@@ -17097,7 +17184,7 @@
                                           </p:stCondLst>
                                         </p:cTn>
                                         <p:tgtEl>
-                                          <p:spTgt spid="49"/>
+                                          <p:spTgt spid="52"/>
                                         </p:tgtEl>
                                         <p:attrNameLst>
                                           <p:attrName>style.visibility</p:attrName>
@@ -17111,7 +17198,7 @@
                                       <p:cBhvr>
                                         <p:cTn id="16" dur="600"/>
                                         <p:tgtEl>
-                                          <p:spTgt spid="49"/>
+                                          <p:spTgt spid="52"/>
                                         </p:tgtEl>
                                       </p:cBhvr>
                                     </p:animEffect>
@@ -17150,7 +17237,7 @@
                                           </p:stCondLst>
                                         </p:cTn>
                                         <p:tgtEl>
-                                          <p:spTgt spid="46"/>
+                                          <p:spTgt spid="49"/>
                                         </p:tgtEl>
                                         <p:attrNameLst>
                                           <p:attrName>style.visibility</p:attrName>
@@ -17177,7 +17264,7 @@
                                           </p:stCondLst>
                                         </p:cTn>
                                         <p:tgtEl>
-                                          <p:spTgt spid="47"/>
+                                          <p:spTgt spid="50"/>
                                         </p:tgtEl>
                                         <p:attrNameLst>
                                           <p:attrName>style.visibility</p:attrName>
@@ -17204,7 +17291,7 @@
                                           </p:stCondLst>
                                         </p:cTn>
                                         <p:tgtEl>
-                                          <p:spTgt spid="48"/>
+                                          <p:spTgt spid="51"/>
                                         </p:tgtEl>
                                         <p:attrNameLst>
                                           <p:attrName>style.visibility</p:attrName>
@@ -17231,7 +17318,7 @@
                                           </p:stCondLst>
                                         </p:cTn>
                                         <p:tgtEl>
-                                          <p:spTgt spid="49"/>
+                                          <p:spTgt spid="52"/>
                                         </p:tgtEl>
                                         <p:attrNameLst>
                                           <p:attrName>style.visibility</p:attrName>
@@ -17258,7 +17345,7 @@
                                           </p:stCondLst>
                                         </p:cTn>
                                         <p:tgtEl>
-                                          <p:spTgt spid="50"/>
+                                          <p:spTgt spid="53"/>
                                         </p:tgtEl>
                                         <p:attrNameLst>
                                           <p:attrName>style.visibility</p:attrName>
@@ -17272,7 +17359,7 @@
                                       <p:cBhvr>
                                         <p:cTn id="33" dur="600"/>
                                         <p:tgtEl>
-                                          <p:spTgt spid="50"/>
+                                          <p:spTgt spid="53"/>
                                         </p:tgtEl>
                                       </p:cBhvr>
                                     </p:animEffect>
@@ -17293,7 +17380,7 @@
                                           </p:stCondLst>
                                         </p:cTn>
                                         <p:tgtEl>
-                                          <p:spTgt spid="51"/>
+                                          <p:spTgt spid="54"/>
                                         </p:tgtEl>
                                         <p:attrNameLst>
                                           <p:attrName>style.visibility</p:attrName>
@@ -17307,7 +17394,7 @@
                                       <p:cBhvr>
                                         <p:cTn id="36" dur="600"/>
                                         <p:tgtEl>
-                                          <p:spTgt spid="51"/>
+                                          <p:spTgt spid="54"/>
                                         </p:tgtEl>
                                       </p:cBhvr>
                                     </p:animEffect>
@@ -17328,7 +17415,7 @@
                                           </p:stCondLst>
                                         </p:cTn>
                                         <p:tgtEl>
-                                          <p:spTgt spid="52"/>
+                                          <p:spTgt spid="55"/>
                                         </p:tgtEl>
                                         <p:attrNameLst>
                                           <p:attrName>style.visibility</p:attrName>
@@ -17342,7 +17429,7 @@
                                       <p:cBhvr>
                                         <p:cTn id="39" dur="600"/>
                                         <p:tgtEl>
-                                          <p:spTgt spid="52"/>
+                                          <p:spTgt spid="55"/>
                                         </p:tgtEl>
                                       </p:cBhvr>
                                     </p:animEffect>
@@ -17363,7 +17450,7 @@
                                           </p:stCondLst>
                                         </p:cTn>
                                         <p:tgtEl>
-                                          <p:spTgt spid="53"/>
+                                          <p:spTgt spid="56"/>
                                         </p:tgtEl>
                                         <p:attrNameLst>
                                           <p:attrName>style.visibility</p:attrName>
@@ -17377,7 +17464,7 @@
                                       <p:cBhvr>
                                         <p:cTn id="42" dur="600"/>
                                         <p:tgtEl>
-                                          <p:spTgt spid="53"/>
+                                          <p:spTgt spid="56"/>
                                         </p:tgtEl>
                                       </p:cBhvr>
                                     </p:animEffect>
@@ -17416,7 +17503,7 @@
                                           </p:stCondLst>
                                         </p:cTn>
                                         <p:tgtEl>
-                                          <p:spTgt spid="50"/>
+                                          <p:spTgt spid="53"/>
                                         </p:tgtEl>
                                         <p:attrNameLst>
                                           <p:attrName>style.visibility</p:attrName>
@@ -17443,7 +17530,7 @@
                                           </p:stCondLst>
                                         </p:cTn>
                                         <p:tgtEl>
-                                          <p:spTgt spid="51"/>
+                                          <p:spTgt spid="54"/>
                                         </p:tgtEl>
                                         <p:attrNameLst>
                                           <p:attrName>style.visibility</p:attrName>
@@ -17470,7 +17557,7 @@
                                           </p:stCondLst>
                                         </p:cTn>
                                         <p:tgtEl>
-                                          <p:spTgt spid="52"/>
+                                          <p:spTgt spid="55"/>
                                         </p:tgtEl>
                                         <p:attrNameLst>
                                           <p:attrName>style.visibility</p:attrName>
@@ -17497,7 +17584,7 @@
                                           </p:stCondLst>
                                         </p:cTn>
                                         <p:tgtEl>
-                                          <p:spTgt spid="53"/>
+                                          <p:spTgt spid="56"/>
                                         </p:tgtEl>
                                         <p:attrNameLst>
                                           <p:attrName>style.visibility</p:attrName>
@@ -17524,7 +17611,7 @@
                                           </p:stCondLst>
                                         </p:cTn>
                                         <p:tgtEl>
-                                          <p:spTgt spid="54"/>
+                                          <p:spTgt spid="57"/>
                                         </p:tgtEl>
                                         <p:attrNameLst>
                                           <p:attrName>style.visibility</p:attrName>
@@ -17538,7 +17625,7 @@
                                       <p:cBhvr>
                                         <p:cTn id="59" dur="600"/>
                                         <p:tgtEl>
-                                          <p:spTgt spid="54"/>
+                                          <p:spTgt spid="57"/>
                                         </p:tgtEl>
                                       </p:cBhvr>
                                     </p:animEffect>
@@ -17559,7 +17646,7 @@
                                           </p:stCondLst>
                                         </p:cTn>
                                         <p:tgtEl>
-                                          <p:spTgt spid="55"/>
+                                          <p:spTgt spid="58"/>
                                         </p:tgtEl>
                                         <p:attrNameLst>
                                           <p:attrName>style.visibility</p:attrName>
@@ -17573,7 +17660,7 @@
                                       <p:cBhvr>
                                         <p:cTn id="62" dur="600"/>
                                         <p:tgtEl>
-                                          <p:spTgt spid="55"/>
+                                          <p:spTgt spid="58"/>
                                         </p:tgtEl>
                                       </p:cBhvr>
                                     </p:animEffect>
@@ -17594,7 +17681,7 @@
                                           </p:stCondLst>
                                         </p:cTn>
                                         <p:tgtEl>
-                                          <p:spTgt spid="56"/>
+                                          <p:spTgt spid="59"/>
                                         </p:tgtEl>
                                         <p:attrNameLst>
                                           <p:attrName>style.visibility</p:attrName>
@@ -17608,7 +17695,7 @@
                                       <p:cBhvr>
                                         <p:cTn id="65" dur="600"/>
                                         <p:tgtEl>
-                                          <p:spTgt spid="56"/>
+                                          <p:spTgt spid="59"/>
                                         </p:tgtEl>
                                       </p:cBhvr>
                                     </p:animEffect>
@@ -17629,7 +17716,7 @@
                                           </p:stCondLst>
                                         </p:cTn>
                                         <p:tgtEl>
-                                          <p:spTgt spid="57"/>
+                                          <p:spTgt spid="60"/>
                                         </p:tgtEl>
                                         <p:attrNameLst>
                                           <p:attrName>style.visibility</p:attrName>
@@ -17643,7 +17730,7 @@
                                       <p:cBhvr>
                                         <p:cTn id="68" dur="600"/>
                                         <p:tgtEl>
-                                          <p:spTgt spid="57"/>
+                                          <p:spTgt spid="60"/>
                                         </p:tgtEl>
                                       </p:cBhvr>
                                     </p:animEffect>
@@ -17682,7 +17769,7 @@
                                           </p:stCondLst>
                                         </p:cTn>
                                         <p:tgtEl>
-                                          <p:spTgt spid="54"/>
+                                          <p:spTgt spid="57"/>
                                         </p:tgtEl>
                                         <p:attrNameLst>
                                           <p:attrName>style.visibility</p:attrName>
@@ -17709,7 +17796,7 @@
                                           </p:stCondLst>
                                         </p:cTn>
                                         <p:tgtEl>
-                                          <p:spTgt spid="55"/>
+                                          <p:spTgt spid="58"/>
                                         </p:tgtEl>
                                         <p:attrNameLst>
                                           <p:attrName>style.visibility</p:attrName>
@@ -17736,7 +17823,7 @@
                                           </p:stCondLst>
                                         </p:cTn>
                                         <p:tgtEl>
-                                          <p:spTgt spid="56"/>
+                                          <p:spTgt spid="59"/>
                                         </p:tgtEl>
                                         <p:attrNameLst>
                                           <p:attrName>style.visibility</p:attrName>
@@ -17763,7 +17850,7 @@
                                           </p:stCondLst>
                                         </p:cTn>
                                         <p:tgtEl>
-                                          <p:spTgt spid="57"/>
+                                          <p:spTgt spid="60"/>
                                         </p:tgtEl>
                                         <p:attrNameLst>
                                           <p:attrName>style.visibility</p:attrName>
@@ -17790,7 +17877,7 @@
                                           </p:stCondLst>
                                         </p:cTn>
                                         <p:tgtEl>
-                                          <p:spTgt spid="58"/>
+                                          <p:spTgt spid="61"/>
                                         </p:tgtEl>
                                         <p:attrNameLst>
                                           <p:attrName>style.visibility</p:attrName>
@@ -17804,7 +17891,7 @@
                                       <p:cBhvr>
                                         <p:cTn id="85" dur="600"/>
                                         <p:tgtEl>
-                                          <p:spTgt spid="58"/>
+                                          <p:spTgt spid="61"/>
                                         </p:tgtEl>
                                       </p:cBhvr>
                                     </p:animEffect>
@@ -17825,7 +17912,7 @@
                                           </p:stCondLst>
                                         </p:cTn>
                                         <p:tgtEl>
-                                          <p:spTgt spid="59"/>
+                                          <p:spTgt spid="62"/>
                                         </p:tgtEl>
                                         <p:attrNameLst>
                                           <p:attrName>style.visibility</p:attrName>
@@ -17839,7 +17926,7 @@
                                       <p:cBhvr>
                                         <p:cTn id="88" dur="600"/>
                                         <p:tgtEl>
-                                          <p:spTgt spid="59"/>
+                                          <p:spTgt spid="62"/>
                                         </p:tgtEl>
                                       </p:cBhvr>
                                     </p:animEffect>
@@ -17860,7 +17947,7 @@
                                           </p:stCondLst>
                                         </p:cTn>
                                         <p:tgtEl>
-                                          <p:spTgt spid="60"/>
+                                          <p:spTgt spid="63"/>
                                         </p:tgtEl>
                                         <p:attrNameLst>
                                           <p:attrName>style.visibility</p:attrName>
@@ -17874,7 +17961,7 @@
                                       <p:cBhvr>
                                         <p:cTn id="91" dur="600"/>
                                         <p:tgtEl>
-                                          <p:spTgt spid="60"/>
+                                          <p:spTgt spid="63"/>
                                         </p:tgtEl>
                                       </p:cBhvr>
                                     </p:animEffect>
@@ -17895,7 +17982,7 @@
                                           </p:stCondLst>
                                         </p:cTn>
                                         <p:tgtEl>
-                                          <p:spTgt spid="61"/>
+                                          <p:spTgt spid="64"/>
                                         </p:tgtEl>
                                         <p:attrNameLst>
                                           <p:attrName>style.visibility</p:attrName>
@@ -17909,7 +17996,7 @@
                                       <p:cBhvr>
                                         <p:cTn id="94" dur="600"/>
                                         <p:tgtEl>
-                                          <p:spTgt spid="61"/>
+                                          <p:spTgt spid="64"/>
                                         </p:tgtEl>
                                       </p:cBhvr>
                                     </p:animEffect>
@@ -17948,7 +18035,7 @@
                                           </p:stCondLst>
                                         </p:cTn>
                                         <p:tgtEl>
-                                          <p:spTgt spid="58"/>
+                                          <p:spTgt spid="61"/>
                                         </p:tgtEl>
                                         <p:attrNameLst>
                                           <p:attrName>style.visibility</p:attrName>
@@ -17975,7 +18062,7 @@
                                           </p:stCondLst>
                                         </p:cTn>
                                         <p:tgtEl>
-                                          <p:spTgt spid="59"/>
+                                          <p:spTgt spid="62"/>
                                         </p:tgtEl>
                                         <p:attrNameLst>
                                           <p:attrName>style.visibility</p:attrName>
@@ -18002,7 +18089,7 @@
                                           </p:stCondLst>
                                         </p:cTn>
                                         <p:tgtEl>
-                                          <p:spTgt spid="60"/>
+                                          <p:spTgt spid="63"/>
                                         </p:tgtEl>
                                         <p:attrNameLst>
                                           <p:attrName>style.visibility</p:attrName>
@@ -18029,7 +18116,7 @@
                                           </p:stCondLst>
                                         </p:cTn>
                                         <p:tgtEl>
-                                          <p:spTgt spid="61"/>
+                                          <p:spTgt spid="64"/>
                                         </p:tgtEl>
                                         <p:attrNameLst>
                                           <p:attrName>style.visibility</p:attrName>
@@ -18070,38 +18157,38 @@
       </p:par>
     </p:tnLst>
     <p:bldLst>
-      <p:bldP spid="46" grpId="0" animBg="1"/>
-      <p:bldP spid="47" grpId="0" animBg="1"/>
-      <p:bldP spid="48" grpId="0" animBg="1"/>
       <p:bldP spid="49" grpId="0" animBg="1"/>
-      <p:bldP spid="46" grpId="1" animBg="1"/>
-      <p:bldP spid="47" grpId="1" animBg="1"/>
-      <p:bldP spid="48" grpId="1" animBg="1"/>
-      <p:bldP spid="49" grpId="1" animBg="1"/>
       <p:bldP spid="50" grpId="0" animBg="1"/>
       <p:bldP spid="51" grpId="0" animBg="1"/>
       <p:bldP spid="52" grpId="0" animBg="1"/>
-      <p:bldP spid="53" grpId="0" animBg="1"/>
+      <p:bldP spid="49" grpId="1" animBg="1"/>
       <p:bldP spid="50" grpId="1" animBg="1"/>
       <p:bldP spid="51" grpId="1" animBg="1"/>
       <p:bldP spid="52" grpId="1" animBg="1"/>
-      <p:bldP spid="53" grpId="1" animBg="1"/>
+      <p:bldP spid="53" grpId="0" animBg="1"/>
       <p:bldP spid="54" grpId="0" animBg="1"/>
       <p:bldP spid="55" grpId="0" animBg="1"/>
       <p:bldP spid="56" grpId="0" animBg="1"/>
-      <p:bldP spid="57" grpId="0" animBg="1"/>
+      <p:bldP spid="53" grpId="1" animBg="1"/>
       <p:bldP spid="54" grpId="1" animBg="1"/>
       <p:bldP spid="55" grpId="1" animBg="1"/>
       <p:bldP spid="56" grpId="1" animBg="1"/>
-      <p:bldP spid="57" grpId="1" animBg="1"/>
+      <p:bldP spid="57" grpId="0" animBg="1"/>
       <p:bldP spid="58" grpId="0" animBg="1"/>
       <p:bldP spid="59" grpId="0" animBg="1"/>
       <p:bldP spid="60" grpId="0" animBg="1"/>
-      <p:bldP spid="61" grpId="0" animBg="1"/>
+      <p:bldP spid="57" grpId="1" animBg="1"/>
       <p:bldP spid="58" grpId="1" animBg="1"/>
       <p:bldP spid="59" grpId="1" animBg="1"/>
       <p:bldP spid="60" grpId="1" animBg="1"/>
+      <p:bldP spid="61" grpId="0" animBg="1"/>
+      <p:bldP spid="62" grpId="0" animBg="1"/>
+      <p:bldP spid="63" grpId="0" animBg="1"/>
+      <p:bldP spid="64" grpId="0" animBg="1"/>
       <p:bldP spid="61" grpId="1" animBg="1"/>
+      <p:bldP spid="62" grpId="1" animBg="1"/>
+      <p:bldP spid="63" grpId="1" animBg="1"/>
+      <p:bldP spid="64" grpId="1" animBg="1"/>
     </p:bldLst>
   </p:timing>
 </p:sld>
@@ -18235,7 +18322,7 @@
                 <a:ea typeface="SF Pro Text" pitchFamily="34" charset="-122"/>
                 <a:cs typeface="SF Pro Text" pitchFamily="34" charset="-120"/>
               </a:rPr>
-              <a:t>Same as LMC: go straight to the right offer.</a:t>
+              <a:t>Go straight to the right offer. Applies if Customer asks for a refund or contests the lockout charge.</a:t>
             </a:r>
             <a:endParaRPr lang="en-US" sz="1200" dirty="0"/>
           </a:p>
@@ -18834,7 +18921,49 @@
                           <a:ea typeface="SF Pro Text" pitchFamily="34" charset="-122"/>
                           <a:cs typeface="SF Pro Text" pitchFamily="34" charset="-120"/>
                         </a:rPr>
-                        <a:t>Credits up to 75% of the job, keep $40 for the CP. Escalates? Service Recovery. Cancelling? Toward ETF (max 50% off).</a:t>
+                        <a:t>Credits up to 75% of the job, keep $40 for the CP. </a:t>
+                      </a:r>
+                      <a:endParaRPr lang="en-US" sz="950" dirty="0">
+                        <a:latin typeface="SF Pro Text" charset="0"/>
+                        <a:ea typeface="SF Pro Text" charset="0"/>
+                        <a:cs typeface="SF Pro Text" charset="0"/>
+                      </a:endParaRPr>
+                    </a:p>
+                    <a:p>
+                      <a:pPr indent="0" marL="0">
+                        <a:buNone/>
+                      </a:pPr>
+                      <a:r>
+                        <a:rPr lang="en-US" sz="950" dirty="0">
+                          <a:solidFill>
+                            <a:srgbClr val="6E6E73"/>
+                          </a:solidFill>
+                          <a:latin typeface="SF Pro Text" pitchFamily="34" charset="0"/>
+                          <a:ea typeface="SF Pro Text" pitchFamily="34" charset="-122"/>
+                          <a:cs typeface="SF Pro Text" pitchFamily="34" charset="-120"/>
+                        </a:rPr>
+                        <a:t>Escalates? Send to Service Recovery. </a:t>
+                      </a:r>
+                      <a:endParaRPr lang="en-US" sz="950" dirty="0">
+                        <a:latin typeface="SF Pro Text" charset="0"/>
+                        <a:ea typeface="SF Pro Text" charset="0"/>
+                        <a:cs typeface="SF Pro Text" charset="0"/>
+                      </a:endParaRPr>
+                    </a:p>
+                    <a:p>
+                      <a:pPr indent="0" marL="0">
+                        <a:buNone/>
+                      </a:pPr>
+                      <a:r>
+                        <a:rPr lang="en-US" sz="950" dirty="0">
+                          <a:solidFill>
+                            <a:srgbClr val="6E6E73"/>
+                          </a:solidFill>
+                          <a:latin typeface="SF Pro Text" pitchFamily="34" charset="0"/>
+                          <a:ea typeface="SF Pro Text" pitchFamily="34" charset="-122"/>
+                          <a:cs typeface="SF Pro Text" pitchFamily="34" charset="-120"/>
+                        </a:rPr>
+                        <a:t>Cancelling? Offer to apply the LO fee toward ETF (max 50% off).</a:t>
                       </a:r>
                       <a:endParaRPr lang="en-US" sz="950" dirty="0">
                         <a:latin typeface="SF Pro Text" charset="0"/>
@@ -19605,11 +19734,11 @@
         <p:spPr>
           <a:xfrm>
             <a:off x="411480" y="1325880"/>
-            <a:ext cx="4091940" cy="2331720"/>
+            <a:ext cx="4091940" cy="1691640"/>
           </a:xfrm>
           <a:prstGeom prst="roundRect">
             <a:avLst>
-              <a:gd name="adj" fmla="val 3137"/>
+              <a:gd name="adj" fmla="val 4324"/>
             </a:avLst>
           </a:prstGeom>
           <a:solidFill>
@@ -19720,7 +19849,7 @@
         <p:spPr>
           <a:xfrm>
             <a:off x="594360" y="2039112"/>
-            <a:ext cx="3726180" cy="1508760"/>
+            <a:ext cx="3726180" cy="868680"/>
           </a:xfrm>
           <a:prstGeom prst="rect">
             <a:avLst/>
@@ -19826,11 +19955,11 @@
         <p:spPr>
           <a:xfrm>
             <a:off x="4640580" y="1325880"/>
-            <a:ext cx="4091940" cy="2331720"/>
+            <a:ext cx="4091940" cy="1691640"/>
           </a:xfrm>
           <a:prstGeom prst="roundRect">
             <a:avLst>
-              <a:gd name="adj" fmla="val 3137"/>
+              <a:gd name="adj" fmla="val 4324"/>
             </a:avLst>
           </a:prstGeom>
           <a:solidFill>
@@ -19941,7 +20070,7 @@
         <p:spPr>
           <a:xfrm>
             <a:off x="4823460" y="2039112"/>
-            <a:ext cx="3726180" cy="1508760"/>
+            <a:ext cx="3726180" cy="868680"/>
           </a:xfrm>
           <a:prstGeom prst="rect">
             <a:avLst/>
@@ -20035,6 +20164,318 @@
               <a:t>Lateness doesn't matter here</a:t>
             </a:r>
             <a:endParaRPr lang="en-US" sz="1000" dirty="0"/>
+          </a:p>
+        </p:txBody>
+      </p:sp>
+      <p:sp>
+        <p:nvSpPr>
+          <p:cNvPr id="16" name="Text 11"/>
+          <p:cNvSpPr/>
+          <p:nvPr/>
+        </p:nvSpPr>
+        <p:spPr>
+          <a:xfrm>
+            <a:off x="3543300" y="2606040"/>
+            <a:ext cx="777240" cy="274320"/>
+          </a:xfrm>
+          <a:prstGeom prst="roundRect">
+            <a:avLst>
+              <a:gd name="adj" fmla="val 20000"/>
+            </a:avLst>
+          </a:prstGeom>
+          <a:solidFill>
+            <a:srgbClr val="FFFFFF"/>
+          </a:solidFill>
+          <a:ln w="12700">
+            <a:solidFill>
+              <a:srgbClr val="0B7A6F"/>
+            </a:solidFill>
+          </a:ln>
+        </p:spPr>
+        <p:txBody>
+          <a:bodyPr wrap="square" lIns="0" tIns="0" rIns="0" bIns="0" rtlCol="0" anchor="ctr"/>
+          <a:lstStyle/>
+          <a:p>
+            <a:pPr algn="ctr" indent="0" marL="0">
+              <a:buNone/>
+            </a:pPr>
+            <a:r>
+              <a:rPr lang="en-US" sz="850" b="1" dirty="0">
+                <a:solidFill>
+                  <a:srgbClr val="0B7A6F"/>
+                </a:solidFill>
+                <a:latin typeface="SF Pro Text" pitchFamily="34" charset="0"/>
+                <a:ea typeface="SF Pro Text" pitchFamily="34" charset="-122"/>
+                <a:cs typeface="SF Pro Text" pitchFamily="34" charset="-120"/>
+              </a:rPr>
+              <a:t>Details  ›</a:t>
+            </a:r>
+            <a:endParaRPr lang="en-US" sz="850" dirty="0"/>
+          </a:p>
+        </p:txBody>
+      </p:sp>
+      <p:sp>
+        <p:nvSpPr>
+          <p:cNvPr id="17" name="step1Panel"/>
+          <p:cNvSpPr/>
+          <p:nvPr/>
+        </p:nvSpPr>
+        <p:spPr>
+          <a:xfrm>
+            <a:off x="411480" y="3154680"/>
+            <a:ext cx="4091940" cy="1325880"/>
+          </a:xfrm>
+          <a:prstGeom prst="roundRect">
+            <a:avLst>
+              <a:gd name="adj" fmla="val 4138"/>
+            </a:avLst>
+          </a:prstGeom>
+          <a:solidFill>
+            <a:srgbClr val="E3F4F1"/>
+          </a:solidFill>
+          <a:ln w="15875">
+            <a:solidFill>
+              <a:srgbClr val="0B7A6F"/>
+            </a:solidFill>
+            <a:prstDash val="solid"/>
+          </a:ln>
+        </p:spPr>
+      </p:sp>
+      <p:sp>
+        <p:nvSpPr>
+          <p:cNvPr id="18" name="step1Text"/>
+          <p:cNvSpPr txBox="1"/>
+          <p:nvPr/>
+        </p:nvSpPr>
+        <p:spPr>
+          <a:xfrm>
+            <a:off x="594360" y="3246120"/>
+            <a:ext cx="3726180" cy="1143000"/>
+          </a:xfrm>
+          <a:prstGeom prst="rect">
+            <a:avLst/>
+          </a:prstGeom>
+          <a:noFill/>
+          <a:ln/>
+        </p:spPr>
+        <p:txBody>
+          <a:bodyPr wrap="square" lIns="0" tIns="0" rIns="0" bIns="0" rtlCol="0" anchor="ctr"/>
+          <a:lstStyle/>
+          <a:p>
+            <a:pPr indent="0" marL="0">
+              <a:spcAft>
+                <a:spcPts val="400"/>
+              </a:spcAft>
+              <a:buNone/>
+            </a:pPr>
+            <a:r>
+              <a:rPr lang="en-US" sz="1050" b="1" dirty="0">
+                <a:solidFill>
+                  <a:srgbClr val="1D1D1F"/>
+                </a:solidFill>
+                <a:latin typeface="SF Pro Text" pitchFamily="34" charset="0"/>
+                <a:ea typeface="SF Pro Text" pitchFamily="34" charset="-122"/>
+                <a:cs typeface="SF Pro Text" pitchFamily="34" charset="-120"/>
+              </a:rPr>
+              <a:t>CP was denied entry because:</a:t>
+            </a:r>
+            <a:endParaRPr lang="en-US" sz="1050" dirty="0"/>
+          </a:p>
+          <a:p>
+            <a:pPr marL="152400" indent="-152400">
+              <a:spcAft>
+                <a:spcPts val="400"/>
+              </a:spcAft>
+              <a:buSzPct val="100000"/>
+              <a:buChar char="•"/>
+            </a:pPr>
+            <a:r>
+              <a:rPr lang="en-US" sz="1050" dirty="0">
+                <a:solidFill>
+                  <a:srgbClr val="1D1D1F"/>
+                </a:solidFill>
+                <a:latin typeface="SF Pro Text" pitchFamily="34" charset="0"/>
+                <a:ea typeface="SF Pro Text" pitchFamily="34" charset="-122"/>
+                <a:cs typeface="SF Pro Text" pitchFamily="34" charset="-120"/>
+              </a:rPr>
+              <a:t>Looked unprofessional</a:t>
+            </a:r>
+            <a:endParaRPr lang="en-US" sz="1050" dirty="0"/>
+          </a:p>
+          <a:p>
+            <a:pPr marL="152400" indent="-152400">
+              <a:spcAft>
+                <a:spcPts val="400"/>
+              </a:spcAft>
+              <a:buSzPct val="100000"/>
+              <a:buChar char="•"/>
+            </a:pPr>
+            <a:r>
+              <a:rPr lang="en-US" sz="1050" dirty="0">
+                <a:solidFill>
+                  <a:srgbClr val="1D1D1F"/>
+                </a:solidFill>
+                <a:latin typeface="SF Pro Text" pitchFamily="34" charset="0"/>
+                <a:ea typeface="SF Pro Text" pitchFamily="34" charset="-122"/>
+                <a:cs typeface="SF Pro Text" pitchFamily="34" charset="-120"/>
+              </a:rPr>
+              <a:t>Brought an unauthorized guest</a:t>
+            </a:r>
+            <a:endParaRPr lang="en-US" sz="1050" dirty="0"/>
+          </a:p>
+          <a:p>
+            <a:pPr marL="152400" indent="-152400">
+              <a:spcAft>
+                <a:spcPts val="400"/>
+              </a:spcAft>
+              <a:buSzPct val="100000"/>
+              <a:buChar char="•"/>
+            </a:pPr>
+            <a:r>
+              <a:rPr lang="en-US" sz="1050" dirty="0">
+                <a:solidFill>
+                  <a:srgbClr val="1D1D1F"/>
+                </a:solidFill>
+                <a:latin typeface="SF Pro Text" pitchFamily="34" charset="0"/>
+                <a:ea typeface="SF Pro Text" pitchFamily="34" charset="-122"/>
+                <a:cs typeface="SF Pro Text" pitchFamily="34" charset="-120"/>
+              </a:rPr>
+              <a:t>Did not have any cleaning supplies</a:t>
+            </a:r>
+            <a:endParaRPr lang="en-US" sz="1050" dirty="0"/>
+          </a:p>
+        </p:txBody>
+      </p:sp>
+      <p:sp>
+        <p:nvSpPr>
+          <p:cNvPr id="19" name="Text 14"/>
+          <p:cNvSpPr/>
+          <p:nvPr/>
+        </p:nvSpPr>
+        <p:spPr>
+          <a:xfrm>
+            <a:off x="7772400" y="2606040"/>
+            <a:ext cx="777240" cy="274320"/>
+          </a:xfrm>
+          <a:prstGeom prst="roundRect">
+            <a:avLst>
+              <a:gd name="adj" fmla="val 20000"/>
+            </a:avLst>
+          </a:prstGeom>
+          <a:solidFill>
+            <a:srgbClr val="FFFFFF"/>
+          </a:solidFill>
+          <a:ln w="12700">
+            <a:solidFill>
+              <a:srgbClr val="0B7A6F"/>
+            </a:solidFill>
+          </a:ln>
+        </p:spPr>
+        <p:txBody>
+          <a:bodyPr wrap="square" lIns="0" tIns="0" rIns="0" bIns="0" rtlCol="0" anchor="ctr"/>
+          <a:lstStyle/>
+          <a:p>
+            <a:pPr algn="ctr" indent="0" marL="0">
+              <a:buNone/>
+            </a:pPr>
+            <a:r>
+              <a:rPr lang="en-US" sz="850" b="1" dirty="0">
+                <a:solidFill>
+                  <a:srgbClr val="0B7A6F"/>
+                </a:solidFill>
+                <a:latin typeface="SF Pro Text" pitchFamily="34" charset="0"/>
+                <a:ea typeface="SF Pro Text" pitchFamily="34" charset="-122"/>
+                <a:cs typeface="SF Pro Text" pitchFamily="34" charset="-120"/>
+              </a:rPr>
+              <a:t>Details  ›</a:t>
+            </a:r>
+            <a:endParaRPr lang="en-US" sz="850" dirty="0"/>
+          </a:p>
+        </p:txBody>
+      </p:sp>
+      <p:sp>
+        <p:nvSpPr>
+          <p:cNvPr id="20" name="step2Panel"/>
+          <p:cNvSpPr/>
+          <p:nvPr/>
+        </p:nvSpPr>
+        <p:spPr>
+          <a:xfrm>
+            <a:off x="4640580" y="3154680"/>
+            <a:ext cx="4091940" cy="1325880"/>
+          </a:xfrm>
+          <a:prstGeom prst="roundRect">
+            <a:avLst>
+              <a:gd name="adj" fmla="val 4138"/>
+            </a:avLst>
+          </a:prstGeom>
+          <a:solidFill>
+            <a:srgbClr val="E3F4F1"/>
+          </a:solidFill>
+          <a:ln w="15875">
+            <a:solidFill>
+              <a:srgbClr val="0B7A6F"/>
+            </a:solidFill>
+            <a:prstDash val="solid"/>
+          </a:ln>
+        </p:spPr>
+      </p:sp>
+      <p:sp>
+        <p:nvSpPr>
+          <p:cNvPr id="21" name="step2Text"/>
+          <p:cNvSpPr txBox="1"/>
+          <p:nvPr/>
+        </p:nvSpPr>
+        <p:spPr>
+          <a:xfrm>
+            <a:off x="4823460" y="3246120"/>
+            <a:ext cx="3726180" cy="1143000"/>
+          </a:xfrm>
+          <a:prstGeom prst="rect">
+            <a:avLst/>
+          </a:prstGeom>
+          <a:noFill/>
+          <a:ln/>
+        </p:spPr>
+        <p:txBody>
+          <a:bodyPr wrap="square" lIns="0" tIns="0" rIns="0" bIns="0" rtlCol="0" anchor="ctr"/>
+          <a:lstStyle/>
+          <a:p>
+            <a:pPr indent="0" marL="0">
+              <a:spcAft>
+                <a:spcPts val="400"/>
+              </a:spcAft>
+              <a:buNone/>
+            </a:pPr>
+            <a:r>
+              <a:rPr lang="en-US" sz="1050" b="1" dirty="0">
+                <a:solidFill>
+                  <a:srgbClr val="0B7A6F"/>
+                </a:solidFill>
+                <a:latin typeface="SF Pro Text" pitchFamily="34" charset="0"/>
+                <a:ea typeface="SF Pro Text" pitchFamily="34" charset="-122"/>
+                <a:cs typeface="SF Pro Text" pitchFamily="34" charset="-120"/>
+              </a:rPr>
+              <a:t>Our fault → </a:t>
+            </a:r>
+            <a:pPr indent="0" marL="0">
+              <a:spcAft>
+                <a:spcPts val="400"/>
+              </a:spcAft>
+              <a:buNone/>
+            </a:pPr>
+            <a:r>
+              <a:rPr lang="en-US" sz="1050" dirty="0">
+                <a:solidFill>
+                  <a:srgbClr val="1D1D1F"/>
+                </a:solidFill>
+                <a:latin typeface="SF Pro Text" pitchFamily="34" charset="0"/>
+                <a:ea typeface="SF Pro Text" pitchFamily="34" charset="-122"/>
+                <a:cs typeface="SF Pro Text" pitchFamily="34" charset="-120"/>
+              </a:rPr>
+              <a:t>We missed to act on job cancellation request; CP wasn’t notified, causing the lockout</a:t>
+            </a:r>
+            <a:endParaRPr lang="en-US" sz="1050" dirty="0"/>
           </a:p>
         </p:txBody>
       </p:sp>
@@ -20091,6 +20532,218 @@
   <p:clrMapOvr>
     <a:masterClrMapping/>
   </p:clrMapOvr>
+  <p:timing>
+    <p:tnLst>
+      <p:par>
+        <p:cTn id="1" dur="indefinite" restart="never" nodeType="tmRoot">
+          <p:childTnLst>
+            <p:seq concurrent="1" nextAc="seek">
+              <p:cTn id="2" dur="indefinite" nodeType="mainSeq">
+                <p:childTnLst>
+                  <p:par>
+                    <p:cTn id="9" fill="hold">
+                      <p:stCondLst>
+                        <p:cond delay="indefinite"/>
+                      </p:stCondLst>
+                      <p:childTnLst>
+                        <p:par>
+                          <p:cTn id="10" fill="hold">
+                            <p:stCondLst>
+                              <p:cond delay="0"/>
+                            </p:stCondLst>
+                            <p:childTnLst>
+                              <p:par>
+                                <p:cTn id="5" presetID="10" presetClass="entr" presetSubtype="0" fill="hold" grpId="0" nodeType="clickEffect">
+                                  <p:stCondLst>
+                                    <p:cond delay="0"/>
+                                  </p:stCondLst>
+                                  <p:childTnLst>
+                                    <p:set>
+                                      <p:cBhvr>
+                                        <p:cTn id="6" dur="1" fill="hold">
+                                          <p:stCondLst>
+                                            <p:cond delay="0"/>
+                                          </p:stCondLst>
+                                        </p:cTn>
+                                        <p:tgtEl>
+                                          <p:spTgt spid="17"/>
+                                        </p:tgtEl>
+                                        <p:attrNameLst>
+                                          <p:attrName>style.visibility</p:attrName>
+                                        </p:attrNameLst>
+                                      </p:cBhvr>
+                                      <p:to>
+                                        <p:strVal val="visible"/>
+                                      </p:to>
+                                    </p:set>
+                                    <p:animEffect transition="in" filter="fade">
+                                      <p:cBhvr>
+                                        <p:cTn id="7" dur="600"/>
+                                        <p:tgtEl>
+                                          <p:spTgt spid="17"/>
+                                        </p:tgtEl>
+                                      </p:cBhvr>
+                                    </p:animEffect>
+                                  </p:childTnLst>
+                                </p:cTn>
+                              </p:par>
+                              <p:par>
+                                <p:cTn id="8" presetID="10" presetClass="entr" presetSubtype="0" fill="hold" grpId="0" nodeType="withEffect">
+                                  <p:stCondLst>
+                                    <p:cond delay="0"/>
+                                  </p:stCondLst>
+                                  <p:childTnLst>
+                                    <p:set>
+                                      <p:cBhvr>
+                                        <p:cTn id="9" dur="1" fill="hold">
+                                          <p:stCondLst>
+                                            <p:cond delay="0"/>
+                                          </p:stCondLst>
+                                        </p:cTn>
+                                        <p:tgtEl>
+                                          <p:spTgt spid="18"/>
+                                        </p:tgtEl>
+                                        <p:attrNameLst>
+                                          <p:attrName>style.visibility</p:attrName>
+                                        </p:attrNameLst>
+                                      </p:cBhvr>
+                                      <p:to>
+                                        <p:strVal val="visible"/>
+                                      </p:to>
+                                    </p:set>
+                                    <p:animEffect transition="in" filter="fade">
+                                      <p:cBhvr>
+                                        <p:cTn id="10" dur="600"/>
+                                        <p:tgtEl>
+                                          <p:spTgt spid="18"/>
+                                        </p:tgtEl>
+                                      </p:cBhvr>
+                                    </p:animEffect>
+                                  </p:childTnLst>
+                                </p:cTn>
+                              </p:par>
+                            </p:childTnLst>
+                          </p:cTn>
+                        </p:par>
+                      </p:childTnLst>
+                    </p:cTn>
+                  </p:par>
+                  <p:par>
+                    <p:cTn id="17" fill="hold">
+                      <p:stCondLst>
+                        <p:cond delay="indefinite"/>
+                      </p:stCondLst>
+                      <p:childTnLst>
+                        <p:par>
+                          <p:cTn id="18" fill="hold">
+                            <p:stCondLst>
+                              <p:cond delay="0"/>
+                            </p:stCondLst>
+                            <p:childTnLst>
+                              <p:par>
+                                <p:cTn id="13" presetID="10" presetClass="entr" presetSubtype="0" fill="hold" grpId="0" nodeType="clickEffect">
+                                  <p:stCondLst>
+                                    <p:cond delay="0"/>
+                                  </p:stCondLst>
+                                  <p:childTnLst>
+                                    <p:set>
+                                      <p:cBhvr>
+                                        <p:cTn id="14" dur="1" fill="hold">
+                                          <p:stCondLst>
+                                            <p:cond delay="0"/>
+                                          </p:stCondLst>
+                                        </p:cTn>
+                                        <p:tgtEl>
+                                          <p:spTgt spid="20"/>
+                                        </p:tgtEl>
+                                        <p:attrNameLst>
+                                          <p:attrName>style.visibility</p:attrName>
+                                        </p:attrNameLst>
+                                      </p:cBhvr>
+                                      <p:to>
+                                        <p:strVal val="visible"/>
+                                      </p:to>
+                                    </p:set>
+                                    <p:animEffect transition="in" filter="fade">
+                                      <p:cBhvr>
+                                        <p:cTn id="15" dur="600"/>
+                                        <p:tgtEl>
+                                          <p:spTgt spid="20"/>
+                                        </p:tgtEl>
+                                      </p:cBhvr>
+                                    </p:animEffect>
+                                  </p:childTnLst>
+                                </p:cTn>
+                              </p:par>
+                              <p:par>
+                                <p:cTn id="16" presetID="10" presetClass="entr" presetSubtype="0" fill="hold" grpId="0" nodeType="withEffect">
+                                  <p:stCondLst>
+                                    <p:cond delay="0"/>
+                                  </p:stCondLst>
+                                  <p:childTnLst>
+                                    <p:set>
+                                      <p:cBhvr>
+                                        <p:cTn id="17" dur="1" fill="hold">
+                                          <p:stCondLst>
+                                            <p:cond delay="0"/>
+                                          </p:stCondLst>
+                                        </p:cTn>
+                                        <p:tgtEl>
+                                          <p:spTgt spid="21"/>
+                                        </p:tgtEl>
+                                        <p:attrNameLst>
+                                          <p:attrName>style.visibility</p:attrName>
+                                        </p:attrNameLst>
+                                      </p:cBhvr>
+                                      <p:to>
+                                        <p:strVal val="visible"/>
+                                      </p:to>
+                                    </p:set>
+                                    <p:animEffect transition="in" filter="fade">
+                                      <p:cBhvr>
+                                        <p:cTn id="18" dur="600"/>
+                                        <p:tgtEl>
+                                          <p:spTgt spid="21"/>
+                                        </p:tgtEl>
+                                      </p:cBhvr>
+                                    </p:animEffect>
+                                  </p:childTnLst>
+                                </p:cTn>
+                              </p:par>
+                            </p:childTnLst>
+                          </p:cTn>
+                        </p:par>
+                      </p:childTnLst>
+                    </p:cTn>
+                  </p:par>
+                </p:childTnLst>
+              </p:cTn>
+              <p:prevCondLst>
+                <p:cond evt="onPrev" delay="0">
+                  <p:tgtEl>
+                    <p:sldTgt/>
+                  </p:tgtEl>
+                </p:cond>
+              </p:prevCondLst>
+              <p:nextCondLst>
+                <p:cond evt="onNext" delay="0">
+                  <p:tgtEl>
+                    <p:sldTgt/>
+                  </p:tgtEl>
+                </p:cond>
+              </p:nextCondLst>
+            </p:seq>
+          </p:childTnLst>
+        </p:cTn>
+      </p:par>
+    </p:tnLst>
+    <p:bldLst>
+      <p:bldP spid="17" grpId="0" animBg="1"/>
+      <p:bldP spid="18" grpId="0" animBg="1"/>
+      <p:bldP spid="20" grpId="0" animBg="1"/>
+      <p:bldP spid="21" grpId="0" animBg="1"/>
+    </p:bldLst>
+  </p:timing>
 </p:sld>
 </file>
 

</xml_diff>

<commit_message>
Lockout deck: live-ticket practice slide replaces the wrap-up
Co-Authored-By: Claude Opus 5.5 <noreply@anthropic.com>
Claude-Session: https://claude.ai/code/session_01FEzv8wwqWDgTsXP8Yz6XYn
</commit_message>
<xml_diff>
--- a/incorrect-info-lmc-lockout/incorrect-info-lmc-lockout.pptx
+++ b/incorrect-info-lmc-lockout/incorrect-info-lmc-lockout.pptx
@@ -2112,7 +2112,7 @@
           <a:p>
             <a:r>
               <a:rPr lang="en-US" dirty="0"/>
-              <a:t>TRAINER: recap the three takeaways, then open the floor for questions on Lockouts.</a:t>
+              <a:t>TRAINER: share a live Lockout ticket. Give trainees a few minutes to review it on their own, then work through it together. 1) Is the lockout valid or invalid, and why? Walk the four questions in order: did the customer want the appointment, did the CP arrive on time (30 min before to 30 min after start), did the CP arrive at the address, and did the CP try to complete it (2+ contact attempts, 5+ min apart, 15+ min on site, entry notes followed). Remember the exception if the customer refused entry or wanted to cancel on arrival. 2) What actions are you going to take? Invalid: refund through the CP Dashboard (and the Premium fee if charged). Valid: only if the customer asks for a refund or contests the charge, go straight to their customer category offer. Check the special scenarios (entry denied for CP fault or T&amp;S; cancelled via Support but not actioned). Leave an internal note with your findings. Which macro? 3) 5-minute writing challenge: each trainee writes the comms they would send the customer. Read a few aloud and compare. Then open the floor for questions on Lockouts.</a:t>
             </a:r>
             <a:endParaRPr lang="en-US" dirty="0"/>
           </a:p>
@@ -22999,7 +22999,7 @@
                 <a:ea typeface="SF Pro Display" pitchFamily="34" charset="-122"/>
                 <a:cs typeface="SF Pro Display" pitchFamily="34" charset="-120"/>
               </a:rPr>
-              <a:t>LOCKOUT  ·  WRAP-UP</a:t>
+              <a:t>LOCKOUT  ·  PRACTICE</a:t>
             </a:r>
             <a:endParaRPr lang="en-US" sz="800" dirty="0"/>
           </a:p>
@@ -23038,7 +23038,7 @@
                 <a:ea typeface="SF Pro Display" pitchFamily="34" charset="-122"/>
                 <a:cs typeface="SF Pro Display" pitchFamily="34" charset="-120"/>
               </a:rPr>
-              <a:t>Wrap-up</a:t>
+              <a:t>Let's investigate together!</a:t>
             </a:r>
             <a:endParaRPr lang="en-US" sz="2400" dirty="0"/>
           </a:p>
@@ -23077,7 +23077,7 @@
                 <a:ea typeface="SF Pro Text" pitchFamily="34" charset="-122"/>
                 <a:cs typeface="SF Pro Text" pitchFamily="34" charset="-120"/>
               </a:rPr>
-              <a:t>Key takeaways before we move on.</a:t>
+              <a:t>Review the live ticket and investigate.</a:t>
             </a:r>
             <a:endParaRPr lang="en-US" sz="1200" dirty="0"/>
           </a:p>
@@ -23091,12 +23091,12 @@
         </p:nvSpPr>
         <p:spPr>
           <a:xfrm>
-            <a:off x="411480" y="1325880"/>
-            <a:ext cx="2682240" cy="1600200"/>
+            <a:off x="411480" y="1298448"/>
+            <a:ext cx="3383280" cy="2633472"/>
           </a:xfrm>
           <a:prstGeom prst="roundRect">
             <a:avLst>
-              <a:gd name="adj" fmla="val 4571"/>
+              <a:gd name="adj" fmla="val 2778"/>
             </a:avLst>
           </a:prstGeom>
           <a:solidFill>
@@ -23118,8 +23118,8 @@
         </p:nvSpPr>
         <p:spPr>
           <a:xfrm>
-            <a:off x="576072" y="1508760"/>
-            <a:ext cx="274320" cy="274320"/>
+            <a:off x="594360" y="1481328"/>
+            <a:ext cx="384048" cy="384048"/>
           </a:xfrm>
           <a:prstGeom prst="ellipse">
             <a:avLst/>
@@ -23135,16 +23135,40 @@
           </a:ln>
         </p:spPr>
       </p:sp>
-      <p:sp>
-        <p:nvSpPr>
-          <p:cNvPr id="8" name="Text 5"/>
+      <p:pic>
+        <p:nvPicPr>
+          <p:cNvPr id="8" name="Image 0" descr="preencoded.png">    </p:cNvPr>
+          <p:cNvPicPr>
+            <a:picLocks noChangeAspect="1"/>
+          </p:cNvPicPr>
+          <p:nvPr/>
+        </p:nvPicPr>
+        <p:blipFill>
+          <a:blip r:embed="rId1"/>
+          <a:stretch>
+            <a:fillRect/>
+          </a:stretch>
+        </p:blipFill>
+        <p:spPr>
+          <a:xfrm>
+            <a:off x="686532" y="1573500"/>
+            <a:ext cx="199705" cy="199705"/>
+          </a:xfrm>
+          <a:prstGeom prst="rect">
+            <a:avLst/>
+          </a:prstGeom>
+        </p:spPr>
+      </p:pic>
+      <p:sp>
+        <p:nvSpPr>
+          <p:cNvPr id="9" name="Text 5"/>
           <p:cNvSpPr txBox="1"/>
           <p:nvPr/>
         </p:nvSpPr>
         <p:spPr>
           <a:xfrm>
-            <a:off x="576072" y="1508760"/>
-            <a:ext cx="274320" cy="274320"/>
+            <a:off x="594360" y="2011680"/>
+            <a:ext cx="3017520" cy="292608"/>
           </a:xfrm>
           <a:prstGeom prst="rect">
             <a:avLst/>
@@ -23153,37 +23177,37 @@
           <a:ln/>
         </p:spPr>
         <p:txBody>
-          <a:bodyPr wrap="square" lIns="0" tIns="0" rIns="0" bIns="0" rtlCol="0" anchor="ctr"/>
-          <a:lstStyle/>
-          <a:p>
-            <a:pPr algn="ctr" indent="0" marL="0">
-              <a:buNone/>
-            </a:pPr>
-            <a:r>
-              <a:rPr lang="en-US" sz="900" b="1" dirty="0">
-                <a:solidFill>
-                  <a:srgbClr val="0B7A6F"/>
+          <a:bodyPr wrap="square" lIns="0" tIns="0" rIns="0" bIns="0" rtlCol="0" anchor="t"/>
+          <a:lstStyle/>
+          <a:p>
+            <a:pPr indent="0" marL="0">
+              <a:buNone/>
+            </a:pPr>
+            <a:r>
+              <a:rPr lang="en-US" sz="1300" b="1" dirty="0">
+                <a:solidFill>
+                  <a:srgbClr val="1D1D1F"/>
                 </a:solidFill>
                 <a:latin typeface="SF Pro Display" pitchFamily="34" charset="0"/>
                 <a:ea typeface="SF Pro Display" pitchFamily="34" charset="-122"/>
                 <a:cs typeface="SF Pro Display" pitchFamily="34" charset="-120"/>
               </a:rPr>
-              <a:t>1</a:t>
-            </a:r>
-            <a:endParaRPr lang="en-US" sz="900" dirty="0"/>
-          </a:p>
-        </p:txBody>
-      </p:sp>
-      <p:sp>
-        <p:nvSpPr>
-          <p:cNvPr id="9" name="Text 6"/>
+              <a:t>Live ticket</a:t>
+            </a:r>
+            <a:endParaRPr lang="en-US" sz="1300" dirty="0"/>
+          </a:p>
+        </p:txBody>
+      </p:sp>
+      <p:sp>
+        <p:nvSpPr>
+          <p:cNvPr id="10" name="Text 6"/>
           <p:cNvSpPr txBox="1"/>
           <p:nvPr/>
         </p:nvSpPr>
         <p:spPr>
           <a:xfrm>
-            <a:off x="576072" y="1929384"/>
-            <a:ext cx="2353056" cy="274320"/>
+            <a:off x="594360" y="2350008"/>
+            <a:ext cx="3017520" cy="731520"/>
           </a:xfrm>
           <a:prstGeom prst="rect">
             <a:avLst/>
@@ -23199,46 +23223,7 @@
               <a:buNone/>
             </a:pPr>
             <a:r>
-              <a:rPr lang="en-US" sz="1200" b="1" dirty="0">
-                <a:solidFill>
-                  <a:srgbClr val="1D1D1F"/>
-                </a:solidFill>
-                <a:latin typeface="SF Pro Display" pitchFamily="34" charset="0"/>
-                <a:ea typeface="SF Pro Display" pitchFamily="34" charset="-122"/>
-                <a:cs typeface="SF Pro Display" pitchFamily="34" charset="-120"/>
-              </a:rPr>
-              <a:t>Four questions</a:t>
-            </a:r>
-            <a:endParaRPr lang="en-US" sz="1200" dirty="0"/>
-          </a:p>
-        </p:txBody>
-      </p:sp>
-      <p:sp>
-        <p:nvSpPr>
-          <p:cNvPr id="10" name="Text 7"/>
-          <p:cNvSpPr txBox="1"/>
-          <p:nvPr/>
-        </p:nvSpPr>
-        <p:spPr>
-          <a:xfrm>
-            <a:off x="576072" y="2221992"/>
-            <a:ext cx="2353056" cy="612648"/>
-          </a:xfrm>
-          <a:prstGeom prst="rect">
-            <a:avLst/>
-          </a:prstGeom>
-          <a:noFill/>
-          <a:ln/>
-        </p:spPr>
-        <p:txBody>
-          <a:bodyPr wrap="square" lIns="0" tIns="0" rIns="0" bIns="0" rtlCol="0" anchor="t"/>
-          <a:lstStyle/>
-          <a:p>
-            <a:pPr indent="0" marL="0">
-              <a:buNone/>
-            </a:pPr>
-            <a:r>
-              <a:rPr lang="en-US" sz="950" dirty="0">
+              <a:rPr lang="en-US" sz="1050" dirty="0">
                 <a:solidFill>
                   <a:srgbClr val="6E6E73"/>
                 </a:solidFill>
@@ -23246,26 +23231,73 @@
                 <a:ea typeface="SF Pro Text" pitchFamily="34" charset="-122"/>
                 <a:cs typeface="SF Pro Text" pitchFamily="34" charset="-120"/>
               </a:rPr>
-              <a:t>Wanted it? On time? At the address? Tried to get in?</a:t>
-            </a:r>
-            <a:endParaRPr lang="en-US" sz="950" dirty="0"/>
-          </a:p>
-        </p:txBody>
-      </p:sp>
-      <p:sp>
-        <p:nvSpPr>
-          <p:cNvPr id="11" name="Shape 8"/>
+              <a:t>Your trainer will provide a live ticket. Review it and investigate before you decide anything.</a:t>
+            </a:r>
+            <a:endParaRPr lang="en-US" sz="1050" dirty="0"/>
+          </a:p>
+        </p:txBody>
+      </p:sp>
+      <p:sp>
+        <p:nvSpPr>
+          <p:cNvPr id="11" name="Text 7"/>
           <p:cNvSpPr/>
           <p:nvPr/>
         </p:nvSpPr>
         <p:spPr>
           <a:xfrm>
-            <a:off x="3230880" y="1325880"/>
-            <a:ext cx="2682240" cy="1600200"/>
+            <a:off x="594360" y="3401568"/>
+            <a:ext cx="1371600" cy="329184"/>
           </a:xfrm>
           <a:prstGeom prst="roundRect">
             <a:avLst>
-              <a:gd name="adj" fmla="val 4571"/>
+              <a:gd name="adj" fmla="val 22222"/>
+            </a:avLst>
+          </a:prstGeom>
+          <a:solidFill>
+            <a:srgbClr val="FFF3D6"/>
+          </a:solidFill>
+          <a:ln>
+            <a:solidFill>
+              <a:srgbClr val="FFF3D6"/>
+            </a:solidFill>
+          </a:ln>
+        </p:spPr>
+        <p:txBody>
+          <a:bodyPr wrap="square" lIns="0" tIns="0" rIns="0" bIns="0" rtlCol="0" anchor="ctr"/>
+          <a:lstStyle/>
+          <a:p>
+            <a:pPr algn="ctr" indent="0" marL="0">
+              <a:buNone/>
+            </a:pPr>
+            <a:r>
+              <a:rPr lang="en-US" sz="950" b="1" dirty="0">
+                <a:solidFill>
+                  <a:srgbClr val="9A6410"/>
+                </a:solidFill>
+                <a:latin typeface="SF Pro Text" pitchFamily="34" charset="0"/>
+                <a:ea typeface="SF Pro Text" pitchFamily="34" charset="-122"/>
+                <a:cs typeface="SF Pro Text" pitchFamily="34" charset="-120"/>
+              </a:rPr>
+              <a:t>Trainer provides</a:t>
+            </a:r>
+            <a:endParaRPr lang="en-US" sz="950" dirty="0"/>
+          </a:p>
+        </p:txBody>
+      </p:sp>
+      <p:sp>
+        <p:nvSpPr>
+          <p:cNvPr id="12" name="Shape 8"/>
+          <p:cNvSpPr/>
+          <p:nvPr/>
+        </p:nvSpPr>
+        <p:spPr>
+          <a:xfrm>
+            <a:off x="3931920" y="1298448"/>
+            <a:ext cx="4800600" cy="786384"/>
+          </a:xfrm>
+          <a:prstGeom prst="roundRect">
+            <a:avLst>
+              <a:gd name="adj" fmla="val 9302"/>
             </a:avLst>
           </a:prstGeom>
           <a:solidFill>
@@ -23281,13 +23313,13 @@
       </p:sp>
       <p:sp>
         <p:nvSpPr>
-          <p:cNvPr id="12" name="Shape 9"/>
+          <p:cNvPr id="13" name="Shape 9"/>
           <p:cNvSpPr/>
           <p:nvPr/>
         </p:nvSpPr>
         <p:spPr>
           <a:xfrm>
-            <a:off x="3395472" y="1508760"/>
+            <a:off x="4114800" y="1554480"/>
             <a:ext cx="274320" cy="274320"/>
           </a:xfrm>
           <a:prstGeom prst="ellipse">
@@ -23306,13 +23338,13 @@
       </p:sp>
       <p:sp>
         <p:nvSpPr>
-          <p:cNvPr id="13" name="Text 10"/>
+          <p:cNvPr id="14" name="Text 10"/>
           <p:cNvSpPr txBox="1"/>
           <p:nvPr/>
         </p:nvSpPr>
         <p:spPr>
           <a:xfrm>
-            <a:off x="3395472" y="1508760"/>
+            <a:off x="4114800" y="1554480"/>
             <a:ext cx="274320" cy="274320"/>
           </a:xfrm>
           <a:prstGeom prst="rect">
@@ -23337,7 +23369,7 @@
                 <a:ea typeface="SF Pro Display" pitchFamily="34" charset="-122"/>
                 <a:cs typeface="SF Pro Display" pitchFamily="34" charset="-120"/>
               </a:rPr>
-              <a:t>2</a:t>
+              <a:t>1</a:t>
             </a:r>
             <a:endParaRPr lang="en-US" sz="900" dirty="0"/>
           </a:p>
@@ -23345,14 +23377,14 @@
       </p:sp>
       <p:sp>
         <p:nvSpPr>
-          <p:cNvPr id="14" name="Text 11"/>
+          <p:cNvPr id="15" name="Text 11"/>
           <p:cNvSpPr txBox="1"/>
           <p:nvPr/>
         </p:nvSpPr>
         <p:spPr>
           <a:xfrm>
-            <a:off x="3395472" y="1929384"/>
-            <a:ext cx="2353056" cy="274320"/>
+            <a:off x="4572000" y="1426464"/>
+            <a:ext cx="3977640" cy="292608"/>
           </a:xfrm>
           <a:prstGeom prst="rect">
             <a:avLst/>
@@ -23361,14 +23393,14 @@
           <a:ln/>
         </p:spPr>
         <p:txBody>
-          <a:bodyPr wrap="square" lIns="0" tIns="0" rIns="0" bIns="0" rtlCol="0" anchor="t"/>
+          <a:bodyPr wrap="square" lIns="0" tIns="0" rIns="0" bIns="0" rtlCol="0" anchor="ctr"/>
           <a:lstStyle/>
           <a:p>
             <a:pPr indent="0" marL="0">
               <a:buNone/>
             </a:pPr>
             <a:r>
-              <a:rPr lang="en-US" sz="1200" b="1" dirty="0">
+              <a:rPr lang="en-US" sz="1250" b="1" dirty="0">
                 <a:solidFill>
                   <a:srgbClr val="1D1D1F"/>
                 </a:solidFill>
@@ -23376,22 +23408,22 @@
                 <a:ea typeface="SF Pro Display" pitchFamily="34" charset="-122"/>
                 <a:cs typeface="SF Pro Display" pitchFamily="34" charset="-120"/>
               </a:rPr>
-              <a:t>Invalid? CP pays</a:t>
-            </a:r>
-            <a:endParaRPr lang="en-US" sz="1200" dirty="0"/>
-          </a:p>
-        </p:txBody>
-      </p:sp>
-      <p:sp>
-        <p:nvSpPr>
-          <p:cNvPr id="15" name="Text 12"/>
+              <a:t>Is the lockout valid or invalid? Why?</a:t>
+            </a:r>
+            <a:endParaRPr lang="en-US" sz="1250" dirty="0"/>
+          </a:p>
+        </p:txBody>
+      </p:sp>
+      <p:sp>
+        <p:nvSpPr>
+          <p:cNvPr id="16" name="Text 12"/>
           <p:cNvSpPr txBox="1"/>
           <p:nvPr/>
         </p:nvSpPr>
         <p:spPr>
           <a:xfrm>
-            <a:off x="3395472" y="2221992"/>
-            <a:ext cx="2353056" cy="612648"/>
+            <a:off x="4572000" y="1737360"/>
+            <a:ext cx="3977640" cy="256032"/>
           </a:xfrm>
           <a:prstGeom prst="rect">
             <a:avLst/>
@@ -23400,14 +23432,14 @@
           <a:ln/>
         </p:spPr>
         <p:txBody>
-          <a:bodyPr wrap="square" lIns="0" tIns="0" rIns="0" bIns="0" rtlCol="0" anchor="t"/>
+          <a:bodyPr wrap="square" lIns="0" tIns="0" rIns="0" bIns="0" rtlCol="0" anchor="ctr"/>
           <a:lstStyle/>
           <a:p>
             <a:pPr indent="0" marL="0">
               <a:buNone/>
             </a:pPr>
             <a:r>
-              <a:rPr lang="en-US" sz="950" dirty="0">
+              <a:rPr lang="en-US" sz="1000" dirty="0">
                 <a:solidFill>
                   <a:srgbClr val="6E6E73"/>
                 </a:solidFill>
@@ -23415,26 +23447,26 @@
                 <a:ea typeface="SF Pro Text" pitchFamily="34" charset="-122"/>
                 <a:cs typeface="SF Pro Text" pitchFamily="34" charset="-120"/>
               </a:rPr>
-              <a:t>Refund through the CP Dashboard, not admin.</a:t>
-            </a:r>
-            <a:endParaRPr lang="en-US" sz="950" dirty="0"/>
-          </a:p>
-        </p:txBody>
-      </p:sp>
-      <p:sp>
-        <p:nvSpPr>
-          <p:cNvPr id="16" name="Shape 13"/>
+              <a:t>Wanted it? On time? At the address? Tried to get in?</a:t>
+            </a:r>
+            <a:endParaRPr lang="en-US" sz="1000" dirty="0"/>
+          </a:p>
+        </p:txBody>
+      </p:sp>
+      <p:sp>
+        <p:nvSpPr>
+          <p:cNvPr id="17" name="Shape 13"/>
           <p:cNvSpPr/>
           <p:nvPr/>
         </p:nvSpPr>
         <p:spPr>
           <a:xfrm>
-            <a:off x="6050280" y="1325880"/>
-            <a:ext cx="2682240" cy="1600200"/>
+            <a:off x="3931920" y="2221992"/>
+            <a:ext cx="4800600" cy="786384"/>
           </a:xfrm>
           <a:prstGeom prst="roundRect">
             <a:avLst>
-              <a:gd name="adj" fmla="val 4571"/>
+              <a:gd name="adj" fmla="val 9302"/>
             </a:avLst>
           </a:prstGeom>
           <a:solidFill>
@@ -23450,13 +23482,13 @@
       </p:sp>
       <p:sp>
         <p:nvSpPr>
-          <p:cNvPr id="17" name="Shape 14"/>
+          <p:cNvPr id="18" name="Shape 14"/>
           <p:cNvSpPr/>
           <p:nvPr/>
         </p:nvSpPr>
         <p:spPr>
           <a:xfrm>
-            <a:off x="6214872" y="1508760"/>
+            <a:off x="4114800" y="2478024"/>
             <a:ext cx="274320" cy="274320"/>
           </a:xfrm>
           <a:prstGeom prst="ellipse">
@@ -23475,13 +23507,13 @@
       </p:sp>
       <p:sp>
         <p:nvSpPr>
-          <p:cNvPr id="18" name="Text 15"/>
+          <p:cNvPr id="19" name="Text 15"/>
           <p:cNvSpPr txBox="1"/>
           <p:nvPr/>
         </p:nvSpPr>
         <p:spPr>
           <a:xfrm>
-            <a:off x="6214872" y="1508760"/>
+            <a:off x="4114800" y="2478024"/>
             <a:ext cx="274320" cy="274320"/>
           </a:xfrm>
           <a:prstGeom prst="rect">
@@ -23506,7 +23538,7 @@
                 <a:ea typeface="SF Pro Display" pitchFamily="34" charset="-122"/>
                 <a:cs typeface="SF Pro Display" pitchFamily="34" charset="-120"/>
               </a:rPr>
-              <a:t>3</a:t>
+              <a:t>2</a:t>
             </a:r>
             <a:endParaRPr lang="en-US" sz="900" dirty="0"/>
           </a:p>
@@ -23514,14 +23546,14 @@
       </p:sp>
       <p:sp>
         <p:nvSpPr>
-          <p:cNvPr id="19" name="Text 16"/>
+          <p:cNvPr id="20" name="Text 16"/>
           <p:cNvSpPr txBox="1"/>
           <p:nvPr/>
         </p:nvSpPr>
         <p:spPr>
           <a:xfrm>
-            <a:off x="6214872" y="1929384"/>
-            <a:ext cx="2353056" cy="274320"/>
+            <a:off x="4572000" y="2350008"/>
+            <a:ext cx="3977640" cy="292608"/>
           </a:xfrm>
           <a:prstGeom prst="rect">
             <a:avLst/>
@@ -23530,14 +23562,14 @@
           <a:ln/>
         </p:spPr>
         <p:txBody>
-          <a:bodyPr wrap="square" lIns="0" tIns="0" rIns="0" bIns="0" rtlCol="0" anchor="t"/>
+          <a:bodyPr wrap="square" lIns="0" tIns="0" rIns="0" bIns="0" rtlCol="0" anchor="ctr"/>
           <a:lstStyle/>
           <a:p>
             <a:pPr indent="0" marL="0">
               <a:buNone/>
             </a:pPr>
             <a:r>
-              <a:rPr lang="en-US" sz="1200" b="1" dirty="0">
+              <a:rPr lang="en-US" sz="1250" b="1" dirty="0">
                 <a:solidFill>
                   <a:srgbClr val="1D1D1F"/>
                 </a:solidFill>
@@ -23545,22 +23577,22 @@
                 <a:ea typeface="SF Pro Display" pitchFamily="34" charset="-122"/>
                 <a:cs typeface="SF Pro Display" pitchFamily="34" charset="-120"/>
               </a:rPr>
-              <a:t>Valid? By category</a:t>
-            </a:r>
-            <a:endParaRPr lang="en-US" sz="1200" dirty="0"/>
-          </a:p>
-        </p:txBody>
-      </p:sp>
-      <p:sp>
-        <p:nvSpPr>
-          <p:cNvPr id="20" name="Text 17"/>
+              <a:t>What actions are you going to take?</a:t>
+            </a:r>
+            <a:endParaRPr lang="en-US" sz="1250" dirty="0"/>
+          </a:p>
+        </p:txBody>
+      </p:sp>
+      <p:sp>
+        <p:nvSpPr>
+          <p:cNvPr id="21" name="Text 17"/>
           <p:cNvSpPr txBox="1"/>
           <p:nvPr/>
         </p:nvSpPr>
         <p:spPr>
           <a:xfrm>
-            <a:off x="6214872" y="2221992"/>
-            <a:ext cx="2353056" cy="612648"/>
+            <a:off x="4572000" y="2660904"/>
+            <a:ext cx="3977640" cy="256032"/>
           </a:xfrm>
           <a:prstGeom prst="rect">
             <a:avLst/>
@@ -23569,14 +23601,14 @@
           <a:ln/>
         </p:spPr>
         <p:txBody>
-          <a:bodyPr wrap="square" lIns="0" tIns="0" rIns="0" bIns="0" rtlCol="0" anchor="t"/>
+          <a:bodyPr wrap="square" lIns="0" tIns="0" rIns="0" bIns="0" rtlCol="0" anchor="ctr"/>
           <a:lstStyle/>
           <a:p>
             <a:pPr indent="0" marL="0">
               <a:buNone/>
             </a:pPr>
             <a:r>
-              <a:rPr lang="en-US" sz="950" dirty="0">
+              <a:rPr lang="en-US" sz="1000" dirty="0">
                 <a:solidFill>
                   <a:srgbClr val="6E6E73"/>
                 </a:solidFill>
@@ -23584,26 +23616,195 @@
                 <a:ea typeface="SF Pro Text" pitchFamily="34" charset="-122"/>
                 <a:cs typeface="SF Pro Text" pitchFamily="34" charset="-120"/>
               </a:rPr>
-              <a:t>Straight to the tier's offer. $40 CP cost stays.</a:t>
-            </a:r>
-            <a:endParaRPr lang="en-US" sz="950" dirty="0"/>
-          </a:p>
-        </p:txBody>
-      </p:sp>
-      <p:sp>
-        <p:nvSpPr>
-          <p:cNvPr id="21" name="Shape 18"/>
+              <a:t>Invalid: CP Dashboard refund. Valid: customer category.</a:t>
+            </a:r>
+            <a:endParaRPr lang="en-US" sz="1000" dirty="0"/>
+          </a:p>
+        </p:txBody>
+      </p:sp>
+      <p:sp>
+        <p:nvSpPr>
+          <p:cNvPr id="22" name="Shape 18"/>
           <p:cNvSpPr/>
           <p:nvPr/>
         </p:nvSpPr>
         <p:spPr>
           <a:xfrm>
-            <a:off x="411480" y="3108960"/>
-            <a:ext cx="8321040" cy="914400"/>
+            <a:off x="3931920" y="3145536"/>
+            <a:ext cx="4800600" cy="786384"/>
           </a:xfrm>
           <a:prstGeom prst="roundRect">
             <a:avLst>
-              <a:gd name="adj" fmla="val 8000"/>
+              <a:gd name="adj" fmla="val 9302"/>
+            </a:avLst>
+          </a:prstGeom>
+          <a:solidFill>
+            <a:srgbClr val="FFFFFF"/>
+          </a:solidFill>
+          <a:ln w="9525">
+            <a:solidFill>
+              <a:srgbClr val="DCE1E7"/>
+            </a:solidFill>
+            <a:prstDash val="solid"/>
+          </a:ln>
+        </p:spPr>
+      </p:sp>
+      <p:sp>
+        <p:nvSpPr>
+          <p:cNvPr id="23" name="Shape 19"/>
+          <p:cNvSpPr/>
+          <p:nvPr/>
+        </p:nvSpPr>
+        <p:spPr>
+          <a:xfrm>
+            <a:off x="4114800" y="3401568"/>
+            <a:ext cx="274320" cy="274320"/>
+          </a:xfrm>
+          <a:prstGeom prst="ellipse">
+            <a:avLst/>
+          </a:prstGeom>
+          <a:solidFill>
+            <a:srgbClr val="E3F4F1"/>
+          </a:solidFill>
+          <a:ln w="12700">
+            <a:solidFill>
+              <a:srgbClr val="E3F4F1"/>
+            </a:solidFill>
+            <a:prstDash val="solid"/>
+          </a:ln>
+        </p:spPr>
+      </p:sp>
+      <p:sp>
+        <p:nvSpPr>
+          <p:cNvPr id="24" name="Text 20"/>
+          <p:cNvSpPr txBox="1"/>
+          <p:nvPr/>
+        </p:nvSpPr>
+        <p:spPr>
+          <a:xfrm>
+            <a:off x="4114800" y="3401568"/>
+            <a:ext cx="274320" cy="274320"/>
+          </a:xfrm>
+          <a:prstGeom prst="rect">
+            <a:avLst/>
+          </a:prstGeom>
+          <a:noFill/>
+          <a:ln/>
+        </p:spPr>
+        <p:txBody>
+          <a:bodyPr wrap="square" lIns="0" tIns="0" rIns="0" bIns="0" rtlCol="0" anchor="ctr"/>
+          <a:lstStyle/>
+          <a:p>
+            <a:pPr algn="ctr" indent="0" marL="0">
+              <a:buNone/>
+            </a:pPr>
+            <a:r>
+              <a:rPr lang="en-US" sz="900" b="1" dirty="0">
+                <a:solidFill>
+                  <a:srgbClr val="0B7A6F"/>
+                </a:solidFill>
+                <a:latin typeface="SF Pro Display" pitchFamily="34" charset="0"/>
+                <a:ea typeface="SF Pro Display" pitchFamily="34" charset="-122"/>
+                <a:cs typeface="SF Pro Display" pitchFamily="34" charset="-120"/>
+              </a:rPr>
+              <a:t>3</a:t>
+            </a:r>
+            <a:endParaRPr lang="en-US" sz="900" dirty="0"/>
+          </a:p>
+        </p:txBody>
+      </p:sp>
+      <p:sp>
+        <p:nvSpPr>
+          <p:cNvPr id="25" name="Text 21"/>
+          <p:cNvSpPr txBox="1"/>
+          <p:nvPr/>
+        </p:nvSpPr>
+        <p:spPr>
+          <a:xfrm>
+            <a:off x="4572000" y="3273552"/>
+            <a:ext cx="3977640" cy="292608"/>
+          </a:xfrm>
+          <a:prstGeom prst="rect">
+            <a:avLst/>
+          </a:prstGeom>
+          <a:noFill/>
+          <a:ln/>
+        </p:spPr>
+        <p:txBody>
+          <a:bodyPr wrap="square" lIns="0" tIns="0" rIns="0" bIns="0" rtlCol="0" anchor="ctr"/>
+          <a:lstStyle/>
+          <a:p>
+            <a:pPr indent="0" marL="0">
+              <a:buNone/>
+            </a:pPr>
+            <a:r>
+              <a:rPr lang="en-US" sz="1250" b="1" dirty="0">
+                <a:solidFill>
+                  <a:srgbClr val="1D1D1F"/>
+                </a:solidFill>
+                <a:latin typeface="SF Pro Display" pitchFamily="34" charset="0"/>
+                <a:ea typeface="SF Pro Display" pitchFamily="34" charset="-122"/>
+                <a:cs typeface="SF Pro Display" pitchFamily="34" charset="-120"/>
+              </a:rPr>
+              <a:t>5-min writing challenge</a:t>
+            </a:r>
+            <a:endParaRPr lang="en-US" sz="1250" dirty="0"/>
+          </a:p>
+        </p:txBody>
+      </p:sp>
+      <p:sp>
+        <p:nvSpPr>
+          <p:cNvPr id="26" name="Text 22"/>
+          <p:cNvSpPr txBox="1"/>
+          <p:nvPr/>
+        </p:nvSpPr>
+        <p:spPr>
+          <a:xfrm>
+            <a:off x="4572000" y="3584448"/>
+            <a:ext cx="3977640" cy="256032"/>
+          </a:xfrm>
+          <a:prstGeom prst="rect">
+            <a:avLst/>
+          </a:prstGeom>
+          <a:noFill/>
+          <a:ln/>
+        </p:spPr>
+        <p:txBody>
+          <a:bodyPr wrap="square" lIns="0" tIns="0" rIns="0" bIns="0" rtlCol="0" anchor="ctr"/>
+          <a:lstStyle/>
+          <a:p>
+            <a:pPr indent="0" marL="0">
+              <a:buNone/>
+            </a:pPr>
+            <a:r>
+              <a:rPr lang="en-US" sz="1000" dirty="0">
+                <a:solidFill>
+                  <a:srgbClr val="6E6E73"/>
+                </a:solidFill>
+                <a:latin typeface="SF Pro Text" pitchFamily="34" charset="0"/>
+                <a:ea typeface="SF Pro Text" pitchFamily="34" charset="-122"/>
+                <a:cs typeface="SF Pro Text" pitchFamily="34" charset="-120"/>
+              </a:rPr>
+              <a:t>Create your comms for the customer.</a:t>
+            </a:r>
+            <a:endParaRPr lang="en-US" sz="1000" dirty="0"/>
+          </a:p>
+        </p:txBody>
+      </p:sp>
+      <p:sp>
+        <p:nvSpPr>
+          <p:cNvPr id="27" name="Shape 23"/>
+          <p:cNvSpPr/>
+          <p:nvPr/>
+        </p:nvSpPr>
+        <p:spPr>
+          <a:xfrm>
+            <a:off x="411480" y="4069080"/>
+            <a:ext cx="8321040" cy="502920"/>
+          </a:xfrm>
+          <a:prstGeom prst="roundRect">
+            <a:avLst>
+              <a:gd name="adj" fmla="val 14545"/>
             </a:avLst>
           </a:prstGeom>
           <a:solidFill>
@@ -23619,22 +23820,22 @@
       </p:sp>
       <p:pic>
         <p:nvPicPr>
-          <p:cNvPr id="22" name="Image 0" descr="preencoded.png">    </p:cNvPr>
+          <p:cNvPr id="28" name="Image 1" descr="preencoded.png">    </p:cNvPr>
           <p:cNvPicPr>
             <a:picLocks noChangeAspect="1"/>
           </p:cNvPicPr>
           <p:nvPr/>
         </p:nvPicPr>
         <p:blipFill>
-          <a:blip r:embed="rId1"/>
+          <a:blip r:embed="rId2"/>
           <a:stretch>
             <a:fillRect/>
           </a:stretch>
         </p:blipFill>
         <p:spPr>
           <a:xfrm>
-            <a:off x="731520" y="3383280"/>
-            <a:ext cx="365760" cy="365760"/>
+            <a:off x="640080" y="4192524"/>
+            <a:ext cx="256032" cy="256032"/>
           </a:xfrm>
           <a:prstGeom prst="rect">
             <a:avLst/>
@@ -23643,14 +23844,14 @@
       </p:pic>
       <p:sp>
         <p:nvSpPr>
-          <p:cNvPr id="23" name="Text 19"/>
+          <p:cNvPr id="29" name="Text 24"/>
           <p:cNvSpPr txBox="1"/>
           <p:nvPr/>
         </p:nvSpPr>
         <p:spPr>
           <a:xfrm>
-            <a:off x="1325880" y="3108960"/>
-            <a:ext cx="7223760" cy="914400"/>
+            <a:off x="1051560" y="4069080"/>
+            <a:ext cx="7498080" cy="502920"/>
           </a:xfrm>
           <a:prstGeom prst="rect">
             <a:avLst/>
@@ -23666,7 +23867,7 @@
               <a:buNone/>
             </a:pPr>
             <a:r>
-              <a:rPr lang="en-US" sz="2000" b="1" dirty="0">
+              <a:rPr lang="en-US" sz="1400" b="1" dirty="0">
                 <a:solidFill>
                   <a:srgbClr val="FFFFFF"/>
                 </a:solidFill>
@@ -23674,11 +23875,8 @@
                 <a:ea typeface="SF Pro Display" pitchFamily="34" charset="-122"/>
                 <a:cs typeface="SF Pro Display" pitchFamily="34" charset="-120"/>
               </a:rPr>
-              <a:t>Questions?</a:t>
-            </a:r>
-            <a:endParaRPr lang="en-US" sz="2000" dirty="0"/>
-          </a:p>
-          <a:p>
+              <a:t>Questions?  </a:t>
+            </a:r>
             <a:pPr indent="0" marL="0">
               <a:buNone/>
             </a:pPr>
@@ -23693,7 +23891,7 @@
               </a:rPr>
               <a:t>Open the floor before we move to the next topic.</a:t>
             </a:r>
-            <a:endParaRPr lang="en-US" sz="2000" dirty="0"/>
+            <a:endParaRPr lang="en-US" sz="1400" dirty="0"/>
           </a:p>
         </p:txBody>
       </p:sp>

</xml_diff>

<commit_message>
Priority Fee: two tiles; screenshots open on click from two buttons
Co-Authored-By: Claude Opus 5.5 <noreply@anthropic.com>
Claude-Session: https://claude.ai/code/session_01FEzv8wwqWDgTsXP8Yz6XYn
</commit_message>
<xml_diff>
--- a/incorrect-info-lmc-lockout/incorrect-info-lmc-lockout.pptx
+++ b/incorrect-info-lmc-lockout/incorrect-info-lmc-lockout.pptx
@@ -2219,7 +2219,7 @@
           <a:p>
             <a:r>
               <a:rPr lang="en-US" dirty="0"/>
-              <a:t>The system automatically applies a Priority Fee when the customer books a cleaning scheduled to take place within 12–48 hours from the time they book it, or reschedules a cleaning and the new appointment is within 48 hours from the time they make the change. The Priority Fee is also subject to the standard 15% processing fee charged on billable services. Whenever we talk about refunding the Priority Fee, that includes the associated 15% processing fee. Example: Priority Fee $15/hr x 3 hrs = $45; processing fee (15%) $6.75; total charged $51.75. When refunding, refund both, since the processing fee was charged because of the Priority Fee. ON THE SLIDE: left, the message customers see when the date and time they pick incurs a Priority Fee ("This time is a high-demand date &amp; time for cleaners. Priority rates may apply."). Right, how the charge shows on the Job Admin page: the + PriorityMarkup line in the Base breakdown (here $23.50/hr), and the 15% processing fee in the Txn Fee column.</a:t>
+              <a:t>The system automatically applies a Priority Fee when the customer books a cleaning scheduled to take place within 12–48 hours from the time they book it, or reschedules a cleaning and the new appointment is within 48 hours from the time they make the change. The Priority Fee is also subject to the standard 15% processing fee charged on billable services. Whenever we talk about refunding the Priority Fee, that includes the associated 15% processing fee. Example: Priority Fee $15/hr x 3 hrs = $45; processing fee (15%) $6.75; total charged $51.75. When refunding, refund both, since the processing fee was charged because of the Priority Fee. ON THE SLIDE: first, the message customers see when the date and time they pick incurs a Priority Fee ("This time is a high-demand date &amp; time for cleaners. Priority rates may apply."). Second, how the charge shows on the Job Admin page: the + PriorityMarkup line in the Base breakdown (here $23.50/hr), and the 15% processing fee in the Txn Fee column. TRAINER: the screenshots are hidden when the slide opens. Click once (What the customer sees when booking) to show the booking prompt, click again (How it shows in Job Admin) to swap to the Job Admin screenshot, and click a third time to close it.</a:t>
             </a:r>
             <a:endParaRPr lang="en-US" dirty="0"/>
           </a:p>
@@ -26087,7 +26087,7 @@
         <p:spPr>
           <a:xfrm>
             <a:off x="411480" y="1298448"/>
-            <a:ext cx="2514600" cy="1051560"/>
+            <a:ext cx="4091940" cy="1051560"/>
           </a:xfrm>
           <a:prstGeom prst="roundRect">
             <a:avLst>
@@ -26114,7 +26114,7 @@
         <p:spPr>
           <a:xfrm>
             <a:off x="411480" y="1371600"/>
-            <a:ext cx="2514600" cy="502920"/>
+            <a:ext cx="4091940" cy="502920"/>
           </a:xfrm>
           <a:prstGeom prst="rect">
             <a:avLst/>
@@ -26130,7 +26130,7 @@
               <a:buNone/>
             </a:pPr>
             <a:r>
-              <a:rPr lang="en-US" sz="2600" b="1" dirty="0">
+              <a:rPr lang="en-US" sz="2800" b="1" dirty="0">
                 <a:solidFill>
                   <a:srgbClr val="0B7A6F"/>
                 </a:solidFill>
@@ -26140,7 +26140,7 @@
               </a:rPr>
               <a:t>&lt; 48 hrs</a:t>
             </a:r>
-            <a:endParaRPr lang="en-US" sz="2600" dirty="0"/>
+            <a:endParaRPr lang="en-US" sz="2800" dirty="0"/>
           </a:p>
         </p:txBody>
       </p:sp>
@@ -26152,8 +26152,8 @@
         </p:nvSpPr>
         <p:spPr>
           <a:xfrm>
-            <a:off x="548640" y="1892808"/>
-            <a:ext cx="2240280" cy="384048"/>
+            <a:off x="594360" y="1892808"/>
+            <a:ext cx="3726180" cy="365760"/>
           </a:xfrm>
           <a:prstGeom prst="rect">
             <a:avLst/>
@@ -26169,7 +26169,7 @@
               <a:buNone/>
             </a:pPr>
             <a:r>
-              <a:rPr lang="en-US" sz="900" dirty="0">
+              <a:rPr lang="en-US" sz="1000" dirty="0">
                 <a:solidFill>
                   <a:srgbClr val="6E6E73"/>
                 </a:solidFill>
@@ -26179,105 +26179,20 @@
               </a:rPr>
               <a:t>Booked (12–48 hrs out) or rescheduled into this window</a:t>
             </a:r>
-            <a:endParaRPr lang="en-US" sz="900" dirty="0"/>
-          </a:p>
-        </p:txBody>
-      </p:sp>
-      <p:sp>
-        <p:nvSpPr>
-          <p:cNvPr id="9" name="Text 6"/>
-          <p:cNvSpPr txBox="1"/>
-          <p:nvPr/>
-        </p:nvSpPr>
-        <p:spPr>
-          <a:xfrm>
-            <a:off x="411480" y="2468880"/>
-            <a:ext cx="2514600" cy="182880"/>
-          </a:xfrm>
-          <a:prstGeom prst="rect">
-            <a:avLst/>
-          </a:prstGeom>
-          <a:noFill/>
-          <a:ln/>
-        </p:spPr>
-        <p:txBody>
-          <a:bodyPr wrap="square" lIns="0" tIns="0" rIns="0" bIns="0" rtlCol="0" anchor="t"/>
-          <a:lstStyle/>
-          <a:p>
-            <a:pPr indent="0" marL="0">
-              <a:buNone/>
-            </a:pPr>
-            <a:r>
-              <a:rPr lang="en-US" sz="800" b="1" spc="50" kern="0" dirty="0">
-                <a:solidFill>
-                  <a:srgbClr val="6E6E73"/>
-                </a:solidFill>
-                <a:latin typeface="SF Pro Display" pitchFamily="34" charset="0"/>
-                <a:ea typeface="SF Pro Display" pitchFamily="34" charset="-122"/>
-                <a:cs typeface="SF Pro Display" pitchFamily="34" charset="-120"/>
-              </a:rPr>
-              <a:t>WHAT THE CUSTOMER SEES WHEN BOOKING</a:t>
-            </a:r>
-            <a:endParaRPr lang="en-US" sz="800" dirty="0"/>
-          </a:p>
-        </p:txBody>
-      </p:sp>
-      <p:pic>
-        <p:nvPicPr>
-          <p:cNvPr id="10" name="Image 0" descr="/tmp/claude-0/-workspace-training/3ce5cff6-cccf-5f33-b0ee-0b147a55120e/scratchpad/img6/priority_prompt.png">    </p:cNvPr>
-          <p:cNvPicPr>
-            <a:picLocks noChangeAspect="1"/>
-          </p:cNvPicPr>
-          <p:nvPr/>
-        </p:nvPicPr>
-        <p:blipFill>
-          <a:blip r:embed="rId1"/>
-          <a:stretch>
-            <a:fillRect/>
-          </a:stretch>
-        </p:blipFill>
-        <p:spPr>
-          <a:xfrm>
-            <a:off x="411480" y="2670048"/>
-            <a:ext cx="2514600" cy="1196906"/>
-          </a:xfrm>
-          <a:prstGeom prst="rect">
-            <a:avLst/>
-          </a:prstGeom>
-        </p:spPr>
-      </p:pic>
-      <p:sp>
-        <p:nvSpPr>
-          <p:cNvPr id="11" name="Shape 7"/>
+            <a:endParaRPr lang="en-US" sz="1000" dirty="0"/>
+          </a:p>
+        </p:txBody>
+      </p:sp>
+      <p:sp>
+        <p:nvSpPr>
+          <p:cNvPr id="9" name="Shape 6"/>
           <p:cNvSpPr/>
           <p:nvPr/>
         </p:nvSpPr>
         <p:spPr>
           <a:xfrm>
-            <a:off x="411480" y="2670048"/>
-            <a:ext cx="2514600" cy="1196906"/>
-          </a:xfrm>
-          <a:prstGeom prst="rect">
-            <a:avLst/>
-          </a:prstGeom>
-          <a:ln w="9525">
-            <a:solidFill>
-              <a:srgbClr val="DCE1E7"/>
-            </a:solidFill>
-            <a:prstDash val="solid"/>
-          </a:ln>
-        </p:spPr>
-      </p:sp>
-      <p:sp>
-        <p:nvSpPr>
-          <p:cNvPr id="12" name="Shape 8"/>
-          <p:cNvSpPr/>
-          <p:nvPr/>
-        </p:nvSpPr>
-        <p:spPr>
-          <a:xfrm>
-            <a:off x="3063240" y="1298448"/>
-            <a:ext cx="1417320" cy="1051560"/>
+            <a:off x="4640580" y="1298448"/>
+            <a:ext cx="4091940" cy="1051560"/>
           </a:xfrm>
           <a:prstGeom prst="roundRect">
             <a:avLst>
@@ -26297,14 +26212,14 @@
       </p:sp>
       <p:sp>
         <p:nvSpPr>
-          <p:cNvPr id="13" name="Text 9"/>
+          <p:cNvPr id="10" name="Text 7"/>
           <p:cNvSpPr txBox="1"/>
           <p:nvPr/>
         </p:nvSpPr>
         <p:spPr>
           <a:xfrm>
-            <a:off x="3063240" y="1371600"/>
-            <a:ext cx="1417320" cy="502920"/>
+            <a:off x="4640580" y="1371600"/>
+            <a:ext cx="4091940" cy="502920"/>
           </a:xfrm>
           <a:prstGeom prst="rect">
             <a:avLst/>
@@ -26320,7 +26235,7 @@
               <a:buNone/>
             </a:pPr>
             <a:r>
-              <a:rPr lang="en-US" sz="2600" b="1" dirty="0">
+              <a:rPr lang="en-US" sz="2800" b="1" dirty="0">
                 <a:solidFill>
                   <a:srgbClr val="0B7A6F"/>
                 </a:solidFill>
@@ -26330,20 +26245,20 @@
               </a:rPr>
               <a:t>+ 15%</a:t>
             </a:r>
-            <a:endParaRPr lang="en-US" sz="2600" dirty="0"/>
-          </a:p>
-        </p:txBody>
-      </p:sp>
-      <p:sp>
-        <p:nvSpPr>
-          <p:cNvPr id="14" name="Text 10"/>
+            <a:endParaRPr lang="en-US" sz="2800" dirty="0"/>
+          </a:p>
+        </p:txBody>
+      </p:sp>
+      <p:sp>
+        <p:nvSpPr>
+          <p:cNvPr id="11" name="Text 8"/>
           <p:cNvSpPr txBox="1"/>
           <p:nvPr/>
         </p:nvSpPr>
         <p:spPr>
           <a:xfrm>
-            <a:off x="3200400" y="1892808"/>
-            <a:ext cx="1143000" cy="384048"/>
+            <a:off x="4823460" y="1892808"/>
+            <a:ext cx="3726180" cy="365760"/>
           </a:xfrm>
           <a:prstGeom prst="rect">
             <a:avLst/>
@@ -26359,7 +26274,7 @@
               <a:buNone/>
             </a:pPr>
             <a:r>
-              <a:rPr lang="en-US" sz="900" dirty="0">
+              <a:rPr lang="en-US" sz="1000" dirty="0">
                 <a:solidFill>
                   <a:srgbClr val="6E6E73"/>
                 </a:solidFill>
@@ -26367,68 +26282,46 @@
                 <a:ea typeface="SF Pro Text" pitchFamily="34" charset="-122"/>
                 <a:cs typeface="SF Pro Text" pitchFamily="34" charset="-120"/>
               </a:rPr>
-              <a:t>Processing fee on top</a:t>
-            </a:r>
-            <a:endParaRPr lang="en-US" sz="900" dirty="0"/>
-          </a:p>
-        </p:txBody>
-      </p:sp>
-      <p:sp>
-        <p:nvSpPr>
-          <p:cNvPr id="15" name="Shape 11"/>
+              <a:t>Processing fee charged on top of the Priority Fee</a:t>
+            </a:r>
+            <a:endParaRPr lang="en-US" sz="1000" dirty="0"/>
+          </a:p>
+        </p:txBody>
+      </p:sp>
+      <p:sp>
+        <p:nvSpPr>
+          <p:cNvPr id="12" name="Text 9"/>
           <p:cNvSpPr/>
           <p:nvPr/>
         </p:nvSpPr>
         <p:spPr>
           <a:xfrm>
-            <a:off x="3063240" y="2468880"/>
-            <a:ext cx="1417320" cy="1399032"/>
+            <a:off x="902970" y="2468880"/>
+            <a:ext cx="3108960" cy="329184"/>
           </a:xfrm>
           <a:prstGeom prst="roundRect">
             <a:avLst>
-              <a:gd name="adj" fmla="val 5229"/>
+              <a:gd name="adj" fmla="val 22222"/>
             </a:avLst>
           </a:prstGeom>
           <a:solidFill>
-            <a:srgbClr val="E3F4F1"/>
+            <a:srgbClr val="FFFFFF"/>
           </a:solidFill>
-          <a:ln w="9525">
+          <a:ln w="19050">
             <a:solidFill>
-              <a:srgbClr val="E3F4F1"/>
+              <a:srgbClr val="0B7A6F"/>
             </a:solidFill>
-            <a:prstDash val="solid"/>
           </a:ln>
         </p:spPr>
-      </p:sp>
-      <p:sp>
-        <p:nvSpPr>
-          <p:cNvPr id="16" name="Text 12"/>
-          <p:cNvSpPr txBox="1"/>
-          <p:nvPr/>
-        </p:nvSpPr>
-        <p:spPr>
-          <a:xfrm>
-            <a:off x="3172968" y="2560320"/>
-            <a:ext cx="1197864" cy="1234440"/>
-          </a:xfrm>
-          <a:prstGeom prst="rect">
-            <a:avLst/>
-          </a:prstGeom>
-          <a:noFill/>
-          <a:ln/>
-        </p:spPr>
-        <p:txBody>
-          <a:bodyPr wrap="square" lIns="0" tIns="0" rIns="0" bIns="0" rtlCol="0" anchor="t"/>
-          <a:lstStyle/>
-          <a:p>
-            <a:pPr indent="0" marL="0">
-              <a:spcAft>
-                <a:spcPts val="400"/>
-              </a:spcAft>
-              <a:buNone/>
-            </a:pPr>
-            <a:r>
-              <a:rPr lang="en-US" sz="900" b="1" dirty="0">
+        <p:txBody>
+          <a:bodyPr wrap="square" rtlCol="0" anchor="ctr"/>
+          <a:lstStyle/>
+          <a:p>
+            <a:pPr algn="ctr" indent="0" marL="0">
+              <a:buNone/>
+            </a:pPr>
+            <a:r>
+              <a:rPr lang="en-US" sz="1000" b="1" dirty="0">
                 <a:solidFill>
                   <a:srgbClr val="0B7A6F"/>
                 </a:solidFill>
@@ -26436,126 +26329,68 @@
                 <a:ea typeface="SF Pro Display" pitchFamily="34" charset="-122"/>
                 <a:cs typeface="SF Pro Display" pitchFamily="34" charset="-120"/>
               </a:rPr>
-              <a:t>In Job Admin</a:t>
-            </a:r>
-            <a:endParaRPr lang="en-US" sz="900" dirty="0"/>
-          </a:p>
-          <a:p>
-            <a:pPr indent="0" marL="0">
-              <a:spcAft>
-                <a:spcPts val="400"/>
-              </a:spcAft>
-              <a:buNone/>
-            </a:pPr>
-            <a:r>
-              <a:rPr lang="en-US" sz="900" dirty="0">
-                <a:solidFill>
-                  <a:srgbClr val="1D1D1F"/>
-                </a:solidFill>
-                <a:latin typeface="SF Pro Text" pitchFamily="34" charset="0"/>
-                <a:ea typeface="SF Pro Text" pitchFamily="34" charset="-122"/>
-                <a:cs typeface="SF Pro Text" pitchFamily="34" charset="-120"/>
-              </a:rPr>
-              <a:t>+ PriorityMarkup in the Base breakdown; the 15% in Txn Fee.</a:t>
-            </a:r>
-            <a:endParaRPr lang="en-US" sz="900" dirty="0"/>
-          </a:p>
-        </p:txBody>
-      </p:sp>
-      <p:sp>
-        <p:nvSpPr>
-          <p:cNvPr id="17" name="Text 13"/>
-          <p:cNvSpPr txBox="1"/>
-          <p:nvPr/>
-        </p:nvSpPr>
-        <p:spPr>
-          <a:xfrm>
-            <a:off x="4617720" y="1298448"/>
-            <a:ext cx="4114800" cy="182880"/>
-          </a:xfrm>
-          <a:prstGeom prst="rect">
-            <a:avLst/>
-          </a:prstGeom>
-          <a:noFill/>
-          <a:ln/>
-        </p:spPr>
-        <p:txBody>
-          <a:bodyPr wrap="square" lIns="0" tIns="0" rIns="0" bIns="0" rtlCol="0" anchor="t"/>
-          <a:lstStyle/>
-          <a:p>
-            <a:pPr indent="0" marL="0">
-              <a:buNone/>
-            </a:pPr>
-            <a:r>
-              <a:rPr lang="en-US" sz="800" b="1" spc="50" kern="0" dirty="0">
-                <a:solidFill>
-                  <a:srgbClr val="6E6E73"/>
+              <a:t>▶  What the customer sees when booking</a:t>
+            </a:r>
+            <a:endParaRPr lang="en-US" sz="1000" dirty="0"/>
+          </a:p>
+        </p:txBody>
+      </p:sp>
+      <p:sp>
+        <p:nvSpPr>
+          <p:cNvPr id="13" name="Text 10"/>
+          <p:cNvSpPr/>
+          <p:nvPr/>
+        </p:nvSpPr>
+        <p:spPr>
+          <a:xfrm>
+            <a:off x="5132070" y="2468880"/>
+            <a:ext cx="3108960" cy="329184"/>
+          </a:xfrm>
+          <a:prstGeom prst="roundRect">
+            <a:avLst>
+              <a:gd name="adj" fmla="val 22222"/>
+            </a:avLst>
+          </a:prstGeom>
+          <a:solidFill>
+            <a:srgbClr val="FFFFFF"/>
+          </a:solidFill>
+          <a:ln w="19050">
+            <a:solidFill>
+              <a:srgbClr val="0B7A6F"/>
+            </a:solidFill>
+          </a:ln>
+        </p:spPr>
+        <p:txBody>
+          <a:bodyPr wrap="square" rtlCol="0" anchor="ctr"/>
+          <a:lstStyle/>
+          <a:p>
+            <a:pPr algn="ctr" indent="0" marL="0">
+              <a:buNone/>
+            </a:pPr>
+            <a:r>
+              <a:rPr lang="en-US" sz="1000" b="1" dirty="0">
+                <a:solidFill>
+                  <a:srgbClr val="0B7A6F"/>
                 </a:solidFill>
                 <a:latin typeface="SF Pro Display" pitchFamily="34" charset="0"/>
                 <a:ea typeface="SF Pro Display" pitchFamily="34" charset="-122"/>
                 <a:cs typeface="SF Pro Display" pitchFamily="34" charset="-120"/>
               </a:rPr>
-              <a:t>HOW IT SHOWS IN JOB ADMIN</a:t>
-            </a:r>
-            <a:endParaRPr lang="en-US" sz="800" dirty="0"/>
-          </a:p>
-        </p:txBody>
-      </p:sp>
-      <p:pic>
-        <p:nvPicPr>
-          <p:cNvPr id="18" name="Image 1" descr="/tmp/claude-0/-workspace-training/3ce5cff6-cccf-5f33-b0ee-0b147a55120e/scratchpad/img6/priority_crm.png">    </p:cNvPr>
-          <p:cNvPicPr>
-            <a:picLocks noChangeAspect="1"/>
-          </p:cNvPicPr>
-          <p:nvPr/>
-        </p:nvPicPr>
-        <p:blipFill>
-          <a:blip r:embed="rId2"/>
-          <a:stretch>
-            <a:fillRect/>
-          </a:stretch>
-        </p:blipFill>
-        <p:spPr>
-          <a:xfrm>
-            <a:off x="4617720" y="1499616"/>
-            <a:ext cx="4114800" cy="1658516"/>
-          </a:xfrm>
-          <a:prstGeom prst="rect">
-            <a:avLst/>
-          </a:prstGeom>
-        </p:spPr>
-      </p:pic>
-      <p:sp>
-        <p:nvSpPr>
-          <p:cNvPr id="19" name="Shape 14"/>
+              <a:t>▶  How it shows in Job Admin</a:t>
+            </a:r>
+            <a:endParaRPr lang="en-US" sz="1000" dirty="0"/>
+          </a:p>
+        </p:txBody>
+      </p:sp>
+      <p:sp>
+        <p:nvSpPr>
+          <p:cNvPr id="14" name="Shape 11"/>
           <p:cNvSpPr/>
           <p:nvPr/>
         </p:nvSpPr>
         <p:spPr>
           <a:xfrm>
-            <a:off x="4617720" y="1499616"/>
-            <a:ext cx="4114800" cy="1658516"/>
-          </a:xfrm>
-          <a:prstGeom prst="rect">
-            <a:avLst/>
-          </a:prstGeom>
-          <a:ln w="9525">
-            <a:solidFill>
-              <a:srgbClr val="DCE1E7"/>
-            </a:solidFill>
-            <a:prstDash val="solid"/>
-          </a:ln>
-        </p:spPr>
-      </p:sp>
-      <p:sp>
-        <p:nvSpPr>
-          <p:cNvPr id="20" name="Shape 15"/>
-          <p:cNvSpPr/>
-          <p:nvPr/>
-        </p:nvSpPr>
-        <p:spPr>
-          <a:xfrm>
-            <a:off x="411480" y="4023360"/>
+            <a:off x="411480" y="3017520"/>
             <a:ext cx="8321040" cy="384048"/>
           </a:xfrm>
           <a:prstGeom prst="roundRect">
@@ -26576,7 +26411,276 @@
       </p:sp>
       <p:pic>
         <p:nvPicPr>
-          <p:cNvPr id="21" name="Image 2" descr="preencoded.png">    </p:cNvPr>
+          <p:cNvPr id="15" name="Image 0" descr="preencoded.png">    </p:cNvPr>
+          <p:cNvPicPr>
+            <a:picLocks noChangeAspect="1"/>
+          </p:cNvPicPr>
+          <p:nvPr/>
+        </p:nvPicPr>
+        <p:blipFill>
+          <a:blip r:embed="rId1"/>
+          <a:stretch>
+            <a:fillRect/>
+          </a:stretch>
+        </p:blipFill>
+        <p:spPr>
+          <a:xfrm>
+            <a:off x="566928" y="3127248"/>
+            <a:ext cx="164592" cy="164592"/>
+          </a:xfrm>
+          <a:prstGeom prst="rect">
+            <a:avLst/>
+          </a:prstGeom>
+        </p:spPr>
+      </p:pic>
+      <p:sp>
+        <p:nvSpPr>
+          <p:cNvPr id="16" name="Text 12"/>
+          <p:cNvSpPr txBox="1"/>
+          <p:nvPr/>
+        </p:nvSpPr>
+        <p:spPr>
+          <a:xfrm>
+            <a:off x="822960" y="3118104"/>
+            <a:ext cx="7772400" cy="201168"/>
+          </a:xfrm>
+          <a:prstGeom prst="rect">
+            <a:avLst/>
+          </a:prstGeom>
+          <a:noFill/>
+          <a:ln/>
+        </p:spPr>
+        <p:txBody>
+          <a:bodyPr wrap="square" lIns="0" tIns="0" rIns="0" bIns="0" rtlCol="0" anchor="t"/>
+          <a:lstStyle/>
+          <a:p>
+            <a:pPr indent="0" marL="0">
+              <a:buNone/>
+            </a:pPr>
+            <a:r>
+              <a:rPr lang="en-US" sz="1000" b="1" dirty="0">
+                <a:solidFill>
+                  <a:srgbClr val="9A6410"/>
+                </a:solidFill>
+                <a:latin typeface="SF Pro Text" pitchFamily="34" charset="0"/>
+                <a:ea typeface="SF Pro Text" pitchFamily="34" charset="-122"/>
+                <a:cs typeface="SF Pro Text" pitchFamily="34" charset="-120"/>
+              </a:rPr>
+              <a:t>Refunding it?  </a:t>
+            </a:r>
+            <a:pPr indent="0" marL="0">
+              <a:buNone/>
+            </a:pPr>
+            <a:r>
+              <a:rPr lang="en-US" sz="1000" dirty="0">
+                <a:solidFill>
+                  <a:srgbClr val="1D1D1F"/>
+                </a:solidFill>
+                <a:latin typeface="SF Pro Text" pitchFamily="34" charset="0"/>
+                <a:ea typeface="SF Pro Text" pitchFamily="34" charset="-122"/>
+                <a:cs typeface="SF Pro Text" pitchFamily="34" charset="-120"/>
+              </a:rPr>
+              <a:t>refund the 15% processing fee with it.</a:t>
+            </a:r>
+            <a:endParaRPr lang="en-US" sz="1000" dirty="0"/>
+          </a:p>
+        </p:txBody>
+      </p:sp>
+      <p:sp>
+        <p:nvSpPr>
+          <p:cNvPr id="17" name="pop1_2Panel"/>
+          <p:cNvSpPr/>
+          <p:nvPr/>
+        </p:nvSpPr>
+        <p:spPr>
+          <a:xfrm>
+            <a:off x="411480" y="1298448"/>
+            <a:ext cx="8321040" cy="3346704"/>
+          </a:xfrm>
+          <a:prstGeom prst="roundRect">
+            <a:avLst>
+              <a:gd name="adj" fmla="val 1639"/>
+            </a:avLst>
+          </a:prstGeom>
+          <a:solidFill>
+            <a:srgbClr val="FFFFFF"/>
+          </a:solidFill>
+          <a:ln w="19050">
+            <a:solidFill>
+              <a:srgbClr val="0B7A6F"/>
+            </a:solidFill>
+            <a:prstDash val="solid"/>
+          </a:ln>
+          <a:effectLst>
+            <a:outerShdw sx="100000" sy="100000" kx="0" ky="0" algn="bl" rotWithShape="0" blurRad="76200" dist="25400" dir="5400000">
+              <a:srgbClr val="000000">
+                <a:alpha val="18000"/>
+              </a:srgbClr>
+            </a:outerShdw>
+          </a:effectLst>
+        </p:spPr>
+      </p:sp>
+      <p:sp>
+        <p:nvSpPr>
+          <p:cNvPr id="18" name="pop1_2Label"/>
+          <p:cNvSpPr txBox="1"/>
+          <p:nvPr/>
+        </p:nvSpPr>
+        <p:spPr>
+          <a:xfrm>
+            <a:off x="640080" y="1389888"/>
+            <a:ext cx="7863840" cy="310896"/>
+          </a:xfrm>
+          <a:prstGeom prst="rect">
+            <a:avLst/>
+          </a:prstGeom>
+          <a:noFill/>
+          <a:ln/>
+        </p:spPr>
+        <p:txBody>
+          <a:bodyPr wrap="square" lIns="0" tIns="0" rIns="0" bIns="0" rtlCol="0" anchor="ctr"/>
+          <a:lstStyle/>
+          <a:p>
+            <a:pPr indent="0" marL="0">
+              <a:buNone/>
+            </a:pPr>
+            <a:r>
+              <a:rPr lang="en-US" sz="1200" b="1" dirty="0">
+                <a:solidFill>
+                  <a:srgbClr val="0B7A6F"/>
+                </a:solidFill>
+                <a:latin typeface="SF Pro Display" pitchFamily="34" charset="0"/>
+                <a:ea typeface="SF Pro Display" pitchFamily="34" charset="-122"/>
+                <a:cs typeface="SF Pro Display" pitchFamily="34" charset="-120"/>
+              </a:rPr>
+              <a:t>What the customer sees when booking</a:t>
+            </a:r>
+            <a:endParaRPr lang="en-US" sz="1200" dirty="0"/>
+          </a:p>
+        </p:txBody>
+      </p:sp>
+      <p:pic>
+        <p:nvPicPr>
+          <p:cNvPr id="19" name="pop1_2Img" descr="/tmp/claude-0/-workspace-training/3ce5cff6-cccf-5f33-b0ee-0b147a55120e/scratchpad/img6/priority_prompt.png">    </p:cNvPr>
+          <p:cNvPicPr>
+            <a:picLocks noChangeAspect="1"/>
+          </p:cNvPicPr>
+          <p:nvPr/>
+        </p:nvPicPr>
+        <p:blipFill>
+          <a:blip r:embed="rId2"/>
+          <a:stretch>
+            <a:fillRect/>
+          </a:stretch>
+        </p:blipFill>
+        <p:spPr>
+          <a:xfrm>
+            <a:off x="1651960" y="1755648"/>
+            <a:ext cx="5840080" cy="2779776"/>
+          </a:xfrm>
+          <a:prstGeom prst="rect">
+            <a:avLst/>
+          </a:prstGeom>
+        </p:spPr>
+      </p:pic>
+      <p:sp>
+        <p:nvSpPr>
+          <p:cNvPr id="20" name="pop1_2Frame"/>
+          <p:cNvSpPr/>
+          <p:nvPr/>
+        </p:nvSpPr>
+        <p:spPr>
+          <a:xfrm>
+            <a:off x="1651960" y="1755648"/>
+            <a:ext cx="5840080" cy="2779776"/>
+          </a:xfrm>
+          <a:prstGeom prst="rect">
+            <a:avLst/>
+          </a:prstGeom>
+          <a:ln w="9525">
+            <a:solidFill>
+              <a:srgbClr val="DCE1E7"/>
+            </a:solidFill>
+            <a:prstDash val="solid"/>
+          </a:ln>
+        </p:spPr>
+      </p:sp>
+      <p:sp>
+        <p:nvSpPr>
+          <p:cNvPr id="21" name="pop2_3Panel"/>
+          <p:cNvSpPr/>
+          <p:nvPr/>
+        </p:nvSpPr>
+        <p:spPr>
+          <a:xfrm>
+            <a:off x="411480" y="1298448"/>
+            <a:ext cx="8321040" cy="3346704"/>
+          </a:xfrm>
+          <a:prstGeom prst="roundRect">
+            <a:avLst>
+              <a:gd name="adj" fmla="val 1639"/>
+            </a:avLst>
+          </a:prstGeom>
+          <a:solidFill>
+            <a:srgbClr val="FFFFFF"/>
+          </a:solidFill>
+          <a:ln w="19050">
+            <a:solidFill>
+              <a:srgbClr val="0B7A6F"/>
+            </a:solidFill>
+            <a:prstDash val="solid"/>
+          </a:ln>
+          <a:effectLst>
+            <a:outerShdw sx="100000" sy="100000" kx="0" ky="0" algn="bl" rotWithShape="0" blurRad="76200" dist="25400" dir="5400000">
+              <a:srgbClr val="000000">
+                <a:alpha val="18000"/>
+              </a:srgbClr>
+            </a:outerShdw>
+          </a:effectLst>
+        </p:spPr>
+      </p:sp>
+      <p:sp>
+        <p:nvSpPr>
+          <p:cNvPr id="22" name="pop2_3Label"/>
+          <p:cNvSpPr txBox="1"/>
+          <p:nvPr/>
+        </p:nvSpPr>
+        <p:spPr>
+          <a:xfrm>
+            <a:off x="640080" y="1389888"/>
+            <a:ext cx="7863840" cy="310896"/>
+          </a:xfrm>
+          <a:prstGeom prst="rect">
+            <a:avLst/>
+          </a:prstGeom>
+          <a:noFill/>
+          <a:ln/>
+        </p:spPr>
+        <p:txBody>
+          <a:bodyPr wrap="square" lIns="0" tIns="0" rIns="0" bIns="0" rtlCol="0" anchor="ctr"/>
+          <a:lstStyle/>
+          <a:p>
+            <a:pPr indent="0" marL="0">
+              <a:buNone/>
+            </a:pPr>
+            <a:r>
+              <a:rPr lang="en-US" sz="1200" b="1" dirty="0">
+                <a:solidFill>
+                  <a:srgbClr val="0B7A6F"/>
+                </a:solidFill>
+                <a:latin typeface="SF Pro Display" pitchFamily="34" charset="0"/>
+                <a:ea typeface="SF Pro Display" pitchFamily="34" charset="-122"/>
+                <a:cs typeface="SF Pro Display" pitchFamily="34" charset="-120"/>
+              </a:rPr>
+              <a:t>How it shows in Job Admin</a:t>
+            </a:r>
+            <a:endParaRPr lang="en-US" sz="1200" dirty="0"/>
+          </a:p>
+        </p:txBody>
+      </p:sp>
+      <p:pic>
+        <p:nvPicPr>
+          <p:cNvPr id="23" name="pop2_3Img" descr="/tmp/claude-0/-workspace-training/3ce5cff6-cccf-5f33-b0ee-0b147a55120e/scratchpad/img6/priority_crm.png">    </p:cNvPr>
           <p:cNvPicPr>
             <a:picLocks noChangeAspect="1"/>
           </p:cNvPicPr>
@@ -26590,8 +26694,8 @@
         </p:blipFill>
         <p:spPr>
           <a:xfrm>
-            <a:off x="566928" y="4133088"/>
-            <a:ext cx="164592" cy="164592"/>
+            <a:off x="1123670" y="1755648"/>
+            <a:ext cx="6896659" cy="2779776"/>
           </a:xfrm>
           <a:prstGeom prst="rect">
             <a:avLst/>
@@ -26600,56 +26704,25 @@
       </p:pic>
       <p:sp>
         <p:nvSpPr>
-          <p:cNvPr id="22" name="Text 16"/>
-          <p:cNvSpPr txBox="1"/>
-          <p:nvPr/>
-        </p:nvSpPr>
-        <p:spPr>
-          <a:xfrm>
-            <a:off x="822960" y="4123944"/>
-            <a:ext cx="7772400" cy="201168"/>
-          </a:xfrm>
-          <a:prstGeom prst="rect">
-            <a:avLst/>
-          </a:prstGeom>
-          <a:noFill/>
-          <a:ln/>
-        </p:spPr>
-        <p:txBody>
-          <a:bodyPr wrap="square" lIns="0" tIns="0" rIns="0" bIns="0" rtlCol="0" anchor="t"/>
-          <a:lstStyle/>
-          <a:p>
-            <a:pPr indent="0" marL="0">
-              <a:buNone/>
-            </a:pPr>
-            <a:r>
-              <a:rPr lang="en-US" sz="1000" b="1" dirty="0">
-                <a:solidFill>
-                  <a:srgbClr val="9A6410"/>
-                </a:solidFill>
-                <a:latin typeface="SF Pro Text" pitchFamily="34" charset="0"/>
-                <a:ea typeface="SF Pro Text" pitchFamily="34" charset="-122"/>
-                <a:cs typeface="SF Pro Text" pitchFamily="34" charset="-120"/>
-              </a:rPr>
-              <a:t>Refunding it?  </a:t>
-            </a:r>
-            <a:pPr indent="0" marL="0">
-              <a:buNone/>
-            </a:pPr>
-            <a:r>
-              <a:rPr lang="en-US" sz="1000" dirty="0">
-                <a:solidFill>
-                  <a:srgbClr val="1D1D1F"/>
-                </a:solidFill>
-                <a:latin typeface="SF Pro Text" pitchFamily="34" charset="0"/>
-                <a:ea typeface="SF Pro Text" pitchFamily="34" charset="-122"/>
-                <a:cs typeface="SF Pro Text" pitchFamily="34" charset="-120"/>
-              </a:rPr>
-              <a:t>refund the 15% processing fee with it.</a:t>
-            </a:r>
-            <a:endParaRPr lang="en-US" sz="1000" dirty="0"/>
-          </a:p>
-        </p:txBody>
+          <p:cNvPr id="24" name="pop2_3Frame"/>
+          <p:cNvSpPr/>
+          <p:nvPr/>
+        </p:nvSpPr>
+        <p:spPr>
+          <a:xfrm>
+            <a:off x="1123670" y="1755648"/>
+            <a:ext cx="6896659" cy="2779776"/>
+          </a:xfrm>
+          <a:prstGeom prst="rect">
+            <a:avLst/>
+          </a:prstGeom>
+          <a:ln w="9525">
+            <a:solidFill>
+              <a:srgbClr val="DCE1E7"/>
+            </a:solidFill>
+            <a:prstDash val="solid"/>
+          </a:ln>
+        </p:spPr>
       </p:sp>
       <p:sp>
         <p:nvSpPr>
@@ -26704,6 +26777,600 @@
   <p:clrMapOvr>
     <a:masterClrMapping/>
   </p:clrMapOvr>
+  <p:timing>
+    <p:tnLst>
+      <p:par>
+        <p:cTn id="1" dur="indefinite" restart="never" nodeType="tmRoot">
+          <p:childTnLst>
+            <p:seq concurrent="1" nextAc="seek">
+              <p:cTn id="2" dur="indefinite" nodeType="mainSeq">
+                <p:childTnLst>
+                  <p:par>
+                    <p:cTn id="15" fill="hold">
+                      <p:stCondLst>
+                        <p:cond delay="indefinite"/>
+                      </p:stCondLst>
+                      <p:childTnLst>
+                        <p:par>
+                          <p:cTn id="16" fill="hold">
+                            <p:stCondLst>
+                              <p:cond delay="0"/>
+                            </p:stCondLst>
+                            <p:childTnLst>
+                              <p:par>
+                                <p:cTn id="5" presetID="10" presetClass="entr" presetSubtype="0" fill="hold" grpId="0" nodeType="clickEffect">
+                                  <p:stCondLst>
+                                    <p:cond delay="0"/>
+                                  </p:stCondLst>
+                                  <p:childTnLst>
+                                    <p:set>
+                                      <p:cBhvr>
+                                        <p:cTn id="6" dur="1" fill="hold">
+                                          <p:stCondLst>
+                                            <p:cond delay="0"/>
+                                          </p:stCondLst>
+                                        </p:cTn>
+                                        <p:tgtEl>
+                                          <p:spTgt spid="17"/>
+                                        </p:tgtEl>
+                                        <p:attrNameLst>
+                                          <p:attrName>style.visibility</p:attrName>
+                                        </p:attrNameLst>
+                                      </p:cBhvr>
+                                      <p:to>
+                                        <p:strVal val="visible"/>
+                                      </p:to>
+                                    </p:set>
+                                    <p:animEffect transition="in" filter="fade">
+                                      <p:cBhvr>
+                                        <p:cTn id="7" dur="600"/>
+                                        <p:tgtEl>
+                                          <p:spTgt spid="17"/>
+                                        </p:tgtEl>
+                                      </p:cBhvr>
+                                    </p:animEffect>
+                                  </p:childTnLst>
+                                </p:cTn>
+                              </p:par>
+                              <p:par>
+                                <p:cTn id="8" presetID="10" presetClass="entr" presetSubtype="0" fill="hold" grpId="0" nodeType="withEffect">
+                                  <p:stCondLst>
+                                    <p:cond delay="0"/>
+                                  </p:stCondLst>
+                                  <p:childTnLst>
+                                    <p:set>
+                                      <p:cBhvr>
+                                        <p:cTn id="9" dur="1" fill="hold">
+                                          <p:stCondLst>
+                                            <p:cond delay="0"/>
+                                          </p:stCondLst>
+                                        </p:cTn>
+                                        <p:tgtEl>
+                                          <p:spTgt spid="18"/>
+                                        </p:tgtEl>
+                                        <p:attrNameLst>
+                                          <p:attrName>style.visibility</p:attrName>
+                                        </p:attrNameLst>
+                                      </p:cBhvr>
+                                      <p:to>
+                                        <p:strVal val="visible"/>
+                                      </p:to>
+                                    </p:set>
+                                    <p:animEffect transition="in" filter="fade">
+                                      <p:cBhvr>
+                                        <p:cTn id="10" dur="600"/>
+                                        <p:tgtEl>
+                                          <p:spTgt spid="18"/>
+                                        </p:tgtEl>
+                                      </p:cBhvr>
+                                    </p:animEffect>
+                                  </p:childTnLst>
+                                </p:cTn>
+                              </p:par>
+                              <p:par>
+                                <p:cTn id="11" presetID="10" presetClass="entr" presetSubtype="0" fill="hold" grpId="0" nodeType="withEffect">
+                                  <p:stCondLst>
+                                    <p:cond delay="0"/>
+                                  </p:stCondLst>
+                                  <p:childTnLst>
+                                    <p:set>
+                                      <p:cBhvr>
+                                        <p:cTn id="12" dur="1" fill="hold">
+                                          <p:stCondLst>
+                                            <p:cond delay="0"/>
+                                          </p:stCondLst>
+                                        </p:cTn>
+                                        <p:tgtEl>
+                                          <p:spTgt spid="19"/>
+                                        </p:tgtEl>
+                                        <p:attrNameLst>
+                                          <p:attrName>style.visibility</p:attrName>
+                                        </p:attrNameLst>
+                                      </p:cBhvr>
+                                      <p:to>
+                                        <p:strVal val="visible"/>
+                                      </p:to>
+                                    </p:set>
+                                    <p:animEffect transition="in" filter="fade">
+                                      <p:cBhvr>
+                                        <p:cTn id="13" dur="600"/>
+                                        <p:tgtEl>
+                                          <p:spTgt spid="19"/>
+                                        </p:tgtEl>
+                                      </p:cBhvr>
+                                    </p:animEffect>
+                                  </p:childTnLst>
+                                </p:cTn>
+                              </p:par>
+                              <p:par>
+                                <p:cTn id="14" presetID="10" presetClass="entr" presetSubtype="0" fill="hold" grpId="0" nodeType="withEffect">
+                                  <p:stCondLst>
+                                    <p:cond delay="0"/>
+                                  </p:stCondLst>
+                                  <p:childTnLst>
+                                    <p:set>
+                                      <p:cBhvr>
+                                        <p:cTn id="15" dur="1" fill="hold">
+                                          <p:stCondLst>
+                                            <p:cond delay="0"/>
+                                          </p:stCondLst>
+                                        </p:cTn>
+                                        <p:tgtEl>
+                                          <p:spTgt spid="20"/>
+                                        </p:tgtEl>
+                                        <p:attrNameLst>
+                                          <p:attrName>style.visibility</p:attrName>
+                                        </p:attrNameLst>
+                                      </p:cBhvr>
+                                      <p:to>
+                                        <p:strVal val="visible"/>
+                                      </p:to>
+                                    </p:set>
+                                    <p:animEffect transition="in" filter="fade">
+                                      <p:cBhvr>
+                                        <p:cTn id="16" dur="600"/>
+                                        <p:tgtEl>
+                                          <p:spTgt spid="20"/>
+                                        </p:tgtEl>
+                                      </p:cBhvr>
+                                    </p:animEffect>
+                                  </p:childTnLst>
+                                </p:cTn>
+                              </p:par>
+                            </p:childTnLst>
+                          </p:cTn>
+                        </p:par>
+                      </p:childTnLst>
+                    </p:cTn>
+                  </p:par>
+                  <p:par>
+                    <p:cTn id="41" fill="hold">
+                      <p:stCondLst>
+                        <p:cond delay="indefinite"/>
+                      </p:stCondLst>
+                      <p:childTnLst>
+                        <p:par>
+                          <p:cTn id="42" fill="hold">
+                            <p:stCondLst>
+                              <p:cond delay="0"/>
+                            </p:stCondLst>
+                            <p:childTnLst>
+                              <p:par>
+                                <p:cTn id="19" presetID="1" presetClass="exit" presetSubtype="0" fill="hold" grpId="1" nodeType="clickEffect">
+                                  <p:stCondLst>
+                                    <p:cond delay="0"/>
+                                  </p:stCondLst>
+                                  <p:childTnLst>
+                                    <p:set>
+                                      <p:cBhvr>
+                                        <p:cTn id="20" dur="1" fill="hold">
+                                          <p:stCondLst>
+                                            <p:cond delay="0"/>
+                                          </p:stCondLst>
+                                        </p:cTn>
+                                        <p:tgtEl>
+                                          <p:spTgt spid="17"/>
+                                        </p:tgtEl>
+                                        <p:attrNameLst>
+                                          <p:attrName>style.visibility</p:attrName>
+                                        </p:attrNameLst>
+                                      </p:cBhvr>
+                                      <p:to>
+                                        <p:strVal val="hidden"/>
+                                      </p:to>
+                                    </p:set>
+                                  </p:childTnLst>
+                                </p:cTn>
+                              </p:par>
+                              <p:par>
+                                <p:cTn id="22" presetID="1" presetClass="exit" presetSubtype="0" fill="hold" grpId="1" nodeType="withEffect">
+                                  <p:stCondLst>
+                                    <p:cond delay="0"/>
+                                  </p:stCondLst>
+                                  <p:childTnLst>
+                                    <p:set>
+                                      <p:cBhvr>
+                                        <p:cTn id="23" dur="1" fill="hold">
+                                          <p:stCondLst>
+                                            <p:cond delay="0"/>
+                                          </p:stCondLst>
+                                        </p:cTn>
+                                        <p:tgtEl>
+                                          <p:spTgt spid="18"/>
+                                        </p:tgtEl>
+                                        <p:attrNameLst>
+                                          <p:attrName>style.visibility</p:attrName>
+                                        </p:attrNameLst>
+                                      </p:cBhvr>
+                                      <p:to>
+                                        <p:strVal val="hidden"/>
+                                      </p:to>
+                                    </p:set>
+                                  </p:childTnLst>
+                                </p:cTn>
+                              </p:par>
+                              <p:par>
+                                <p:cTn id="25" presetID="1" presetClass="exit" presetSubtype="0" fill="hold" grpId="1" nodeType="withEffect">
+                                  <p:stCondLst>
+                                    <p:cond delay="0"/>
+                                  </p:stCondLst>
+                                  <p:childTnLst>
+                                    <p:set>
+                                      <p:cBhvr>
+                                        <p:cTn id="26" dur="1" fill="hold">
+                                          <p:stCondLst>
+                                            <p:cond delay="0"/>
+                                          </p:stCondLst>
+                                        </p:cTn>
+                                        <p:tgtEl>
+                                          <p:spTgt spid="19"/>
+                                        </p:tgtEl>
+                                        <p:attrNameLst>
+                                          <p:attrName>style.visibility</p:attrName>
+                                        </p:attrNameLst>
+                                      </p:cBhvr>
+                                      <p:to>
+                                        <p:strVal val="hidden"/>
+                                      </p:to>
+                                    </p:set>
+                                  </p:childTnLst>
+                                </p:cTn>
+                              </p:par>
+                              <p:par>
+                                <p:cTn id="28" presetID="1" presetClass="exit" presetSubtype="0" fill="hold" grpId="1" nodeType="withEffect">
+                                  <p:stCondLst>
+                                    <p:cond delay="0"/>
+                                  </p:stCondLst>
+                                  <p:childTnLst>
+                                    <p:set>
+                                      <p:cBhvr>
+                                        <p:cTn id="29" dur="1" fill="hold">
+                                          <p:stCondLst>
+                                            <p:cond delay="0"/>
+                                          </p:stCondLst>
+                                        </p:cTn>
+                                        <p:tgtEl>
+                                          <p:spTgt spid="20"/>
+                                        </p:tgtEl>
+                                        <p:attrNameLst>
+                                          <p:attrName>style.visibility</p:attrName>
+                                        </p:attrNameLst>
+                                      </p:cBhvr>
+                                      <p:to>
+                                        <p:strVal val="hidden"/>
+                                      </p:to>
+                                    </p:set>
+                                  </p:childTnLst>
+                                </p:cTn>
+                              </p:par>
+                              <p:par>
+                                <p:cTn id="31" presetID="10" presetClass="entr" presetSubtype="0" fill="hold" grpId="0" nodeType="withEffect">
+                                  <p:stCondLst>
+                                    <p:cond delay="0"/>
+                                  </p:stCondLst>
+                                  <p:childTnLst>
+                                    <p:set>
+                                      <p:cBhvr>
+                                        <p:cTn id="32" dur="1" fill="hold">
+                                          <p:stCondLst>
+                                            <p:cond delay="0"/>
+                                          </p:stCondLst>
+                                        </p:cTn>
+                                        <p:tgtEl>
+                                          <p:spTgt spid="21"/>
+                                        </p:tgtEl>
+                                        <p:attrNameLst>
+                                          <p:attrName>style.visibility</p:attrName>
+                                        </p:attrNameLst>
+                                      </p:cBhvr>
+                                      <p:to>
+                                        <p:strVal val="visible"/>
+                                      </p:to>
+                                    </p:set>
+                                    <p:animEffect transition="in" filter="fade">
+                                      <p:cBhvr>
+                                        <p:cTn id="33" dur="600"/>
+                                        <p:tgtEl>
+                                          <p:spTgt spid="21"/>
+                                        </p:tgtEl>
+                                      </p:cBhvr>
+                                    </p:animEffect>
+                                  </p:childTnLst>
+                                </p:cTn>
+                              </p:par>
+                              <p:par>
+                                <p:cTn id="34" presetID="10" presetClass="entr" presetSubtype="0" fill="hold" grpId="0" nodeType="withEffect">
+                                  <p:stCondLst>
+                                    <p:cond delay="0"/>
+                                  </p:stCondLst>
+                                  <p:childTnLst>
+                                    <p:set>
+                                      <p:cBhvr>
+                                        <p:cTn id="35" dur="1" fill="hold">
+                                          <p:stCondLst>
+                                            <p:cond delay="0"/>
+                                          </p:stCondLst>
+                                        </p:cTn>
+                                        <p:tgtEl>
+                                          <p:spTgt spid="22"/>
+                                        </p:tgtEl>
+                                        <p:attrNameLst>
+                                          <p:attrName>style.visibility</p:attrName>
+                                        </p:attrNameLst>
+                                      </p:cBhvr>
+                                      <p:to>
+                                        <p:strVal val="visible"/>
+                                      </p:to>
+                                    </p:set>
+                                    <p:animEffect transition="in" filter="fade">
+                                      <p:cBhvr>
+                                        <p:cTn id="36" dur="600"/>
+                                        <p:tgtEl>
+                                          <p:spTgt spid="22"/>
+                                        </p:tgtEl>
+                                      </p:cBhvr>
+                                    </p:animEffect>
+                                  </p:childTnLst>
+                                </p:cTn>
+                              </p:par>
+                              <p:par>
+                                <p:cTn id="37" presetID="10" presetClass="entr" presetSubtype="0" fill="hold" grpId="0" nodeType="withEffect">
+                                  <p:stCondLst>
+                                    <p:cond delay="0"/>
+                                  </p:stCondLst>
+                                  <p:childTnLst>
+                                    <p:set>
+                                      <p:cBhvr>
+                                        <p:cTn id="38" dur="1" fill="hold">
+                                          <p:stCondLst>
+                                            <p:cond delay="0"/>
+                                          </p:stCondLst>
+                                        </p:cTn>
+                                        <p:tgtEl>
+                                          <p:spTgt spid="23"/>
+                                        </p:tgtEl>
+                                        <p:attrNameLst>
+                                          <p:attrName>style.visibility</p:attrName>
+                                        </p:attrNameLst>
+                                      </p:cBhvr>
+                                      <p:to>
+                                        <p:strVal val="visible"/>
+                                      </p:to>
+                                    </p:set>
+                                    <p:animEffect transition="in" filter="fade">
+                                      <p:cBhvr>
+                                        <p:cTn id="39" dur="600"/>
+                                        <p:tgtEl>
+                                          <p:spTgt spid="23"/>
+                                        </p:tgtEl>
+                                      </p:cBhvr>
+                                    </p:animEffect>
+                                  </p:childTnLst>
+                                </p:cTn>
+                              </p:par>
+                              <p:par>
+                                <p:cTn id="40" presetID="10" presetClass="entr" presetSubtype="0" fill="hold" grpId="0" nodeType="withEffect">
+                                  <p:stCondLst>
+                                    <p:cond delay="0"/>
+                                  </p:stCondLst>
+                                  <p:childTnLst>
+                                    <p:set>
+                                      <p:cBhvr>
+                                        <p:cTn id="41" dur="1" fill="hold">
+                                          <p:stCondLst>
+                                            <p:cond delay="0"/>
+                                          </p:stCondLst>
+                                        </p:cTn>
+                                        <p:tgtEl>
+                                          <p:spTgt spid="24"/>
+                                        </p:tgtEl>
+                                        <p:attrNameLst>
+                                          <p:attrName>style.visibility</p:attrName>
+                                        </p:attrNameLst>
+                                      </p:cBhvr>
+                                      <p:to>
+                                        <p:strVal val="visible"/>
+                                      </p:to>
+                                    </p:set>
+                                    <p:animEffect transition="in" filter="fade">
+                                      <p:cBhvr>
+                                        <p:cTn id="42" dur="600"/>
+                                        <p:tgtEl>
+                                          <p:spTgt spid="24"/>
+                                        </p:tgtEl>
+                                      </p:cBhvr>
+                                    </p:animEffect>
+                                  </p:childTnLst>
+                                </p:cTn>
+                              </p:par>
+                            </p:childTnLst>
+                          </p:cTn>
+                        </p:par>
+                      </p:childTnLst>
+                    </p:cTn>
+                  </p:par>
+                  <p:par>
+                    <p:cTn id="55" fill="hold">
+                      <p:stCondLst>
+                        <p:cond delay="indefinite"/>
+                      </p:stCondLst>
+                      <p:childTnLst>
+                        <p:par>
+                          <p:cTn id="56" fill="hold">
+                            <p:stCondLst>
+                              <p:cond delay="0"/>
+                            </p:stCondLst>
+                            <p:childTnLst>
+                              <p:par>
+                                <p:cTn id="45" presetID="1" presetClass="exit" presetSubtype="0" fill="hold" grpId="1" nodeType="clickEffect">
+                                  <p:stCondLst>
+                                    <p:cond delay="0"/>
+                                  </p:stCondLst>
+                                  <p:childTnLst>
+                                    <p:set>
+                                      <p:cBhvr>
+                                        <p:cTn id="46" dur="1" fill="hold">
+                                          <p:stCondLst>
+                                            <p:cond delay="0"/>
+                                          </p:stCondLst>
+                                        </p:cTn>
+                                        <p:tgtEl>
+                                          <p:spTgt spid="21"/>
+                                        </p:tgtEl>
+                                        <p:attrNameLst>
+                                          <p:attrName>style.visibility</p:attrName>
+                                        </p:attrNameLst>
+                                      </p:cBhvr>
+                                      <p:to>
+                                        <p:strVal val="hidden"/>
+                                      </p:to>
+                                    </p:set>
+                                  </p:childTnLst>
+                                </p:cTn>
+                              </p:par>
+                              <p:par>
+                                <p:cTn id="48" presetID="1" presetClass="exit" presetSubtype="0" fill="hold" grpId="1" nodeType="withEffect">
+                                  <p:stCondLst>
+                                    <p:cond delay="0"/>
+                                  </p:stCondLst>
+                                  <p:childTnLst>
+                                    <p:set>
+                                      <p:cBhvr>
+                                        <p:cTn id="49" dur="1" fill="hold">
+                                          <p:stCondLst>
+                                            <p:cond delay="0"/>
+                                          </p:stCondLst>
+                                        </p:cTn>
+                                        <p:tgtEl>
+                                          <p:spTgt spid="22"/>
+                                        </p:tgtEl>
+                                        <p:attrNameLst>
+                                          <p:attrName>style.visibility</p:attrName>
+                                        </p:attrNameLst>
+                                      </p:cBhvr>
+                                      <p:to>
+                                        <p:strVal val="hidden"/>
+                                      </p:to>
+                                    </p:set>
+                                  </p:childTnLst>
+                                </p:cTn>
+                              </p:par>
+                              <p:par>
+                                <p:cTn id="51" presetID="1" presetClass="exit" presetSubtype="0" fill="hold" grpId="1" nodeType="withEffect">
+                                  <p:stCondLst>
+                                    <p:cond delay="0"/>
+                                  </p:stCondLst>
+                                  <p:childTnLst>
+                                    <p:set>
+                                      <p:cBhvr>
+                                        <p:cTn id="52" dur="1" fill="hold">
+                                          <p:stCondLst>
+                                            <p:cond delay="0"/>
+                                          </p:stCondLst>
+                                        </p:cTn>
+                                        <p:tgtEl>
+                                          <p:spTgt spid="23"/>
+                                        </p:tgtEl>
+                                        <p:attrNameLst>
+                                          <p:attrName>style.visibility</p:attrName>
+                                        </p:attrNameLst>
+                                      </p:cBhvr>
+                                      <p:to>
+                                        <p:strVal val="hidden"/>
+                                      </p:to>
+                                    </p:set>
+                                  </p:childTnLst>
+                                </p:cTn>
+                              </p:par>
+                              <p:par>
+                                <p:cTn id="54" presetID="1" presetClass="exit" presetSubtype="0" fill="hold" grpId="1" nodeType="withEffect">
+                                  <p:stCondLst>
+                                    <p:cond delay="0"/>
+                                  </p:stCondLst>
+                                  <p:childTnLst>
+                                    <p:set>
+                                      <p:cBhvr>
+                                        <p:cTn id="55" dur="1" fill="hold">
+                                          <p:stCondLst>
+                                            <p:cond delay="0"/>
+                                          </p:stCondLst>
+                                        </p:cTn>
+                                        <p:tgtEl>
+                                          <p:spTgt spid="24"/>
+                                        </p:tgtEl>
+                                        <p:attrNameLst>
+                                          <p:attrName>style.visibility</p:attrName>
+                                        </p:attrNameLst>
+                                      </p:cBhvr>
+                                      <p:to>
+                                        <p:strVal val="hidden"/>
+                                      </p:to>
+                                    </p:set>
+                                  </p:childTnLst>
+                                </p:cTn>
+                              </p:par>
+                            </p:childTnLst>
+                          </p:cTn>
+                        </p:par>
+                      </p:childTnLst>
+                    </p:cTn>
+                  </p:par>
+                </p:childTnLst>
+              </p:cTn>
+              <p:prevCondLst>
+                <p:cond evt="onPrev" delay="0">
+                  <p:tgtEl>
+                    <p:sldTgt/>
+                  </p:tgtEl>
+                </p:cond>
+              </p:prevCondLst>
+              <p:nextCondLst>
+                <p:cond evt="onNext" delay="0">
+                  <p:tgtEl>
+                    <p:sldTgt/>
+                  </p:tgtEl>
+                </p:cond>
+              </p:nextCondLst>
+            </p:seq>
+          </p:childTnLst>
+        </p:cTn>
+      </p:par>
+    </p:tnLst>
+    <p:bldLst>
+      <p:bldP spid="17" grpId="0" animBg="1"/>
+      <p:bldP spid="18" grpId="0" animBg="1"/>
+      <p:bldP spid="20" grpId="0" animBg="1"/>
+      <p:bldP spid="17" grpId="1" animBg="1"/>
+      <p:bldP spid="18" grpId="1" animBg="1"/>
+      <p:bldP spid="20" grpId="1" animBg="1"/>
+      <p:bldP spid="21" grpId="0" animBg="1"/>
+      <p:bldP spid="22" grpId="0" animBg="1"/>
+      <p:bldP spid="24" grpId="0" animBg="1"/>
+      <p:bldP spid="21" grpId="1" animBg="1"/>
+      <p:bldP spid="22" grpId="1" animBg="1"/>
+      <p:bldP spid="24" grpId="1" animBg="1"/>
+    </p:bldLst>
+  </p:timing>
 </p:sld>
 </file>
 

</xml_diff>

<commit_message>
Priority Fee decision flow: C-fault wording and escalation note
Co-Authored-By: Claude Opus 5.5 <noreply@anthropic.com>
Claude-Session: https://claude.ai/code/session_01FEzv8wwqWDgTsXP8Yz6XYn
</commit_message>
<xml_diff>
--- a/incorrect-info-lmc-lockout/incorrect-info-lmc-lockout.pptx
+++ b/incorrect-info-lmc-lockout/incorrect-info-lmc-lockout.pptx
@@ -2394,7 +2394,7 @@
           <a:p>
             <a:r>
               <a:rPr lang="en-US" dirty="0"/>
-              <a:t>Pull up the account history first. Before saying anything to the customer about a resolution, ask one question: why did the customer end up in the priority window? Their own scheduling choice, or because Homeaglow or the CP forced them into it? C-fault (the customer chose the window: booked or rescheduled within 48 hours on their own, or picked a high-demand date, and nothing on our side drove it): the fee stands. Explain the policy plainly and show them the Priority Fee notice they saw at booking. You can soften it with up to 100% of the Priority Fee in account credits as a courtesy; treat 100% as a ceiling, not a starting point, and frame it as goodwill, not "we got this wrong". Macro: Priority Fee: Issue Credits up to 100% of the Priority Fee. CP/Platform fault (Homeaglow or the CP caused the priority window): refund the full Priority Fee and the associated 15% processing fee to the original payment method, and acknowledge specifically what happened (e.g. "your last cleaner cancelled on short notice"). Macro: Priority Fee Refunded. The two paths are mutually exclusive: never refund and credit the same fee unless a supervisor approves. Not sure which? Escalate. Only take the refund path if you can point to one of these known scenarios (not exhaustive): 1) the customer's previous CP was a no-show or cancelled at the last minute; 2) the customer's previous CP requested to reschedule; 3) the customer was affected by a system bug; 4) the customer immediately booked another cleaning after reporting their previous CP for Poor Cleaning Quality (PCQ). If a case doesn't match exactly but is genuinely comparable (something on Homeaglow's or the CP's end forced the customer into the window, not their own scheduling choice), treat it the same way. If you're not sure whether it's truly comparable or the customer's own choice dressed up differently, escalate. Worked example: "I was charged a $15/hr priority fee for my cleaning yesterday. I didn't do anything different from usual." The account history shows their scheduled CP cancelled the day before, so they had to rebook on short notice. That's scenario 1: skip the credit macro, send Priority Fee Refunded, refund the $15/hr fee and its 15% processing fee to the original payment method, and acknowledge that the previous CP's cancellation caused it. Check for repeat Priority Fee disputes on the same account before offering courtesy credits again. TRAINER: the scenarios are hidden when the slide opens. Click once (Scenarios) to open the box with scenario 1, then click to add scenarios 2, 3 and 4 one at a time; the fifth click closes the box.</a:t>
+              <a:t>Pull up the account history first. Before saying anything to the customer about a resolution, ask one question: why did the customer end up in the priority window? Their own scheduling choice, or because Homeaglow or the CP forced them into it? C-fault (the customer chose the window: booked or rescheduled within 48 hours on their own, or picked a high-demand date, and nothing on our side drove it): the fee stands. Explain the policy plainly and offer up to 100% of the Priority Fee in account credits as a courtesy. Treat 100% as a ceiling, not your starting point: base the amount on the customer's history and how the conversation is going, and position it as a goodwill gesture, not "we got this wrong". Macro: Priority Fee: Issue Credits up to 100% of the Priority Fee. CP/Platform fault (Homeaglow or the CP caused the priority window): refund the full Priority Fee and the associated 15% processing fee to the original payment method, and acknowledge specifically what happened (e.g. "your last cleaner cancelled on short notice"). Macro: Priority Fee Refunded. The two paths are mutually exclusive: never refund and credit the same fee unless a supervisor approves. Not sure which? Escalate. Only take the refund path if you can point to one of these known scenarios (not exhaustive): 1) the customer's previous CP was a no-show or cancelled at the last minute; 2) the customer's previous CP requested to reschedule; 3) the customer was affected by a system bug; 4) the customer immediately booked another cleaning after reporting their previous CP for Poor Cleaning Quality (PCQ). If a case doesn't match exactly but is genuinely comparable (something on Homeaglow's or the CP's end forced the customer into the window, not their own scheduling choice), treat it the same way. If you're not sure whether it's truly comparable or the customer's own choice dressed up differently, escalate. Worked example: "I was charged a $15/hr priority fee for my cleaning yesterday. I didn't do anything different from usual." The account history shows their scheduled CP cancelled the day before, so they had to rebook on short notice. That's scenario 1: skip the credit macro, send Priority Fee Refunded, refund the $15/hr fee and its 15% processing fee to the original payment method, and acknowledge that the previous CP's cancellation caused it. Check for repeat Priority Fee disputes on the same account before offering courtesy credits again. TRAINER: the scenarios are hidden when the slide opens. Click once (Scenarios) to open the box with scenario 1, then click to add scenarios 2, 3 and 4 one at a time; the fifth click closes the box.</a:t>
             </a:r>
             <a:endParaRPr lang="en-US" dirty="0"/>
           </a:p>
@@ -28596,7 +28596,7 @@
                 <a:ea typeface="SF Pro Text" pitchFamily="34" charset="-122"/>
                 <a:cs typeface="SF Pro Text" pitchFamily="34" charset="-120"/>
               </a:rPr>
-              <a:t>Show them the Priority Fee notice they saw at booking.</a:t>
+              <a:t>Treat 100% as a ceiling, not your starting point, and position it as a goodwill gesture.</a:t>
             </a:r>
             <a:endParaRPr lang="en-US" sz="1000" dirty="0"/>
           </a:p>
@@ -28948,14 +28948,65 @@
       </p:sp>
       <p:sp>
         <p:nvSpPr>
-          <p:cNvPr id="29" name="Text 24"/>
+          <p:cNvPr id="29" name="Shape 24"/>
+          <p:cNvSpPr/>
+          <p:nvPr/>
+        </p:nvSpPr>
+        <p:spPr>
+          <a:xfrm>
+            <a:off x="411480" y="4389120"/>
+            <a:ext cx="8321040" cy="384048"/>
+          </a:xfrm>
+          <a:prstGeom prst="roundRect">
+            <a:avLst>
+              <a:gd name="adj" fmla="val 19048"/>
+            </a:avLst>
+          </a:prstGeom>
+          <a:solidFill>
+            <a:srgbClr val="FFF3D6"/>
+          </a:solidFill>
+          <a:ln w="9525">
+            <a:solidFill>
+              <a:srgbClr val="FFF3D6"/>
+            </a:solidFill>
+            <a:prstDash val="solid"/>
+          </a:ln>
+        </p:spPr>
+      </p:sp>
+      <p:pic>
+        <p:nvPicPr>
+          <p:cNvPr id="30" name="Image 2" descr="preencoded.png">    </p:cNvPr>
+          <p:cNvPicPr>
+            <a:picLocks noChangeAspect="1"/>
+          </p:cNvPicPr>
+          <p:nvPr/>
+        </p:nvPicPr>
+        <p:blipFill>
+          <a:blip r:embed="rId3"/>
+          <a:stretch>
+            <a:fillRect/>
+          </a:stretch>
+        </p:blipFill>
+        <p:spPr>
+          <a:xfrm>
+            <a:off x="566928" y="4498848"/>
+            <a:ext cx="164592" cy="164592"/>
+          </a:xfrm>
+          <a:prstGeom prst="rect">
+            <a:avLst/>
+          </a:prstGeom>
+        </p:spPr>
+      </p:pic>
+      <p:sp>
+        <p:nvSpPr>
+          <p:cNvPr id="31" name="Text 25"/>
           <p:cNvSpPr txBox="1"/>
           <p:nvPr/>
         </p:nvSpPr>
         <p:spPr>
           <a:xfrm>
-            <a:off x="411480" y="3950208"/>
-            <a:ext cx="3840480" cy="329184"/>
+            <a:off x="822960" y="4489704"/>
+            <a:ext cx="7772400" cy="201168"/>
           </a:xfrm>
           <a:prstGeom prst="rect">
             <a:avLst/>
@@ -28964,30 +29015,44 @@
           <a:ln/>
         </p:spPr>
         <p:txBody>
-          <a:bodyPr wrap="square" lIns="0" tIns="0" rIns="0" bIns="0" rtlCol="0" anchor="ctr"/>
-          <a:lstStyle/>
-          <a:p>
-            <a:pPr algn="ctr" indent="0" marL="0">
-              <a:buNone/>
-            </a:pPr>
-            <a:r>
-              <a:rPr lang="en-US" sz="900" b="1" dirty="0">
-                <a:solidFill>
-                  <a:srgbClr val="6E6E73"/>
+          <a:bodyPr wrap="square" lIns="0" tIns="0" rIns="0" bIns="0" rtlCol="0" anchor="t"/>
+          <a:lstStyle/>
+          <a:p>
+            <a:pPr indent="0" marL="0">
+              <a:buNone/>
+            </a:pPr>
+            <a:r>
+              <a:rPr lang="en-US" sz="1000" b="1" dirty="0">
+                <a:solidFill>
+                  <a:srgbClr val="9A6410"/>
                 </a:solidFill>
                 <a:latin typeface="SF Pro Text" pitchFamily="34" charset="0"/>
                 <a:ea typeface="SF Pro Text" pitchFamily="34" charset="-122"/>
                 <a:cs typeface="SF Pro Text" pitchFamily="34" charset="-120"/>
               </a:rPr>
-              <a:t>Not sure which? Escalate. Never refund and credit the same fee.</a:t>
-            </a:r>
-            <a:endParaRPr lang="en-US" sz="900" dirty="0"/>
-          </a:p>
-        </p:txBody>
-      </p:sp>
-      <p:sp>
-        <p:nvSpPr>
-          <p:cNvPr id="30" name="pop1_5Panel"/>
+              <a:t>Note:  </a:t>
+            </a:r>
+            <a:pPr indent="0" marL="0">
+              <a:buNone/>
+            </a:pPr>
+            <a:r>
+              <a:rPr lang="en-US" sz="1000" dirty="0">
+                <a:solidFill>
+                  <a:srgbClr val="1D1D1F"/>
+                </a:solidFill>
+                <a:latin typeface="SF Pro Text" pitchFamily="34" charset="0"/>
+                <a:ea typeface="SF Pro Text" pitchFamily="34" charset="-122"/>
+                <a:cs typeface="SF Pro Text" pitchFamily="34" charset="-120"/>
+              </a:rPr>
+              <a:t>if unsure whether the case is comparable or customer-driven, escalate rather than deciding solo.</a:t>
+            </a:r>
+            <a:endParaRPr lang="en-US" sz="1000" dirty="0"/>
+          </a:p>
+        </p:txBody>
+      </p:sp>
+      <p:sp>
+        <p:nvSpPr>
+          <p:cNvPr id="32" name="pop1_5Panel"/>
           <p:cNvSpPr/>
           <p:nvPr/>
         </p:nvSpPr>
@@ -29021,7 +29086,7 @@
       </p:sp>
       <p:sp>
         <p:nvSpPr>
-          <p:cNvPr id="31" name="pop1_5Title"/>
+          <p:cNvPr id="33" name="pop1_5Title"/>
           <p:cNvSpPr txBox="1"/>
           <p:nvPr/>
         </p:nvSpPr>
@@ -29060,7 +29125,7 @@
       </p:sp>
       <p:sp>
         <p:nvSpPr>
-          <p:cNvPr id="32" name="pop1_5Row"/>
+          <p:cNvPr id="34" name="pop1_5Row"/>
           <p:cNvSpPr/>
           <p:nvPr/>
         </p:nvSpPr>
@@ -29087,14 +29152,14 @@
       </p:sp>
       <p:pic>
         <p:nvPicPr>
-          <p:cNvPr id="33" name="pop1_5Icon" descr="preencoded.png">    </p:cNvPr>
+          <p:cNvPr id="35" name="pop1_5Icon" descr="preencoded.png">    </p:cNvPr>
           <p:cNvPicPr>
             <a:picLocks noChangeAspect="1"/>
           </p:cNvPicPr>
           <p:nvPr/>
         </p:nvPicPr>
         <p:blipFill>
-          <a:blip r:embed="rId3"/>
+          <a:blip r:embed="rId4"/>
           <a:stretch>
             <a:fillRect/>
           </a:stretch>
@@ -29111,7 +29176,7 @@
       </p:pic>
       <p:sp>
         <p:nvSpPr>
-          <p:cNvPr id="34" name="pop1_5Text"/>
+          <p:cNvPr id="36" name="pop1_5Text"/>
           <p:cNvSpPr txBox="1"/>
           <p:nvPr/>
         </p:nvSpPr>
@@ -29164,7 +29229,7 @@
       </p:sp>
       <p:sp>
         <p:nvSpPr>
-          <p:cNvPr id="35" name="pop2_5Row"/>
+          <p:cNvPr id="37" name="pop2_5Row"/>
           <p:cNvSpPr/>
           <p:nvPr/>
         </p:nvSpPr>
@@ -29191,14 +29256,14 @@
       </p:sp>
       <p:pic>
         <p:nvPicPr>
-          <p:cNvPr id="36" name="pop2_5Icon" descr="preencoded.png">    </p:cNvPr>
+          <p:cNvPr id="38" name="pop2_5Icon" descr="preencoded.png">    </p:cNvPr>
           <p:cNvPicPr>
             <a:picLocks noChangeAspect="1"/>
           </p:cNvPicPr>
           <p:nvPr/>
         </p:nvPicPr>
         <p:blipFill>
-          <a:blip r:embed="rId4"/>
+          <a:blip r:embed="rId5"/>
           <a:stretch>
             <a:fillRect/>
           </a:stretch>
@@ -29215,7 +29280,7 @@
       </p:pic>
       <p:sp>
         <p:nvSpPr>
-          <p:cNvPr id="37" name="pop2_5Text"/>
+          <p:cNvPr id="39" name="pop2_5Text"/>
           <p:cNvSpPr txBox="1"/>
           <p:nvPr/>
         </p:nvSpPr>
@@ -29268,7 +29333,7 @@
       </p:sp>
       <p:sp>
         <p:nvSpPr>
-          <p:cNvPr id="38" name="pop3_5Row"/>
+          <p:cNvPr id="40" name="pop3_5Row"/>
           <p:cNvSpPr/>
           <p:nvPr/>
         </p:nvSpPr>
@@ -29295,14 +29360,14 @@
       </p:sp>
       <p:pic>
         <p:nvPicPr>
-          <p:cNvPr id="39" name="pop3_5Icon" descr="preencoded.png">    </p:cNvPr>
+          <p:cNvPr id="41" name="pop3_5Icon" descr="preencoded.png">    </p:cNvPr>
           <p:cNvPicPr>
             <a:picLocks noChangeAspect="1"/>
           </p:cNvPicPr>
           <p:nvPr/>
         </p:nvPicPr>
         <p:blipFill>
-          <a:blip r:embed="rId5"/>
+          <a:blip r:embed="rId6"/>
           <a:stretch>
             <a:fillRect/>
           </a:stretch>
@@ -29319,7 +29384,7 @@
       </p:pic>
       <p:sp>
         <p:nvSpPr>
-          <p:cNvPr id="40" name="pop3_5Text"/>
+          <p:cNvPr id="42" name="pop3_5Text"/>
           <p:cNvSpPr txBox="1"/>
           <p:nvPr/>
         </p:nvSpPr>
@@ -29372,7 +29437,7 @@
       </p:sp>
       <p:sp>
         <p:nvSpPr>
-          <p:cNvPr id="41" name="pop4_5Row"/>
+          <p:cNvPr id="43" name="pop4_5Row"/>
           <p:cNvSpPr/>
           <p:nvPr/>
         </p:nvSpPr>
@@ -29399,14 +29464,14 @@
       </p:sp>
       <p:pic>
         <p:nvPicPr>
-          <p:cNvPr id="42" name="pop4_5Icon" descr="preencoded.png">    </p:cNvPr>
+          <p:cNvPr id="44" name="pop4_5Icon" descr="preencoded.png">    </p:cNvPr>
           <p:cNvPicPr>
             <a:picLocks noChangeAspect="1"/>
           </p:cNvPicPr>
           <p:nvPr/>
         </p:nvPicPr>
         <p:blipFill>
-          <a:blip r:embed="rId6"/>
+          <a:blip r:embed="rId7"/>
           <a:stretch>
             <a:fillRect/>
           </a:stretch>
@@ -29423,7 +29488,7 @@
       </p:pic>
       <p:sp>
         <p:nvSpPr>
-          <p:cNvPr id="43" name="pop4_5Text"/>
+          <p:cNvPr id="45" name="pop4_5Text"/>
           <p:cNvSpPr txBox="1"/>
           <p:nvPr/>
         </p:nvSpPr>
@@ -29561,7 +29626,7 @@
                                           </p:stCondLst>
                                         </p:cTn>
                                         <p:tgtEl>
-                                          <p:spTgt spid="30"/>
+                                          <p:spTgt spid="32"/>
                                         </p:tgtEl>
                                         <p:attrNameLst>
                                           <p:attrName>style.visibility</p:attrName>
@@ -29575,7 +29640,7 @@
                                       <p:cBhvr>
                                         <p:cTn id="7" dur="600"/>
                                         <p:tgtEl>
-                                          <p:spTgt spid="30"/>
+                                          <p:spTgt spid="32"/>
                                         </p:tgtEl>
                                       </p:cBhvr>
                                     </p:animEffect>
@@ -29596,7 +29661,7 @@
                                           </p:stCondLst>
                                         </p:cTn>
                                         <p:tgtEl>
-                                          <p:spTgt spid="31"/>
+                                          <p:spTgt spid="33"/>
                                         </p:tgtEl>
                                         <p:attrNameLst>
                                           <p:attrName>style.visibility</p:attrName>
@@ -29610,7 +29675,7 @@
                                       <p:cBhvr>
                                         <p:cTn id="10" dur="600"/>
                                         <p:tgtEl>
-                                          <p:spTgt spid="31"/>
+                                          <p:spTgt spid="33"/>
                                         </p:tgtEl>
                                       </p:cBhvr>
                                     </p:animEffect>
@@ -29631,7 +29696,7 @@
                                           </p:stCondLst>
                                         </p:cTn>
                                         <p:tgtEl>
-                                          <p:spTgt spid="32"/>
+                                          <p:spTgt spid="34"/>
                                         </p:tgtEl>
                                         <p:attrNameLst>
                                           <p:attrName>style.visibility</p:attrName>
@@ -29645,7 +29710,7 @@
                                       <p:cBhvr>
                                         <p:cTn id="13" dur="600"/>
                                         <p:tgtEl>
-                                          <p:spTgt spid="32"/>
+                                          <p:spTgt spid="34"/>
                                         </p:tgtEl>
                                       </p:cBhvr>
                                     </p:animEffect>
@@ -29666,7 +29731,7 @@
                                           </p:stCondLst>
                                         </p:cTn>
                                         <p:tgtEl>
-                                          <p:spTgt spid="33"/>
+                                          <p:spTgt spid="35"/>
                                         </p:tgtEl>
                                         <p:attrNameLst>
                                           <p:attrName>style.visibility</p:attrName>
@@ -29680,7 +29745,7 @@
                                       <p:cBhvr>
                                         <p:cTn id="16" dur="600"/>
                                         <p:tgtEl>
-                                          <p:spTgt spid="33"/>
+                                          <p:spTgt spid="35"/>
                                         </p:tgtEl>
                                       </p:cBhvr>
                                     </p:animEffect>
@@ -29701,7 +29766,7 @@
                                           </p:stCondLst>
                                         </p:cTn>
                                         <p:tgtEl>
-                                          <p:spTgt spid="34"/>
+                                          <p:spTgt spid="36"/>
                                         </p:tgtEl>
                                         <p:attrNameLst>
                                           <p:attrName>style.visibility</p:attrName>
@@ -29715,7 +29780,7 @@
                                       <p:cBhvr>
                                         <p:cTn id="19" dur="600"/>
                                         <p:tgtEl>
-                                          <p:spTgt spid="34"/>
+                                          <p:spTgt spid="36"/>
                                         </p:tgtEl>
                                       </p:cBhvr>
                                     </p:animEffect>
@@ -29754,7 +29819,7 @@
                                           </p:stCondLst>
                                         </p:cTn>
                                         <p:tgtEl>
-                                          <p:spTgt spid="35"/>
+                                          <p:spTgt spid="37"/>
                                         </p:tgtEl>
                                         <p:attrNameLst>
                                           <p:attrName>style.visibility</p:attrName>
@@ -29768,7 +29833,7 @@
                                       <p:cBhvr>
                                         <p:cTn id="24" dur="600"/>
                                         <p:tgtEl>
-                                          <p:spTgt spid="35"/>
+                                          <p:spTgt spid="37"/>
                                         </p:tgtEl>
                                       </p:cBhvr>
                                     </p:animEffect>
@@ -29789,7 +29854,7 @@
                                           </p:stCondLst>
                                         </p:cTn>
                                         <p:tgtEl>
-                                          <p:spTgt spid="36"/>
+                                          <p:spTgt spid="38"/>
                                         </p:tgtEl>
                                         <p:attrNameLst>
                                           <p:attrName>style.visibility</p:attrName>
@@ -29803,7 +29868,7 @@
                                       <p:cBhvr>
                                         <p:cTn id="27" dur="600"/>
                                         <p:tgtEl>
-                                          <p:spTgt spid="36"/>
+                                          <p:spTgt spid="38"/>
                                         </p:tgtEl>
                                       </p:cBhvr>
                                     </p:animEffect>
@@ -29824,7 +29889,7 @@
                                           </p:stCondLst>
                                         </p:cTn>
                                         <p:tgtEl>
-                                          <p:spTgt spid="37"/>
+                                          <p:spTgt spid="39"/>
                                         </p:tgtEl>
                                         <p:attrNameLst>
                                           <p:attrName>style.visibility</p:attrName>
@@ -29838,7 +29903,7 @@
                                       <p:cBhvr>
                                         <p:cTn id="30" dur="600"/>
                                         <p:tgtEl>
-                                          <p:spTgt spid="37"/>
+                                          <p:spTgt spid="39"/>
                                         </p:tgtEl>
                                       </p:cBhvr>
                                     </p:animEffect>
@@ -29877,7 +29942,7 @@
                                           </p:stCondLst>
                                         </p:cTn>
                                         <p:tgtEl>
-                                          <p:spTgt spid="38"/>
+                                          <p:spTgt spid="40"/>
                                         </p:tgtEl>
                                         <p:attrNameLst>
                                           <p:attrName>style.visibility</p:attrName>
@@ -29891,7 +29956,7 @@
                                       <p:cBhvr>
                                         <p:cTn id="35" dur="600"/>
                                         <p:tgtEl>
-                                          <p:spTgt spid="38"/>
+                                          <p:spTgt spid="40"/>
                                         </p:tgtEl>
                                       </p:cBhvr>
                                     </p:animEffect>
@@ -29912,7 +29977,7 @@
                                           </p:stCondLst>
                                         </p:cTn>
                                         <p:tgtEl>
-                                          <p:spTgt spid="39"/>
+                                          <p:spTgt spid="41"/>
                                         </p:tgtEl>
                                         <p:attrNameLst>
                                           <p:attrName>style.visibility</p:attrName>
@@ -29926,7 +29991,7 @@
                                       <p:cBhvr>
                                         <p:cTn id="38" dur="600"/>
                                         <p:tgtEl>
-                                          <p:spTgt spid="39"/>
+                                          <p:spTgt spid="41"/>
                                         </p:tgtEl>
                                       </p:cBhvr>
                                     </p:animEffect>
@@ -29947,7 +30012,7 @@
                                           </p:stCondLst>
                                         </p:cTn>
                                         <p:tgtEl>
-                                          <p:spTgt spid="40"/>
+                                          <p:spTgt spid="42"/>
                                         </p:tgtEl>
                                         <p:attrNameLst>
                                           <p:attrName>style.visibility</p:attrName>
@@ -29961,7 +30026,7 @@
                                       <p:cBhvr>
                                         <p:cTn id="41" dur="600"/>
                                         <p:tgtEl>
-                                          <p:spTgt spid="40"/>
+                                          <p:spTgt spid="42"/>
                                         </p:tgtEl>
                                       </p:cBhvr>
                                     </p:animEffect>
@@ -30000,7 +30065,7 @@
                                           </p:stCondLst>
                                         </p:cTn>
                                         <p:tgtEl>
-                                          <p:spTgt spid="41"/>
+                                          <p:spTgt spid="43"/>
                                         </p:tgtEl>
                                         <p:attrNameLst>
                                           <p:attrName>style.visibility</p:attrName>
@@ -30014,7 +30079,7 @@
                                       <p:cBhvr>
                                         <p:cTn id="46" dur="600"/>
                                         <p:tgtEl>
-                                          <p:spTgt spid="41"/>
+                                          <p:spTgt spid="43"/>
                                         </p:tgtEl>
                                       </p:cBhvr>
                                     </p:animEffect>
@@ -30035,7 +30100,7 @@
                                           </p:stCondLst>
                                         </p:cTn>
                                         <p:tgtEl>
-                                          <p:spTgt spid="42"/>
+                                          <p:spTgt spid="44"/>
                                         </p:tgtEl>
                                         <p:attrNameLst>
                                           <p:attrName>style.visibility</p:attrName>
@@ -30049,7 +30114,7 @@
                                       <p:cBhvr>
                                         <p:cTn id="49" dur="600"/>
                                         <p:tgtEl>
-                                          <p:spTgt spid="42"/>
+                                          <p:spTgt spid="44"/>
                                         </p:tgtEl>
                                       </p:cBhvr>
                                     </p:animEffect>
@@ -30070,7 +30135,7 @@
                                           </p:stCondLst>
                                         </p:cTn>
                                         <p:tgtEl>
-                                          <p:spTgt spid="43"/>
+                                          <p:spTgt spid="45"/>
                                         </p:tgtEl>
                                         <p:attrNameLst>
                                           <p:attrName>style.visibility</p:attrName>
@@ -30084,7 +30149,7 @@
                                       <p:cBhvr>
                                         <p:cTn id="52" dur="600"/>
                                         <p:tgtEl>
-                                          <p:spTgt spid="43"/>
+                                          <p:spTgt spid="45"/>
                                         </p:tgtEl>
                                       </p:cBhvr>
                                     </p:animEffect>
@@ -30123,7 +30188,7 @@
                                           </p:stCondLst>
                                         </p:cTn>
                                         <p:tgtEl>
-                                          <p:spTgt spid="30"/>
+                                          <p:spTgt spid="32"/>
                                         </p:tgtEl>
                                         <p:attrNameLst>
                                           <p:attrName>style.visibility</p:attrName>
@@ -30150,7 +30215,7 @@
                                           </p:stCondLst>
                                         </p:cTn>
                                         <p:tgtEl>
-                                          <p:spTgt spid="31"/>
+                                          <p:spTgt spid="33"/>
                                         </p:tgtEl>
                                         <p:attrNameLst>
                                           <p:attrName>style.visibility</p:attrName>
@@ -30177,7 +30242,7 @@
                                           </p:stCondLst>
                                         </p:cTn>
                                         <p:tgtEl>
-                                          <p:spTgt spid="32"/>
+                                          <p:spTgt spid="34"/>
                                         </p:tgtEl>
                                         <p:attrNameLst>
                                           <p:attrName>style.visibility</p:attrName>
@@ -30204,7 +30269,7 @@
                                           </p:stCondLst>
                                         </p:cTn>
                                         <p:tgtEl>
-                                          <p:spTgt spid="33"/>
+                                          <p:spTgt spid="35"/>
                                         </p:tgtEl>
                                         <p:attrNameLst>
                                           <p:attrName>style.visibility</p:attrName>
@@ -30231,7 +30296,7 @@
                                           </p:stCondLst>
                                         </p:cTn>
                                         <p:tgtEl>
-                                          <p:spTgt spid="34"/>
+                                          <p:spTgt spid="36"/>
                                         </p:tgtEl>
                                         <p:attrNameLst>
                                           <p:attrName>style.visibility</p:attrName>
@@ -30258,7 +30323,7 @@
                                           </p:stCondLst>
                                         </p:cTn>
                                         <p:tgtEl>
-                                          <p:spTgt spid="35"/>
+                                          <p:spTgt spid="37"/>
                                         </p:tgtEl>
                                         <p:attrNameLst>
                                           <p:attrName>style.visibility</p:attrName>
@@ -30285,7 +30350,7 @@
                                           </p:stCondLst>
                                         </p:cTn>
                                         <p:tgtEl>
-                                          <p:spTgt spid="36"/>
+                                          <p:spTgt spid="38"/>
                                         </p:tgtEl>
                                         <p:attrNameLst>
                                           <p:attrName>style.visibility</p:attrName>
@@ -30312,7 +30377,7 @@
                                           </p:stCondLst>
                                         </p:cTn>
                                         <p:tgtEl>
-                                          <p:spTgt spid="37"/>
+                                          <p:spTgt spid="39"/>
                                         </p:tgtEl>
                                         <p:attrNameLst>
                                           <p:attrName>style.visibility</p:attrName>
@@ -30339,7 +30404,7 @@
                                           </p:stCondLst>
                                         </p:cTn>
                                         <p:tgtEl>
-                                          <p:spTgt spid="38"/>
+                                          <p:spTgt spid="40"/>
                                         </p:tgtEl>
                                         <p:attrNameLst>
                                           <p:attrName>style.visibility</p:attrName>
@@ -30366,7 +30431,7 @@
                                           </p:stCondLst>
                                         </p:cTn>
                                         <p:tgtEl>
-                                          <p:spTgt spid="39"/>
+                                          <p:spTgt spid="41"/>
                                         </p:tgtEl>
                                         <p:attrNameLst>
                                           <p:attrName>style.visibility</p:attrName>
@@ -30393,7 +30458,7 @@
                                           </p:stCondLst>
                                         </p:cTn>
                                         <p:tgtEl>
-                                          <p:spTgt spid="40"/>
+                                          <p:spTgt spid="42"/>
                                         </p:tgtEl>
                                         <p:attrNameLst>
                                           <p:attrName>style.visibility</p:attrName>
@@ -30420,7 +30485,7 @@
                                           </p:stCondLst>
                                         </p:cTn>
                                         <p:tgtEl>
-                                          <p:spTgt spid="41"/>
+                                          <p:spTgt spid="43"/>
                                         </p:tgtEl>
                                         <p:attrNameLst>
                                           <p:attrName>style.visibility</p:attrName>
@@ -30447,7 +30512,7 @@
                                           </p:stCondLst>
                                         </p:cTn>
                                         <p:tgtEl>
-                                          <p:spTgt spid="42"/>
+                                          <p:spTgt spid="44"/>
                                         </p:tgtEl>
                                         <p:attrNameLst>
                                           <p:attrName>style.visibility</p:attrName>
@@ -30474,7 +30539,7 @@
                                           </p:stCondLst>
                                         </p:cTn>
                                         <p:tgtEl>
-                                          <p:spTgt spid="43"/>
+                                          <p:spTgt spid="45"/>
                                         </p:tgtEl>
                                         <p:attrNameLst>
                                           <p:attrName>style.visibility</p:attrName>
@@ -30515,26 +30580,26 @@
       </p:par>
     </p:tnLst>
     <p:bldLst>
-      <p:bldP spid="30" grpId="0" animBg="1"/>
-      <p:bldP spid="31" grpId="0" animBg="1"/>
       <p:bldP spid="32" grpId="0" animBg="1"/>
+      <p:bldP spid="33" grpId="0" animBg="1"/>
       <p:bldP spid="34" grpId="0" animBg="1"/>
-      <p:bldP spid="35" grpId="0" animBg="1"/>
+      <p:bldP spid="36" grpId="0" animBg="1"/>
       <p:bldP spid="37" grpId="0" animBg="1"/>
-      <p:bldP spid="38" grpId="0" animBg="1"/>
+      <p:bldP spid="39" grpId="0" animBg="1"/>
       <p:bldP spid="40" grpId="0" animBg="1"/>
-      <p:bldP spid="41" grpId="0" animBg="1"/>
+      <p:bldP spid="42" grpId="0" animBg="1"/>
       <p:bldP spid="43" grpId="0" animBg="1"/>
-      <p:bldP spid="30" grpId="1" animBg="1"/>
-      <p:bldP spid="31" grpId="1" animBg="1"/>
+      <p:bldP spid="45" grpId="0" animBg="1"/>
       <p:bldP spid="32" grpId="1" animBg="1"/>
+      <p:bldP spid="33" grpId="1" animBg="1"/>
       <p:bldP spid="34" grpId="1" animBg="1"/>
-      <p:bldP spid="35" grpId="1" animBg="1"/>
+      <p:bldP spid="36" grpId="1" animBg="1"/>
       <p:bldP spid="37" grpId="1" animBg="1"/>
-      <p:bldP spid="38" grpId="1" animBg="1"/>
+      <p:bldP spid="39" grpId="1" animBg="1"/>
       <p:bldP spid="40" grpId="1" animBg="1"/>
-      <p:bldP spid="41" grpId="1" animBg="1"/>
+      <p:bldP spid="42" grpId="1" animBg="1"/>
       <p:bldP spid="43" grpId="1" animBg="1"/>
+      <p:bldP spid="45" grpId="1" animBg="1"/>
     </p:bldLst>
   </p:timing>
 </p:sld>

</xml_diff>

<commit_message>
Premium Upsell: Payment History screenshot on Two reasons slide; keep trainer's slide 28 and 30 edits
Co-Authored-By: Claude Opus 5.5 <noreply@anthropic.com>
Claude-Session: https://claude.ai/code/session_01FEzv8wwqWDgTsXP8Yz6XYn
</commit_message>
<xml_diff>
--- a/incorrect-info-lmc-lockout/incorrect-info-lmc-lockout.pptx
+++ b/incorrect-info-lmc-lockout/incorrect-info-lmc-lockout.pptx
@@ -2922,7 +2922,7 @@
           <a:p>
             <a:r>
               <a:rPr lang="en-US" dirty="0"/>
-              <a:t>The Premium Fee can be refunded under two independent circumstances, and only one needs to apply: (1) the customer requests a refund for the Premium Fee; (2) the job has a confirmed service issue, even if the customer never mentions the Premium Fee. The second trigger is the one agents most often overlook. When a job has a confirmed service issue (such as Poor Cleaning Quality), always check whether a Premium Fee was charged. If it was, refund it as part of resolving the service issue, even if the customer only complained about the cleaning.</a:t>
+              <a:t>The Premium Fee can be refunded under two independent circumstances, and only one needs to apply: (1) the customer requests a refund for the Premium Fee; (2) the job has a confirmed service issue, even if the customer never mentions the Premium Fee. The second trigger is the one agents most often overlook. When a job has a confirmed service issue (such as Poor Cleaning Quality), always check whether a Premium Fee was charged. If it was, refund it as part of resolving the service issue, even if the customer only complained about the cleaning. ON THE SLIDE: the customer's Payment History in the CRM. The Premium Fee shows as premium_surcharge in the Reason column, usually $20 plus tax (here $21.35); the boxed rows are the Premium charges.</a:t>
             </a:r>
             <a:endParaRPr lang="en-US" dirty="0"/>
           </a:p>
@@ -27571,7 +27571,7 @@
                 <a:ea typeface="SF Pro Text" pitchFamily="34" charset="-122"/>
                 <a:cs typeface="SF Pro Text" pitchFamily="34" charset="-120"/>
               </a:rPr>
-              <a:t>Customer booked/rescheduled: Jul 27, 10:00 AM</a:t>
+              <a:t>Customer rescheduled: Jul 27, 10:00 AM</a:t>
             </a:r>
             <a:endParaRPr lang="en-US" sz="1000" dirty="0"/>
           </a:p>
@@ -27792,7 +27792,7 @@
                 <a:ea typeface="SF Pro Text" pitchFamily="34" charset="-122"/>
                 <a:cs typeface="SF Pro Text" pitchFamily="34" charset="-120"/>
               </a:rPr>
-              <a:t>Customer booked/rescheduled: Jul 27, 10:00 AM</a:t>
+              <a:t>Customer rescheduled: Jul 27, 10:00 AM</a:t>
             </a:r>
             <a:endParaRPr lang="en-US" sz="1000" dirty="0"/>
           </a:p>
@@ -31501,7 +31501,7 @@
                 <a:ea typeface="SF Pro Display" pitchFamily="34" charset="-122"/>
                 <a:cs typeface="SF Pro Display" pitchFamily="34" charset="-120"/>
               </a:rPr>
-              <a:t>Knowledge check</a:t>
+              <a:t>Let’s See What You’ve Got!</a:t>
             </a:r>
             <a:endParaRPr lang="en-US" sz="2400" dirty="0"/>
           </a:p>
@@ -31509,46 +31509,7 @@
       </p:sp>
       <p:sp>
         <p:nvSpPr>
-          <p:cNvPr id="4" name="Text 2"/>
-          <p:cNvSpPr txBox="1"/>
-          <p:nvPr/>
-        </p:nvSpPr>
-        <p:spPr>
-          <a:xfrm>
-            <a:off x="438912" y="960120"/>
-            <a:ext cx="8229600" cy="274320"/>
-          </a:xfrm>
-          <a:prstGeom prst="rect">
-            <a:avLst/>
-          </a:prstGeom>
-          <a:noFill/>
-          <a:ln/>
-        </p:spPr>
-        <p:txBody>
-          <a:bodyPr wrap="square" lIns="0" tIns="0" rIns="0" bIns="0" rtlCol="0" anchor="t"/>
-          <a:lstStyle/>
-          <a:p>
-            <a:pPr indent="0" marL="0">
-              <a:buNone/>
-            </a:pPr>
-            <a:r>
-              <a:rPr lang="en-US" sz="1200" dirty="0">
-                <a:solidFill>
-                  <a:srgbClr val="6E6E73"/>
-                </a:solidFill>
-                <a:latin typeface="SF Pro Text" pitchFamily="34" charset="0"/>
-                <a:ea typeface="SF Pro Text" pitchFamily="34" charset="-122"/>
-                <a:cs typeface="SF Pro Text" pitchFamily="34" charset="-120"/>
-              </a:rPr>
-              <a:t>Ask each question, then click to reveal the answer.</a:t>
-            </a:r>
-            <a:endParaRPr lang="en-US" sz="1200" dirty="0"/>
-          </a:p>
-        </p:txBody>
-      </p:sp>
-      <p:sp>
-        <p:nvSpPr>
-          <p:cNvPr id="6" name="Shape 3"/>
+          <p:cNvPr id="5" name="Shape 2"/>
           <p:cNvSpPr/>
           <p:nvPr/>
         </p:nvSpPr>
@@ -31575,7 +31536,7 @@
       </p:sp>
       <p:sp>
         <p:nvSpPr>
-          <p:cNvPr id="7" name="Shape 4"/>
+          <p:cNvPr id="6" name="Shape 3"/>
           <p:cNvSpPr/>
           <p:nvPr/>
         </p:nvSpPr>
@@ -31600,7 +31561,7 @@
       </p:sp>
       <p:sp>
         <p:nvSpPr>
-          <p:cNvPr id="8" name="Text 5"/>
+          <p:cNvPr id="7" name="Text 4"/>
           <p:cNvSpPr txBox="1"/>
           <p:nvPr/>
         </p:nvSpPr>
@@ -31639,7 +31600,7 @@
       </p:sp>
       <p:sp>
         <p:nvSpPr>
-          <p:cNvPr id="9" name="Text 6"/>
+          <p:cNvPr id="8" name="Text 5"/>
           <p:cNvSpPr txBox="1"/>
           <p:nvPr/>
         </p:nvSpPr>
@@ -31678,7 +31639,7 @@
       </p:sp>
       <p:sp>
         <p:nvSpPr>
-          <p:cNvPr id="10" name="Shape 7"/>
+          <p:cNvPr id="9" name="Shape 6"/>
           <p:cNvSpPr/>
           <p:nvPr/>
         </p:nvSpPr>
@@ -31705,7 +31666,7 @@
       </p:sp>
       <p:sp>
         <p:nvSpPr>
-          <p:cNvPr id="11" name="step1Ans"/>
+          <p:cNvPr id="10" name="step1Ans"/>
           <p:cNvSpPr txBox="1"/>
           <p:nvPr/>
         </p:nvSpPr>
@@ -31744,7 +31705,7 @@
       </p:sp>
       <p:sp>
         <p:nvSpPr>
-          <p:cNvPr id="12" name="Shape 9"/>
+          <p:cNvPr id="11" name="Shape 8"/>
           <p:cNvSpPr/>
           <p:nvPr/>
         </p:nvSpPr>
@@ -31771,7 +31732,7 @@
       </p:sp>
       <p:sp>
         <p:nvSpPr>
-          <p:cNvPr id="13" name="Shape 10"/>
+          <p:cNvPr id="12" name="Shape 9"/>
           <p:cNvSpPr/>
           <p:nvPr/>
         </p:nvSpPr>
@@ -31796,7 +31757,7 @@
       </p:sp>
       <p:sp>
         <p:nvSpPr>
-          <p:cNvPr id="14" name="Text 11"/>
+          <p:cNvPr id="13" name="Text 10"/>
           <p:cNvSpPr txBox="1"/>
           <p:nvPr/>
         </p:nvSpPr>
@@ -31835,7 +31796,7 @@
       </p:sp>
       <p:sp>
         <p:nvSpPr>
-          <p:cNvPr id="15" name="Text 12"/>
+          <p:cNvPr id="14" name="Text 11"/>
           <p:cNvSpPr txBox="1"/>
           <p:nvPr/>
         </p:nvSpPr>
@@ -31874,7 +31835,7 @@
       </p:sp>
       <p:sp>
         <p:nvSpPr>
-          <p:cNvPr id="16" name="Shape 13"/>
+          <p:cNvPr id="15" name="Shape 12"/>
           <p:cNvSpPr/>
           <p:nvPr/>
         </p:nvSpPr>
@@ -31901,7 +31862,7 @@
       </p:sp>
       <p:sp>
         <p:nvSpPr>
-          <p:cNvPr id="17" name="step2Ans"/>
+          <p:cNvPr id="16" name="step2Ans"/>
           <p:cNvSpPr txBox="1"/>
           <p:nvPr/>
         </p:nvSpPr>
@@ -31940,7 +31901,7 @@
       </p:sp>
       <p:sp>
         <p:nvSpPr>
-          <p:cNvPr id="18" name="Shape 15"/>
+          <p:cNvPr id="17" name="Shape 14"/>
           <p:cNvSpPr/>
           <p:nvPr/>
         </p:nvSpPr>
@@ -31967,7 +31928,7 @@
       </p:sp>
       <p:sp>
         <p:nvSpPr>
-          <p:cNvPr id="19" name="Shape 16"/>
+          <p:cNvPr id="18" name="Shape 15"/>
           <p:cNvSpPr/>
           <p:nvPr/>
         </p:nvSpPr>
@@ -31992,7 +31953,7 @@
       </p:sp>
       <p:sp>
         <p:nvSpPr>
-          <p:cNvPr id="20" name="Text 17"/>
+          <p:cNvPr id="19" name="Text 16"/>
           <p:cNvSpPr txBox="1"/>
           <p:nvPr/>
         </p:nvSpPr>
@@ -32031,7 +31992,7 @@
       </p:sp>
       <p:sp>
         <p:nvSpPr>
-          <p:cNvPr id="21" name="Text 18"/>
+          <p:cNvPr id="20" name="Text 17"/>
           <p:cNvSpPr txBox="1"/>
           <p:nvPr/>
         </p:nvSpPr>
@@ -32070,7 +32031,7 @@
       </p:sp>
       <p:sp>
         <p:nvSpPr>
-          <p:cNvPr id="22" name="Shape 19"/>
+          <p:cNvPr id="21" name="Shape 18"/>
           <p:cNvSpPr/>
           <p:nvPr/>
         </p:nvSpPr>
@@ -32097,7 +32058,7 @@
       </p:sp>
       <p:sp>
         <p:nvSpPr>
-          <p:cNvPr id="23" name="step3Ans"/>
+          <p:cNvPr id="22" name="step3Ans"/>
           <p:cNvSpPr txBox="1"/>
           <p:nvPr/>
         </p:nvSpPr>
@@ -32136,7 +32097,7 @@
       </p:sp>
       <p:sp>
         <p:nvSpPr>
-          <p:cNvPr id="24" name="Shape 21"/>
+          <p:cNvPr id="23" name="Shape 20"/>
           <p:cNvSpPr/>
           <p:nvPr/>
         </p:nvSpPr>
@@ -32163,7 +32124,7 @@
       </p:sp>
       <p:sp>
         <p:nvSpPr>
-          <p:cNvPr id="25" name="Shape 22"/>
+          <p:cNvPr id="24" name="Shape 21"/>
           <p:cNvSpPr/>
           <p:nvPr/>
         </p:nvSpPr>
@@ -32188,7 +32149,7 @@
       </p:sp>
       <p:sp>
         <p:nvSpPr>
-          <p:cNvPr id="26" name="Text 23"/>
+          <p:cNvPr id="25" name="Text 22"/>
           <p:cNvSpPr txBox="1"/>
           <p:nvPr/>
         </p:nvSpPr>
@@ -32227,7 +32188,7 @@
       </p:sp>
       <p:sp>
         <p:nvSpPr>
-          <p:cNvPr id="27" name="Text 24"/>
+          <p:cNvPr id="26" name="Text 23"/>
           <p:cNvSpPr txBox="1"/>
           <p:nvPr/>
         </p:nvSpPr>
@@ -32266,7 +32227,7 @@
       </p:sp>
       <p:sp>
         <p:nvSpPr>
-          <p:cNvPr id="28" name="Shape 25"/>
+          <p:cNvPr id="27" name="Shape 24"/>
           <p:cNvSpPr/>
           <p:nvPr/>
         </p:nvSpPr>
@@ -32293,7 +32254,7 @@
       </p:sp>
       <p:sp>
         <p:nvSpPr>
-          <p:cNvPr id="29" name="step4Ans"/>
+          <p:cNvPr id="28" name="step4Ans"/>
           <p:cNvSpPr txBox="1"/>
           <p:nvPr/>
         </p:nvSpPr>
@@ -32417,7 +32378,7 @@
                                           </p:stCondLst>
                                         </p:cTn>
                                         <p:tgtEl>
-                                          <p:spTgt spid="11"/>
+                                          <p:spTgt spid="10"/>
                                         </p:tgtEl>
                                         <p:attrNameLst>
                                           <p:attrName>style.visibility</p:attrName>
@@ -32431,7 +32392,7 @@
                                       <p:cBhvr>
                                         <p:cTn id="7" dur="600"/>
                                         <p:tgtEl>
-                                          <p:spTgt spid="11"/>
+                                          <p:spTgt spid="10"/>
                                         </p:tgtEl>
                                       </p:cBhvr>
                                     </p:animEffect>
@@ -32470,7 +32431,7 @@
                                           </p:stCondLst>
                                         </p:cTn>
                                         <p:tgtEl>
-                                          <p:spTgt spid="17"/>
+                                          <p:spTgt spid="16"/>
                                         </p:tgtEl>
                                         <p:attrNameLst>
                                           <p:attrName>style.visibility</p:attrName>
@@ -32484,7 +32445,7 @@
                                       <p:cBhvr>
                                         <p:cTn id="12" dur="600"/>
                                         <p:tgtEl>
-                                          <p:spTgt spid="17"/>
+                                          <p:spTgt spid="16"/>
                                         </p:tgtEl>
                                       </p:cBhvr>
                                     </p:animEffect>
@@ -32523,7 +32484,7 @@
                                           </p:stCondLst>
                                         </p:cTn>
                                         <p:tgtEl>
-                                          <p:spTgt spid="23"/>
+                                          <p:spTgt spid="22"/>
                                         </p:tgtEl>
                                         <p:attrNameLst>
                                           <p:attrName>style.visibility</p:attrName>
@@ -32537,7 +32498,7 @@
                                       <p:cBhvr>
                                         <p:cTn id="17" dur="600"/>
                                         <p:tgtEl>
-                                          <p:spTgt spid="23"/>
+                                          <p:spTgt spid="22"/>
                                         </p:tgtEl>
                                       </p:cBhvr>
                                     </p:animEffect>
@@ -32576,7 +32537,7 @@
                                           </p:stCondLst>
                                         </p:cTn>
                                         <p:tgtEl>
-                                          <p:spTgt spid="29"/>
+                                          <p:spTgt spid="28"/>
                                         </p:tgtEl>
                                         <p:attrNameLst>
                                           <p:attrName>style.visibility</p:attrName>
@@ -32590,7 +32551,7 @@
                                       <p:cBhvr>
                                         <p:cTn id="22" dur="600"/>
                                         <p:tgtEl>
-                                          <p:spTgt spid="29"/>
+                                          <p:spTgt spid="28"/>
                                         </p:tgtEl>
                                       </p:cBhvr>
                                     </p:animEffect>
@@ -32625,10 +32586,10 @@
       </p:par>
     </p:tnLst>
     <p:bldLst>
-      <p:bldP spid="11" grpId="0" animBg="1"/>
-      <p:bldP spid="17" grpId="0" animBg="1"/>
-      <p:bldP spid="23" grpId="0" animBg="1"/>
-      <p:bldP spid="29" grpId="0" animBg="1"/>
+      <p:bldP spid="10" grpId="0" animBg="1"/>
+      <p:bldP spid="16" grpId="0" animBg="1"/>
+      <p:bldP spid="22" grpId="0" animBg="1"/>
+      <p:bldP spid="28" grpId="0" animBg="1"/>
     </p:bldLst>
   </p:timing>
 </p:sld>
@@ -35384,12 +35345,12 @@
         </p:nvSpPr>
         <p:spPr>
           <a:xfrm>
-            <a:off x="411480" y="1325880"/>
-            <a:ext cx="4091940" cy="1691640"/>
+            <a:off x="411480" y="1298448"/>
+            <a:ext cx="4091940" cy="1325880"/>
           </a:xfrm>
           <a:prstGeom prst="roundRect">
             <a:avLst>
-              <a:gd name="adj" fmla="val 4324"/>
+              <a:gd name="adj" fmla="val 5517"/>
             </a:avLst>
           </a:prstGeom>
           <a:solidFill>
@@ -35411,7 +35372,7 @@
         </p:nvSpPr>
         <p:spPr>
           <a:xfrm>
-            <a:off x="576072" y="1490472"/>
+            <a:off x="576072" y="1463040"/>
             <a:ext cx="329184" cy="329184"/>
           </a:xfrm>
           <a:prstGeom prst="ellipse">
@@ -35444,7 +35405,7 @@
         </p:blipFill>
         <p:spPr>
           <a:xfrm>
-            <a:off x="655076" y="1569476"/>
+            <a:off x="655076" y="1542044"/>
             <a:ext cx="171176" cy="171176"/>
           </a:xfrm>
           <a:prstGeom prst="rect">
@@ -35460,7 +35421,7 @@
         </p:nvSpPr>
         <p:spPr>
           <a:xfrm>
-            <a:off x="576072" y="1929384"/>
+            <a:off x="576072" y="1901952"/>
             <a:ext cx="3762756" cy="274320"/>
           </a:xfrm>
           <a:prstGeom prst="rect">
@@ -35499,8 +35460,8 @@
         </p:nvSpPr>
         <p:spPr>
           <a:xfrm>
-            <a:off x="576072" y="2221992"/>
-            <a:ext cx="3762756" cy="704088"/>
+            <a:off x="576072" y="2194560"/>
+            <a:ext cx="3762756" cy="338328"/>
           </a:xfrm>
           <a:prstGeom prst="rect">
             <a:avLst/>
@@ -35538,12 +35499,12 @@
         </p:nvSpPr>
         <p:spPr>
           <a:xfrm>
-            <a:off x="4640580" y="1325880"/>
-            <a:ext cx="4091940" cy="1691640"/>
+            <a:off x="4640580" y="1298448"/>
+            <a:ext cx="4091940" cy="1325880"/>
           </a:xfrm>
           <a:prstGeom prst="roundRect">
             <a:avLst>
-              <a:gd name="adj" fmla="val 4324"/>
+              <a:gd name="adj" fmla="val 5517"/>
             </a:avLst>
           </a:prstGeom>
           <a:solidFill>
@@ -35565,7 +35526,7 @@
         </p:nvSpPr>
         <p:spPr>
           <a:xfrm>
-            <a:off x="4805172" y="1490472"/>
+            <a:off x="4805172" y="1463040"/>
             <a:ext cx="329184" cy="329184"/>
           </a:xfrm>
           <a:prstGeom prst="ellipse">
@@ -35598,7 +35559,7 @@
         </p:blipFill>
         <p:spPr>
           <a:xfrm>
-            <a:off x="4884176" y="1569476"/>
+            <a:off x="4884176" y="1542044"/>
             <a:ext cx="171176" cy="171176"/>
           </a:xfrm>
           <a:prstGeom prst="rect">
@@ -35614,7 +35575,7 @@
         </p:nvSpPr>
         <p:spPr>
           <a:xfrm>
-            <a:off x="4805172" y="1929384"/>
+            <a:off x="4805172" y="1901952"/>
             <a:ext cx="3762756" cy="274320"/>
           </a:xfrm>
           <a:prstGeom prst="rect">
@@ -35653,8 +35614,8 @@
         </p:nvSpPr>
         <p:spPr>
           <a:xfrm>
-            <a:off x="4805172" y="2221992"/>
-            <a:ext cx="3762756" cy="704088"/>
+            <a:off x="4805172" y="2194560"/>
+            <a:ext cx="3762756" cy="338328"/>
           </a:xfrm>
           <a:prstGeom prst="rect">
             <a:avLst/>
@@ -35733,34 +35694,46 @@
       </p:sp>
       <p:sp>
         <p:nvSpPr>
-          <p:cNvPr id="17" name="Shape 12"/>
-          <p:cNvSpPr/>
-          <p:nvPr/>
-        </p:nvSpPr>
-        <p:spPr>
-          <a:xfrm>
-            <a:off x="411480" y="3200400"/>
-            <a:ext cx="8321040" cy="384048"/>
-          </a:xfrm>
-          <a:prstGeom prst="roundRect">
-            <a:avLst>
-              <a:gd name="adj" fmla="val 19048"/>
-            </a:avLst>
-          </a:prstGeom>
-          <a:solidFill>
-            <a:srgbClr val="FFF3D6"/>
-          </a:solidFill>
-          <a:ln w="9525">
-            <a:solidFill>
-              <a:srgbClr val="FFF3D6"/>
-            </a:solidFill>
-            <a:prstDash val="solid"/>
-          </a:ln>
-        </p:spPr>
+          <p:cNvPr id="17" name="Text 12"/>
+          <p:cNvSpPr txBox="1"/>
+          <p:nvPr/>
+        </p:nvSpPr>
+        <p:spPr>
+          <a:xfrm>
+            <a:off x="411480" y="2743200"/>
+            <a:ext cx="5486400" cy="182880"/>
+          </a:xfrm>
+          <a:prstGeom prst="rect">
+            <a:avLst/>
+          </a:prstGeom>
+          <a:noFill/>
+          <a:ln/>
+        </p:spPr>
+        <p:txBody>
+          <a:bodyPr wrap="square" lIns="0" tIns="0" rIns="0" bIns="0" rtlCol="0" anchor="t"/>
+          <a:lstStyle/>
+          <a:p>
+            <a:pPr indent="0" marL="0">
+              <a:buNone/>
+            </a:pPr>
+            <a:r>
+              <a:rPr lang="en-US" sz="800" b="1" spc="50" kern="0" dirty="0">
+                <a:solidFill>
+                  <a:srgbClr val="6E6E73"/>
+                </a:solidFill>
+                <a:latin typeface="SF Pro Display" pitchFamily="34" charset="0"/>
+                <a:ea typeface="SF Pro Display" pitchFamily="34" charset="-122"/>
+                <a:cs typeface="SF Pro Display" pitchFamily="34" charset="-120"/>
+              </a:rPr>
+              <a:t>SPOT IT IN THE CRM › PAYMENT HISTORY</a:t>
+            </a:r>
+            <a:endParaRPr lang="en-US" sz="800" dirty="0"/>
+          </a:p>
+        </p:txBody>
       </p:sp>
       <p:pic>
         <p:nvPicPr>
-          <p:cNvPr id="18" name="Image 2" descr="preencoded.png">    </p:cNvPr>
+          <p:cNvPr id="18" name="Image 2" descr="/tmp/claude-0/-workspace-training/3ce5cff6-cccf-5f33-b0ee-0b147a55120e/scratchpad/img6/premium_payment_history.png">    </p:cNvPr>
           <p:cNvPicPr>
             <a:picLocks noChangeAspect="1"/>
           </p:cNvPicPr>
@@ -35774,8 +35747,8 @@
         </p:blipFill>
         <p:spPr>
           <a:xfrm>
-            <a:off x="566928" y="3310128"/>
-            <a:ext cx="164592" cy="164592"/>
+            <a:off x="411480" y="2926080"/>
+            <a:ext cx="6047704" cy="1600200"/>
           </a:xfrm>
           <a:prstGeom prst="rect">
             <a:avLst/>
@@ -35784,14 +35757,63 @@
       </p:pic>
       <p:sp>
         <p:nvSpPr>
-          <p:cNvPr id="19" name="Text 13"/>
+          <p:cNvPr id="19" name="Shape 13"/>
+          <p:cNvSpPr/>
+          <p:nvPr/>
+        </p:nvSpPr>
+        <p:spPr>
+          <a:xfrm>
+            <a:off x="411480" y="2926080"/>
+            <a:ext cx="6047704" cy="1600200"/>
+          </a:xfrm>
+          <a:prstGeom prst="rect">
+            <a:avLst/>
+          </a:prstGeom>
+          <a:ln w="9525">
+            <a:solidFill>
+              <a:srgbClr val="DCE1E7"/>
+            </a:solidFill>
+            <a:prstDash val="solid"/>
+          </a:ln>
+        </p:spPr>
+      </p:sp>
+      <p:sp>
+        <p:nvSpPr>
+          <p:cNvPr id="20" name="Shape 14"/>
+          <p:cNvSpPr/>
+          <p:nvPr/>
+        </p:nvSpPr>
+        <p:spPr>
+          <a:xfrm>
+            <a:off x="6596344" y="2743200"/>
+            <a:ext cx="2136176" cy="1783080"/>
+          </a:xfrm>
+          <a:prstGeom prst="roundRect">
+            <a:avLst>
+              <a:gd name="adj" fmla="val 4103"/>
+            </a:avLst>
+          </a:prstGeom>
+          <a:solidFill>
+            <a:srgbClr val="E3F4F1"/>
+          </a:solidFill>
+          <a:ln w="9525">
+            <a:solidFill>
+              <a:srgbClr val="E3F4F1"/>
+            </a:solidFill>
+            <a:prstDash val="solid"/>
+          </a:ln>
+        </p:spPr>
+      </p:sp>
+      <p:sp>
+        <p:nvSpPr>
+          <p:cNvPr id="21" name="Text 15"/>
           <p:cNvSpPr txBox="1"/>
           <p:nvPr/>
         </p:nvSpPr>
         <p:spPr>
           <a:xfrm>
-            <a:off x="822960" y="3300984"/>
-            <a:ext cx="7772400" cy="201168"/>
+            <a:off x="6733504" y="2834640"/>
+            <a:ext cx="1861856" cy="1600200"/>
           </a:xfrm>
           <a:prstGeom prst="rect">
             <a:avLst/>
@@ -35804,24 +35826,53 @@
           <a:lstStyle/>
           <a:p>
             <a:pPr indent="0" marL="0">
-              <a:buNone/>
-            </a:pPr>
-            <a:r>
-              <a:rPr lang="en-US" sz="1000" b="1" dirty="0">
-                <a:solidFill>
-                  <a:srgbClr val="9A6410"/>
+              <a:spcAft>
+                <a:spcPts val="400"/>
+              </a:spcAft>
+              <a:buNone/>
+            </a:pPr>
+            <a:r>
+              <a:rPr lang="en-US" sz="950" b="1" dirty="0">
+                <a:solidFill>
+                  <a:srgbClr val="0B7A6F"/>
+                </a:solidFill>
+                <a:latin typeface="SF Pro Display" pitchFamily="34" charset="0"/>
+                <a:ea typeface="SF Pro Display" pitchFamily="34" charset="-122"/>
+                <a:cs typeface="SF Pro Display" pitchFamily="34" charset="-120"/>
+              </a:rPr>
+              <a:t>Look for</a:t>
+            </a:r>
+            <a:endParaRPr lang="en-US" sz="950" dirty="0"/>
+          </a:p>
+          <a:p>
+            <a:pPr indent="0" marL="0">
+              <a:spcAft>
+                <a:spcPts val="400"/>
+              </a:spcAft>
+              <a:buNone/>
+            </a:pPr>
+            <a:r>
+              <a:rPr lang="en-US" sz="950" b="1" dirty="0">
+                <a:solidFill>
+                  <a:srgbClr val="1D1D1F"/>
                 </a:solidFill>
                 <a:latin typeface="SF Pro Text" pitchFamily="34" charset="0"/>
                 <a:ea typeface="SF Pro Text" pitchFamily="34" charset="-122"/>
                 <a:cs typeface="SF Pro Text" pitchFamily="34" charset="-120"/>
               </a:rPr>
-              <a:t>Confirmed service issue?  </a:t>
-            </a:r>
+              <a:t>premium_surcharge</a:t>
+            </a:r>
+            <a:endParaRPr lang="en-US" sz="950" dirty="0"/>
+          </a:p>
+          <a:p>
             <a:pPr indent="0" marL="0">
-              <a:buNone/>
-            </a:pPr>
-            <a:r>
-              <a:rPr lang="en-US" sz="1000" dirty="0">
+              <a:spcAft>
+                <a:spcPts val="400"/>
+              </a:spcAft>
+              <a:buNone/>
+            </a:pPr>
+            <a:r>
+              <a:rPr lang="en-US" sz="950" dirty="0">
                 <a:solidFill>
                   <a:srgbClr val="1D1D1F"/>
                 </a:solidFill>
@@ -35829,9 +35880,29 @@
                 <a:ea typeface="SF Pro Text" pitchFamily="34" charset="-122"/>
                 <a:cs typeface="SF Pro Text" pitchFamily="34" charset="-120"/>
               </a:rPr>
-              <a:t>always check for a Premium Fee, and refund it.</a:t>
-            </a:r>
-            <a:endParaRPr lang="en-US" sz="1000" dirty="0"/>
+              <a:t>$20 + tax, e.g. $21.35</a:t>
+            </a:r>
+            <a:endParaRPr lang="en-US" sz="950" dirty="0"/>
+          </a:p>
+          <a:p>
+            <a:pPr indent="0" marL="0">
+              <a:spcAft>
+                <a:spcPts val="400"/>
+              </a:spcAft>
+              <a:buNone/>
+            </a:pPr>
+            <a:r>
+              <a:rPr lang="en-US" sz="950" dirty="0">
+                <a:solidFill>
+                  <a:srgbClr val="6E6E73"/>
+                </a:solidFill>
+                <a:latin typeface="SF Pro Text" pitchFamily="34" charset="0"/>
+                <a:ea typeface="SF Pro Text" pitchFamily="34" charset="-122"/>
+                <a:cs typeface="SF Pro Text" pitchFamily="34" charset="-120"/>
+              </a:rPr>
+              <a:t>Confirmed service issue? Always check for it, and refund it.</a:t>
+            </a:r>
+            <a:endParaRPr lang="en-US" sz="950" dirty="0"/>
           </a:p>
         </p:txBody>
       </p:sp>

</xml_diff>

<commit_message>
Processing Fee: rebuild decision flow slide; carry over Premium slide edits
Slide 41 becomes a two-branch decision flow (properly disclosed vs failed
to set expectations) with each item revealed per click. Slides 33-35 keep
Anjuli's text and video-link edits, with links as shape-level boxes.

Co-Authored-By: Claude Opus 5.5 <noreply@anthropic.com>
Claude-Session: https://claude.ai/code/session_01FEzv8wwqWDgTsXP8Yz6XYn
</commit_message>
<xml_diff>
--- a/incorrect-info-lmc-lockout/incorrect-info-lmc-lockout.pptx
+++ b/incorrect-info-lmc-lockout/incorrect-info-lmc-lockout.pptx
@@ -3626,7 +3626,7 @@
           <a:p>
             <a:r>
               <a:rPr lang="en-US" dirty="0"/>
-              <a:t>Homeaglow properly set expectations: explain that the Processing Fee is a standard charge included in every cleaning. Keep it neutral; don't imply it was charged incorrectly. If they only wanted clarification, the explanation is enough. If they're still unhappy but staying, you may issue a one-time $10 or $20 account credit as goodwill (use your judgment). Never issue a credit equal to the Processing Fee itself: that implies the fee was inappropriate. If they specifically want cash back instead of credits, or will cancel unless refunded, you may issue a $10 or $20 partial refund instead. Set clear expectations that the fee is standard and ongoing: this is a one-time exception, not a waiver. Homeaglow failed to set proper expectations: refund the Processing Fee in full to the original payment method, and acknowledge the specific expectation-setting issue without suggesting the fee is generally invalid. If they no longer want their ForeverClean membership because of it, waive the ETF when processing the cancellation. Macro: Processing Fee.</a:t>
+              <a:t>Start with why the customer is contesting the fee. Your resolution should reflect why they're contesting it, not just the fact that they are. TRAINER: both boxes start empty; each click reveals the next item. BRANCH 1, Homeaglow properly disclosed the fee (an expectation gap: they overlooked it, forgot, or assumed the hourly rate included all fees). Always explain neutrally that the Processing Fee is a standard charge on every cleaning; if they only wanted clarification, that's enough. 1) Wants to keep their membership but is still unhappy: explain the fee, plus a one-time $10 or $20 goodwill credit (use your judgment). 2) Wants a cash refund, or may cancel unless refunded: explain the fee, plus a $10 or $20 partial refund. Set clear expectations that the fee is standard and ongoing: this is a one-time exception, not a waiver. 3) Objects to future fees rather than this charge: move into retention; offer a $10–$15 Membership Fee reduction, and escalate to Support or a TL, who can approve reductions of up to 50%. Never issue a credit equal to the exact Processing Fee: it implies the fee was inappropriate. BRANCH 2, Homeaglow failed to set proper expectations: refund the Processing Fee in full to the original payment method, and acknowledge the specific expectation-setting issue without suggesting the fee is generally invalid. If they're cancelling ForeverClean over it, waive the ETF when processing the cancellation. Sample scenarios: a Sales rep failed to mention the Processing Fee, or incorrectly stated there are no additional fees; a system or onboarding issue prevented the customer from seeing the fee disclosure. Macro: Processing Fee.</a:t>
             </a:r>
             <a:endParaRPr lang="en-US" dirty="0"/>
           </a:p>
@@ -6337,9 +6337,6 @@
               </a:rPr>
               <a:t>Questions?  </a:t>
             </a:r>
-            <a:pPr indent="0" marL="0">
-              <a:buNone/>
-            </a:pPr>
             <a:r>
               <a:rPr lang="en-US" sz="1100" dirty="0">
                 <a:solidFill>
@@ -7753,9 +7750,6 @@
               </a:rPr>
               <a:t>Two questions:  </a:t>
             </a:r>
-            <a:pPr indent="0" marL="0">
-              <a:buNone/>
-            </a:pPr>
             <a:r>
               <a:rPr lang="en-US" sz="1000" dirty="0">
                 <a:solidFill>
@@ -10676,9 +10670,6 @@
               </a:rPr>
               <a:t>Only if asked:  </a:t>
             </a:r>
-            <a:pPr indent="0" marL="0">
-              <a:buNone/>
-            </a:pPr>
             <a:r>
               <a:rPr lang="en-US" sz="1000" dirty="0">
                 <a:solidFill>
@@ -10780,9 +10771,6 @@
               </a:rPr>
               <a:t>Recommended Macro:  </a:t>
             </a:r>
-            <a:pPr indent="0" marL="0">
-              <a:buNone/>
-            </a:pPr>
             <a:r>
               <a:rPr lang="en-US" sz="950" b="1" dirty="0">
                 <a:solidFill>
@@ -11474,9 +11462,6 @@
               </a:rPr>
               <a:t>LMC only:  </a:t>
             </a:r>
-            <a:pPr indent="0" marL="0">
-              <a:buNone/>
-            </a:pPr>
             <a:r>
               <a:rPr lang="en-US" sz="1000" dirty="0">
                 <a:solidFill>
@@ -13698,9 +13683,6 @@
               </a:rPr>
               <a:t>Questions?  </a:t>
             </a:r>
-            <a:pPr indent="0" marL="0">
-              <a:buNone/>
-            </a:pPr>
             <a:r>
               <a:rPr lang="en-US" sz="1100" dirty="0">
                 <a:solidFill>
@@ -16553,9 +16535,6 @@
               </a:rPr>
               <a:t>Validate first:  </a:t>
             </a:r>
-            <a:pPr indent="0" marL="0">
-              <a:buNone/>
-            </a:pPr>
             <a:r>
               <a:rPr lang="en-US" sz="1000" dirty="0">
                 <a:solidFill>
@@ -17866,9 +17845,6 @@
               </a:rPr>
               <a:t>Important:  </a:t>
             </a:r>
-            <a:pPr indent="0" marL="0">
-              <a:buNone/>
-            </a:pPr>
             <a:r>
               <a:rPr lang="en-US" sz="950" b="1" dirty="0">
                 <a:solidFill>
@@ -20780,9 +20756,6 @@
                         </a:rPr>
                         <a:t>Admin refund the full job cost. </a:t>
                       </a:r>
-                      <a:pPr indent="0" marL="0">
-                        <a:buNone/>
-                      </a:pPr>
                       <a:r>
                         <a:rPr lang="en-US" sz="800" b="1" dirty="0">
                           <a:solidFill>
@@ -21594,9 +21567,6 @@
               </a:rPr>
               <a:t>Recommended Macros:  </a:t>
             </a:r>
-            <a:pPr indent="0" marL="0">
-              <a:buNone/>
-            </a:pPr>
             <a:r>
               <a:rPr lang="en-US" sz="950" b="1" dirty="0">
                 <a:solidFill>
@@ -22535,12 +22505,6 @@
               </a:rPr>
               <a:t>Our fault → </a:t>
             </a:r>
-            <a:pPr indent="0" marL="0">
-              <a:spcAft>
-                <a:spcPts val="400"/>
-              </a:spcAft>
-              <a:buNone/>
-            </a:pPr>
             <a:r>
               <a:rPr lang="en-US" sz="1050" dirty="0">
                 <a:solidFill>
@@ -24974,9 +24938,6 @@
               </a:rPr>
               <a:t>Questions?  </a:t>
             </a:r>
-            <a:pPr indent="0" marL="0">
-              <a:buNone/>
-            </a:pPr>
             <a:r>
               <a:rPr lang="en-US" sz="1100" dirty="0">
                 <a:solidFill>
@@ -26379,9 +26340,6 @@
               </a:rPr>
               <a:t>Refunding it?  </a:t>
             </a:r>
-            <a:pPr indent="0" marL="0">
-              <a:buNone/>
-            </a:pPr>
             <a:r>
               <a:rPr lang="en-US" sz="1000" dirty="0">
                 <a:solidFill>
@@ -27947,9 +27905,6 @@
               </a:rPr>
               <a:t>Same original date in both.  </a:t>
             </a:r>
-            <a:pPr indent="0" marL="0">
-              <a:buNone/>
-            </a:pPr>
             <a:r>
               <a:rPr lang="en-US" sz="1000" dirty="0">
                 <a:solidFill>
@@ -28777,9 +28732,6 @@
               </a:rPr>
               <a:t>Macro:  </a:t>
             </a:r>
-            <a:pPr indent="0" marL="0">
-              <a:buNone/>
-            </a:pPr>
             <a:r>
               <a:rPr lang="en-US" sz="950" b="1" dirty="0">
                 <a:solidFill>
@@ -28881,9 +28833,6 @@
               </a:rPr>
               <a:t>Macro:  </a:t>
             </a:r>
-            <a:pPr indent="0" marL="0">
-              <a:buNone/>
-            </a:pPr>
             <a:r>
               <a:rPr lang="en-US" sz="950" b="1" dirty="0">
                 <a:solidFill>
@@ -29032,9 +28981,6 @@
               </a:rPr>
               <a:t>Note:  </a:t>
             </a:r>
-            <a:pPr indent="0" marL="0">
-              <a:buNone/>
-            </a:pPr>
             <a:r>
               <a:rPr lang="en-US" sz="1000" dirty="0">
                 <a:solidFill>
@@ -29209,9 +29155,6 @@
               </a:rPr>
               <a:t>CP no-show   </a:t>
             </a:r>
-            <a:pPr indent="0" marL="0">
-              <a:buNone/>
-            </a:pPr>
             <a:r>
               <a:rPr lang="en-US" sz="950" dirty="0">
                 <a:solidFill>
@@ -29313,9 +29256,6 @@
               </a:rPr>
               <a:t>CP rescheduled   </a:t>
             </a:r>
-            <a:pPr indent="0" marL="0">
-              <a:buNone/>
-            </a:pPr>
             <a:r>
               <a:rPr lang="en-US" sz="950" dirty="0">
                 <a:solidFill>
@@ -29417,9 +29357,6 @@
               </a:rPr>
               <a:t>System bug   </a:t>
             </a:r>
-            <a:pPr indent="0" marL="0">
-              <a:buNone/>
-            </a:pPr>
             <a:r>
               <a:rPr lang="en-US" sz="950" dirty="0">
                 <a:solidFill>
@@ -29521,9 +29458,6 @@
               </a:rPr>
               <a:t>Rebooked after PCQ   </a:t>
             </a:r>
-            <a:pPr indent="0" marL="0">
-              <a:buNone/>
-            </a:pPr>
             <a:r>
               <a:rPr lang="en-US" sz="950" dirty="0">
                 <a:solidFill>
@@ -33523,9 +33457,6 @@
               </a:rPr>
               <a:t>Questions?  </a:t>
             </a:r>
-            <a:pPr indent="0" marL="0">
-              <a:buNone/>
-            </a:pPr>
             <a:r>
               <a:rPr lang="en-US" sz="1100" dirty="0">
                 <a:solidFill>
@@ -34845,7 +34776,48 @@
       </p:sp>
       <p:sp>
         <p:nvSpPr>
-          <p:cNvPr id="14" name="Shape 10"/>
+          <p:cNvPr id="14" name="Text 10">
+            <a:hlinkClick r:id="rId2" tooltip="Play: choosing Premium at booking"/>
+          </p:cNvPr>
+          <p:cNvSpPr/>
+          <p:nvPr/>
+        </p:nvSpPr>
+        <p:spPr>
+          <a:xfrm>
+            <a:off x="4296766" y="2272284"/>
+            <a:ext cx="1188720" cy="146304"/>
+          </a:xfrm>
+          <a:prstGeom prst="rect">
+            <a:avLst/>
+          </a:prstGeom>
+          <a:noFill/>
+          <a:ln/>
+        </p:spPr>
+        <p:txBody>
+          <a:bodyPr wrap="square" lIns="0" tIns="0" rIns="0" bIns="0" rtlCol="0" anchor="ctr"/>
+          <a:lstStyle/>
+          <a:p>
+            <a:pPr indent="0" marL="0">
+              <a:buNone/>
+            </a:pPr>
+            <a:r>
+              <a:rPr lang="en-US" sz="800" b="1" u="none" dirty="0">
+                <a:solidFill>
+                  <a:srgbClr val="0B7A6F"/>
+                </a:solidFill>
+                <a:latin typeface="SF Pro Text" pitchFamily="34" charset="0"/>
+                <a:ea typeface="SF Pro Text" pitchFamily="34" charset="-122"/>
+                <a:cs typeface="SF Pro Text" pitchFamily="34" charset="-120"/>
+              </a:rPr>
+              <a:t>▷ watch how it’s done</a:t>
+            </a:r>
+            <a:endParaRPr lang="en-US" sz="800" dirty="0"/>
+          </a:p>
+        </p:txBody>
+      </p:sp>
+      <p:sp>
+        <p:nvSpPr>
+          <p:cNvPr id="15" name="Shape 11"/>
           <p:cNvSpPr/>
           <p:nvPr/>
         </p:nvSpPr>
@@ -34872,7 +34844,7 @@
       </p:sp>
       <p:sp>
         <p:nvSpPr>
-          <p:cNvPr id="15" name="Shape 11"/>
+          <p:cNvPr id="16" name="Shape 12"/>
           <p:cNvSpPr/>
           <p:nvPr/>
         </p:nvSpPr>
@@ -34897,14 +34869,14 @@
       </p:sp>
       <p:pic>
         <p:nvPicPr>
-          <p:cNvPr id="16" name="Image 1" descr="preencoded.png">    </p:cNvPr>
+          <p:cNvPr id="17" name="Image 1" descr="preencoded.png">    </p:cNvPr>
           <p:cNvPicPr>
             <a:picLocks noChangeAspect="1"/>
           </p:cNvPicPr>
           <p:nvPr/>
         </p:nvPicPr>
         <p:blipFill>
-          <a:blip r:embed="rId2"/>
+          <a:blip r:embed="rId3"/>
           <a:stretch>
             <a:fillRect/>
           </a:stretch>
@@ -34921,7 +34893,7 @@
       </p:pic>
       <p:sp>
         <p:nvSpPr>
-          <p:cNvPr id="17" name="Text 12"/>
+          <p:cNvPr id="18" name="Text 13"/>
           <p:cNvSpPr txBox="1"/>
           <p:nvPr/>
         </p:nvSpPr>
@@ -34952,7 +34924,7 @@
                 <a:ea typeface="SF Pro Display" pitchFamily="34" charset="-122"/>
                 <a:cs typeface="SF Pro Display" pitchFamily="34" charset="-120"/>
               </a:rPr>
-              <a:t>Not the Priority Fee</a:t>
+              <a:t>Cleaner preference level</a:t>
             </a:r>
             <a:endParaRPr lang="en-US" sz="1300" dirty="0"/>
           </a:p>
@@ -34960,7 +34932,7 @@
       </p:sp>
       <p:sp>
         <p:nvSpPr>
-          <p:cNvPr id="18" name="Text 13"/>
+          <p:cNvPr id="19" name="Text 14"/>
           <p:cNvSpPr txBox="1"/>
           <p:nvPr/>
         </p:nvSpPr>
@@ -34987,7 +34959,7 @@
               <a:buChar char="•"/>
             </a:pPr>
             <a:r>
-              <a:rPr lang="en-US" sz="1000" dirty="0">
+              <a:rPr lang="en-US" sz="1000" b="1" dirty="0">
                 <a:solidFill>
                   <a:srgbClr val="1D1D1F"/>
                 </a:solidFill>
@@ -34995,7 +34967,40 @@
                 <a:ea typeface="SF Pro Text" pitchFamily="34" charset="-122"/>
                 <a:cs typeface="SF Pro Text" pitchFamily="34" charset="-120"/>
               </a:rPr>
-              <a:t>Automatic, not chosen</a:t>
+              <a:t>Standard</a:t>
+            </a:r>
+            <a:r>
+              <a:rPr lang="en-US" sz="1000" dirty="0">
+                <a:solidFill>
+                  <a:srgbClr val="1D1D1F"/>
+                </a:solidFill>
+                <a:latin typeface="SF Pro Text" pitchFamily="34" charset="0"/>
+                <a:ea typeface="SF Pro Text" pitchFamily="34" charset="-122"/>
+                <a:cs typeface="SF Pro Text" pitchFamily="34" charset="-120"/>
+              </a:rPr>
+              <a:t>: experienced, background checked cleaners </a:t>
+            </a:r>
+            <a:r>
+              <a:rPr lang="en-US" sz="1050" b="1" dirty="0">
+                <a:solidFill>
+                  <a:srgbClr val="0B7A6F"/>
+                </a:solidFill>
+                <a:latin typeface="SF Pro Text" pitchFamily="34" charset="0"/>
+                <a:ea typeface="SF Pro Text" pitchFamily="34" charset="-122"/>
+                <a:cs typeface="SF Pro Text" pitchFamily="34" charset="-120"/>
+              </a:rPr>
+              <a:t>→ </a:t>
+            </a:r>
+            <a:r>
+              <a:rPr lang="en-US" sz="1000" dirty="0">
+                <a:solidFill>
+                  <a:srgbClr val="1D1D1F"/>
+                </a:solidFill>
+                <a:latin typeface="SF Pro Text" pitchFamily="34" charset="0"/>
+                <a:ea typeface="SF Pro Text" pitchFamily="34" charset="-122"/>
+                <a:cs typeface="SF Pro Text" pitchFamily="34" charset="-120"/>
+              </a:rPr>
+              <a:t>no additional fee</a:t>
             </a:r>
             <a:endParaRPr lang="en-US" sz="1000" dirty="0"/>
           </a:p>
@@ -35008,7 +35013,7 @@
               <a:buChar char="•"/>
             </a:pPr>
             <a:r>
-              <a:rPr lang="en-US" sz="1000" dirty="0">
+              <a:rPr lang="en-US" sz="1000" b="1" dirty="0">
                 <a:solidFill>
                   <a:srgbClr val="1D1D1F"/>
                 </a:solidFill>
@@ -35016,18 +35021,8 @@
                 <a:ea typeface="SF Pro Text" pitchFamily="34" charset="-122"/>
                 <a:cs typeface="SF Pro Text" pitchFamily="34" charset="-120"/>
               </a:rPr>
-              <a:t>Triggered by booking or rescheduling</a:t>
-            </a:r>
-            <a:endParaRPr lang="en-US" sz="1000" dirty="0"/>
-          </a:p>
-          <a:p>
-            <a:pPr marL="127000" indent="-127000">
-              <a:spcAft>
-                <a:spcPts val="500"/>
-              </a:spcAft>
-              <a:buSzPct val="100000"/>
-              <a:buChar char="•"/>
-            </a:pPr>
+              <a:t>Premium</a:t>
+            </a:r>
             <a:r>
               <a:rPr lang="en-US" sz="1000" dirty="0">
                 <a:solidFill>
@@ -35037,7 +35032,29 @@
                 <a:ea typeface="SF Pro Text" pitchFamily="34" charset="-122"/>
                 <a:cs typeface="SF Pro Text" pitchFamily="34" charset="-120"/>
               </a:rPr>
-              <a:t>Inside the 48-hour window</a:t>
+              <a:t>: matched with the most highly rated cleaners </a:t>
+            </a:r>
+            <a:r>
+              <a:rPr lang="en-US" sz="1050" b="1" dirty="0">
+                <a:solidFill>
+                  <a:srgbClr val="0B7A6F"/>
+                </a:solidFill>
+                <a:latin typeface="SF Pro Text" pitchFamily="34" charset="0"/>
+                <a:ea typeface="SF Pro Text" pitchFamily="34" charset="-122"/>
+                <a:cs typeface="SF Pro Text" pitchFamily="34" charset="-120"/>
+              </a:rPr>
+              <a:t>→ </a:t>
+            </a:r>
+            <a:r>
+              <a:rPr lang="en-US" sz="1000" dirty="0">
+                <a:solidFill>
+                  <a:srgbClr val="1D1D1F"/>
+                </a:solidFill>
+                <a:latin typeface="SF Pro Text" pitchFamily="34" charset="0"/>
+                <a:ea typeface="SF Pro Text" pitchFamily="34" charset="-122"/>
+                <a:cs typeface="SF Pro Text" pitchFamily="34" charset="-120"/>
+              </a:rPr>
+              <a:t>with premium fee</a:t>
             </a:r>
             <a:endParaRPr lang="en-US" sz="1000" dirty="0"/>
           </a:p>
@@ -35045,7 +35062,7 @@
       </p:sp>
       <p:sp>
         <p:nvSpPr>
-          <p:cNvPr id="19" name="Shape 14"/>
+          <p:cNvPr id="20" name="Shape 15"/>
           <p:cNvSpPr/>
           <p:nvPr/>
         </p:nvSpPr>
@@ -35072,14 +35089,14 @@
       </p:sp>
       <p:pic>
         <p:nvPicPr>
-          <p:cNvPr id="20" name="Image 2" descr="preencoded.png">    </p:cNvPr>
+          <p:cNvPr id="21" name="Image 2" descr="preencoded.png">    </p:cNvPr>
           <p:cNvPicPr>
             <a:picLocks noChangeAspect="1"/>
           </p:cNvPicPr>
           <p:nvPr/>
         </p:nvPicPr>
         <p:blipFill>
-          <a:blip r:embed="rId3"/>
+          <a:blip r:embed="rId4"/>
           <a:stretch>
             <a:fillRect/>
           </a:stretch>
@@ -35096,7 +35113,7 @@
       </p:pic>
       <p:sp>
         <p:nvSpPr>
-          <p:cNvPr id="21" name="Text 15"/>
+          <p:cNvPr id="22" name="Text 16"/>
           <p:cNvSpPr txBox="1"/>
           <p:nvPr/>
         </p:nvSpPr>
@@ -35129,9 +35146,6 @@
               </a:rPr>
               <a:t>Where to find it:  </a:t>
             </a:r>
-            <a:pPr indent="0" marL="0">
-              <a:buNone/>
-            </a:pPr>
             <a:r>
               <a:rPr lang="en-US" sz="1000" dirty="0">
                 <a:solidFill>
@@ -35861,6 +35875,26 @@
                 <a:cs typeface="SF Pro Text" pitchFamily="34" charset="-120"/>
               </a:rPr>
               <a:t>premium_surcharge</a:t>
+            </a:r>
+            <a:endParaRPr lang="en-US" sz="950" dirty="0"/>
+          </a:p>
+          <a:p>
+            <a:pPr indent="0" marL="0">
+              <a:spcAft>
+                <a:spcPts val="400"/>
+              </a:spcAft>
+              <a:buNone/>
+            </a:pPr>
+            <a:r>
+              <a:rPr lang="en-US" sz="850" b="1" dirty="0">
+                <a:solidFill>
+                  <a:srgbClr val="6E6E73"/>
+                </a:solidFill>
+                <a:latin typeface="SF Pro Text" pitchFamily="34" charset="0"/>
+                <a:ea typeface="SF Pro Text" pitchFamily="34" charset="-122"/>
+                <a:cs typeface="SF Pro Text" pitchFamily="34" charset="-120"/>
+              </a:rPr>
+              <a:t>(may include tax)</a:t>
             </a:r>
             <a:endParaRPr lang="en-US" sz="950" dirty="0"/>
           </a:p>
@@ -36835,17 +36869,6 @@
             <a:pPr algn="ctr" indent="0" marL="0">
               <a:buNone/>
             </a:pPr>
-            <a:r>
-              <a:rPr lang="en-US" sz="1000" b="1" dirty="0">
-                <a:solidFill>
-                  <a:srgbClr val="FFFFFF"/>
-                </a:solidFill>
-                <a:latin typeface="SF Pro Display" pitchFamily="34" charset="0"/>
-                <a:ea typeface="SF Pro Display" pitchFamily="34" charset="-122"/>
-                <a:cs typeface="SF Pro Display" pitchFamily="34" charset="-120"/>
-              </a:rPr>
-              <a:t>Switch the experience to Standard</a:t>
-            </a:r>
             <a:endParaRPr lang="en-US" sz="1000" dirty="0"/>
           </a:p>
         </p:txBody>
@@ -37122,7 +37145,87 @@
       </p:sp>
       <p:sp>
         <p:nvSpPr>
-          <p:cNvPr id="19" name="Shape 15"/>
+          <p:cNvPr id="19" name="Text 15"/>
+          <p:cNvSpPr txBox="1"/>
+          <p:nvPr/>
+        </p:nvSpPr>
+        <p:spPr>
+          <a:xfrm>
+            <a:off x="411480" y="2871216"/>
+            <a:ext cx="1965960" cy="274320"/>
+          </a:xfrm>
+          <a:prstGeom prst="rect">
+            <a:avLst/>
+          </a:prstGeom>
+          <a:noFill/>
+          <a:ln/>
+        </p:spPr>
+        <p:txBody>
+          <a:bodyPr wrap="square" lIns="0" tIns="0" rIns="0" bIns="0" rtlCol="0" anchor="b"/>
+          <a:lstStyle/>
+          <a:p>
+            <a:pPr algn="ctr" indent="0" marL="0">
+              <a:buNone/>
+            </a:pPr>
+            <a:r>
+              <a:rPr lang="en-US" sz="1000" b="1" dirty="0">
+                <a:solidFill>
+                  <a:srgbClr val="FFFFFF"/>
+                </a:solidFill>
+                <a:latin typeface="SF Pro Display" pitchFamily="34" charset="0"/>
+                <a:ea typeface="SF Pro Display" pitchFamily="34" charset="-122"/>
+                <a:cs typeface="SF Pro Display" pitchFamily="34" charset="-120"/>
+              </a:rPr>
+              <a:t>Switch to Standard</a:t>
+            </a:r>
+            <a:endParaRPr lang="en-US" sz="1000" dirty="0"/>
+          </a:p>
+        </p:txBody>
+      </p:sp>
+      <p:sp>
+        <p:nvSpPr>
+          <p:cNvPr id="20" name="keepU_watch">
+            <a:hlinkClick r:id="rId1" tooltip="Play: switching Premium to Standard"/>
+          </p:cNvPr>
+          <p:cNvSpPr/>
+          <p:nvPr/>
+        </p:nvSpPr>
+        <p:spPr>
+          <a:xfrm>
+            <a:off x="891540" y="3163824"/>
+            <a:ext cx="1005840" cy="182880"/>
+          </a:xfrm>
+          <a:prstGeom prst="rect">
+            <a:avLst/>
+          </a:prstGeom>
+          <a:noFill/>
+          <a:ln/>
+        </p:spPr>
+        <p:txBody>
+          <a:bodyPr wrap="square" lIns="0" tIns="0" rIns="0" bIns="0" rtlCol="0" anchor="ctr"/>
+          <a:lstStyle/>
+          <a:p>
+            <a:pPr algn="ctr" indent="0" marL="0">
+              <a:buNone/>
+            </a:pPr>
+            <a:r>
+              <a:rPr lang="en-US" sz="900" b="1" u="sng" dirty="0">
+                <a:solidFill>
+                  <a:srgbClr val="B6D7A8"/>
+                </a:solidFill>
+                <a:latin typeface="SF Pro Text" pitchFamily="34" charset="0"/>
+                <a:ea typeface="SF Pro Text" pitchFamily="34" charset="-122"/>
+                <a:cs typeface="SF Pro Text" pitchFamily="34" charset="-120"/>
+              </a:rPr>
+              <a:t>▷ watch &amp; learn</a:t>
+            </a:r>
+            <a:endParaRPr lang="en-US" sz="900" dirty="0"/>
+          </a:p>
+        </p:txBody>
+      </p:sp>
+      <p:sp>
+        <p:nvSpPr>
+          <p:cNvPr id="21" name="Shape 17"/>
           <p:cNvSpPr/>
           <p:nvPr/>
         </p:nvSpPr>
@@ -37149,14 +37252,14 @@
       </p:sp>
       <p:pic>
         <p:nvPicPr>
-          <p:cNvPr id="20" name="Image 0" descr="preencoded.png">    </p:cNvPr>
+          <p:cNvPr id="22" name="Image 0" descr="preencoded.png">    </p:cNvPr>
           <p:cNvPicPr>
             <a:picLocks noChangeAspect="1"/>
           </p:cNvPicPr>
           <p:nvPr/>
         </p:nvPicPr>
         <p:blipFill>
-          <a:blip r:embed="rId1"/>
+          <a:blip r:embed="rId2"/>
           <a:stretch>
             <a:fillRect/>
           </a:stretch>
@@ -37173,7 +37276,7 @@
       </p:pic>
       <p:sp>
         <p:nvSpPr>
-          <p:cNvPr id="21" name="Text 16"/>
+          <p:cNvPr id="23" name="Text 18"/>
           <p:cNvSpPr txBox="1"/>
           <p:nvPr/>
         </p:nvSpPr>
@@ -37206,9 +37309,6 @@
               </a:rPr>
               <a:t>Looks resolved?  </a:t>
             </a:r>
-            <a:pPr indent="0" marL="0">
-              <a:buNone/>
-            </a:pPr>
             <a:r>
               <a:rPr lang="en-US" sz="1000" dirty="0">
                 <a:solidFill>
@@ -39430,9 +39530,6 @@
               </a:rPr>
               <a:t>Questions?  </a:t>
             </a:r>
-            <a:pPr indent="0" marL="0">
-              <a:buNone/>
-            </a:pPr>
             <a:r>
               <a:rPr lang="en-US" sz="1100" dirty="0">
                 <a:solidFill>
@@ -40741,9 +40838,6 @@
               </a:rPr>
               <a:t>Usually contested because of  </a:t>
             </a:r>
-            <a:pPr indent="0" marL="0">
-              <a:buNone/>
-            </a:pPr>
             <a:r>
               <a:rPr lang="en-US" sz="1000" dirty="0">
                 <a:solidFill>
@@ -41497,9 +41591,6 @@
               </a:rPr>
               <a:t>Our error:  </a:t>
             </a:r>
-            <a:pPr indent="0" marL="0">
-              <a:buNone/>
-            </a:pPr>
             <a:r>
               <a:rPr lang="en-US" sz="1000" dirty="0">
                 <a:solidFill>
@@ -42233,9 +42324,6 @@
               </a:rPr>
               <a:t>Verify first:  </a:t>
             </a:r>
-            <a:pPr indent="0" marL="0">
-              <a:buNone/>
-            </a:pPr>
             <a:r>
               <a:rPr lang="en-US" sz="1000" dirty="0">
                 <a:solidFill>
@@ -42396,7 +42484,7 @@
                 <a:ea typeface="SF Pro Display" pitchFamily="34" charset="-122"/>
                 <a:cs typeface="SF Pro Display" pitchFamily="34" charset="-120"/>
               </a:rPr>
-              <a:t>Choose the resolution</a:t>
+              <a:t>Decision flow</a:t>
             </a:r>
             <a:endParaRPr lang="en-US" sz="2400" dirty="0"/>
           </a:p>
@@ -42435,7 +42523,7 @@
                 <a:ea typeface="SF Pro Text" pitchFamily="34" charset="-122"/>
                 <a:cs typeface="SF Pro Text" pitchFamily="34" charset="-120"/>
               </a:rPr>
-              <a:t>Based on why they're contesting it, not just that they are.</a:t>
+              <a:t>If the customer is contesting the charge.</a:t>
             </a:r>
             <a:endParaRPr lang="en-US" sz="1200" dirty="0"/>
           </a:p>
@@ -42443,18 +42531,18 @@
       </p:sp>
       <p:sp>
         <p:nvSpPr>
-          <p:cNvPr id="6" name="Shape 3"/>
+          <p:cNvPr id="6" name="Text 3"/>
           <p:cNvSpPr/>
           <p:nvPr/>
         </p:nvSpPr>
         <p:spPr>
           <a:xfrm>
-            <a:off x="2468880" y="1298448"/>
-            <a:ext cx="4206240" cy="402336"/>
+            <a:off x="2651760" y="1280160"/>
+            <a:ext cx="3840480" cy="384048"/>
           </a:xfrm>
           <a:prstGeom prst="roundRect">
             <a:avLst>
-              <a:gd name="adj" fmla="val 18182"/>
+              <a:gd name="adj" fmla="val 19048"/>
             </a:avLst>
           </a:prstGeom>
           <a:solidFill>
@@ -42464,27 +42552,8 @@
             <a:solidFill>
               <a:srgbClr val="9A6410"/>
             </a:solidFill>
-            <a:prstDash val="solid"/>
           </a:ln>
         </p:spPr>
-      </p:sp>
-      <p:sp>
-        <p:nvSpPr>
-          <p:cNvPr id="7" name="Text 4"/>
-          <p:cNvSpPr txBox="1"/>
-          <p:nvPr/>
-        </p:nvSpPr>
-        <p:spPr>
-          <a:xfrm>
-            <a:off x="2468880" y="1298448"/>
-            <a:ext cx="4206240" cy="402336"/>
-          </a:xfrm>
-          <a:prstGeom prst="rect">
-            <a:avLst/>
-          </a:prstGeom>
-          <a:noFill/>
-          <a:ln/>
-        </p:spPr>
         <p:txBody>
           <a:bodyPr wrap="square" lIns="0" tIns="0" rIns="0" bIns="0" rtlCol="0" anchor="ctr"/>
           <a:lstStyle/>
@@ -42493,7 +42562,7 @@
               <a:buNone/>
             </a:pPr>
             <a:r>
-              <a:rPr lang="en-US" sz="1000" b="1" dirty="0">
+              <a:rPr lang="en-US" sz="1100" b="1" dirty="0">
                 <a:solidFill>
                   <a:srgbClr val="9A6410"/>
                 </a:solidFill>
@@ -42501,22 +42570,22 @@
                 <a:ea typeface="SF Pro Display" pitchFamily="34" charset="-122"/>
                 <a:cs typeface="SF Pro Display" pitchFamily="34" charset="-120"/>
               </a:rPr>
-              <a:t>Did Homeaglow set expectations properly?</a:t>
-            </a:r>
-            <a:endParaRPr lang="en-US" sz="1000" dirty="0"/>
-          </a:p>
-        </p:txBody>
-      </p:sp>
-      <p:sp>
-        <p:nvSpPr>
-          <p:cNvPr id="8" name="Shape 5"/>
+              <a:t>Why is the customer contesting the fee?</a:t>
+            </a:r>
+            <a:endParaRPr lang="en-US" sz="1100" dirty="0"/>
+          </a:p>
+        </p:txBody>
+      </p:sp>
+      <p:sp>
+        <p:nvSpPr>
+          <p:cNvPr id="7" name="Shape 4"/>
           <p:cNvSpPr/>
           <p:nvPr/>
         </p:nvSpPr>
         <p:spPr>
           <a:xfrm>
-            <a:off x="4572000" y="1700784"/>
-            <a:ext cx="0" cy="128016"/>
+            <a:off x="4572000" y="1664208"/>
+            <a:ext cx="0" cy="146304"/>
           </a:xfrm>
           <a:prstGeom prst="line">
             <a:avLst/>
@@ -42532,14 +42601,14 @@
       </p:sp>
       <p:sp>
         <p:nvSpPr>
-          <p:cNvPr id="9" name="Shape 6"/>
+          <p:cNvPr id="8" name="Shape 5"/>
           <p:cNvSpPr/>
           <p:nvPr/>
         </p:nvSpPr>
         <p:spPr>
           <a:xfrm>
-            <a:off x="2331720" y="1828800"/>
-            <a:ext cx="4480560" cy="0"/>
+            <a:off x="2423160" y="1810512"/>
+            <a:ext cx="4297680" cy="0"/>
           </a:xfrm>
           <a:prstGeom prst="line">
             <a:avLst/>
@@ -42555,13 +42624,13 @@
       </p:sp>
       <p:sp>
         <p:nvSpPr>
-          <p:cNvPr id="10" name="Shape 7"/>
+          <p:cNvPr id="9" name="Shape 6"/>
           <p:cNvSpPr/>
           <p:nvPr/>
         </p:nvSpPr>
         <p:spPr>
           <a:xfrm>
-            <a:off x="2331720" y="1828800"/>
+            <a:off x="2423160" y="1810512"/>
             <a:ext cx="0" cy="128016"/>
           </a:xfrm>
           <a:prstGeom prst="line">
@@ -42579,13 +42648,13 @@
       </p:sp>
       <p:sp>
         <p:nvSpPr>
-          <p:cNvPr id="11" name="Shape 8"/>
+          <p:cNvPr id="10" name="Shape 7"/>
           <p:cNvSpPr/>
           <p:nvPr/>
         </p:nvSpPr>
         <p:spPr>
           <a:xfrm>
-            <a:off x="6812280" y="1828800"/>
+            <a:off x="6720840" y="1810512"/>
             <a:ext cx="0" cy="128016"/>
           </a:xfrm>
           <a:prstGeom prst="line">
@@ -42603,13 +42672,41 @@
       </p:sp>
       <p:sp>
         <p:nvSpPr>
+          <p:cNvPr id="11" name="Text 8"/>
+          <p:cNvSpPr txBox="1"/>
+          <p:nvPr/>
+        </p:nvSpPr>
+        <p:spPr>
+          <a:xfrm>
+            <a:off x="2496312" y="1828800"/>
+            <a:ext cx="548640" cy="201168"/>
+          </a:xfrm>
+          <a:prstGeom prst="rect">
+            <a:avLst/>
+          </a:prstGeom>
+          <a:noFill/>
+          <a:ln/>
+        </p:spPr>
+        <p:txBody>
+          <a:bodyPr wrap="square" lIns="0" tIns="0" rIns="0" bIns="0" rtlCol="0" anchor="t"/>
+          <a:lstStyle/>
+          <a:p>
+            <a:pPr indent="0" marL="0">
+              <a:buNone/>
+            </a:pPr>
+            <a:endParaRPr lang="en-US" sz="850" dirty="0"/>
+          </a:p>
+        </p:txBody>
+      </p:sp>
+      <p:sp>
+        <p:nvSpPr>
           <p:cNvPr id="12" name="Text 9"/>
           <p:cNvSpPr txBox="1"/>
           <p:nvPr/>
         </p:nvSpPr>
         <p:spPr>
           <a:xfrm>
-            <a:off x="2404872" y="1847088"/>
+            <a:off x="6793992" y="1828800"/>
             <a:ext cx="548640" cy="201168"/>
           </a:xfrm>
           <a:prstGeom prst="rect">
@@ -42632,213 +42729,17 @@
       <p:sp>
         <p:nvSpPr>
           <p:cNvPr id="13" name="Text 10"/>
-          <p:cNvSpPr txBox="1"/>
-          <p:nvPr/>
-        </p:nvSpPr>
-        <p:spPr>
-          <a:xfrm>
-            <a:off x="6885432" y="1847088"/>
-            <a:ext cx="548640" cy="201168"/>
-          </a:xfrm>
-          <a:prstGeom prst="rect">
-            <a:avLst/>
-          </a:prstGeom>
-          <a:noFill/>
-          <a:ln/>
-        </p:spPr>
-        <p:txBody>
-          <a:bodyPr wrap="square" lIns="0" tIns="0" rIns="0" bIns="0" rtlCol="0" anchor="t"/>
-          <a:lstStyle/>
-          <a:p>
-            <a:pPr indent="0" marL="0">
-              <a:buNone/>
-            </a:pPr>
-            <a:endParaRPr lang="en-US" sz="850" dirty="0"/>
-          </a:p>
-        </p:txBody>
-      </p:sp>
-      <p:sp>
-        <p:nvSpPr>
-          <p:cNvPr id="14" name="Text 11"/>
-          <p:cNvSpPr txBox="1"/>
-          <p:nvPr/>
-        </p:nvSpPr>
-        <p:spPr>
-          <a:xfrm>
-            <a:off x="2404872" y="1828800"/>
-            <a:ext cx="1645920" cy="128016"/>
-          </a:xfrm>
-          <a:prstGeom prst="rect">
-            <a:avLst/>
-          </a:prstGeom>
-          <a:noFill/>
-          <a:ln/>
-        </p:spPr>
-        <p:txBody>
-          <a:bodyPr wrap="square" lIns="0" tIns="0" rIns="0" bIns="0" rtlCol="0" anchor="t"/>
-          <a:lstStyle/>
-          <a:p>
-            <a:pPr indent="0" marL="0">
-              <a:buNone/>
-            </a:pPr>
-            <a:r>
-              <a:rPr lang="en-US" sz="800" b="1" dirty="0">
-                <a:solidFill>
-                  <a:srgbClr val="6E6E73"/>
-                </a:solidFill>
-                <a:latin typeface="SF Pro Text" pitchFamily="34" charset="0"/>
-                <a:ea typeface="SF Pro Text" pitchFamily="34" charset="-122"/>
-                <a:cs typeface="SF Pro Text" pitchFamily="34" charset="-120"/>
-              </a:rPr>
-              <a:t>Yes: expectation gap</a:t>
-            </a:r>
-            <a:endParaRPr lang="en-US" sz="800" dirty="0"/>
-          </a:p>
-        </p:txBody>
-      </p:sp>
-      <p:sp>
-        <p:nvSpPr>
-          <p:cNvPr id="15" name="Text 12"/>
-          <p:cNvSpPr txBox="1"/>
-          <p:nvPr/>
-        </p:nvSpPr>
-        <p:spPr>
-          <a:xfrm>
-            <a:off x="6885432" y="1828800"/>
-            <a:ext cx="1645920" cy="128016"/>
-          </a:xfrm>
-          <a:prstGeom prst="rect">
-            <a:avLst/>
-          </a:prstGeom>
-          <a:noFill/>
-          <a:ln/>
-        </p:spPr>
-        <p:txBody>
-          <a:bodyPr wrap="square" lIns="0" tIns="0" rIns="0" bIns="0" rtlCol="0" anchor="t"/>
-          <a:lstStyle/>
-          <a:p>
-            <a:pPr indent="0" marL="0">
-              <a:buNone/>
-            </a:pPr>
-            <a:r>
-              <a:rPr lang="en-US" sz="800" b="1" dirty="0">
-                <a:solidFill>
-                  <a:srgbClr val="6E6E73"/>
-                </a:solidFill>
-                <a:latin typeface="SF Pro Text" pitchFamily="34" charset="0"/>
-                <a:ea typeface="SF Pro Text" pitchFamily="34" charset="-122"/>
-                <a:cs typeface="SF Pro Text" pitchFamily="34" charset="-120"/>
-              </a:rPr>
-              <a:t>No: we failed to</a:t>
-            </a:r>
-            <a:endParaRPr lang="en-US" sz="800" dirty="0"/>
-          </a:p>
-        </p:txBody>
-      </p:sp>
-      <p:sp>
-        <p:nvSpPr>
-          <p:cNvPr id="16" name="Shape 13"/>
           <p:cNvSpPr/>
           <p:nvPr/>
         </p:nvSpPr>
         <p:spPr>
           <a:xfrm>
-            <a:off x="411480" y="1956816"/>
-            <a:ext cx="3840480" cy="420624"/>
+            <a:off x="411480" y="1938528"/>
+            <a:ext cx="4023360" cy="329184"/>
           </a:xfrm>
           <a:prstGeom prst="roundRect">
             <a:avLst>
-              <a:gd name="adj" fmla="val 17391"/>
-            </a:avLst>
-          </a:prstGeom>
-          <a:solidFill>
-            <a:srgbClr val="FFFFFF"/>
-          </a:solidFill>
-          <a:ln w="12700">
-            <a:solidFill>
-              <a:srgbClr val="DCE1E7"/>
-            </a:solidFill>
-            <a:prstDash val="solid"/>
-          </a:ln>
-        </p:spPr>
-      </p:sp>
-      <p:sp>
-        <p:nvSpPr>
-          <p:cNvPr id="17" name="Text 14"/>
-          <p:cNvSpPr txBox="1"/>
-          <p:nvPr/>
-        </p:nvSpPr>
-        <p:spPr>
-          <a:xfrm>
-            <a:off x="411480" y="1956816"/>
-            <a:ext cx="3840480" cy="420624"/>
-          </a:xfrm>
-          <a:prstGeom prst="rect">
-            <a:avLst/>
-          </a:prstGeom>
-          <a:noFill/>
-          <a:ln/>
-        </p:spPr>
-        <p:txBody>
-          <a:bodyPr wrap="square" lIns="0" tIns="0" rIns="0" bIns="0" rtlCol="0" anchor="ctr"/>
-          <a:lstStyle/>
-          <a:p>
-            <a:pPr algn="ctr" indent="0" marL="0">
-              <a:buNone/>
-            </a:pPr>
-            <a:r>
-              <a:rPr lang="en-US" sz="1000" b="1" dirty="0">
-                <a:solidFill>
-                  <a:srgbClr val="1D1D1F"/>
-                </a:solidFill>
-                <a:latin typeface="SF Pro Display" pitchFamily="34" charset="0"/>
-                <a:ea typeface="SF Pro Display" pitchFamily="34" charset="-122"/>
-                <a:cs typeface="SF Pro Display" pitchFamily="34" charset="-120"/>
-              </a:rPr>
-              <a:t>Explain: a standard charge on every cleaning</a:t>
-            </a:r>
-            <a:endParaRPr lang="en-US" sz="1000" dirty="0"/>
-          </a:p>
-        </p:txBody>
-      </p:sp>
-      <p:sp>
-        <p:nvSpPr>
-          <p:cNvPr id="18" name="Shape 15"/>
-          <p:cNvSpPr/>
-          <p:nvPr/>
-        </p:nvSpPr>
-        <p:spPr>
-          <a:xfrm>
-            <a:off x="2331720" y="2377440"/>
-            <a:ext cx="0" cy="128016"/>
-          </a:xfrm>
-          <a:prstGeom prst="line">
-            <a:avLst/>
-          </a:prstGeom>
-          <a:noFill/>
-          <a:ln w="12700">
-            <a:solidFill>
-              <a:srgbClr val="6E6E73"/>
-            </a:solidFill>
-            <a:prstDash val="solid"/>
-            <a:tailEnd type="triangle"/>
-          </a:ln>
-        </p:spPr>
-      </p:sp>
-      <p:sp>
-        <p:nvSpPr>
-          <p:cNvPr id="19" name="Shape 16"/>
-          <p:cNvSpPr/>
-          <p:nvPr/>
-        </p:nvSpPr>
-        <p:spPr>
-          <a:xfrm>
-            <a:off x="411480" y="2505456"/>
-            <a:ext cx="3840480" cy="420624"/>
-          </a:xfrm>
-          <a:prstGeom prst="roundRect">
-            <a:avLst>
-              <a:gd name="adj" fmla="val 17391"/>
+              <a:gd name="adj" fmla="val 16667"/>
             </a:avLst>
           </a:prstGeom>
           <a:solidFill>
@@ -42848,27 +42749,8 @@
             <a:solidFill>
               <a:srgbClr val="0B7A6F"/>
             </a:solidFill>
-            <a:prstDash val="solid"/>
           </a:ln>
         </p:spPr>
-      </p:sp>
-      <p:sp>
-        <p:nvSpPr>
-          <p:cNvPr id="20" name="Text 17"/>
-          <p:cNvSpPr txBox="1"/>
-          <p:nvPr/>
-        </p:nvSpPr>
-        <p:spPr>
-          <a:xfrm>
-            <a:off x="411480" y="2505456"/>
-            <a:ext cx="3840480" cy="420624"/>
-          </a:xfrm>
-          <a:prstGeom prst="rect">
-            <a:avLst/>
-          </a:prstGeom>
-          <a:noFill/>
-          <a:ln/>
-        </p:spPr>
         <p:txBody>
           <a:bodyPr wrap="square" lIns="0" tIns="0" rIns="0" bIns="0" rtlCol="0" anchor="ctr"/>
           <a:lstStyle/>
@@ -42877,7 +42759,7 @@
               <a:buNone/>
             </a:pPr>
             <a:r>
-              <a:rPr lang="en-US" sz="1000" b="1" dirty="0">
+              <a:rPr lang="en-US" sz="1050" b="1" dirty="0">
                 <a:solidFill>
                   <a:srgbClr val="FFFFFF"/>
                 </a:solidFill>
@@ -42885,56 +42767,79 @@
                 <a:ea typeface="SF Pro Display" pitchFamily="34" charset="-122"/>
                 <a:cs typeface="SF Pro Display" pitchFamily="34" charset="-120"/>
               </a:rPr>
-              <a:t>Still unhappy, staying? One-time $10 or $20 credit</a:t>
-            </a:r>
-            <a:endParaRPr lang="en-US" sz="1000" dirty="0"/>
-          </a:p>
-        </p:txBody>
-      </p:sp>
-      <p:sp>
-        <p:nvSpPr>
-          <p:cNvPr id="21" name="Shape 18"/>
+              <a:t>Homeaglow properly disclosed the fee</a:t>
+            </a:r>
+            <a:endParaRPr lang="en-US" sz="1050" dirty="0"/>
+          </a:p>
+        </p:txBody>
+      </p:sp>
+      <p:sp>
+        <p:nvSpPr>
+          <p:cNvPr id="14" name="Text 11"/>
           <p:cNvSpPr/>
           <p:nvPr/>
         </p:nvSpPr>
         <p:spPr>
           <a:xfrm>
-            <a:off x="2331720" y="2926080"/>
-            <a:ext cx="0" cy="128016"/>
-          </a:xfrm>
-          <a:prstGeom prst="line">
-            <a:avLst/>
-          </a:prstGeom>
-          <a:noFill/>
+            <a:off x="4709160" y="1938528"/>
+            <a:ext cx="4023360" cy="329184"/>
+          </a:xfrm>
+          <a:prstGeom prst="roundRect">
+            <a:avLst>
+              <a:gd name="adj" fmla="val 16667"/>
+            </a:avLst>
+          </a:prstGeom>
+          <a:solidFill>
+            <a:srgbClr val="B3261E"/>
+          </a:solidFill>
           <a:ln w="12700">
             <a:solidFill>
-              <a:srgbClr val="6E6E73"/>
+              <a:srgbClr val="B3261E"/>
             </a:solidFill>
-            <a:prstDash val="solid"/>
-            <a:tailEnd type="triangle"/>
           </a:ln>
         </p:spPr>
-      </p:sp>
-      <p:sp>
-        <p:nvSpPr>
-          <p:cNvPr id="22" name="Shape 19"/>
+        <p:txBody>
+          <a:bodyPr wrap="square" lIns="0" tIns="0" rIns="0" bIns="0" rtlCol="0" anchor="ctr"/>
+          <a:lstStyle/>
+          <a:p>
+            <a:pPr algn="ctr" indent="0" marL="0">
+              <a:buNone/>
+            </a:pPr>
+            <a:r>
+              <a:rPr lang="en-US" sz="1050" b="1" dirty="0">
+                <a:solidFill>
+                  <a:srgbClr val="FFFFFF"/>
+                </a:solidFill>
+                <a:latin typeface="SF Pro Display" pitchFamily="34" charset="0"/>
+                <a:ea typeface="SF Pro Display" pitchFamily="34" charset="-122"/>
+                <a:cs typeface="SF Pro Display" pitchFamily="34" charset="-120"/>
+              </a:rPr>
+              <a:t>Homeaglow failed to set proper expectations</a:t>
+            </a:r>
+            <a:endParaRPr lang="en-US" sz="1050" dirty="0"/>
+          </a:p>
+        </p:txBody>
+      </p:sp>
+      <p:sp>
+        <p:nvSpPr>
+          <p:cNvPr id="15" name="Shape 12"/>
           <p:cNvSpPr/>
           <p:nvPr/>
         </p:nvSpPr>
         <p:spPr>
           <a:xfrm>
-            <a:off x="411480" y="3054096"/>
-            <a:ext cx="3840480" cy="420624"/>
+            <a:off x="411480" y="2340864"/>
+            <a:ext cx="4023360" cy="1975104"/>
           </a:xfrm>
           <a:prstGeom prst="roundRect">
             <a:avLst>
-              <a:gd name="adj" fmla="val 17391"/>
+              <a:gd name="adj" fmla="val 3704"/>
             </a:avLst>
           </a:prstGeom>
           <a:solidFill>
-            <a:srgbClr val="0B7A6F"/>
+            <a:srgbClr val="E3F4F1"/>
           </a:solidFill>
-          <a:ln w="12700">
+          <a:ln w="9525">
             <a:solidFill>
               <a:srgbClr val="0B7A6F"/>
             </a:solidFill>
@@ -42944,14 +42849,41 @@
       </p:sp>
       <p:sp>
         <p:nvSpPr>
-          <p:cNvPr id="23" name="Text 20"/>
+          <p:cNvPr id="16" name="Shape 13"/>
+          <p:cNvSpPr/>
+          <p:nvPr/>
+        </p:nvSpPr>
+        <p:spPr>
+          <a:xfrm>
+            <a:off x="4709160" y="2340864"/>
+            <a:ext cx="4023360" cy="1975104"/>
+          </a:xfrm>
+          <a:prstGeom prst="roundRect">
+            <a:avLst>
+              <a:gd name="adj" fmla="val 3704"/>
+            </a:avLst>
+          </a:prstGeom>
+          <a:solidFill>
+            <a:srgbClr val="FCEBEA"/>
+          </a:solidFill>
+          <a:ln w="9525">
+            <a:solidFill>
+              <a:srgbClr val="B3261E"/>
+            </a:solidFill>
+            <a:prstDash val="solid"/>
+          </a:ln>
+        </p:spPr>
+      </p:sp>
+      <p:sp>
+        <p:nvSpPr>
+          <p:cNvPr id="17" name="step1Item"/>
           <p:cNvSpPr txBox="1"/>
           <p:nvPr/>
         </p:nvSpPr>
         <p:spPr>
           <a:xfrm>
-            <a:off x="411480" y="3054096"/>
-            <a:ext cx="3840480" cy="420624"/>
+            <a:off x="594360" y="2450592"/>
+            <a:ext cx="3657600" cy="457200"/>
           </a:xfrm>
           <a:prstGeom prst="rect">
             <a:avLst/>
@@ -42960,64 +42892,65 @@
           <a:ln/>
         </p:spPr>
         <p:txBody>
-          <a:bodyPr wrap="square" lIns="0" tIns="0" rIns="0" bIns="0" rtlCol="0" anchor="ctr"/>
-          <a:lstStyle/>
-          <a:p>
-            <a:pPr algn="ctr" indent="0" marL="0">
+          <a:bodyPr wrap="square" lIns="0" tIns="0" rIns="0" bIns="0" rtlCol="0" anchor="t"/>
+          <a:lstStyle/>
+          <a:p>
+            <a:pPr indent="0" marL="0">
               <a:buNone/>
             </a:pPr>
             <a:r>
               <a:rPr lang="en-US" sz="1000" b="1" dirty="0">
                 <a:solidFill>
-                  <a:srgbClr val="FFFFFF"/>
+                  <a:srgbClr val="1D1D1F"/>
                 </a:solidFill>
                 <a:latin typeface="SF Pro Display" pitchFamily="34" charset="0"/>
                 <a:ea typeface="SF Pro Display" pitchFamily="34" charset="-122"/>
                 <a:cs typeface="SF Pro Display" pitchFamily="34" charset="-120"/>
               </a:rPr>
-              <a:t>Wants cash or will cancel? $10 or $20 partial refund</a:t>
+              <a:t>1.  Wants to keep membership</a:t>
             </a:r>
             <a:endParaRPr lang="en-US" sz="1000" dirty="0"/>
           </a:p>
-        </p:txBody>
-      </p:sp>
-      <p:sp>
-        <p:nvSpPr>
-          <p:cNvPr id="24" name="Shape 21"/>
-          <p:cNvSpPr/>
-          <p:nvPr/>
-        </p:nvSpPr>
-        <p:spPr>
-          <a:xfrm>
-            <a:off x="4892040" y="1956816"/>
-            <a:ext cx="3840480" cy="420624"/>
-          </a:xfrm>
-          <a:prstGeom prst="roundRect">
-            <a:avLst>
-              <a:gd name="adj" fmla="val 17391"/>
-            </a:avLst>
-          </a:prstGeom>
-          <a:solidFill>
-            <a:srgbClr val="0B7A6F"/>
-          </a:solidFill>
-          <a:ln w="12700">
-            <a:solidFill>
-              <a:srgbClr val="0B7A6F"/>
-            </a:solidFill>
-            <a:prstDash val="solid"/>
-          </a:ln>
-        </p:spPr>
-      </p:sp>
-      <p:sp>
-        <p:nvSpPr>
-          <p:cNvPr id="25" name="Text 22"/>
+          <a:p>
+            <a:pPr indent="0" marL="0">
+              <a:buNone/>
+            </a:pPr>
+            <a:r>
+              <a:rPr lang="en-US" sz="1000" b="1" dirty="0">
+                <a:solidFill>
+                  <a:srgbClr val="0B7A6F"/>
+                </a:solidFill>
+                <a:latin typeface="SF Pro Text" pitchFamily="34" charset="0"/>
+                <a:ea typeface="SF Pro Text" pitchFamily="34" charset="-122"/>
+                <a:cs typeface="SF Pro Text" pitchFamily="34" charset="-120"/>
+              </a:rPr>
+              <a:t>→  </a:t>
+            </a:r>
+            <a:r>
+              <a:rPr lang="en-US" sz="1000" dirty="0">
+                <a:solidFill>
+                  <a:srgbClr val="1D1D1F"/>
+                </a:solidFill>
+                <a:latin typeface="SF Pro Text" pitchFamily="34" charset="0"/>
+                <a:ea typeface="SF Pro Text" pitchFamily="34" charset="-122"/>
+                <a:cs typeface="SF Pro Text" pitchFamily="34" charset="-120"/>
+              </a:rPr>
+              <a:t>Explain the fee + $10–$20 goodwill credit</a:t>
+            </a:r>
+            <a:endParaRPr lang="en-US" sz="1000" dirty="0"/>
+          </a:p>
+        </p:txBody>
+      </p:sp>
+      <p:sp>
+        <p:nvSpPr>
+          <p:cNvPr id="18" name="step2Item"/>
           <p:cNvSpPr txBox="1"/>
           <p:nvPr/>
         </p:nvSpPr>
         <p:spPr>
           <a:xfrm>
-            <a:off x="4892040" y="1956816"/>
-            <a:ext cx="3840480" cy="420624"/>
+            <a:off x="594360" y="2999232"/>
+            <a:ext cx="3657600" cy="457200"/>
           </a:xfrm>
           <a:prstGeom prst="rect">
             <a:avLst/>
@@ -43026,105 +42959,132 @@
           <a:ln/>
         </p:spPr>
         <p:txBody>
-          <a:bodyPr wrap="square" lIns="0" tIns="0" rIns="0" bIns="0" rtlCol="0" anchor="ctr"/>
-          <a:lstStyle/>
-          <a:p>
-            <a:pPr algn="ctr" indent="0" marL="0">
+          <a:bodyPr wrap="square" lIns="0" tIns="0" rIns="0" bIns="0" rtlCol="0" anchor="t"/>
+          <a:lstStyle/>
+          <a:p>
+            <a:pPr indent="0" marL="0">
               <a:buNone/>
             </a:pPr>
             <a:r>
               <a:rPr lang="en-US" sz="1000" b="1" dirty="0">
                 <a:solidFill>
-                  <a:srgbClr val="FFFFFF"/>
+                  <a:srgbClr val="1D1D1F"/>
                 </a:solidFill>
                 <a:latin typeface="SF Pro Display" pitchFamily="34" charset="0"/>
                 <a:ea typeface="SF Pro Display" pitchFamily="34" charset="-122"/>
                 <a:cs typeface="SF Pro Display" pitchFamily="34" charset="-120"/>
               </a:rPr>
-              <a:t>Refund the Processing Fee in full</a:t>
+              <a:t>2.  Wants a cash refund, or may cancel</a:t>
             </a:r>
             <a:endParaRPr lang="en-US" sz="1000" dirty="0"/>
           </a:p>
           <a:p>
-            <a:pPr algn="ctr" indent="0" marL="0">
+            <a:pPr indent="0" marL="0">
               <a:buNone/>
             </a:pPr>
             <a:r>
               <a:rPr lang="en-US" sz="1000" b="1" dirty="0">
                 <a:solidFill>
-                  <a:srgbClr val="FFFFFF"/>
+                  <a:srgbClr val="0B7A6F"/>
+                </a:solidFill>
+                <a:latin typeface="SF Pro Text" pitchFamily="34" charset="0"/>
+                <a:ea typeface="SF Pro Text" pitchFamily="34" charset="-122"/>
+                <a:cs typeface="SF Pro Text" pitchFamily="34" charset="-120"/>
+              </a:rPr>
+              <a:t>→  </a:t>
+            </a:r>
+            <a:r>
+              <a:rPr lang="en-US" sz="1000" dirty="0">
+                <a:solidFill>
+                  <a:srgbClr val="1D1D1F"/>
+                </a:solidFill>
+                <a:latin typeface="SF Pro Text" pitchFamily="34" charset="0"/>
+                <a:ea typeface="SF Pro Text" pitchFamily="34" charset="-122"/>
+                <a:cs typeface="SF Pro Text" pitchFamily="34" charset="-120"/>
+              </a:rPr>
+              <a:t>Explain the fee + $10–$20 partial refund</a:t>
+            </a:r>
+            <a:endParaRPr lang="en-US" sz="1000" dirty="0"/>
+          </a:p>
+        </p:txBody>
+      </p:sp>
+      <p:sp>
+        <p:nvSpPr>
+          <p:cNvPr id="19" name="step3Item"/>
+          <p:cNvSpPr txBox="1"/>
+          <p:nvPr/>
+        </p:nvSpPr>
+        <p:spPr>
+          <a:xfrm>
+            <a:off x="594360" y="3547872"/>
+            <a:ext cx="3657600" cy="457200"/>
+          </a:xfrm>
+          <a:prstGeom prst="rect">
+            <a:avLst/>
+          </a:prstGeom>
+          <a:noFill/>
+          <a:ln/>
+        </p:spPr>
+        <p:txBody>
+          <a:bodyPr wrap="square" lIns="0" tIns="0" rIns="0" bIns="0" rtlCol="0" anchor="t"/>
+          <a:lstStyle/>
+          <a:p>
+            <a:pPr indent="0" marL="0">
+              <a:buNone/>
+            </a:pPr>
+            <a:r>
+              <a:rPr lang="en-US" sz="1000" b="1" dirty="0">
+                <a:solidFill>
+                  <a:srgbClr val="1D1D1F"/>
                 </a:solidFill>
                 <a:latin typeface="SF Pro Display" pitchFamily="34" charset="0"/>
                 <a:ea typeface="SF Pro Display" pitchFamily="34" charset="-122"/>
                 <a:cs typeface="SF Pro Display" pitchFamily="34" charset="-120"/>
               </a:rPr>
-              <a:t>to the original payment method</a:t>
+              <a:t>3.  Objects to future fees</a:t>
             </a:r>
             <a:endParaRPr lang="en-US" sz="1000" dirty="0"/>
           </a:p>
-        </p:txBody>
-      </p:sp>
-      <p:sp>
-        <p:nvSpPr>
-          <p:cNvPr id="26" name="Shape 23"/>
-          <p:cNvSpPr/>
-          <p:nvPr/>
-        </p:nvSpPr>
-        <p:spPr>
-          <a:xfrm>
-            <a:off x="6812280" y="2377440"/>
-            <a:ext cx="0" cy="128016"/>
-          </a:xfrm>
-          <a:prstGeom prst="line">
-            <a:avLst/>
-          </a:prstGeom>
-          <a:noFill/>
-          <a:ln w="12700">
-            <a:solidFill>
-              <a:srgbClr val="6E6E73"/>
-            </a:solidFill>
-            <a:prstDash val="solid"/>
-            <a:tailEnd type="triangle"/>
-          </a:ln>
-        </p:spPr>
-      </p:sp>
-      <p:sp>
-        <p:nvSpPr>
-          <p:cNvPr id="27" name="Shape 24"/>
-          <p:cNvSpPr/>
-          <p:nvPr/>
-        </p:nvSpPr>
-        <p:spPr>
-          <a:xfrm>
-            <a:off x="4892040" y="2505456"/>
-            <a:ext cx="3840480" cy="420624"/>
-          </a:xfrm>
-          <a:prstGeom prst="roundRect">
-            <a:avLst>
-              <a:gd name="adj" fmla="val 17391"/>
-            </a:avLst>
-          </a:prstGeom>
-          <a:solidFill>
-            <a:srgbClr val="FFFFFF"/>
-          </a:solidFill>
-          <a:ln w="12700">
-            <a:solidFill>
-              <a:srgbClr val="DCE1E7"/>
-            </a:solidFill>
-            <a:prstDash val="solid"/>
-          </a:ln>
-        </p:spPr>
-      </p:sp>
-      <p:sp>
-        <p:nvSpPr>
-          <p:cNvPr id="28" name="Text 25"/>
+          <a:p>
+            <a:pPr indent="0" marL="0">
+              <a:buNone/>
+            </a:pPr>
+            <a:r>
+              <a:rPr lang="en-US" sz="1000" b="1" dirty="0">
+                <a:solidFill>
+                  <a:srgbClr val="0B7A6F"/>
+                </a:solidFill>
+                <a:latin typeface="SF Pro Text" pitchFamily="34" charset="0"/>
+                <a:ea typeface="SF Pro Text" pitchFamily="34" charset="-122"/>
+                <a:cs typeface="SF Pro Text" pitchFamily="34" charset="-120"/>
+              </a:rPr>
+              <a:t>→  </a:t>
+            </a:r>
+            <a:r>
+              <a:rPr lang="en-US" sz="1000" dirty="0">
+                <a:solidFill>
+                  <a:srgbClr val="1D1D1F"/>
+                </a:solidFill>
+                <a:latin typeface="SF Pro Text" pitchFamily="34" charset="0"/>
+                <a:ea typeface="SF Pro Text" pitchFamily="34" charset="-122"/>
+                <a:cs typeface="SF Pro Text" pitchFamily="34" charset="-120"/>
+              </a:rPr>
+              <a:t>$10–$15 MF reduction (up to 50% via TL)</a:t>
+            </a:r>
+            <a:endParaRPr lang="en-US" sz="1000" dirty="0"/>
+          </a:p>
+        </p:txBody>
+      </p:sp>
+      <p:sp>
+        <p:nvSpPr>
+          <p:cNvPr id="20" name="step3Never"/>
           <p:cNvSpPr txBox="1"/>
           <p:nvPr/>
         </p:nvSpPr>
         <p:spPr>
           <a:xfrm>
-            <a:off x="4892040" y="2505456"/>
-            <a:ext cx="3840480" cy="420624"/>
+            <a:off x="594360" y="4023360"/>
+            <a:ext cx="3657600" cy="201168"/>
           </a:xfrm>
           <a:prstGeom prst="rect">
             <a:avLst/>
@@ -43133,12 +43093,62 @@
           <a:ln/>
         </p:spPr>
         <p:txBody>
-          <a:bodyPr wrap="square" lIns="0" tIns="0" rIns="0" bIns="0" rtlCol="0" anchor="ctr"/>
-          <a:lstStyle/>
-          <a:p>
-            <a:pPr algn="ctr" indent="0" marL="0">
-              <a:buNone/>
-            </a:pPr>
+          <a:bodyPr wrap="square" lIns="0" tIns="0" rIns="0" bIns="0" rtlCol="0" anchor="t"/>
+          <a:lstStyle/>
+          <a:p>
+            <a:pPr indent="0" marL="0">
+              <a:buNone/>
+            </a:pPr>
+            <a:r>
+              <a:rPr lang="en-US" sz="900" b="1" dirty="0">
+                <a:solidFill>
+                  <a:srgbClr val="6E6E73"/>
+                </a:solidFill>
+                <a:latin typeface="SF Pro Text" pitchFamily="34" charset="0"/>
+                <a:ea typeface="SF Pro Text" pitchFamily="34" charset="-122"/>
+                <a:cs typeface="SF Pro Text" pitchFamily="34" charset="-120"/>
+              </a:rPr>
+              <a:t>Never credit the exact fee amount.</a:t>
+            </a:r>
+            <a:endParaRPr lang="en-US" sz="900" dirty="0"/>
+          </a:p>
+        </p:txBody>
+      </p:sp>
+      <p:sp>
+        <p:nvSpPr>
+          <p:cNvPr id="21" name="step4Item"/>
+          <p:cNvSpPr txBox="1"/>
+          <p:nvPr/>
+        </p:nvSpPr>
+        <p:spPr>
+          <a:xfrm>
+            <a:off x="4892040" y="2450592"/>
+            <a:ext cx="3657600" cy="228600"/>
+          </a:xfrm>
+          <a:prstGeom prst="rect">
+            <a:avLst/>
+          </a:prstGeom>
+          <a:noFill/>
+          <a:ln/>
+        </p:spPr>
+        <p:txBody>
+          <a:bodyPr wrap="square" lIns="0" tIns="0" rIns="0" bIns="0" rtlCol="0" anchor="t"/>
+          <a:lstStyle/>
+          <a:p>
+            <a:pPr indent="0" marL="0">
+              <a:buNone/>
+            </a:pPr>
+            <a:r>
+              <a:rPr lang="en-US" sz="1000" b="1" dirty="0">
+                <a:solidFill>
+                  <a:srgbClr val="B3261E"/>
+                </a:solidFill>
+                <a:latin typeface="SF Pro Text" pitchFamily="34" charset="0"/>
+                <a:ea typeface="SF Pro Text" pitchFamily="34" charset="-122"/>
+                <a:cs typeface="SF Pro Text" pitchFamily="34" charset="-120"/>
+              </a:rPr>
+              <a:t>✓  </a:t>
+            </a:r>
             <a:r>
               <a:rPr lang="en-US" sz="1000" b="1" dirty="0">
                 <a:solidFill>
@@ -43148,7 +43158,7 @@
                 <a:ea typeface="SF Pro Display" pitchFamily="34" charset="-122"/>
                 <a:cs typeface="SF Pro Display" pitchFamily="34" charset="-120"/>
               </a:rPr>
-              <a:t>Name the specific expectation issue</a:t>
+              <a:t>Refund the Processing Fee in full</a:t>
             </a:r>
             <a:endParaRPr lang="en-US" sz="1000" dirty="0"/>
           </a:p>
@@ -43156,65 +43166,14 @@
       </p:sp>
       <p:sp>
         <p:nvSpPr>
-          <p:cNvPr id="29" name="Shape 26"/>
-          <p:cNvSpPr/>
-          <p:nvPr/>
-        </p:nvSpPr>
-        <p:spPr>
-          <a:xfrm>
-            <a:off x="6812280" y="2926080"/>
-            <a:ext cx="0" cy="128016"/>
-          </a:xfrm>
-          <a:prstGeom prst="line">
-            <a:avLst/>
-          </a:prstGeom>
-          <a:noFill/>
-          <a:ln w="12700">
-            <a:solidFill>
-              <a:srgbClr val="6E6E73"/>
-            </a:solidFill>
-            <a:prstDash val="solid"/>
-            <a:tailEnd type="triangle"/>
-          </a:ln>
-        </p:spPr>
-      </p:sp>
-      <p:sp>
-        <p:nvSpPr>
-          <p:cNvPr id="30" name="Shape 27"/>
-          <p:cNvSpPr/>
-          <p:nvPr/>
-        </p:nvSpPr>
-        <p:spPr>
-          <a:xfrm>
-            <a:off x="4892040" y="3054096"/>
-            <a:ext cx="3840480" cy="420624"/>
-          </a:xfrm>
-          <a:prstGeom prst="roundRect">
-            <a:avLst>
-              <a:gd name="adj" fmla="val 17391"/>
-            </a:avLst>
-          </a:prstGeom>
-          <a:solidFill>
-            <a:srgbClr val="1D1D1F"/>
-          </a:solidFill>
-          <a:ln w="12700">
-            <a:solidFill>
-              <a:srgbClr val="1D1D1F"/>
-            </a:solidFill>
-            <a:prstDash val="solid"/>
-          </a:ln>
-        </p:spPr>
-      </p:sp>
-      <p:sp>
-        <p:nvSpPr>
-          <p:cNvPr id="31" name="Text 28"/>
+          <p:cNvPr id="22" name="step5Item"/>
           <p:cNvSpPr txBox="1"/>
           <p:nvPr/>
         </p:nvSpPr>
         <p:spPr>
           <a:xfrm>
-            <a:off x="4892040" y="3054096"/>
-            <a:ext cx="3840480" cy="420624"/>
+            <a:off x="4892040" y="2743200"/>
+            <a:ext cx="3657600" cy="228600"/>
           </a:xfrm>
           <a:prstGeom prst="rect">
             <a:avLst/>
@@ -43223,115 +43182,90 @@
           <a:ln/>
         </p:spPr>
         <p:txBody>
-          <a:bodyPr wrap="square" lIns="0" tIns="0" rIns="0" bIns="0" rtlCol="0" anchor="ctr"/>
-          <a:lstStyle/>
-          <a:p>
-            <a:pPr algn="ctr" indent="0" marL="0">
+          <a:bodyPr wrap="square" lIns="0" tIns="0" rIns="0" bIns="0" rtlCol="0" anchor="t"/>
+          <a:lstStyle/>
+          <a:p>
+            <a:pPr indent="0" marL="0">
               <a:buNone/>
             </a:pPr>
             <a:r>
               <a:rPr lang="en-US" sz="1000" b="1" dirty="0">
                 <a:solidFill>
-                  <a:srgbClr val="FFFFFF"/>
+                  <a:srgbClr val="B3261E"/>
+                </a:solidFill>
+                <a:latin typeface="SF Pro Text" pitchFamily="34" charset="0"/>
+                <a:ea typeface="SF Pro Text" pitchFamily="34" charset="-122"/>
+                <a:cs typeface="SF Pro Text" pitchFamily="34" charset="-120"/>
+              </a:rPr>
+              <a:t>✓  </a:t>
+            </a:r>
+            <a:r>
+              <a:rPr lang="en-US" sz="1000" b="1" dirty="0">
+                <a:solidFill>
+                  <a:srgbClr val="1D1D1F"/>
                 </a:solidFill>
                 <a:latin typeface="SF Pro Display" pitchFamily="34" charset="0"/>
                 <a:ea typeface="SF Pro Display" pitchFamily="34" charset="-122"/>
                 <a:cs typeface="SF Pro Display" pitchFamily="34" charset="-120"/>
               </a:rPr>
-              <a:t>Cancelling FC over it? Waive the ETF</a:t>
-            </a:r>
-            <a:endParaRPr lang="en-US" sz="1000" dirty="0"/>
-          </a:p>
-        </p:txBody>
-      </p:sp>
-      <p:sp>
-        <p:nvSpPr>
-          <p:cNvPr id="32" name="Shape 29"/>
-          <p:cNvSpPr/>
-          <p:nvPr/>
-        </p:nvSpPr>
-        <p:spPr>
-          <a:xfrm>
-            <a:off x="411480" y="3675888"/>
-            <a:ext cx="8321040" cy="384048"/>
-          </a:xfrm>
-          <a:prstGeom prst="roundRect">
-            <a:avLst>
-              <a:gd name="adj" fmla="val 19048"/>
-            </a:avLst>
-          </a:prstGeom>
-          <a:solidFill>
-            <a:srgbClr val="FFF3D6"/>
-          </a:solidFill>
-          <a:ln w="9525">
-            <a:solidFill>
-              <a:srgbClr val="FFF3D6"/>
-            </a:solidFill>
-            <a:prstDash val="solid"/>
-          </a:ln>
-        </p:spPr>
-      </p:sp>
-      <p:pic>
-        <p:nvPicPr>
-          <p:cNvPr id="33" name="Image 0" descr="preencoded.png">    </p:cNvPr>
-          <p:cNvPicPr>
-            <a:picLocks noChangeAspect="1"/>
-          </p:cNvPicPr>
-          <p:nvPr/>
-        </p:nvPicPr>
-        <p:blipFill>
-          <a:blip r:embed="rId1"/>
-          <a:stretch>
-            <a:fillRect/>
-          </a:stretch>
-        </p:blipFill>
-        <p:spPr>
-          <a:xfrm>
-            <a:off x="566928" y="3785616"/>
-            <a:ext cx="164592" cy="164592"/>
-          </a:xfrm>
-          <a:prstGeom prst="rect">
-            <a:avLst/>
-          </a:prstGeom>
-        </p:spPr>
-      </p:pic>
-      <p:sp>
-        <p:nvSpPr>
-          <p:cNvPr id="34" name="Text 30"/>
-          <p:cNvSpPr txBox="1"/>
-          <p:nvPr/>
-        </p:nvSpPr>
-        <p:spPr>
-          <a:xfrm>
-            <a:off x="822960" y="3776472"/>
-            <a:ext cx="7772400" cy="201168"/>
-          </a:xfrm>
-          <a:prstGeom prst="rect">
-            <a:avLst/>
-          </a:prstGeom>
-          <a:noFill/>
-          <a:ln/>
-        </p:spPr>
-        <p:txBody>
-          <a:bodyPr wrap="square" lIns="0" tIns="0" rIns="0" bIns="0" rtlCol="0" anchor="t"/>
-          <a:lstStyle/>
-          <a:p>
-            <a:pPr indent="0" marL="0">
-              <a:buNone/>
-            </a:pPr>
-            <a:r>
-              <a:rPr lang="en-US" sz="1000" b="1" dirty="0">
-                <a:solidFill>
-                  <a:srgbClr val="9A6410"/>
+              <a:t>Canceling FC over it? </a:t>
+            </a:r>
+            <a:r>
+              <a:rPr lang="en-US" sz="1000" dirty="0">
+                <a:solidFill>
+                  <a:srgbClr val="1D1D1F"/>
                 </a:solidFill>
                 <a:latin typeface="SF Pro Text" pitchFamily="34" charset="0"/>
                 <a:ea typeface="SF Pro Text" pitchFamily="34" charset="-122"/>
                 <a:cs typeface="SF Pro Text" pitchFamily="34" charset="-120"/>
               </a:rPr>
-              <a:t>Never  </a:t>
-            </a:r>
+              <a:t>Waive the ETF</a:t>
+            </a:r>
+            <a:endParaRPr lang="en-US" sz="1000" dirty="0"/>
+          </a:p>
+        </p:txBody>
+      </p:sp>
+      <p:sp>
+        <p:nvSpPr>
+          <p:cNvPr id="23" name="step6Item"/>
+          <p:cNvSpPr txBox="1"/>
+          <p:nvPr/>
+        </p:nvSpPr>
+        <p:spPr>
+          <a:xfrm>
+            <a:off x="4892040" y="3090672"/>
+            <a:ext cx="3657600" cy="658368"/>
+          </a:xfrm>
+          <a:prstGeom prst="rect">
+            <a:avLst/>
+          </a:prstGeom>
+          <a:noFill/>
+          <a:ln/>
+        </p:spPr>
+        <p:txBody>
+          <a:bodyPr wrap="square" lIns="0" tIns="0" rIns="0" bIns="0" rtlCol="0" anchor="t"/>
+          <a:lstStyle/>
+          <a:p>
             <a:pPr indent="0" marL="0">
               <a:buNone/>
+            </a:pPr>
+            <a:r>
+              <a:rPr lang="en-US" sz="1000" b="1" dirty="0">
+                <a:solidFill>
+                  <a:srgbClr val="B3261E"/>
+                </a:solidFill>
+                <a:latin typeface="SF Pro Display" pitchFamily="34" charset="0"/>
+                <a:ea typeface="SF Pro Display" pitchFamily="34" charset="-122"/>
+                <a:cs typeface="SF Pro Display" pitchFamily="34" charset="-120"/>
+              </a:rPr>
+              <a:t>Sample scenarios</a:t>
+            </a:r>
+            <a:endParaRPr lang="en-US" sz="1000" dirty="0"/>
+          </a:p>
+          <a:p>
+            <a:pPr marL="127000" indent="-127000">
+              <a:buSzPct val="100000"/>
+              <a:buChar char="•"/>
             </a:pPr>
             <a:r>
               <a:rPr lang="en-US" sz="1000" dirty="0">
@@ -43342,7 +43276,7 @@
                 <a:ea typeface="SF Pro Text" pitchFamily="34" charset="-122"/>
                 <a:cs typeface="SF Pro Text" pitchFamily="34" charset="-120"/>
               </a:rPr>
-              <a:t>issue a credit equal to the exact Processing Fee. It says the fee was wrong.</a:t>
+              <a:t>A sales rep failed to mention the Processing Fee, or incorrectly stated there are no additional fees</a:t>
             </a:r>
             <a:endParaRPr lang="en-US" sz="1000" dirty="0"/>
           </a:p>
@@ -43350,13 +43284,53 @@
       </p:sp>
       <p:sp>
         <p:nvSpPr>
-          <p:cNvPr id="35" name="Shape 31"/>
+          <p:cNvPr id="24" name="step7Item"/>
+          <p:cNvSpPr txBox="1"/>
+          <p:nvPr/>
+        </p:nvSpPr>
+        <p:spPr>
+          <a:xfrm>
+            <a:off x="4892040" y="3730752"/>
+            <a:ext cx="3657600" cy="457200"/>
+          </a:xfrm>
+          <a:prstGeom prst="rect">
+            <a:avLst/>
+          </a:prstGeom>
+          <a:noFill/>
+          <a:ln/>
+        </p:spPr>
+        <p:txBody>
+          <a:bodyPr wrap="square" lIns="0" tIns="0" rIns="0" bIns="0" rtlCol="0" anchor="t"/>
+          <a:lstStyle/>
+          <a:p>
+            <a:pPr marL="127000" indent="-127000">
+              <a:buSzPct val="100000"/>
+              <a:buChar char="•"/>
+            </a:pPr>
+            <a:r>
+              <a:rPr lang="en-US" sz="1000" dirty="0">
+                <a:solidFill>
+                  <a:srgbClr val="1D1D1F"/>
+                </a:solidFill>
+                <a:latin typeface="SF Pro Text" pitchFamily="34" charset="0"/>
+                <a:ea typeface="SF Pro Text" pitchFamily="34" charset="-122"/>
+                <a:cs typeface="SF Pro Text" pitchFamily="34" charset="-120"/>
+              </a:rPr>
+              <a:t>A system onboarding issue prevented the customer from seeing the fee disclosure</a:t>
+            </a:r>
+            <a:endParaRPr lang="en-US" sz="1000" dirty="0"/>
+          </a:p>
+        </p:txBody>
+      </p:sp>
+      <p:sp>
+        <p:nvSpPr>
+          <p:cNvPr id="25" name="Shape 22"/>
           <p:cNvSpPr/>
           <p:nvPr/>
         </p:nvSpPr>
         <p:spPr>
           <a:xfrm>
-            <a:off x="411480" y="4169664"/>
+            <a:off x="411480" y="4425696"/>
             <a:ext cx="2926080" cy="292608"/>
           </a:xfrm>
           <a:prstGeom prst="roundRect">
@@ -43377,21 +43351,21 @@
       </p:sp>
       <p:pic>
         <p:nvPicPr>
-          <p:cNvPr id="36" name="Image 1" descr="preencoded.png">    </p:cNvPr>
+          <p:cNvPr id="26" name="Image 0" descr="preencoded.png">    </p:cNvPr>
           <p:cNvPicPr>
             <a:picLocks noChangeAspect="1"/>
           </p:cNvPicPr>
           <p:nvPr/>
         </p:nvPicPr>
         <p:blipFill>
-          <a:blip r:embed="rId2"/>
+          <a:blip r:embed="rId1"/>
           <a:stretch>
             <a:fillRect/>
           </a:stretch>
         </p:blipFill>
         <p:spPr>
           <a:xfrm>
-            <a:off x="521208" y="4242816"/>
+            <a:off x="521208" y="4498848"/>
             <a:ext cx="146304" cy="146304"/>
           </a:xfrm>
           <a:prstGeom prst="rect">
@@ -43401,13 +43375,13 @@
       </p:pic>
       <p:sp>
         <p:nvSpPr>
-          <p:cNvPr id="37" name="Text 32"/>
+          <p:cNvPr id="27" name="Text 23"/>
           <p:cNvSpPr txBox="1"/>
           <p:nvPr/>
         </p:nvSpPr>
         <p:spPr>
           <a:xfrm>
-            <a:off x="731520" y="4169664"/>
+            <a:off x="731520" y="4425696"/>
             <a:ext cx="2560320" cy="292608"/>
           </a:xfrm>
           <a:prstGeom prst="rect">
@@ -43434,9 +43408,6 @@
               </a:rPr>
               <a:t>Recommended Macro:  </a:t>
             </a:r>
-            <a:pPr indent="0" marL="0">
-              <a:buNone/>
-            </a:pPr>
             <a:r>
               <a:rPr lang="en-US" sz="950" b="1" dirty="0">
                 <a:solidFill>
@@ -43505,6 +43476,452 @@
   <p:clrMapOvr>
     <a:masterClrMapping/>
   </p:clrMapOvr>
+  <p:timing>
+    <p:tnLst>
+      <p:par>
+        <p:cTn id="1" dur="indefinite" restart="never" nodeType="tmRoot">
+          <p:childTnLst>
+            <p:seq concurrent="1" nextAc="seek">
+              <p:cTn id="2" dur="indefinite" nodeType="mainSeq">
+                <p:childTnLst>
+                  <p:par>
+                    <p:cTn id="6" fill="hold">
+                      <p:stCondLst>
+                        <p:cond delay="indefinite"/>
+                      </p:stCondLst>
+                      <p:childTnLst>
+                        <p:par>
+                          <p:cTn id="7" fill="hold">
+                            <p:stCondLst>
+                              <p:cond delay="0"/>
+                            </p:stCondLst>
+                            <p:childTnLst>
+                              <p:par>
+                                <p:cTn id="5" presetID="10" presetClass="entr" presetSubtype="0" fill="hold" grpId="0" nodeType="clickEffect">
+                                  <p:stCondLst>
+                                    <p:cond delay="0"/>
+                                  </p:stCondLst>
+                                  <p:childTnLst>
+                                    <p:set>
+                                      <p:cBhvr>
+                                        <p:cTn id="6" dur="1" fill="hold">
+                                          <p:stCondLst>
+                                            <p:cond delay="0"/>
+                                          </p:stCondLst>
+                                        </p:cTn>
+                                        <p:tgtEl>
+                                          <p:spTgt spid="17"/>
+                                        </p:tgtEl>
+                                        <p:attrNameLst>
+                                          <p:attrName>style.visibility</p:attrName>
+                                        </p:attrNameLst>
+                                      </p:cBhvr>
+                                      <p:to>
+                                        <p:strVal val="visible"/>
+                                      </p:to>
+                                    </p:set>
+                                    <p:animEffect transition="in" filter="fade">
+                                      <p:cBhvr>
+                                        <p:cTn id="7" dur="600"/>
+                                        <p:tgtEl>
+                                          <p:spTgt spid="17"/>
+                                        </p:tgtEl>
+                                      </p:cBhvr>
+                                    </p:animEffect>
+                                  </p:childTnLst>
+                                </p:cTn>
+                              </p:par>
+                            </p:childTnLst>
+                          </p:cTn>
+                        </p:par>
+                      </p:childTnLst>
+                    </p:cTn>
+                  </p:par>
+                  <p:par>
+                    <p:cTn id="11" fill="hold">
+                      <p:stCondLst>
+                        <p:cond delay="indefinite"/>
+                      </p:stCondLst>
+                      <p:childTnLst>
+                        <p:par>
+                          <p:cTn id="12" fill="hold">
+                            <p:stCondLst>
+                              <p:cond delay="0"/>
+                            </p:stCondLst>
+                            <p:childTnLst>
+                              <p:par>
+                                <p:cTn id="10" presetID="10" presetClass="entr" presetSubtype="0" fill="hold" grpId="0" nodeType="clickEffect">
+                                  <p:stCondLst>
+                                    <p:cond delay="0"/>
+                                  </p:stCondLst>
+                                  <p:childTnLst>
+                                    <p:set>
+                                      <p:cBhvr>
+                                        <p:cTn id="11" dur="1" fill="hold">
+                                          <p:stCondLst>
+                                            <p:cond delay="0"/>
+                                          </p:stCondLst>
+                                        </p:cTn>
+                                        <p:tgtEl>
+                                          <p:spTgt spid="18"/>
+                                        </p:tgtEl>
+                                        <p:attrNameLst>
+                                          <p:attrName>style.visibility</p:attrName>
+                                        </p:attrNameLst>
+                                      </p:cBhvr>
+                                      <p:to>
+                                        <p:strVal val="visible"/>
+                                      </p:to>
+                                    </p:set>
+                                    <p:animEffect transition="in" filter="fade">
+                                      <p:cBhvr>
+                                        <p:cTn id="12" dur="600"/>
+                                        <p:tgtEl>
+                                          <p:spTgt spid="18"/>
+                                        </p:tgtEl>
+                                      </p:cBhvr>
+                                    </p:animEffect>
+                                  </p:childTnLst>
+                                </p:cTn>
+                              </p:par>
+                            </p:childTnLst>
+                          </p:cTn>
+                        </p:par>
+                      </p:childTnLst>
+                    </p:cTn>
+                  </p:par>
+                  <p:par>
+                    <p:cTn id="19" fill="hold">
+                      <p:stCondLst>
+                        <p:cond delay="indefinite"/>
+                      </p:stCondLst>
+                      <p:childTnLst>
+                        <p:par>
+                          <p:cTn id="20" fill="hold">
+                            <p:stCondLst>
+                              <p:cond delay="0"/>
+                            </p:stCondLst>
+                            <p:childTnLst>
+                              <p:par>
+                                <p:cTn id="15" presetID="10" presetClass="entr" presetSubtype="0" fill="hold" grpId="0" nodeType="clickEffect">
+                                  <p:stCondLst>
+                                    <p:cond delay="0"/>
+                                  </p:stCondLst>
+                                  <p:childTnLst>
+                                    <p:set>
+                                      <p:cBhvr>
+                                        <p:cTn id="16" dur="1" fill="hold">
+                                          <p:stCondLst>
+                                            <p:cond delay="0"/>
+                                          </p:stCondLst>
+                                        </p:cTn>
+                                        <p:tgtEl>
+                                          <p:spTgt spid="19"/>
+                                        </p:tgtEl>
+                                        <p:attrNameLst>
+                                          <p:attrName>style.visibility</p:attrName>
+                                        </p:attrNameLst>
+                                      </p:cBhvr>
+                                      <p:to>
+                                        <p:strVal val="visible"/>
+                                      </p:to>
+                                    </p:set>
+                                    <p:animEffect transition="in" filter="fade">
+                                      <p:cBhvr>
+                                        <p:cTn id="17" dur="600"/>
+                                        <p:tgtEl>
+                                          <p:spTgt spid="19"/>
+                                        </p:tgtEl>
+                                      </p:cBhvr>
+                                    </p:animEffect>
+                                  </p:childTnLst>
+                                </p:cTn>
+                              </p:par>
+                              <p:par>
+                                <p:cTn id="18" presetID="10" presetClass="entr" presetSubtype="0" fill="hold" grpId="0" nodeType="withEffect">
+                                  <p:stCondLst>
+                                    <p:cond delay="0"/>
+                                  </p:stCondLst>
+                                  <p:childTnLst>
+                                    <p:set>
+                                      <p:cBhvr>
+                                        <p:cTn id="19" dur="1" fill="hold">
+                                          <p:stCondLst>
+                                            <p:cond delay="0"/>
+                                          </p:stCondLst>
+                                        </p:cTn>
+                                        <p:tgtEl>
+                                          <p:spTgt spid="20"/>
+                                        </p:tgtEl>
+                                        <p:attrNameLst>
+                                          <p:attrName>style.visibility</p:attrName>
+                                        </p:attrNameLst>
+                                      </p:cBhvr>
+                                      <p:to>
+                                        <p:strVal val="visible"/>
+                                      </p:to>
+                                    </p:set>
+                                    <p:animEffect transition="in" filter="fade">
+                                      <p:cBhvr>
+                                        <p:cTn id="20" dur="600"/>
+                                        <p:tgtEl>
+                                          <p:spTgt spid="20"/>
+                                        </p:tgtEl>
+                                      </p:cBhvr>
+                                    </p:animEffect>
+                                  </p:childTnLst>
+                                </p:cTn>
+                              </p:par>
+                            </p:childTnLst>
+                          </p:cTn>
+                        </p:par>
+                      </p:childTnLst>
+                    </p:cTn>
+                  </p:par>
+                  <p:par>
+                    <p:cTn id="24" fill="hold">
+                      <p:stCondLst>
+                        <p:cond delay="indefinite"/>
+                      </p:stCondLst>
+                      <p:childTnLst>
+                        <p:par>
+                          <p:cTn id="25" fill="hold">
+                            <p:stCondLst>
+                              <p:cond delay="0"/>
+                            </p:stCondLst>
+                            <p:childTnLst>
+                              <p:par>
+                                <p:cTn id="23" presetID="10" presetClass="entr" presetSubtype="0" fill="hold" grpId="0" nodeType="clickEffect">
+                                  <p:stCondLst>
+                                    <p:cond delay="0"/>
+                                  </p:stCondLst>
+                                  <p:childTnLst>
+                                    <p:set>
+                                      <p:cBhvr>
+                                        <p:cTn id="24" dur="1" fill="hold">
+                                          <p:stCondLst>
+                                            <p:cond delay="0"/>
+                                          </p:stCondLst>
+                                        </p:cTn>
+                                        <p:tgtEl>
+                                          <p:spTgt spid="21"/>
+                                        </p:tgtEl>
+                                        <p:attrNameLst>
+                                          <p:attrName>style.visibility</p:attrName>
+                                        </p:attrNameLst>
+                                      </p:cBhvr>
+                                      <p:to>
+                                        <p:strVal val="visible"/>
+                                      </p:to>
+                                    </p:set>
+                                    <p:animEffect transition="in" filter="fade">
+                                      <p:cBhvr>
+                                        <p:cTn id="25" dur="600"/>
+                                        <p:tgtEl>
+                                          <p:spTgt spid="21"/>
+                                        </p:tgtEl>
+                                      </p:cBhvr>
+                                    </p:animEffect>
+                                  </p:childTnLst>
+                                </p:cTn>
+                              </p:par>
+                            </p:childTnLst>
+                          </p:cTn>
+                        </p:par>
+                      </p:childTnLst>
+                    </p:cTn>
+                  </p:par>
+                  <p:par>
+                    <p:cTn id="29" fill="hold">
+                      <p:stCondLst>
+                        <p:cond delay="indefinite"/>
+                      </p:stCondLst>
+                      <p:childTnLst>
+                        <p:par>
+                          <p:cTn id="30" fill="hold">
+                            <p:stCondLst>
+                              <p:cond delay="0"/>
+                            </p:stCondLst>
+                            <p:childTnLst>
+                              <p:par>
+                                <p:cTn id="28" presetID="10" presetClass="entr" presetSubtype="0" fill="hold" grpId="0" nodeType="clickEffect">
+                                  <p:stCondLst>
+                                    <p:cond delay="0"/>
+                                  </p:stCondLst>
+                                  <p:childTnLst>
+                                    <p:set>
+                                      <p:cBhvr>
+                                        <p:cTn id="29" dur="1" fill="hold">
+                                          <p:stCondLst>
+                                            <p:cond delay="0"/>
+                                          </p:stCondLst>
+                                        </p:cTn>
+                                        <p:tgtEl>
+                                          <p:spTgt spid="22"/>
+                                        </p:tgtEl>
+                                        <p:attrNameLst>
+                                          <p:attrName>style.visibility</p:attrName>
+                                        </p:attrNameLst>
+                                      </p:cBhvr>
+                                      <p:to>
+                                        <p:strVal val="visible"/>
+                                      </p:to>
+                                    </p:set>
+                                    <p:animEffect transition="in" filter="fade">
+                                      <p:cBhvr>
+                                        <p:cTn id="30" dur="600"/>
+                                        <p:tgtEl>
+                                          <p:spTgt spid="22"/>
+                                        </p:tgtEl>
+                                      </p:cBhvr>
+                                    </p:animEffect>
+                                  </p:childTnLst>
+                                </p:cTn>
+                              </p:par>
+                            </p:childTnLst>
+                          </p:cTn>
+                        </p:par>
+                      </p:childTnLst>
+                    </p:cTn>
+                  </p:par>
+                  <p:par>
+                    <p:cTn id="34" fill="hold">
+                      <p:stCondLst>
+                        <p:cond delay="indefinite"/>
+                      </p:stCondLst>
+                      <p:childTnLst>
+                        <p:par>
+                          <p:cTn id="35" fill="hold">
+                            <p:stCondLst>
+                              <p:cond delay="0"/>
+                            </p:stCondLst>
+                            <p:childTnLst>
+                              <p:par>
+                                <p:cTn id="33" presetID="10" presetClass="entr" presetSubtype="0" fill="hold" grpId="0" nodeType="clickEffect">
+                                  <p:stCondLst>
+                                    <p:cond delay="0"/>
+                                  </p:stCondLst>
+                                  <p:childTnLst>
+                                    <p:set>
+                                      <p:cBhvr>
+                                        <p:cTn id="34" dur="1" fill="hold">
+                                          <p:stCondLst>
+                                            <p:cond delay="0"/>
+                                          </p:stCondLst>
+                                        </p:cTn>
+                                        <p:tgtEl>
+                                          <p:spTgt spid="23"/>
+                                        </p:tgtEl>
+                                        <p:attrNameLst>
+                                          <p:attrName>style.visibility</p:attrName>
+                                        </p:attrNameLst>
+                                      </p:cBhvr>
+                                      <p:to>
+                                        <p:strVal val="visible"/>
+                                      </p:to>
+                                    </p:set>
+                                    <p:animEffect transition="in" filter="fade">
+                                      <p:cBhvr>
+                                        <p:cTn id="35" dur="600"/>
+                                        <p:tgtEl>
+                                          <p:spTgt spid="23"/>
+                                        </p:tgtEl>
+                                      </p:cBhvr>
+                                    </p:animEffect>
+                                  </p:childTnLst>
+                                </p:cTn>
+                              </p:par>
+                            </p:childTnLst>
+                          </p:cTn>
+                        </p:par>
+                      </p:childTnLst>
+                    </p:cTn>
+                  </p:par>
+                  <p:par>
+                    <p:cTn id="39" fill="hold">
+                      <p:stCondLst>
+                        <p:cond delay="indefinite"/>
+                      </p:stCondLst>
+                      <p:childTnLst>
+                        <p:par>
+                          <p:cTn id="40" fill="hold">
+                            <p:stCondLst>
+                              <p:cond delay="0"/>
+                            </p:stCondLst>
+                            <p:childTnLst>
+                              <p:par>
+                                <p:cTn id="38" presetID="10" presetClass="entr" presetSubtype="0" fill="hold" grpId="0" nodeType="clickEffect">
+                                  <p:stCondLst>
+                                    <p:cond delay="0"/>
+                                  </p:stCondLst>
+                                  <p:childTnLst>
+                                    <p:set>
+                                      <p:cBhvr>
+                                        <p:cTn id="39" dur="1" fill="hold">
+                                          <p:stCondLst>
+                                            <p:cond delay="0"/>
+                                          </p:stCondLst>
+                                        </p:cTn>
+                                        <p:tgtEl>
+                                          <p:spTgt spid="24"/>
+                                        </p:tgtEl>
+                                        <p:attrNameLst>
+                                          <p:attrName>style.visibility</p:attrName>
+                                        </p:attrNameLst>
+                                      </p:cBhvr>
+                                      <p:to>
+                                        <p:strVal val="visible"/>
+                                      </p:to>
+                                    </p:set>
+                                    <p:animEffect transition="in" filter="fade">
+                                      <p:cBhvr>
+                                        <p:cTn id="40" dur="600"/>
+                                        <p:tgtEl>
+                                          <p:spTgt spid="24"/>
+                                        </p:tgtEl>
+                                      </p:cBhvr>
+                                    </p:animEffect>
+                                  </p:childTnLst>
+                                </p:cTn>
+                              </p:par>
+                            </p:childTnLst>
+                          </p:cTn>
+                        </p:par>
+                      </p:childTnLst>
+                    </p:cTn>
+                  </p:par>
+                </p:childTnLst>
+              </p:cTn>
+              <p:prevCondLst>
+                <p:cond evt="onPrev" delay="0">
+                  <p:tgtEl>
+                    <p:sldTgt/>
+                  </p:tgtEl>
+                </p:cond>
+              </p:prevCondLst>
+              <p:nextCondLst>
+                <p:cond evt="onNext" delay="0">
+                  <p:tgtEl>
+                    <p:sldTgt/>
+                  </p:tgtEl>
+                </p:cond>
+              </p:nextCondLst>
+            </p:seq>
+          </p:childTnLst>
+        </p:cTn>
+      </p:par>
+    </p:tnLst>
+    <p:bldLst>
+      <p:bldP spid="17" grpId="0" animBg="1"/>
+      <p:bldP spid="18" grpId="0" animBg="1"/>
+      <p:bldP spid="19" grpId="0" animBg="1"/>
+      <p:bldP spid="20" grpId="0" animBg="1"/>
+      <p:bldP spid="21" grpId="0" animBg="1"/>
+      <p:bldP spid="22" grpId="0" animBg="1"/>
+      <p:bldP spid="23" grpId="0" animBg="1"/>
+      <p:bldP spid="24" grpId="0" animBg="1"/>
+    </p:bldLst>
+  </p:timing>
 </p:sld>
 </file>
 
@@ -46494,9 +46911,6 @@
               </a:rPr>
               <a:t>Questions?  </a:t>
             </a:r>
-            <a:pPr indent="0" marL="0">
-              <a:buNone/>
-            </a:pPr>
             <a:r>
               <a:rPr lang="en-US" sz="1100" dirty="0">
                 <a:solidFill>
@@ -47604,9 +48018,6 @@
               </a:rPr>
               <a:t>Verify first:  </a:t>
             </a:r>
-            <a:pPr indent="0" marL="0">
-              <a:buNone/>
-            </a:pPr>
             <a:r>
               <a:rPr lang="en-US" sz="1000" dirty="0">
                 <a:solidFill>
@@ -48963,9 +49374,6 @@
               </a:rPr>
               <a:t>Waiting on a reply?  </a:t>
             </a:r>
-            <a:pPr indent="0" marL="0">
-              <a:buNone/>
-            </a:pPr>
             <a:r>
               <a:rPr lang="en-US" sz="1000" dirty="0">
                 <a:solidFill>
@@ -50938,9 +51346,6 @@
               </a:rPr>
               <a:t>Disclosed and agreed?  </a:t>
             </a:r>
-            <a:pPr indent="0" marL="0">
-              <a:buNone/>
-            </a:pPr>
             <a:r>
               <a:rPr lang="en-US" sz="1000" dirty="0">
                 <a:solidFill>
@@ -51042,9 +51447,6 @@
               </a:rPr>
               <a:t>Recommended Macro:  </a:t>
             </a:r>
-            <a:pPr indent="0" marL="0">
-              <a:buNone/>
-            </a:pPr>
             <a:r>
               <a:rPr lang="en-US" sz="950" b="1" dirty="0">
                 <a:solidFill>

</xml_diff>

<commit_message>
Processing Fee: add what the fee covers; make slide 42 a reminders slide
Co-Authored-By: Claude Opus 5.5 <noreply@anthropic.com>
Claude-Session: https://claude.ai/code/session_01FEzv8wwqWDgTsXP8Yz6XYn
</commit_message>
<xml_diff>
--- a/incorrect-info-lmc-lockout/incorrect-info-lmc-lockout.pptx
+++ b/incorrect-info-lmc-lockout/incorrect-info-lmc-lockout.pptx
@@ -3362,7 +3362,7 @@
           <a:p>
             <a:r>
               <a:rPr lang="en-US" dirty="0"/>
-              <a:t>The Processing Fee is a standard percentage-based charge included in the total cost of every cleaning. The percentage depends on membership status: 5% for non-ForeverClean and deactivated ForeverClean customers; 15% for active ForeverClean customers. It's a standard part of Homeaglow's pricing, not a penalty or a discretionary charge, so your role is not to decide whether it should have been charged: in most cases it's valid. Most customers contest it because of expectation gaps, not billing errors: they didn't realize it applied when they signed up, or they enrolled through Sales and only remember an "around $23/hour" price without the fee called out separately. That doesn't make the fee wrong, but it can leave them feeling misled.</a:t>
+              <a:t>The Processing Fee is a standard percentage-based charge included in the total cost of every cleaning. The percentage depends on membership status: 5% for non-ForeverClean and deactivated ForeverClean customers; 15% for active ForeverClean customers. It helps cover online bookings, secure credit card payment, background checks and 24/7 support. It's a standard part of Homeaglow's pricing, not a penalty or a discretionary charge, so your role is not to decide whether it should have been charged: in most cases it's valid. Most customers contest it because of expectation gaps, not billing errors: they didn't realize it applied when they signed up, or they enrolled through Sales and only remember an "around $23/hour" price without the fee called out separately. That doesn't make the fee wrong, but it can leave them feeling misled.</a:t>
             </a:r>
             <a:endParaRPr lang="en-US" dirty="0"/>
           </a:p>
@@ -3714,7 +3714,7 @@
           <a:p>
             <a:r>
               <a:rPr lang="en-US" dirty="0"/>
-              <a:t>If the customer's concern is paying the Processing Fee on future bookings rather than this specific charge, move into the appropriate retention flow. Offer a $10–$15 Membership Fee reduction. If the situation calls for more, escalate to Support or a TL, who can approve reductions of up to 50%. Things to watch for: don't investigate whether the Processing Fee is generally valid (it's standard pricing); investigate why the customer is contesting it and whether we set expectations properly; goodwill acknowledges the experience, it doesn't mean the fee was wrong; never credit the exact fee amount; if we failed to disclose it, refund it in full; if they cancel FC because of our misrepresentation, waive the ETF.</a:t>
+              <a:t>Reminders. Do: ask why the customer is contesting the fee; check what they were actually told (sales call or notes); keep goodwill one-time. Don't: debate whether the Processing Fee is valid (it's standard pricing); credit the exact fee amount (it implies the fee was wrong); promise a permanent waiver. Also remember: goodwill acknowledges the experience, it doesn't mean the fee was wrong; if we failed to disclose it, refund it in full; if they cancel FC because of our misrepresentation, waive the ETF; if they object to future fees, offer a $10–$15 Membership Fee reduction (up to 50% via a TL).</a:t>
             </a:r>
             <a:endParaRPr lang="en-US" dirty="0"/>
           </a:p>
@@ -40120,7 +40120,7 @@
                 <a:ea typeface="SF Pro Text" pitchFamily="34" charset="-122"/>
                 <a:cs typeface="SF Pro Text" pitchFamily="34" charset="-120"/>
               </a:rPr>
-              <a:t>If they don't want future fees</a:t>
+              <a:t>Reminders</a:t>
             </a:r>
             <a:endParaRPr lang="en-US" sz="1050" dirty="0"/>
           </a:p>
@@ -40551,11 +40551,11 @@
         <p:spPr>
           <a:xfrm>
             <a:off x="411480" y="1325880"/>
-            <a:ext cx="4091940" cy="1325880"/>
+            <a:ext cx="4091940" cy="1188720"/>
           </a:xfrm>
           <a:prstGeom prst="roundRect">
             <a:avLst>
-              <a:gd name="adj" fmla="val 5517"/>
+              <a:gd name="adj" fmla="val 6154"/>
             </a:avLst>
           </a:prstGeom>
           <a:solidFill>
@@ -40617,7 +40617,7 @@
         <p:spPr>
           <a:xfrm>
             <a:off x="594360" y="2148840"/>
-            <a:ext cx="3726180" cy="411480"/>
+            <a:ext cx="3726180" cy="274320"/>
           </a:xfrm>
           <a:prstGeom prst="rect">
             <a:avLst/>
@@ -40656,11 +40656,11 @@
         <p:spPr>
           <a:xfrm>
             <a:off x="4640580" y="1325880"/>
-            <a:ext cx="4091940" cy="1325880"/>
+            <a:ext cx="4091940" cy="1188720"/>
           </a:xfrm>
           <a:prstGeom prst="roundRect">
             <a:avLst>
-              <a:gd name="adj" fmla="val 5517"/>
+              <a:gd name="adj" fmla="val 6154"/>
             </a:avLst>
           </a:prstGeom>
           <a:solidFill>
@@ -40722,7 +40722,7 @@
         <p:spPr>
           <a:xfrm>
             <a:off x="4823460" y="2148840"/>
-            <a:ext cx="3726180" cy="411480"/>
+            <a:ext cx="3726180" cy="274320"/>
           </a:xfrm>
           <a:prstGeom prst="rect">
             <a:avLst/>
@@ -40760,7 +40760,425 @@
         </p:nvSpPr>
         <p:spPr>
           <a:xfrm>
-            <a:off x="411480" y="2880360"/>
+            <a:off x="411480" y="2651760"/>
+            <a:ext cx="8321040" cy="960120"/>
+          </a:xfrm>
+          <a:prstGeom prst="roundRect">
+            <a:avLst>
+              <a:gd name="adj" fmla="val 7619"/>
+            </a:avLst>
+          </a:prstGeom>
+          <a:solidFill>
+            <a:srgbClr val="FFFFFF"/>
+          </a:solidFill>
+          <a:ln w="9525">
+            <a:solidFill>
+              <a:srgbClr val="DCE1E7"/>
+            </a:solidFill>
+            <a:prstDash val="solid"/>
+          </a:ln>
+        </p:spPr>
+      </p:sp>
+      <p:sp>
+        <p:nvSpPr>
+          <p:cNvPr id="13" name="Text 10"/>
+          <p:cNvSpPr txBox="1"/>
+          <p:nvPr/>
+        </p:nvSpPr>
+        <p:spPr>
+          <a:xfrm>
+            <a:off x="594360" y="2761488"/>
+            <a:ext cx="3657600" cy="182880"/>
+          </a:xfrm>
+          <a:prstGeom prst="rect">
+            <a:avLst/>
+          </a:prstGeom>
+          <a:noFill/>
+          <a:ln/>
+        </p:spPr>
+        <p:txBody>
+          <a:bodyPr wrap="square" lIns="0" tIns="0" rIns="0" bIns="0" rtlCol="0" anchor="t"/>
+          <a:lstStyle/>
+          <a:p>
+            <a:pPr indent="0" marL="0">
+              <a:buNone/>
+            </a:pPr>
+            <a:r>
+              <a:rPr lang="en-US" sz="800" b="1" spc="50" kern="0" dirty="0">
+                <a:solidFill>
+                  <a:srgbClr val="0B7A6F"/>
+                </a:solidFill>
+                <a:latin typeface="SF Pro Display" pitchFamily="34" charset="0"/>
+                <a:ea typeface="SF Pro Display" pitchFamily="34" charset="-122"/>
+                <a:cs typeface="SF Pro Display" pitchFamily="34" charset="-120"/>
+              </a:rPr>
+              <a:t>IT HELPS COVER</a:t>
+            </a:r>
+            <a:endParaRPr lang="en-US" sz="800" dirty="0"/>
+          </a:p>
+        </p:txBody>
+      </p:sp>
+      <p:sp>
+        <p:nvSpPr>
+          <p:cNvPr id="14" name="Shape 11"/>
+          <p:cNvSpPr/>
+          <p:nvPr/>
+        </p:nvSpPr>
+        <p:spPr>
+          <a:xfrm>
+            <a:off x="594360" y="3017520"/>
+            <a:ext cx="384048" cy="384048"/>
+          </a:xfrm>
+          <a:prstGeom prst="ellipse">
+            <a:avLst/>
+          </a:prstGeom>
+          <a:solidFill>
+            <a:srgbClr val="E3F4F1"/>
+          </a:solidFill>
+          <a:ln w="12700">
+            <a:solidFill>
+              <a:srgbClr val="E3F4F1"/>
+            </a:solidFill>
+            <a:prstDash val="solid"/>
+          </a:ln>
+        </p:spPr>
+      </p:sp>
+      <p:pic>
+        <p:nvPicPr>
+          <p:cNvPr id="15" name="Image 0" descr="preencoded.png">    </p:cNvPr>
+          <p:cNvPicPr>
+            <a:picLocks noChangeAspect="1"/>
+          </p:cNvPicPr>
+          <p:nvPr/>
+        </p:nvPicPr>
+        <p:blipFill>
+          <a:blip r:embed="rId1"/>
+          <a:stretch>
+            <a:fillRect/>
+          </a:stretch>
+        </p:blipFill>
+        <p:spPr>
+          <a:xfrm>
+            <a:off x="686532" y="3109692"/>
+            <a:ext cx="199705" cy="199705"/>
+          </a:xfrm>
+          <a:prstGeom prst="rect">
+            <a:avLst/>
+          </a:prstGeom>
+        </p:spPr>
+      </p:pic>
+      <p:sp>
+        <p:nvSpPr>
+          <p:cNvPr id="16" name="Text 12"/>
+          <p:cNvSpPr txBox="1"/>
+          <p:nvPr/>
+        </p:nvSpPr>
+        <p:spPr>
+          <a:xfrm>
+            <a:off x="1069848" y="3017520"/>
+            <a:ext cx="1440180" cy="384048"/>
+          </a:xfrm>
+          <a:prstGeom prst="rect">
+            <a:avLst/>
+          </a:prstGeom>
+          <a:noFill/>
+          <a:ln/>
+        </p:spPr>
+        <p:txBody>
+          <a:bodyPr wrap="square" lIns="0" tIns="0" rIns="0" bIns="0" rtlCol="0" anchor="ctr"/>
+          <a:lstStyle/>
+          <a:p>
+            <a:pPr indent="0" marL="0">
+              <a:buNone/>
+            </a:pPr>
+            <a:r>
+              <a:rPr lang="en-US" sz="1050" b="1" dirty="0">
+                <a:solidFill>
+                  <a:srgbClr val="1D1D1F"/>
+                </a:solidFill>
+                <a:latin typeface="SF Pro Display" pitchFamily="34" charset="0"/>
+                <a:ea typeface="SF Pro Display" pitchFamily="34" charset="-122"/>
+                <a:cs typeface="SF Pro Display" pitchFamily="34" charset="-120"/>
+              </a:rPr>
+              <a:t>Online bookings</a:t>
+            </a:r>
+            <a:endParaRPr lang="en-US" sz="1050" dirty="0"/>
+          </a:p>
+        </p:txBody>
+      </p:sp>
+      <p:sp>
+        <p:nvSpPr>
+          <p:cNvPr id="17" name="Shape 13"/>
+          <p:cNvSpPr/>
+          <p:nvPr/>
+        </p:nvSpPr>
+        <p:spPr>
+          <a:xfrm>
+            <a:off x="2583180" y="3017520"/>
+            <a:ext cx="384048" cy="384048"/>
+          </a:xfrm>
+          <a:prstGeom prst="ellipse">
+            <a:avLst/>
+          </a:prstGeom>
+          <a:solidFill>
+            <a:srgbClr val="E3F4F1"/>
+          </a:solidFill>
+          <a:ln w="12700">
+            <a:solidFill>
+              <a:srgbClr val="E3F4F1"/>
+            </a:solidFill>
+            <a:prstDash val="solid"/>
+          </a:ln>
+        </p:spPr>
+      </p:sp>
+      <p:pic>
+        <p:nvPicPr>
+          <p:cNvPr id="18" name="Image 1" descr="preencoded.png">    </p:cNvPr>
+          <p:cNvPicPr>
+            <a:picLocks noChangeAspect="1"/>
+          </p:cNvPicPr>
+          <p:nvPr/>
+        </p:nvPicPr>
+        <p:blipFill>
+          <a:blip r:embed="rId2"/>
+          <a:stretch>
+            <a:fillRect/>
+          </a:stretch>
+        </p:blipFill>
+        <p:spPr>
+          <a:xfrm>
+            <a:off x="2675352" y="3109692"/>
+            <a:ext cx="199705" cy="199705"/>
+          </a:xfrm>
+          <a:prstGeom prst="rect">
+            <a:avLst/>
+          </a:prstGeom>
+        </p:spPr>
+      </p:pic>
+      <p:sp>
+        <p:nvSpPr>
+          <p:cNvPr id="19" name="Text 14"/>
+          <p:cNvSpPr txBox="1"/>
+          <p:nvPr/>
+        </p:nvSpPr>
+        <p:spPr>
+          <a:xfrm>
+            <a:off x="3058668" y="3017520"/>
+            <a:ext cx="1440180" cy="384048"/>
+          </a:xfrm>
+          <a:prstGeom prst="rect">
+            <a:avLst/>
+          </a:prstGeom>
+          <a:noFill/>
+          <a:ln/>
+        </p:spPr>
+        <p:txBody>
+          <a:bodyPr wrap="square" lIns="0" tIns="0" rIns="0" bIns="0" rtlCol="0" anchor="ctr"/>
+          <a:lstStyle/>
+          <a:p>
+            <a:pPr indent="0" marL="0">
+              <a:buNone/>
+            </a:pPr>
+            <a:r>
+              <a:rPr lang="en-US" sz="1050" b="1" dirty="0">
+                <a:solidFill>
+                  <a:srgbClr val="1D1D1F"/>
+                </a:solidFill>
+                <a:latin typeface="SF Pro Display" pitchFamily="34" charset="0"/>
+                <a:ea typeface="SF Pro Display" pitchFamily="34" charset="-122"/>
+                <a:cs typeface="SF Pro Display" pitchFamily="34" charset="-120"/>
+              </a:rPr>
+              <a:t>Secure credit card payment</a:t>
+            </a:r>
+            <a:endParaRPr lang="en-US" sz="1050" dirty="0"/>
+          </a:p>
+        </p:txBody>
+      </p:sp>
+      <p:sp>
+        <p:nvSpPr>
+          <p:cNvPr id="20" name="Shape 15"/>
+          <p:cNvSpPr/>
+          <p:nvPr/>
+        </p:nvSpPr>
+        <p:spPr>
+          <a:xfrm>
+            <a:off x="4572000" y="3017520"/>
+            <a:ext cx="384048" cy="384048"/>
+          </a:xfrm>
+          <a:prstGeom prst="ellipse">
+            <a:avLst/>
+          </a:prstGeom>
+          <a:solidFill>
+            <a:srgbClr val="E3F4F1"/>
+          </a:solidFill>
+          <a:ln w="12700">
+            <a:solidFill>
+              <a:srgbClr val="E3F4F1"/>
+            </a:solidFill>
+            <a:prstDash val="solid"/>
+          </a:ln>
+        </p:spPr>
+      </p:sp>
+      <p:pic>
+        <p:nvPicPr>
+          <p:cNvPr id="21" name="Image 2" descr="preencoded.png">    </p:cNvPr>
+          <p:cNvPicPr>
+            <a:picLocks noChangeAspect="1"/>
+          </p:cNvPicPr>
+          <p:nvPr/>
+        </p:nvPicPr>
+        <p:blipFill>
+          <a:blip r:embed="rId3"/>
+          <a:stretch>
+            <a:fillRect/>
+          </a:stretch>
+        </p:blipFill>
+        <p:spPr>
+          <a:xfrm>
+            <a:off x="4664172" y="3109692"/>
+            <a:ext cx="199705" cy="199705"/>
+          </a:xfrm>
+          <a:prstGeom prst="rect">
+            <a:avLst/>
+          </a:prstGeom>
+        </p:spPr>
+      </p:pic>
+      <p:sp>
+        <p:nvSpPr>
+          <p:cNvPr id="22" name="Text 16"/>
+          <p:cNvSpPr txBox="1"/>
+          <p:nvPr/>
+        </p:nvSpPr>
+        <p:spPr>
+          <a:xfrm>
+            <a:off x="5047488" y="3017520"/>
+            <a:ext cx="1440180" cy="384048"/>
+          </a:xfrm>
+          <a:prstGeom prst="rect">
+            <a:avLst/>
+          </a:prstGeom>
+          <a:noFill/>
+          <a:ln/>
+        </p:spPr>
+        <p:txBody>
+          <a:bodyPr wrap="square" lIns="0" tIns="0" rIns="0" bIns="0" rtlCol="0" anchor="ctr"/>
+          <a:lstStyle/>
+          <a:p>
+            <a:pPr indent="0" marL="0">
+              <a:buNone/>
+            </a:pPr>
+            <a:r>
+              <a:rPr lang="en-US" sz="1050" b="1" dirty="0">
+                <a:solidFill>
+                  <a:srgbClr val="1D1D1F"/>
+                </a:solidFill>
+                <a:latin typeface="SF Pro Display" pitchFamily="34" charset="0"/>
+                <a:ea typeface="SF Pro Display" pitchFamily="34" charset="-122"/>
+                <a:cs typeface="SF Pro Display" pitchFamily="34" charset="-120"/>
+              </a:rPr>
+              <a:t>Background checks</a:t>
+            </a:r>
+            <a:endParaRPr lang="en-US" sz="1050" dirty="0"/>
+          </a:p>
+        </p:txBody>
+      </p:sp>
+      <p:sp>
+        <p:nvSpPr>
+          <p:cNvPr id="23" name="Shape 17"/>
+          <p:cNvSpPr/>
+          <p:nvPr/>
+        </p:nvSpPr>
+        <p:spPr>
+          <a:xfrm>
+            <a:off x="6560820" y="3017520"/>
+            <a:ext cx="384048" cy="384048"/>
+          </a:xfrm>
+          <a:prstGeom prst="ellipse">
+            <a:avLst/>
+          </a:prstGeom>
+          <a:solidFill>
+            <a:srgbClr val="E3F4F1"/>
+          </a:solidFill>
+          <a:ln w="12700">
+            <a:solidFill>
+              <a:srgbClr val="E3F4F1"/>
+            </a:solidFill>
+            <a:prstDash val="solid"/>
+          </a:ln>
+        </p:spPr>
+      </p:sp>
+      <p:pic>
+        <p:nvPicPr>
+          <p:cNvPr id="24" name="Image 3" descr="preencoded.png">    </p:cNvPr>
+          <p:cNvPicPr>
+            <a:picLocks noChangeAspect="1"/>
+          </p:cNvPicPr>
+          <p:nvPr/>
+        </p:nvPicPr>
+        <p:blipFill>
+          <a:blip r:embed="rId4"/>
+          <a:stretch>
+            <a:fillRect/>
+          </a:stretch>
+        </p:blipFill>
+        <p:spPr>
+          <a:xfrm>
+            <a:off x="6652992" y="3109692"/>
+            <a:ext cx="199705" cy="199705"/>
+          </a:xfrm>
+          <a:prstGeom prst="rect">
+            <a:avLst/>
+          </a:prstGeom>
+        </p:spPr>
+      </p:pic>
+      <p:sp>
+        <p:nvSpPr>
+          <p:cNvPr id="25" name="Text 18"/>
+          <p:cNvSpPr txBox="1"/>
+          <p:nvPr/>
+        </p:nvSpPr>
+        <p:spPr>
+          <a:xfrm>
+            <a:off x="7036308" y="3017520"/>
+            <a:ext cx="1440180" cy="384048"/>
+          </a:xfrm>
+          <a:prstGeom prst="rect">
+            <a:avLst/>
+          </a:prstGeom>
+          <a:noFill/>
+          <a:ln/>
+        </p:spPr>
+        <p:txBody>
+          <a:bodyPr wrap="square" lIns="0" tIns="0" rIns="0" bIns="0" rtlCol="0" anchor="ctr"/>
+          <a:lstStyle/>
+          <a:p>
+            <a:pPr indent="0" marL="0">
+              <a:buNone/>
+            </a:pPr>
+            <a:r>
+              <a:rPr lang="en-US" sz="1050" b="1" dirty="0">
+                <a:solidFill>
+                  <a:srgbClr val="1D1D1F"/>
+                </a:solidFill>
+                <a:latin typeface="SF Pro Display" pitchFamily="34" charset="0"/>
+                <a:ea typeface="SF Pro Display" pitchFamily="34" charset="-122"/>
+                <a:cs typeface="SF Pro Display" pitchFamily="34" charset="-120"/>
+              </a:rPr>
+              <a:t>24/7 support</a:t>
+            </a:r>
+            <a:endParaRPr lang="en-US" sz="1050" dirty="0"/>
+          </a:p>
+        </p:txBody>
+      </p:sp>
+      <p:sp>
+        <p:nvSpPr>
+          <p:cNvPr id="26" name="Shape 19"/>
+          <p:cNvSpPr/>
+          <p:nvPr/>
+        </p:nvSpPr>
+        <p:spPr>
+          <a:xfrm>
+            <a:off x="411480" y="3794760"/>
             <a:ext cx="8321040" cy="384048"/>
           </a:xfrm>
           <a:prstGeom prst="roundRect">
@@ -40781,21 +41199,21 @@
       </p:sp>
       <p:pic>
         <p:nvPicPr>
-          <p:cNvPr id="13" name="Image 0" descr="preencoded.png">    </p:cNvPr>
+          <p:cNvPr id="27" name="Image 4" descr="preencoded.png">    </p:cNvPr>
           <p:cNvPicPr>
             <a:picLocks noChangeAspect="1"/>
           </p:cNvPicPr>
           <p:nvPr/>
         </p:nvPicPr>
         <p:blipFill>
-          <a:blip r:embed="rId1"/>
+          <a:blip r:embed="rId5"/>
           <a:stretch>
             <a:fillRect/>
           </a:stretch>
         </p:blipFill>
         <p:spPr>
           <a:xfrm>
-            <a:off x="566928" y="2990088"/>
+            <a:off x="566928" y="3904488"/>
             <a:ext cx="164592" cy="164592"/>
           </a:xfrm>
           <a:prstGeom prst="rect">
@@ -40805,13 +41223,13 @@
       </p:pic>
       <p:sp>
         <p:nvSpPr>
-          <p:cNvPr id="14" name="Text 10"/>
+          <p:cNvPr id="28" name="Text 20"/>
           <p:cNvSpPr txBox="1"/>
           <p:nvPr/>
         </p:nvSpPr>
         <p:spPr>
           <a:xfrm>
-            <a:off x="822960" y="2980944"/>
+            <a:off x="822960" y="3895344"/>
             <a:ext cx="7772400" cy="201168"/>
           </a:xfrm>
           <a:prstGeom prst="rect">
@@ -44014,7 +44432,7 @@
                 <a:ea typeface="SF Pro Display" pitchFamily="34" charset="-122"/>
                 <a:cs typeface="SF Pro Display" pitchFamily="34" charset="-120"/>
               </a:rPr>
-              <a:t>They don't want future fees</a:t>
+              <a:t>Reminders</a:t>
             </a:r>
             <a:endParaRPr lang="en-US" sz="2400" dirty="0"/>
           </a:p>
@@ -44053,7 +44471,7 @@
                 <a:ea typeface="SF Pro Text" pitchFamily="34" charset="-122"/>
                 <a:cs typeface="SF Pro Text" pitchFamily="34" charset="-120"/>
               </a:rPr>
-              <a:t>A retention conversation, not a refund one.</a:t>
+              <a:t>Keep these in mind on every Processing Fee ticket.</a:t>
             </a:r>
             <a:endParaRPr lang="en-US" sz="1200" dirty="0"/>
           </a:p>
@@ -44067,258 +44485,12 @@
         </p:nvSpPr>
         <p:spPr>
           <a:xfrm>
-            <a:off x="411480" y="1371600"/>
-            <a:ext cx="2606040" cy="640080"/>
+            <a:off x="411480" y="1325880"/>
+            <a:ext cx="4091940" cy="1737360"/>
           </a:xfrm>
           <a:prstGeom prst="roundRect">
             <a:avLst>
-              <a:gd name="adj" fmla="val 11429"/>
-            </a:avLst>
-          </a:prstGeom>
-          <a:solidFill>
-            <a:srgbClr val="FFFFFF"/>
-          </a:solidFill>
-          <a:ln w="12700">
-            <a:solidFill>
-              <a:srgbClr val="DCE1E7"/>
-            </a:solidFill>
-            <a:prstDash val="solid"/>
-          </a:ln>
-        </p:spPr>
-      </p:sp>
-      <p:sp>
-        <p:nvSpPr>
-          <p:cNvPr id="7" name="Text 4"/>
-          <p:cNvSpPr txBox="1"/>
-          <p:nvPr/>
-        </p:nvSpPr>
-        <p:spPr>
-          <a:xfrm>
-            <a:off x="411480" y="1371600"/>
-            <a:ext cx="2606040" cy="640080"/>
-          </a:xfrm>
-          <a:prstGeom prst="rect">
-            <a:avLst/>
-          </a:prstGeom>
-          <a:noFill/>
-          <a:ln/>
-        </p:spPr>
-        <p:txBody>
-          <a:bodyPr wrap="square" lIns="0" tIns="0" rIns="0" bIns="0" rtlCol="0" anchor="ctr"/>
-          <a:lstStyle/>
-          <a:p>
-            <a:pPr algn="ctr" indent="0" marL="0">
-              <a:buNone/>
-            </a:pPr>
-            <a:r>
-              <a:rPr lang="en-US" sz="1000" b="1" dirty="0">
-                <a:solidFill>
-                  <a:srgbClr val="1D1D1F"/>
-                </a:solidFill>
-                <a:latin typeface="SF Pro Display" pitchFamily="34" charset="0"/>
-                <a:ea typeface="SF Pro Display" pitchFamily="34" charset="-122"/>
-                <a:cs typeface="SF Pro Display" pitchFamily="34" charset="-120"/>
-              </a:rPr>
-              <a:t>Move into the retention flow</a:t>
-            </a:r>
-            <a:endParaRPr lang="en-US" sz="1000" dirty="0"/>
-          </a:p>
-        </p:txBody>
-      </p:sp>
-      <p:sp>
-        <p:nvSpPr>
-          <p:cNvPr id="8" name="Shape 5"/>
-          <p:cNvSpPr/>
-          <p:nvPr/>
-        </p:nvSpPr>
-        <p:spPr>
-          <a:xfrm>
-            <a:off x="3017520" y="1691640"/>
-            <a:ext cx="246888" cy="0"/>
-          </a:xfrm>
-          <a:prstGeom prst="line">
-            <a:avLst/>
-          </a:prstGeom>
-          <a:noFill/>
-          <a:ln w="12700">
-            <a:solidFill>
-              <a:srgbClr val="6E6E73"/>
-            </a:solidFill>
-            <a:prstDash val="solid"/>
-            <a:tailEnd type="triangle"/>
-          </a:ln>
-        </p:spPr>
-      </p:sp>
-      <p:sp>
-        <p:nvSpPr>
-          <p:cNvPr id="9" name="Shape 6"/>
-          <p:cNvSpPr/>
-          <p:nvPr/>
-        </p:nvSpPr>
-        <p:spPr>
-          <a:xfrm>
-            <a:off x="3264408" y="1371600"/>
-            <a:ext cx="2606040" cy="640080"/>
-          </a:xfrm>
-          <a:prstGeom prst="roundRect">
-            <a:avLst>
-              <a:gd name="adj" fmla="val 11429"/>
-            </a:avLst>
-          </a:prstGeom>
-          <a:solidFill>
-            <a:srgbClr val="0B7A6F"/>
-          </a:solidFill>
-          <a:ln w="12700">
-            <a:solidFill>
-              <a:srgbClr val="0B7A6F"/>
-            </a:solidFill>
-            <a:prstDash val="solid"/>
-          </a:ln>
-        </p:spPr>
-      </p:sp>
-      <p:sp>
-        <p:nvSpPr>
-          <p:cNvPr id="10" name="Text 7"/>
-          <p:cNvSpPr txBox="1"/>
-          <p:nvPr/>
-        </p:nvSpPr>
-        <p:spPr>
-          <a:xfrm>
-            <a:off x="3264408" y="1371600"/>
-            <a:ext cx="2606040" cy="640080"/>
-          </a:xfrm>
-          <a:prstGeom prst="rect">
-            <a:avLst/>
-          </a:prstGeom>
-          <a:noFill/>
-          <a:ln/>
-        </p:spPr>
-        <p:txBody>
-          <a:bodyPr wrap="square" lIns="0" tIns="0" rIns="0" bIns="0" rtlCol="0" anchor="ctr"/>
-          <a:lstStyle/>
-          <a:p>
-            <a:pPr algn="ctr" indent="0" marL="0">
-              <a:buNone/>
-            </a:pPr>
-            <a:r>
-              <a:rPr lang="en-US" sz="1000" b="1" dirty="0">
-                <a:solidFill>
-                  <a:srgbClr val="FFFFFF"/>
-                </a:solidFill>
-                <a:latin typeface="SF Pro Display" pitchFamily="34" charset="0"/>
-                <a:ea typeface="SF Pro Display" pitchFamily="34" charset="-122"/>
-                <a:cs typeface="SF Pro Display" pitchFamily="34" charset="-120"/>
-              </a:rPr>
-              <a:t>Offer a $10–$15 Membership Fee reduction</a:t>
-            </a:r>
-            <a:endParaRPr lang="en-US" sz="1000" dirty="0"/>
-          </a:p>
-        </p:txBody>
-      </p:sp>
-      <p:sp>
-        <p:nvSpPr>
-          <p:cNvPr id="11" name="Shape 8"/>
-          <p:cNvSpPr/>
-          <p:nvPr/>
-        </p:nvSpPr>
-        <p:spPr>
-          <a:xfrm>
-            <a:off x="5870448" y="1691640"/>
-            <a:ext cx="246888" cy="0"/>
-          </a:xfrm>
-          <a:prstGeom prst="line">
-            <a:avLst/>
-          </a:prstGeom>
-          <a:noFill/>
-          <a:ln w="12700">
-            <a:solidFill>
-              <a:srgbClr val="6E6E73"/>
-            </a:solidFill>
-            <a:prstDash val="solid"/>
-            <a:tailEnd type="triangle"/>
-          </a:ln>
-        </p:spPr>
-      </p:sp>
-      <p:sp>
-        <p:nvSpPr>
-          <p:cNvPr id="12" name="Shape 9"/>
-          <p:cNvSpPr/>
-          <p:nvPr/>
-        </p:nvSpPr>
-        <p:spPr>
-          <a:xfrm>
-            <a:off x="6117336" y="1371600"/>
-            <a:ext cx="2606040" cy="640080"/>
-          </a:xfrm>
-          <a:prstGeom prst="roundRect">
-            <a:avLst>
-              <a:gd name="adj" fmla="val 11429"/>
-            </a:avLst>
-          </a:prstGeom>
-          <a:solidFill>
-            <a:srgbClr val="FFF3D6"/>
-          </a:solidFill>
-          <a:ln w="12700">
-            <a:solidFill>
-              <a:srgbClr val="9A6410"/>
-            </a:solidFill>
-            <a:prstDash val="solid"/>
-          </a:ln>
-        </p:spPr>
-      </p:sp>
-      <p:sp>
-        <p:nvSpPr>
-          <p:cNvPr id="13" name="Text 10"/>
-          <p:cNvSpPr txBox="1"/>
-          <p:nvPr/>
-        </p:nvSpPr>
-        <p:spPr>
-          <a:xfrm>
-            <a:off x="6117336" y="1371600"/>
-            <a:ext cx="2606040" cy="640080"/>
-          </a:xfrm>
-          <a:prstGeom prst="rect">
-            <a:avLst/>
-          </a:prstGeom>
-          <a:noFill/>
-          <a:ln/>
-        </p:spPr>
-        <p:txBody>
-          <a:bodyPr wrap="square" lIns="0" tIns="0" rIns="0" bIns="0" rtlCol="0" anchor="ctr"/>
-          <a:lstStyle/>
-          <a:p>
-            <a:pPr algn="ctr" indent="0" marL="0">
-              <a:buNone/>
-            </a:pPr>
-            <a:r>
-              <a:rPr lang="en-US" sz="1000" b="1" dirty="0">
-                <a:solidFill>
-                  <a:srgbClr val="9A6410"/>
-                </a:solidFill>
-                <a:latin typeface="SF Pro Display" pitchFamily="34" charset="0"/>
-                <a:ea typeface="SF Pro Display" pitchFamily="34" charset="-122"/>
-                <a:cs typeface="SF Pro Display" pitchFamily="34" charset="-120"/>
-              </a:rPr>
-              <a:t>Need more? Escalate to Support or a TL (up to 50%)</a:t>
-            </a:r>
-            <a:endParaRPr lang="en-US" sz="1000" dirty="0"/>
-          </a:p>
-        </p:txBody>
-      </p:sp>
-      <p:sp>
-        <p:nvSpPr>
-          <p:cNvPr id="14" name="Shape 11"/>
-          <p:cNvSpPr/>
-          <p:nvPr/>
-        </p:nvSpPr>
-        <p:spPr>
-          <a:xfrm>
-            <a:off x="411480" y="2286000"/>
-            <a:ext cx="4091940" cy="1600200"/>
-          </a:xfrm>
-          <a:prstGeom prst="roundRect">
-            <a:avLst>
-              <a:gd name="adj" fmla="val 4571"/>
+              <a:gd name="adj" fmla="val 4211"/>
             </a:avLst>
           </a:prstGeom>
           <a:solidFill>
@@ -44334,13 +44506,13 @@
       </p:sp>
       <p:sp>
         <p:nvSpPr>
-          <p:cNvPr id="15" name="Shape 12"/>
+          <p:cNvPr id="7" name="Shape 4"/>
           <p:cNvSpPr/>
           <p:nvPr/>
         </p:nvSpPr>
         <p:spPr>
           <a:xfrm>
-            <a:off x="594360" y="2468880"/>
+            <a:off x="594360" y="1508760"/>
             <a:ext cx="384048" cy="384048"/>
           </a:xfrm>
           <a:prstGeom prst="ellipse">
@@ -44359,7 +44531,7 @@
       </p:sp>
       <p:pic>
         <p:nvPicPr>
-          <p:cNvPr id="16" name="Image 0" descr="preencoded.png">    </p:cNvPr>
+          <p:cNvPr id="8" name="Image 0" descr="preencoded.png">    </p:cNvPr>
           <p:cNvPicPr>
             <a:picLocks noChangeAspect="1"/>
           </p:cNvPicPr>
@@ -44373,7 +44545,7 @@
         </p:blipFill>
         <p:spPr>
           <a:xfrm>
-            <a:off x="686532" y="2561052"/>
+            <a:off x="686532" y="1600932"/>
             <a:ext cx="199705" cy="199705"/>
           </a:xfrm>
           <a:prstGeom prst="rect">
@@ -44383,13 +44555,13 @@
       </p:pic>
       <p:sp>
         <p:nvSpPr>
-          <p:cNvPr id="17" name="Text 13"/>
+          <p:cNvPr id="9" name="Text 5"/>
           <p:cNvSpPr txBox="1"/>
           <p:nvPr/>
         </p:nvSpPr>
         <p:spPr>
           <a:xfrm>
-            <a:off x="1097280" y="2468880"/>
+            <a:off x="1097280" y="1508760"/>
             <a:ext cx="3223260" cy="384048"/>
           </a:xfrm>
           <a:prstGeom prst="rect">
@@ -44422,14 +44594,14 @@
       </p:sp>
       <p:sp>
         <p:nvSpPr>
-          <p:cNvPr id="18" name="Text 14"/>
+          <p:cNvPr id="10" name="Text 6"/>
           <p:cNvSpPr txBox="1"/>
           <p:nvPr/>
         </p:nvSpPr>
         <p:spPr>
           <a:xfrm>
-            <a:off x="594360" y="2999232"/>
-            <a:ext cx="3726180" cy="777240"/>
+            <a:off x="594360" y="2039112"/>
+            <a:ext cx="3726180" cy="914400"/>
           </a:xfrm>
           <a:prstGeom prst="rect">
             <a:avLst/>
@@ -44507,18 +44679,18 @@
       </p:sp>
       <p:sp>
         <p:nvSpPr>
-          <p:cNvPr id="19" name="Shape 15"/>
+          <p:cNvPr id="11" name="Shape 7"/>
           <p:cNvSpPr/>
           <p:nvPr/>
         </p:nvSpPr>
         <p:spPr>
           <a:xfrm>
-            <a:off x="4640580" y="2286000"/>
-            <a:ext cx="4091940" cy="1600200"/>
+            <a:off x="4640580" y="1325880"/>
+            <a:ext cx="4091940" cy="1737360"/>
           </a:xfrm>
           <a:prstGeom prst="roundRect">
             <a:avLst>
-              <a:gd name="adj" fmla="val 4571"/>
+              <a:gd name="adj" fmla="val 4211"/>
             </a:avLst>
           </a:prstGeom>
           <a:solidFill>
@@ -44534,13 +44706,13 @@
       </p:sp>
       <p:sp>
         <p:nvSpPr>
-          <p:cNvPr id="20" name="Shape 16"/>
+          <p:cNvPr id="12" name="Shape 8"/>
           <p:cNvSpPr/>
           <p:nvPr/>
         </p:nvSpPr>
         <p:spPr>
           <a:xfrm>
-            <a:off x="4823460" y="2468880"/>
+            <a:off x="4823460" y="1508760"/>
             <a:ext cx="384048" cy="384048"/>
           </a:xfrm>
           <a:prstGeom prst="ellipse">
@@ -44559,7 +44731,7 @@
       </p:sp>
       <p:pic>
         <p:nvPicPr>
-          <p:cNvPr id="21" name="Image 1" descr="preencoded.png">    </p:cNvPr>
+          <p:cNvPr id="13" name="Image 1" descr="preencoded.png">    </p:cNvPr>
           <p:cNvPicPr>
             <a:picLocks noChangeAspect="1"/>
           </p:cNvPicPr>
@@ -44573,7 +44745,7 @@
         </p:blipFill>
         <p:spPr>
           <a:xfrm>
-            <a:off x="4915632" y="2561052"/>
+            <a:off x="4915632" y="1600932"/>
             <a:ext cx="199705" cy="199705"/>
           </a:xfrm>
           <a:prstGeom prst="rect">
@@ -44583,13 +44755,13 @@
       </p:pic>
       <p:sp>
         <p:nvSpPr>
-          <p:cNvPr id="22" name="Text 17"/>
+          <p:cNvPr id="14" name="Text 9"/>
           <p:cNvSpPr txBox="1"/>
           <p:nvPr/>
         </p:nvSpPr>
         <p:spPr>
           <a:xfrm>
-            <a:off x="5326380" y="2468880"/>
+            <a:off x="5326380" y="1508760"/>
             <a:ext cx="3223260" cy="384048"/>
           </a:xfrm>
           <a:prstGeom prst="rect">
@@ -44622,14 +44794,14 @@
       </p:sp>
       <p:sp>
         <p:nvSpPr>
-          <p:cNvPr id="23" name="Text 18"/>
+          <p:cNvPr id="15" name="Text 10"/>
           <p:cNvSpPr txBox="1"/>
           <p:nvPr/>
         </p:nvSpPr>
         <p:spPr>
           <a:xfrm>
-            <a:off x="4823460" y="2999232"/>
-            <a:ext cx="3726180" cy="777240"/>
+            <a:off x="4823460" y="2039112"/>
+            <a:ext cx="3726180" cy="914400"/>
           </a:xfrm>
           <a:prstGeom prst="rect">
             <a:avLst/>
@@ -44700,6 +44872,107 @@
                 <a:cs typeface="SF Pro Text" pitchFamily="34" charset="-120"/>
               </a:rPr>
               <a:t>Promise a permanent waiver</a:t>
+            </a:r>
+            <a:endParaRPr lang="en-US" sz="1000" dirty="0"/>
+          </a:p>
+        </p:txBody>
+      </p:sp>
+      <p:sp>
+        <p:nvSpPr>
+          <p:cNvPr id="16" name="Shape 11"/>
+          <p:cNvSpPr/>
+          <p:nvPr/>
+        </p:nvSpPr>
+        <p:spPr>
+          <a:xfrm>
+            <a:off x="411480" y="3291840"/>
+            <a:ext cx="8321040" cy="384048"/>
+          </a:xfrm>
+          <a:prstGeom prst="roundRect">
+            <a:avLst>
+              <a:gd name="adj" fmla="val 19048"/>
+            </a:avLst>
+          </a:prstGeom>
+          <a:solidFill>
+            <a:srgbClr val="FFF3D6"/>
+          </a:solidFill>
+          <a:ln w="9525">
+            <a:solidFill>
+              <a:srgbClr val="FFF3D6"/>
+            </a:solidFill>
+            <a:prstDash val="solid"/>
+          </a:ln>
+        </p:spPr>
+      </p:sp>
+      <p:pic>
+        <p:nvPicPr>
+          <p:cNvPr id="17" name="Image 2" descr="preencoded.png">    </p:cNvPr>
+          <p:cNvPicPr>
+            <a:picLocks noChangeAspect="1"/>
+          </p:cNvPicPr>
+          <p:nvPr/>
+        </p:nvPicPr>
+        <p:blipFill>
+          <a:blip r:embed="rId3"/>
+          <a:stretch>
+            <a:fillRect/>
+          </a:stretch>
+        </p:blipFill>
+        <p:spPr>
+          <a:xfrm>
+            <a:off x="566928" y="3401568"/>
+            <a:ext cx="164592" cy="164592"/>
+          </a:xfrm>
+          <a:prstGeom prst="rect">
+            <a:avLst/>
+          </a:prstGeom>
+        </p:spPr>
+      </p:pic>
+      <p:sp>
+        <p:nvSpPr>
+          <p:cNvPr id="18" name="Text 12"/>
+          <p:cNvSpPr txBox="1"/>
+          <p:nvPr/>
+        </p:nvSpPr>
+        <p:spPr>
+          <a:xfrm>
+            <a:off x="822960" y="3392424"/>
+            <a:ext cx="7772400" cy="201168"/>
+          </a:xfrm>
+          <a:prstGeom prst="rect">
+            <a:avLst/>
+          </a:prstGeom>
+          <a:noFill/>
+          <a:ln/>
+        </p:spPr>
+        <p:txBody>
+          <a:bodyPr wrap="square" lIns="0" tIns="0" rIns="0" bIns="0" rtlCol="0" anchor="t"/>
+          <a:lstStyle/>
+          <a:p>
+            <a:pPr indent="0" marL="0">
+              <a:buNone/>
+            </a:pPr>
+            <a:r>
+              <a:rPr lang="en-US" sz="1000" b="1" dirty="0">
+                <a:solidFill>
+                  <a:srgbClr val="9A6410"/>
+                </a:solidFill>
+                <a:latin typeface="SF Pro Text" pitchFamily="34" charset="0"/>
+                <a:ea typeface="SF Pro Text" pitchFamily="34" charset="-122"/>
+                <a:cs typeface="SF Pro Text" pitchFamily="34" charset="-120"/>
+              </a:rPr>
+              <a:t>Remember:  </a:t>
+            </a:r>
+            <a:r>
+              <a:rPr lang="en-US" sz="1000" dirty="0">
+                <a:solidFill>
+                  <a:srgbClr val="1D1D1F"/>
+                </a:solidFill>
+                <a:latin typeface="SF Pro Text" pitchFamily="34" charset="0"/>
+                <a:ea typeface="SF Pro Text" pitchFamily="34" charset="-122"/>
+                <a:cs typeface="SF Pro Text" pitchFamily="34" charset="-120"/>
+              </a:rPr>
+              <a:t>goodwill acknowledges the experience. It doesn’t mean the fee was wrong.</a:t>
             </a:r>
             <a:endParaRPr lang="en-US" sz="1000" dirty="0"/>
           </a:p>

</xml_diff>